<commit_message>
feat: more presentation stuff
</commit_message>
<xml_diff>
--- a/presentation/slides.pptx
+++ b/presentation/slides.pptx
@@ -25,9 +25,11 @@
     <p:sldId id="273" r:id="rId19"/>
     <p:sldId id="274" r:id="rId20"/>
     <p:sldId id="275" r:id="rId21"/>
+    <p:sldId id="276" r:id="rId22"/>
+    <p:sldId id="277" r:id="rId23"/>
   </p:sldIdLst>
   <p:notesMasterIdLst>
-    <p:notesMasterId r:id="rId22"/>
+    <p:notesMasterId r:id="rId24"/>
   </p:notesMasterIdLst>
   <p:sldSz cx="9144000" cy="5143500"/>
   <p:notesSz cx="5143500" cy="9144000"/>
@@ -1601,6 +1603,182 @@
             <a:fld id="{F7021451-1387-4CA6-816F-3879F97B5CBC}" type="slidenum">
               <a:rPr lang="en-US"/>
               <a:t>20</a:t>
+            </a:fld>
+            <a:endParaRPr lang="en-US"/>
+          </a:p>
+        </p:txBody>
+      </p:sp>
+    </p:spTree>
+    <p:extLst>
+      <p:ext uri="{BB962C8B-B14F-4D97-AF65-F5344CB8AC3E}">
+        <p14:creationId xmlns:p14="http://schemas.microsoft.com/office/powerpoint/2010/main" val="1024086991"/>
+      </p:ext>
+    </p:extLst>
+  </p:cSld>
+  <p:clrMapOvr>
+    <a:masterClrMapping/>
+  </p:clrMapOvr>
+</p:notes>
+</file>
+
+<file path=ppt/notesSlides/notesSlide21.xml><?xml version="1.0" encoding="utf-8"?>
+<p:notes xmlns:a="http://schemas.openxmlformats.org/drawingml/2006/main" xmlns:r="http://schemas.openxmlformats.org/officeDocument/2006/relationships" xmlns:p="http://schemas.openxmlformats.org/presentationml/2006/main">
+  <p:cSld>
+    <p:spTree>
+      <p:nvGrpSpPr>
+        <p:cNvPr id="1" name=""/>
+        <p:cNvGrpSpPr/>
+        <p:nvPr/>
+      </p:nvGrpSpPr>
+      <p:grpSpPr>
+        <a:xfrm>
+          <a:off x="0" y="0"/>
+          <a:ext cx="0" cy="0"/>
+          <a:chOff x="0" y="0"/>
+          <a:chExt cx="0" cy="0"/>
+        </a:xfrm>
+      </p:grpSpPr>
+      <p:sp>
+        <p:nvSpPr>
+          <p:cNvPr id="2" name="Slide Image Placeholder 1"/>
+          <p:cNvSpPr>
+            <a:spLocks noGrp="1" noRot="1" noChangeAspect="1"/>
+          </p:cNvSpPr>
+          <p:nvPr>
+            <p:ph type="sldImg"/>
+          </p:nvPr>
+        </p:nvSpPr>
+        <p:spPr/>
+      </p:sp>
+      <p:sp>
+        <p:nvSpPr>
+          <p:cNvPr id="3" name="Notes Placeholder 2"/>
+          <p:cNvSpPr>
+            <a:spLocks noGrp="1"/>
+          </p:cNvSpPr>
+          <p:nvPr>
+            <p:ph type="body" idx="1"/>
+          </p:nvPr>
+        </p:nvSpPr>
+        <p:spPr/>
+        <p:txBody>
+          <a:bodyPr/>
+          <a:lstStyle/>
+          <a:p>
+            <a:r>
+              <a:rPr lang="en-US" dirty="0"/>
+              <a:t/>
+            </a:r>
+            <a:endParaRPr lang="en-US" dirty="0"/>
+          </a:p>
+        </p:txBody>
+      </p:sp>
+      <p:sp>
+        <p:nvSpPr>
+          <p:cNvPr id="4" name="Slide Number Placeholder 3"/>
+          <p:cNvSpPr>
+            <a:spLocks noGrp="1"/>
+          </p:cNvSpPr>
+          <p:nvPr>
+            <p:ph type="sldNum" sz="quarter" idx="10"/>
+          </p:nvPr>
+        </p:nvSpPr>
+        <p:spPr/>
+        <p:txBody>
+          <a:bodyPr/>
+          <a:lstStyle/>
+          <a:p>
+            <a:fld id="{F7021451-1387-4CA6-816F-3879F97B5CBC}" type="slidenum">
+              <a:rPr lang="en-US"/>
+              <a:t>21</a:t>
+            </a:fld>
+            <a:endParaRPr lang="en-US"/>
+          </a:p>
+        </p:txBody>
+      </p:sp>
+    </p:spTree>
+    <p:extLst>
+      <p:ext uri="{BB962C8B-B14F-4D97-AF65-F5344CB8AC3E}">
+        <p14:creationId xmlns:p14="http://schemas.microsoft.com/office/powerpoint/2010/main" val="1024086991"/>
+      </p:ext>
+    </p:extLst>
+  </p:cSld>
+  <p:clrMapOvr>
+    <a:masterClrMapping/>
+  </p:clrMapOvr>
+</p:notes>
+</file>
+
+<file path=ppt/notesSlides/notesSlide22.xml><?xml version="1.0" encoding="utf-8"?>
+<p:notes xmlns:a="http://schemas.openxmlformats.org/drawingml/2006/main" xmlns:r="http://schemas.openxmlformats.org/officeDocument/2006/relationships" xmlns:p="http://schemas.openxmlformats.org/presentationml/2006/main">
+  <p:cSld>
+    <p:spTree>
+      <p:nvGrpSpPr>
+        <p:cNvPr id="1" name=""/>
+        <p:cNvGrpSpPr/>
+        <p:nvPr/>
+      </p:nvGrpSpPr>
+      <p:grpSpPr>
+        <a:xfrm>
+          <a:off x="0" y="0"/>
+          <a:ext cx="0" cy="0"/>
+          <a:chOff x="0" y="0"/>
+          <a:chExt cx="0" cy="0"/>
+        </a:xfrm>
+      </p:grpSpPr>
+      <p:sp>
+        <p:nvSpPr>
+          <p:cNvPr id="2" name="Slide Image Placeholder 1"/>
+          <p:cNvSpPr>
+            <a:spLocks noGrp="1" noRot="1" noChangeAspect="1"/>
+          </p:cNvSpPr>
+          <p:nvPr>
+            <p:ph type="sldImg"/>
+          </p:nvPr>
+        </p:nvSpPr>
+        <p:spPr/>
+      </p:sp>
+      <p:sp>
+        <p:nvSpPr>
+          <p:cNvPr id="3" name="Notes Placeholder 2"/>
+          <p:cNvSpPr>
+            <a:spLocks noGrp="1"/>
+          </p:cNvSpPr>
+          <p:nvPr>
+            <p:ph type="body" idx="1"/>
+          </p:nvPr>
+        </p:nvSpPr>
+        <p:spPr/>
+        <p:txBody>
+          <a:bodyPr/>
+          <a:lstStyle/>
+          <a:p>
+            <a:r>
+              <a:rPr lang="en-US" dirty="0"/>
+              <a:t/>
+            </a:r>
+            <a:endParaRPr lang="en-US" dirty="0"/>
+          </a:p>
+        </p:txBody>
+      </p:sp>
+      <p:sp>
+        <p:nvSpPr>
+          <p:cNvPr id="4" name="Slide Number Placeholder 3"/>
+          <p:cNvSpPr>
+            <a:spLocks noGrp="1"/>
+          </p:cNvSpPr>
+          <p:nvPr>
+            <p:ph type="sldNum" sz="quarter" idx="10"/>
+          </p:nvPr>
+        </p:nvSpPr>
+        <p:spPr/>
+        <p:txBody>
+          <a:bodyPr/>
+          <a:lstStyle/>
+          <a:p>
+            <a:fld id="{F7021451-1387-4CA6-816F-3879F97B5CBC}" type="slidenum">
+              <a:rPr lang="en-US"/>
+              <a:t>22</a:t>
             </a:fld>
             <a:endParaRPr lang="en-US"/>
           </a:p>
@@ -2567,8 +2745,8 @@
         </p:nvSpPr>
         <p:spPr>
           <a:xfrm>
-            <a:off x="457200" y="1463040"/>
-            <a:ext cx="8229600" cy="914400"/>
+            <a:off x="457200" y="1188720"/>
+            <a:ext cx="8229600" cy="1463040"/>
           </a:xfrm>
           <a:prstGeom prst="rect">
             <a:avLst/>
@@ -2584,14 +2762,28 @@
               <a:buNone/>
             </a:pPr>
             <a:r>
-              <a:rPr lang="en-US" sz="3600" b="1" dirty="0">
-                <a:solidFill>
-                  <a:srgbClr val="000000"/>
-                </a:solidFill>
-              </a:rPr>
-              <a:t>Evaluating Refactoring as a Process</a:t>
-            </a:r>
-            <a:endParaRPr lang="en-US" sz="3600" dirty="0"/>
+              <a:rPr lang="en-US" sz="3200" b="1" dirty="0">
+                <a:solidFill>
+                  <a:srgbClr val="000000"/>
+                </a:solidFill>
+              </a:rPr>
+              <a:t>Beyond Before-and-After</a:t>
+            </a:r>
+            <a:endParaRPr lang="en-US" sz="3200" dirty="0"/>
+          </a:p>
+          <a:p>
+            <a:pPr algn="ctr" indent="0" marL="0">
+              <a:buNone/>
+            </a:pPr>
+            <a:r>
+              <a:rPr lang="en-US" sz="3200" b="1" dirty="0">
+                <a:solidFill>
+                  <a:srgbClr val="000000"/>
+                </a:solidFill>
+              </a:rPr>
+              <a:t>Process-Quality Evaluation of Refactoring Sessions</a:t>
+            </a:r>
+            <a:endParaRPr lang="en-US" sz="3200" dirty="0"/>
           </a:p>
         </p:txBody>
       </p:sp>
@@ -2603,7 +2795,7 @@
         </p:nvSpPr>
         <p:spPr>
           <a:xfrm>
-            <a:off x="457200" y="2468880"/>
+            <a:off x="457200" y="2834640"/>
             <a:ext cx="8229600" cy="822960"/>
           </a:xfrm>
           <a:prstGeom prst="rect">
@@ -2758,7 +2950,7 @@
                   <a:srgbClr val="000000"/>
                 </a:solidFill>
               </a:rPr>
-              <a:t>Manual-Refactor: detect + synthesise</a:t>
+              <a:t>Four kinds of divergence</a:t>
             </a:r>
             <a:endParaRPr lang="en-US" sz="2800" dirty="0"/>
           </a:p>
@@ -2798,7 +2990,7 @@
                   <a:srgbClr val="000000"/>
                 </a:solidFill>
               </a:rPr>
-              <a:t>What: developer hand-edited something the IDE could have done safely (and with its precondition checks).</a:t>
+              <a:t>Four categories of process waste - each fitting the four requirements: detectable from the event stream, actionable for the developer, synthesisable as a concrete alternative.</a:t>
             </a:r>
             <a:endParaRPr lang="en-US" sz="1600" dirty="0"/>
           </a:p>
@@ -2816,7 +3008,7 @@
                   <a:srgbClr val="000000"/>
                 </a:solidFill>
               </a:rPr>
-              <a:t>Detect: run RefactoringMiner on sliding commit windows; cross-check against the IDE event stream.</a:t>
+              <a:t>Ordering - right refactorings, wrong sequence.</a:t>
             </a:r>
             <a:endParaRPr lang="en-US" sz="1600" dirty="0"/>
           </a:p>
@@ -2834,7 +3026,7 @@
                   <a:srgbClr val="000000"/>
                 </a:solidFill>
               </a:rPr>
-              <a:t>Anything RefactoringMiner finds that the IDE did not emit is a manual refactoring.</a:t>
+              <a:t>Manual-Refactor - wrong tool (hand-edit when the IDE could safely have done it).</a:t>
             </a:r>
             <a:endParaRPr lang="en-US" sz="1600" dirty="0"/>
           </a:p>
@@ -2852,7 +3044,7 @@
                   <a:srgbClr val="000000"/>
                 </a:solidFill>
               </a:rPr>
-              <a:t>Synthesise: apply the equivalent IDE refactoring, then three-way merge the user's other edits back on top.</a:t>
+              <a:t>Rework - wrong churn (added then removed).</a:t>
             </a:r>
             <a:endParaRPr lang="en-US" sz="1600" dirty="0"/>
           </a:p>
@@ -2870,7 +3062,25 @@
                   <a:srgbClr val="000000"/>
                 </a:solidFill>
               </a:rPr>
-              <a:t>Wrap-and-patch layer reconciles minor JDT ↔ IntelliJ AST differences (e.g. static modifiers, variable liveness) so the synthesised path validates.</a:t>
+              <a:t>Hygiene - missing safety checkpoints (no tests, no commits).</a:t>
+            </a:r>
+            <a:endParaRPr lang="en-US" sz="1600" dirty="0"/>
+          </a:p>
+          <a:p>
+            <a:pPr marL="342900" indent="-342900">
+              <a:spcAft>
+                <a:spcPts val="600"/>
+              </a:spcAft>
+              <a:buSzPct val="100000"/>
+              <a:buChar char="•"/>
+            </a:pPr>
+            <a:r>
+              <a:rPr lang="en-US" sz="1600" dirty="0">
+                <a:solidFill>
+                  <a:srgbClr val="000000"/>
+                </a:solidFill>
+              </a:rPr>
+              <a:t>Each kind gets its own slide next, covering both detection and synthesis.</a:t>
             </a:r>
             <a:endParaRPr lang="en-US" sz="1600" dirty="0"/>
           </a:p>
@@ -2931,7 +3141,7 @@
                   <a:srgbClr val="000000"/>
                 </a:solidFill>
               </a:rPr>
-              <a:t>Rework: detect + synthesise</a:t>
+              <a:t>Ordering: detect + synthesise</a:t>
             </a:r>
             <a:endParaRPr lang="en-US" sz="2800" dirty="0"/>
           </a:p>
@@ -2945,8 +3155,8 @@
         </p:nvSpPr>
         <p:spPr>
           <a:xfrm>
-            <a:off x="457200" y="1188720"/>
-            <a:ext cx="8229600" cy="3657600"/>
+            <a:off x="457200" y="1097280"/>
+            <a:ext cx="8229600" cy="1783080"/>
           </a:xfrm>
           <a:prstGeom prst="rect">
             <a:avLst/>
@@ -2966,14 +3176,14 @@
               <a:buChar char="•"/>
             </a:pPr>
             <a:r>
-              <a:rPr lang="en-US" sz="1600" dirty="0">
-                <a:solidFill>
-                  <a:srgbClr val="000000"/>
-                </a:solidFill>
-              </a:rPr>
-              <a:t>What: code added and later removed (or vice versa) — net-zero churn, but real cost while it was there.</a:t>
-            </a:r>
-            <a:endParaRPr lang="en-US" sz="1600" dirty="0"/>
+              <a:rPr lang="en-US" sz="1400" dirty="0">
+                <a:solidFill>
+                  <a:srgbClr val="000000"/>
+                </a:solidFill>
+              </a:rPr>
+              <a:t>What: the right refactorings, performed in a suboptimal order - final state is fine, intermediate states are worse than they needed to be.</a:t>
+            </a:r>
+            <a:endParaRPr lang="en-US" sz="1400" dirty="0"/>
           </a:p>
           <a:p>
             <a:pPr marL="342900" indent="-342900">
@@ -2984,14 +3194,14 @@
               <a:buChar char="•"/>
             </a:pPr>
             <a:r>
-              <a:rPr lang="en-US" sz="1600" dirty="0">
-                <a:solidFill>
-                  <a:srgbClr val="000000"/>
-                </a:solidFill>
-              </a:rPr>
-              <a:t>Detect: hash normalised lines; pair add/remove events by (file, scope, content-hash).</a:t>
-            </a:r>
-            <a:endParaRPr lang="en-US" sz="1600" dirty="0"/>
+              <a:rPr lang="en-US" sz="1400" dirty="0">
+                <a:solidFill>
+                  <a:srgbClr val="000000"/>
+                </a:solidFill>
+              </a:rPr>
+              <a:t>Detect: find a subsequence of refactorings whose reordering still validates to the user's terminal state (canonical AST hash, formatting/comments ignored).</a:t>
+            </a:r>
+            <a:endParaRPr lang="en-US" sz="1400" dirty="0"/>
           </a:p>
           <a:p>
             <a:pPr marL="342900" indent="-342900">
@@ -3002,14 +3212,14 @@
               <a:buChar char="•"/>
             </a:pPr>
             <a:r>
-              <a:rPr lang="en-US" sz="1600" dirty="0">
-                <a:solidFill>
-                  <a:srgbClr val="000000"/>
-                </a:solidFill>
-              </a:rPr>
-              <a:t>Synthesise: strip both halves from the trajectory; replay the rest of the user's edits unchanged; validate the terminal state matches.</a:t>
-            </a:r>
-            <a:endParaRPr lang="en-US" sz="1600" dirty="0"/>
+              <a:rPr lang="en-US" sz="1400" dirty="0">
+                <a:solidFill>
+                  <a:srgbClr val="000000"/>
+                </a:solidFill>
+              </a:rPr>
+              <a:t>Synthesise: build a dependency DAG over the refactorings in the window.</a:t>
+            </a:r>
+            <a:endParaRPr lang="en-US" sz="1400" dirty="0"/>
           </a:p>
           <a:p>
             <a:pPr marL="342900" indent="-342900">
@@ -3020,17 +3230,41 @@
               <a:buChar char="•"/>
             </a:pPr>
             <a:r>
-              <a:rPr lang="en-US" sz="1600" dirty="0">
-                <a:solidFill>
-                  <a:srgbClr val="000000"/>
-                </a:solidFill>
-              </a:rPr>
-              <a:t>Simplest of the four synthesisers, but high recall — precision and recall both 1.00 on the injection set.</a:t>
-            </a:r>
-            <a:endParaRPr lang="en-US" sz="1600" dirty="0"/>
-          </a:p>
-        </p:txBody>
-      </p:sp>
+              <a:rPr lang="en-US" sz="1400" dirty="0">
+                <a:solidFill>
+                  <a:srgbClr val="000000"/>
+                </a:solidFill>
+              </a:rPr>
+              <a:t>Prefix-trie DFS over valid topological orderings - shares work across common prefixes, rolls back with git checkout on backtrack.</a:t>
+            </a:r>
+            <a:endParaRPr lang="en-US" sz="1400" dirty="0"/>
+          </a:p>
+        </p:txBody>
+      </p:sp>
+      <p:pic>
+        <p:nvPicPr>
+          <p:cNvPr id="4" name="Image 0" descr="images/reorder-synthesis.png">    </p:cNvPr>
+          <p:cNvPicPr>
+            <a:picLocks noChangeAspect="1"/>
+          </p:cNvPicPr>
+          <p:nvPr/>
+        </p:nvPicPr>
+        <p:blipFill>
+          <a:blip r:embed="rId1"/>
+          <a:stretch>
+            <a:fillRect/>
+          </a:stretch>
+        </p:blipFill>
+        <p:spPr>
+          <a:xfrm>
+            <a:off x="1828800" y="3017520"/>
+            <a:ext cx="5486400" cy="1874520"/>
+          </a:xfrm>
+          <a:prstGeom prst="rect">
+            <a:avLst/>
+          </a:prstGeom>
+        </p:spPr>
+      </p:pic>
     </p:spTree>
   </p:cSld>
   <p:clrMapOvr>
@@ -3086,7 +3320,7 @@
                   <a:srgbClr val="000000"/>
                 </a:solidFill>
               </a:rPr>
-              <a:t>Hygiene: detect + synthesise</a:t>
+              <a:t>Manual-Refactor: detect + synthesise</a:t>
             </a:r>
             <a:endParaRPr lang="en-US" sz="2800" dirty="0"/>
           </a:p>
@@ -3100,8 +3334,8 @@
         </p:nvSpPr>
         <p:spPr>
           <a:xfrm>
-            <a:off x="457200" y="1188720"/>
-            <a:ext cx="8229600" cy="3657600"/>
+            <a:off x="457200" y="1097280"/>
+            <a:ext cx="8229600" cy="1691640"/>
           </a:xfrm>
           <a:prstGeom prst="rect">
             <a:avLst/>
@@ -3121,14 +3355,14 @@
               <a:buChar char="•"/>
             </a:pPr>
             <a:r>
-              <a:rPr lang="en-US" sz="1600" dirty="0">
-                <a:solidFill>
-                  <a:srgbClr val="000000"/>
-                </a:solidFill>
-              </a:rPr>
-              <a:t>What: long stretches of work without safety checkpoints — no test runs, no commits.</a:t>
-            </a:r>
-            <a:endParaRPr lang="en-US" sz="1600" dirty="0"/>
+              <a:rPr lang="en-US" sz="1300" dirty="0">
+                <a:solidFill>
+                  <a:srgbClr val="000000"/>
+                </a:solidFill>
+              </a:rPr>
+              <a:t>What: developer hand-edited something the IDE could have done safely (and with its precondition checks).</a:t>
+            </a:r>
+            <a:endParaRPr lang="en-US" sz="1300" dirty="0"/>
           </a:p>
           <a:p>
             <a:pPr marL="342900" indent="-342900">
@@ -3139,14 +3373,14 @@
               <a:buChar char="•"/>
             </a:pPr>
             <a:r>
-              <a:rPr lang="en-US" sz="1600" dirty="0">
-                <a:solidFill>
-                  <a:srgbClr val="000000"/>
-                </a:solidFill>
-              </a:rPr>
-              <a:t>Detect: 60-second windows with no test-run events; commit-gap events when commits are spaced beyond threshold.</a:t>
-            </a:r>
-            <a:endParaRPr lang="en-US" sz="1600" dirty="0"/>
+              <a:rPr lang="en-US" sz="1300" dirty="0">
+                <a:solidFill>
+                  <a:srgbClr val="000000"/>
+                </a:solidFill>
+              </a:rPr>
+              <a:t>Detect: run RefactoringMiner on sliding commit windows; cross-check against the IDE event stream — anything RefactoringMiner finds that the IDE did not emit is a manual refactoring.</a:t>
+            </a:r>
+            <a:endParaRPr lang="en-US" sz="1300" dirty="0"/>
           </a:p>
           <a:p>
             <a:pPr marL="342900" indent="-342900">
@@ -3157,14 +3391,14 @@
               <a:buChar char="•"/>
             </a:pPr>
             <a:r>
-              <a:rPr lang="en-US" sz="1600" dirty="0">
-                <a:solidFill>
-                  <a:srgbClr val="000000"/>
-                </a:solidFill>
-              </a:rPr>
-              <a:t>Synthesise: model an alternative cadence that inserts test-run and commit events at the right points.</a:t>
-            </a:r>
-            <a:endParaRPr lang="en-US" sz="1600" dirty="0"/>
+              <a:rPr lang="en-US" sz="1300" dirty="0">
+                <a:solidFill>
+                  <a:srgbClr val="000000"/>
+                </a:solidFill>
+              </a:rPr>
+              <a:t>Synthesise: apply the equivalent IDE refactoring, then three-way merge the user's other edits back on top.</a:t>
+            </a:r>
+            <a:endParaRPr lang="en-US" sz="1300" dirty="0"/>
           </a:p>
           <a:p>
             <a:pPr marL="342900" indent="-342900">
@@ -3175,35 +3409,41 @@
               <a:buChar char="•"/>
             </a:pPr>
             <a:r>
-              <a:rPr lang="en-US" sz="1600" dirty="0">
-                <a:solidFill>
-                  <a:srgbClr val="000000"/>
-                </a:solidFill>
-              </a:rPr>
-              <a:t>The alternative's J(τ) credits those checkpoints via the skip-tests and commit-gap terms.</a:t>
-            </a:r>
-            <a:endParaRPr lang="en-US" sz="1600" dirty="0"/>
-          </a:p>
-          <a:p>
-            <a:pPr marL="342900" indent="-342900">
-              <a:spcAft>
-                <a:spcPts val="600"/>
-              </a:spcAft>
-              <a:buSzPct val="100000"/>
-              <a:buChar char="•"/>
-            </a:pPr>
-            <a:r>
-              <a:rPr lang="en-US" sz="1600" dirty="0">
-                <a:solidFill>
-                  <a:srgbClr val="000000"/>
-                </a:solidFill>
-              </a:rPr>
-              <a:t>Cheap to compute, but consistently surfaces meaningful divergences in the user study.</a:t>
-            </a:r>
-            <a:endParaRPr lang="en-US" sz="1600" dirty="0"/>
-          </a:p>
-        </p:txBody>
-      </p:sp>
+              <a:rPr lang="en-US" sz="1300" dirty="0">
+                <a:solidFill>
+                  <a:srgbClr val="000000"/>
+                </a:solidFill>
+              </a:rPr>
+              <a:t>Wrap-and-patch layer reconciles minor JDT ↔ IntelliJ AST differences (e.g. static modifiers, variable liveness).</a:t>
+            </a:r>
+            <a:endParaRPr lang="en-US" sz="1300" dirty="0"/>
+          </a:p>
+        </p:txBody>
+      </p:sp>
+      <p:pic>
+        <p:nvPicPr>
+          <p:cNvPr id="4" name="Image 0" descr="images/manual-refactor.png">    </p:cNvPr>
+          <p:cNvPicPr>
+            <a:picLocks noChangeAspect="1"/>
+          </p:cNvPicPr>
+          <p:nvPr/>
+        </p:nvPicPr>
+        <p:blipFill>
+          <a:blip r:embed="rId1"/>
+          <a:stretch>
+            <a:fillRect/>
+          </a:stretch>
+        </p:blipFill>
+        <p:spPr>
+          <a:xfrm>
+            <a:off x="1463040" y="2880360"/>
+            <a:ext cx="6217920" cy="2039112"/>
+          </a:xfrm>
+          <a:prstGeom prst="rect">
+            <a:avLst/>
+          </a:prstGeom>
+        </p:spPr>
+      </p:pic>
     </p:spTree>
   </p:cSld>
   <p:clrMapOvr>
@@ -3259,7 +3499,7 @@
                   <a:srgbClr val="000000"/>
                 </a:solidFill>
               </a:rPr>
-              <a:t>Comparable divergence magnitudes</a:t>
+              <a:t>Rework: detect + synthesise</a:t>
             </a:r>
             <a:endParaRPr lang="en-US" sz="2800" dirty="0"/>
           </a:p>
@@ -3273,8 +3513,8 @@
         </p:nvSpPr>
         <p:spPr>
           <a:xfrm>
-            <a:off x="457200" y="1188720"/>
-            <a:ext cx="8229600" cy="3657600"/>
+            <a:off x="457200" y="1097280"/>
+            <a:ext cx="8229600" cy="1691640"/>
           </a:xfrm>
           <a:prstGeom prst="rect">
             <a:avLst/>
@@ -3294,14 +3534,14 @@
               <a:buChar char="•"/>
             </a:pPr>
             <a:r>
-              <a:rPr lang="en-US" sz="1600" dirty="0">
-                <a:solidFill>
-                  <a:srgbClr val="000000"/>
-                </a:solidFill>
-              </a:rPr>
-              <a:t>Magnitude = J(τ*_final) − J(τ_final).</a:t>
-            </a:r>
-            <a:endParaRPr lang="en-US" sz="1600" dirty="0"/>
+              <a:rPr lang="en-US" sz="1300" dirty="0">
+                <a:solidFill>
+                  <a:srgbClr val="000000"/>
+                </a:solidFill>
+              </a:rPr>
+              <a:t>What: code added and later removed (or vice versa) - net-zero churn, but real cost while it was there.</a:t>
+            </a:r>
+            <a:endParaRPr lang="en-US" sz="1300" dirty="0"/>
           </a:p>
           <a:p>
             <a:pPr marL="342900" indent="-342900">
@@ -3312,14 +3552,14 @@
               <a:buChar char="•"/>
             </a:pPr>
             <a:r>
-              <a:rPr lang="en-US" sz="1600" dirty="0">
-                <a:solidFill>
-                  <a:srgbClr val="000000"/>
-                </a:solidFill>
-              </a:rPr>
-              <a:t>The score gap when the alternative is substituted at the divergence point but the rest of the user's trajectory is left unchanged.</a:t>
-            </a:r>
-            <a:endParaRPr lang="en-US" sz="1600" dirty="0"/>
+              <a:rPr lang="en-US" sz="1300" dirty="0">
+                <a:solidFill>
+                  <a:srgbClr val="000000"/>
+                </a:solidFill>
+              </a:rPr>
+              <a:t>Detect: hash normalised lines; pair add/remove events by (file, scope, content-hash).</a:t>
+            </a:r>
+            <a:endParaRPr lang="en-US" sz="1300" dirty="0"/>
           </a:p>
           <a:p>
             <a:pPr marL="342900" indent="-342900">
@@ -3330,14 +3570,14 @@
               <a:buChar char="•"/>
             </a:pPr>
             <a:r>
-              <a:rPr lang="en-US" sz="1600" dirty="0">
-                <a:solidFill>
-                  <a:srgbClr val="000000"/>
-                </a:solidFill>
-              </a:rPr>
-              <a:t>Makes magnitudes comparable across all four divergence kinds.</a:t>
-            </a:r>
-            <a:endParaRPr lang="en-US" sz="1600" dirty="0"/>
+              <a:rPr lang="en-US" sz="1300" dirty="0">
+                <a:solidFill>
+                  <a:srgbClr val="000000"/>
+                </a:solidFill>
+              </a:rPr>
+              <a:t>Synthesise: strip both halves from the trajectory; replay the rest of the user's edits unchanged; validate the terminal state matches.</a:t>
+            </a:r>
+            <a:endParaRPr lang="en-US" sz="1300" dirty="0"/>
           </a:p>
           <a:p>
             <a:pPr marL="342900" indent="-342900">
@@ -3348,35 +3588,41 @@
               <a:buChar char="•"/>
             </a:pPr>
             <a:r>
-              <a:rPr lang="en-US" sz="1600" dirty="0">
-                <a:solidFill>
-                  <a:srgbClr val="000000"/>
-                </a:solidFill>
-              </a:rPr>
-              <a:t>Lets the dashboard rank divergence points and surface the most impactful first.</a:t>
-            </a:r>
-            <a:endParaRPr lang="en-US" sz="1600" dirty="0"/>
-          </a:p>
-          <a:p>
-            <a:pPr marL="342900" indent="-342900">
-              <a:spcAft>
-                <a:spcPts val="600"/>
-              </a:spcAft>
-              <a:buSzPct val="100000"/>
-              <a:buChar char="•"/>
-            </a:pPr>
-            <a:r>
-              <a:rPr lang="en-US" sz="1600" dirty="0">
-                <a:solidFill>
-                  <a:srgbClr val="000000"/>
-                </a:solidFill>
-              </a:rPr>
-              <a:t>This is the number the demo will point at.</a:t>
-            </a:r>
-            <a:endParaRPr lang="en-US" sz="1600" dirty="0"/>
-          </a:p>
-        </p:txBody>
-      </p:sp>
+              <a:rPr lang="en-US" sz="1300" dirty="0">
+                <a:solidFill>
+                  <a:srgbClr val="000000"/>
+                </a:solidFill>
+              </a:rPr>
+              <a:t>Simplest of the four synthesisers, but high recall - precision and recall both 1.00 on the injection set.</a:t>
+            </a:r>
+            <a:endParaRPr lang="en-US" sz="1300" dirty="0"/>
+          </a:p>
+        </p:txBody>
+      </p:sp>
+      <p:pic>
+        <p:nvPicPr>
+          <p:cNvPr id="4" name="Image 0" descr="images/rework.png">    </p:cNvPr>
+          <p:cNvPicPr>
+            <a:picLocks noChangeAspect="1"/>
+          </p:cNvPicPr>
+          <p:nvPr/>
+        </p:nvPicPr>
+        <p:blipFill>
+          <a:blip r:embed="rId1"/>
+          <a:stretch>
+            <a:fillRect/>
+          </a:stretch>
+        </p:blipFill>
+        <p:spPr>
+          <a:xfrm>
+            <a:off x="2377440" y="2834640"/>
+            <a:ext cx="4389120" cy="2121408"/>
+          </a:xfrm>
+          <a:prstGeom prst="rect">
+            <a:avLst/>
+          </a:prstGeom>
+        </p:spPr>
+      </p:pic>
     </p:spTree>
   </p:cSld>
   <p:clrMapOvr>
@@ -3432,7 +3678,7 @@
                   <a:srgbClr val="000000"/>
                 </a:solidFill>
               </a:rPr>
-              <a:t>Three datasets</a:t>
+              <a:t>Hygiene: detect + synthesise</a:t>
             </a:r>
             <a:endParaRPr lang="en-US" sz="2800" dirty="0"/>
           </a:p>
@@ -3472,7 +3718,7 @@
                   <a:srgbClr val="000000"/>
                 </a:solidFill>
               </a:rPr>
-              <a:t>45 hand-recorded injection sessions with deliberately-injected bad behaviours (labelled ground truth).</a:t>
+              <a:t>What: long stretches of work without safety checkpoints - no test runs, no commits.</a:t>
             </a:r>
             <a:endParaRPr lang="en-US" sz="1600" dirty="0"/>
           </a:p>
@@ -3490,7 +3736,7 @@
                   <a:srgbClr val="000000"/>
                 </a:solidFill>
               </a:rPr>
-              <a:t>30-session randomised user study — 5 participants, 3 with-feedback vs 2 no-feedback baseline.</a:t>
+              <a:t>Detect: 60-second windows with no test-run events; commit-gap events when commits are spaced beyond threshold.</a:t>
             </a:r>
             <a:endParaRPr lang="en-US" sz="1600" dirty="0"/>
           </a:p>
@@ -3508,7 +3754,43 @@
                   <a:srgbClr val="000000"/>
                 </a:solidFill>
               </a:rPr>
-              <a:t>48-session agent extension across 8 LLM agent stacks (mentioned briefly — motivates future work).</a:t>
+              <a:t>Synthesise: model an alternative cadence that inserts test-run and commit events at the right points.</a:t>
+            </a:r>
+            <a:endParaRPr lang="en-US" sz="1600" dirty="0"/>
+          </a:p>
+          <a:p>
+            <a:pPr marL="342900" indent="-342900">
+              <a:spcAft>
+                <a:spcPts val="600"/>
+              </a:spcAft>
+              <a:buSzPct val="100000"/>
+              <a:buChar char="•"/>
+            </a:pPr>
+            <a:r>
+              <a:rPr lang="en-US" sz="1600" dirty="0">
+                <a:solidFill>
+                  <a:srgbClr val="000000"/>
+                </a:solidFill>
+              </a:rPr>
+              <a:t>The alternative's J(τ) credits those checkpoints via the skip-tests and commit-gap terms.</a:t>
+            </a:r>
+            <a:endParaRPr lang="en-US" sz="1600" dirty="0"/>
+          </a:p>
+          <a:p>
+            <a:pPr marL="342900" indent="-342900">
+              <a:spcAft>
+                <a:spcPts val="600"/>
+              </a:spcAft>
+              <a:buSzPct val="100000"/>
+              <a:buChar char="•"/>
+            </a:pPr>
+            <a:r>
+              <a:rPr lang="en-US" sz="1600" dirty="0">
+                <a:solidFill>
+                  <a:srgbClr val="000000"/>
+                </a:solidFill>
+              </a:rPr>
+              <a:t>Cheap to compute, but consistently surfaces meaningful divergences in the user study.</a:t>
             </a:r>
             <a:endParaRPr lang="en-US" sz="1600" dirty="0"/>
           </a:p>
@@ -3569,7 +3851,7 @@
                   <a:srgbClr val="000000"/>
                 </a:solidFill>
               </a:rPr>
-              <a:t>Detector precision &amp; recall</a:t>
+              <a:t>Comparable divergence magnitudes</a:t>
             </a:r>
             <a:endParaRPr lang="en-US" sz="2800" dirty="0"/>
           </a:p>
@@ -3609,7 +3891,7 @@
                   <a:srgbClr val="000000"/>
                 </a:solidFill>
               </a:rPr>
-              <a:t>Precision = 1.00 across all four divergence kinds — every detection is valid.</a:t>
+              <a:t>Magnitude = J(τ*_final) − J(τ_final).</a:t>
             </a:r>
             <a:endParaRPr lang="en-US" sz="1600" dirty="0"/>
           </a:p>
@@ -3627,7 +3909,7 @@
                   <a:srgbClr val="000000"/>
                 </a:solidFill>
               </a:rPr>
-              <a:t>Recall — Rework 1.00, Hygiene 1.00, Manual-Refactor 0.76, Ordering 0.40.</a:t>
+              <a:t>The score gap when the alternative is substituted at the divergence point but the rest of the user's trajectory is left unchanged.</a:t>
             </a:r>
             <a:endParaRPr lang="en-US" sz="1600" dirty="0"/>
           </a:p>
@@ -3645,7 +3927,7 @@
                   <a:srgbClr val="000000"/>
                 </a:solidFill>
               </a:rPr>
-              <a:t>Inter-rater agreement (Cohen's κ) — 1.00 for Ordering and Manual-Refactor, 0.86 for Rework, 0.72 for Hygiene.</a:t>
+              <a:t>Makes magnitudes comparable across all four divergence kinds.</a:t>
             </a:r>
             <a:endParaRPr lang="en-US" sz="1600" dirty="0"/>
           </a:p>
@@ -3663,7 +3945,25 @@
                   <a:srgbClr val="000000"/>
                 </a:solidFill>
               </a:rPr>
-              <a:t>Ordering recall gap is honest and explained: the synthesiser rejects windows it cannot safely reproduce. A scope limit, not a detector flaw.</a:t>
+              <a:t>Lets the dashboard surface each divergence point alongside its score impact, so the highest-impact moments are easy to spot in the session summary.</a:t>
+            </a:r>
+            <a:endParaRPr lang="en-US" sz="1600" dirty="0"/>
+          </a:p>
+          <a:p>
+            <a:pPr marL="342900" indent="-342900">
+              <a:spcAft>
+                <a:spcPts val="600"/>
+              </a:spcAft>
+              <a:buSzPct val="100000"/>
+              <a:buChar char="•"/>
+            </a:pPr>
+            <a:r>
+              <a:rPr lang="en-US" sz="1600" dirty="0">
+                <a:solidFill>
+                  <a:srgbClr val="000000"/>
+                </a:solidFill>
+              </a:rPr>
+              <a:t>This is the number the demo will point at.</a:t>
             </a:r>
             <a:endParaRPr lang="en-US" sz="1600" dirty="0"/>
           </a:p>
@@ -3702,8 +4002,8 @@
         </p:nvSpPr>
         <p:spPr>
           <a:xfrm>
-            <a:off x="457200" y="274320"/>
-            <a:ext cx="8229600" cy="640080"/>
+            <a:off x="457200" y="1828800"/>
+            <a:ext cx="8229600" cy="914400"/>
           </a:xfrm>
           <a:prstGeom prst="rect">
             <a:avLst/>
@@ -3715,18 +4015,18 @@
           <a:bodyPr wrap="square" lIns="0" tIns="0" rIns="0" bIns="0" rtlCol="0" anchor="ctr"/>
           <a:lstStyle/>
           <a:p>
-            <a:pPr indent="0" marL="0">
+            <a:pPr algn="ctr" indent="0" marL="0">
               <a:buNone/>
             </a:pPr>
             <a:r>
-              <a:rPr lang="en-US" sz="2800" b="1" dirty="0">
-                <a:solidFill>
-                  <a:srgbClr val="000000"/>
-                </a:solidFill>
-              </a:rPr>
-              <a:t>Score robustness</a:t>
-            </a:r>
-            <a:endParaRPr lang="en-US" sz="2800" dirty="0"/>
+              <a:rPr lang="en-US" sz="4400" b="1" dirty="0">
+                <a:solidFill>
+                  <a:srgbClr val="000000"/>
+                </a:solidFill>
+              </a:rPr>
+              <a:t>Demo (part 2): results</a:t>
+            </a:r>
+            <a:endParaRPr lang="en-US" sz="4400" dirty="0"/>
           </a:p>
         </p:txBody>
       </p:sp>
@@ -3738,8 +4038,8 @@
         </p:nvSpPr>
         <p:spPr>
           <a:xfrm>
-            <a:off x="457200" y="1188720"/>
-            <a:ext cx="8229600" cy="3657600"/>
+            <a:off x="457200" y="2834640"/>
+            <a:ext cx="8229600" cy="1097280"/>
           </a:xfrm>
           <a:prstGeom prst="rect">
             <a:avLst/>
@@ -3748,79 +4048,21 @@
           <a:ln/>
         </p:spPr>
         <p:txBody>
-          <a:bodyPr wrap="square" rtlCol="0" anchor="t"/>
-          <a:lstStyle/>
-          <a:p>
-            <a:pPr marL="342900" indent="-342900">
-              <a:spcAft>
-                <a:spcPts val="600"/>
-              </a:spcAft>
-              <a:buSzPct val="100000"/>
-              <a:buChar char="•"/>
-            </a:pPr>
-            <a:r>
-              <a:rPr lang="en-US" sz="1600" dirty="0">
-                <a:solidFill>
-                  <a:srgbClr val="000000"/>
-                </a:solidFill>
-              </a:rPr>
-              <a:t>Single-knob sensitivity sweep: scale any one weight by {0.1×–10×}, top-1 recommendation is preserved in 96.5% of user-study cases.</a:t>
-            </a:r>
-            <a:endParaRPr lang="en-US" sz="1600" dirty="0"/>
-          </a:p>
-          <a:p>
-            <a:pPr marL="342900" indent="-342900">
-              <a:spcAft>
-                <a:spcPts val="600"/>
-              </a:spcAft>
-              <a:buSzPct val="100000"/>
-              <a:buChar char="•"/>
-            </a:pPr>
-            <a:r>
-              <a:rPr lang="en-US" sz="1600" dirty="0">
-                <a:solidFill>
-                  <a:srgbClr val="000000"/>
-                </a:solidFill>
-              </a:rPr>
-              <a:t>Multi-knob Monte Carlo (200 samples): top-1 stability drops to 84.6%; mean Kendall τ = 0.586.</a:t>
-            </a:r>
-            <a:endParaRPr lang="en-US" sz="1600" dirty="0"/>
-          </a:p>
-          <a:p>
-            <a:pPr marL="342900" indent="-342900">
-              <a:spcAft>
-                <a:spcPts val="600"/>
-              </a:spcAft>
-              <a:buSzPct val="100000"/>
-              <a:buChar char="•"/>
-            </a:pPr>
-            <a:r>
-              <a:rPr lang="en-US" sz="1600" dirty="0">
-                <a:solidFill>
-                  <a:srgbClr val="000000"/>
-                </a:solidFill>
-              </a:rPr>
-              <a:t>Honest framing — stable near the chosen weights, less stable under arbitrary joint perturbations.</a:t>
-            </a:r>
-            <a:endParaRPr lang="en-US" sz="1600" dirty="0"/>
-          </a:p>
-          <a:p>
-            <a:pPr marL="342900" indent="-342900">
-              <a:spcAft>
-                <a:spcPts val="600"/>
-              </a:spcAft>
-              <a:buSzPct val="100000"/>
-              <a:buChar char="•"/>
-            </a:pPr>
-            <a:r>
-              <a:rPr lang="en-US" sz="1600" dirty="0">
-                <a:solidFill>
-                  <a:srgbClr val="000000"/>
-                </a:solidFill>
-              </a:rPr>
-              <a:t>Ablation confirms each process term contributes real signal; endpoint gain alone does not recover the ranking.</a:t>
-            </a:r>
-            <a:endParaRPr lang="en-US" sz="1600" dirty="0"/>
+          <a:bodyPr wrap="square" rtlCol="0" anchor="ctr"/>
+          <a:lstStyle/>
+          <a:p>
+            <a:pPr algn="ctr" indent="0" marL="0">
+              <a:buNone/>
+            </a:pPr>
+            <a:r>
+              <a:rPr lang="en-US" sz="1800" i="1" dirty="0">
+                <a:solidFill>
+                  <a:srgbClr val="555555"/>
+                </a:solidFill>
+              </a:rPr>
+              <a:t>Now the live session has been analysed: walk through the divergence points the tool found, then show a higher-scoring alternative I prepared earlier.</a:t>
+            </a:r>
+            <a:endParaRPr lang="en-US" sz="1800" dirty="0"/>
           </a:p>
         </p:txBody>
       </p:sp>
@@ -3879,106 +4121,520 @@
                   <a:srgbClr val="000000"/>
                 </a:solidFill>
               </a:rPr>
-              <a:t>User study: does feedback change behaviour?</a:t>
+              <a:t>What we wanted to evaluate</a:t>
             </a:r>
             <a:endParaRPr lang="en-US" sz="2800" dirty="0"/>
           </a:p>
         </p:txBody>
       </p:sp>
-      <p:sp>
-        <p:nvSpPr>
-          <p:cNvPr id="3" name="Text 1"/>
-          <p:cNvSpPr/>
-          <p:nvPr/>
-        </p:nvSpPr>
-        <p:spPr>
-          <a:xfrm>
-            <a:off x="457200" y="1188720"/>
-            <a:ext cx="8229600" cy="3657600"/>
-          </a:xfrm>
-          <a:prstGeom prst="rect">
-            <a:avLst/>
-          </a:prstGeom>
-          <a:noFill/>
-          <a:ln/>
-        </p:spPr>
-        <p:txBody>
-          <a:bodyPr wrap="square" rtlCol="0" anchor="t"/>
-          <a:lstStyle/>
-          <a:p>
-            <a:pPr marL="342900" indent="-342900">
-              <a:spcAft>
-                <a:spcPts val="600"/>
-              </a:spcAft>
-              <a:buSzPct val="100000"/>
-              <a:buChar char="•"/>
-            </a:pPr>
-            <a:r>
-              <a:rPr lang="en-US" sz="1600" dirty="0">
-                <a:solidFill>
-                  <a:srgbClr val="000000"/>
-                </a:solidFill>
-              </a:rPr>
-              <a:t>With-feedback group: 2.7 divergence points per session.</a:t>
-            </a:r>
-            <a:endParaRPr lang="en-US" sz="1600" dirty="0"/>
-          </a:p>
-          <a:p>
-            <a:pPr marL="342900" indent="-342900">
-              <a:spcAft>
-                <a:spcPts val="600"/>
-              </a:spcAft>
-              <a:buSzPct val="100000"/>
-              <a:buChar char="•"/>
-            </a:pPr>
-            <a:r>
-              <a:rPr lang="en-US" sz="1600" dirty="0">
-                <a:solidFill>
-                  <a:srgbClr val="000000"/>
-                </a:solidFill>
-              </a:rPr>
-              <a:t>No-feedback baseline: 6.0 divergence points per session — 2.2× difference.</a:t>
-            </a:r>
-            <a:endParaRPr lang="en-US" sz="1600" dirty="0"/>
-          </a:p>
-          <a:p>
-            <a:pPr marL="342900" indent="-342900">
-              <a:spcAft>
-                <a:spcPts val="600"/>
-              </a:spcAft>
-              <a:buSzPct val="100000"/>
-              <a:buChar char="•"/>
-            </a:pPr>
-            <a:r>
-              <a:rPr lang="en-US" sz="1600" dirty="0">
-                <a:solidFill>
-                  <a:srgbClr val="000000"/>
-                </a:solidFill>
-              </a:rPr>
-              <a:t>Gain-stripped process-score slope across the 6-session arc — +4.47 per session with feedback, −0.40 per session without.</a:t>
-            </a:r>
-            <a:endParaRPr lang="en-US" sz="1600" dirty="0"/>
-          </a:p>
-          <a:p>
-            <a:pPr marL="342900" indent="-342900">
-              <a:spcAft>
-                <a:spcPts val="600"/>
-              </a:spcAft>
-              <a:buSzPct val="100000"/>
-              <a:buChar char="•"/>
-            </a:pPr>
-            <a:r>
-              <a:rPr lang="en-US" sz="1600" dirty="0">
-                <a:solidFill>
-                  <a:srgbClr val="000000"/>
-                </a:solidFill>
-              </a:rPr>
-              <a:t>Caveat: n=3 vs n=2 is directional evidence, not a hypothesis test.</a:t>
-            </a:r>
-            <a:endParaRPr lang="en-US" sz="1600" dirty="0"/>
-          </a:p>
-        </p:txBody>
-      </p:sp>
+      <p:graphicFrame>
+        <p:nvGraphicFramePr>
+          <p:cNvPr id="18" name="Table 0"/>
+          <p:cNvGraphicFramePr>
+            <a:graphicFrameLocks noGrp="1"/>
+          </p:cNvGraphicFramePr>
+          <p:nvPr>
+            <p:extLst>
+              <p:ext uri="{D42A27DB-BD31-4B8C-83A1-F6EECF244321}">
+                <p14:modId xmlns:p14="http://schemas.microsoft.com/office/powerpoint/2010/main" val="1579011935"/>
+              </p:ext>
+            </p:extLst>
+          </p:nvPr>
+        </p:nvGraphicFramePr>
+        <p:xfrm>
+          <a:off x="457200" y="1280160"/>
+          <a:ext cx="8229600" cy="914400"/>
+        </p:xfrm>
+        <a:graphic>
+          <a:graphicData uri="http://schemas.openxmlformats.org/drawingml/2006/table">
+            <a:tbl>
+              <a:tblPr/>
+              <a:tblGrid>
+                <a:gridCol w="3474720"/>
+                <a:gridCol w="4754880"/>
+              </a:tblGrid>
+              <a:tr h="0">
+                <a:tc>
+                  <a:txBody>
+                    <a:bodyPr/>
+                    <a:lstStyle/>
+                    <a:p>
+                      <a:pPr algn="l" indent="0" marL="0">
+                        <a:buNone/>
+                      </a:pPr>
+                      <a:r>
+                        <a:rPr lang="en-US" sz="1300" b="1" dirty="0">
+                          <a:solidFill>
+                            <a:srgbClr val="1A1A1A"/>
+                          </a:solidFill>
+                        </a:rPr>
+                        <a:t>Question</a:t>
+                      </a:r>
+                      <a:endParaRPr lang="en-US" sz="1300" dirty="0"/>
+                    </a:p>
+                  </a:txBody>
+                  <a:tcPr marL="73152" marR="73152" marT="73152" marB="73152" anchor="ctr">
+                    <a:lnL w="6350" cap="flat" cmpd="sng" algn="ctr">
+                      <a:solidFill>
+                        <a:srgbClr val="CCCCCC"/>
+                      </a:solidFill>
+                      <a:prstDash val="solid"/>
+                      <a:round/>
+                      <a:headEnd type="none" w="med" len="med"/>
+                      <a:tailEnd type="none" w="med" len="med"/>
+                    </a:lnL>
+                    <a:lnR w="6350" cap="flat" cmpd="sng" algn="ctr">
+                      <a:solidFill>
+                        <a:srgbClr val="CCCCCC"/>
+                      </a:solidFill>
+                      <a:prstDash val="solid"/>
+                      <a:round/>
+                      <a:headEnd type="none" w="med" len="med"/>
+                      <a:tailEnd type="none" w="med" len="med"/>
+                    </a:lnR>
+                    <a:lnT w="6350" cap="flat" cmpd="sng" algn="ctr">
+                      <a:solidFill>
+                        <a:srgbClr val="CCCCCC"/>
+                      </a:solidFill>
+                      <a:prstDash val="solid"/>
+                      <a:round/>
+                      <a:headEnd type="none" w="med" len="med"/>
+                      <a:tailEnd type="none" w="med" len="med"/>
+                    </a:lnT>
+                    <a:lnB w="6350" cap="flat" cmpd="sng" algn="ctr">
+                      <a:solidFill>
+                        <a:srgbClr val="CCCCCC"/>
+                      </a:solidFill>
+                      <a:prstDash val="solid"/>
+                      <a:round/>
+                      <a:headEnd type="none" w="med" len="med"/>
+                      <a:tailEnd type="none" w="med" len="med"/>
+                    </a:lnB>
+                    <a:solidFill>
+                      <a:srgbClr val="F0F0F0"/>
+                    </a:solidFill>
+                  </a:tcPr>
+                </a:tc>
+                <a:tc>
+                  <a:txBody>
+                    <a:bodyPr/>
+                    <a:lstStyle/>
+                    <a:p>
+                      <a:pPr algn="l" indent="0" marL="0">
+                        <a:buNone/>
+                      </a:pPr>
+                      <a:r>
+                        <a:rPr lang="en-US" sz="1300" b="1" dirty="0">
+                          <a:solidFill>
+                            <a:srgbClr val="1A1A1A"/>
+                          </a:solidFill>
+                        </a:rPr>
+                        <a:t>Answered by</a:t>
+                      </a:r>
+                      <a:endParaRPr lang="en-US" sz="1300" dirty="0"/>
+                    </a:p>
+                  </a:txBody>
+                  <a:tcPr marL="73152" marR="73152" marT="73152" marB="73152" anchor="ctr">
+                    <a:lnL w="6350" cap="flat" cmpd="sng" algn="ctr">
+                      <a:solidFill>
+                        <a:srgbClr val="CCCCCC"/>
+                      </a:solidFill>
+                      <a:prstDash val="solid"/>
+                      <a:round/>
+                      <a:headEnd type="none" w="med" len="med"/>
+                      <a:tailEnd type="none" w="med" len="med"/>
+                    </a:lnL>
+                    <a:lnR w="6350" cap="flat" cmpd="sng" algn="ctr">
+                      <a:solidFill>
+                        <a:srgbClr val="CCCCCC"/>
+                      </a:solidFill>
+                      <a:prstDash val="solid"/>
+                      <a:round/>
+                      <a:headEnd type="none" w="med" len="med"/>
+                      <a:tailEnd type="none" w="med" len="med"/>
+                    </a:lnR>
+                    <a:lnT w="6350" cap="flat" cmpd="sng" algn="ctr">
+                      <a:solidFill>
+                        <a:srgbClr val="CCCCCC"/>
+                      </a:solidFill>
+                      <a:prstDash val="solid"/>
+                      <a:round/>
+                      <a:headEnd type="none" w="med" len="med"/>
+                      <a:tailEnd type="none" w="med" len="med"/>
+                    </a:lnT>
+                    <a:lnB w="6350" cap="flat" cmpd="sng" algn="ctr">
+                      <a:solidFill>
+                        <a:srgbClr val="CCCCCC"/>
+                      </a:solidFill>
+                      <a:prstDash val="solid"/>
+                      <a:round/>
+                      <a:headEnd type="none" w="med" len="med"/>
+                      <a:tailEnd type="none" w="med" len="med"/>
+                    </a:lnB>
+                    <a:solidFill>
+                      <a:srgbClr val="F0F0F0"/>
+                    </a:solidFill>
+                  </a:tcPr>
+                </a:tc>
+              </a:tr>
+              <a:tr h="0">
+                <a:tc>
+                  <a:txBody>
+                    <a:bodyPr/>
+                    <a:lstStyle/>
+                    <a:p>
+                      <a:pPr algn="l" indent="0" marL="0">
+                        <a:buNone/>
+                      </a:pPr>
+                      <a:r>
+                        <a:rPr lang="en-US" sz="1300" b="1" dirty="0">
+                          <a:solidFill>
+                            <a:srgbClr val="1A1A1A"/>
+                          </a:solidFill>
+                        </a:rPr>
+                        <a:t>Is the tool accurate? Does it detect real divergences without false positives?</a:t>
+                      </a:r>
+                      <a:endParaRPr lang="en-US" sz="1300" dirty="0"/>
+                    </a:p>
+                  </a:txBody>
+                  <a:tcPr marL="91440" marR="91440" marT="91440" marB="91440" anchor="ctr">
+                    <a:lnL w="6350" cap="flat" cmpd="sng" algn="ctr">
+                      <a:solidFill>
+                        <a:srgbClr val="CCCCCC"/>
+                      </a:solidFill>
+                      <a:prstDash val="solid"/>
+                      <a:round/>
+                      <a:headEnd type="none" w="med" len="med"/>
+                      <a:tailEnd type="none" w="med" len="med"/>
+                    </a:lnL>
+                    <a:lnR w="6350" cap="flat" cmpd="sng" algn="ctr">
+                      <a:solidFill>
+                        <a:srgbClr val="CCCCCC"/>
+                      </a:solidFill>
+                      <a:prstDash val="solid"/>
+                      <a:round/>
+                      <a:headEnd type="none" w="med" len="med"/>
+                      <a:tailEnd type="none" w="med" len="med"/>
+                    </a:lnR>
+                    <a:lnT w="6350" cap="flat" cmpd="sng" algn="ctr">
+                      <a:solidFill>
+                        <a:srgbClr val="CCCCCC"/>
+                      </a:solidFill>
+                      <a:prstDash val="solid"/>
+                      <a:round/>
+                      <a:headEnd type="none" w="med" len="med"/>
+                      <a:tailEnd type="none" w="med" len="med"/>
+                    </a:lnT>
+                    <a:lnB w="6350" cap="flat" cmpd="sng" algn="ctr">
+                      <a:solidFill>
+                        <a:srgbClr val="CCCCCC"/>
+                      </a:solidFill>
+                      <a:prstDash val="solid"/>
+                      <a:round/>
+                      <a:headEnd type="none" w="med" len="med"/>
+                      <a:tailEnd type="none" w="med" len="med"/>
+                    </a:lnB>
+                  </a:tcPr>
+                </a:tc>
+                <a:tc>
+                  <a:txBody>
+                    <a:bodyPr/>
+                    <a:lstStyle/>
+                    <a:p>
+                      <a:pPr algn="l" indent="0" marL="0">
+                        <a:buNone/>
+                      </a:pPr>
+                      <a:r>
+                        <a:rPr lang="en-US" sz="1300" dirty="0">
+                          <a:solidFill>
+                            <a:srgbClr val="555555"/>
+                          </a:solidFill>
+                        </a:rPr>
+                        <a:t>45 labelled injection sessions, scored against per-kind precision and recall (Slide 18).</a:t>
+                      </a:r>
+                      <a:endParaRPr lang="en-US" sz="1300" dirty="0"/>
+                    </a:p>
+                  </a:txBody>
+                  <a:tcPr marL="91440" marR="91440" marT="91440" marB="91440" anchor="ctr">
+                    <a:lnL w="6350" cap="flat" cmpd="sng" algn="ctr">
+                      <a:solidFill>
+                        <a:srgbClr val="CCCCCC"/>
+                      </a:solidFill>
+                      <a:prstDash val="solid"/>
+                      <a:round/>
+                      <a:headEnd type="none" w="med" len="med"/>
+                      <a:tailEnd type="none" w="med" len="med"/>
+                    </a:lnL>
+                    <a:lnR w="6350" cap="flat" cmpd="sng" algn="ctr">
+                      <a:solidFill>
+                        <a:srgbClr val="CCCCCC"/>
+                      </a:solidFill>
+                      <a:prstDash val="solid"/>
+                      <a:round/>
+                      <a:headEnd type="none" w="med" len="med"/>
+                      <a:tailEnd type="none" w="med" len="med"/>
+                    </a:lnR>
+                    <a:lnT w="6350" cap="flat" cmpd="sng" algn="ctr">
+                      <a:solidFill>
+                        <a:srgbClr val="CCCCCC"/>
+                      </a:solidFill>
+                      <a:prstDash val="solid"/>
+                      <a:round/>
+                      <a:headEnd type="none" w="med" len="med"/>
+                      <a:tailEnd type="none" w="med" len="med"/>
+                    </a:lnT>
+                    <a:lnB w="6350" cap="flat" cmpd="sng" algn="ctr">
+                      <a:solidFill>
+                        <a:srgbClr val="CCCCCC"/>
+                      </a:solidFill>
+                      <a:prstDash val="solid"/>
+                      <a:round/>
+                      <a:headEnd type="none" w="med" len="med"/>
+                      <a:tailEnd type="none" w="med" len="med"/>
+                    </a:lnB>
+                  </a:tcPr>
+                </a:tc>
+              </a:tr>
+              <a:tr h="0">
+                <a:tc>
+                  <a:txBody>
+                    <a:bodyPr/>
+                    <a:lstStyle/>
+                    <a:p>
+                      <a:pPr algn="l" indent="0" marL="0">
+                        <a:buNone/>
+                      </a:pPr>
+                      <a:r>
+                        <a:rPr lang="en-US" sz="1300" b="1" dirty="0">
+                          <a:solidFill>
+                            <a:srgbClr val="1A1A1A"/>
+                          </a:solidFill>
+                        </a:rPr>
+                        <a:t>Is the process score reliable? Does the ranking hold up when the weights are perturbed?</a:t>
+                      </a:r>
+                      <a:endParaRPr lang="en-US" sz="1300" dirty="0"/>
+                    </a:p>
+                  </a:txBody>
+                  <a:tcPr marL="91440" marR="91440" marT="91440" marB="91440" anchor="ctr">
+                    <a:lnL w="6350" cap="flat" cmpd="sng" algn="ctr">
+                      <a:solidFill>
+                        <a:srgbClr val="CCCCCC"/>
+                      </a:solidFill>
+                      <a:prstDash val="solid"/>
+                      <a:round/>
+                      <a:headEnd type="none" w="med" len="med"/>
+                      <a:tailEnd type="none" w="med" len="med"/>
+                    </a:lnL>
+                    <a:lnR w="6350" cap="flat" cmpd="sng" algn="ctr">
+                      <a:solidFill>
+                        <a:srgbClr val="CCCCCC"/>
+                      </a:solidFill>
+                      <a:prstDash val="solid"/>
+                      <a:round/>
+                      <a:headEnd type="none" w="med" len="med"/>
+                      <a:tailEnd type="none" w="med" len="med"/>
+                    </a:lnR>
+                    <a:lnT w="6350" cap="flat" cmpd="sng" algn="ctr">
+                      <a:solidFill>
+                        <a:srgbClr val="CCCCCC"/>
+                      </a:solidFill>
+                      <a:prstDash val="solid"/>
+                      <a:round/>
+                      <a:headEnd type="none" w="med" len="med"/>
+                      <a:tailEnd type="none" w="med" len="med"/>
+                    </a:lnT>
+                    <a:lnB w="6350" cap="flat" cmpd="sng" algn="ctr">
+                      <a:solidFill>
+                        <a:srgbClr val="CCCCCC"/>
+                      </a:solidFill>
+                      <a:prstDash val="solid"/>
+                      <a:round/>
+                      <a:headEnd type="none" w="med" len="med"/>
+                      <a:tailEnd type="none" w="med" len="med"/>
+                    </a:lnB>
+                  </a:tcPr>
+                </a:tc>
+                <a:tc>
+                  <a:txBody>
+                    <a:bodyPr/>
+                    <a:lstStyle/>
+                    <a:p>
+                      <a:pPr algn="l" indent="0" marL="0">
+                        <a:buNone/>
+                      </a:pPr>
+                      <a:r>
+                        <a:rPr lang="en-US" sz="1300" dirty="0">
+                          <a:solidFill>
+                            <a:srgbClr val="555555"/>
+                          </a:solidFill>
+                        </a:rPr>
+                        <a:t>Injection set + user-study rankable subset, used for the sensitivity sweep and ablation study (Slide 19).</a:t>
+                      </a:r>
+                      <a:endParaRPr lang="en-US" sz="1300" dirty="0"/>
+                    </a:p>
+                  </a:txBody>
+                  <a:tcPr marL="91440" marR="91440" marT="91440" marB="91440" anchor="ctr">
+                    <a:lnL w="6350" cap="flat" cmpd="sng" algn="ctr">
+                      <a:solidFill>
+                        <a:srgbClr val="CCCCCC"/>
+                      </a:solidFill>
+                      <a:prstDash val="solid"/>
+                      <a:round/>
+                      <a:headEnd type="none" w="med" len="med"/>
+                      <a:tailEnd type="none" w="med" len="med"/>
+                    </a:lnL>
+                    <a:lnR w="6350" cap="flat" cmpd="sng" algn="ctr">
+                      <a:solidFill>
+                        <a:srgbClr val="CCCCCC"/>
+                      </a:solidFill>
+                      <a:prstDash val="solid"/>
+                      <a:round/>
+                      <a:headEnd type="none" w="med" len="med"/>
+                      <a:tailEnd type="none" w="med" len="med"/>
+                    </a:lnR>
+                    <a:lnT w="6350" cap="flat" cmpd="sng" algn="ctr">
+                      <a:solidFill>
+                        <a:srgbClr val="CCCCCC"/>
+                      </a:solidFill>
+                      <a:prstDash val="solid"/>
+                      <a:round/>
+                      <a:headEnd type="none" w="med" len="med"/>
+                      <a:tailEnd type="none" w="med" len="med"/>
+                    </a:lnT>
+                    <a:lnB w="6350" cap="flat" cmpd="sng" algn="ctr">
+                      <a:solidFill>
+                        <a:srgbClr val="CCCCCC"/>
+                      </a:solidFill>
+                      <a:prstDash val="solid"/>
+                      <a:round/>
+                      <a:headEnd type="none" w="med" len="med"/>
+                      <a:tailEnd type="none" w="med" len="med"/>
+                    </a:lnB>
+                  </a:tcPr>
+                </a:tc>
+              </a:tr>
+              <a:tr h="0">
+                <a:tc>
+                  <a:txBody>
+                    <a:bodyPr/>
+                    <a:lstStyle/>
+                    <a:p>
+                      <a:pPr algn="l" indent="0" marL="0">
+                        <a:buNone/>
+                      </a:pPr>
+                      <a:r>
+                        <a:rPr lang="en-US" sz="1300" b="1" dirty="0">
+                          <a:solidFill>
+                            <a:srgbClr val="1A1A1A"/>
+                          </a:solidFill>
+                        </a:rPr>
+                        <a:t>Does the tool change developer behaviour? Fewer divergences over time when feedback is shown?</a:t>
+                      </a:r>
+                      <a:endParaRPr lang="en-US" sz="1300" dirty="0"/>
+                    </a:p>
+                  </a:txBody>
+                  <a:tcPr marL="91440" marR="91440" marT="91440" marB="91440" anchor="ctr">
+                    <a:lnL w="6350" cap="flat" cmpd="sng" algn="ctr">
+                      <a:solidFill>
+                        <a:srgbClr val="CCCCCC"/>
+                      </a:solidFill>
+                      <a:prstDash val="solid"/>
+                      <a:round/>
+                      <a:headEnd type="none" w="med" len="med"/>
+                      <a:tailEnd type="none" w="med" len="med"/>
+                    </a:lnL>
+                    <a:lnR w="6350" cap="flat" cmpd="sng" algn="ctr">
+                      <a:solidFill>
+                        <a:srgbClr val="CCCCCC"/>
+                      </a:solidFill>
+                      <a:prstDash val="solid"/>
+                      <a:round/>
+                      <a:headEnd type="none" w="med" len="med"/>
+                      <a:tailEnd type="none" w="med" len="med"/>
+                    </a:lnR>
+                    <a:lnT w="6350" cap="flat" cmpd="sng" algn="ctr">
+                      <a:solidFill>
+                        <a:srgbClr val="CCCCCC"/>
+                      </a:solidFill>
+                      <a:prstDash val="solid"/>
+                      <a:round/>
+                      <a:headEnd type="none" w="med" len="med"/>
+                      <a:tailEnd type="none" w="med" len="med"/>
+                    </a:lnT>
+                    <a:lnB w="6350" cap="flat" cmpd="sng" algn="ctr">
+                      <a:solidFill>
+                        <a:srgbClr val="CCCCCC"/>
+                      </a:solidFill>
+                      <a:prstDash val="solid"/>
+                      <a:round/>
+                      <a:headEnd type="none" w="med" len="med"/>
+                      <a:tailEnd type="none" w="med" len="med"/>
+                    </a:lnB>
+                  </a:tcPr>
+                </a:tc>
+                <a:tc>
+                  <a:txBody>
+                    <a:bodyPr/>
+                    <a:lstStyle/>
+                    <a:p>
+                      <a:pPr algn="l" indent="0" marL="0">
+                        <a:buNone/>
+                      </a:pPr>
+                      <a:r>
+                        <a:rPr lang="en-US" sz="1300" dirty="0">
+                          <a:solidFill>
+                            <a:srgbClr val="555555"/>
+                          </a:solidFill>
+                        </a:rPr>
+                        <a:t>30-session randomised user study, plus a 48-session agent extension as motivation for future work (Slide 20).</a:t>
+                      </a:r>
+                      <a:endParaRPr lang="en-US" sz="1300" dirty="0"/>
+                    </a:p>
+                  </a:txBody>
+                  <a:tcPr marL="91440" marR="91440" marT="91440" marB="91440" anchor="ctr">
+                    <a:lnL w="6350" cap="flat" cmpd="sng" algn="ctr">
+                      <a:solidFill>
+                        <a:srgbClr val="CCCCCC"/>
+                      </a:solidFill>
+                      <a:prstDash val="solid"/>
+                      <a:round/>
+                      <a:headEnd type="none" w="med" len="med"/>
+                      <a:tailEnd type="none" w="med" len="med"/>
+                    </a:lnL>
+                    <a:lnR w="6350" cap="flat" cmpd="sng" algn="ctr">
+                      <a:solidFill>
+                        <a:srgbClr val="CCCCCC"/>
+                      </a:solidFill>
+                      <a:prstDash val="solid"/>
+                      <a:round/>
+                      <a:headEnd type="none" w="med" len="med"/>
+                      <a:tailEnd type="none" w="med" len="med"/>
+                    </a:lnR>
+                    <a:lnT w="6350" cap="flat" cmpd="sng" algn="ctr">
+                      <a:solidFill>
+                        <a:srgbClr val="CCCCCC"/>
+                      </a:solidFill>
+                      <a:prstDash val="solid"/>
+                      <a:round/>
+                      <a:headEnd type="none" w="med" len="med"/>
+                      <a:tailEnd type="none" w="med" len="med"/>
+                    </a:lnT>
+                    <a:lnB w="6350" cap="flat" cmpd="sng" algn="ctr">
+                      <a:solidFill>
+                        <a:srgbClr val="CCCCCC"/>
+                      </a:solidFill>
+                      <a:prstDash val="solid"/>
+                      <a:round/>
+                      <a:headEnd type="none" w="med" len="med"/>
+                      <a:tailEnd type="none" w="med" len="med"/>
+                    </a:lnB>
+                  </a:tcPr>
+                </a:tc>
+              </a:tr>
+            </a:tbl>
+          </a:graphicData>
+        </a:graphic>
+      </p:graphicFrame>
     </p:spTree>
   </p:cSld>
   <p:clrMapOvr>
@@ -4012,8 +4668,8 @@
         </p:nvSpPr>
         <p:spPr>
           <a:xfrm>
-            <a:off x="457200" y="1828800"/>
-            <a:ext cx="8229600" cy="914400"/>
+            <a:off x="457200" y="274320"/>
+            <a:ext cx="8229600" cy="640080"/>
           </a:xfrm>
           <a:prstGeom prst="rect">
             <a:avLst/>
@@ -4025,18 +4681,18 @@
           <a:bodyPr wrap="square" lIns="0" tIns="0" rIns="0" bIns="0" rtlCol="0" anchor="ctr"/>
           <a:lstStyle/>
           <a:p>
-            <a:pPr algn="ctr" indent="0" marL="0">
+            <a:pPr indent="0" marL="0">
               <a:buNone/>
             </a:pPr>
             <a:r>
-              <a:rPr lang="en-US" sz="4800" b="1" dirty="0">
-                <a:solidFill>
-                  <a:srgbClr val="000000"/>
-                </a:solidFill>
-              </a:rPr>
-              <a:t>Demo</a:t>
-            </a:r>
-            <a:endParaRPr lang="en-US" sz="4800" dirty="0"/>
+              <a:rPr lang="en-US" sz="2800" b="1" dirty="0">
+                <a:solidFill>
+                  <a:srgbClr val="000000"/>
+                </a:solidFill>
+              </a:rPr>
+              <a:t>Detector precision &amp; recall</a:t>
+            </a:r>
+            <a:endParaRPr lang="en-US" sz="2800" dirty="0"/>
           </a:p>
         </p:txBody>
       </p:sp>
@@ -4048,8 +4704,8 @@
         </p:nvSpPr>
         <p:spPr>
           <a:xfrm>
-            <a:off x="457200" y="2834640"/>
-            <a:ext cx="8229600" cy="914400"/>
+            <a:off x="457200" y="1188720"/>
+            <a:ext cx="8229600" cy="3657600"/>
           </a:xfrm>
           <a:prstGeom prst="rect">
             <a:avLst/>
@@ -4058,21 +4714,79 @@
           <a:ln/>
         </p:spPr>
         <p:txBody>
-          <a:bodyPr wrap="square" rtlCol="0" anchor="ctr"/>
-          <a:lstStyle/>
-          <a:p>
-            <a:pPr algn="ctr" indent="0" marL="0">
-              <a:buNone/>
-            </a:pPr>
-            <a:r>
-              <a:rPr lang="en-US" sz="1800" i="1" dirty="0">
-                <a:solidFill>
-                  <a:srgbClr val="555555"/>
-                </a:solidFill>
-              </a:rPr>
-              <a:t>I'll show one identified divergence point and the alternative path the tool constructed — and how much better it scores.</a:t>
-            </a:r>
-            <a:endParaRPr lang="en-US" sz="1800" dirty="0"/>
+          <a:bodyPr wrap="square" rtlCol="0" anchor="t"/>
+          <a:lstStyle/>
+          <a:p>
+            <a:pPr marL="342900" indent="-342900">
+              <a:spcAft>
+                <a:spcPts val="600"/>
+              </a:spcAft>
+              <a:buSzPct val="100000"/>
+              <a:buChar char="•"/>
+            </a:pPr>
+            <a:r>
+              <a:rPr lang="en-US" sz="1600" dirty="0">
+                <a:solidFill>
+                  <a:srgbClr val="000000"/>
+                </a:solidFill>
+              </a:rPr>
+              <a:t>Precision = 1.00 across all four divergence kinds - every detection is valid.</a:t>
+            </a:r>
+            <a:endParaRPr lang="en-US" sz="1600" dirty="0"/>
+          </a:p>
+          <a:p>
+            <a:pPr marL="342900" indent="-342900">
+              <a:spcAft>
+                <a:spcPts val="600"/>
+              </a:spcAft>
+              <a:buSzPct val="100000"/>
+              <a:buChar char="•"/>
+            </a:pPr>
+            <a:r>
+              <a:rPr lang="en-US" sz="1600" dirty="0">
+                <a:solidFill>
+                  <a:srgbClr val="000000"/>
+                </a:solidFill>
+              </a:rPr>
+              <a:t>Recall - Rework 1.00, Hygiene 1.00, Manual-Refactor 0.76, Ordering 0.40.</a:t>
+            </a:r>
+            <a:endParaRPr lang="en-US" sz="1600" dirty="0"/>
+          </a:p>
+          <a:p>
+            <a:pPr marL="342900" indent="-342900">
+              <a:spcAft>
+                <a:spcPts val="600"/>
+              </a:spcAft>
+              <a:buSzPct val="100000"/>
+              <a:buChar char="•"/>
+            </a:pPr>
+            <a:r>
+              <a:rPr lang="en-US" sz="1600" dirty="0">
+                <a:solidFill>
+                  <a:srgbClr val="000000"/>
+                </a:solidFill>
+              </a:rPr>
+              <a:t>Inter-rater agreement (Cohen's κ) -1.00 for Ordering and Manual-Refactor, 0.86 for Rework, 0.72 for Hygiene.</a:t>
+            </a:r>
+            <a:endParaRPr lang="en-US" sz="1600" dirty="0"/>
+          </a:p>
+          <a:p>
+            <a:pPr marL="342900" indent="-342900">
+              <a:spcAft>
+                <a:spcPts val="600"/>
+              </a:spcAft>
+              <a:buSzPct val="100000"/>
+              <a:buChar char="•"/>
+            </a:pPr>
+            <a:r>
+              <a:rPr lang="en-US" sz="1600" dirty="0">
+                <a:solidFill>
+                  <a:srgbClr val="000000"/>
+                </a:solidFill>
+              </a:rPr>
+              <a:t>Ordering recall gap is honest and explained: the synthesiser rejects windows it cannot safely reproduce. A scope limit, not a detector flaw.</a:t>
+            </a:r>
+            <a:endParaRPr lang="en-US" sz="1600" dirty="0"/>
           </a:p>
         </p:txBody>
       </p:sp>
@@ -4131,7 +4845,7 @@
                   <a:srgbClr val="000000"/>
                 </a:solidFill>
               </a:rPr>
-              <a:t>Contributions</a:t>
+              <a:t>Score robustness</a:t>
             </a:r>
             <a:endParaRPr lang="en-US" sz="2800" dirty="0"/>
           </a:p>
@@ -4171,7 +4885,7 @@
                   <a:srgbClr val="000000"/>
                 </a:solidFill>
               </a:rPr>
-              <a:t>A process-quality metric J(τ) combining endpoint, process, and safety signals in one principled score.</a:t>
+              <a:t>Single-knob sensitivity sweep: scale any one weight by {0.1×–10×}, top-1 recommendation is preserved in 96.5% of user-study cases.</a:t>
             </a:r>
             <a:endParaRPr lang="en-US" sz="1600" dirty="0"/>
           </a:p>
@@ -4189,7 +4903,7 @@
                   <a:srgbClr val="000000"/>
                 </a:solidFill>
               </a:rPr>
-              <a:t>A divergence-point detector with four actionable kinds, each with a per-kind synthesiser that constructs a concrete alternative trajectory.</a:t>
+              <a:t>Multi-knob Monte Carlo (200 samples): top-1 stability drops to 84.6%; mean Kendall τ = 0.586.</a:t>
             </a:r>
             <a:endParaRPr lang="en-US" sz="1600" dirty="0"/>
           </a:p>
@@ -4207,7 +4921,7 @@
                   <a:srgbClr val="000000"/>
                 </a:solidFill>
               </a:rPr>
-              <a:t>Three datasets — 45 injection sessions, 30-session user study, 48-session agent extension — with reproducible analysis (Jupyter notebook reproduces every table and figure).</a:t>
+              <a:t>Honest framing - stable near the chosen weights, less stable under arbitrary joint perturbations.</a:t>
             </a:r>
             <a:endParaRPr lang="en-US" sz="1600" dirty="0"/>
           </a:p>
@@ -4225,7 +4939,7 @@
                   <a:srgbClr val="000000"/>
                 </a:solidFill>
               </a:rPr>
-              <a:t>A deployable end-to-end system: IntelliJ plugin, analysis backend, and dashboard.</a:t>
+              <a:t>Ablation confirms each process term contributes real signal; endpoint gain alone does not recover the ranking.</a:t>
             </a:r>
             <a:endParaRPr lang="en-US" sz="1600" dirty="0"/>
           </a:p>
@@ -4437,6 +5151,316 @@
         </p:nvSpPr>
         <p:spPr>
           <a:xfrm>
+            <a:off x="457200" y="274320"/>
+            <a:ext cx="8229600" cy="640080"/>
+          </a:xfrm>
+          <a:prstGeom prst="rect">
+            <a:avLst/>
+          </a:prstGeom>
+          <a:noFill/>
+          <a:ln/>
+        </p:spPr>
+        <p:txBody>
+          <a:bodyPr wrap="square" lIns="0" tIns="0" rIns="0" bIns="0" rtlCol="0" anchor="ctr"/>
+          <a:lstStyle/>
+          <a:p>
+            <a:pPr indent="0" marL="0">
+              <a:buNone/>
+            </a:pPr>
+            <a:r>
+              <a:rPr lang="en-US" sz="2800" b="1" dirty="0">
+                <a:solidFill>
+                  <a:srgbClr val="000000"/>
+                </a:solidFill>
+              </a:rPr>
+              <a:t>User study: does feedback change behaviour?</a:t>
+            </a:r>
+            <a:endParaRPr lang="en-US" sz="2800" dirty="0"/>
+          </a:p>
+        </p:txBody>
+      </p:sp>
+      <p:sp>
+        <p:nvSpPr>
+          <p:cNvPr id="3" name="Text 1"/>
+          <p:cNvSpPr/>
+          <p:nvPr/>
+        </p:nvSpPr>
+        <p:spPr>
+          <a:xfrm>
+            <a:off x="457200" y="1188720"/>
+            <a:ext cx="8229600" cy="3657600"/>
+          </a:xfrm>
+          <a:prstGeom prst="rect">
+            <a:avLst/>
+          </a:prstGeom>
+          <a:noFill/>
+          <a:ln/>
+        </p:spPr>
+        <p:txBody>
+          <a:bodyPr wrap="square" rtlCol="0" anchor="t"/>
+          <a:lstStyle/>
+          <a:p>
+            <a:pPr marL="342900" indent="-342900">
+              <a:spcAft>
+                <a:spcPts val="600"/>
+              </a:spcAft>
+              <a:buSzPct val="100000"/>
+              <a:buChar char="•"/>
+            </a:pPr>
+            <a:r>
+              <a:rPr lang="en-US" sz="1600" dirty="0">
+                <a:solidFill>
+                  <a:srgbClr val="000000"/>
+                </a:solidFill>
+              </a:rPr>
+              <a:t>With-feedback group: 2.7 divergence points per session.</a:t>
+            </a:r>
+            <a:endParaRPr lang="en-US" sz="1600" dirty="0"/>
+          </a:p>
+          <a:p>
+            <a:pPr marL="342900" indent="-342900">
+              <a:spcAft>
+                <a:spcPts val="600"/>
+              </a:spcAft>
+              <a:buSzPct val="100000"/>
+              <a:buChar char="•"/>
+            </a:pPr>
+            <a:r>
+              <a:rPr lang="en-US" sz="1600" dirty="0">
+                <a:solidFill>
+                  <a:srgbClr val="000000"/>
+                </a:solidFill>
+              </a:rPr>
+              <a:t>No-feedback baseline: 6.0 divergence points per session -2.2× difference.</a:t>
+            </a:r>
+            <a:endParaRPr lang="en-US" sz="1600" dirty="0"/>
+          </a:p>
+          <a:p>
+            <a:pPr marL="342900" indent="-342900">
+              <a:spcAft>
+                <a:spcPts val="600"/>
+              </a:spcAft>
+              <a:buSzPct val="100000"/>
+              <a:buChar char="•"/>
+            </a:pPr>
+            <a:r>
+              <a:rPr lang="en-US" sz="1600" dirty="0">
+                <a:solidFill>
+                  <a:srgbClr val="000000"/>
+                </a:solidFill>
+              </a:rPr>
+              <a:t>Gain-stripped process-score slope across the 6-session arc -+4.47 per session with feedback, −0.40 per session without.</a:t>
+            </a:r>
+            <a:endParaRPr lang="en-US" sz="1600" dirty="0"/>
+          </a:p>
+          <a:p>
+            <a:pPr marL="342900" indent="-342900">
+              <a:spcAft>
+                <a:spcPts val="600"/>
+              </a:spcAft>
+              <a:buSzPct val="100000"/>
+              <a:buChar char="•"/>
+            </a:pPr>
+            <a:r>
+              <a:rPr lang="en-US" sz="1600" dirty="0">
+                <a:solidFill>
+                  <a:srgbClr val="000000"/>
+                </a:solidFill>
+              </a:rPr>
+              <a:t>Caveat: n=3 vs n=2 is directional evidence, not a hypothesis test.</a:t>
+            </a:r>
+            <a:endParaRPr lang="en-US" sz="1600" dirty="0"/>
+          </a:p>
+        </p:txBody>
+      </p:sp>
+    </p:spTree>
+  </p:cSld>
+  <p:clrMapOvr>
+    <a:masterClrMapping/>
+  </p:clrMapOvr>
+</p:sld>
+</file>
+
+<file path=ppt/slides/slide21.xml><?xml version="1.0" encoding="utf-8"?>
+<p:sld xmlns:a="http://schemas.openxmlformats.org/drawingml/2006/main" xmlns:r="http://schemas.openxmlformats.org/officeDocument/2006/relationships" xmlns:p="http://schemas.openxmlformats.org/presentationml/2006/main">
+  <p:cSld name="Slide 21">
+    <p:spTree>
+      <p:nvGrpSpPr>
+        <p:cNvPr id="1" name=""/>
+        <p:cNvGrpSpPr/>
+        <p:nvPr/>
+      </p:nvGrpSpPr>
+      <p:grpSpPr>
+        <a:xfrm>
+          <a:off x="0" y="0"/>
+          <a:ext cx="0" cy="0"/>
+          <a:chOff x="0" y="0"/>
+          <a:chExt cx="0" cy="0"/>
+        </a:xfrm>
+      </p:grpSpPr>
+      <p:sp>
+        <p:nvSpPr>
+          <p:cNvPr id="2" name="Text 0"/>
+          <p:cNvSpPr/>
+          <p:nvPr/>
+        </p:nvSpPr>
+        <p:spPr>
+          <a:xfrm>
+            <a:off x="457200" y="274320"/>
+            <a:ext cx="8229600" cy="640080"/>
+          </a:xfrm>
+          <a:prstGeom prst="rect">
+            <a:avLst/>
+          </a:prstGeom>
+          <a:noFill/>
+          <a:ln/>
+        </p:spPr>
+        <p:txBody>
+          <a:bodyPr wrap="square" lIns="0" tIns="0" rIns="0" bIns="0" rtlCol="0" anchor="ctr"/>
+          <a:lstStyle/>
+          <a:p>
+            <a:pPr indent="0" marL="0">
+              <a:buNone/>
+            </a:pPr>
+            <a:r>
+              <a:rPr lang="en-US" sz="2800" b="1" dirty="0">
+                <a:solidFill>
+                  <a:srgbClr val="000000"/>
+                </a:solidFill>
+              </a:rPr>
+              <a:t>Contributions</a:t>
+            </a:r>
+            <a:endParaRPr lang="en-US" sz="2800" dirty="0"/>
+          </a:p>
+        </p:txBody>
+      </p:sp>
+      <p:sp>
+        <p:nvSpPr>
+          <p:cNvPr id="3" name="Text 1"/>
+          <p:cNvSpPr/>
+          <p:nvPr/>
+        </p:nvSpPr>
+        <p:spPr>
+          <a:xfrm>
+            <a:off x="457200" y="1188720"/>
+            <a:ext cx="8229600" cy="3657600"/>
+          </a:xfrm>
+          <a:prstGeom prst="rect">
+            <a:avLst/>
+          </a:prstGeom>
+          <a:noFill/>
+          <a:ln/>
+        </p:spPr>
+        <p:txBody>
+          <a:bodyPr wrap="square" rtlCol="0" anchor="t"/>
+          <a:lstStyle/>
+          <a:p>
+            <a:pPr marL="342900" indent="-342900">
+              <a:spcAft>
+                <a:spcPts val="600"/>
+              </a:spcAft>
+              <a:buSzPct val="100000"/>
+              <a:buChar char="•"/>
+            </a:pPr>
+            <a:r>
+              <a:rPr lang="en-US" sz="1600" dirty="0">
+                <a:solidFill>
+                  <a:srgbClr val="000000"/>
+                </a:solidFill>
+              </a:rPr>
+              <a:t>A process-quality metric J(τ) combining endpoint, process, and safety signals in one principled score.</a:t>
+            </a:r>
+            <a:endParaRPr lang="en-US" sz="1600" dirty="0"/>
+          </a:p>
+          <a:p>
+            <a:pPr marL="342900" indent="-342900">
+              <a:spcAft>
+                <a:spcPts val="600"/>
+              </a:spcAft>
+              <a:buSzPct val="100000"/>
+              <a:buChar char="•"/>
+            </a:pPr>
+            <a:r>
+              <a:rPr lang="en-US" sz="1600" dirty="0">
+                <a:solidFill>
+                  <a:srgbClr val="000000"/>
+                </a:solidFill>
+              </a:rPr>
+              <a:t>A divergence-point detector with four actionable kinds, each with a per-kind synthesiser that constructs a concrete alternative trajectory.</a:t>
+            </a:r>
+            <a:endParaRPr lang="en-US" sz="1600" dirty="0"/>
+          </a:p>
+          <a:p>
+            <a:pPr marL="342900" indent="-342900">
+              <a:spcAft>
+                <a:spcPts val="600"/>
+              </a:spcAft>
+              <a:buSzPct val="100000"/>
+              <a:buChar char="•"/>
+            </a:pPr>
+            <a:r>
+              <a:rPr lang="en-US" sz="1600" dirty="0">
+                <a:solidFill>
+                  <a:srgbClr val="000000"/>
+                </a:solidFill>
+              </a:rPr>
+              <a:t>Three datasets -45 injection sessions, 30-session user study, 48-session agent extension - with reproducible analysis (Jupyter notebook reproduces every table and figure).</a:t>
+            </a:r>
+            <a:endParaRPr lang="en-US" sz="1600" dirty="0"/>
+          </a:p>
+          <a:p>
+            <a:pPr marL="342900" indent="-342900">
+              <a:spcAft>
+                <a:spcPts val="600"/>
+              </a:spcAft>
+              <a:buSzPct val="100000"/>
+              <a:buChar char="•"/>
+            </a:pPr>
+            <a:r>
+              <a:rPr lang="en-US" sz="1600" dirty="0">
+                <a:solidFill>
+                  <a:srgbClr val="000000"/>
+                </a:solidFill>
+              </a:rPr>
+              <a:t>A deployable end-to-end system: IntelliJ plugin, analysis backend, and dashboard.</a:t>
+            </a:r>
+            <a:endParaRPr lang="en-US" sz="1600" dirty="0"/>
+          </a:p>
+        </p:txBody>
+      </p:sp>
+    </p:spTree>
+  </p:cSld>
+  <p:clrMapOvr>
+    <a:masterClrMapping/>
+  </p:clrMapOvr>
+</p:sld>
+</file>
+
+<file path=ppt/slides/slide22.xml><?xml version="1.0" encoding="utf-8"?>
+<p:sld xmlns:a="http://schemas.openxmlformats.org/drawingml/2006/main" xmlns:r="http://schemas.openxmlformats.org/officeDocument/2006/relationships" xmlns:p="http://schemas.openxmlformats.org/presentationml/2006/main">
+  <p:cSld name="Slide 22">
+    <p:spTree>
+      <p:nvGrpSpPr>
+        <p:cNvPr id="1" name=""/>
+        <p:cNvGrpSpPr/>
+        <p:nvPr/>
+      </p:nvGrpSpPr>
+      <p:grpSpPr>
+        <a:xfrm>
+          <a:off x="0" y="0"/>
+          <a:ext cx="0" cy="0"/>
+          <a:chOff x="0" y="0"/>
+          <a:chExt cx="0" cy="0"/>
+        </a:xfrm>
+      </p:grpSpPr>
+      <p:sp>
+        <p:nvSpPr>
+          <p:cNvPr id="2" name="Text 0"/>
+          <p:cNvSpPr/>
+          <p:nvPr/>
+        </p:nvSpPr>
+        <p:spPr>
+          <a:xfrm>
             <a:off x="457200" y="1645920"/>
             <a:ext cx="8229600" cy="1371600"/>
           </a:xfrm>
@@ -4459,7 +5483,7 @@
                   <a:srgbClr val="000000"/>
                 </a:solidFill>
               </a:rPr>
-              <a:t>Refactoring quality isn't just about where you end up — it's about the path you walked to get there.</a:t>
+              <a:t>Refactoring quality isn't just about where you end up - it's about the path you walked to get there.</a:t>
             </a:r>
             <a:endParaRPr lang="en-US" sz="2600" dirty="0"/>
           </a:p>
@@ -4531,7 +5555,7 @@
                   <a:srgbClr val="555555"/>
                 </a:solidFill>
               </a:rPr>
-              <a:t>Thank you — happy to take questions.</a:t>
+              <a:t>Thank you - happy to take questions.</a:t>
             </a:r>
             <a:endParaRPr lang="en-US" sz="1600" dirty="0"/>
           </a:p>
@@ -4747,7 +5771,7 @@
                   <a:srgbClr val="000000"/>
                 </a:solidFill>
               </a:rPr>
-              <a:t>The core idea, visualised</a:t>
+              <a:t>Narrowing the design space</a:t>
             </a:r>
             <a:endParaRPr lang="en-US" sz="2800" dirty="0"/>
           </a:p>
@@ -4761,8 +5785,8 @@
         </p:nvSpPr>
         <p:spPr>
           <a:xfrm>
-            <a:off x="457200" y="1188720"/>
-            <a:ext cx="8229600" cy="3657600"/>
+            <a:off x="457200" y="1097280"/>
+            <a:ext cx="8229600" cy="457200"/>
           </a:xfrm>
           <a:prstGeom prst="rect">
             <a:avLst/>
@@ -4771,6 +5795,42 @@
           <a:ln/>
         </p:spPr>
         <p:txBody>
+          <a:bodyPr wrap="square" lIns="0" tIns="0" rIns="0" bIns="0" rtlCol="0" anchor="ctr"/>
+          <a:lstStyle/>
+          <a:p>
+            <a:pPr indent="0" marL="0">
+              <a:buNone/>
+            </a:pPr>
+            <a:r>
+              <a:rPr lang="en-US" sz="1300" i="1" dirty="0">
+                <a:solidFill>
+                  <a:srgbClr val="555555"/>
+                </a:solidFill>
+              </a:rPr>
+              <a:t>Evaluating refactoring as a process is a wide, mostly-unexplored design space. Four requirements shaped what we built.</a:t>
+            </a:r>
+            <a:endParaRPr lang="en-US" sz="1300" dirty="0"/>
+          </a:p>
+        </p:txBody>
+      </p:sp>
+      <p:sp>
+        <p:nvSpPr>
+          <p:cNvPr id="4" name="Text 2"/>
+          <p:cNvSpPr/>
+          <p:nvPr/>
+        </p:nvSpPr>
+        <p:spPr>
+          <a:xfrm>
+            <a:off x="457200" y="1645920"/>
+            <a:ext cx="8229600" cy="3291840"/>
+          </a:xfrm>
+          <a:prstGeom prst="rect">
+            <a:avLst/>
+          </a:prstGeom>
+          <a:noFill/>
+          <a:ln/>
+        </p:spPr>
+        <p:txBody>
           <a:bodyPr wrap="square" rtlCol="0" anchor="t"/>
           <a:lstStyle/>
           <a:p>
@@ -4782,14 +5842,42 @@
               <a:buChar char="•"/>
             </a:pPr>
             <a:r>
-              <a:rPr lang="en-US" sz="1600" dirty="0">
-                <a:solidFill>
-                  <a:srgbClr val="000000"/>
-                </a:solidFill>
-              </a:rPr>
-              <a:t>Solid line: user's trajectory through code states.</a:t>
-            </a:r>
-            <a:endParaRPr lang="en-US" sz="1600" dirty="0"/>
+              <a:rPr lang="en-US" sz="1300" b="1" dirty="0">
+                <a:solidFill>
+                  <a:srgbClr val="000000"/>
+                </a:solidFill>
+              </a:rPr>
+              <a:t>Quantifiable + comparable score </a:t>
+            </a:r>
+            <a:pPr indent="0" marL="0">
+              <a:spcAft>
+                <a:spcPts val="600"/>
+              </a:spcAft>
+              <a:buNone/>
+            </a:pPr>
+            <a:r>
+              <a:rPr lang="en-US" sz="1300" dirty="0">
+                <a:solidFill>
+                  <a:srgbClr val="000000"/>
+                </a:solidFill>
+              </a:rPr>
+              <a:t>- one number per trajectory so sessions can be compared. </a:t>
+            </a:r>
+            <a:pPr indent="0" marL="0">
+              <a:spcAft>
+                <a:spcPts val="600"/>
+              </a:spcAft>
+              <a:buNone/>
+            </a:pPr>
+            <a:r>
+              <a:rPr lang="en-US" sz="1300" dirty="0">
+                <a:solidFill>
+                  <a:srgbClr val="888888"/>
+                </a:solidFill>
+              </a:rPr>
+              <a:t>Builds on composite quality models (Quamoco, QMOOD), adapted from snapshot- to trajectory-level.</a:t>
+            </a:r>
+            <a:endParaRPr lang="en-US" sz="1300" dirty="0"/>
           </a:p>
           <a:p>
             <a:pPr marL="342900" indent="-342900">
@@ -4800,14 +5888,42 @@
               <a:buChar char="•"/>
             </a:pPr>
             <a:r>
-              <a:rPr lang="en-US" sz="1600" dirty="0">
-                <a:solidFill>
-                  <a:srgbClr val="000000"/>
-                </a:solidFill>
-              </a:rPr>
-              <a:t>Dashed line: synthesised alternative trajectory.</a:t>
-            </a:r>
-            <a:endParaRPr lang="en-US" sz="1600" dirty="0"/>
+              <a:rPr lang="en-US" sz="1300" b="1" dirty="0">
+                <a:solidFill>
+                  <a:srgbClr val="000000"/>
+                </a:solidFill>
+              </a:rPr>
+              <a:t>Seamless, in-workflow capture </a:t>
+            </a:r>
+            <a:pPr indent="0" marL="0">
+              <a:spcAft>
+                <a:spcPts val="600"/>
+              </a:spcAft>
+              <a:buNone/>
+            </a:pPr>
+            <a:r>
+              <a:rPr lang="en-US" sz="1300" dirty="0">
+                <a:solidFill>
+                  <a:srgbClr val="000000"/>
+                </a:solidFill>
+              </a:rPr>
+              <a:t>- zero extra developer effort to use the tool. </a:t>
+            </a:r>
+            <a:pPr indent="0" marL="0">
+              <a:spcAft>
+                <a:spcPts val="600"/>
+              </a:spcAft>
+              <a:buNone/>
+            </a:pPr>
+            <a:r>
+              <a:rPr lang="en-US" sz="1300" dirty="0">
+                <a:solidFill>
+                  <a:srgbClr val="888888"/>
+                </a:solidFill>
+              </a:rPr>
+              <a:t>IDE-event logging is a known-feasible approach (Damevski et al., CodeWatcher).</a:t>
+            </a:r>
+            <a:endParaRPr lang="en-US" sz="1300" dirty="0"/>
           </a:p>
           <a:p>
             <a:pPr marL="342900" indent="-342900">
@@ -4818,14 +5934,42 @@
               <a:buChar char="•"/>
             </a:pPr>
             <a:r>
-              <a:rPr lang="en-US" sz="1600" dirty="0">
-                <a:solidFill>
-                  <a:srgbClr val="000000"/>
-                </a:solidFill>
-              </a:rPr>
-              <a:t>Both end at the same final state.</a:t>
-            </a:r>
-            <a:endParaRPr lang="en-US" sz="1600" dirty="0"/>
+              <a:rPr lang="en-US" sz="1300" b="1" dirty="0">
+                <a:solidFill>
+                  <a:srgbClr val="000000"/>
+                </a:solidFill>
+              </a:rPr>
+              <a:t>Actionable, moment-specific feedback </a:t>
+            </a:r>
+            <a:pPr indent="0" marL="0">
+              <a:spcAft>
+                <a:spcPts val="600"/>
+              </a:spcAft>
+              <a:buNone/>
+            </a:pPr>
+            <a:r>
+              <a:rPr lang="en-US" sz="1300" dirty="0">
+                <a:solidFill>
+                  <a:srgbClr val="000000"/>
+                </a:solidFill>
+              </a:rPr>
+              <a:t>- point to a specific moment AND a "what you could have done instead" alternative. </a:t>
+            </a:r>
+            <a:pPr indent="0" marL="0">
+              <a:spcAft>
+                <a:spcPts val="600"/>
+              </a:spcAft>
+              <a:buNone/>
+            </a:pPr>
+            <a:r>
+              <a:rPr lang="en-US" sz="1300" dirty="0">
+                <a:solidFill>
+                  <a:srgbClr val="888888"/>
+                </a:solidFill>
+              </a:rPr>
+              <a:t>Inverts prior refactoring recommenders (ReSynth, Refactoring Navigator, search-based refactoring): the synthesised sequence becomes the comparison point against an observed trace.</a:t>
+            </a:r>
+            <a:endParaRPr lang="en-US" sz="1300" dirty="0"/>
           </a:p>
           <a:p>
             <a:pPr marL="342900" indent="-342900">
@@ -4836,32 +5980,28 @@
               <a:buChar char="•"/>
             </a:pPr>
             <a:r>
-              <a:rPr lang="en-US" sz="1600" dirty="0">
-                <a:solidFill>
-                  <a:srgbClr val="000000"/>
-                </a:solidFill>
-              </a:rPr>
-              <a:t>Mark the divergence point and the score gap ΔJ between the two final scores.</a:t>
-            </a:r>
-            <a:endParaRPr lang="en-US" sz="1600" dirty="0"/>
-          </a:p>
-          <a:p>
-            <a:pPr marL="342900" indent="-342900">
+              <a:rPr lang="en-US" sz="1300" b="1" dirty="0">
+                <a:solidFill>
+                  <a:srgbClr val="000000"/>
+                </a:solidFill>
+              </a:rPr>
+              <a:t>Efficient alternative synthesis </a:t>
+            </a:r>
+            <a:pPr indent="0" marL="0">
               <a:spcAft>
                 <a:spcPts val="600"/>
               </a:spcAft>
-              <a:buSzPct val="100000"/>
-              <a:buChar char="•"/>
-            </a:pPr>
-            <a:r>
-              <a:rPr lang="en-US" sz="1600" dirty="0">
-                <a:solidFill>
-                  <a:srgbClr val="000000"/>
-                </a:solidFill>
-              </a:rPr>
-              <a:t>[FIGURE: introduction/divergence_diagram.png — to be placed here]</a:t>
-            </a:r>
-            <a:endParaRPr lang="en-US" sz="1600" dirty="0"/>
+              <a:buNone/>
+            </a:pPr>
+            <a:r>
+              <a:rPr lang="en-US" sz="1300" dirty="0">
+                <a:solidFill>
+                  <a:srgbClr val="000000"/>
+                </a:solidFill>
+              </a:rPr>
+              <a:t>- the state-action space over a real codebase is too large to enumerate, so we must find efficient methods of identifying "better" alternatives.</a:t>
+            </a:r>
+            <a:endParaRPr lang="en-US" sz="1300" dirty="0"/>
           </a:p>
         </p:txBody>
       </p:sp>
@@ -4920,7 +6060,7 @@
                   <a:srgbClr val="000000"/>
                 </a:solidFill>
               </a:rPr>
-              <a:t>What the tool does, end to end</a:t>
+              <a:t>Desired outcome: a comparable counterfactual</a:t>
             </a:r>
             <a:endParaRPr lang="en-US" sz="2800" dirty="0"/>
           </a:p>
@@ -4935,7 +6075,7 @@
         <p:spPr>
           <a:xfrm>
             <a:off x="457200" y="1097280"/>
-            <a:ext cx="8229600" cy="1554480"/>
+            <a:ext cx="8229600" cy="1463040"/>
           </a:xfrm>
           <a:prstGeom prst="rect">
             <a:avLst/>
@@ -4960,7 +6100,7 @@
                   <a:srgbClr val="000000"/>
                 </a:solidFill>
               </a:rPr>
-              <a:t>IntelliJ plugin: records every edit, refactoring, build, test, and commit during a session.</a:t>
+              <a:t>Given those four requirements, the concrete thing we wanted the tool to produce, for any recorded session:</a:t>
             </a:r>
             <a:endParaRPr lang="en-US" sz="1600" dirty="0"/>
           </a:p>
@@ -4978,7 +6118,7 @@
                   <a:srgbClr val="000000"/>
                 </a:solidFill>
               </a:rPr>
-              <a:t>Analysis backend: reconstructs the trajectory, scores it, and detects divergence points.</a:t>
+              <a:t>Solid line - the user's actual trajectory through code states.</a:t>
             </a:r>
             <a:endParaRPr lang="en-US" sz="1600" dirty="0"/>
           </a:p>
@@ -4996,576 +6136,54 @@
                   <a:srgbClr val="000000"/>
                 </a:solidFill>
               </a:rPr>
-              <a:t>Dashboard: surfaces where you diverged, an alternative path, how much better it scores, and why.</a:t>
+              <a:t>Dashed line - synthesised alternative; same start, same finish, measurably higher J(τ).</a:t>
             </a:r>
             <a:endParaRPr lang="en-US" sz="1600" dirty="0"/>
           </a:p>
-        </p:txBody>
-      </p:sp>
-      <p:sp>
-        <p:nvSpPr>
-          <p:cNvPr id="4" name="Shape 2"/>
-          <p:cNvSpPr/>
+          <a:p>
+            <a:pPr marL="342900" indent="-342900">
+              <a:spcAft>
+                <a:spcPts val="600"/>
+              </a:spcAft>
+              <a:buSzPct val="100000"/>
+              <a:buChar char="•"/>
+            </a:pPr>
+            <a:r>
+              <a:rPr lang="en-US" sz="1600" dirty="0">
+                <a:solidFill>
+                  <a:srgbClr val="000000"/>
+                </a:solidFill>
+              </a:rPr>
+              <a:t>Divergence point marks where the two paths split; ΔJ quantifies the gap.</a:t>
+            </a:r>
+            <a:endParaRPr lang="en-US" sz="1600" dirty="0"/>
+          </a:p>
+        </p:txBody>
+      </p:sp>
+      <p:pic>
+        <p:nvPicPr>
+          <p:cNvPr id="4" name="Image 0" descr="images/divergence-point.png">    </p:cNvPr>
+          <p:cNvPicPr>
+            <a:picLocks noChangeAspect="1"/>
+          </p:cNvPicPr>
           <p:nvPr/>
-        </p:nvSpPr>
+        </p:nvPicPr>
+        <p:blipFill>
+          <a:blip r:embed="rId1"/>
+          <a:stretch>
+            <a:fillRect/>
+          </a:stretch>
+        </p:blipFill>
         <p:spPr>
           <a:xfrm>
-            <a:off x="182880" y="2788920"/>
-            <a:ext cx="2377440" cy="2103120"/>
+            <a:off x="2651760" y="2697480"/>
+            <a:ext cx="3840480" cy="2276856"/>
           </a:xfrm>
           <a:prstGeom prst="rect">
             <a:avLst/>
           </a:prstGeom>
-          <a:solidFill>
-            <a:srgbClr val="FFFFFF"/>
-          </a:solidFill>
-          <a:ln w="12700">
-            <a:solidFill>
-              <a:srgbClr val="000000"/>
-            </a:solidFill>
-            <a:prstDash val="solid"/>
-          </a:ln>
         </p:spPr>
-      </p:sp>
-      <p:sp>
-        <p:nvSpPr>
-          <p:cNvPr id="5" name="Text 3"/>
-          <p:cNvSpPr/>
-          <p:nvPr/>
-        </p:nvSpPr>
-        <p:spPr>
-          <a:xfrm>
-            <a:off x="274320" y="2971800"/>
-            <a:ext cx="2194560" cy="457200"/>
-          </a:xfrm>
-          <a:prstGeom prst="rect">
-            <a:avLst/>
-          </a:prstGeom>
-          <a:noFill/>
-          <a:ln/>
-        </p:spPr>
-        <p:txBody>
-          <a:bodyPr wrap="square" lIns="0" tIns="0" rIns="0" bIns="0" rtlCol="0" anchor="ctr"/>
-          <a:lstStyle/>
-          <a:p>
-            <a:pPr algn="ctr" indent="0" marL="0">
-              <a:buNone/>
-            </a:pPr>
-            <a:r>
-              <a:rPr lang="en-US" sz="1600" b="1" dirty="0">
-                <a:solidFill>
-                  <a:srgbClr val="000000"/>
-                </a:solidFill>
-              </a:rPr>
-              <a:t>IntelliJ Plugin</a:t>
-            </a:r>
-            <a:endParaRPr lang="en-US" sz="1600" dirty="0"/>
-          </a:p>
-        </p:txBody>
-      </p:sp>
-      <p:sp>
-        <p:nvSpPr>
-          <p:cNvPr id="6" name="Shape 4"/>
-          <p:cNvSpPr/>
-          <p:nvPr/>
-        </p:nvSpPr>
-        <p:spPr>
-          <a:xfrm>
-            <a:off x="457200" y="3520440"/>
-            <a:ext cx="1828800" cy="0"/>
-          </a:xfrm>
-          <a:prstGeom prst="line">
-            <a:avLst/>
-          </a:prstGeom>
-          <a:noFill/>
-          <a:ln w="9525">
-            <a:solidFill>
-              <a:srgbClr val="999999"/>
-            </a:solidFill>
-            <a:prstDash val="solid"/>
-          </a:ln>
-        </p:spPr>
-      </p:sp>
-      <p:sp>
-        <p:nvSpPr>
-          <p:cNvPr id="7" name="Text 5"/>
-          <p:cNvSpPr/>
-          <p:nvPr/>
-        </p:nvSpPr>
-        <p:spPr>
-          <a:xfrm>
-            <a:off x="411480" y="3703320"/>
-            <a:ext cx="2011680" cy="1097280"/>
-          </a:xfrm>
-          <a:prstGeom prst="rect">
-            <a:avLst/>
-          </a:prstGeom>
-          <a:noFill/>
-          <a:ln/>
-        </p:spPr>
-        <p:txBody>
-          <a:bodyPr wrap="square" rtlCol="0" anchor="t"/>
-          <a:lstStyle/>
-          <a:p>
-            <a:pPr marL="342900" indent="-342900">
-              <a:spcAft>
-                <a:spcPts val="800"/>
-              </a:spcAft>
-              <a:buSzPct val="100000"/>
-              <a:buChar char="•"/>
-            </a:pPr>
-            <a:r>
-              <a:rPr lang="en-US" sz="1200" dirty="0">
-                <a:solidFill>
-                  <a:srgbClr val="333333"/>
-                </a:solidFill>
-              </a:rPr>
-              <a:t>Records developer events</a:t>
-            </a:r>
-            <a:endParaRPr lang="en-US" sz="1200" dirty="0"/>
-          </a:p>
-          <a:p>
-            <a:pPr marL="342900" indent="-342900">
-              <a:spcAft>
-                <a:spcPts val="800"/>
-              </a:spcAft>
-              <a:buSzPct val="100000"/>
-              <a:buChar char="•"/>
-            </a:pPr>
-            <a:r>
-              <a:rPr lang="en-US" sz="1200" dirty="0">
-                <a:solidFill>
-                  <a:srgbClr val="333333"/>
-                </a:solidFill>
-              </a:rPr>
-              <a:t>Captures initial codebase</a:t>
-            </a:r>
-            <a:endParaRPr lang="en-US" sz="1200" dirty="0"/>
-          </a:p>
-        </p:txBody>
-      </p:sp>
-      <p:sp>
-        <p:nvSpPr>
-          <p:cNvPr id="8" name="Shape 6"/>
-          <p:cNvSpPr/>
-          <p:nvPr/>
-        </p:nvSpPr>
-        <p:spPr>
-          <a:xfrm>
-            <a:off x="3383280" y="2788920"/>
-            <a:ext cx="2377440" cy="2103120"/>
-          </a:xfrm>
-          <a:prstGeom prst="rect">
-            <a:avLst/>
-          </a:prstGeom>
-          <a:solidFill>
-            <a:srgbClr val="FFFFFF"/>
-          </a:solidFill>
-          <a:ln w="12700">
-            <a:solidFill>
-              <a:srgbClr val="000000"/>
-            </a:solidFill>
-            <a:prstDash val="solid"/>
-          </a:ln>
-        </p:spPr>
-      </p:sp>
-      <p:sp>
-        <p:nvSpPr>
-          <p:cNvPr id="9" name="Text 7"/>
-          <p:cNvSpPr/>
-          <p:nvPr/>
-        </p:nvSpPr>
-        <p:spPr>
-          <a:xfrm>
-            <a:off x="3474720" y="2971800"/>
-            <a:ext cx="2194560" cy="457200"/>
-          </a:xfrm>
-          <a:prstGeom prst="rect">
-            <a:avLst/>
-          </a:prstGeom>
-          <a:noFill/>
-          <a:ln/>
-        </p:spPr>
-        <p:txBody>
-          <a:bodyPr wrap="square" lIns="0" tIns="0" rIns="0" bIns="0" rtlCol="0" anchor="ctr"/>
-          <a:lstStyle/>
-          <a:p>
-            <a:pPr algn="ctr" indent="0" marL="0">
-              <a:buNone/>
-            </a:pPr>
-            <a:r>
-              <a:rPr lang="en-US" sz="1600" b="1" dirty="0">
-                <a:solidFill>
-                  <a:srgbClr val="000000"/>
-                </a:solidFill>
-              </a:rPr>
-              <a:t>Analysis Backend</a:t>
-            </a:r>
-            <a:endParaRPr lang="en-US" sz="1600" dirty="0"/>
-          </a:p>
-        </p:txBody>
-      </p:sp>
-      <p:sp>
-        <p:nvSpPr>
-          <p:cNvPr id="10" name="Shape 8"/>
-          <p:cNvSpPr/>
-          <p:nvPr/>
-        </p:nvSpPr>
-        <p:spPr>
-          <a:xfrm>
-            <a:off x="3657600" y="3520440"/>
-            <a:ext cx="1828800" cy="0"/>
-          </a:xfrm>
-          <a:prstGeom prst="line">
-            <a:avLst/>
-          </a:prstGeom>
-          <a:noFill/>
-          <a:ln w="9525">
-            <a:solidFill>
-              <a:srgbClr val="999999"/>
-            </a:solidFill>
-            <a:prstDash val="solid"/>
-          </a:ln>
-        </p:spPr>
-      </p:sp>
-      <p:sp>
-        <p:nvSpPr>
-          <p:cNvPr id="11" name="Text 9"/>
-          <p:cNvSpPr/>
-          <p:nvPr/>
-        </p:nvSpPr>
-        <p:spPr>
-          <a:xfrm>
-            <a:off x="3611880" y="3703320"/>
-            <a:ext cx="2011680" cy="1097280"/>
-          </a:xfrm>
-          <a:prstGeom prst="rect">
-            <a:avLst/>
-          </a:prstGeom>
-          <a:noFill/>
-          <a:ln/>
-        </p:spPr>
-        <p:txBody>
-          <a:bodyPr wrap="square" rtlCol="0" anchor="t"/>
-          <a:lstStyle/>
-          <a:p>
-            <a:pPr marL="342900" indent="-342900">
-              <a:spcAft>
-                <a:spcPts val="800"/>
-              </a:spcAft>
-              <a:buSzPct val="100000"/>
-              <a:buChar char="•"/>
-            </a:pPr>
-            <a:r>
-              <a:rPr lang="en-US" sz="1200" dirty="0">
-                <a:solidFill>
-                  <a:srgbClr val="333333"/>
-                </a:solidFill>
-              </a:rPr>
-              <a:t>Shadow repo reconstruction</a:t>
-            </a:r>
-            <a:endParaRPr lang="en-US" sz="1200" dirty="0"/>
-          </a:p>
-          <a:p>
-            <a:pPr marL="342900" indent="-342900">
-              <a:spcAft>
-                <a:spcPts val="800"/>
-              </a:spcAft>
-              <a:buSzPct val="100000"/>
-              <a:buChar char="•"/>
-            </a:pPr>
-            <a:r>
-              <a:rPr lang="en-US" sz="1200" dirty="0">
-                <a:solidFill>
-                  <a:srgbClr val="333333"/>
-                </a:solidFill>
-              </a:rPr>
-              <a:t>Metric calculation</a:t>
-            </a:r>
-            <a:endParaRPr lang="en-US" sz="1200" dirty="0"/>
-          </a:p>
-          <a:p>
-            <a:pPr marL="342900" indent="-342900">
-              <a:spcAft>
-                <a:spcPts val="800"/>
-              </a:spcAft>
-              <a:buSzPct val="100000"/>
-              <a:buChar char="•"/>
-            </a:pPr>
-            <a:r>
-              <a:rPr lang="en-US" sz="1200" dirty="0">
-                <a:solidFill>
-                  <a:srgbClr val="333333"/>
-                </a:solidFill>
-              </a:rPr>
-              <a:t>Divergence synthesis</a:t>
-            </a:r>
-            <a:endParaRPr lang="en-US" sz="1200" dirty="0"/>
-          </a:p>
-        </p:txBody>
-      </p:sp>
-      <p:sp>
-        <p:nvSpPr>
-          <p:cNvPr id="12" name="Shape 10"/>
-          <p:cNvSpPr/>
-          <p:nvPr/>
-        </p:nvSpPr>
-        <p:spPr>
-          <a:xfrm>
-            <a:off x="6583680" y="2788920"/>
-            <a:ext cx="2377440" cy="2103120"/>
-          </a:xfrm>
-          <a:prstGeom prst="rect">
-            <a:avLst/>
-          </a:prstGeom>
-          <a:solidFill>
-            <a:srgbClr val="FFFFFF"/>
-          </a:solidFill>
-          <a:ln w="12700">
-            <a:solidFill>
-              <a:srgbClr val="000000"/>
-            </a:solidFill>
-            <a:prstDash val="solid"/>
-          </a:ln>
-        </p:spPr>
-      </p:sp>
-      <p:sp>
-        <p:nvSpPr>
-          <p:cNvPr id="13" name="Text 11"/>
-          <p:cNvSpPr/>
-          <p:nvPr/>
-        </p:nvSpPr>
-        <p:spPr>
-          <a:xfrm>
-            <a:off x="6675120" y="2971800"/>
-            <a:ext cx="2194560" cy="457200"/>
-          </a:xfrm>
-          <a:prstGeom prst="rect">
-            <a:avLst/>
-          </a:prstGeom>
-          <a:noFill/>
-          <a:ln/>
-        </p:spPr>
-        <p:txBody>
-          <a:bodyPr wrap="square" lIns="0" tIns="0" rIns="0" bIns="0" rtlCol="0" anchor="ctr"/>
-          <a:lstStyle/>
-          <a:p>
-            <a:pPr algn="ctr" indent="0" marL="0">
-              <a:buNone/>
-            </a:pPr>
-            <a:r>
-              <a:rPr lang="en-US" sz="1600" b="1" dirty="0">
-                <a:solidFill>
-                  <a:srgbClr val="000000"/>
-                </a:solidFill>
-              </a:rPr>
-              <a:t>Dashboard</a:t>
-            </a:r>
-            <a:endParaRPr lang="en-US" sz="1600" dirty="0"/>
-          </a:p>
-        </p:txBody>
-      </p:sp>
-      <p:sp>
-        <p:nvSpPr>
-          <p:cNvPr id="14" name="Shape 12"/>
-          <p:cNvSpPr/>
-          <p:nvPr/>
-        </p:nvSpPr>
-        <p:spPr>
-          <a:xfrm>
-            <a:off x="6858000" y="3520440"/>
-            <a:ext cx="1828800" cy="0"/>
-          </a:xfrm>
-          <a:prstGeom prst="line">
-            <a:avLst/>
-          </a:prstGeom>
-          <a:noFill/>
-          <a:ln w="9525">
-            <a:solidFill>
-              <a:srgbClr val="999999"/>
-            </a:solidFill>
-            <a:prstDash val="solid"/>
-          </a:ln>
-        </p:spPr>
-      </p:sp>
-      <p:sp>
-        <p:nvSpPr>
-          <p:cNvPr id="15" name="Text 13"/>
-          <p:cNvSpPr/>
-          <p:nvPr/>
-        </p:nvSpPr>
-        <p:spPr>
-          <a:xfrm>
-            <a:off x="6812280" y="3703320"/>
-            <a:ext cx="2011680" cy="1097280"/>
-          </a:xfrm>
-          <a:prstGeom prst="rect">
-            <a:avLst/>
-          </a:prstGeom>
-          <a:noFill/>
-          <a:ln/>
-        </p:spPr>
-        <p:txBody>
-          <a:bodyPr wrap="square" rtlCol="0" anchor="t"/>
-          <a:lstStyle/>
-          <a:p>
-            <a:pPr marL="342900" indent="-342900">
-              <a:spcAft>
-                <a:spcPts val="800"/>
-              </a:spcAft>
-              <a:buSzPct val="100000"/>
-              <a:buChar char="•"/>
-            </a:pPr>
-            <a:r>
-              <a:rPr lang="en-US" sz="1200" dirty="0">
-                <a:solidFill>
-                  <a:srgbClr val="333333"/>
-                </a:solidFill>
-              </a:rPr>
-              <a:t>Ranks divergence points</a:t>
-            </a:r>
-            <a:endParaRPr lang="en-US" sz="1200" dirty="0"/>
-          </a:p>
-          <a:p>
-            <a:pPr marL="342900" indent="-342900">
-              <a:spcAft>
-                <a:spcPts val="800"/>
-              </a:spcAft>
-              <a:buSzPct val="100000"/>
-              <a:buChar char="•"/>
-            </a:pPr>
-            <a:r>
-              <a:rPr lang="en-US" sz="1200" dirty="0">
-                <a:solidFill>
-                  <a:srgbClr val="333333"/>
-                </a:solidFill>
-              </a:rPr>
-              <a:t>Explains alternative paths</a:t>
-            </a:r>
-            <a:endParaRPr lang="en-US" sz="1200" dirty="0"/>
-          </a:p>
-        </p:txBody>
-      </p:sp>
-      <p:sp>
-        <p:nvSpPr>
-          <p:cNvPr id="16" name="Shape 14"/>
-          <p:cNvSpPr/>
-          <p:nvPr/>
-        </p:nvSpPr>
-        <p:spPr>
-          <a:xfrm>
-            <a:off x="2560320" y="3840480"/>
-            <a:ext cx="822960" cy="0"/>
-          </a:xfrm>
-          <a:prstGeom prst="line">
-            <a:avLst/>
-          </a:prstGeom>
-          <a:noFill/>
-          <a:ln w="19050">
-            <a:solidFill>
-              <a:srgbClr val="000000"/>
-            </a:solidFill>
-            <a:prstDash val="solid"/>
-            <a:tailEnd type="triangle"/>
-          </a:ln>
-        </p:spPr>
-      </p:sp>
-      <p:sp>
-        <p:nvSpPr>
-          <p:cNvPr id="17" name="Text 15"/>
-          <p:cNvSpPr/>
-          <p:nvPr/>
-        </p:nvSpPr>
-        <p:spPr>
-          <a:xfrm>
-            <a:off x="2514600" y="3520440"/>
-            <a:ext cx="914400" cy="274320"/>
-          </a:xfrm>
-          <a:prstGeom prst="rect">
-            <a:avLst/>
-          </a:prstGeom>
-          <a:noFill/>
-          <a:ln/>
-        </p:spPr>
-        <p:txBody>
-          <a:bodyPr wrap="square" lIns="0" tIns="0" rIns="0" bIns="0" rtlCol="0" anchor="ctr"/>
-          <a:lstStyle/>
-          <a:p>
-            <a:pPr algn="ctr" indent="0" marL="0">
-              <a:buNone/>
-            </a:pPr>
-            <a:r>
-              <a:rPr lang="en-US" sz="900" i="1" dirty="0">
-                <a:solidFill>
-                  <a:srgbClr val="555555"/>
-                </a:solidFill>
-              </a:rPr>
-              <a:t>events.jsonl + initial-src/</a:t>
-            </a:r>
-            <a:endParaRPr lang="en-US" sz="900" dirty="0"/>
-          </a:p>
-        </p:txBody>
-      </p:sp>
-      <p:sp>
-        <p:nvSpPr>
-          <p:cNvPr id="18" name="Shape 16"/>
-          <p:cNvSpPr/>
-          <p:nvPr/>
-        </p:nvSpPr>
-        <p:spPr>
-          <a:xfrm>
-            <a:off x="5760720" y="3840480"/>
-            <a:ext cx="822960" cy="0"/>
-          </a:xfrm>
-          <a:prstGeom prst="line">
-            <a:avLst/>
-          </a:prstGeom>
-          <a:noFill/>
-          <a:ln w="19050">
-            <a:solidFill>
-              <a:srgbClr val="000000"/>
-            </a:solidFill>
-            <a:prstDash val="solid"/>
-            <a:tailEnd type="triangle"/>
-          </a:ln>
-        </p:spPr>
-      </p:sp>
-      <p:sp>
-        <p:nvSpPr>
-          <p:cNvPr id="19" name="Text 17"/>
-          <p:cNvSpPr/>
-          <p:nvPr/>
-        </p:nvSpPr>
-        <p:spPr>
-          <a:xfrm>
-            <a:off x="5715000" y="3520440"/>
-            <a:ext cx="914400" cy="274320"/>
-          </a:xfrm>
-          <a:prstGeom prst="rect">
-            <a:avLst/>
-          </a:prstGeom>
-          <a:noFill/>
-          <a:ln/>
-        </p:spPr>
-        <p:txBody>
-          <a:bodyPr wrap="square" lIns="0" tIns="0" rIns="0" bIns="0" rtlCol="0" anchor="ctr"/>
-          <a:lstStyle/>
-          <a:p>
-            <a:pPr algn="ctr" indent="0" marL="0">
-              <a:buNone/>
-            </a:pPr>
-            <a:r>
-              <a:rPr lang="en-US" sz="900" i="1" dirty="0">
-                <a:solidFill>
-                  <a:srgbClr val="555555"/>
-                </a:solidFill>
-              </a:rPr>
-              <a:t>analysis-report.json</a:t>
-            </a:r>
-            <a:endParaRPr lang="en-US" sz="900" dirty="0"/>
-          </a:p>
-        </p:txBody>
-      </p:sp>
+      </p:pic>
     </p:spTree>
   </p:cSld>
   <p:clrMapOvr>
@@ -5599,8 +6217,8 @@
         </p:nvSpPr>
         <p:spPr>
           <a:xfrm>
-            <a:off x="457200" y="274320"/>
-            <a:ext cx="8229600" cy="640080"/>
+            <a:off x="457200" y="1828800"/>
+            <a:ext cx="8229600" cy="914400"/>
           </a:xfrm>
           <a:prstGeom prst="rect">
             <a:avLst/>
@@ -5612,18 +6230,18 @@
           <a:bodyPr wrap="square" lIns="0" tIns="0" rIns="0" bIns="0" rtlCol="0" anchor="ctr"/>
           <a:lstStyle/>
           <a:p>
-            <a:pPr indent="0" marL="0">
+            <a:pPr algn="ctr" indent="0" marL="0">
               <a:buNone/>
             </a:pPr>
             <a:r>
-              <a:rPr lang="en-US" sz="2800" b="1" dirty="0">
-                <a:solidFill>
-                  <a:srgbClr val="000000"/>
-                </a:solidFill>
-              </a:rPr>
-              <a:t>Scoring a trajectory: J(τ)</a:t>
-            </a:r>
-            <a:endParaRPr lang="en-US" sz="2800" dirty="0"/>
+              <a:rPr lang="en-US" sz="4400" b="1" dirty="0">
+                <a:solidFill>
+                  <a:srgbClr val="000000"/>
+                </a:solidFill>
+              </a:rPr>
+              <a:t>Demo (part 1): live capture</a:t>
+            </a:r>
+            <a:endParaRPr lang="en-US" sz="4400" dirty="0"/>
           </a:p>
         </p:txBody>
       </p:sp>
@@ -5635,8 +6253,8 @@
         </p:nvSpPr>
         <p:spPr>
           <a:xfrm>
-            <a:off x="457200" y="1188720"/>
-            <a:ext cx="8229600" cy="3657600"/>
+            <a:off x="457200" y="2834640"/>
+            <a:ext cx="8229600" cy="1097280"/>
           </a:xfrm>
           <a:prstGeom prst="rect">
             <a:avLst/>
@@ -5645,115 +6263,21 @@
           <a:ln/>
         </p:spPr>
         <p:txBody>
-          <a:bodyPr wrap="square" rtlCol="0" anchor="t"/>
-          <a:lstStyle/>
-          <a:p>
-            <a:pPr marL="342900" indent="-342900">
-              <a:spcAft>
-                <a:spcPts val="600"/>
-              </a:spcAft>
-              <a:buSzPct val="100000"/>
-              <a:buChar char="•"/>
-            </a:pPr>
-            <a:r>
-              <a:rPr lang="en-US" sz="1600" dirty="0">
-                <a:solidFill>
-                  <a:srgbClr val="000000"/>
-                </a:solidFill>
-              </a:rPr>
-              <a:t>Process score J(τ) on a 0–100 scale, baseline 50.</a:t>
-            </a:r>
-            <a:endParaRPr lang="en-US" sz="1600" dirty="0"/>
-          </a:p>
-          <a:p>
-            <a:pPr marL="342900" indent="-342900">
-              <a:spcAft>
-                <a:spcPts val="600"/>
-              </a:spcAft>
-              <a:buSzPct val="100000"/>
-              <a:buChar char="•"/>
-            </a:pPr>
-            <a:r>
-              <a:rPr lang="en-US" sz="1600" dirty="0">
-                <a:solidFill>
-                  <a:srgbClr val="000000"/>
-                </a:solidFill>
-              </a:rPr>
-              <a:t>Positive terms — cleanliness gain (W_g = 50), step-savings bonus (W_l = 11).</a:t>
-            </a:r>
-            <a:endParaRPr lang="en-US" sz="1600" dirty="0"/>
-          </a:p>
-          <a:p>
-            <a:pPr marL="342900" indent="-342900">
-              <a:spcAft>
-                <a:spcPts val="600"/>
-              </a:spcAft>
-              <a:buSzPct val="100000"/>
-              <a:buChar char="•"/>
-            </a:pPr>
-            <a:r>
-              <a:rPr lang="en-US" sz="1600" dirty="0">
-                <a:solidFill>
-                  <a:srgbClr val="000000"/>
-                </a:solidFill>
-              </a:rPr>
-              <a:t>Process penalties — intermediate-lag (11), commit-gap (7).</a:t>
-            </a:r>
-            <a:endParaRPr lang="en-US" sz="1600" dirty="0"/>
-          </a:p>
-          <a:p>
-            <a:pPr marL="342900" indent="-342900">
-              <a:spcAft>
-                <a:spcPts val="600"/>
-              </a:spcAft>
-              <a:buSzPct val="100000"/>
-              <a:buChar char="•"/>
-            </a:pPr>
-            <a:r>
-              <a:rPr lang="en-US" sz="1600" dirty="0">
-                <a:solidFill>
-                  <a:srgbClr val="000000"/>
-                </a:solidFill>
-              </a:rPr>
-              <a:t>Safety penalties — broken build/test (28), skip-tests (14), manual-when-IDE (11).</a:t>
-            </a:r>
-            <a:endParaRPr lang="en-US" sz="1600" dirty="0"/>
-          </a:p>
-          <a:p>
-            <a:pPr marL="342900" indent="-342900">
-              <a:spcAft>
-                <a:spcPts val="600"/>
-              </a:spcAft>
-              <a:buSzPct val="100000"/>
-              <a:buChar char="•"/>
-            </a:pPr>
-            <a:r>
-              <a:rPr lang="en-US" sz="1600" dirty="0">
-                <a:solidFill>
-                  <a:srgbClr val="000000"/>
-                </a:solidFill>
-              </a:rPr>
-              <a:t>Key design choice: the broken-state penalty is sized so no single-step gain can outweigh a broken build.</a:t>
-            </a:r>
-            <a:endParaRPr lang="en-US" sz="1600" dirty="0"/>
-          </a:p>
-          <a:p>
-            <a:pPr marL="342900" indent="-342900">
-              <a:spcAft>
-                <a:spcPts val="600"/>
-              </a:spcAft>
-              <a:buSzPct val="100000"/>
-              <a:buChar char="•"/>
-            </a:pPr>
-            <a:r>
-              <a:rPr lang="en-US" sz="1600" dirty="0">
-                <a:solidFill>
-                  <a:srgbClr val="000000"/>
-                </a:solidFill>
-              </a:rPr>
-              <a:t>Behaviour preservation is non-negotiable.</a:t>
-            </a:r>
-            <a:endParaRPr lang="en-US" sz="1600" dirty="0"/>
+          <a:bodyPr wrap="square" rtlCol="0" anchor="ctr"/>
+          <a:lstStyle/>
+          <a:p>
+            <a:pPr algn="ctr" indent="0" marL="0">
+              <a:buNone/>
+            </a:pPr>
+            <a:r>
+              <a:rPr lang="en-US" sz="1800" i="1" dirty="0">
+                <a:solidFill>
+                  <a:srgbClr val="555555"/>
+                </a:solidFill>
+              </a:rPr>
+              <a:t>I'll start a short live refactoring session. The tool will analyse it in the background while we walk through the methodology.</a:t>
+            </a:r>
+            <a:endParaRPr lang="en-US" sz="1800" dirty="0"/>
           </a:p>
         </p:txBody>
       </p:sp>
@@ -5812,7 +6336,7 @@
                   <a:srgbClr val="000000"/>
                 </a:solidFill>
               </a:rPr>
-              <a:t>The cleanliness sub-score</a:t>
+              <a:t>What the tool does, end to end</a:t>
             </a:r>
             <a:endParaRPr lang="en-US" sz="2800" dirty="0"/>
           </a:p>
@@ -5826,8 +6350,8 @@
         </p:nvSpPr>
         <p:spPr>
           <a:xfrm>
-            <a:off x="457200" y="1188720"/>
-            <a:ext cx="8229600" cy="3657600"/>
+            <a:off x="457200" y="1097280"/>
+            <a:ext cx="8229600" cy="1554480"/>
           </a:xfrm>
           <a:prstGeom prst="rect">
             <a:avLst/>
@@ -5852,7 +6376,7 @@
                   <a:srgbClr val="000000"/>
                 </a:solidFill>
               </a:rPr>
-              <a:t>Six equally-weighted code-quality signals.</a:t>
+              <a:t>IntelliJ plugin: records every edit, refactoring, build, test, and commit during a session.</a:t>
             </a:r>
             <a:endParaRPr lang="en-US" sz="1600" dirty="0"/>
           </a:p>
@@ -5870,7 +6394,7 @@
                   <a:srgbClr val="000000"/>
                 </a:solidFill>
               </a:rPr>
-              <a:t>Cognitive complexity, coupling (CBO), duplication (CPD), readability, code smells (PMD), cohesion (TCC).</a:t>
+              <a:t>Analysis backend: reconstructs the trajectory, scores it, and detects divergence points.</a:t>
             </a:r>
             <a:endParaRPr lang="en-US" sz="1600" dirty="0"/>
           </a:p>
@@ -5888,27 +6412,573 @@
                   <a:srgbClr val="000000"/>
                 </a:solidFill>
               </a:rPr>
-              <a:t>Normalised against the trajectory's own range, so different sessions are comparable.</a:t>
+              <a:t>Dashboard: surfaces where you diverged, an alternative path, how much better it scores, and why.</a:t>
             </a:r>
             <a:endParaRPr lang="en-US" sz="1600" dirty="0"/>
           </a:p>
+        </p:txBody>
+      </p:sp>
+      <p:sp>
+        <p:nvSpPr>
+          <p:cNvPr id="4" name="Shape 2"/>
+          <p:cNvSpPr/>
+          <p:nvPr/>
+        </p:nvSpPr>
+        <p:spPr>
+          <a:xfrm>
+            <a:off x="182880" y="2788920"/>
+            <a:ext cx="2377440" cy="2103120"/>
+          </a:xfrm>
+          <a:prstGeom prst="rect">
+            <a:avLst/>
+          </a:prstGeom>
+          <a:solidFill>
+            <a:srgbClr val="FFFFFF"/>
+          </a:solidFill>
+          <a:ln w="12700">
+            <a:solidFill>
+              <a:srgbClr val="000000"/>
+            </a:solidFill>
+            <a:prstDash val="solid"/>
+          </a:ln>
+        </p:spPr>
+      </p:sp>
+      <p:sp>
+        <p:nvSpPr>
+          <p:cNvPr id="5" name="Text 3"/>
+          <p:cNvSpPr/>
+          <p:nvPr/>
+        </p:nvSpPr>
+        <p:spPr>
+          <a:xfrm>
+            <a:off x="274320" y="2971800"/>
+            <a:ext cx="2194560" cy="457200"/>
+          </a:xfrm>
+          <a:prstGeom prst="rect">
+            <a:avLst/>
+          </a:prstGeom>
+          <a:noFill/>
+          <a:ln/>
+        </p:spPr>
+        <p:txBody>
+          <a:bodyPr wrap="square" lIns="0" tIns="0" rIns="0" bIns="0" rtlCol="0" anchor="ctr"/>
+          <a:lstStyle/>
+          <a:p>
+            <a:pPr algn="ctr" indent="0" marL="0">
+              <a:buNone/>
+            </a:pPr>
+            <a:r>
+              <a:rPr lang="en-US" sz="1600" b="1" dirty="0">
+                <a:solidFill>
+                  <a:srgbClr val="000000"/>
+                </a:solidFill>
+              </a:rPr>
+              <a:t>IntelliJ Plugin</a:t>
+            </a:r>
+            <a:endParaRPr lang="en-US" sz="1600" dirty="0"/>
+          </a:p>
+        </p:txBody>
+      </p:sp>
+      <p:sp>
+        <p:nvSpPr>
+          <p:cNvPr id="6" name="Shape 4"/>
+          <p:cNvSpPr/>
+          <p:nvPr/>
+        </p:nvSpPr>
+        <p:spPr>
+          <a:xfrm>
+            <a:off x="457200" y="3520440"/>
+            <a:ext cx="1828800" cy="0"/>
+          </a:xfrm>
+          <a:prstGeom prst="line">
+            <a:avLst/>
+          </a:prstGeom>
+          <a:noFill/>
+          <a:ln w="9525">
+            <a:solidFill>
+              <a:srgbClr val="999999"/>
+            </a:solidFill>
+            <a:prstDash val="solid"/>
+          </a:ln>
+        </p:spPr>
+      </p:sp>
+      <p:sp>
+        <p:nvSpPr>
+          <p:cNvPr id="7" name="Text 5"/>
+          <p:cNvSpPr/>
+          <p:nvPr/>
+        </p:nvSpPr>
+        <p:spPr>
+          <a:xfrm>
+            <a:off x="411480" y="3703320"/>
+            <a:ext cx="2011680" cy="1097280"/>
+          </a:xfrm>
+          <a:prstGeom prst="rect">
+            <a:avLst/>
+          </a:prstGeom>
+          <a:noFill/>
+          <a:ln/>
+        </p:spPr>
+        <p:txBody>
+          <a:bodyPr wrap="square" rtlCol="0" anchor="t"/>
+          <a:lstStyle/>
           <a:p>
             <a:pPr marL="342900" indent="-342900">
               <a:spcAft>
-                <a:spcPts val="600"/>
+                <a:spcPts val="800"/>
               </a:spcAft>
               <a:buSzPct val="100000"/>
               <a:buChar char="•"/>
             </a:pPr>
             <a:r>
-              <a:rPr lang="en-US" sz="1600" dirty="0">
-                <a:solidFill>
-                  <a:srgbClr val="000000"/>
-                </a:solidFill>
-              </a:rPr>
-              <a:t>Equal weights are justified: no trajectory-level calibration data exists, so equal weights are the least-assumptive choice.</a:t>
+              <a:rPr lang="en-US" sz="1200" dirty="0">
+                <a:solidFill>
+                  <a:srgbClr val="333333"/>
+                </a:solidFill>
+              </a:rPr>
+              <a:t>Records developer events</a:t>
+            </a:r>
+            <a:endParaRPr lang="en-US" sz="1200" dirty="0"/>
+          </a:p>
+          <a:p>
+            <a:pPr marL="342900" indent="-342900">
+              <a:spcAft>
+                <a:spcPts val="800"/>
+              </a:spcAft>
+              <a:buSzPct val="100000"/>
+              <a:buChar char="•"/>
+            </a:pPr>
+            <a:r>
+              <a:rPr lang="en-US" sz="1200" dirty="0">
+                <a:solidFill>
+                  <a:srgbClr val="333333"/>
+                </a:solidFill>
+              </a:rPr>
+              <a:t>Captures initial codebase</a:t>
+            </a:r>
+            <a:endParaRPr lang="en-US" sz="1200" dirty="0"/>
+          </a:p>
+        </p:txBody>
+      </p:sp>
+      <p:sp>
+        <p:nvSpPr>
+          <p:cNvPr id="8" name="Shape 6"/>
+          <p:cNvSpPr/>
+          <p:nvPr/>
+        </p:nvSpPr>
+        <p:spPr>
+          <a:xfrm>
+            <a:off x="3383280" y="2788920"/>
+            <a:ext cx="2377440" cy="2103120"/>
+          </a:xfrm>
+          <a:prstGeom prst="rect">
+            <a:avLst/>
+          </a:prstGeom>
+          <a:solidFill>
+            <a:srgbClr val="FFFFFF"/>
+          </a:solidFill>
+          <a:ln w="12700">
+            <a:solidFill>
+              <a:srgbClr val="000000"/>
+            </a:solidFill>
+            <a:prstDash val="solid"/>
+          </a:ln>
+        </p:spPr>
+      </p:sp>
+      <p:sp>
+        <p:nvSpPr>
+          <p:cNvPr id="9" name="Text 7"/>
+          <p:cNvSpPr/>
+          <p:nvPr/>
+        </p:nvSpPr>
+        <p:spPr>
+          <a:xfrm>
+            <a:off x="3474720" y="2971800"/>
+            <a:ext cx="2194560" cy="457200"/>
+          </a:xfrm>
+          <a:prstGeom prst="rect">
+            <a:avLst/>
+          </a:prstGeom>
+          <a:noFill/>
+          <a:ln/>
+        </p:spPr>
+        <p:txBody>
+          <a:bodyPr wrap="square" lIns="0" tIns="0" rIns="0" bIns="0" rtlCol="0" anchor="ctr"/>
+          <a:lstStyle/>
+          <a:p>
+            <a:pPr algn="ctr" indent="0" marL="0">
+              <a:buNone/>
+            </a:pPr>
+            <a:r>
+              <a:rPr lang="en-US" sz="1600" b="1" dirty="0">
+                <a:solidFill>
+                  <a:srgbClr val="000000"/>
+                </a:solidFill>
+              </a:rPr>
+              <a:t>Analysis Backend</a:t>
             </a:r>
             <a:endParaRPr lang="en-US" sz="1600" dirty="0"/>
+          </a:p>
+        </p:txBody>
+      </p:sp>
+      <p:sp>
+        <p:nvSpPr>
+          <p:cNvPr id="10" name="Shape 8"/>
+          <p:cNvSpPr/>
+          <p:nvPr/>
+        </p:nvSpPr>
+        <p:spPr>
+          <a:xfrm>
+            <a:off x="3657600" y="3520440"/>
+            <a:ext cx="1828800" cy="0"/>
+          </a:xfrm>
+          <a:prstGeom prst="line">
+            <a:avLst/>
+          </a:prstGeom>
+          <a:noFill/>
+          <a:ln w="9525">
+            <a:solidFill>
+              <a:srgbClr val="999999"/>
+            </a:solidFill>
+            <a:prstDash val="solid"/>
+          </a:ln>
+        </p:spPr>
+      </p:sp>
+      <p:sp>
+        <p:nvSpPr>
+          <p:cNvPr id="11" name="Text 9"/>
+          <p:cNvSpPr/>
+          <p:nvPr/>
+        </p:nvSpPr>
+        <p:spPr>
+          <a:xfrm>
+            <a:off x="3611880" y="3703320"/>
+            <a:ext cx="2011680" cy="1097280"/>
+          </a:xfrm>
+          <a:prstGeom prst="rect">
+            <a:avLst/>
+          </a:prstGeom>
+          <a:noFill/>
+          <a:ln/>
+        </p:spPr>
+        <p:txBody>
+          <a:bodyPr wrap="square" rtlCol="0" anchor="t"/>
+          <a:lstStyle/>
+          <a:p>
+            <a:pPr marL="342900" indent="-342900">
+              <a:spcAft>
+                <a:spcPts val="800"/>
+              </a:spcAft>
+              <a:buSzPct val="100000"/>
+              <a:buChar char="•"/>
+            </a:pPr>
+            <a:r>
+              <a:rPr lang="en-US" sz="1200" dirty="0">
+                <a:solidFill>
+                  <a:srgbClr val="333333"/>
+                </a:solidFill>
+              </a:rPr>
+              <a:t>Shadow repo reconstruction</a:t>
+            </a:r>
+            <a:endParaRPr lang="en-US" sz="1200" dirty="0"/>
+          </a:p>
+          <a:p>
+            <a:pPr marL="342900" indent="-342900">
+              <a:spcAft>
+                <a:spcPts val="800"/>
+              </a:spcAft>
+              <a:buSzPct val="100000"/>
+              <a:buChar char="•"/>
+            </a:pPr>
+            <a:r>
+              <a:rPr lang="en-US" sz="1200" dirty="0">
+                <a:solidFill>
+                  <a:srgbClr val="333333"/>
+                </a:solidFill>
+              </a:rPr>
+              <a:t>Metric calculation</a:t>
+            </a:r>
+            <a:endParaRPr lang="en-US" sz="1200" dirty="0"/>
+          </a:p>
+          <a:p>
+            <a:pPr marL="342900" indent="-342900">
+              <a:spcAft>
+                <a:spcPts val="800"/>
+              </a:spcAft>
+              <a:buSzPct val="100000"/>
+              <a:buChar char="•"/>
+            </a:pPr>
+            <a:r>
+              <a:rPr lang="en-US" sz="1200" dirty="0">
+                <a:solidFill>
+                  <a:srgbClr val="333333"/>
+                </a:solidFill>
+              </a:rPr>
+              <a:t>Divergence synthesis</a:t>
+            </a:r>
+            <a:endParaRPr lang="en-US" sz="1200" dirty="0"/>
+          </a:p>
+        </p:txBody>
+      </p:sp>
+      <p:sp>
+        <p:nvSpPr>
+          <p:cNvPr id="12" name="Shape 10"/>
+          <p:cNvSpPr/>
+          <p:nvPr/>
+        </p:nvSpPr>
+        <p:spPr>
+          <a:xfrm>
+            <a:off x="6583680" y="2788920"/>
+            <a:ext cx="2377440" cy="2103120"/>
+          </a:xfrm>
+          <a:prstGeom prst="rect">
+            <a:avLst/>
+          </a:prstGeom>
+          <a:solidFill>
+            <a:srgbClr val="FFFFFF"/>
+          </a:solidFill>
+          <a:ln w="12700">
+            <a:solidFill>
+              <a:srgbClr val="000000"/>
+            </a:solidFill>
+            <a:prstDash val="solid"/>
+          </a:ln>
+        </p:spPr>
+      </p:sp>
+      <p:sp>
+        <p:nvSpPr>
+          <p:cNvPr id="13" name="Text 11"/>
+          <p:cNvSpPr/>
+          <p:nvPr/>
+        </p:nvSpPr>
+        <p:spPr>
+          <a:xfrm>
+            <a:off x="6675120" y="2971800"/>
+            <a:ext cx="2194560" cy="457200"/>
+          </a:xfrm>
+          <a:prstGeom prst="rect">
+            <a:avLst/>
+          </a:prstGeom>
+          <a:noFill/>
+          <a:ln/>
+        </p:spPr>
+        <p:txBody>
+          <a:bodyPr wrap="square" lIns="0" tIns="0" rIns="0" bIns="0" rtlCol="0" anchor="ctr"/>
+          <a:lstStyle/>
+          <a:p>
+            <a:pPr algn="ctr" indent="0" marL="0">
+              <a:buNone/>
+            </a:pPr>
+            <a:r>
+              <a:rPr lang="en-US" sz="1600" b="1" dirty="0">
+                <a:solidFill>
+                  <a:srgbClr val="000000"/>
+                </a:solidFill>
+              </a:rPr>
+              <a:t>Dashboard</a:t>
+            </a:r>
+            <a:endParaRPr lang="en-US" sz="1600" dirty="0"/>
+          </a:p>
+        </p:txBody>
+      </p:sp>
+      <p:sp>
+        <p:nvSpPr>
+          <p:cNvPr id="14" name="Shape 12"/>
+          <p:cNvSpPr/>
+          <p:nvPr/>
+        </p:nvSpPr>
+        <p:spPr>
+          <a:xfrm>
+            <a:off x="6858000" y="3520440"/>
+            <a:ext cx="1828800" cy="0"/>
+          </a:xfrm>
+          <a:prstGeom prst="line">
+            <a:avLst/>
+          </a:prstGeom>
+          <a:noFill/>
+          <a:ln w="9525">
+            <a:solidFill>
+              <a:srgbClr val="999999"/>
+            </a:solidFill>
+            <a:prstDash val="solid"/>
+          </a:ln>
+        </p:spPr>
+      </p:sp>
+      <p:sp>
+        <p:nvSpPr>
+          <p:cNvPr id="15" name="Text 13"/>
+          <p:cNvSpPr/>
+          <p:nvPr/>
+        </p:nvSpPr>
+        <p:spPr>
+          <a:xfrm>
+            <a:off x="6812280" y="3703320"/>
+            <a:ext cx="2011680" cy="1097280"/>
+          </a:xfrm>
+          <a:prstGeom prst="rect">
+            <a:avLst/>
+          </a:prstGeom>
+          <a:noFill/>
+          <a:ln/>
+        </p:spPr>
+        <p:txBody>
+          <a:bodyPr wrap="square" rtlCol="0" anchor="t"/>
+          <a:lstStyle/>
+          <a:p>
+            <a:pPr marL="342900" indent="-342900">
+              <a:spcAft>
+                <a:spcPts val="800"/>
+              </a:spcAft>
+              <a:buSzPct val="100000"/>
+              <a:buChar char="•"/>
+            </a:pPr>
+            <a:r>
+              <a:rPr lang="en-US" sz="1200" dirty="0">
+                <a:solidFill>
+                  <a:srgbClr val="333333"/>
+                </a:solidFill>
+              </a:rPr>
+              <a:t>Surfaces divergence points in context</a:t>
+            </a:r>
+            <a:endParaRPr lang="en-US" sz="1200" dirty="0"/>
+          </a:p>
+          <a:p>
+            <a:pPr marL="342900" indent="-342900">
+              <a:spcAft>
+                <a:spcPts val="800"/>
+              </a:spcAft>
+              <a:buSzPct val="100000"/>
+              <a:buChar char="•"/>
+            </a:pPr>
+            <a:r>
+              <a:rPr lang="en-US" sz="1200" dirty="0">
+                <a:solidFill>
+                  <a:srgbClr val="333333"/>
+                </a:solidFill>
+              </a:rPr>
+              <a:t>Explains alternative paths</a:t>
+            </a:r>
+            <a:endParaRPr lang="en-US" sz="1200" dirty="0"/>
+          </a:p>
+        </p:txBody>
+      </p:sp>
+      <p:sp>
+        <p:nvSpPr>
+          <p:cNvPr id="16" name="Shape 14"/>
+          <p:cNvSpPr/>
+          <p:nvPr/>
+        </p:nvSpPr>
+        <p:spPr>
+          <a:xfrm>
+            <a:off x="2560320" y="3840480"/>
+            <a:ext cx="822960" cy="0"/>
+          </a:xfrm>
+          <a:prstGeom prst="line">
+            <a:avLst/>
+          </a:prstGeom>
+          <a:noFill/>
+          <a:ln w="19050">
+            <a:solidFill>
+              <a:srgbClr val="000000"/>
+            </a:solidFill>
+            <a:prstDash val="solid"/>
+            <a:tailEnd type="triangle"/>
+          </a:ln>
+        </p:spPr>
+      </p:sp>
+      <p:sp>
+        <p:nvSpPr>
+          <p:cNvPr id="17" name="Text 15"/>
+          <p:cNvSpPr/>
+          <p:nvPr/>
+        </p:nvSpPr>
+        <p:spPr>
+          <a:xfrm>
+            <a:off x="2514600" y="3520440"/>
+            <a:ext cx="914400" cy="274320"/>
+          </a:xfrm>
+          <a:prstGeom prst="rect">
+            <a:avLst/>
+          </a:prstGeom>
+          <a:noFill/>
+          <a:ln/>
+        </p:spPr>
+        <p:txBody>
+          <a:bodyPr wrap="square" lIns="0" tIns="0" rIns="0" bIns="0" rtlCol="0" anchor="ctr"/>
+          <a:lstStyle/>
+          <a:p>
+            <a:pPr algn="ctr" indent="0" marL="0">
+              <a:buNone/>
+            </a:pPr>
+            <a:r>
+              <a:rPr lang="en-US" sz="900" i="1" dirty="0">
+                <a:solidFill>
+                  <a:srgbClr val="555555"/>
+                </a:solidFill>
+              </a:rPr>
+              <a:t>events.jsonl + initial-src/</a:t>
+            </a:r>
+            <a:endParaRPr lang="en-US" sz="900" dirty="0"/>
+          </a:p>
+        </p:txBody>
+      </p:sp>
+      <p:sp>
+        <p:nvSpPr>
+          <p:cNvPr id="18" name="Shape 16"/>
+          <p:cNvSpPr/>
+          <p:nvPr/>
+        </p:nvSpPr>
+        <p:spPr>
+          <a:xfrm>
+            <a:off x="5760720" y="3840480"/>
+            <a:ext cx="822960" cy="0"/>
+          </a:xfrm>
+          <a:prstGeom prst="line">
+            <a:avLst/>
+          </a:prstGeom>
+          <a:noFill/>
+          <a:ln w="19050">
+            <a:solidFill>
+              <a:srgbClr val="000000"/>
+            </a:solidFill>
+            <a:prstDash val="solid"/>
+            <a:tailEnd type="triangle"/>
+          </a:ln>
+        </p:spPr>
+      </p:sp>
+      <p:sp>
+        <p:nvSpPr>
+          <p:cNvPr id="19" name="Text 17"/>
+          <p:cNvSpPr/>
+          <p:nvPr/>
+        </p:nvSpPr>
+        <p:spPr>
+          <a:xfrm>
+            <a:off x="5715000" y="3520440"/>
+            <a:ext cx="914400" cy="274320"/>
+          </a:xfrm>
+          <a:prstGeom prst="rect">
+            <a:avLst/>
+          </a:prstGeom>
+          <a:noFill/>
+          <a:ln/>
+        </p:spPr>
+        <p:txBody>
+          <a:bodyPr wrap="square" lIns="0" tIns="0" rIns="0" bIns="0" rtlCol="0" anchor="ctr"/>
+          <a:lstStyle/>
+          <a:p>
+            <a:pPr algn="ctr" indent="0" marL="0">
+              <a:buNone/>
+            </a:pPr>
+            <a:r>
+              <a:rPr lang="en-US" sz="900" i="1" dirty="0">
+                <a:solidFill>
+                  <a:srgbClr val="555555"/>
+                </a:solidFill>
+              </a:rPr>
+              <a:t>analysis-report.json</a:t>
+            </a:r>
+            <a:endParaRPr lang="en-US" sz="900" dirty="0"/>
           </a:p>
         </p:txBody>
       </p:sp>
@@ -5967,7 +7037,7 @@
                   <a:srgbClr val="000000"/>
                 </a:solidFill>
               </a:rPr>
-              <a:t>Four kinds of divergence</a:t>
+              <a:t>Scoring a trajectory: J(τ)</a:t>
             </a:r>
             <a:endParaRPr lang="en-US" sz="2800" dirty="0"/>
           </a:p>
@@ -5981,8 +7051,8 @@
         </p:nvSpPr>
         <p:spPr>
           <a:xfrm>
-            <a:off x="457200" y="1188720"/>
-            <a:ext cx="8229600" cy="3657600"/>
+            <a:off x="457200" y="1143000"/>
+            <a:ext cx="8229600" cy="548640"/>
           </a:xfrm>
           <a:prstGeom prst="rect">
             <a:avLst/>
@@ -5991,97 +7061,860 @@
           <a:ln/>
         </p:spPr>
         <p:txBody>
-          <a:bodyPr wrap="square" rtlCol="0" anchor="t"/>
-          <a:lstStyle/>
-          <a:p>
-            <a:pPr marL="342900" indent="-342900">
-              <a:spcAft>
-                <a:spcPts val="600"/>
-              </a:spcAft>
-              <a:buSzPct val="100000"/>
-              <a:buChar char="•"/>
-            </a:pPr>
-            <a:r>
-              <a:rPr lang="en-US" sz="1600" dirty="0">
-                <a:solidFill>
-                  <a:srgbClr val="000000"/>
-                </a:solidFill>
-              </a:rPr>
-              <a:t>Ordering — the right refactorings, performed in a suboptimal order.</a:t>
-            </a:r>
-            <a:endParaRPr lang="en-US" sz="1600" dirty="0"/>
-          </a:p>
-          <a:p>
-            <a:pPr marL="342900" indent="-342900">
-              <a:spcAft>
-                <a:spcPts val="600"/>
-              </a:spcAft>
-              <a:buSzPct val="100000"/>
-              <a:buChar char="•"/>
-            </a:pPr>
-            <a:r>
-              <a:rPr lang="en-US" sz="1600" dirty="0">
-                <a:solidFill>
-                  <a:srgbClr val="000000"/>
-                </a:solidFill>
-              </a:rPr>
-              <a:t>Manual-Refactor — hand-edited what the IDE could do safely.</a:t>
-            </a:r>
-            <a:endParaRPr lang="en-US" sz="1600" dirty="0"/>
-          </a:p>
-          <a:p>
-            <a:pPr marL="342900" indent="-342900">
-              <a:spcAft>
-                <a:spcPts val="600"/>
-              </a:spcAft>
-              <a:buSzPct val="100000"/>
-              <a:buChar char="•"/>
-            </a:pPr>
-            <a:r>
-              <a:rPr lang="en-US" sz="1600" dirty="0">
-                <a:solidFill>
-                  <a:srgbClr val="000000"/>
-                </a:solidFill>
-              </a:rPr>
-              <a:t>Rework — added code then removed it (or vice versa); net-zero churn.</a:t>
-            </a:r>
-            <a:endParaRPr lang="en-US" sz="1600" dirty="0"/>
-          </a:p>
-          <a:p>
-            <a:pPr marL="342900" indent="-342900">
-              <a:spcAft>
-                <a:spcPts val="600"/>
-              </a:spcAft>
-              <a:buSzPct val="100000"/>
-              <a:buChar char="•"/>
-            </a:pPr>
-            <a:r>
-              <a:rPr lang="en-US" sz="1600" dirty="0">
-                <a:solidFill>
-                  <a:srgbClr val="000000"/>
-                </a:solidFill>
-              </a:rPr>
-              <a:t>Hygiene — long stretches without tests or commits.</a:t>
-            </a:r>
-            <a:endParaRPr lang="en-US" sz="1600" dirty="0"/>
-          </a:p>
-          <a:p>
-            <a:pPr marL="342900" indent="-342900">
-              <a:spcAft>
-                <a:spcPts val="600"/>
-              </a:spcAft>
-              <a:buSzPct val="100000"/>
-              <a:buChar char="•"/>
-            </a:pPr>
-            <a:r>
-              <a:rPr lang="en-US" sz="1600" dirty="0">
-                <a:solidFill>
-                  <a:srgbClr val="000000"/>
-                </a:solidFill>
-              </a:rPr>
-              <a:t>Each is actionable, and each has its own detector + synthesiser — the next four slides walk through them.</a:t>
-            </a:r>
-            <a:endParaRPr lang="en-US" sz="1600" dirty="0"/>
+          <a:bodyPr wrap="square" lIns="0" tIns="0" rIns="0" bIns="0" rtlCol="0" anchor="ctr"/>
+          <a:lstStyle/>
+          <a:p>
+            <a:pPr algn="ctr" indent="0" marL="0">
+              <a:buNone/>
+            </a:pPr>
+            <a:r>
+              <a:rPr lang="en-US" sz="2200" dirty="0">
+                <a:solidFill>
+                  <a:srgbClr val="000000"/>
+                </a:solidFill>
+              </a:rPr>
+              <a:t>J(τ)  =  clip</a:t>
+            </a:r>
+            <a:pPr algn="ctr" indent="0" marL="0">
+              <a:buNone/>
+            </a:pPr>
+            <a:r>
+              <a:rPr lang="en-US" sz="2200" baseline="-40000" dirty="0">
+                <a:solidFill>
+                  <a:srgbClr val="000000"/>
+                </a:solidFill>
+              </a:rPr>
+              <a:t>[0,100]</a:t>
+            </a:r>
+            <a:pPr algn="ctr" indent="0" marL="0">
+              <a:buNone/>
+            </a:pPr>
+            <a:r>
+              <a:rPr lang="en-US" sz="2200" dirty="0">
+                <a:solidFill>
+                  <a:srgbClr val="000000"/>
+                </a:solidFill>
+              </a:rPr>
+              <a:t>  (    50    </a:t>
+            </a:r>
+            <a:pPr algn="ctr" indent="0" marL="0">
+              <a:buNone/>
+            </a:pPr>
+            <a:r>
+              <a:rPr lang="en-US" sz="2200" i="1" dirty="0">
+                <a:solidFill>
+                  <a:srgbClr val="777777"/>
+                </a:solidFill>
+              </a:rPr>
+              <a:t>(baseline)</a:t>
+            </a:r>
+            <a:pPr algn="ctr" indent="0" marL="0">
+              <a:buNone/>
+            </a:pPr>
+            <a:r>
+              <a:rPr lang="en-US" sz="2200" dirty="0">
+                <a:solidFill>
+                  <a:srgbClr val="000000"/>
+                </a:solidFill>
+              </a:rPr>
+              <a:t>    +</a:t>
+            </a:r>
+            <a:endParaRPr lang="en-US" sz="2200" dirty="0"/>
+          </a:p>
+        </p:txBody>
+      </p:sp>
+      <p:graphicFrame>
+        <p:nvGraphicFramePr>
+          <p:cNvPr id="9" name="Table 0"/>
+          <p:cNvGraphicFramePr>
+            <a:graphicFrameLocks noGrp="1"/>
+          </p:cNvGraphicFramePr>
+          <p:nvPr>
+            <p:extLst>
+              <p:ext uri="{D42A27DB-BD31-4B8C-83A1-F6EECF244321}">
+                <p14:modId xmlns:p14="http://schemas.microsoft.com/office/powerpoint/2010/main" val="1579011935"/>
+              </p:ext>
+            </p:extLst>
+          </p:nvPr>
+        </p:nvGraphicFramePr>
+        <p:xfrm>
+          <a:off x="2377440" y="1874520"/>
+          <a:ext cx="4389120" cy="914400"/>
+        </p:xfrm>
+        <a:graphic>
+          <a:graphicData uri="http://schemas.openxmlformats.org/drawingml/2006/table">
+            <a:tbl>
+              <a:tblPr/>
+              <a:tblGrid>
+                <a:gridCol w="731520"/>
+                <a:gridCol w="365760"/>
+                <a:gridCol w="3291840"/>
+              </a:tblGrid>
+              <a:tr h="310896">
+                <a:tc>
+                  <a:txBody>
+                    <a:bodyPr/>
+                    <a:lstStyle/>
+                    <a:p>
+                      <a:pPr algn="r" indent="0" marL="0">
+                        <a:buNone/>
+                      </a:pPr>
+                      <a:r>
+                        <a:rPr lang="en-US" sz="1600" b="1" dirty="0">
+                          <a:solidFill>
+                            <a:srgbClr val="0A7D2A"/>
+                          </a:solidFill>
+                        </a:rPr>
+                        <a:t>+50</a:t>
+                      </a:r>
+                      <a:endParaRPr lang="en-US" sz="1600" dirty="0"/>
+                    </a:p>
+                  </a:txBody>
+                  <a:tcPr marL="54864" marR="54864" marT="54864" marB="54864" anchor="ctr">
+                    <a:lnL w="0" cap="flat" cmpd="sng" algn="ctr">
+                      <a:noFill/>
+                    </a:lnL>
+                    <a:lnR w="0" cap="flat" cmpd="sng" algn="ctr">
+                      <a:noFill/>
+                    </a:lnR>
+                    <a:lnT w="0" cap="flat" cmpd="sng" algn="ctr">
+                      <a:noFill/>
+                    </a:lnT>
+                    <a:lnB w="0" cap="flat" cmpd="sng" algn="ctr">
+                      <a:noFill/>
+                    </a:lnB>
+                  </a:tcPr>
+                </a:tc>
+                <a:tc>
+                  <a:txBody>
+                    <a:bodyPr/>
+                    <a:lstStyle/>
+                    <a:p>
+                      <a:pPr algn="ctr" indent="0" marL="0">
+                        <a:buNone/>
+                      </a:pPr>
+                      <a:r>
+                        <a:rPr lang="en-US" sz="1600" dirty="0">
+                          <a:solidFill>
+                            <a:srgbClr val="555555"/>
+                          </a:solidFill>
+                        </a:rPr>
+                        <a:t>×</a:t>
+                      </a:r>
+                      <a:endParaRPr lang="en-US" sz="1600" dirty="0"/>
+                    </a:p>
+                  </a:txBody>
+                  <a:tcPr marL="36576" marR="36576" marT="36576" marB="36576" anchor="ctr">
+                    <a:lnL w="0" cap="flat" cmpd="sng" algn="ctr">
+                      <a:noFill/>
+                    </a:lnL>
+                    <a:lnR w="0" cap="flat" cmpd="sng" algn="ctr">
+                      <a:noFill/>
+                    </a:lnR>
+                    <a:lnT w="0" cap="flat" cmpd="sng" algn="ctr">
+                      <a:noFill/>
+                    </a:lnT>
+                    <a:lnB w="0" cap="flat" cmpd="sng" algn="ctr">
+                      <a:noFill/>
+                    </a:lnB>
+                  </a:tcPr>
+                </a:tc>
+                <a:tc>
+                  <a:txBody>
+                    <a:bodyPr/>
+                    <a:lstStyle/>
+                    <a:p>
+                      <a:pPr algn="l" indent="0" marL="0">
+                        <a:buNone/>
+                      </a:pPr>
+                      <a:r>
+                        <a:rPr lang="en-US" sz="1600" dirty="0">
+                          <a:solidFill>
+                            <a:srgbClr val="1A1A1A"/>
+                          </a:solidFill>
+                        </a:rPr>
+                        <a:t>cleanliness gain</a:t>
+                      </a:r>
+                      <a:endParaRPr lang="en-US" sz="1600" dirty="0"/>
+                    </a:p>
+                  </a:txBody>
+                  <a:tcPr marL="54864" marR="54864" marT="54864" marB="54864" anchor="ctr">
+                    <a:lnL w="0" cap="flat" cmpd="sng" algn="ctr">
+                      <a:noFill/>
+                    </a:lnL>
+                    <a:lnR w="0" cap="flat" cmpd="sng" algn="ctr">
+                      <a:noFill/>
+                    </a:lnR>
+                    <a:lnT w="0" cap="flat" cmpd="sng" algn="ctr">
+                      <a:noFill/>
+                    </a:lnT>
+                    <a:lnB w="0" cap="flat" cmpd="sng" algn="ctr">
+                      <a:noFill/>
+                    </a:lnB>
+                  </a:tcPr>
+                </a:tc>
+              </a:tr>
+              <a:tr h="310896">
+                <a:tc>
+                  <a:txBody>
+                    <a:bodyPr/>
+                    <a:lstStyle/>
+                    <a:p>
+                      <a:pPr algn="r" indent="0" marL="0">
+                        <a:buNone/>
+                      </a:pPr>
+                      <a:r>
+                        <a:rPr lang="en-US" sz="1600" b="1" dirty="0">
+                          <a:solidFill>
+                            <a:srgbClr val="0A7D2A"/>
+                          </a:solidFill>
+                        </a:rPr>
+                        <a:t>+11</a:t>
+                      </a:r>
+                      <a:endParaRPr lang="en-US" sz="1600" dirty="0"/>
+                    </a:p>
+                  </a:txBody>
+                  <a:tcPr marL="54864" marR="54864" marT="54864" marB="54864" anchor="ctr">
+                    <a:lnL w="0" cap="flat" cmpd="sng" algn="ctr">
+                      <a:noFill/>
+                    </a:lnL>
+                    <a:lnR w="0" cap="flat" cmpd="sng" algn="ctr">
+                      <a:noFill/>
+                    </a:lnR>
+                    <a:lnT w="0" cap="flat" cmpd="sng" algn="ctr">
+                      <a:noFill/>
+                    </a:lnT>
+                    <a:lnB w="0" cap="flat" cmpd="sng" algn="ctr">
+                      <a:noFill/>
+                    </a:lnB>
+                  </a:tcPr>
+                </a:tc>
+                <a:tc>
+                  <a:txBody>
+                    <a:bodyPr/>
+                    <a:lstStyle/>
+                    <a:p>
+                      <a:pPr algn="ctr" indent="0" marL="0">
+                        <a:buNone/>
+                      </a:pPr>
+                      <a:r>
+                        <a:rPr lang="en-US" sz="1600" dirty="0">
+                          <a:solidFill>
+                            <a:srgbClr val="555555"/>
+                          </a:solidFill>
+                        </a:rPr>
+                        <a:t>×</a:t>
+                      </a:r>
+                      <a:endParaRPr lang="en-US" sz="1600" dirty="0"/>
+                    </a:p>
+                  </a:txBody>
+                  <a:tcPr marL="36576" marR="36576" marT="36576" marB="36576" anchor="ctr">
+                    <a:lnL w="0" cap="flat" cmpd="sng" algn="ctr">
+                      <a:noFill/>
+                    </a:lnL>
+                    <a:lnR w="0" cap="flat" cmpd="sng" algn="ctr">
+                      <a:noFill/>
+                    </a:lnR>
+                    <a:lnT w="0" cap="flat" cmpd="sng" algn="ctr">
+                      <a:noFill/>
+                    </a:lnT>
+                    <a:lnB w="0" cap="flat" cmpd="sng" algn="ctr">
+                      <a:noFill/>
+                    </a:lnB>
+                  </a:tcPr>
+                </a:tc>
+                <a:tc>
+                  <a:txBody>
+                    <a:bodyPr/>
+                    <a:lstStyle/>
+                    <a:p>
+                      <a:pPr algn="l" indent="0" marL="0">
+                        <a:buNone/>
+                      </a:pPr>
+                      <a:r>
+                        <a:rPr lang="en-US" sz="1600" dirty="0">
+                          <a:solidFill>
+                            <a:srgbClr val="1A1A1A"/>
+                          </a:solidFill>
+                        </a:rPr>
+                        <a:t>step-savings bonus</a:t>
+                      </a:r>
+                      <a:endParaRPr lang="en-US" sz="1600" dirty="0"/>
+                    </a:p>
+                  </a:txBody>
+                  <a:tcPr marL="54864" marR="54864" marT="54864" marB="54864" anchor="ctr">
+                    <a:lnL w="0" cap="flat" cmpd="sng" algn="ctr">
+                      <a:noFill/>
+                    </a:lnL>
+                    <a:lnR w="0" cap="flat" cmpd="sng" algn="ctr">
+                      <a:noFill/>
+                    </a:lnR>
+                    <a:lnT w="0" cap="flat" cmpd="sng" algn="ctr">
+                      <a:noFill/>
+                    </a:lnT>
+                    <a:lnB w="0" cap="flat" cmpd="sng" algn="ctr">
+                      <a:noFill/>
+                    </a:lnB>
+                  </a:tcPr>
+                </a:tc>
+              </a:tr>
+              <a:tr h="310896">
+                <a:tc>
+                  <a:txBody>
+                    <a:bodyPr/>
+                    <a:lstStyle/>
+                    <a:p>
+                      <a:pPr algn="r" indent="0" marL="0">
+                        <a:buNone/>
+                      </a:pPr>
+                      <a:r>
+                        <a:rPr lang="en-US" sz="1600" b="1" dirty="0">
+                          <a:solidFill>
+                            <a:srgbClr val="B33A1E"/>
+                          </a:solidFill>
+                        </a:rPr>
+                        <a:t>−28</a:t>
+                      </a:r>
+                      <a:endParaRPr lang="en-US" sz="1600" dirty="0"/>
+                    </a:p>
+                  </a:txBody>
+                  <a:tcPr marL="54864" marR="54864" marT="54864" marB="54864" anchor="ctr">
+                    <a:lnL w="0" cap="flat" cmpd="sng" algn="ctr">
+                      <a:noFill/>
+                    </a:lnL>
+                    <a:lnR w="0" cap="flat" cmpd="sng" algn="ctr">
+                      <a:noFill/>
+                    </a:lnR>
+                    <a:lnT w="0" cap="flat" cmpd="sng" algn="ctr">
+                      <a:noFill/>
+                    </a:lnT>
+                    <a:lnB w="0" cap="flat" cmpd="sng" algn="ctr">
+                      <a:noFill/>
+                    </a:lnB>
+                  </a:tcPr>
+                </a:tc>
+                <a:tc>
+                  <a:txBody>
+                    <a:bodyPr/>
+                    <a:lstStyle/>
+                    <a:p>
+                      <a:pPr algn="ctr" indent="0" marL="0">
+                        <a:buNone/>
+                      </a:pPr>
+                      <a:r>
+                        <a:rPr lang="en-US" sz="1600" dirty="0">
+                          <a:solidFill>
+                            <a:srgbClr val="555555"/>
+                          </a:solidFill>
+                        </a:rPr>
+                        <a:t>×</a:t>
+                      </a:r>
+                      <a:endParaRPr lang="en-US" sz="1600" dirty="0"/>
+                    </a:p>
+                  </a:txBody>
+                  <a:tcPr marL="36576" marR="36576" marT="36576" marB="36576" anchor="ctr">
+                    <a:lnL w="0" cap="flat" cmpd="sng" algn="ctr">
+                      <a:noFill/>
+                    </a:lnL>
+                    <a:lnR w="0" cap="flat" cmpd="sng" algn="ctr">
+                      <a:noFill/>
+                    </a:lnR>
+                    <a:lnT w="0" cap="flat" cmpd="sng" algn="ctr">
+                      <a:noFill/>
+                    </a:lnT>
+                    <a:lnB w="0" cap="flat" cmpd="sng" algn="ctr">
+                      <a:noFill/>
+                    </a:lnB>
+                  </a:tcPr>
+                </a:tc>
+                <a:tc>
+                  <a:txBody>
+                    <a:bodyPr/>
+                    <a:lstStyle/>
+                    <a:p>
+                      <a:pPr algn="l" indent="0" marL="0">
+                        <a:buNone/>
+                      </a:pPr>
+                      <a:r>
+                        <a:rPr lang="en-US" sz="1600" dirty="0">
+                          <a:solidFill>
+                            <a:srgbClr val="1A1A1A"/>
+                          </a:solidFill>
+                        </a:rPr>
+                        <a:t>broken build / test rate</a:t>
+                      </a:r>
+                      <a:endParaRPr lang="en-US" sz="1600" dirty="0"/>
+                    </a:p>
+                  </a:txBody>
+                  <a:tcPr marL="54864" marR="54864" marT="54864" marB="54864" anchor="ctr">
+                    <a:lnL w="0" cap="flat" cmpd="sng" algn="ctr">
+                      <a:noFill/>
+                    </a:lnL>
+                    <a:lnR w="0" cap="flat" cmpd="sng" algn="ctr">
+                      <a:noFill/>
+                    </a:lnR>
+                    <a:lnT w="0" cap="flat" cmpd="sng" algn="ctr">
+                      <a:noFill/>
+                    </a:lnT>
+                    <a:lnB w="0" cap="flat" cmpd="sng" algn="ctr">
+                      <a:noFill/>
+                    </a:lnB>
+                  </a:tcPr>
+                </a:tc>
+              </a:tr>
+              <a:tr h="310896">
+                <a:tc>
+                  <a:txBody>
+                    <a:bodyPr/>
+                    <a:lstStyle/>
+                    <a:p>
+                      <a:pPr algn="r" indent="0" marL="0">
+                        <a:buNone/>
+                      </a:pPr>
+                      <a:r>
+                        <a:rPr lang="en-US" sz="1600" b="1" dirty="0">
+                          <a:solidFill>
+                            <a:srgbClr val="B33A1E"/>
+                          </a:solidFill>
+                        </a:rPr>
+                        <a:t>−14</a:t>
+                      </a:r>
+                      <a:endParaRPr lang="en-US" sz="1600" dirty="0"/>
+                    </a:p>
+                  </a:txBody>
+                  <a:tcPr marL="54864" marR="54864" marT="54864" marB="54864" anchor="ctr">
+                    <a:lnL w="0" cap="flat" cmpd="sng" algn="ctr">
+                      <a:noFill/>
+                    </a:lnL>
+                    <a:lnR w="0" cap="flat" cmpd="sng" algn="ctr">
+                      <a:noFill/>
+                    </a:lnR>
+                    <a:lnT w="0" cap="flat" cmpd="sng" algn="ctr">
+                      <a:noFill/>
+                    </a:lnT>
+                    <a:lnB w="0" cap="flat" cmpd="sng" algn="ctr">
+                      <a:noFill/>
+                    </a:lnB>
+                  </a:tcPr>
+                </a:tc>
+                <a:tc>
+                  <a:txBody>
+                    <a:bodyPr/>
+                    <a:lstStyle/>
+                    <a:p>
+                      <a:pPr algn="ctr" indent="0" marL="0">
+                        <a:buNone/>
+                      </a:pPr>
+                      <a:r>
+                        <a:rPr lang="en-US" sz="1600" dirty="0">
+                          <a:solidFill>
+                            <a:srgbClr val="555555"/>
+                          </a:solidFill>
+                        </a:rPr>
+                        <a:t>×</a:t>
+                      </a:r>
+                      <a:endParaRPr lang="en-US" sz="1600" dirty="0"/>
+                    </a:p>
+                  </a:txBody>
+                  <a:tcPr marL="36576" marR="36576" marT="36576" marB="36576" anchor="ctr">
+                    <a:lnL w="0" cap="flat" cmpd="sng" algn="ctr">
+                      <a:noFill/>
+                    </a:lnL>
+                    <a:lnR w="0" cap="flat" cmpd="sng" algn="ctr">
+                      <a:noFill/>
+                    </a:lnR>
+                    <a:lnT w="0" cap="flat" cmpd="sng" algn="ctr">
+                      <a:noFill/>
+                    </a:lnT>
+                    <a:lnB w="0" cap="flat" cmpd="sng" algn="ctr">
+                      <a:noFill/>
+                    </a:lnB>
+                  </a:tcPr>
+                </a:tc>
+                <a:tc>
+                  <a:txBody>
+                    <a:bodyPr/>
+                    <a:lstStyle/>
+                    <a:p>
+                      <a:pPr algn="l" indent="0" marL="0">
+                        <a:buNone/>
+                      </a:pPr>
+                      <a:r>
+                        <a:rPr lang="en-US" sz="1600" dirty="0">
+                          <a:solidFill>
+                            <a:srgbClr val="1A1A1A"/>
+                          </a:solidFill>
+                        </a:rPr>
+                        <a:t>skipped-test rate</a:t>
+                      </a:r>
+                      <a:endParaRPr lang="en-US" sz="1600" dirty="0"/>
+                    </a:p>
+                  </a:txBody>
+                  <a:tcPr marL="54864" marR="54864" marT="54864" marB="54864" anchor="ctr">
+                    <a:lnL w="0" cap="flat" cmpd="sng" algn="ctr">
+                      <a:noFill/>
+                    </a:lnL>
+                    <a:lnR w="0" cap="flat" cmpd="sng" algn="ctr">
+                      <a:noFill/>
+                    </a:lnR>
+                    <a:lnT w="0" cap="flat" cmpd="sng" algn="ctr">
+                      <a:noFill/>
+                    </a:lnT>
+                    <a:lnB w="0" cap="flat" cmpd="sng" algn="ctr">
+                      <a:noFill/>
+                    </a:lnB>
+                  </a:tcPr>
+                </a:tc>
+              </a:tr>
+              <a:tr h="310896">
+                <a:tc>
+                  <a:txBody>
+                    <a:bodyPr/>
+                    <a:lstStyle/>
+                    <a:p>
+                      <a:pPr algn="r" indent="0" marL="0">
+                        <a:buNone/>
+                      </a:pPr>
+                      <a:r>
+                        <a:rPr lang="en-US" sz="1600" b="1" dirty="0">
+                          <a:solidFill>
+                            <a:srgbClr val="B33A1E"/>
+                          </a:solidFill>
+                        </a:rPr>
+                        <a:t>−11</a:t>
+                      </a:r>
+                      <a:endParaRPr lang="en-US" sz="1600" dirty="0"/>
+                    </a:p>
+                  </a:txBody>
+                  <a:tcPr marL="54864" marR="54864" marT="54864" marB="54864" anchor="ctr">
+                    <a:lnL w="0" cap="flat" cmpd="sng" algn="ctr">
+                      <a:noFill/>
+                    </a:lnL>
+                    <a:lnR w="0" cap="flat" cmpd="sng" algn="ctr">
+                      <a:noFill/>
+                    </a:lnR>
+                    <a:lnT w="0" cap="flat" cmpd="sng" algn="ctr">
+                      <a:noFill/>
+                    </a:lnT>
+                    <a:lnB w="0" cap="flat" cmpd="sng" algn="ctr">
+                      <a:noFill/>
+                    </a:lnB>
+                  </a:tcPr>
+                </a:tc>
+                <a:tc>
+                  <a:txBody>
+                    <a:bodyPr/>
+                    <a:lstStyle/>
+                    <a:p>
+                      <a:pPr algn="ctr" indent="0" marL="0">
+                        <a:buNone/>
+                      </a:pPr>
+                      <a:r>
+                        <a:rPr lang="en-US" sz="1600" dirty="0">
+                          <a:solidFill>
+                            <a:srgbClr val="555555"/>
+                          </a:solidFill>
+                        </a:rPr>
+                        <a:t>×</a:t>
+                      </a:r>
+                      <a:endParaRPr lang="en-US" sz="1600" dirty="0"/>
+                    </a:p>
+                  </a:txBody>
+                  <a:tcPr marL="36576" marR="36576" marT="36576" marB="36576" anchor="ctr">
+                    <a:lnL w="0" cap="flat" cmpd="sng" algn="ctr">
+                      <a:noFill/>
+                    </a:lnL>
+                    <a:lnR w="0" cap="flat" cmpd="sng" algn="ctr">
+                      <a:noFill/>
+                    </a:lnR>
+                    <a:lnT w="0" cap="flat" cmpd="sng" algn="ctr">
+                      <a:noFill/>
+                    </a:lnT>
+                    <a:lnB w="0" cap="flat" cmpd="sng" algn="ctr">
+                      <a:noFill/>
+                    </a:lnB>
+                  </a:tcPr>
+                </a:tc>
+                <a:tc>
+                  <a:txBody>
+                    <a:bodyPr/>
+                    <a:lstStyle/>
+                    <a:p>
+                      <a:pPr algn="l" indent="0" marL="0">
+                        <a:buNone/>
+                      </a:pPr>
+                      <a:r>
+                        <a:rPr lang="en-US" sz="1600" dirty="0">
+                          <a:solidFill>
+                            <a:srgbClr val="1A1A1A"/>
+                          </a:solidFill>
+                        </a:rPr>
+                        <a:t>manual edits the IDE could refactor</a:t>
+                      </a:r>
+                      <a:endParaRPr lang="en-US" sz="1600" dirty="0"/>
+                    </a:p>
+                  </a:txBody>
+                  <a:tcPr marL="54864" marR="54864" marT="54864" marB="54864" anchor="ctr">
+                    <a:lnL w="0" cap="flat" cmpd="sng" algn="ctr">
+                      <a:noFill/>
+                    </a:lnL>
+                    <a:lnR w="0" cap="flat" cmpd="sng" algn="ctr">
+                      <a:noFill/>
+                    </a:lnR>
+                    <a:lnT w="0" cap="flat" cmpd="sng" algn="ctr">
+                      <a:noFill/>
+                    </a:lnT>
+                    <a:lnB w="0" cap="flat" cmpd="sng" algn="ctr">
+                      <a:noFill/>
+                    </a:lnB>
+                  </a:tcPr>
+                </a:tc>
+              </a:tr>
+              <a:tr h="310896">
+                <a:tc>
+                  <a:txBody>
+                    <a:bodyPr/>
+                    <a:lstStyle/>
+                    <a:p>
+                      <a:pPr algn="r" indent="0" marL="0">
+                        <a:buNone/>
+                      </a:pPr>
+                      <a:r>
+                        <a:rPr lang="en-US" sz="1600" b="1" dirty="0">
+                          <a:solidFill>
+                            <a:srgbClr val="B33A1E"/>
+                          </a:solidFill>
+                        </a:rPr>
+                        <a:t>−11</a:t>
+                      </a:r>
+                      <a:endParaRPr lang="en-US" sz="1600" dirty="0"/>
+                    </a:p>
+                  </a:txBody>
+                  <a:tcPr marL="54864" marR="54864" marT="54864" marB="54864" anchor="ctr">
+                    <a:lnL w="0" cap="flat" cmpd="sng" algn="ctr">
+                      <a:noFill/>
+                    </a:lnL>
+                    <a:lnR w="0" cap="flat" cmpd="sng" algn="ctr">
+                      <a:noFill/>
+                    </a:lnR>
+                    <a:lnT w="0" cap="flat" cmpd="sng" algn="ctr">
+                      <a:noFill/>
+                    </a:lnT>
+                    <a:lnB w="0" cap="flat" cmpd="sng" algn="ctr">
+                      <a:noFill/>
+                    </a:lnB>
+                  </a:tcPr>
+                </a:tc>
+                <a:tc>
+                  <a:txBody>
+                    <a:bodyPr/>
+                    <a:lstStyle/>
+                    <a:p>
+                      <a:pPr algn="ctr" indent="0" marL="0">
+                        <a:buNone/>
+                      </a:pPr>
+                      <a:r>
+                        <a:rPr lang="en-US" sz="1600" dirty="0">
+                          <a:solidFill>
+                            <a:srgbClr val="555555"/>
+                          </a:solidFill>
+                        </a:rPr>
+                        <a:t>×</a:t>
+                      </a:r>
+                      <a:endParaRPr lang="en-US" sz="1600" dirty="0"/>
+                    </a:p>
+                  </a:txBody>
+                  <a:tcPr marL="36576" marR="36576" marT="36576" marB="36576" anchor="ctr">
+                    <a:lnL w="0" cap="flat" cmpd="sng" algn="ctr">
+                      <a:noFill/>
+                    </a:lnL>
+                    <a:lnR w="0" cap="flat" cmpd="sng" algn="ctr">
+                      <a:noFill/>
+                    </a:lnR>
+                    <a:lnT w="0" cap="flat" cmpd="sng" algn="ctr">
+                      <a:noFill/>
+                    </a:lnT>
+                    <a:lnB w="0" cap="flat" cmpd="sng" algn="ctr">
+                      <a:noFill/>
+                    </a:lnB>
+                  </a:tcPr>
+                </a:tc>
+                <a:tc>
+                  <a:txBody>
+                    <a:bodyPr/>
+                    <a:lstStyle/>
+                    <a:p>
+                      <a:pPr algn="l" indent="0" marL="0">
+                        <a:buNone/>
+                      </a:pPr>
+                      <a:r>
+                        <a:rPr lang="en-US" sz="1600" dirty="0">
+                          <a:solidFill>
+                            <a:srgbClr val="1A1A1A"/>
+                          </a:solidFill>
+                        </a:rPr>
+                        <a:t>intermediate-state lag</a:t>
+                      </a:r>
+                      <a:endParaRPr lang="en-US" sz="1600" dirty="0"/>
+                    </a:p>
+                  </a:txBody>
+                  <a:tcPr marL="54864" marR="54864" marT="54864" marB="54864" anchor="ctr">
+                    <a:lnL w="0" cap="flat" cmpd="sng" algn="ctr">
+                      <a:noFill/>
+                    </a:lnL>
+                    <a:lnR w="0" cap="flat" cmpd="sng" algn="ctr">
+                      <a:noFill/>
+                    </a:lnR>
+                    <a:lnT w="0" cap="flat" cmpd="sng" algn="ctr">
+                      <a:noFill/>
+                    </a:lnT>
+                    <a:lnB w="0" cap="flat" cmpd="sng" algn="ctr">
+                      <a:noFill/>
+                    </a:lnB>
+                  </a:tcPr>
+                </a:tc>
+              </a:tr>
+              <a:tr h="310896">
+                <a:tc>
+                  <a:txBody>
+                    <a:bodyPr/>
+                    <a:lstStyle/>
+                    <a:p>
+                      <a:pPr algn="r" indent="0" marL="0">
+                        <a:buNone/>
+                      </a:pPr>
+                      <a:r>
+                        <a:rPr lang="en-US" sz="1600" b="1" dirty="0">
+                          <a:solidFill>
+                            <a:srgbClr val="B33A1E"/>
+                          </a:solidFill>
+                        </a:rPr>
+                        <a:t>−7</a:t>
+                      </a:r>
+                      <a:endParaRPr lang="en-US" sz="1600" dirty="0"/>
+                    </a:p>
+                  </a:txBody>
+                  <a:tcPr marL="54864" marR="54864" marT="54864" marB="54864" anchor="ctr">
+                    <a:lnL w="0" cap="flat" cmpd="sng" algn="ctr">
+                      <a:noFill/>
+                    </a:lnL>
+                    <a:lnR w="0" cap="flat" cmpd="sng" algn="ctr">
+                      <a:noFill/>
+                    </a:lnR>
+                    <a:lnT w="0" cap="flat" cmpd="sng" algn="ctr">
+                      <a:noFill/>
+                    </a:lnT>
+                    <a:lnB w="0" cap="flat" cmpd="sng" algn="ctr">
+                      <a:noFill/>
+                    </a:lnB>
+                  </a:tcPr>
+                </a:tc>
+                <a:tc>
+                  <a:txBody>
+                    <a:bodyPr/>
+                    <a:lstStyle/>
+                    <a:p>
+                      <a:pPr algn="ctr" indent="0" marL="0">
+                        <a:buNone/>
+                      </a:pPr>
+                      <a:r>
+                        <a:rPr lang="en-US" sz="1600" dirty="0">
+                          <a:solidFill>
+                            <a:srgbClr val="555555"/>
+                          </a:solidFill>
+                        </a:rPr>
+                        <a:t>×</a:t>
+                      </a:r>
+                      <a:endParaRPr lang="en-US" sz="1600" dirty="0"/>
+                    </a:p>
+                  </a:txBody>
+                  <a:tcPr marL="36576" marR="36576" marT="36576" marB="36576" anchor="ctr">
+                    <a:lnL w="0" cap="flat" cmpd="sng" algn="ctr">
+                      <a:noFill/>
+                    </a:lnL>
+                    <a:lnR w="0" cap="flat" cmpd="sng" algn="ctr">
+                      <a:noFill/>
+                    </a:lnR>
+                    <a:lnT w="0" cap="flat" cmpd="sng" algn="ctr">
+                      <a:noFill/>
+                    </a:lnT>
+                    <a:lnB w="0" cap="flat" cmpd="sng" algn="ctr">
+                      <a:noFill/>
+                    </a:lnB>
+                  </a:tcPr>
+                </a:tc>
+                <a:tc>
+                  <a:txBody>
+                    <a:bodyPr/>
+                    <a:lstStyle/>
+                    <a:p>
+                      <a:pPr algn="l" indent="0" marL="0">
+                        <a:buNone/>
+                      </a:pPr>
+                      <a:r>
+                        <a:rPr lang="en-US" sz="1600" dirty="0">
+                          <a:solidFill>
+                            <a:srgbClr val="1A1A1A"/>
+                          </a:solidFill>
+                        </a:rPr>
+                        <a:t>commit-gap events</a:t>
+                      </a:r>
+                      <a:endParaRPr lang="en-US" sz="1600" dirty="0"/>
+                    </a:p>
+                  </a:txBody>
+                  <a:tcPr marL="54864" marR="54864" marT="54864" marB="54864" anchor="ctr">
+                    <a:lnL w="0" cap="flat" cmpd="sng" algn="ctr">
+                      <a:noFill/>
+                    </a:lnL>
+                    <a:lnR w="0" cap="flat" cmpd="sng" algn="ctr">
+                      <a:noFill/>
+                    </a:lnR>
+                    <a:lnT w="0" cap="flat" cmpd="sng" algn="ctr">
+                      <a:noFill/>
+                    </a:lnT>
+                    <a:lnB w="0" cap="flat" cmpd="sng" algn="ctr">
+                      <a:noFill/>
+                    </a:lnB>
+                  </a:tcPr>
+                </a:tc>
+              </a:tr>
+            </a:tbl>
+          </a:graphicData>
+        </a:graphic>
+      </p:graphicFrame>
+      <p:sp>
+        <p:nvSpPr>
+          <p:cNvPr id="5" name="Text 2"/>
+          <p:cNvSpPr/>
+          <p:nvPr/>
+        </p:nvSpPr>
+        <p:spPr>
+          <a:xfrm>
+            <a:off x="457200" y="4160520"/>
+            <a:ext cx="8229600" cy="457200"/>
+          </a:xfrm>
+          <a:prstGeom prst="rect">
+            <a:avLst/>
+          </a:prstGeom>
+          <a:noFill/>
+          <a:ln/>
+        </p:spPr>
+        <p:txBody>
+          <a:bodyPr wrap="square" lIns="0" tIns="0" rIns="0" bIns="0" rtlCol="0" anchor="ctr"/>
+          <a:lstStyle/>
+          <a:p>
+            <a:pPr algn="ctr" indent="0" marL="0">
+              <a:buNone/>
+            </a:pPr>
+            <a:r>
+              <a:rPr lang="en-US" sz="2200" dirty="0">
+                <a:solidFill>
+                  <a:srgbClr val="000000"/>
+                </a:solidFill>
+              </a:rPr>
+              <a:t>)</a:t>
+            </a:r>
+            <a:endParaRPr lang="en-US" sz="2200" dirty="0"/>
           </a:p>
         </p:txBody>
       </p:sp>
@@ -6140,7 +7973,7 @@
                   <a:srgbClr val="000000"/>
                 </a:solidFill>
               </a:rPr>
-              <a:t>Ordering: detect + synthesise</a:t>
+              <a:t>The cleanliness sub-score</a:t>
             </a:r>
             <a:endParaRPr lang="en-US" sz="2800" dirty="0"/>
           </a:p>
@@ -6180,7 +8013,7 @@
                   <a:srgbClr val="000000"/>
                 </a:solidFill>
               </a:rPr>
-              <a:t>What: the right refactorings, performed in a suboptimal order — final state is fine, intermediate states are worse than they needed to be.</a:t>
+              <a:t>Six equally-weighted code-quality signals.</a:t>
             </a:r>
             <a:endParaRPr lang="en-US" sz="1600" dirty="0"/>
           </a:p>
@@ -6198,7 +8031,7 @@
                   <a:srgbClr val="000000"/>
                 </a:solidFill>
               </a:rPr>
-              <a:t>Detect: find a subsequence of refactorings whose reordering still validates to the user's terminal state (canonical AST hash, formatting/comments ignored).</a:t>
+              <a:t>Cognitive complexity, coupling (CBO), duplication (CPD), readability, code smells (PMD), cohesion (TCC).</a:t>
             </a:r>
             <a:endParaRPr lang="en-US" sz="1600" dirty="0"/>
           </a:p>
@@ -6216,7 +8049,7 @@
                   <a:srgbClr val="000000"/>
                 </a:solidFill>
               </a:rPr>
-              <a:t>Synthesise: build a dependency DAG over the refactorings in the window.</a:t>
+              <a:t>Normalised against the trajectory's own range, so different sessions are comparable.</a:t>
             </a:r>
             <a:endParaRPr lang="en-US" sz="1600" dirty="0"/>
           </a:p>
@@ -6234,25 +8067,7 @@
                   <a:srgbClr val="000000"/>
                 </a:solidFill>
               </a:rPr>
-              <a:t>Prefix-trie DFS over valid topological orderings — shares work across common prefixes, rolls back with git checkout on backtrack.</a:t>
-            </a:r>
-            <a:endParaRPr lang="en-US" sz="1600" dirty="0"/>
-          </a:p>
-          <a:p>
-            <a:pPr marL="342900" indent="-342900">
-              <a:spcAft>
-                <a:spcPts val="600"/>
-              </a:spcAft>
-              <a:buSzPct val="100000"/>
-              <a:buChar char="•"/>
-            </a:pPr>
-            <a:r>
-              <a:rPr lang="en-US" sz="1600" dirty="0">
-                <a:solidFill>
-                  <a:srgbClr val="000000"/>
-                </a:solidFill>
-              </a:rPr>
-              <a:t>[FIGURE: methodology-reorder-trie — to be placed here]</a:t>
+              <a:t>Equal weights are justified: no trajectory-level calibration data exists, so equal weights are the least-assumptive choice.</a:t>
             </a:r>
             <a:endParaRPr lang="en-US" sz="1600" dirty="0"/>
           </a:p>

</xml_diff>

<commit_message>
feat: more slide changes
</commit_message>
<xml_diff>
--- a/presentation/slides.pptx
+++ b/presentation/slides.pptx
@@ -24,12 +24,9 @@
     <p:sldId id="272" r:id="rId18"/>
     <p:sldId id="273" r:id="rId19"/>
     <p:sldId id="274" r:id="rId20"/>
-    <p:sldId id="275" r:id="rId21"/>
-    <p:sldId id="276" r:id="rId22"/>
-    <p:sldId id="277" r:id="rId23"/>
   </p:sldIdLst>
   <p:notesMasterIdLst>
-    <p:notesMasterId r:id="rId24"/>
+    <p:notesMasterId r:id="rId21"/>
   </p:notesMasterIdLst>
   <p:sldSz cx="9144000" cy="5143500"/>
   <p:notesSz cx="5143500" cy="9144000"/>
@@ -1515,270 +1512,6 @@
             <a:fld id="{F7021451-1387-4CA6-816F-3879F97B5CBC}" type="slidenum">
               <a:rPr lang="en-US"/>
               <a:t>2</a:t>
-            </a:fld>
-            <a:endParaRPr lang="en-US"/>
-          </a:p>
-        </p:txBody>
-      </p:sp>
-    </p:spTree>
-    <p:extLst>
-      <p:ext uri="{BB962C8B-B14F-4D97-AF65-F5344CB8AC3E}">
-        <p14:creationId xmlns:p14="http://schemas.microsoft.com/office/powerpoint/2010/main" val="1024086991"/>
-      </p:ext>
-    </p:extLst>
-  </p:cSld>
-  <p:clrMapOvr>
-    <a:masterClrMapping/>
-  </p:clrMapOvr>
-</p:notes>
-</file>
-
-<file path=ppt/notesSlides/notesSlide20.xml><?xml version="1.0" encoding="utf-8"?>
-<p:notes xmlns:a="http://schemas.openxmlformats.org/drawingml/2006/main" xmlns:r="http://schemas.openxmlformats.org/officeDocument/2006/relationships" xmlns:p="http://schemas.openxmlformats.org/presentationml/2006/main">
-  <p:cSld>
-    <p:spTree>
-      <p:nvGrpSpPr>
-        <p:cNvPr id="1" name=""/>
-        <p:cNvGrpSpPr/>
-        <p:nvPr/>
-      </p:nvGrpSpPr>
-      <p:grpSpPr>
-        <a:xfrm>
-          <a:off x="0" y="0"/>
-          <a:ext cx="0" cy="0"/>
-          <a:chOff x="0" y="0"/>
-          <a:chExt cx="0" cy="0"/>
-        </a:xfrm>
-      </p:grpSpPr>
-      <p:sp>
-        <p:nvSpPr>
-          <p:cNvPr id="2" name="Slide Image Placeholder 1"/>
-          <p:cNvSpPr>
-            <a:spLocks noGrp="1" noRot="1" noChangeAspect="1"/>
-          </p:cNvSpPr>
-          <p:nvPr>
-            <p:ph type="sldImg"/>
-          </p:nvPr>
-        </p:nvSpPr>
-        <p:spPr/>
-      </p:sp>
-      <p:sp>
-        <p:nvSpPr>
-          <p:cNvPr id="3" name="Notes Placeholder 2"/>
-          <p:cNvSpPr>
-            <a:spLocks noGrp="1"/>
-          </p:cNvSpPr>
-          <p:nvPr>
-            <p:ph type="body" idx="1"/>
-          </p:nvPr>
-        </p:nvSpPr>
-        <p:spPr/>
-        <p:txBody>
-          <a:bodyPr/>
-          <a:lstStyle/>
-          <a:p>
-            <a:r>
-              <a:rPr lang="en-US" dirty="0"/>
-              <a:t/>
-            </a:r>
-            <a:endParaRPr lang="en-US" dirty="0"/>
-          </a:p>
-        </p:txBody>
-      </p:sp>
-      <p:sp>
-        <p:nvSpPr>
-          <p:cNvPr id="4" name="Slide Number Placeholder 3"/>
-          <p:cNvSpPr>
-            <a:spLocks noGrp="1"/>
-          </p:cNvSpPr>
-          <p:nvPr>
-            <p:ph type="sldNum" sz="quarter" idx="10"/>
-          </p:nvPr>
-        </p:nvSpPr>
-        <p:spPr/>
-        <p:txBody>
-          <a:bodyPr/>
-          <a:lstStyle/>
-          <a:p>
-            <a:fld id="{F7021451-1387-4CA6-816F-3879F97B5CBC}" type="slidenum">
-              <a:rPr lang="en-US"/>
-              <a:t>20</a:t>
-            </a:fld>
-            <a:endParaRPr lang="en-US"/>
-          </a:p>
-        </p:txBody>
-      </p:sp>
-    </p:spTree>
-    <p:extLst>
-      <p:ext uri="{BB962C8B-B14F-4D97-AF65-F5344CB8AC3E}">
-        <p14:creationId xmlns:p14="http://schemas.microsoft.com/office/powerpoint/2010/main" val="1024086991"/>
-      </p:ext>
-    </p:extLst>
-  </p:cSld>
-  <p:clrMapOvr>
-    <a:masterClrMapping/>
-  </p:clrMapOvr>
-</p:notes>
-</file>
-
-<file path=ppt/notesSlides/notesSlide21.xml><?xml version="1.0" encoding="utf-8"?>
-<p:notes xmlns:a="http://schemas.openxmlformats.org/drawingml/2006/main" xmlns:r="http://schemas.openxmlformats.org/officeDocument/2006/relationships" xmlns:p="http://schemas.openxmlformats.org/presentationml/2006/main">
-  <p:cSld>
-    <p:spTree>
-      <p:nvGrpSpPr>
-        <p:cNvPr id="1" name=""/>
-        <p:cNvGrpSpPr/>
-        <p:nvPr/>
-      </p:nvGrpSpPr>
-      <p:grpSpPr>
-        <a:xfrm>
-          <a:off x="0" y="0"/>
-          <a:ext cx="0" cy="0"/>
-          <a:chOff x="0" y="0"/>
-          <a:chExt cx="0" cy="0"/>
-        </a:xfrm>
-      </p:grpSpPr>
-      <p:sp>
-        <p:nvSpPr>
-          <p:cNvPr id="2" name="Slide Image Placeholder 1"/>
-          <p:cNvSpPr>
-            <a:spLocks noGrp="1" noRot="1" noChangeAspect="1"/>
-          </p:cNvSpPr>
-          <p:nvPr>
-            <p:ph type="sldImg"/>
-          </p:nvPr>
-        </p:nvSpPr>
-        <p:spPr/>
-      </p:sp>
-      <p:sp>
-        <p:nvSpPr>
-          <p:cNvPr id="3" name="Notes Placeholder 2"/>
-          <p:cNvSpPr>
-            <a:spLocks noGrp="1"/>
-          </p:cNvSpPr>
-          <p:nvPr>
-            <p:ph type="body" idx="1"/>
-          </p:nvPr>
-        </p:nvSpPr>
-        <p:spPr/>
-        <p:txBody>
-          <a:bodyPr/>
-          <a:lstStyle/>
-          <a:p>
-            <a:r>
-              <a:rPr lang="en-US" dirty="0"/>
-              <a:t/>
-            </a:r>
-            <a:endParaRPr lang="en-US" dirty="0"/>
-          </a:p>
-        </p:txBody>
-      </p:sp>
-      <p:sp>
-        <p:nvSpPr>
-          <p:cNvPr id="4" name="Slide Number Placeholder 3"/>
-          <p:cNvSpPr>
-            <a:spLocks noGrp="1"/>
-          </p:cNvSpPr>
-          <p:nvPr>
-            <p:ph type="sldNum" sz="quarter" idx="10"/>
-          </p:nvPr>
-        </p:nvSpPr>
-        <p:spPr/>
-        <p:txBody>
-          <a:bodyPr/>
-          <a:lstStyle/>
-          <a:p>
-            <a:fld id="{F7021451-1387-4CA6-816F-3879F97B5CBC}" type="slidenum">
-              <a:rPr lang="en-US"/>
-              <a:t>21</a:t>
-            </a:fld>
-            <a:endParaRPr lang="en-US"/>
-          </a:p>
-        </p:txBody>
-      </p:sp>
-    </p:spTree>
-    <p:extLst>
-      <p:ext uri="{BB962C8B-B14F-4D97-AF65-F5344CB8AC3E}">
-        <p14:creationId xmlns:p14="http://schemas.microsoft.com/office/powerpoint/2010/main" val="1024086991"/>
-      </p:ext>
-    </p:extLst>
-  </p:cSld>
-  <p:clrMapOvr>
-    <a:masterClrMapping/>
-  </p:clrMapOvr>
-</p:notes>
-</file>
-
-<file path=ppt/notesSlides/notesSlide22.xml><?xml version="1.0" encoding="utf-8"?>
-<p:notes xmlns:a="http://schemas.openxmlformats.org/drawingml/2006/main" xmlns:r="http://schemas.openxmlformats.org/officeDocument/2006/relationships" xmlns:p="http://schemas.openxmlformats.org/presentationml/2006/main">
-  <p:cSld>
-    <p:spTree>
-      <p:nvGrpSpPr>
-        <p:cNvPr id="1" name=""/>
-        <p:cNvGrpSpPr/>
-        <p:nvPr/>
-      </p:nvGrpSpPr>
-      <p:grpSpPr>
-        <a:xfrm>
-          <a:off x="0" y="0"/>
-          <a:ext cx="0" cy="0"/>
-          <a:chOff x="0" y="0"/>
-          <a:chExt cx="0" cy="0"/>
-        </a:xfrm>
-      </p:grpSpPr>
-      <p:sp>
-        <p:nvSpPr>
-          <p:cNvPr id="2" name="Slide Image Placeholder 1"/>
-          <p:cNvSpPr>
-            <a:spLocks noGrp="1" noRot="1" noChangeAspect="1"/>
-          </p:cNvSpPr>
-          <p:nvPr>
-            <p:ph type="sldImg"/>
-          </p:nvPr>
-        </p:nvSpPr>
-        <p:spPr/>
-      </p:sp>
-      <p:sp>
-        <p:nvSpPr>
-          <p:cNvPr id="3" name="Notes Placeholder 2"/>
-          <p:cNvSpPr>
-            <a:spLocks noGrp="1"/>
-          </p:cNvSpPr>
-          <p:nvPr>
-            <p:ph type="body" idx="1"/>
-          </p:nvPr>
-        </p:nvSpPr>
-        <p:spPr/>
-        <p:txBody>
-          <a:bodyPr/>
-          <a:lstStyle/>
-          <a:p>
-            <a:r>
-              <a:rPr lang="en-US" dirty="0"/>
-              <a:t/>
-            </a:r>
-            <a:endParaRPr lang="en-US" dirty="0"/>
-          </a:p>
-        </p:txBody>
-      </p:sp>
-      <p:sp>
-        <p:nvSpPr>
-          <p:cNvPr id="4" name="Slide Number Placeholder 3"/>
-          <p:cNvSpPr>
-            <a:spLocks noGrp="1"/>
-          </p:cNvSpPr>
-          <p:nvPr>
-            <p:ph type="sldNum" sz="quarter" idx="10"/>
-          </p:nvPr>
-        </p:nvSpPr>
-        <p:spPr/>
-        <p:txBody>
-          <a:bodyPr/>
-          <a:lstStyle/>
-          <a:p>
-            <a:fld id="{F7021451-1387-4CA6-816F-3879F97B5CBC}" type="slidenum">
-              <a:rPr lang="en-US"/>
-              <a:t>22</a:t>
             </a:fld>
             <a:endParaRPr lang="en-US"/>
           </a:p>
@@ -2950,197 +2683,6 @@
                   <a:srgbClr val="000000"/>
                 </a:solidFill>
               </a:rPr>
-              <a:t>Four kinds of divergence</a:t>
-            </a:r>
-            <a:endParaRPr lang="en-US" sz="2800" dirty="0"/>
-          </a:p>
-        </p:txBody>
-      </p:sp>
-      <p:sp>
-        <p:nvSpPr>
-          <p:cNvPr id="3" name="Text 1"/>
-          <p:cNvSpPr/>
-          <p:nvPr/>
-        </p:nvSpPr>
-        <p:spPr>
-          <a:xfrm>
-            <a:off x="457200" y="1188720"/>
-            <a:ext cx="8229600" cy="3657600"/>
-          </a:xfrm>
-          <a:prstGeom prst="rect">
-            <a:avLst/>
-          </a:prstGeom>
-          <a:noFill/>
-          <a:ln/>
-        </p:spPr>
-        <p:txBody>
-          <a:bodyPr wrap="square" rtlCol="0" anchor="t"/>
-          <a:lstStyle/>
-          <a:p>
-            <a:pPr marL="342900" indent="-342900">
-              <a:spcAft>
-                <a:spcPts val="600"/>
-              </a:spcAft>
-              <a:buSzPct val="100000"/>
-              <a:buChar char="•"/>
-            </a:pPr>
-            <a:r>
-              <a:rPr lang="en-US" sz="1600" dirty="0">
-                <a:solidFill>
-                  <a:srgbClr val="000000"/>
-                </a:solidFill>
-              </a:rPr>
-              <a:t>Four categories of process waste - each fitting the four requirements: detectable from the event stream, actionable for the developer, synthesisable as a concrete alternative.</a:t>
-            </a:r>
-            <a:endParaRPr lang="en-US" sz="1600" dirty="0"/>
-          </a:p>
-          <a:p>
-            <a:pPr marL="342900" indent="-342900">
-              <a:spcAft>
-                <a:spcPts val="600"/>
-              </a:spcAft>
-              <a:buSzPct val="100000"/>
-              <a:buChar char="•"/>
-            </a:pPr>
-            <a:r>
-              <a:rPr lang="en-US" sz="1600" dirty="0">
-                <a:solidFill>
-                  <a:srgbClr val="000000"/>
-                </a:solidFill>
-              </a:rPr>
-              <a:t>Ordering - right refactorings, wrong sequence.</a:t>
-            </a:r>
-            <a:endParaRPr lang="en-US" sz="1600" dirty="0"/>
-          </a:p>
-          <a:p>
-            <a:pPr marL="342900" indent="-342900">
-              <a:spcAft>
-                <a:spcPts val="600"/>
-              </a:spcAft>
-              <a:buSzPct val="100000"/>
-              <a:buChar char="•"/>
-            </a:pPr>
-            <a:r>
-              <a:rPr lang="en-US" sz="1600" dirty="0">
-                <a:solidFill>
-                  <a:srgbClr val="000000"/>
-                </a:solidFill>
-              </a:rPr>
-              <a:t>Manual-Refactor - wrong tool (hand-edit when the IDE could safely have done it).</a:t>
-            </a:r>
-            <a:endParaRPr lang="en-US" sz="1600" dirty="0"/>
-          </a:p>
-          <a:p>
-            <a:pPr marL="342900" indent="-342900">
-              <a:spcAft>
-                <a:spcPts val="600"/>
-              </a:spcAft>
-              <a:buSzPct val="100000"/>
-              <a:buChar char="•"/>
-            </a:pPr>
-            <a:r>
-              <a:rPr lang="en-US" sz="1600" dirty="0">
-                <a:solidFill>
-                  <a:srgbClr val="000000"/>
-                </a:solidFill>
-              </a:rPr>
-              <a:t>Rework - wrong churn (added then removed).</a:t>
-            </a:r>
-            <a:endParaRPr lang="en-US" sz="1600" dirty="0"/>
-          </a:p>
-          <a:p>
-            <a:pPr marL="342900" indent="-342900">
-              <a:spcAft>
-                <a:spcPts val="600"/>
-              </a:spcAft>
-              <a:buSzPct val="100000"/>
-              <a:buChar char="•"/>
-            </a:pPr>
-            <a:r>
-              <a:rPr lang="en-US" sz="1600" dirty="0">
-                <a:solidFill>
-                  <a:srgbClr val="000000"/>
-                </a:solidFill>
-              </a:rPr>
-              <a:t>Hygiene - missing safety checkpoints (no tests, no commits).</a:t>
-            </a:r>
-            <a:endParaRPr lang="en-US" sz="1600" dirty="0"/>
-          </a:p>
-          <a:p>
-            <a:pPr marL="342900" indent="-342900">
-              <a:spcAft>
-                <a:spcPts val="600"/>
-              </a:spcAft>
-              <a:buSzPct val="100000"/>
-              <a:buChar char="•"/>
-            </a:pPr>
-            <a:r>
-              <a:rPr lang="en-US" sz="1600" dirty="0">
-                <a:solidFill>
-                  <a:srgbClr val="000000"/>
-                </a:solidFill>
-              </a:rPr>
-              <a:t>Each kind gets its own slide next, covering both detection and synthesis.</a:t>
-            </a:r>
-            <a:endParaRPr lang="en-US" sz="1600" dirty="0"/>
-          </a:p>
-        </p:txBody>
-      </p:sp>
-    </p:spTree>
-  </p:cSld>
-  <p:clrMapOvr>
-    <a:masterClrMapping/>
-  </p:clrMapOvr>
-</p:sld>
-</file>
-
-<file path=ppt/slides/slide11.xml><?xml version="1.0" encoding="utf-8"?>
-<p:sld xmlns:a="http://schemas.openxmlformats.org/drawingml/2006/main" xmlns:r="http://schemas.openxmlformats.org/officeDocument/2006/relationships" xmlns:p="http://schemas.openxmlformats.org/presentationml/2006/main">
-  <p:cSld name="Slide 11">
-    <p:spTree>
-      <p:nvGrpSpPr>
-        <p:cNvPr id="1" name=""/>
-        <p:cNvGrpSpPr/>
-        <p:nvPr/>
-      </p:nvGrpSpPr>
-      <p:grpSpPr>
-        <a:xfrm>
-          <a:off x="0" y="0"/>
-          <a:ext cx="0" cy="0"/>
-          <a:chOff x="0" y="0"/>
-          <a:chExt cx="0" cy="0"/>
-        </a:xfrm>
-      </p:grpSpPr>
-      <p:sp>
-        <p:nvSpPr>
-          <p:cNvPr id="2" name="Text 0"/>
-          <p:cNvSpPr/>
-          <p:nvPr/>
-        </p:nvSpPr>
-        <p:spPr>
-          <a:xfrm>
-            <a:off x="457200" y="274320"/>
-            <a:ext cx="8229600" cy="640080"/>
-          </a:xfrm>
-          <a:prstGeom prst="rect">
-            <a:avLst/>
-          </a:prstGeom>
-          <a:noFill/>
-          <a:ln/>
-        </p:spPr>
-        <p:txBody>
-          <a:bodyPr wrap="square" lIns="0" tIns="0" rIns="0" bIns="0" rtlCol="0" anchor="ctr"/>
-          <a:lstStyle/>
-          <a:p>
-            <a:pPr indent="0" marL="0">
-              <a:buNone/>
-            </a:pPr>
-            <a:r>
-              <a:rPr lang="en-US" sz="2800" b="1" dirty="0">
-                <a:solidFill>
-                  <a:srgbClr val="000000"/>
-                </a:solidFill>
-              </a:rPr>
               <a:t>Ordering: detect + synthesise</a:t>
             </a:r>
             <a:endParaRPr lang="en-US" sz="2800" dirty="0"/>
@@ -3273,9 +2815,9 @@
 </p:sld>
 </file>
 
-<file path=ppt/slides/slide12.xml><?xml version="1.0" encoding="utf-8"?>
+<file path=ppt/slides/slide11.xml><?xml version="1.0" encoding="utf-8"?>
 <p:sld xmlns:a="http://schemas.openxmlformats.org/drawingml/2006/main" xmlns:r="http://schemas.openxmlformats.org/officeDocument/2006/relationships" xmlns:p="http://schemas.openxmlformats.org/presentationml/2006/main">
-  <p:cSld name="Slide 12">
+  <p:cSld name="Slide 11">
     <p:spTree>
       <p:nvGrpSpPr>
         <p:cNvPr id="1" name=""/>
@@ -3452,9 +2994,9 @@
 </p:sld>
 </file>
 
-<file path=ppt/slides/slide13.xml><?xml version="1.0" encoding="utf-8"?>
+<file path=ppt/slides/slide12.xml><?xml version="1.0" encoding="utf-8"?>
 <p:sld xmlns:a="http://schemas.openxmlformats.org/drawingml/2006/main" xmlns:r="http://schemas.openxmlformats.org/officeDocument/2006/relationships" xmlns:p="http://schemas.openxmlformats.org/presentationml/2006/main">
-  <p:cSld name="Slide 13">
+  <p:cSld name="Slide 12">
     <p:spTree>
       <p:nvGrpSpPr>
         <p:cNvPr id="1" name=""/>
@@ -3631,8 +3173,181 @@
 </p:sld>
 </file>
 
+<file path=ppt/slides/slide13.xml><?xml version="1.0" encoding="utf-8"?>
+<p:sld xmlns:a="http://schemas.openxmlformats.org/drawingml/2006/main" xmlns:r="http://schemas.openxmlformats.org/officeDocument/2006/relationships" xmlns:p="http://schemas.openxmlformats.org/presentationml/2006/main">
+  <p:cSld name="Slide 13">
+    <p:spTree>
+      <p:nvGrpSpPr>
+        <p:cNvPr id="1" name=""/>
+        <p:cNvGrpSpPr/>
+        <p:nvPr/>
+      </p:nvGrpSpPr>
+      <p:grpSpPr>
+        <a:xfrm>
+          <a:off x="0" y="0"/>
+          <a:ext cx="0" cy="0"/>
+          <a:chOff x="0" y="0"/>
+          <a:chExt cx="0" cy="0"/>
+        </a:xfrm>
+      </p:grpSpPr>
+      <p:sp>
+        <p:nvSpPr>
+          <p:cNvPr id="2" name="Text 0"/>
+          <p:cNvSpPr/>
+          <p:nvPr/>
+        </p:nvSpPr>
+        <p:spPr>
+          <a:xfrm>
+            <a:off x="457200" y="274320"/>
+            <a:ext cx="8229600" cy="640080"/>
+          </a:xfrm>
+          <a:prstGeom prst="rect">
+            <a:avLst/>
+          </a:prstGeom>
+          <a:noFill/>
+          <a:ln/>
+        </p:spPr>
+        <p:txBody>
+          <a:bodyPr wrap="square" lIns="0" tIns="0" rIns="0" bIns="0" rtlCol="0" anchor="ctr"/>
+          <a:lstStyle/>
+          <a:p>
+            <a:pPr indent="0" marL="0">
+              <a:buNone/>
+            </a:pPr>
+            <a:r>
+              <a:rPr lang="en-US" sz="2800" b="1" dirty="0">
+                <a:solidFill>
+                  <a:srgbClr val="000000"/>
+                </a:solidFill>
+              </a:rPr>
+              <a:t>Hygiene: detect + synthesise</a:t>
+            </a:r>
+            <a:endParaRPr lang="en-US" sz="2800" dirty="0"/>
+          </a:p>
+        </p:txBody>
+      </p:sp>
+      <p:sp>
+        <p:nvSpPr>
+          <p:cNvPr id="3" name="Text 1"/>
+          <p:cNvSpPr/>
+          <p:nvPr/>
+        </p:nvSpPr>
+        <p:spPr>
+          <a:xfrm>
+            <a:off x="457200" y="1188720"/>
+            <a:ext cx="8229600" cy="3657600"/>
+          </a:xfrm>
+          <a:prstGeom prst="rect">
+            <a:avLst/>
+          </a:prstGeom>
+          <a:noFill/>
+          <a:ln/>
+        </p:spPr>
+        <p:txBody>
+          <a:bodyPr wrap="square" rtlCol="0" anchor="t"/>
+          <a:lstStyle/>
+          <a:p>
+            <a:pPr marL="342900" indent="-342900">
+              <a:spcAft>
+                <a:spcPts val="600"/>
+              </a:spcAft>
+              <a:buSzPct val="100000"/>
+              <a:buChar char="•"/>
+            </a:pPr>
+            <a:r>
+              <a:rPr lang="en-US" sz="1600" dirty="0">
+                <a:solidFill>
+                  <a:srgbClr val="000000"/>
+                </a:solidFill>
+              </a:rPr>
+              <a:t>What: long stretches of work without safety checkpoints - no test runs, no commits.</a:t>
+            </a:r>
+            <a:endParaRPr lang="en-US" sz="1600" dirty="0"/>
+          </a:p>
+          <a:p>
+            <a:pPr marL="342900" indent="-342900">
+              <a:spcAft>
+                <a:spcPts val="600"/>
+              </a:spcAft>
+              <a:buSzPct val="100000"/>
+              <a:buChar char="•"/>
+            </a:pPr>
+            <a:r>
+              <a:rPr lang="en-US" sz="1600" dirty="0">
+                <a:solidFill>
+                  <a:srgbClr val="000000"/>
+                </a:solidFill>
+              </a:rPr>
+              <a:t>Detect: 60-second windows with no test-run events; commit-gap events when commits are spaced beyond threshold.</a:t>
+            </a:r>
+            <a:endParaRPr lang="en-US" sz="1600" dirty="0"/>
+          </a:p>
+          <a:p>
+            <a:pPr marL="342900" indent="-342900">
+              <a:spcAft>
+                <a:spcPts val="600"/>
+              </a:spcAft>
+              <a:buSzPct val="100000"/>
+              <a:buChar char="•"/>
+            </a:pPr>
+            <a:r>
+              <a:rPr lang="en-US" sz="1600" dirty="0">
+                <a:solidFill>
+                  <a:srgbClr val="000000"/>
+                </a:solidFill>
+              </a:rPr>
+              <a:t>Synthesise: model an alternative cadence that inserts test-run and commit events at the right points.</a:t>
+            </a:r>
+            <a:endParaRPr lang="en-US" sz="1600" dirty="0"/>
+          </a:p>
+          <a:p>
+            <a:pPr marL="342900" indent="-342900">
+              <a:spcAft>
+                <a:spcPts val="600"/>
+              </a:spcAft>
+              <a:buSzPct val="100000"/>
+              <a:buChar char="•"/>
+            </a:pPr>
+            <a:r>
+              <a:rPr lang="en-US" sz="1600" dirty="0">
+                <a:solidFill>
+                  <a:srgbClr val="000000"/>
+                </a:solidFill>
+              </a:rPr>
+              <a:t>The alternative's J(τ) credits those checkpoints via the skip-tests and commit-gap terms.</a:t>
+            </a:r>
+            <a:endParaRPr lang="en-US" sz="1600" dirty="0"/>
+          </a:p>
+          <a:p>
+            <a:pPr marL="342900" indent="-342900">
+              <a:spcAft>
+                <a:spcPts val="600"/>
+              </a:spcAft>
+              <a:buSzPct val="100000"/>
+              <a:buChar char="•"/>
+            </a:pPr>
+            <a:r>
+              <a:rPr lang="en-US" sz="1600" dirty="0">
+                <a:solidFill>
+                  <a:srgbClr val="000000"/>
+                </a:solidFill>
+              </a:rPr>
+              <a:t>Cheap to compute, but consistently surfaces meaningful divergences in the user study.</a:t>
+            </a:r>
+            <a:endParaRPr lang="en-US" sz="1600" dirty="0"/>
+          </a:p>
+        </p:txBody>
+      </p:sp>
+    </p:spTree>
+  </p:cSld>
+  <p:clrMapOvr>
+    <a:masterClrMapping/>
+  </p:clrMapOvr>
+</p:sld>
+</file>
+
 <file path=ppt/slides/slide14.xml><?xml version="1.0" encoding="utf-8"?>
-<p:sld xmlns:a="http://schemas.openxmlformats.org/drawingml/2006/main" xmlns:r="http://schemas.openxmlformats.org/officeDocument/2006/relationships" xmlns:p="http://schemas.openxmlformats.org/presentationml/2006/main">
+<p:sld xmlns:a="http://schemas.openxmlformats.org/drawingml/2006/main" xmlns:r="http://schemas.openxmlformats.org/officeDocument/2006/relationships" xmlns:p="http://schemas.openxmlformats.org/presentationml/2006/main" show="0">
   <p:cSld name="Slide 14">
     <p:spTree>
       <p:nvGrpSpPr>
@@ -3678,7 +3393,7 @@
                   <a:srgbClr val="000000"/>
                 </a:solidFill>
               </a:rPr>
-              <a:t>Hygiene: detect + synthesise</a:t>
+              <a:t>Comparable divergence magnitudes</a:t>
             </a:r>
             <a:endParaRPr lang="en-US" sz="2800" dirty="0"/>
           </a:p>
@@ -3718,7 +3433,7 @@
                   <a:srgbClr val="000000"/>
                 </a:solidFill>
               </a:rPr>
-              <a:t>What: long stretches of work without safety checkpoints - no test runs, no commits.</a:t>
+              <a:t>Magnitude = J(τ*_final) − J(τ_final).</a:t>
             </a:r>
             <a:endParaRPr lang="en-US" sz="1600" dirty="0"/>
           </a:p>
@@ -3736,7 +3451,7 @@
                   <a:srgbClr val="000000"/>
                 </a:solidFill>
               </a:rPr>
-              <a:t>Detect: 60-second windows with no test-run events; commit-gap events when commits are spaced beyond threshold.</a:t>
+              <a:t>The score gap when the alternative is substituted at the divergence point but the rest of the user's trajectory is left unchanged.</a:t>
             </a:r>
             <a:endParaRPr lang="en-US" sz="1600" dirty="0"/>
           </a:p>
@@ -3754,7 +3469,7 @@
                   <a:srgbClr val="000000"/>
                 </a:solidFill>
               </a:rPr>
-              <a:t>Synthesise: model an alternative cadence that inserts test-run and commit events at the right points.</a:t>
+              <a:t>Makes magnitudes comparable across all four divergence kinds.</a:t>
             </a:r>
             <a:endParaRPr lang="en-US" sz="1600" dirty="0"/>
           </a:p>
@@ -3772,7 +3487,7 @@
                   <a:srgbClr val="000000"/>
                 </a:solidFill>
               </a:rPr>
-              <a:t>The alternative's J(τ) credits those checkpoints via the skip-tests and commit-gap terms.</a:t>
+              <a:t>Lets the dashboard surface each divergence point alongside its score impact, so the highest-impact moments are easy to spot in the session summary.</a:t>
             </a:r>
             <a:endParaRPr lang="en-US" sz="1600" dirty="0"/>
           </a:p>
@@ -3790,7 +3505,7 @@
                   <a:srgbClr val="000000"/>
                 </a:solidFill>
               </a:rPr>
-              <a:t>Cheap to compute, but consistently surfaces meaningful divergences in the user study.</a:t>
+              <a:t>This is the number the demo will point at.</a:t>
             </a:r>
             <a:endParaRPr lang="en-US" sz="1600" dirty="0"/>
           </a:p>
@@ -3851,276 +3566,6 @@
                   <a:srgbClr val="000000"/>
                 </a:solidFill>
               </a:rPr>
-              <a:t>Comparable divergence magnitudes</a:t>
-            </a:r>
-            <a:endParaRPr lang="en-US" sz="2800" dirty="0"/>
-          </a:p>
-        </p:txBody>
-      </p:sp>
-      <p:sp>
-        <p:nvSpPr>
-          <p:cNvPr id="3" name="Text 1"/>
-          <p:cNvSpPr/>
-          <p:nvPr/>
-        </p:nvSpPr>
-        <p:spPr>
-          <a:xfrm>
-            <a:off x="457200" y="1188720"/>
-            <a:ext cx="8229600" cy="3657600"/>
-          </a:xfrm>
-          <a:prstGeom prst="rect">
-            <a:avLst/>
-          </a:prstGeom>
-          <a:noFill/>
-          <a:ln/>
-        </p:spPr>
-        <p:txBody>
-          <a:bodyPr wrap="square" rtlCol="0" anchor="t"/>
-          <a:lstStyle/>
-          <a:p>
-            <a:pPr marL="342900" indent="-342900">
-              <a:spcAft>
-                <a:spcPts val="600"/>
-              </a:spcAft>
-              <a:buSzPct val="100000"/>
-              <a:buChar char="•"/>
-            </a:pPr>
-            <a:r>
-              <a:rPr lang="en-US" sz="1600" dirty="0">
-                <a:solidFill>
-                  <a:srgbClr val="000000"/>
-                </a:solidFill>
-              </a:rPr>
-              <a:t>Magnitude = J(τ*_final) − J(τ_final).</a:t>
-            </a:r>
-            <a:endParaRPr lang="en-US" sz="1600" dirty="0"/>
-          </a:p>
-          <a:p>
-            <a:pPr marL="342900" indent="-342900">
-              <a:spcAft>
-                <a:spcPts val="600"/>
-              </a:spcAft>
-              <a:buSzPct val="100000"/>
-              <a:buChar char="•"/>
-            </a:pPr>
-            <a:r>
-              <a:rPr lang="en-US" sz="1600" dirty="0">
-                <a:solidFill>
-                  <a:srgbClr val="000000"/>
-                </a:solidFill>
-              </a:rPr>
-              <a:t>The score gap when the alternative is substituted at the divergence point but the rest of the user's trajectory is left unchanged.</a:t>
-            </a:r>
-            <a:endParaRPr lang="en-US" sz="1600" dirty="0"/>
-          </a:p>
-          <a:p>
-            <a:pPr marL="342900" indent="-342900">
-              <a:spcAft>
-                <a:spcPts val="600"/>
-              </a:spcAft>
-              <a:buSzPct val="100000"/>
-              <a:buChar char="•"/>
-            </a:pPr>
-            <a:r>
-              <a:rPr lang="en-US" sz="1600" dirty="0">
-                <a:solidFill>
-                  <a:srgbClr val="000000"/>
-                </a:solidFill>
-              </a:rPr>
-              <a:t>Makes magnitudes comparable across all four divergence kinds.</a:t>
-            </a:r>
-            <a:endParaRPr lang="en-US" sz="1600" dirty="0"/>
-          </a:p>
-          <a:p>
-            <a:pPr marL="342900" indent="-342900">
-              <a:spcAft>
-                <a:spcPts val="600"/>
-              </a:spcAft>
-              <a:buSzPct val="100000"/>
-              <a:buChar char="•"/>
-            </a:pPr>
-            <a:r>
-              <a:rPr lang="en-US" sz="1600" dirty="0">
-                <a:solidFill>
-                  <a:srgbClr val="000000"/>
-                </a:solidFill>
-              </a:rPr>
-              <a:t>Lets the dashboard surface each divergence point alongside its score impact, so the highest-impact moments are easy to spot in the session summary.</a:t>
-            </a:r>
-            <a:endParaRPr lang="en-US" sz="1600" dirty="0"/>
-          </a:p>
-          <a:p>
-            <a:pPr marL="342900" indent="-342900">
-              <a:spcAft>
-                <a:spcPts val="600"/>
-              </a:spcAft>
-              <a:buSzPct val="100000"/>
-              <a:buChar char="•"/>
-            </a:pPr>
-            <a:r>
-              <a:rPr lang="en-US" sz="1600" dirty="0">
-                <a:solidFill>
-                  <a:srgbClr val="000000"/>
-                </a:solidFill>
-              </a:rPr>
-              <a:t>This is the number the demo will point at.</a:t>
-            </a:r>
-            <a:endParaRPr lang="en-US" sz="1600" dirty="0"/>
-          </a:p>
-        </p:txBody>
-      </p:sp>
-    </p:spTree>
-  </p:cSld>
-  <p:clrMapOvr>
-    <a:masterClrMapping/>
-  </p:clrMapOvr>
-</p:sld>
-</file>
-
-<file path=ppt/slides/slide16.xml><?xml version="1.0" encoding="utf-8"?>
-<p:sld xmlns:a="http://schemas.openxmlformats.org/drawingml/2006/main" xmlns:r="http://schemas.openxmlformats.org/officeDocument/2006/relationships" xmlns:p="http://schemas.openxmlformats.org/presentationml/2006/main">
-  <p:cSld name="Slide 16">
-    <p:spTree>
-      <p:nvGrpSpPr>
-        <p:cNvPr id="1" name=""/>
-        <p:cNvGrpSpPr/>
-        <p:nvPr/>
-      </p:nvGrpSpPr>
-      <p:grpSpPr>
-        <a:xfrm>
-          <a:off x="0" y="0"/>
-          <a:ext cx="0" cy="0"/>
-          <a:chOff x="0" y="0"/>
-          <a:chExt cx="0" cy="0"/>
-        </a:xfrm>
-      </p:grpSpPr>
-      <p:sp>
-        <p:nvSpPr>
-          <p:cNvPr id="2" name="Text 0"/>
-          <p:cNvSpPr/>
-          <p:nvPr/>
-        </p:nvSpPr>
-        <p:spPr>
-          <a:xfrm>
-            <a:off x="457200" y="1828800"/>
-            <a:ext cx="8229600" cy="914400"/>
-          </a:xfrm>
-          <a:prstGeom prst="rect">
-            <a:avLst/>
-          </a:prstGeom>
-          <a:noFill/>
-          <a:ln/>
-        </p:spPr>
-        <p:txBody>
-          <a:bodyPr wrap="square" lIns="0" tIns="0" rIns="0" bIns="0" rtlCol="0" anchor="ctr"/>
-          <a:lstStyle/>
-          <a:p>
-            <a:pPr algn="ctr" indent="0" marL="0">
-              <a:buNone/>
-            </a:pPr>
-            <a:r>
-              <a:rPr lang="en-US" sz="4400" b="1" dirty="0">
-                <a:solidFill>
-                  <a:srgbClr val="000000"/>
-                </a:solidFill>
-              </a:rPr>
-              <a:t>Demo (part 2): results</a:t>
-            </a:r>
-            <a:endParaRPr lang="en-US" sz="4400" dirty="0"/>
-          </a:p>
-        </p:txBody>
-      </p:sp>
-      <p:sp>
-        <p:nvSpPr>
-          <p:cNvPr id="3" name="Text 1"/>
-          <p:cNvSpPr/>
-          <p:nvPr/>
-        </p:nvSpPr>
-        <p:spPr>
-          <a:xfrm>
-            <a:off x="457200" y="2834640"/>
-            <a:ext cx="8229600" cy="1097280"/>
-          </a:xfrm>
-          <a:prstGeom prst="rect">
-            <a:avLst/>
-          </a:prstGeom>
-          <a:noFill/>
-          <a:ln/>
-        </p:spPr>
-        <p:txBody>
-          <a:bodyPr wrap="square" rtlCol="0" anchor="ctr"/>
-          <a:lstStyle/>
-          <a:p>
-            <a:pPr algn="ctr" indent="0" marL="0">
-              <a:buNone/>
-            </a:pPr>
-            <a:r>
-              <a:rPr lang="en-US" sz="1800" i="1" dirty="0">
-                <a:solidFill>
-                  <a:srgbClr val="555555"/>
-                </a:solidFill>
-              </a:rPr>
-              <a:t>Now the live session has been analysed: walk through the divergence points the tool found, then show a higher-scoring alternative I prepared earlier.</a:t>
-            </a:r>
-            <a:endParaRPr lang="en-US" sz="1800" dirty="0"/>
-          </a:p>
-        </p:txBody>
-      </p:sp>
-    </p:spTree>
-  </p:cSld>
-  <p:clrMapOvr>
-    <a:masterClrMapping/>
-  </p:clrMapOvr>
-</p:sld>
-</file>
-
-<file path=ppt/slides/slide17.xml><?xml version="1.0" encoding="utf-8"?>
-<p:sld xmlns:a="http://schemas.openxmlformats.org/drawingml/2006/main" xmlns:r="http://schemas.openxmlformats.org/officeDocument/2006/relationships" xmlns:p="http://schemas.openxmlformats.org/presentationml/2006/main">
-  <p:cSld name="Slide 17">
-    <p:spTree>
-      <p:nvGrpSpPr>
-        <p:cNvPr id="1" name=""/>
-        <p:cNvGrpSpPr/>
-        <p:nvPr/>
-      </p:nvGrpSpPr>
-      <p:grpSpPr>
-        <a:xfrm>
-          <a:off x="0" y="0"/>
-          <a:ext cx="0" cy="0"/>
-          <a:chOff x="0" y="0"/>
-          <a:chExt cx="0" cy="0"/>
-        </a:xfrm>
-      </p:grpSpPr>
-      <p:sp>
-        <p:nvSpPr>
-          <p:cNvPr id="2" name="Text 0"/>
-          <p:cNvSpPr/>
-          <p:nvPr/>
-        </p:nvSpPr>
-        <p:spPr>
-          <a:xfrm>
-            <a:off x="457200" y="274320"/>
-            <a:ext cx="8229600" cy="640080"/>
-          </a:xfrm>
-          <a:prstGeom prst="rect">
-            <a:avLst/>
-          </a:prstGeom>
-          <a:noFill/>
-          <a:ln/>
-        </p:spPr>
-        <p:txBody>
-          <a:bodyPr wrap="square" lIns="0" tIns="0" rIns="0" bIns="0" rtlCol="0" anchor="ctr"/>
-          <a:lstStyle/>
-          <a:p>
-            <a:pPr indent="0" marL="0">
-              <a:buNone/>
-            </a:pPr>
-            <a:r>
-              <a:rPr lang="en-US" sz="2800" b="1" dirty="0">
-                <a:solidFill>
-                  <a:srgbClr val="000000"/>
-                </a:solidFill>
-              </a:rPr>
               <a:t>What we wanted to evaluate</a:t>
             </a:r>
             <a:endParaRPr lang="en-US" sz="2800" dirty="0"/>
@@ -4129,7 +3574,7 @@
       </p:sp>
       <p:graphicFrame>
         <p:nvGraphicFramePr>
-          <p:cNvPr id="18" name="Table 0"/>
+          <p:cNvPr id="16" name="Table 0"/>
           <p:cNvGraphicFramePr>
             <a:graphicFrameLocks noGrp="1"/>
           </p:cNvGraphicFramePr>
@@ -4350,7 +3795,7 @@
                             <a:srgbClr val="555555"/>
                           </a:solidFill>
                         </a:rPr>
-                        <a:t>45 labelled injection sessions, scored against per-kind precision and recall (Slide 18).</a:t>
+                        <a:t>45 labelled injection sessions, scored against per-kind precision and recall (Slide 16).</a:t>
                       </a:r>
                       <a:endParaRPr lang="en-US" sz="1300" dirty="0"/>
                     </a:p>
@@ -4468,7 +3913,7 @@
                             <a:srgbClr val="555555"/>
                           </a:solidFill>
                         </a:rPr>
-                        <a:t>Injection set + user-study rankable subset, used for the sensitivity sweep and ablation study (Slide 19).</a:t>
+                        <a:t>Injection set + user-study rankable subset, used for the sensitivity sweep and ablation study (Slide 17).</a:t>
                       </a:r>
                       <a:endParaRPr lang="en-US" sz="1300" dirty="0"/>
                     </a:p>
@@ -4586,7 +4031,7 @@
                             <a:srgbClr val="555555"/>
                           </a:solidFill>
                         </a:rPr>
-                        <a:t>30-session randomised user study, plus a 48-session agent extension as motivation for future work (Slide 20).</a:t>
+                        <a:t>30-session randomised user study, plus a 48-session agent extension as motivation for future work (Slide 18).</a:t>
                       </a:r>
                       <a:endParaRPr lang="en-US" sz="1300" dirty="0"/>
                     </a:p>
@@ -4643,6 +4088,316 @@
 </p:sld>
 </file>
 
+<file path=ppt/slides/slide16.xml><?xml version="1.0" encoding="utf-8"?>
+<p:sld xmlns:a="http://schemas.openxmlformats.org/drawingml/2006/main" xmlns:r="http://schemas.openxmlformats.org/officeDocument/2006/relationships" xmlns:p="http://schemas.openxmlformats.org/presentationml/2006/main">
+  <p:cSld name="Slide 16">
+    <p:spTree>
+      <p:nvGrpSpPr>
+        <p:cNvPr id="1" name=""/>
+        <p:cNvGrpSpPr/>
+        <p:nvPr/>
+      </p:nvGrpSpPr>
+      <p:grpSpPr>
+        <a:xfrm>
+          <a:off x="0" y="0"/>
+          <a:ext cx="0" cy="0"/>
+          <a:chOff x="0" y="0"/>
+          <a:chExt cx="0" cy="0"/>
+        </a:xfrm>
+      </p:grpSpPr>
+      <p:sp>
+        <p:nvSpPr>
+          <p:cNvPr id="2" name="Text 0"/>
+          <p:cNvSpPr/>
+          <p:nvPr/>
+        </p:nvSpPr>
+        <p:spPr>
+          <a:xfrm>
+            <a:off x="457200" y="274320"/>
+            <a:ext cx="8229600" cy="640080"/>
+          </a:xfrm>
+          <a:prstGeom prst="rect">
+            <a:avLst/>
+          </a:prstGeom>
+          <a:noFill/>
+          <a:ln/>
+        </p:spPr>
+        <p:txBody>
+          <a:bodyPr wrap="square" lIns="0" tIns="0" rIns="0" bIns="0" rtlCol="0" anchor="ctr"/>
+          <a:lstStyle/>
+          <a:p>
+            <a:pPr indent="0" marL="0">
+              <a:buNone/>
+            </a:pPr>
+            <a:r>
+              <a:rPr lang="en-US" sz="2800" b="1" dirty="0">
+                <a:solidFill>
+                  <a:srgbClr val="000000"/>
+                </a:solidFill>
+              </a:rPr>
+              <a:t>Detector precision &amp; recall</a:t>
+            </a:r>
+            <a:endParaRPr lang="en-US" sz="2800" dirty="0"/>
+          </a:p>
+        </p:txBody>
+      </p:sp>
+      <p:sp>
+        <p:nvSpPr>
+          <p:cNvPr id="3" name="Text 1"/>
+          <p:cNvSpPr/>
+          <p:nvPr/>
+        </p:nvSpPr>
+        <p:spPr>
+          <a:xfrm>
+            <a:off x="457200" y="1188720"/>
+            <a:ext cx="8229600" cy="3657600"/>
+          </a:xfrm>
+          <a:prstGeom prst="rect">
+            <a:avLst/>
+          </a:prstGeom>
+          <a:noFill/>
+          <a:ln/>
+        </p:spPr>
+        <p:txBody>
+          <a:bodyPr wrap="square" rtlCol="0" anchor="t"/>
+          <a:lstStyle/>
+          <a:p>
+            <a:pPr marL="342900" indent="-342900">
+              <a:spcAft>
+                <a:spcPts val="600"/>
+              </a:spcAft>
+              <a:buSzPct val="100000"/>
+              <a:buChar char="•"/>
+            </a:pPr>
+            <a:r>
+              <a:rPr lang="en-US" sz="1600" dirty="0">
+                <a:solidFill>
+                  <a:srgbClr val="000000"/>
+                </a:solidFill>
+              </a:rPr>
+              <a:t>Precision = 1.00 across all four divergence kinds - every detection is valid.</a:t>
+            </a:r>
+            <a:endParaRPr lang="en-US" sz="1600" dirty="0"/>
+          </a:p>
+          <a:p>
+            <a:pPr marL="342900" indent="-342900">
+              <a:spcAft>
+                <a:spcPts val="600"/>
+              </a:spcAft>
+              <a:buSzPct val="100000"/>
+              <a:buChar char="•"/>
+            </a:pPr>
+            <a:r>
+              <a:rPr lang="en-US" sz="1600" dirty="0">
+                <a:solidFill>
+                  <a:srgbClr val="000000"/>
+                </a:solidFill>
+              </a:rPr>
+              <a:t>Recall - Rework 1.00, Hygiene 1.00, Manual-Refactor 0.76, Ordering 0.40.</a:t>
+            </a:r>
+            <a:endParaRPr lang="en-US" sz="1600" dirty="0"/>
+          </a:p>
+          <a:p>
+            <a:pPr marL="342900" indent="-342900">
+              <a:spcAft>
+                <a:spcPts val="600"/>
+              </a:spcAft>
+              <a:buSzPct val="100000"/>
+              <a:buChar char="•"/>
+            </a:pPr>
+            <a:r>
+              <a:rPr lang="en-US" sz="1600" dirty="0">
+                <a:solidFill>
+                  <a:srgbClr val="000000"/>
+                </a:solidFill>
+              </a:rPr>
+              <a:t>Inter-rater agreement (Cohen's κ) -1.00 for Ordering and Manual-Refactor, 0.86 for Rework, 0.72 for Hygiene.</a:t>
+            </a:r>
+            <a:endParaRPr lang="en-US" sz="1600" dirty="0"/>
+          </a:p>
+          <a:p>
+            <a:pPr marL="342900" indent="-342900">
+              <a:spcAft>
+                <a:spcPts val="600"/>
+              </a:spcAft>
+              <a:buSzPct val="100000"/>
+              <a:buChar char="•"/>
+            </a:pPr>
+            <a:r>
+              <a:rPr lang="en-US" sz="1600" dirty="0">
+                <a:solidFill>
+                  <a:srgbClr val="000000"/>
+                </a:solidFill>
+              </a:rPr>
+              <a:t>Ordering recall gap is honest and explained: the synthesiser rejects windows it cannot safely reproduce. A scope limit, not a detector flaw.</a:t>
+            </a:r>
+            <a:endParaRPr lang="en-US" sz="1600" dirty="0"/>
+          </a:p>
+        </p:txBody>
+      </p:sp>
+    </p:spTree>
+  </p:cSld>
+  <p:clrMapOvr>
+    <a:masterClrMapping/>
+  </p:clrMapOvr>
+</p:sld>
+</file>
+
+<file path=ppt/slides/slide17.xml><?xml version="1.0" encoding="utf-8"?>
+<p:sld xmlns:a="http://schemas.openxmlformats.org/drawingml/2006/main" xmlns:r="http://schemas.openxmlformats.org/officeDocument/2006/relationships" xmlns:p="http://schemas.openxmlformats.org/presentationml/2006/main">
+  <p:cSld name="Slide 17">
+    <p:spTree>
+      <p:nvGrpSpPr>
+        <p:cNvPr id="1" name=""/>
+        <p:cNvGrpSpPr/>
+        <p:nvPr/>
+      </p:nvGrpSpPr>
+      <p:grpSpPr>
+        <a:xfrm>
+          <a:off x="0" y="0"/>
+          <a:ext cx="0" cy="0"/>
+          <a:chOff x="0" y="0"/>
+          <a:chExt cx="0" cy="0"/>
+        </a:xfrm>
+      </p:grpSpPr>
+      <p:sp>
+        <p:nvSpPr>
+          <p:cNvPr id="2" name="Text 0"/>
+          <p:cNvSpPr/>
+          <p:nvPr/>
+        </p:nvSpPr>
+        <p:spPr>
+          <a:xfrm>
+            <a:off x="457200" y="274320"/>
+            <a:ext cx="8229600" cy="640080"/>
+          </a:xfrm>
+          <a:prstGeom prst="rect">
+            <a:avLst/>
+          </a:prstGeom>
+          <a:noFill/>
+          <a:ln/>
+        </p:spPr>
+        <p:txBody>
+          <a:bodyPr wrap="square" lIns="0" tIns="0" rIns="0" bIns="0" rtlCol="0" anchor="ctr"/>
+          <a:lstStyle/>
+          <a:p>
+            <a:pPr indent="0" marL="0">
+              <a:buNone/>
+            </a:pPr>
+            <a:r>
+              <a:rPr lang="en-US" sz="2800" b="1" dirty="0">
+                <a:solidFill>
+                  <a:srgbClr val="000000"/>
+                </a:solidFill>
+              </a:rPr>
+              <a:t>Score robustness</a:t>
+            </a:r>
+            <a:endParaRPr lang="en-US" sz="2800" dirty="0"/>
+          </a:p>
+        </p:txBody>
+      </p:sp>
+      <p:sp>
+        <p:nvSpPr>
+          <p:cNvPr id="3" name="Text 1"/>
+          <p:cNvSpPr/>
+          <p:nvPr/>
+        </p:nvSpPr>
+        <p:spPr>
+          <a:xfrm>
+            <a:off x="457200" y="1188720"/>
+            <a:ext cx="8229600" cy="3657600"/>
+          </a:xfrm>
+          <a:prstGeom prst="rect">
+            <a:avLst/>
+          </a:prstGeom>
+          <a:noFill/>
+          <a:ln/>
+        </p:spPr>
+        <p:txBody>
+          <a:bodyPr wrap="square" rtlCol="0" anchor="t"/>
+          <a:lstStyle/>
+          <a:p>
+            <a:pPr marL="342900" indent="-342900">
+              <a:spcAft>
+                <a:spcPts val="600"/>
+              </a:spcAft>
+              <a:buSzPct val="100000"/>
+              <a:buChar char="•"/>
+            </a:pPr>
+            <a:r>
+              <a:rPr lang="en-US" sz="1600" dirty="0">
+                <a:solidFill>
+                  <a:srgbClr val="000000"/>
+                </a:solidFill>
+              </a:rPr>
+              <a:t>Single-knob sensitivity sweep: scale any one weight by {0.1×–10×}, top-1 recommendation is preserved in 96.5% of user-study cases.</a:t>
+            </a:r>
+            <a:endParaRPr lang="en-US" sz="1600" dirty="0"/>
+          </a:p>
+          <a:p>
+            <a:pPr marL="342900" indent="-342900">
+              <a:spcAft>
+                <a:spcPts val="600"/>
+              </a:spcAft>
+              <a:buSzPct val="100000"/>
+              <a:buChar char="•"/>
+            </a:pPr>
+            <a:r>
+              <a:rPr lang="en-US" sz="1600" dirty="0">
+                <a:solidFill>
+                  <a:srgbClr val="000000"/>
+                </a:solidFill>
+              </a:rPr>
+              <a:t>Multi-knob Monte Carlo (200 samples): top-1 stability drops to 84.6%; mean Kendall τ = 0.586.</a:t>
+            </a:r>
+            <a:endParaRPr lang="en-US" sz="1600" dirty="0"/>
+          </a:p>
+          <a:p>
+            <a:pPr marL="342900" indent="-342900">
+              <a:spcAft>
+                <a:spcPts val="600"/>
+              </a:spcAft>
+              <a:buSzPct val="100000"/>
+              <a:buChar char="•"/>
+            </a:pPr>
+            <a:r>
+              <a:rPr lang="en-US" sz="1600" dirty="0">
+                <a:solidFill>
+                  <a:srgbClr val="000000"/>
+                </a:solidFill>
+              </a:rPr>
+              <a:t>Honest framing - stable near the chosen weights, less stable under arbitrary joint perturbations.</a:t>
+            </a:r>
+            <a:endParaRPr lang="en-US" sz="1600" dirty="0"/>
+          </a:p>
+          <a:p>
+            <a:pPr marL="342900" indent="-342900">
+              <a:spcAft>
+                <a:spcPts val="600"/>
+              </a:spcAft>
+              <a:buSzPct val="100000"/>
+              <a:buChar char="•"/>
+            </a:pPr>
+            <a:r>
+              <a:rPr lang="en-US" sz="1600" dirty="0">
+                <a:solidFill>
+                  <a:srgbClr val="000000"/>
+                </a:solidFill>
+              </a:rPr>
+              <a:t>Ablation confirms each process term contributes real signal; endpoint gain alone does not recover the ranking.</a:t>
+            </a:r>
+            <a:endParaRPr lang="en-US" sz="1600" dirty="0"/>
+          </a:p>
+        </p:txBody>
+      </p:sp>
+    </p:spTree>
+  </p:cSld>
+  <p:clrMapOvr>
+    <a:masterClrMapping/>
+  </p:clrMapOvr>
+</p:sld>
+</file>
+
 <file path=ppt/slides/slide18.xml><?xml version="1.0" encoding="utf-8"?>
 <p:sld xmlns:a="http://schemas.openxmlformats.org/drawingml/2006/main" xmlns:r="http://schemas.openxmlformats.org/officeDocument/2006/relationships" xmlns:p="http://schemas.openxmlformats.org/presentationml/2006/main">
   <p:cSld name="Slide 18">
@@ -4690,7 +4445,7 @@
                   <a:srgbClr val="000000"/>
                 </a:solidFill>
               </a:rPr>
-              <a:t>Detector precision &amp; recall</a:t>
+              <a:t>User study: does feedback change behaviour?</a:t>
             </a:r>
             <a:endParaRPr lang="en-US" sz="2800" dirty="0"/>
           </a:p>
@@ -4730,7 +4485,7 @@
                   <a:srgbClr val="000000"/>
                 </a:solidFill>
               </a:rPr>
-              <a:t>Precision = 1.00 across all four divergence kinds - every detection is valid.</a:t>
+              <a:t>With-feedback group: 2.7 divergence points per session.</a:t>
             </a:r>
             <a:endParaRPr lang="en-US" sz="1600" dirty="0"/>
           </a:p>
@@ -4748,7 +4503,7 @@
                   <a:srgbClr val="000000"/>
                 </a:solidFill>
               </a:rPr>
-              <a:t>Recall - Rework 1.00, Hygiene 1.00, Manual-Refactor 0.76, Ordering 0.40.</a:t>
+              <a:t>No-feedback baseline: 6.0 divergence points per session -2.2× difference.</a:t>
             </a:r>
             <a:endParaRPr lang="en-US" sz="1600" dirty="0"/>
           </a:p>
@@ -4766,7 +4521,7 @@
                   <a:srgbClr val="000000"/>
                 </a:solidFill>
               </a:rPr>
-              <a:t>Inter-rater agreement (Cohen's κ) -1.00 for Ordering and Manual-Refactor, 0.86 for Rework, 0.72 for Hygiene.</a:t>
+              <a:t>Gain-stripped process-score slope across the 6-session arc -+4.47 per session with feedback, −0.40 per session without.</a:t>
             </a:r>
             <a:endParaRPr lang="en-US" sz="1600" dirty="0"/>
           </a:p>
@@ -4784,7 +4539,7 @@
                   <a:srgbClr val="000000"/>
                 </a:solidFill>
               </a:rPr>
-              <a:t>Ordering recall gap is honest and explained: the synthesiser rejects windows it cannot safely reproduce. A scope limit, not a detector flaw.</a:t>
+              <a:t>Caveat: n=3 vs n=2 is directional evidence, not a hypothesis test.</a:t>
             </a:r>
             <a:endParaRPr lang="en-US" sz="1600" dirty="0"/>
           </a:p>
@@ -4845,7 +4600,7 @@
                   <a:srgbClr val="000000"/>
                 </a:solidFill>
               </a:rPr>
-              <a:t>Score robustness</a:t>
+              <a:t>Contributions</a:t>
             </a:r>
             <a:endParaRPr lang="en-US" sz="2800" dirty="0"/>
           </a:p>
@@ -4885,7 +4640,7 @@
                   <a:srgbClr val="000000"/>
                 </a:solidFill>
               </a:rPr>
-              <a:t>Single-knob sensitivity sweep: scale any one weight by {0.1×–10×}, top-1 recommendation is preserved in 96.5% of user-study cases.</a:t>
+              <a:t>A process-quality metric J(τ) combining endpoint, process, and safety signals in one principled score.</a:t>
             </a:r>
             <a:endParaRPr lang="en-US" sz="1600" dirty="0"/>
           </a:p>
@@ -4903,7 +4658,7 @@
                   <a:srgbClr val="000000"/>
                 </a:solidFill>
               </a:rPr>
-              <a:t>Multi-knob Monte Carlo (200 samples): top-1 stability drops to 84.6%; mean Kendall τ = 0.586.</a:t>
+              <a:t>A divergence-point detector with four actionable kinds, each with a per-kind synthesiser that constructs a concrete alternative trajectory.</a:t>
             </a:r>
             <a:endParaRPr lang="en-US" sz="1600" dirty="0"/>
           </a:p>
@@ -4921,7 +4676,7 @@
                   <a:srgbClr val="000000"/>
                 </a:solidFill>
               </a:rPr>
-              <a:t>Honest framing - stable near the chosen weights, less stable under arbitrary joint perturbations.</a:t>
+              <a:t>Three datasets -45 injection sessions, 30-session user study, 48-session agent extension - with reproducible analysis (Jupyter notebook reproduces every table and figure).</a:t>
             </a:r>
             <a:endParaRPr lang="en-US" sz="1600" dirty="0"/>
           </a:p>
@@ -4939,7 +4694,7 @@
                   <a:srgbClr val="000000"/>
                 </a:solidFill>
               </a:rPr>
-              <a:t>Ablation confirms each process term contributes real signal; endpoint gain alone does not recover the ranking.</a:t>
+              <a:t>A deployable end-to-end system: IntelliJ plugin, analysis backend, and dashboard.</a:t>
             </a:r>
             <a:endParaRPr lang="en-US" sz="1600" dirty="0"/>
           </a:p>
@@ -5014,8 +4769,8 @@
         </p:nvSpPr>
         <p:spPr>
           <a:xfrm>
-            <a:off x="457200" y="1188720"/>
-            <a:ext cx="8229600" cy="3657600"/>
+            <a:off x="457200" y="1097280"/>
+            <a:ext cx="8229600" cy="2286000"/>
           </a:xfrm>
           <a:prstGeom prst="rect">
             <a:avLst/>
@@ -5080,79 +4835,18 @@
             </a:r>
             <a:endParaRPr lang="en-US" sz="1600" dirty="0"/>
           </a:p>
-          <a:p>
-            <a:pPr marL="342900" indent="-342900">
-              <a:spcAft>
-                <a:spcPts val="600"/>
-              </a:spcAft>
-              <a:buSzPct val="100000"/>
-              <a:buChar char="•"/>
-            </a:pPr>
-            <a:r>
-              <a:rPr lang="en-US" sz="1600" dirty="0">
-                <a:solidFill>
-                  <a:srgbClr val="000000"/>
-                </a:solidFill>
-              </a:rPr>
-              <a:t>Which one would you want on your team?</a:t>
-            </a:r>
-            <a:endParaRPr lang="en-US" sz="1600" dirty="0"/>
-          </a:p>
-          <a:p>
-            <a:pPr marL="342900" indent="-342900">
-              <a:spcAft>
-                <a:spcPts val="600"/>
-              </a:spcAft>
-              <a:buSzPct val="100000"/>
-              <a:buChar char="•"/>
-            </a:pPr>
-            <a:r>
-              <a:rPr lang="en-US" sz="1600" dirty="0">
-                <a:solidFill>
-                  <a:srgbClr val="000000"/>
-                </a:solidFill>
-              </a:rPr>
-              <a:t>Endpoint-only evaluation cannot tell them apart.</a:t>
-            </a:r>
-            <a:endParaRPr lang="en-US" sz="1600" dirty="0"/>
-          </a:p>
-        </p:txBody>
-      </p:sp>
-    </p:spTree>
-  </p:cSld>
-  <p:clrMapOvr>
-    <a:masterClrMapping/>
-  </p:clrMapOvr>
-</p:sld>
-</file>
-
-<file path=ppt/slides/slide20.xml><?xml version="1.0" encoding="utf-8"?>
-<p:sld xmlns:a="http://schemas.openxmlformats.org/drawingml/2006/main" xmlns:r="http://schemas.openxmlformats.org/officeDocument/2006/relationships" xmlns:p="http://schemas.openxmlformats.org/presentationml/2006/main">
-  <p:cSld name="Slide 20">
-    <p:spTree>
-      <p:nvGrpSpPr>
-        <p:cNvPr id="1" name=""/>
-        <p:cNvGrpSpPr/>
-        <p:nvPr/>
-      </p:nvGrpSpPr>
-      <p:grpSpPr>
-        <a:xfrm>
-          <a:off x="0" y="0"/>
-          <a:ext cx="0" cy="0"/>
-          <a:chOff x="0" y="0"/>
-          <a:chExt cx="0" cy="0"/>
-        </a:xfrm>
-      </p:grpSpPr>
-      <p:sp>
-        <p:nvSpPr>
-          <p:cNvPr id="2" name="Text 0"/>
+        </p:txBody>
+      </p:sp>
+      <p:sp>
+        <p:nvSpPr>
+          <p:cNvPr id="4" name="Text 2"/>
           <p:cNvSpPr/>
           <p:nvPr/>
         </p:nvSpPr>
         <p:spPr>
           <a:xfrm>
-            <a:off x="457200" y="274320"/>
-            <a:ext cx="8229600" cy="640080"/>
+            <a:off x="457200" y="3840480"/>
+            <a:ext cx="8229600" cy="1097280"/>
           </a:xfrm>
           <a:prstGeom prst="rect">
             <a:avLst/>
@@ -5161,42 +4855,6 @@
           <a:ln/>
         </p:spPr>
         <p:txBody>
-          <a:bodyPr wrap="square" lIns="0" tIns="0" rIns="0" bIns="0" rtlCol="0" anchor="ctr"/>
-          <a:lstStyle/>
-          <a:p>
-            <a:pPr indent="0" marL="0">
-              <a:buNone/>
-            </a:pPr>
-            <a:r>
-              <a:rPr lang="en-US" sz="2800" b="1" dirty="0">
-                <a:solidFill>
-                  <a:srgbClr val="000000"/>
-                </a:solidFill>
-              </a:rPr>
-              <a:t>User study: does feedback change behaviour?</a:t>
-            </a:r>
-            <a:endParaRPr lang="en-US" sz="2800" dirty="0"/>
-          </a:p>
-        </p:txBody>
-      </p:sp>
-      <p:sp>
-        <p:nvSpPr>
-          <p:cNvPr id="3" name="Text 1"/>
-          <p:cNvSpPr/>
-          <p:nvPr/>
-        </p:nvSpPr>
-        <p:spPr>
-          <a:xfrm>
-            <a:off x="457200" y="1188720"/>
-            <a:ext cx="8229600" cy="3657600"/>
-          </a:xfrm>
-          <a:prstGeom prst="rect">
-            <a:avLst/>
-          </a:prstGeom>
-          <a:noFill/>
-          <a:ln/>
-        </p:spPr>
-        <p:txBody>
           <a:bodyPr wrap="square" rtlCol="0" anchor="t"/>
           <a:lstStyle/>
           <a:p>
@@ -5213,7 +4871,7 @@
                   <a:srgbClr val="000000"/>
                 </a:solidFill>
               </a:rPr>
-              <a:t>With-feedback group: 2.7 divergence points per session.</a:t>
+              <a:t>Which one would you want on your team?</a:t>
             </a:r>
             <a:endParaRPr lang="en-US" sz="1600" dirty="0"/>
           </a:p>
@@ -5231,331 +4889,7 @@
                   <a:srgbClr val="000000"/>
                 </a:solidFill>
               </a:rPr>
-              <a:t>No-feedback baseline: 6.0 divergence points per session -2.2× difference.</a:t>
-            </a:r>
-            <a:endParaRPr lang="en-US" sz="1600" dirty="0"/>
-          </a:p>
-          <a:p>
-            <a:pPr marL="342900" indent="-342900">
-              <a:spcAft>
-                <a:spcPts val="600"/>
-              </a:spcAft>
-              <a:buSzPct val="100000"/>
-              <a:buChar char="•"/>
-            </a:pPr>
-            <a:r>
-              <a:rPr lang="en-US" sz="1600" dirty="0">
-                <a:solidFill>
-                  <a:srgbClr val="000000"/>
-                </a:solidFill>
-              </a:rPr>
-              <a:t>Gain-stripped process-score slope across the 6-session arc -+4.47 per session with feedback, −0.40 per session without.</a:t>
-            </a:r>
-            <a:endParaRPr lang="en-US" sz="1600" dirty="0"/>
-          </a:p>
-          <a:p>
-            <a:pPr marL="342900" indent="-342900">
-              <a:spcAft>
-                <a:spcPts val="600"/>
-              </a:spcAft>
-              <a:buSzPct val="100000"/>
-              <a:buChar char="•"/>
-            </a:pPr>
-            <a:r>
-              <a:rPr lang="en-US" sz="1600" dirty="0">
-                <a:solidFill>
-                  <a:srgbClr val="000000"/>
-                </a:solidFill>
-              </a:rPr>
-              <a:t>Caveat: n=3 vs n=2 is directional evidence, not a hypothesis test.</a:t>
-            </a:r>
-            <a:endParaRPr lang="en-US" sz="1600" dirty="0"/>
-          </a:p>
-        </p:txBody>
-      </p:sp>
-    </p:spTree>
-  </p:cSld>
-  <p:clrMapOvr>
-    <a:masterClrMapping/>
-  </p:clrMapOvr>
-</p:sld>
-</file>
-
-<file path=ppt/slides/slide21.xml><?xml version="1.0" encoding="utf-8"?>
-<p:sld xmlns:a="http://schemas.openxmlformats.org/drawingml/2006/main" xmlns:r="http://schemas.openxmlformats.org/officeDocument/2006/relationships" xmlns:p="http://schemas.openxmlformats.org/presentationml/2006/main">
-  <p:cSld name="Slide 21">
-    <p:spTree>
-      <p:nvGrpSpPr>
-        <p:cNvPr id="1" name=""/>
-        <p:cNvGrpSpPr/>
-        <p:nvPr/>
-      </p:nvGrpSpPr>
-      <p:grpSpPr>
-        <a:xfrm>
-          <a:off x="0" y="0"/>
-          <a:ext cx="0" cy="0"/>
-          <a:chOff x="0" y="0"/>
-          <a:chExt cx="0" cy="0"/>
-        </a:xfrm>
-      </p:grpSpPr>
-      <p:sp>
-        <p:nvSpPr>
-          <p:cNvPr id="2" name="Text 0"/>
-          <p:cNvSpPr/>
-          <p:nvPr/>
-        </p:nvSpPr>
-        <p:spPr>
-          <a:xfrm>
-            <a:off x="457200" y="274320"/>
-            <a:ext cx="8229600" cy="640080"/>
-          </a:xfrm>
-          <a:prstGeom prst="rect">
-            <a:avLst/>
-          </a:prstGeom>
-          <a:noFill/>
-          <a:ln/>
-        </p:spPr>
-        <p:txBody>
-          <a:bodyPr wrap="square" lIns="0" tIns="0" rIns="0" bIns="0" rtlCol="0" anchor="ctr"/>
-          <a:lstStyle/>
-          <a:p>
-            <a:pPr indent="0" marL="0">
-              <a:buNone/>
-            </a:pPr>
-            <a:r>
-              <a:rPr lang="en-US" sz="2800" b="1" dirty="0">
-                <a:solidFill>
-                  <a:srgbClr val="000000"/>
-                </a:solidFill>
-              </a:rPr>
-              <a:t>Contributions</a:t>
-            </a:r>
-            <a:endParaRPr lang="en-US" sz="2800" dirty="0"/>
-          </a:p>
-        </p:txBody>
-      </p:sp>
-      <p:sp>
-        <p:nvSpPr>
-          <p:cNvPr id="3" name="Text 1"/>
-          <p:cNvSpPr/>
-          <p:nvPr/>
-        </p:nvSpPr>
-        <p:spPr>
-          <a:xfrm>
-            <a:off x="457200" y="1188720"/>
-            <a:ext cx="8229600" cy="3657600"/>
-          </a:xfrm>
-          <a:prstGeom prst="rect">
-            <a:avLst/>
-          </a:prstGeom>
-          <a:noFill/>
-          <a:ln/>
-        </p:spPr>
-        <p:txBody>
-          <a:bodyPr wrap="square" rtlCol="0" anchor="t"/>
-          <a:lstStyle/>
-          <a:p>
-            <a:pPr marL="342900" indent="-342900">
-              <a:spcAft>
-                <a:spcPts val="600"/>
-              </a:spcAft>
-              <a:buSzPct val="100000"/>
-              <a:buChar char="•"/>
-            </a:pPr>
-            <a:r>
-              <a:rPr lang="en-US" sz="1600" dirty="0">
-                <a:solidFill>
-                  <a:srgbClr val="000000"/>
-                </a:solidFill>
-              </a:rPr>
-              <a:t>A process-quality metric J(τ) combining endpoint, process, and safety signals in one principled score.</a:t>
-            </a:r>
-            <a:endParaRPr lang="en-US" sz="1600" dirty="0"/>
-          </a:p>
-          <a:p>
-            <a:pPr marL="342900" indent="-342900">
-              <a:spcAft>
-                <a:spcPts val="600"/>
-              </a:spcAft>
-              <a:buSzPct val="100000"/>
-              <a:buChar char="•"/>
-            </a:pPr>
-            <a:r>
-              <a:rPr lang="en-US" sz="1600" dirty="0">
-                <a:solidFill>
-                  <a:srgbClr val="000000"/>
-                </a:solidFill>
-              </a:rPr>
-              <a:t>A divergence-point detector with four actionable kinds, each with a per-kind synthesiser that constructs a concrete alternative trajectory.</a:t>
-            </a:r>
-            <a:endParaRPr lang="en-US" sz="1600" dirty="0"/>
-          </a:p>
-          <a:p>
-            <a:pPr marL="342900" indent="-342900">
-              <a:spcAft>
-                <a:spcPts val="600"/>
-              </a:spcAft>
-              <a:buSzPct val="100000"/>
-              <a:buChar char="•"/>
-            </a:pPr>
-            <a:r>
-              <a:rPr lang="en-US" sz="1600" dirty="0">
-                <a:solidFill>
-                  <a:srgbClr val="000000"/>
-                </a:solidFill>
-              </a:rPr>
-              <a:t>Three datasets -45 injection sessions, 30-session user study, 48-session agent extension - with reproducible analysis (Jupyter notebook reproduces every table and figure).</a:t>
-            </a:r>
-            <a:endParaRPr lang="en-US" sz="1600" dirty="0"/>
-          </a:p>
-          <a:p>
-            <a:pPr marL="342900" indent="-342900">
-              <a:spcAft>
-                <a:spcPts val="600"/>
-              </a:spcAft>
-              <a:buSzPct val="100000"/>
-              <a:buChar char="•"/>
-            </a:pPr>
-            <a:r>
-              <a:rPr lang="en-US" sz="1600" dirty="0">
-                <a:solidFill>
-                  <a:srgbClr val="000000"/>
-                </a:solidFill>
-              </a:rPr>
-              <a:t>A deployable end-to-end system: IntelliJ plugin, analysis backend, and dashboard.</a:t>
-            </a:r>
-            <a:endParaRPr lang="en-US" sz="1600" dirty="0"/>
-          </a:p>
-        </p:txBody>
-      </p:sp>
-    </p:spTree>
-  </p:cSld>
-  <p:clrMapOvr>
-    <a:masterClrMapping/>
-  </p:clrMapOvr>
-</p:sld>
-</file>
-
-<file path=ppt/slides/slide22.xml><?xml version="1.0" encoding="utf-8"?>
-<p:sld xmlns:a="http://schemas.openxmlformats.org/drawingml/2006/main" xmlns:r="http://schemas.openxmlformats.org/officeDocument/2006/relationships" xmlns:p="http://schemas.openxmlformats.org/presentationml/2006/main">
-  <p:cSld name="Slide 22">
-    <p:spTree>
-      <p:nvGrpSpPr>
-        <p:cNvPr id="1" name=""/>
-        <p:cNvGrpSpPr/>
-        <p:nvPr/>
-      </p:nvGrpSpPr>
-      <p:grpSpPr>
-        <a:xfrm>
-          <a:off x="0" y="0"/>
-          <a:ext cx="0" cy="0"/>
-          <a:chOff x="0" y="0"/>
-          <a:chExt cx="0" cy="0"/>
-        </a:xfrm>
-      </p:grpSpPr>
-      <p:sp>
-        <p:nvSpPr>
-          <p:cNvPr id="2" name="Text 0"/>
-          <p:cNvSpPr/>
-          <p:nvPr/>
-        </p:nvSpPr>
-        <p:spPr>
-          <a:xfrm>
-            <a:off x="457200" y="1645920"/>
-            <a:ext cx="8229600" cy="1371600"/>
-          </a:xfrm>
-          <a:prstGeom prst="rect">
-            <a:avLst/>
-          </a:prstGeom>
-          <a:noFill/>
-          <a:ln/>
-        </p:spPr>
-        <p:txBody>
-          <a:bodyPr wrap="square" lIns="0" tIns="0" rIns="0" bIns="0" rtlCol="0" anchor="ctr"/>
-          <a:lstStyle/>
-          <a:p>
-            <a:pPr algn="ctr" indent="0" marL="0">
-              <a:buNone/>
-            </a:pPr>
-            <a:r>
-              <a:rPr lang="en-US" sz="2600" i="1" dirty="0">
-                <a:solidFill>
-                  <a:srgbClr val="000000"/>
-                </a:solidFill>
-              </a:rPr>
-              <a:t>Refactoring quality isn't just about where you end up - it's about the path you walked to get there.</a:t>
-            </a:r>
-            <a:endParaRPr lang="en-US" sz="2600" dirty="0"/>
-          </a:p>
-        </p:txBody>
-      </p:sp>
-      <p:sp>
-        <p:nvSpPr>
-          <p:cNvPr id="3" name="Text 1"/>
-          <p:cNvSpPr/>
-          <p:nvPr/>
-        </p:nvSpPr>
-        <p:spPr>
-          <a:xfrm>
-            <a:off x="457200" y="3108960"/>
-            <a:ext cx="8229600" cy="731520"/>
-          </a:xfrm>
-          <a:prstGeom prst="rect">
-            <a:avLst/>
-          </a:prstGeom>
-          <a:noFill/>
-          <a:ln/>
-        </p:spPr>
-        <p:txBody>
-          <a:bodyPr wrap="square" rtlCol="0" anchor="ctr"/>
-          <a:lstStyle/>
-          <a:p>
-            <a:pPr algn="ctr" indent="0" marL="0">
-              <a:buNone/>
-            </a:pPr>
-            <a:r>
-              <a:rPr lang="en-US" sz="2200" b="1" dirty="0">
-                <a:solidFill>
-                  <a:srgbClr val="000000"/>
-                </a:solidFill>
-              </a:rPr>
-              <a:t>This work makes that path measurable, comparable, and improvable.</a:t>
-            </a:r>
-            <a:endParaRPr lang="en-US" sz="2200" dirty="0"/>
-          </a:p>
-        </p:txBody>
-      </p:sp>
-      <p:sp>
-        <p:nvSpPr>
-          <p:cNvPr id="4" name="Text 2"/>
-          <p:cNvSpPr/>
-          <p:nvPr/>
-        </p:nvSpPr>
-        <p:spPr>
-          <a:xfrm>
-            <a:off x="457200" y="4206240"/>
-            <a:ext cx="8229600" cy="457200"/>
-          </a:xfrm>
-          <a:prstGeom prst="rect">
-            <a:avLst/>
-          </a:prstGeom>
-          <a:noFill/>
-          <a:ln/>
-        </p:spPr>
-        <p:txBody>
-          <a:bodyPr wrap="square" rtlCol="0" anchor="ctr"/>
-          <a:lstStyle/>
-          <a:p>
-            <a:pPr algn="ctr" indent="0" marL="0">
-              <a:buNone/>
-            </a:pPr>
-            <a:r>
-              <a:rPr lang="en-US" sz="1600" dirty="0">
-                <a:solidFill>
-                  <a:srgbClr val="555555"/>
-                </a:solidFill>
-              </a:rPr>
-              <a:t>Thank you - happy to take questions.</a:t>
+              <a:t>Endpoint-only evaluation cannot tell them apart.</a:t>
             </a:r>
             <a:endParaRPr lang="en-US" sz="1600" dirty="0"/>
           </a:p>
@@ -6038,8 +5372,8 @@
         </p:nvSpPr>
         <p:spPr>
           <a:xfrm>
-            <a:off x="457200" y="274320"/>
-            <a:ext cx="8229600" cy="640080"/>
+            <a:off x="457200" y="2011680"/>
+            <a:ext cx="8229600" cy="1097280"/>
           </a:xfrm>
           <a:prstGeom prst="rect">
             <a:avLst/>
@@ -6051,139 +5385,21 @@
           <a:bodyPr wrap="square" lIns="0" tIns="0" rIns="0" bIns="0" rtlCol="0" anchor="ctr"/>
           <a:lstStyle/>
           <a:p>
-            <a:pPr indent="0" marL="0">
+            <a:pPr algn="ctr" indent="0" marL="0">
               <a:buNone/>
             </a:pPr>
             <a:r>
-              <a:rPr lang="en-US" sz="2800" b="1" dirty="0">
-                <a:solidFill>
-                  <a:srgbClr val="000000"/>
-                </a:solidFill>
-              </a:rPr>
-              <a:t>Desired outcome: a comparable counterfactual</a:t>
-            </a:r>
-            <a:endParaRPr lang="en-US" sz="2800" dirty="0"/>
-          </a:p>
-        </p:txBody>
-      </p:sp>
-      <p:sp>
-        <p:nvSpPr>
-          <p:cNvPr id="3" name="Text 1"/>
-          <p:cNvSpPr/>
-          <p:nvPr/>
-        </p:nvSpPr>
-        <p:spPr>
-          <a:xfrm>
-            <a:off x="457200" y="1097280"/>
-            <a:ext cx="8229600" cy="1463040"/>
-          </a:xfrm>
-          <a:prstGeom prst="rect">
-            <a:avLst/>
-          </a:prstGeom>
-          <a:noFill/>
-          <a:ln/>
-        </p:spPr>
-        <p:txBody>
-          <a:bodyPr wrap="square" rtlCol="0" anchor="t"/>
-          <a:lstStyle/>
-          <a:p>
-            <a:pPr marL="342900" indent="-342900">
-              <a:spcAft>
-                <a:spcPts val="600"/>
-              </a:spcAft>
-              <a:buSzPct val="100000"/>
-              <a:buChar char="•"/>
-            </a:pPr>
-            <a:r>
-              <a:rPr lang="en-US" sz="1600" dirty="0">
-                <a:solidFill>
-                  <a:srgbClr val="000000"/>
-                </a:solidFill>
-              </a:rPr>
-              <a:t>Given those four requirements, the concrete thing we wanted the tool to produce, for any recorded session:</a:t>
-            </a:r>
-            <a:endParaRPr lang="en-US" sz="1600" dirty="0"/>
-          </a:p>
-          <a:p>
-            <a:pPr marL="342900" indent="-342900">
-              <a:spcAft>
-                <a:spcPts val="600"/>
-              </a:spcAft>
-              <a:buSzPct val="100000"/>
-              <a:buChar char="•"/>
-            </a:pPr>
-            <a:r>
-              <a:rPr lang="en-US" sz="1600" dirty="0">
-                <a:solidFill>
-                  <a:srgbClr val="000000"/>
-                </a:solidFill>
-              </a:rPr>
-              <a:t>Solid line - the user's actual trajectory through code states.</a:t>
-            </a:r>
-            <a:endParaRPr lang="en-US" sz="1600" dirty="0"/>
-          </a:p>
-          <a:p>
-            <a:pPr marL="342900" indent="-342900">
-              <a:spcAft>
-                <a:spcPts val="600"/>
-              </a:spcAft>
-              <a:buSzPct val="100000"/>
-              <a:buChar char="•"/>
-            </a:pPr>
-            <a:r>
-              <a:rPr lang="en-US" sz="1600" dirty="0">
-                <a:solidFill>
-                  <a:srgbClr val="000000"/>
-                </a:solidFill>
-              </a:rPr>
-              <a:t>Dashed line - synthesised alternative; same start, same finish, measurably higher J(τ).</a:t>
-            </a:r>
-            <a:endParaRPr lang="en-US" sz="1600" dirty="0"/>
-          </a:p>
-          <a:p>
-            <a:pPr marL="342900" indent="-342900">
-              <a:spcAft>
-                <a:spcPts val="600"/>
-              </a:spcAft>
-              <a:buSzPct val="100000"/>
-              <a:buChar char="•"/>
-            </a:pPr>
-            <a:r>
-              <a:rPr lang="en-US" sz="1600" dirty="0">
-                <a:solidFill>
-                  <a:srgbClr val="000000"/>
-                </a:solidFill>
-              </a:rPr>
-              <a:t>Divergence point marks where the two paths split; ΔJ quantifies the gap.</a:t>
-            </a:r>
-            <a:endParaRPr lang="en-US" sz="1600" dirty="0"/>
-          </a:p>
-        </p:txBody>
-      </p:sp>
-      <p:pic>
-        <p:nvPicPr>
-          <p:cNvPr id="4" name="Image 0" descr="images/divergence-point.png">    </p:cNvPr>
-          <p:cNvPicPr>
-            <a:picLocks noChangeAspect="1"/>
-          </p:cNvPicPr>
-          <p:nvPr/>
-        </p:nvPicPr>
-        <p:blipFill>
-          <a:blip r:embed="rId1"/>
-          <a:stretch>
-            <a:fillRect/>
-          </a:stretch>
-        </p:blipFill>
-        <p:spPr>
-          <a:xfrm>
-            <a:off x="2651760" y="2697480"/>
-            <a:ext cx="3840480" cy="2276856"/>
-          </a:xfrm>
-          <a:prstGeom prst="rect">
-            <a:avLst/>
-          </a:prstGeom>
-        </p:spPr>
-      </p:pic>
+              <a:rPr lang="en-US" sz="8000" b="1" dirty="0">
+                <a:solidFill>
+                  <a:srgbClr val="000000"/>
+                </a:solidFill>
+              </a:rPr>
+              <a:t>Demo</a:t>
+            </a:r>
+            <a:endParaRPr lang="en-US" sz="8000" dirty="0"/>
+          </a:p>
+        </p:txBody>
+      </p:sp>
     </p:spTree>
   </p:cSld>
   <p:clrMapOvr>
@@ -6217,8 +5433,8 @@
         </p:nvSpPr>
         <p:spPr>
           <a:xfrm>
-            <a:off x="457200" y="1828800"/>
-            <a:ext cx="8229600" cy="914400"/>
+            <a:off x="457200" y="274320"/>
+            <a:ext cx="8229600" cy="640080"/>
           </a:xfrm>
           <a:prstGeom prst="rect">
             <a:avLst/>
@@ -6230,31 +5446,56 @@
           <a:bodyPr wrap="square" lIns="0" tIns="0" rIns="0" bIns="0" rtlCol="0" anchor="ctr"/>
           <a:lstStyle/>
           <a:p>
-            <a:pPr algn="ctr" indent="0" marL="0">
+            <a:pPr indent="0" marL="0">
               <a:buNone/>
             </a:pPr>
             <a:r>
-              <a:rPr lang="en-US" sz="4400" b="1" dirty="0">
-                <a:solidFill>
-                  <a:srgbClr val="000000"/>
-                </a:solidFill>
-              </a:rPr>
-              <a:t>Demo (part 1): live capture</a:t>
-            </a:r>
-            <a:endParaRPr lang="en-US" sz="4400" dirty="0"/>
-          </a:p>
-        </p:txBody>
-      </p:sp>
-      <p:sp>
-        <p:nvSpPr>
-          <p:cNvPr id="3" name="Text 1"/>
+              <a:rPr lang="en-US" sz="2800" b="1" dirty="0">
+                <a:solidFill>
+                  <a:srgbClr val="000000"/>
+                </a:solidFill>
+              </a:rPr>
+              <a:t>What the tool does, end to end</a:t>
+            </a:r>
+            <a:endParaRPr lang="en-US" sz="2800" dirty="0"/>
+          </a:p>
+        </p:txBody>
+      </p:sp>
+      <p:sp>
+        <p:nvSpPr>
+          <p:cNvPr id="3" name="Shape 1"/>
           <p:cNvSpPr/>
           <p:nvPr/>
         </p:nvSpPr>
         <p:spPr>
           <a:xfrm>
-            <a:off x="457200" y="2834640"/>
-            <a:ext cx="8229600" cy="1097280"/>
+            <a:off x="182880" y="1463040"/>
+            <a:ext cx="2377440" cy="2377440"/>
+          </a:xfrm>
+          <a:prstGeom prst="rect">
+            <a:avLst/>
+          </a:prstGeom>
+          <a:solidFill>
+            <a:srgbClr val="FFFFFF"/>
+          </a:solidFill>
+          <a:ln w="12700">
+            <a:solidFill>
+              <a:srgbClr val="000000"/>
+            </a:solidFill>
+            <a:prstDash val="solid"/>
+          </a:ln>
+        </p:spPr>
+      </p:sp>
+      <p:sp>
+        <p:nvSpPr>
+          <p:cNvPr id="4" name="Text 2"/>
+          <p:cNvSpPr/>
+          <p:nvPr/>
+        </p:nvSpPr>
+        <p:spPr>
+          <a:xfrm>
+            <a:off x="274320" y="1645920"/>
+            <a:ext cx="2194560" cy="457200"/>
           </a:xfrm>
           <a:prstGeom prst="rect">
             <a:avLst/>
@@ -6263,21 +5504,538 @@
           <a:ln/>
         </p:spPr>
         <p:txBody>
-          <a:bodyPr wrap="square" rtlCol="0" anchor="ctr"/>
+          <a:bodyPr wrap="square" lIns="0" tIns="0" rIns="0" bIns="0" rtlCol="0" anchor="ctr"/>
           <a:lstStyle/>
           <a:p>
             <a:pPr algn="ctr" indent="0" marL="0">
               <a:buNone/>
             </a:pPr>
             <a:r>
-              <a:rPr lang="en-US" sz="1800" i="1" dirty="0">
+              <a:rPr lang="en-US" sz="1600" b="1" dirty="0">
+                <a:solidFill>
+                  <a:srgbClr val="000000"/>
+                </a:solidFill>
+              </a:rPr>
+              <a:t>IntelliJ Plugin</a:t>
+            </a:r>
+            <a:endParaRPr lang="en-US" sz="1600" dirty="0"/>
+          </a:p>
+        </p:txBody>
+      </p:sp>
+      <p:sp>
+        <p:nvSpPr>
+          <p:cNvPr id="5" name="Shape 3"/>
+          <p:cNvSpPr/>
+          <p:nvPr/>
+        </p:nvSpPr>
+        <p:spPr>
+          <a:xfrm>
+            <a:off x="457200" y="2194560"/>
+            <a:ext cx="1828800" cy="0"/>
+          </a:xfrm>
+          <a:prstGeom prst="line">
+            <a:avLst/>
+          </a:prstGeom>
+          <a:noFill/>
+          <a:ln w="9525">
+            <a:solidFill>
+              <a:srgbClr val="999999"/>
+            </a:solidFill>
+            <a:prstDash val="solid"/>
+          </a:ln>
+        </p:spPr>
+      </p:sp>
+      <p:sp>
+        <p:nvSpPr>
+          <p:cNvPr id="6" name="Text 4"/>
+          <p:cNvSpPr/>
+          <p:nvPr/>
+        </p:nvSpPr>
+        <p:spPr>
+          <a:xfrm>
+            <a:off x="411480" y="2377440"/>
+            <a:ext cx="2011680" cy="1371600"/>
+          </a:xfrm>
+          <a:prstGeom prst="rect">
+            <a:avLst/>
+          </a:prstGeom>
+          <a:noFill/>
+          <a:ln/>
+        </p:spPr>
+        <p:txBody>
+          <a:bodyPr wrap="square" rtlCol="0" anchor="t"/>
+          <a:lstStyle/>
+          <a:p>
+            <a:pPr marL="342900" indent="-342900">
+              <a:spcAft>
+                <a:spcPts val="800"/>
+              </a:spcAft>
+              <a:buSzPct val="100000"/>
+              <a:buChar char="•"/>
+            </a:pPr>
+            <a:r>
+              <a:rPr lang="en-US" sz="1200" dirty="0">
+                <a:solidFill>
+                  <a:srgbClr val="333333"/>
+                </a:solidFill>
+              </a:rPr>
+              <a:t>Records developer events</a:t>
+            </a:r>
+            <a:endParaRPr lang="en-US" sz="1200" dirty="0"/>
+          </a:p>
+          <a:p>
+            <a:pPr marL="342900" indent="-342900">
+              <a:spcAft>
+                <a:spcPts val="800"/>
+              </a:spcAft>
+              <a:buSzPct val="100000"/>
+              <a:buChar char="•"/>
+            </a:pPr>
+            <a:r>
+              <a:rPr lang="en-US" sz="1200" dirty="0">
+                <a:solidFill>
+                  <a:srgbClr val="333333"/>
+                </a:solidFill>
+              </a:rPr>
+              <a:t>Captures initial codebase</a:t>
+            </a:r>
+            <a:endParaRPr lang="en-US" sz="1200" dirty="0"/>
+          </a:p>
+        </p:txBody>
+      </p:sp>
+      <p:sp>
+        <p:nvSpPr>
+          <p:cNvPr id="7" name="Shape 5"/>
+          <p:cNvSpPr/>
+          <p:nvPr/>
+        </p:nvSpPr>
+        <p:spPr>
+          <a:xfrm>
+            <a:off x="3383280" y="1463040"/>
+            <a:ext cx="2377440" cy="2377440"/>
+          </a:xfrm>
+          <a:prstGeom prst="rect">
+            <a:avLst/>
+          </a:prstGeom>
+          <a:solidFill>
+            <a:srgbClr val="FFFFFF"/>
+          </a:solidFill>
+          <a:ln w="12700">
+            <a:solidFill>
+              <a:srgbClr val="000000"/>
+            </a:solidFill>
+            <a:prstDash val="solid"/>
+          </a:ln>
+        </p:spPr>
+      </p:sp>
+      <p:sp>
+        <p:nvSpPr>
+          <p:cNvPr id="8" name="Text 6"/>
+          <p:cNvSpPr/>
+          <p:nvPr/>
+        </p:nvSpPr>
+        <p:spPr>
+          <a:xfrm>
+            <a:off x="3474720" y="1645920"/>
+            <a:ext cx="2194560" cy="457200"/>
+          </a:xfrm>
+          <a:prstGeom prst="rect">
+            <a:avLst/>
+          </a:prstGeom>
+          <a:noFill/>
+          <a:ln/>
+        </p:spPr>
+        <p:txBody>
+          <a:bodyPr wrap="square" lIns="0" tIns="0" rIns="0" bIns="0" rtlCol="0" anchor="ctr"/>
+          <a:lstStyle/>
+          <a:p>
+            <a:pPr algn="ctr" indent="0" marL="0">
+              <a:buNone/>
+            </a:pPr>
+            <a:r>
+              <a:rPr lang="en-US" sz="1600" b="1" dirty="0">
+                <a:solidFill>
+                  <a:srgbClr val="000000"/>
+                </a:solidFill>
+              </a:rPr>
+              <a:t>Analysis Backend</a:t>
+            </a:r>
+            <a:endParaRPr lang="en-US" sz="1600" dirty="0"/>
+          </a:p>
+        </p:txBody>
+      </p:sp>
+      <p:sp>
+        <p:nvSpPr>
+          <p:cNvPr id="9" name="Shape 7"/>
+          <p:cNvSpPr/>
+          <p:nvPr/>
+        </p:nvSpPr>
+        <p:spPr>
+          <a:xfrm>
+            <a:off x="3657600" y="2194560"/>
+            <a:ext cx="1828800" cy="0"/>
+          </a:xfrm>
+          <a:prstGeom prst="line">
+            <a:avLst/>
+          </a:prstGeom>
+          <a:noFill/>
+          <a:ln w="9525">
+            <a:solidFill>
+              <a:srgbClr val="999999"/>
+            </a:solidFill>
+            <a:prstDash val="solid"/>
+          </a:ln>
+        </p:spPr>
+      </p:sp>
+      <p:sp>
+        <p:nvSpPr>
+          <p:cNvPr id="10" name="Text 8"/>
+          <p:cNvSpPr/>
+          <p:nvPr/>
+        </p:nvSpPr>
+        <p:spPr>
+          <a:xfrm>
+            <a:off x="3611880" y="2377440"/>
+            <a:ext cx="2011680" cy="1371600"/>
+          </a:xfrm>
+          <a:prstGeom prst="rect">
+            <a:avLst/>
+          </a:prstGeom>
+          <a:noFill/>
+          <a:ln/>
+        </p:spPr>
+        <p:txBody>
+          <a:bodyPr wrap="square" rtlCol="0" anchor="t"/>
+          <a:lstStyle/>
+          <a:p>
+            <a:pPr marL="342900" indent="-342900">
+              <a:spcAft>
+                <a:spcPts val="800"/>
+              </a:spcAft>
+              <a:buSzPct val="100000"/>
+              <a:buChar char="•"/>
+            </a:pPr>
+            <a:r>
+              <a:rPr lang="en-US" sz="1200" dirty="0">
+                <a:solidFill>
+                  <a:srgbClr val="333333"/>
+                </a:solidFill>
+              </a:rPr>
+              <a:t>Shadow repo reconstruction</a:t>
+            </a:r>
+            <a:endParaRPr lang="en-US" sz="1200" dirty="0"/>
+          </a:p>
+          <a:p>
+            <a:pPr marL="342900" indent="-342900">
+              <a:spcAft>
+                <a:spcPts val="800"/>
+              </a:spcAft>
+              <a:buSzPct val="100000"/>
+              <a:buChar char="•"/>
+            </a:pPr>
+            <a:r>
+              <a:rPr lang="en-US" sz="1200" dirty="0">
+                <a:solidFill>
+                  <a:srgbClr val="333333"/>
+                </a:solidFill>
+              </a:rPr>
+              <a:t>Metric calculation</a:t>
+            </a:r>
+            <a:endParaRPr lang="en-US" sz="1200" dirty="0"/>
+          </a:p>
+          <a:p>
+            <a:pPr marL="342900" indent="-342900">
+              <a:spcAft>
+                <a:spcPts val="800"/>
+              </a:spcAft>
+              <a:buSzPct val="100000"/>
+              <a:buChar char="•"/>
+            </a:pPr>
+            <a:r>
+              <a:rPr lang="en-US" sz="1200" dirty="0">
+                <a:solidFill>
+                  <a:srgbClr val="333333"/>
+                </a:solidFill>
+              </a:rPr>
+              <a:t>Divergence detection &amp; synthesis</a:t>
+            </a:r>
+            <a:endParaRPr lang="en-US" sz="1200" dirty="0"/>
+          </a:p>
+        </p:txBody>
+      </p:sp>
+      <p:sp>
+        <p:nvSpPr>
+          <p:cNvPr id="11" name="Shape 9"/>
+          <p:cNvSpPr/>
+          <p:nvPr/>
+        </p:nvSpPr>
+        <p:spPr>
+          <a:xfrm>
+            <a:off x="6583680" y="1463040"/>
+            <a:ext cx="2377440" cy="2377440"/>
+          </a:xfrm>
+          <a:prstGeom prst="rect">
+            <a:avLst/>
+          </a:prstGeom>
+          <a:solidFill>
+            <a:srgbClr val="FFFFFF"/>
+          </a:solidFill>
+          <a:ln w="12700">
+            <a:solidFill>
+              <a:srgbClr val="000000"/>
+            </a:solidFill>
+            <a:prstDash val="solid"/>
+          </a:ln>
+        </p:spPr>
+      </p:sp>
+      <p:sp>
+        <p:nvSpPr>
+          <p:cNvPr id="12" name="Text 10"/>
+          <p:cNvSpPr/>
+          <p:nvPr/>
+        </p:nvSpPr>
+        <p:spPr>
+          <a:xfrm>
+            <a:off x="6675120" y="1645920"/>
+            <a:ext cx="2194560" cy="457200"/>
+          </a:xfrm>
+          <a:prstGeom prst="rect">
+            <a:avLst/>
+          </a:prstGeom>
+          <a:noFill/>
+          <a:ln/>
+        </p:spPr>
+        <p:txBody>
+          <a:bodyPr wrap="square" lIns="0" tIns="0" rIns="0" bIns="0" rtlCol="0" anchor="ctr"/>
+          <a:lstStyle/>
+          <a:p>
+            <a:pPr algn="ctr" indent="0" marL="0">
+              <a:buNone/>
+            </a:pPr>
+            <a:r>
+              <a:rPr lang="en-US" sz="1600" b="1" dirty="0">
+                <a:solidFill>
+                  <a:srgbClr val="000000"/>
+                </a:solidFill>
+              </a:rPr>
+              <a:t>Dashboard</a:t>
+            </a:r>
+            <a:endParaRPr lang="en-US" sz="1600" dirty="0"/>
+          </a:p>
+        </p:txBody>
+      </p:sp>
+      <p:sp>
+        <p:nvSpPr>
+          <p:cNvPr id="13" name="Shape 11"/>
+          <p:cNvSpPr/>
+          <p:nvPr/>
+        </p:nvSpPr>
+        <p:spPr>
+          <a:xfrm>
+            <a:off x="6858000" y="2194560"/>
+            <a:ext cx="1828800" cy="0"/>
+          </a:xfrm>
+          <a:prstGeom prst="line">
+            <a:avLst/>
+          </a:prstGeom>
+          <a:noFill/>
+          <a:ln w="9525">
+            <a:solidFill>
+              <a:srgbClr val="999999"/>
+            </a:solidFill>
+            <a:prstDash val="solid"/>
+          </a:ln>
+        </p:spPr>
+      </p:sp>
+      <p:sp>
+        <p:nvSpPr>
+          <p:cNvPr id="14" name="Text 12"/>
+          <p:cNvSpPr/>
+          <p:nvPr/>
+        </p:nvSpPr>
+        <p:spPr>
+          <a:xfrm>
+            <a:off x="6812280" y="2377440"/>
+            <a:ext cx="2011680" cy="1371600"/>
+          </a:xfrm>
+          <a:prstGeom prst="rect">
+            <a:avLst/>
+          </a:prstGeom>
+          <a:noFill/>
+          <a:ln/>
+        </p:spPr>
+        <p:txBody>
+          <a:bodyPr wrap="square" rtlCol="0" anchor="t"/>
+          <a:lstStyle/>
+          <a:p>
+            <a:pPr marL="342900" indent="-342900">
+              <a:spcAft>
+                <a:spcPts val="800"/>
+              </a:spcAft>
+              <a:buSzPct val="100000"/>
+              <a:buChar char="•"/>
+            </a:pPr>
+            <a:r>
+              <a:rPr lang="en-US" sz="1200" dirty="0">
+                <a:solidFill>
+                  <a:srgbClr val="333333"/>
+                </a:solidFill>
+              </a:rPr>
+              <a:t>Surfaces divergence points in context</a:t>
+            </a:r>
+            <a:endParaRPr lang="en-US" sz="1200" dirty="0"/>
+          </a:p>
+          <a:p>
+            <a:pPr marL="342900" indent="-342900">
+              <a:spcAft>
+                <a:spcPts val="800"/>
+              </a:spcAft>
+              <a:buSzPct val="100000"/>
+              <a:buChar char="•"/>
+            </a:pPr>
+            <a:r>
+              <a:rPr lang="en-US" sz="1200" dirty="0">
+                <a:solidFill>
+                  <a:srgbClr val="333333"/>
+                </a:solidFill>
+              </a:rPr>
+              <a:t>Explains alternative paths</a:t>
+            </a:r>
+            <a:endParaRPr lang="en-US" sz="1200" dirty="0"/>
+          </a:p>
+        </p:txBody>
+      </p:sp>
+      <p:sp>
+        <p:nvSpPr>
+          <p:cNvPr id="15" name="Shape 13"/>
+          <p:cNvSpPr/>
+          <p:nvPr/>
+        </p:nvSpPr>
+        <p:spPr>
+          <a:xfrm>
+            <a:off x="2560320" y="2651760"/>
+            <a:ext cx="822960" cy="0"/>
+          </a:xfrm>
+          <a:prstGeom prst="line">
+            <a:avLst/>
+          </a:prstGeom>
+          <a:noFill/>
+          <a:ln w="19050">
+            <a:solidFill>
+              <a:srgbClr val="000000"/>
+            </a:solidFill>
+            <a:prstDash val="solid"/>
+            <a:tailEnd type="triangle"/>
+          </a:ln>
+        </p:spPr>
+      </p:sp>
+      <p:sp>
+        <p:nvSpPr>
+          <p:cNvPr id="16" name="Text 14"/>
+          <p:cNvSpPr/>
+          <p:nvPr/>
+        </p:nvSpPr>
+        <p:spPr>
+          <a:xfrm>
+            <a:off x="2514600" y="2148840"/>
+            <a:ext cx="914400" cy="457200"/>
+          </a:xfrm>
+          <a:prstGeom prst="rect">
+            <a:avLst/>
+          </a:prstGeom>
+          <a:noFill/>
+          <a:ln/>
+        </p:spPr>
+        <p:txBody>
+          <a:bodyPr wrap="square" lIns="0" tIns="0" rIns="0" bIns="0" rtlCol="0" anchor="b"/>
+          <a:lstStyle/>
+          <a:p>
+            <a:pPr algn="ctr" indent="0" marL="0">
+              <a:buNone/>
+            </a:pPr>
+            <a:r>
+              <a:rPr lang="en-US" sz="900" i="1" dirty="0">
                 <a:solidFill>
                   <a:srgbClr val="555555"/>
                 </a:solidFill>
               </a:rPr>
-              <a:t>I'll start a short live refactoring session. The tool will analyse it in the background while we walk through the methodology.</a:t>
-            </a:r>
-            <a:endParaRPr lang="en-US" sz="1800" dirty="0"/>
+              <a:t>events.jsonl + initial-src/</a:t>
+            </a:r>
+            <a:endParaRPr lang="en-US" sz="900" dirty="0"/>
+          </a:p>
+        </p:txBody>
+      </p:sp>
+      <p:sp>
+        <p:nvSpPr>
+          <p:cNvPr id="17" name="Shape 15"/>
+          <p:cNvSpPr/>
+          <p:nvPr/>
+        </p:nvSpPr>
+        <p:spPr>
+          <a:xfrm>
+            <a:off x="5760720" y="2651760"/>
+            <a:ext cx="822960" cy="0"/>
+          </a:xfrm>
+          <a:prstGeom prst="line">
+            <a:avLst/>
+          </a:prstGeom>
+          <a:noFill/>
+          <a:ln w="19050">
+            <a:solidFill>
+              <a:srgbClr val="000000"/>
+            </a:solidFill>
+            <a:prstDash val="solid"/>
+            <a:tailEnd type="triangle"/>
+          </a:ln>
+        </p:spPr>
+      </p:sp>
+      <p:sp>
+        <p:nvSpPr>
+          <p:cNvPr id="18" name="Text 16"/>
+          <p:cNvSpPr/>
+          <p:nvPr/>
+        </p:nvSpPr>
+        <p:spPr>
+          <a:xfrm>
+            <a:off x="5715000" y="2148840"/>
+            <a:ext cx="914400" cy="457200"/>
+          </a:xfrm>
+          <a:prstGeom prst="rect">
+            <a:avLst/>
+          </a:prstGeom>
+          <a:noFill/>
+          <a:ln/>
+        </p:spPr>
+        <p:txBody>
+          <a:bodyPr wrap="square" lIns="0" tIns="0" rIns="0" bIns="0" rtlCol="0" anchor="b"/>
+          <a:lstStyle/>
+          <a:p>
+            <a:pPr algn="ctr" indent="0" marL="0">
+              <a:buNone/>
+            </a:pPr>
+            <a:r>
+              <a:rPr lang="en-US" sz="900" i="1" dirty="0">
+                <a:solidFill>
+                  <a:srgbClr val="555555"/>
+                </a:solidFill>
+              </a:rPr>
+              <a:t>analysis</a:t>
+            </a:r>
+            <a:endParaRPr lang="en-US" sz="900" dirty="0"/>
+          </a:p>
+          <a:p>
+            <a:pPr algn="ctr" indent="0" marL="0">
+              <a:buNone/>
+            </a:pPr>
+            <a:r>
+              <a:rPr lang="en-US" sz="900" i="1" dirty="0">
+                <a:solidFill>
+                  <a:srgbClr val="555555"/>
+                </a:solidFill>
+              </a:rPr>
+              <a:t>-report.json</a:t>
+            </a:r>
+            <a:endParaRPr lang="en-US" sz="900" dirty="0"/>
           </a:p>
         </p:txBody>
       </p:sp>
@@ -6336,7 +6094,7 @@
                   <a:srgbClr val="000000"/>
                 </a:solidFill>
               </a:rPr>
-              <a:t>What the tool does, end to end</a:t>
+              <a:t>Four kinds of divergence</a:t>
             </a:r>
             <a:endParaRPr lang="en-US" sz="2800" dirty="0"/>
           </a:p>
@@ -6350,8 +6108,8 @@
         </p:nvSpPr>
         <p:spPr>
           <a:xfrm>
-            <a:off x="457200" y="1097280"/>
-            <a:ext cx="8229600" cy="1554480"/>
+            <a:off x="457200" y="1371600"/>
+            <a:ext cx="8229600" cy="3200400"/>
           </a:xfrm>
           <a:prstGeom prst="rect">
             <a:avLst/>
@@ -6365,620 +6123,130 @@
           <a:p>
             <a:pPr marL="342900" indent="-342900">
               <a:spcAft>
-                <a:spcPts val="600"/>
+                <a:spcPts val="1000"/>
               </a:spcAft>
               <a:buSzPct val="100000"/>
               <a:buChar char="•"/>
             </a:pPr>
             <a:r>
-              <a:rPr lang="en-US" sz="1600" dirty="0">
-                <a:solidFill>
-                  <a:srgbClr val="000000"/>
-                </a:solidFill>
-              </a:rPr>
-              <a:t>IntelliJ plugin: records every edit, refactoring, build, test, and commit during a session.</a:t>
-            </a:r>
-            <a:endParaRPr lang="en-US" sz="1600" dirty="0"/>
+              <a:rPr lang="en-US" sz="1800" dirty="0">
+                <a:solidFill>
+                  <a:srgbClr val="000000"/>
+                </a:solidFill>
+              </a:rPr>
+              <a:t>Ordering </a:t>
+            </a:r>
+            <a:pPr indent="0" marL="0">
+              <a:spcAft>
+                <a:spcPts val="1000"/>
+              </a:spcAft>
+              <a:buNone/>
+            </a:pPr>
+            <a:r>
+              <a:rPr lang="en-US" sz="1800" dirty="0">
+                <a:solidFill>
+                  <a:srgbClr val="888888"/>
+                </a:solidFill>
+              </a:rPr>
+              <a:t>- right refactorings, wrong sequence.</a:t>
+            </a:r>
+            <a:endParaRPr lang="en-US" sz="1800" dirty="0"/>
           </a:p>
           <a:p>
             <a:pPr marL="342900" indent="-342900">
               <a:spcAft>
-                <a:spcPts val="600"/>
+                <a:spcPts val="1000"/>
               </a:spcAft>
               <a:buSzPct val="100000"/>
               <a:buChar char="•"/>
             </a:pPr>
             <a:r>
-              <a:rPr lang="en-US" sz="1600" dirty="0">
-                <a:solidFill>
-                  <a:srgbClr val="000000"/>
-                </a:solidFill>
-              </a:rPr>
-              <a:t>Analysis backend: reconstructs the trajectory, scores it, and detects divergence points.</a:t>
-            </a:r>
-            <a:endParaRPr lang="en-US" sz="1600" dirty="0"/>
+              <a:rPr lang="en-US" sz="1800" dirty="0">
+                <a:solidFill>
+                  <a:srgbClr val="000000"/>
+                </a:solidFill>
+              </a:rPr>
+              <a:t>Manual-Refactor </a:t>
+            </a:r>
+            <a:pPr indent="0" marL="0">
+              <a:spcAft>
+                <a:spcPts val="1000"/>
+              </a:spcAft>
+              <a:buNone/>
+            </a:pPr>
+            <a:r>
+              <a:rPr lang="en-US" sz="1800" dirty="0">
+                <a:solidFill>
+                  <a:srgbClr val="888888"/>
+                </a:solidFill>
+              </a:rPr>
+              <a:t>- unnecessary risk (hand-edit when the IDE could have safely done it).</a:t>
+            </a:r>
+            <a:endParaRPr lang="en-US" sz="1800" dirty="0"/>
           </a:p>
           <a:p>
             <a:pPr marL="342900" indent="-342900">
               <a:spcAft>
-                <a:spcPts val="600"/>
+                <a:spcPts val="1000"/>
               </a:spcAft>
               <a:buSzPct val="100000"/>
               <a:buChar char="•"/>
             </a:pPr>
             <a:r>
-              <a:rPr lang="en-US" sz="1600" dirty="0">
-                <a:solidFill>
-                  <a:srgbClr val="000000"/>
-                </a:solidFill>
-              </a:rPr>
-              <a:t>Dashboard: surfaces where you diverged, an alternative path, how much better it scores, and why.</a:t>
-            </a:r>
-            <a:endParaRPr lang="en-US" sz="1600" dirty="0"/>
-          </a:p>
-        </p:txBody>
-      </p:sp>
-      <p:sp>
-        <p:nvSpPr>
-          <p:cNvPr id="4" name="Shape 2"/>
-          <p:cNvSpPr/>
-          <p:nvPr/>
-        </p:nvSpPr>
-        <p:spPr>
-          <a:xfrm>
-            <a:off x="182880" y="2788920"/>
-            <a:ext cx="2377440" cy="2103120"/>
-          </a:xfrm>
-          <a:prstGeom prst="rect">
-            <a:avLst/>
-          </a:prstGeom>
-          <a:solidFill>
-            <a:srgbClr val="FFFFFF"/>
-          </a:solidFill>
-          <a:ln w="12700">
-            <a:solidFill>
-              <a:srgbClr val="000000"/>
-            </a:solidFill>
-            <a:prstDash val="solid"/>
-          </a:ln>
-        </p:spPr>
-      </p:sp>
-      <p:sp>
-        <p:nvSpPr>
-          <p:cNvPr id="5" name="Text 3"/>
-          <p:cNvSpPr/>
-          <p:nvPr/>
-        </p:nvSpPr>
-        <p:spPr>
-          <a:xfrm>
-            <a:off x="274320" y="2971800"/>
-            <a:ext cx="2194560" cy="457200"/>
-          </a:xfrm>
-          <a:prstGeom prst="rect">
-            <a:avLst/>
-          </a:prstGeom>
-          <a:noFill/>
-          <a:ln/>
-        </p:spPr>
-        <p:txBody>
-          <a:bodyPr wrap="square" lIns="0" tIns="0" rIns="0" bIns="0" rtlCol="0" anchor="ctr"/>
-          <a:lstStyle/>
-          <a:p>
-            <a:pPr algn="ctr" indent="0" marL="0">
+              <a:rPr lang="en-US" sz="1800" dirty="0">
+                <a:solidFill>
+                  <a:srgbClr val="000000"/>
+                </a:solidFill>
+              </a:rPr>
+              <a:t>Rework </a:t>
+            </a:r>
+            <a:pPr indent="0" marL="0">
+              <a:spcAft>
+                <a:spcPts val="1000"/>
+              </a:spcAft>
               <a:buNone/>
             </a:pPr>
             <a:r>
-              <a:rPr lang="en-US" sz="1600" b="1" dirty="0">
-                <a:solidFill>
-                  <a:srgbClr val="000000"/>
-                </a:solidFill>
-              </a:rPr>
-              <a:t>IntelliJ Plugin</a:t>
-            </a:r>
-            <a:endParaRPr lang="en-US" sz="1600" dirty="0"/>
-          </a:p>
-        </p:txBody>
-      </p:sp>
-      <p:sp>
-        <p:nvSpPr>
-          <p:cNvPr id="6" name="Shape 4"/>
-          <p:cNvSpPr/>
-          <p:nvPr/>
-        </p:nvSpPr>
-        <p:spPr>
-          <a:xfrm>
-            <a:off x="457200" y="3520440"/>
-            <a:ext cx="1828800" cy="0"/>
-          </a:xfrm>
-          <a:prstGeom prst="line">
-            <a:avLst/>
-          </a:prstGeom>
-          <a:noFill/>
-          <a:ln w="9525">
-            <a:solidFill>
-              <a:srgbClr val="999999"/>
-            </a:solidFill>
-            <a:prstDash val="solid"/>
-          </a:ln>
-        </p:spPr>
-      </p:sp>
-      <p:sp>
-        <p:nvSpPr>
-          <p:cNvPr id="7" name="Text 5"/>
-          <p:cNvSpPr/>
-          <p:nvPr/>
-        </p:nvSpPr>
-        <p:spPr>
-          <a:xfrm>
-            <a:off x="411480" y="3703320"/>
-            <a:ext cx="2011680" cy="1097280"/>
-          </a:xfrm>
-          <a:prstGeom prst="rect">
-            <a:avLst/>
-          </a:prstGeom>
-          <a:noFill/>
-          <a:ln/>
-        </p:spPr>
-        <p:txBody>
-          <a:bodyPr wrap="square" rtlCol="0" anchor="t"/>
-          <a:lstStyle/>
+              <a:rPr lang="en-US" sz="1800" dirty="0">
+                <a:solidFill>
+                  <a:srgbClr val="888888"/>
+                </a:solidFill>
+              </a:rPr>
+              <a:t>- unnecessary churn (added then removed).</a:t>
+            </a:r>
+            <a:endParaRPr lang="en-US" sz="1800" dirty="0"/>
+          </a:p>
           <a:p>
             <a:pPr marL="342900" indent="-342900">
               <a:spcAft>
-                <a:spcPts val="800"/>
+                <a:spcPts val="1000"/>
               </a:spcAft>
               <a:buSzPct val="100000"/>
               <a:buChar char="•"/>
             </a:pPr>
             <a:r>
-              <a:rPr lang="en-US" sz="1200" dirty="0">
-                <a:solidFill>
-                  <a:srgbClr val="333333"/>
-                </a:solidFill>
-              </a:rPr>
-              <a:t>Records developer events</a:t>
-            </a:r>
-            <a:endParaRPr lang="en-US" sz="1200" dirty="0"/>
-          </a:p>
-          <a:p>
-            <a:pPr marL="342900" indent="-342900">
+              <a:rPr lang="en-US" sz="1800" dirty="0">
+                <a:solidFill>
+                  <a:srgbClr val="000000"/>
+                </a:solidFill>
+              </a:rPr>
+              <a:t>Hygiene </a:t>
+            </a:r>
+            <a:pPr indent="0" marL="0">
               <a:spcAft>
-                <a:spcPts val="800"/>
+                <a:spcPts val="1000"/>
               </a:spcAft>
-              <a:buSzPct val="100000"/>
-              <a:buChar char="•"/>
-            </a:pPr>
-            <a:r>
-              <a:rPr lang="en-US" sz="1200" dirty="0">
-                <a:solidFill>
-                  <a:srgbClr val="333333"/>
-                </a:solidFill>
-              </a:rPr>
-              <a:t>Captures initial codebase</a:t>
-            </a:r>
-            <a:endParaRPr lang="en-US" sz="1200" dirty="0"/>
-          </a:p>
-        </p:txBody>
-      </p:sp>
-      <p:sp>
-        <p:nvSpPr>
-          <p:cNvPr id="8" name="Shape 6"/>
-          <p:cNvSpPr/>
-          <p:nvPr/>
-        </p:nvSpPr>
-        <p:spPr>
-          <a:xfrm>
-            <a:off x="3383280" y="2788920"/>
-            <a:ext cx="2377440" cy="2103120"/>
-          </a:xfrm>
-          <a:prstGeom prst="rect">
-            <a:avLst/>
-          </a:prstGeom>
-          <a:solidFill>
-            <a:srgbClr val="FFFFFF"/>
-          </a:solidFill>
-          <a:ln w="12700">
-            <a:solidFill>
-              <a:srgbClr val="000000"/>
-            </a:solidFill>
-            <a:prstDash val="solid"/>
-          </a:ln>
-        </p:spPr>
-      </p:sp>
-      <p:sp>
-        <p:nvSpPr>
-          <p:cNvPr id="9" name="Text 7"/>
-          <p:cNvSpPr/>
-          <p:nvPr/>
-        </p:nvSpPr>
-        <p:spPr>
-          <a:xfrm>
-            <a:off x="3474720" y="2971800"/>
-            <a:ext cx="2194560" cy="457200"/>
-          </a:xfrm>
-          <a:prstGeom prst="rect">
-            <a:avLst/>
-          </a:prstGeom>
-          <a:noFill/>
-          <a:ln/>
-        </p:spPr>
-        <p:txBody>
-          <a:bodyPr wrap="square" lIns="0" tIns="0" rIns="0" bIns="0" rtlCol="0" anchor="ctr"/>
-          <a:lstStyle/>
-          <a:p>
-            <a:pPr algn="ctr" indent="0" marL="0">
               <a:buNone/>
             </a:pPr>
             <a:r>
-              <a:rPr lang="en-US" sz="1600" b="1" dirty="0">
-                <a:solidFill>
-                  <a:srgbClr val="000000"/>
-                </a:solidFill>
-              </a:rPr>
-              <a:t>Analysis Backend</a:t>
-            </a:r>
-            <a:endParaRPr lang="en-US" sz="1600" dirty="0"/>
-          </a:p>
-        </p:txBody>
-      </p:sp>
-      <p:sp>
-        <p:nvSpPr>
-          <p:cNvPr id="10" name="Shape 8"/>
-          <p:cNvSpPr/>
-          <p:nvPr/>
-        </p:nvSpPr>
-        <p:spPr>
-          <a:xfrm>
-            <a:off x="3657600" y="3520440"/>
-            <a:ext cx="1828800" cy="0"/>
-          </a:xfrm>
-          <a:prstGeom prst="line">
-            <a:avLst/>
-          </a:prstGeom>
-          <a:noFill/>
-          <a:ln w="9525">
-            <a:solidFill>
-              <a:srgbClr val="999999"/>
-            </a:solidFill>
-            <a:prstDash val="solid"/>
-          </a:ln>
-        </p:spPr>
-      </p:sp>
-      <p:sp>
-        <p:nvSpPr>
-          <p:cNvPr id="11" name="Text 9"/>
-          <p:cNvSpPr/>
-          <p:nvPr/>
-        </p:nvSpPr>
-        <p:spPr>
-          <a:xfrm>
-            <a:off x="3611880" y="3703320"/>
-            <a:ext cx="2011680" cy="1097280"/>
-          </a:xfrm>
-          <a:prstGeom prst="rect">
-            <a:avLst/>
-          </a:prstGeom>
-          <a:noFill/>
-          <a:ln/>
-        </p:spPr>
-        <p:txBody>
-          <a:bodyPr wrap="square" rtlCol="0" anchor="t"/>
-          <a:lstStyle/>
-          <a:p>
-            <a:pPr marL="342900" indent="-342900">
-              <a:spcAft>
-                <a:spcPts val="800"/>
-              </a:spcAft>
-              <a:buSzPct val="100000"/>
-              <a:buChar char="•"/>
-            </a:pPr>
-            <a:r>
-              <a:rPr lang="en-US" sz="1200" dirty="0">
-                <a:solidFill>
-                  <a:srgbClr val="333333"/>
-                </a:solidFill>
-              </a:rPr>
-              <a:t>Shadow repo reconstruction</a:t>
-            </a:r>
-            <a:endParaRPr lang="en-US" sz="1200" dirty="0"/>
-          </a:p>
-          <a:p>
-            <a:pPr marL="342900" indent="-342900">
-              <a:spcAft>
-                <a:spcPts val="800"/>
-              </a:spcAft>
-              <a:buSzPct val="100000"/>
-              <a:buChar char="•"/>
-            </a:pPr>
-            <a:r>
-              <a:rPr lang="en-US" sz="1200" dirty="0">
-                <a:solidFill>
-                  <a:srgbClr val="333333"/>
-                </a:solidFill>
-              </a:rPr>
-              <a:t>Metric calculation</a:t>
-            </a:r>
-            <a:endParaRPr lang="en-US" sz="1200" dirty="0"/>
-          </a:p>
-          <a:p>
-            <a:pPr marL="342900" indent="-342900">
-              <a:spcAft>
-                <a:spcPts val="800"/>
-              </a:spcAft>
-              <a:buSzPct val="100000"/>
-              <a:buChar char="•"/>
-            </a:pPr>
-            <a:r>
-              <a:rPr lang="en-US" sz="1200" dirty="0">
-                <a:solidFill>
-                  <a:srgbClr val="333333"/>
-                </a:solidFill>
-              </a:rPr>
-              <a:t>Divergence synthesis</a:t>
-            </a:r>
-            <a:endParaRPr lang="en-US" sz="1200" dirty="0"/>
-          </a:p>
-        </p:txBody>
-      </p:sp>
-      <p:sp>
-        <p:nvSpPr>
-          <p:cNvPr id="12" name="Shape 10"/>
-          <p:cNvSpPr/>
-          <p:nvPr/>
-        </p:nvSpPr>
-        <p:spPr>
-          <a:xfrm>
-            <a:off x="6583680" y="2788920"/>
-            <a:ext cx="2377440" cy="2103120"/>
-          </a:xfrm>
-          <a:prstGeom prst="rect">
-            <a:avLst/>
-          </a:prstGeom>
-          <a:solidFill>
-            <a:srgbClr val="FFFFFF"/>
-          </a:solidFill>
-          <a:ln w="12700">
-            <a:solidFill>
-              <a:srgbClr val="000000"/>
-            </a:solidFill>
-            <a:prstDash val="solid"/>
-          </a:ln>
-        </p:spPr>
-      </p:sp>
-      <p:sp>
-        <p:nvSpPr>
-          <p:cNvPr id="13" name="Text 11"/>
-          <p:cNvSpPr/>
-          <p:nvPr/>
-        </p:nvSpPr>
-        <p:spPr>
-          <a:xfrm>
-            <a:off x="6675120" y="2971800"/>
-            <a:ext cx="2194560" cy="457200"/>
-          </a:xfrm>
-          <a:prstGeom prst="rect">
-            <a:avLst/>
-          </a:prstGeom>
-          <a:noFill/>
-          <a:ln/>
-        </p:spPr>
-        <p:txBody>
-          <a:bodyPr wrap="square" lIns="0" tIns="0" rIns="0" bIns="0" rtlCol="0" anchor="ctr"/>
-          <a:lstStyle/>
-          <a:p>
-            <a:pPr algn="ctr" indent="0" marL="0">
-              <a:buNone/>
-            </a:pPr>
-            <a:r>
-              <a:rPr lang="en-US" sz="1600" b="1" dirty="0">
-                <a:solidFill>
-                  <a:srgbClr val="000000"/>
-                </a:solidFill>
-              </a:rPr>
-              <a:t>Dashboard</a:t>
-            </a:r>
-            <a:endParaRPr lang="en-US" sz="1600" dirty="0"/>
-          </a:p>
-        </p:txBody>
-      </p:sp>
-      <p:sp>
-        <p:nvSpPr>
-          <p:cNvPr id="14" name="Shape 12"/>
-          <p:cNvSpPr/>
-          <p:nvPr/>
-        </p:nvSpPr>
-        <p:spPr>
-          <a:xfrm>
-            <a:off x="6858000" y="3520440"/>
-            <a:ext cx="1828800" cy="0"/>
-          </a:xfrm>
-          <a:prstGeom prst="line">
-            <a:avLst/>
-          </a:prstGeom>
-          <a:noFill/>
-          <a:ln w="9525">
-            <a:solidFill>
-              <a:srgbClr val="999999"/>
-            </a:solidFill>
-            <a:prstDash val="solid"/>
-          </a:ln>
-        </p:spPr>
-      </p:sp>
-      <p:sp>
-        <p:nvSpPr>
-          <p:cNvPr id="15" name="Text 13"/>
-          <p:cNvSpPr/>
-          <p:nvPr/>
-        </p:nvSpPr>
-        <p:spPr>
-          <a:xfrm>
-            <a:off x="6812280" y="3703320"/>
-            <a:ext cx="2011680" cy="1097280"/>
-          </a:xfrm>
-          <a:prstGeom prst="rect">
-            <a:avLst/>
-          </a:prstGeom>
-          <a:noFill/>
-          <a:ln/>
-        </p:spPr>
-        <p:txBody>
-          <a:bodyPr wrap="square" rtlCol="0" anchor="t"/>
-          <a:lstStyle/>
-          <a:p>
-            <a:pPr marL="342900" indent="-342900">
-              <a:spcAft>
-                <a:spcPts val="800"/>
-              </a:spcAft>
-              <a:buSzPct val="100000"/>
-              <a:buChar char="•"/>
-            </a:pPr>
-            <a:r>
-              <a:rPr lang="en-US" sz="1200" dirty="0">
-                <a:solidFill>
-                  <a:srgbClr val="333333"/>
-                </a:solidFill>
-              </a:rPr>
-              <a:t>Surfaces divergence points in context</a:t>
-            </a:r>
-            <a:endParaRPr lang="en-US" sz="1200" dirty="0"/>
-          </a:p>
-          <a:p>
-            <a:pPr marL="342900" indent="-342900">
-              <a:spcAft>
-                <a:spcPts val="800"/>
-              </a:spcAft>
-              <a:buSzPct val="100000"/>
-              <a:buChar char="•"/>
-            </a:pPr>
-            <a:r>
-              <a:rPr lang="en-US" sz="1200" dirty="0">
-                <a:solidFill>
-                  <a:srgbClr val="333333"/>
-                </a:solidFill>
-              </a:rPr>
-              <a:t>Explains alternative paths</a:t>
-            </a:r>
-            <a:endParaRPr lang="en-US" sz="1200" dirty="0"/>
-          </a:p>
-        </p:txBody>
-      </p:sp>
-      <p:sp>
-        <p:nvSpPr>
-          <p:cNvPr id="16" name="Shape 14"/>
-          <p:cNvSpPr/>
-          <p:nvPr/>
-        </p:nvSpPr>
-        <p:spPr>
-          <a:xfrm>
-            <a:off x="2560320" y="3840480"/>
-            <a:ext cx="822960" cy="0"/>
-          </a:xfrm>
-          <a:prstGeom prst="line">
-            <a:avLst/>
-          </a:prstGeom>
-          <a:noFill/>
-          <a:ln w="19050">
-            <a:solidFill>
-              <a:srgbClr val="000000"/>
-            </a:solidFill>
-            <a:prstDash val="solid"/>
-            <a:tailEnd type="triangle"/>
-          </a:ln>
-        </p:spPr>
-      </p:sp>
-      <p:sp>
-        <p:nvSpPr>
-          <p:cNvPr id="17" name="Text 15"/>
-          <p:cNvSpPr/>
-          <p:nvPr/>
-        </p:nvSpPr>
-        <p:spPr>
-          <a:xfrm>
-            <a:off x="2514600" y="3520440"/>
-            <a:ext cx="914400" cy="274320"/>
-          </a:xfrm>
-          <a:prstGeom prst="rect">
-            <a:avLst/>
-          </a:prstGeom>
-          <a:noFill/>
-          <a:ln/>
-        </p:spPr>
-        <p:txBody>
-          <a:bodyPr wrap="square" lIns="0" tIns="0" rIns="0" bIns="0" rtlCol="0" anchor="ctr"/>
-          <a:lstStyle/>
-          <a:p>
-            <a:pPr algn="ctr" indent="0" marL="0">
-              <a:buNone/>
-            </a:pPr>
-            <a:r>
-              <a:rPr lang="en-US" sz="900" i="1" dirty="0">
-                <a:solidFill>
-                  <a:srgbClr val="555555"/>
-                </a:solidFill>
-              </a:rPr>
-              <a:t>events.jsonl + initial-src/</a:t>
-            </a:r>
-            <a:endParaRPr lang="en-US" sz="900" dirty="0"/>
-          </a:p>
-        </p:txBody>
-      </p:sp>
-      <p:sp>
-        <p:nvSpPr>
-          <p:cNvPr id="18" name="Shape 16"/>
-          <p:cNvSpPr/>
-          <p:nvPr/>
-        </p:nvSpPr>
-        <p:spPr>
-          <a:xfrm>
-            <a:off x="5760720" y="3840480"/>
-            <a:ext cx="822960" cy="0"/>
-          </a:xfrm>
-          <a:prstGeom prst="line">
-            <a:avLst/>
-          </a:prstGeom>
-          <a:noFill/>
-          <a:ln w="19050">
-            <a:solidFill>
-              <a:srgbClr val="000000"/>
-            </a:solidFill>
-            <a:prstDash val="solid"/>
-            <a:tailEnd type="triangle"/>
-          </a:ln>
-        </p:spPr>
-      </p:sp>
-      <p:sp>
-        <p:nvSpPr>
-          <p:cNvPr id="19" name="Text 17"/>
-          <p:cNvSpPr/>
-          <p:nvPr/>
-        </p:nvSpPr>
-        <p:spPr>
-          <a:xfrm>
-            <a:off x="5715000" y="3520440"/>
-            <a:ext cx="914400" cy="274320"/>
-          </a:xfrm>
-          <a:prstGeom prst="rect">
-            <a:avLst/>
-          </a:prstGeom>
-          <a:noFill/>
-          <a:ln/>
-        </p:spPr>
-        <p:txBody>
-          <a:bodyPr wrap="square" lIns="0" tIns="0" rIns="0" bIns="0" rtlCol="0" anchor="ctr"/>
-          <a:lstStyle/>
-          <a:p>
-            <a:pPr algn="ctr" indent="0" marL="0">
-              <a:buNone/>
-            </a:pPr>
-            <a:r>
-              <a:rPr lang="en-US" sz="900" i="1" dirty="0">
-                <a:solidFill>
-                  <a:srgbClr val="555555"/>
-                </a:solidFill>
-              </a:rPr>
-              <a:t>analysis-report.json</a:t>
-            </a:r>
-            <a:endParaRPr lang="en-US" sz="900" dirty="0"/>
+              <a:rPr lang="en-US" sz="1800" dirty="0">
+                <a:solidFill>
+                  <a:srgbClr val="888888"/>
+                </a:solidFill>
+              </a:rPr>
+              <a:t>- missing safety checkpoints (no tests, no commits).</a:t>
+            </a:r>
+            <a:endParaRPr lang="en-US" sz="1800" dirty="0"/>
           </a:p>
         </p:txBody>
       </p:sp>
@@ -7228,14 +6496,14 @@
                         <a:buNone/>
                       </a:pPr>
                       <a:r>
-                        <a:rPr lang="en-US" sz="1600" dirty="0">
+                        <a:rPr lang="en-US" sz="1800" dirty="0">
                           <a:solidFill>
                             <a:srgbClr val="1A1A1A"/>
                           </a:solidFill>
                         </a:rPr>
                         <a:t>cleanliness gain</a:t>
                       </a:r>
-                      <a:endParaRPr lang="en-US" sz="1600" dirty="0"/>
+                      <a:endParaRPr lang="en-US" sz="1800" dirty="0"/>
                     </a:p>
                   </a:txBody>
                   <a:tcPr marL="54864" marR="54864" marT="54864" marB="54864" anchor="ctr">
@@ -7332,14 +6600,14 @@
                         <a:buNone/>
                       </a:pPr>
                       <a:r>
-                        <a:rPr lang="en-US" sz="1600" dirty="0">
+                        <a:rPr lang="en-US" sz="1800" dirty="0">
                           <a:solidFill>
                             <a:srgbClr val="1A1A1A"/>
                           </a:solidFill>
                         </a:rPr>
                         <a:t>step-savings bonus</a:t>
                       </a:r>
-                      <a:endParaRPr lang="en-US" sz="1600" dirty="0"/>
+                      <a:endParaRPr lang="en-US" sz="1800" dirty="0"/>
                     </a:p>
                   </a:txBody>
                   <a:tcPr marL="54864" marR="54864" marT="54864" marB="54864" anchor="ctr">
@@ -7436,14 +6704,14 @@
                         <a:buNone/>
                       </a:pPr>
                       <a:r>
-                        <a:rPr lang="en-US" sz="1600" dirty="0">
+                        <a:rPr lang="en-US" sz="1800" dirty="0">
                           <a:solidFill>
                             <a:srgbClr val="1A1A1A"/>
                           </a:solidFill>
                         </a:rPr>
                         <a:t>broken build / test rate</a:t>
                       </a:r>
-                      <a:endParaRPr lang="en-US" sz="1600" dirty="0"/>
+                      <a:endParaRPr lang="en-US" sz="1800" dirty="0"/>
                     </a:p>
                   </a:txBody>
                   <a:tcPr marL="54864" marR="54864" marT="54864" marB="54864" anchor="ctr">
@@ -7540,14 +6808,14 @@
                         <a:buNone/>
                       </a:pPr>
                       <a:r>
-                        <a:rPr lang="en-US" sz="1600" dirty="0">
+                        <a:rPr lang="en-US" sz="1800" dirty="0">
                           <a:solidFill>
                             <a:srgbClr val="1A1A1A"/>
                           </a:solidFill>
                         </a:rPr>
                         <a:t>skipped-test rate</a:t>
                       </a:r>
-                      <a:endParaRPr lang="en-US" sz="1600" dirty="0"/>
+                      <a:endParaRPr lang="en-US" sz="1800" dirty="0"/>
                     </a:p>
                   </a:txBody>
                   <a:tcPr marL="54864" marR="54864" marT="54864" marB="54864" anchor="ctr">
@@ -7644,14 +6912,14 @@
                         <a:buNone/>
                       </a:pPr>
                       <a:r>
-                        <a:rPr lang="en-US" sz="1600" dirty="0">
+                        <a:rPr lang="en-US" sz="1800" dirty="0">
                           <a:solidFill>
                             <a:srgbClr val="1A1A1A"/>
                           </a:solidFill>
                         </a:rPr>
                         <a:t>manual edits the IDE could refactor</a:t>
                       </a:r>
-                      <a:endParaRPr lang="en-US" sz="1600" dirty="0"/>
+                      <a:endParaRPr lang="en-US" sz="1800" dirty="0"/>
                     </a:p>
                   </a:txBody>
                   <a:tcPr marL="54864" marR="54864" marT="54864" marB="54864" anchor="ctr">
@@ -7748,14 +7016,14 @@
                         <a:buNone/>
                       </a:pPr>
                       <a:r>
-                        <a:rPr lang="en-US" sz="1600" dirty="0">
+                        <a:rPr lang="en-US" sz="1800" dirty="0">
                           <a:solidFill>
                             <a:srgbClr val="1A1A1A"/>
                           </a:solidFill>
                         </a:rPr>
-                        <a:t>intermediate-state lag</a:t>
+                        <a:t>Intermediate cleanliness lag (degradation)</a:t>
                       </a:r>
-                      <a:endParaRPr lang="en-US" sz="1600" dirty="0"/>
+                      <a:endParaRPr lang="en-US" sz="1800" dirty="0"/>
                     </a:p>
                   </a:txBody>
                   <a:tcPr marL="54864" marR="54864" marT="54864" marB="54864" anchor="ctr">
@@ -7852,14 +7120,14 @@
                         <a:buNone/>
                       </a:pPr>
                       <a:r>
-                        <a:rPr lang="en-US" sz="1600" dirty="0">
+                        <a:rPr lang="en-US" sz="1800" dirty="0">
                           <a:solidFill>
                             <a:srgbClr val="1A1A1A"/>
                           </a:solidFill>
                         </a:rPr>
-                        <a:t>commit-gap events</a:t>
+                        <a:t>Long durations without commits</a:t>
                       </a:r>
-                      <a:endParaRPr lang="en-US" sz="1600" dirty="0"/>
+                      <a:endParaRPr lang="en-US" sz="1800" dirty="0"/>
                     </a:p>
                   </a:txBody>
                   <a:tcPr marL="54864" marR="54864" marT="54864" marB="54864" anchor="ctr">
@@ -7927,7 +7195,7 @@
 </file>
 
 <file path=ppt/slides/slide9.xml><?xml version="1.0" encoding="utf-8"?>
-<p:sld xmlns:a="http://schemas.openxmlformats.org/drawingml/2006/main" xmlns:r="http://schemas.openxmlformats.org/officeDocument/2006/relationships" xmlns:p="http://schemas.openxmlformats.org/presentationml/2006/main">
+<p:sld xmlns:a="http://schemas.openxmlformats.org/drawingml/2006/main" xmlns:r="http://schemas.openxmlformats.org/officeDocument/2006/relationships" xmlns:p="http://schemas.openxmlformats.org/presentationml/2006/main" show="0">
   <p:cSld name="Slide 9">
     <p:spTree>
       <p:nvGrpSpPr>

</xml_diff>

<commit_message>
feat: improve the scoring trajectory slide
</commit_message>
<xml_diff>
--- a/presentation/slides.pptx
+++ b/presentation/slides.pptx
@@ -6283,7 +6283,7 @@
         </p:nvSpPr>
         <p:spPr>
           <a:xfrm>
-            <a:off x="457200" y="274320"/>
+            <a:off x="457200" y="137160"/>
             <a:ext cx="8229600" cy="640080"/>
           </a:xfrm>
           <a:prstGeom prst="rect">
@@ -6319,8 +6319,8 @@
         </p:nvSpPr>
         <p:spPr>
           <a:xfrm>
-            <a:off x="457200" y="1143000"/>
-            <a:ext cx="8229600" cy="548640"/>
+            <a:off x="457200" y="841248"/>
+            <a:ext cx="8229600" cy="411480"/>
           </a:xfrm>
           <a:prstGeom prst="rect">
             <a:avLst/>
@@ -6406,7 +6406,7 @@
           </p:nvPr>
         </p:nvGraphicFramePr>
         <p:xfrm>
-          <a:off x="2377440" y="1874520"/>
+          <a:off x="2377440" y="1280160"/>
           <a:ext cx="4389120" cy="914400"/>
         </p:xfrm>
         <a:graphic>
@@ -6418,7 +6418,7 @@
                 <a:gridCol w="365760"/>
                 <a:gridCol w="3291840"/>
               </a:tblGrid>
-              <a:tr h="310896">
+              <a:tr h="292608">
                 <a:tc>
                   <a:txBody>
                     <a:bodyPr/>
@@ -6501,7 +6501,7 @@
                             <a:srgbClr val="1A1A1A"/>
                           </a:solidFill>
                         </a:rPr>
-                        <a:t>cleanliness gain</a:t>
+                        <a:t>cleanliness gain*</a:t>
                       </a:r>
                       <a:endParaRPr lang="en-US" sz="1800" dirty="0"/>
                     </a:p>
@@ -6522,7 +6522,7 @@
                   </a:tcPr>
                 </a:tc>
               </a:tr>
-              <a:tr h="310896">
+              <a:tr h="292608">
                 <a:tc>
                   <a:txBody>
                     <a:bodyPr/>
@@ -6626,7 +6626,7 @@
                   </a:tcPr>
                 </a:tc>
               </a:tr>
-              <a:tr h="310896">
+              <a:tr h="292608">
                 <a:tc>
                   <a:txBody>
                     <a:bodyPr/>
@@ -6730,7 +6730,7 @@
                   </a:tcPr>
                 </a:tc>
               </a:tr>
-              <a:tr h="310896">
+              <a:tr h="292608">
                 <a:tc>
                   <a:txBody>
                     <a:bodyPr/>
@@ -6834,7 +6834,7 @@
                   </a:tcPr>
                 </a:tc>
               </a:tr>
-              <a:tr h="310896">
+              <a:tr h="292608">
                 <a:tc>
                   <a:txBody>
                     <a:bodyPr/>
@@ -6938,7 +6938,7 @@
                   </a:tcPr>
                 </a:tc>
               </a:tr>
-              <a:tr h="310896">
+              <a:tr h="292608">
                 <a:tc>
                   <a:txBody>
                     <a:bodyPr/>
@@ -7042,7 +7042,7 @@
                   </a:tcPr>
                 </a:tc>
               </a:tr>
-              <a:tr h="310896">
+              <a:tr h="292608">
                 <a:tc>
                   <a:txBody>
                     <a:bodyPr/>
@@ -7158,8 +7158,8 @@
         </p:nvSpPr>
         <p:spPr>
           <a:xfrm>
-            <a:off x="457200" y="4160520"/>
-            <a:ext cx="8229600" cy="457200"/>
+            <a:off x="457200" y="3749040"/>
+            <a:ext cx="8229600" cy="411480"/>
           </a:xfrm>
           <a:prstGeom prst="rect">
             <a:avLst/>
@@ -7183,6 +7183,56 @@
               <a:t>)</a:t>
             </a:r>
             <a:endParaRPr lang="en-US" sz="2200" dirty="0"/>
+          </a:p>
+        </p:txBody>
+      </p:sp>
+      <p:sp>
+        <p:nvSpPr>
+          <p:cNvPr id="6" name="Text 3"/>
+          <p:cNvSpPr/>
+          <p:nvPr/>
+        </p:nvSpPr>
+        <p:spPr>
+          <a:xfrm>
+            <a:off x="457200" y="4526280"/>
+            <a:ext cx="8229600" cy="548640"/>
+          </a:xfrm>
+          <a:prstGeom prst="rect">
+            <a:avLst/>
+          </a:prstGeom>
+          <a:noFill/>
+          <a:ln/>
+        </p:spPr>
+        <p:txBody>
+          <a:bodyPr wrap="square" lIns="0" tIns="0" rIns="0" bIns="0" rtlCol="0" anchor="ctr"/>
+          <a:lstStyle/>
+          <a:p>
+            <a:pPr algn="ctr" indent="0" marL="0">
+              <a:buNone/>
+            </a:pPr>
+            <a:r>
+              <a:rPr lang="en-US" sz="1100" i="1" dirty="0">
+                <a:solidFill>
+                  <a:srgbClr val="777777"/>
+                </a:solidFill>
+              </a:rPr>
+              <a:t>* cleanliness gain = mean of 6 normalised signals: complexity, coupling, duplication, readability, smells, cohesion.</a:t>
+            </a:r>
+            <a:endParaRPr lang="en-US" sz="1100" dirty="0"/>
+          </a:p>
+          <a:p>
+            <a:pPr algn="ctr" indent="0" marL="0">
+              <a:buNone/>
+            </a:pPr>
+            <a:r>
+              <a:rPr lang="en-US" sz="1100" i="1" dirty="0">
+                <a:solidFill>
+                  <a:srgbClr val="777777"/>
+                </a:solidFill>
+              </a:rPr>
+              <a:t>All 6 weighted equally - no trajectory-level calibration data exists, so equal weights are the least-assumptive choice.</a:t>
+            </a:r>
+            <a:endParaRPr lang="en-US" sz="1100" dirty="0"/>
           </a:p>
         </p:txBody>
       </p:sp>

</xml_diff>

<commit_message>
feat: add the accuracy metrics stuff
</commit_message>
<xml_diff>
--- a/presentation/slides.pptx
+++ b/presentation/slides.pptx
@@ -24,9 +24,10 @@
     <p:sldId id="272" r:id="rId18"/>
     <p:sldId id="273" r:id="rId19"/>
     <p:sldId id="274" r:id="rId20"/>
+    <p:sldId id="275" r:id="rId21"/>
   </p:sldIdLst>
   <p:notesMasterIdLst>
-    <p:notesMasterId r:id="rId21"/>
+    <p:notesMasterId r:id="rId22"/>
   </p:notesMasterIdLst>
   <p:sldSz cx="9144000" cy="5143500"/>
   <p:notesSz cx="5143500" cy="9144000"/>
@@ -1512,6 +1513,94 @@
             <a:fld id="{F7021451-1387-4CA6-816F-3879F97B5CBC}" type="slidenum">
               <a:rPr lang="en-US"/>
               <a:t>2</a:t>
+            </a:fld>
+            <a:endParaRPr lang="en-US"/>
+          </a:p>
+        </p:txBody>
+      </p:sp>
+    </p:spTree>
+    <p:extLst>
+      <p:ext uri="{BB962C8B-B14F-4D97-AF65-F5344CB8AC3E}">
+        <p14:creationId xmlns:p14="http://schemas.microsoft.com/office/powerpoint/2010/main" val="1024086991"/>
+      </p:ext>
+    </p:extLst>
+  </p:cSld>
+  <p:clrMapOvr>
+    <a:masterClrMapping/>
+  </p:clrMapOvr>
+</p:notes>
+</file>
+
+<file path=ppt/notesSlides/notesSlide20.xml><?xml version="1.0" encoding="utf-8"?>
+<p:notes xmlns:a="http://schemas.openxmlformats.org/drawingml/2006/main" xmlns:r="http://schemas.openxmlformats.org/officeDocument/2006/relationships" xmlns:p="http://schemas.openxmlformats.org/presentationml/2006/main">
+  <p:cSld>
+    <p:spTree>
+      <p:nvGrpSpPr>
+        <p:cNvPr id="1" name=""/>
+        <p:cNvGrpSpPr/>
+        <p:nvPr/>
+      </p:nvGrpSpPr>
+      <p:grpSpPr>
+        <a:xfrm>
+          <a:off x="0" y="0"/>
+          <a:ext cx="0" cy="0"/>
+          <a:chOff x="0" y="0"/>
+          <a:chExt cx="0" cy="0"/>
+        </a:xfrm>
+      </p:grpSpPr>
+      <p:sp>
+        <p:nvSpPr>
+          <p:cNvPr id="2" name="Slide Image Placeholder 1"/>
+          <p:cNvSpPr>
+            <a:spLocks noGrp="1" noRot="1" noChangeAspect="1"/>
+          </p:cNvSpPr>
+          <p:nvPr>
+            <p:ph type="sldImg"/>
+          </p:nvPr>
+        </p:nvSpPr>
+        <p:spPr/>
+      </p:sp>
+      <p:sp>
+        <p:nvSpPr>
+          <p:cNvPr id="3" name="Notes Placeholder 2"/>
+          <p:cNvSpPr>
+            <a:spLocks noGrp="1"/>
+          </p:cNvSpPr>
+          <p:nvPr>
+            <p:ph type="body" idx="1"/>
+          </p:nvPr>
+        </p:nvSpPr>
+        <p:spPr/>
+        <p:txBody>
+          <a:bodyPr/>
+          <a:lstStyle/>
+          <a:p>
+            <a:r>
+              <a:rPr lang="en-US" dirty="0"/>
+              <a:t/>
+            </a:r>
+            <a:endParaRPr lang="en-US" dirty="0"/>
+          </a:p>
+        </p:txBody>
+      </p:sp>
+      <p:sp>
+        <p:nvSpPr>
+          <p:cNvPr id="4" name="Slide Number Placeholder 3"/>
+          <p:cNvSpPr>
+            <a:spLocks noGrp="1"/>
+          </p:cNvSpPr>
+          <p:nvPr>
+            <p:ph type="sldNum" sz="quarter" idx="10"/>
+          </p:nvPr>
+        </p:nvSpPr>
+        <p:spPr/>
+        <p:txBody>
+          <a:bodyPr/>
+          <a:lstStyle/>
+          <a:p>
+            <a:fld id="{F7021451-1387-4CA6-816F-3879F97B5CBC}" type="slidenum">
+              <a:rPr lang="en-US"/>
+              <a:t>20</a:t>
             </a:fld>
             <a:endParaRPr lang="en-US"/>
           </a:p>
@@ -4135,7 +4224,7 @@
                   <a:srgbClr val="000000"/>
                 </a:solidFill>
               </a:rPr>
-              <a:t>Detector precision &amp; recall</a:t>
+              <a:t>Is the tool accurate?</a:t>
             </a:r>
             <a:endParaRPr lang="en-US" sz="2800" dirty="0"/>
           </a:p>
@@ -4164,74 +4253,162 @@
           <a:p>
             <a:pPr marL="342900" indent="-342900">
               <a:spcAft>
-                <a:spcPts val="600"/>
+                <a:spcPts val="1000"/>
               </a:spcAft>
               <a:buSzPct val="100000"/>
               <a:buChar char="•"/>
             </a:pPr>
             <a:r>
-              <a:rPr lang="en-US" sz="1600" dirty="0">
+              <a:rPr lang="en-US" sz="1500" dirty="0">
                 <a:solidFill>
                   <a:srgbClr val="000000"/>
                 </a:solidFill>
               </a:rPr>
-              <a:t>Precision = 1.00 across all four divergence kinds - every detection is valid.</a:t>
-            </a:r>
-            <a:endParaRPr lang="en-US" sz="1600" dirty="0"/>
+              <a:t>45 hand-labelled injection sessions </a:t>
+            </a:r>
+            <a:pPr indent="0" marL="0">
+              <a:spcAft>
+                <a:spcPts val="1000"/>
+              </a:spcAft>
+              <a:buNone/>
+            </a:pPr>
+            <a:r>
+              <a:rPr lang="en-US" sz="1500" dirty="0">
+                <a:solidFill>
+                  <a:srgbClr val="888888"/>
+                </a:solidFill>
+              </a:rPr>
+              <a:t>- on a Java codebase.</a:t>
+            </a:r>
+            <a:endParaRPr lang="en-US" sz="1500" dirty="0"/>
           </a:p>
           <a:p>
             <a:pPr marL="342900" indent="-342900">
               <a:spcAft>
-                <a:spcPts val="600"/>
+                <a:spcPts val="1000"/>
               </a:spcAft>
               <a:buSzPct val="100000"/>
               <a:buChar char="•"/>
             </a:pPr>
             <a:r>
-              <a:rPr lang="en-US" sz="1600" dirty="0">
+              <a:rPr lang="en-US" sz="1500" dirty="0">
                 <a:solidFill>
                   <a:srgbClr val="000000"/>
                 </a:solidFill>
               </a:rPr>
-              <a:t>Recall - Rework 1.00, Hygiene 1.00, Manual-Refactor 0.76, Ordering 0.40.</a:t>
-            </a:r>
-            <a:endParaRPr lang="en-US" sz="1600" dirty="0"/>
+              <a:t>3 raters (author + 2 external MEng cohort members) </a:t>
+            </a:r>
+            <a:pPr indent="0" marL="0">
+              <a:spcAft>
+                <a:spcPts val="1000"/>
+              </a:spcAft>
+              <a:buNone/>
+            </a:pPr>
+            <a:r>
+              <a:rPr lang="en-US" sz="1500" dirty="0">
+                <a:solidFill>
+                  <a:srgbClr val="888888"/>
+                </a:solidFill>
+              </a:rPr>
+              <a:t>- inter-rater Cohen's κ = 1.00 (Ordering, Manual-Refactor), 0.86–1.00 (Rework), 0.72–0.86 (Hygiene).</a:t>
+            </a:r>
+            <a:endParaRPr lang="en-US" sz="1500" dirty="0"/>
           </a:p>
           <a:p>
             <a:pPr marL="342900" indent="-342900">
               <a:spcAft>
-                <a:spcPts val="600"/>
+                <a:spcPts val="1000"/>
               </a:spcAft>
               <a:buSzPct val="100000"/>
               <a:buChar char="•"/>
             </a:pPr>
             <a:r>
-              <a:rPr lang="en-US" sz="1600" dirty="0">
+              <a:rPr lang="en-US" sz="1500" dirty="0">
                 <a:solidFill>
                   <a:srgbClr val="000000"/>
                 </a:solidFill>
               </a:rPr>
-              <a:t>Inter-rater agreement (Cohen's κ) -1.00 for Ordering and Manual-Refactor, 0.86 for Rework, 0.72 for Hygiene.</a:t>
-            </a:r>
-            <a:endParaRPr lang="en-US" sz="1600" dirty="0"/>
+              <a:t>Disagreements predominantly surrounding hygiene + rework labels </a:t>
+            </a:r>
+            <a:pPr indent="0" marL="0">
+              <a:spcAft>
+                <a:spcPts val="1000"/>
+              </a:spcAft>
+              <a:buNone/>
+            </a:pPr>
+            <a:r>
+              <a:rPr lang="en-US" sz="1500" dirty="0">
+                <a:solidFill>
+                  <a:srgbClr val="888888"/>
+                </a:solidFill>
+              </a:rPr>
+              <a:t>- differences in opinion of what constitutes a step.</a:t>
+            </a:r>
+            <a:endParaRPr lang="en-US" sz="1500" dirty="0"/>
           </a:p>
           <a:p>
             <a:pPr marL="342900" indent="-342900">
               <a:spcAft>
-                <a:spcPts val="600"/>
+                <a:spcPts val="1000"/>
               </a:spcAft>
               <a:buSzPct val="100000"/>
               <a:buChar char="•"/>
             </a:pPr>
             <a:r>
-              <a:rPr lang="en-US" sz="1600" dirty="0">
+              <a:rPr lang="en-US" sz="1500" dirty="0">
                 <a:solidFill>
                   <a:srgbClr val="000000"/>
                 </a:solidFill>
               </a:rPr>
-              <a:t>Ordering recall gap is honest and explained: the synthesiser rejects windows it cannot safely reproduce. A scope limit, not a detector flaw.</a:t>
-            </a:r>
-            <a:endParaRPr lang="en-US" sz="1600" dirty="0"/>
+              <a:t>Track all ordering points detected </a:t>
+            </a:r>
+            <a:pPr indent="0" marL="0">
+              <a:spcAft>
+                <a:spcPts val="1000"/>
+              </a:spcAft>
+              <a:buNone/>
+            </a:pPr>
+            <a:r>
+              <a:rPr lang="en-US" sz="1500" dirty="0">
+                <a:solidFill>
+                  <a:srgbClr val="888888"/>
+                </a:solidFill>
+              </a:rPr>
+              <a:t>- not only ones with a higher process score than the user.</a:t>
+            </a:r>
+            <a:endParaRPr lang="en-US" sz="1500" dirty="0"/>
+          </a:p>
+          <a:p>
+            <a:pPr marL="342900" indent="-342900">
+              <a:spcAft>
+                <a:spcPts val="1000"/>
+              </a:spcAft>
+              <a:buSzPct val="100000"/>
+              <a:buChar char="•"/>
+            </a:pPr>
+            <a:r>
+              <a:rPr lang="en-US" sz="1500" dirty="0">
+                <a:solidFill>
+                  <a:srgbClr val="000000"/>
+                </a:solidFill>
+              </a:rPr>
+              <a:t>Measure precision + recall </a:t>
+            </a:r>
+            <a:pPr indent="0" marL="0">
+              <a:spcAft>
+                <a:spcPts val="1000"/>
+              </a:spcAft>
+              <a:buNone/>
+            </a:pPr>
+            <a:r>
+              <a:rPr lang="en-US" sz="1500" dirty="0">
+                <a:solidFill>
+                  <a:srgbClr val="888888"/>
+                </a:solidFill>
+              </a:rPr>
+              <a:t>- precision guards against FPs that waste the developer's attention. Recall guards against FNs that miss real opportunities. F1 averages the two - so a high score can hide a detector that's annoying users (lots of FPs) or one that's quietly missing things (lots of FNs). Accuracy is dominated by true negatives.</a:t>
+            </a:r>
+            <a:endParaRPr lang="en-US" sz="1500" dirty="0"/>
           </a:p>
         </p:txBody>
       </p:sp>
@@ -4268,8 +4445,8 @@
         </p:nvSpPr>
         <p:spPr>
           <a:xfrm>
-            <a:off x="457200" y="274320"/>
-            <a:ext cx="8229600" cy="640080"/>
+            <a:off x="457200" y="91440"/>
+            <a:ext cx="8229600" cy="548640"/>
           </a:xfrm>
           <a:prstGeom prst="rect">
             <a:avLst/>
@@ -4290,7 +4467,7 @@
                   <a:srgbClr val="000000"/>
                 </a:solidFill>
               </a:rPr>
-              <a:t>Score robustness</a:t>
+              <a:t>Decision matrix per divergence kind</a:t>
             </a:r>
             <a:endParaRPr lang="en-US" sz="2800" dirty="0"/>
           </a:p>
@@ -4304,8 +4481,8 @@
         </p:nvSpPr>
         <p:spPr>
           <a:xfrm>
-            <a:off x="457200" y="1188720"/>
-            <a:ext cx="8229600" cy="3657600"/>
+            <a:off x="457200" y="658368"/>
+            <a:ext cx="8229600" cy="256032"/>
           </a:xfrm>
           <a:prstGeom prst="rect">
             <a:avLst/>
@@ -4314,79 +4491,2253 @@
           <a:ln/>
         </p:spPr>
         <p:txBody>
-          <a:bodyPr wrap="square" rtlCol="0" anchor="t"/>
-          <a:lstStyle/>
-          <a:p>
-            <a:pPr marL="342900" indent="-342900">
-              <a:spcAft>
-                <a:spcPts val="600"/>
-              </a:spcAft>
-              <a:buSzPct val="100000"/>
-              <a:buChar char="•"/>
-            </a:pPr>
-            <a:r>
-              <a:rPr lang="en-US" sz="1600" dirty="0">
+          <a:bodyPr wrap="square" lIns="0" tIns="0" rIns="0" bIns="0" rtlCol="0" anchor="ctr"/>
+          <a:lstStyle/>
+          <a:p>
+            <a:pPr algn="ctr" indent="0" marL="0">
+              <a:buNone/>
+            </a:pPr>
+            <a:r>
+              <a:rPr lang="en-US" sz="1200" i="1" dirty="0">
+                <a:solidFill>
+                  <a:srgbClr val="555555"/>
+                </a:solidFill>
+              </a:rPr>
+              <a:t>Session-level (45 injection sessions).</a:t>
+            </a:r>
+            <a:endParaRPr lang="en-US" sz="1200" dirty="0"/>
+          </a:p>
+        </p:txBody>
+      </p:sp>
+      <p:sp>
+        <p:nvSpPr>
+          <p:cNvPr id="4" name="Text 2"/>
+          <p:cNvSpPr/>
+          <p:nvPr/>
+        </p:nvSpPr>
+        <p:spPr>
+          <a:xfrm>
+            <a:off x="640080" y="914400"/>
+            <a:ext cx="2834640" cy="201168"/>
+          </a:xfrm>
+          <a:prstGeom prst="rect">
+            <a:avLst/>
+          </a:prstGeom>
+          <a:noFill/>
+          <a:ln/>
+        </p:spPr>
+        <p:txBody>
+          <a:bodyPr wrap="square" lIns="0" tIns="0" rIns="0" bIns="0" rtlCol="0" anchor="b"/>
+          <a:lstStyle/>
+          <a:p>
+            <a:pPr algn="ctr" indent="0" marL="0">
+              <a:buNone/>
+            </a:pPr>
+            <a:r>
+              <a:rPr lang="en-US" sz="1400" b="1" dirty="0">
                 <a:solidFill>
                   <a:srgbClr val="000000"/>
                 </a:solidFill>
               </a:rPr>
-              <a:t>Single-knob sensitivity sweep: scale any one weight by {0.1×–10×}, top-1 recommendation is preserved in 96.5% of user-study cases.</a:t>
-            </a:r>
-            <a:endParaRPr lang="en-US" sz="1600" dirty="0"/>
-          </a:p>
-          <a:p>
-            <a:pPr marL="342900" indent="-342900">
-              <a:spcAft>
-                <a:spcPts val="600"/>
-              </a:spcAft>
-              <a:buSzPct val="100000"/>
-              <a:buChar char="•"/>
-            </a:pPr>
-            <a:r>
-              <a:rPr lang="en-US" sz="1600" dirty="0">
+              <a:t>Manual-Refactor</a:t>
+            </a:r>
+            <a:endParaRPr lang="en-US" sz="1400" dirty="0"/>
+          </a:p>
+        </p:txBody>
+      </p:sp>
+      <p:sp>
+        <p:nvSpPr>
+          <p:cNvPr id="5" name="Text 3"/>
+          <p:cNvSpPr/>
+          <p:nvPr/>
+        </p:nvSpPr>
+        <p:spPr>
+          <a:xfrm>
+            <a:off x="1188720" y="1133856"/>
+            <a:ext cx="1143000" cy="201168"/>
+          </a:xfrm>
+          <a:prstGeom prst="rect">
+            <a:avLst/>
+          </a:prstGeom>
+          <a:noFill/>
+          <a:ln/>
+        </p:spPr>
+        <p:txBody>
+          <a:bodyPr wrap="square" lIns="0" tIns="0" rIns="0" bIns="0" rtlCol="0" anchor="ctr"/>
+          <a:lstStyle/>
+          <a:p>
+            <a:pPr algn="ctr" indent="0" marL="0">
+              <a:buNone/>
+            </a:pPr>
+            <a:r>
+              <a:rPr lang="en-US" sz="900" i="1" dirty="0">
+                <a:solidFill>
+                  <a:srgbClr val="555555"/>
+                </a:solidFill>
+              </a:rPr>
+              <a:t>Predicted +</a:t>
+            </a:r>
+            <a:endParaRPr lang="en-US" sz="900" dirty="0"/>
+          </a:p>
+        </p:txBody>
+      </p:sp>
+      <p:sp>
+        <p:nvSpPr>
+          <p:cNvPr id="6" name="Text 4"/>
+          <p:cNvSpPr/>
+          <p:nvPr/>
+        </p:nvSpPr>
+        <p:spPr>
+          <a:xfrm>
+            <a:off x="2331720" y="1133856"/>
+            <a:ext cx="1143000" cy="201168"/>
+          </a:xfrm>
+          <a:prstGeom prst="rect">
+            <a:avLst/>
+          </a:prstGeom>
+          <a:noFill/>
+          <a:ln/>
+        </p:spPr>
+        <p:txBody>
+          <a:bodyPr wrap="square" lIns="0" tIns="0" rIns="0" bIns="0" rtlCol="0" anchor="ctr"/>
+          <a:lstStyle/>
+          <a:p>
+            <a:pPr algn="ctr" indent="0" marL="0">
+              <a:buNone/>
+            </a:pPr>
+            <a:r>
+              <a:rPr lang="en-US" sz="900" i="1" dirty="0">
+                <a:solidFill>
+                  <a:srgbClr val="555555"/>
+                </a:solidFill>
+              </a:rPr>
+              <a:t>Predicted −</a:t>
+            </a:r>
+            <a:endParaRPr lang="en-US" sz="900" dirty="0"/>
+          </a:p>
+        </p:txBody>
+      </p:sp>
+      <p:sp>
+        <p:nvSpPr>
+          <p:cNvPr id="7" name="Text 5"/>
+          <p:cNvSpPr/>
+          <p:nvPr/>
+        </p:nvSpPr>
+        <p:spPr>
+          <a:xfrm>
+            <a:off x="640080" y="1353312"/>
+            <a:ext cx="548640" cy="548640"/>
+          </a:xfrm>
+          <a:prstGeom prst="rect">
+            <a:avLst/>
+          </a:prstGeom>
+          <a:noFill/>
+          <a:ln/>
+        </p:spPr>
+        <p:txBody>
+          <a:bodyPr wrap="square" lIns="508" tIns="508" rIns="508" bIns="508" rtlCol="0" anchor="ctr"/>
+          <a:lstStyle/>
+          <a:p>
+            <a:pPr algn="r" indent="0" marL="0">
+              <a:buNone/>
+            </a:pPr>
+            <a:r>
+              <a:rPr lang="en-US" sz="900" i="1" dirty="0">
+                <a:solidFill>
+                  <a:srgbClr val="555555"/>
+                </a:solidFill>
+              </a:rPr>
+              <a:t>Actual +</a:t>
+            </a:r>
+            <a:endParaRPr lang="en-US" sz="900" dirty="0"/>
+          </a:p>
+        </p:txBody>
+      </p:sp>
+      <p:sp>
+        <p:nvSpPr>
+          <p:cNvPr id="8" name="Text 6"/>
+          <p:cNvSpPr/>
+          <p:nvPr/>
+        </p:nvSpPr>
+        <p:spPr>
+          <a:xfrm>
+            <a:off x="640080" y="1901952"/>
+            <a:ext cx="548640" cy="548640"/>
+          </a:xfrm>
+          <a:prstGeom prst="rect">
+            <a:avLst/>
+          </a:prstGeom>
+          <a:noFill/>
+          <a:ln/>
+        </p:spPr>
+        <p:txBody>
+          <a:bodyPr wrap="square" lIns="508" tIns="508" rIns="508" bIns="508" rtlCol="0" anchor="ctr"/>
+          <a:lstStyle/>
+          <a:p>
+            <a:pPr algn="r" indent="0" marL="0">
+              <a:buNone/>
+            </a:pPr>
+            <a:r>
+              <a:rPr lang="en-US" sz="900" i="1" dirty="0">
+                <a:solidFill>
+                  <a:srgbClr val="555555"/>
+                </a:solidFill>
+              </a:rPr>
+              <a:t>Actual −</a:t>
+            </a:r>
+            <a:endParaRPr lang="en-US" sz="900" dirty="0"/>
+          </a:p>
+        </p:txBody>
+      </p:sp>
+      <p:sp>
+        <p:nvSpPr>
+          <p:cNvPr id="9" name="Shape 7"/>
+          <p:cNvSpPr/>
+          <p:nvPr/>
+        </p:nvSpPr>
+        <p:spPr>
+          <a:xfrm>
+            <a:off x="1188720" y="1426464"/>
+            <a:ext cx="1143000" cy="548640"/>
+          </a:xfrm>
+          <a:prstGeom prst="rect">
+            <a:avLst/>
+          </a:prstGeom>
+          <a:solidFill>
+            <a:srgbClr val="D4F0DC"/>
+          </a:solidFill>
+          <a:ln w="6350">
+            <a:solidFill>
+              <a:srgbClr val="999999"/>
+            </a:solidFill>
+            <a:prstDash val="solid"/>
+          </a:ln>
+        </p:spPr>
+      </p:sp>
+      <p:sp>
+        <p:nvSpPr>
+          <p:cNvPr id="10" name="Text 8"/>
+          <p:cNvSpPr/>
+          <p:nvPr/>
+        </p:nvSpPr>
+        <p:spPr>
+          <a:xfrm>
+            <a:off x="1188720" y="1426464"/>
+            <a:ext cx="1143000" cy="548640"/>
+          </a:xfrm>
+          <a:prstGeom prst="rect">
+            <a:avLst/>
+          </a:prstGeom>
+          <a:noFill/>
+          <a:ln/>
+        </p:spPr>
+        <p:txBody>
+          <a:bodyPr wrap="square" lIns="0" tIns="0" rIns="0" bIns="0" rtlCol="0" anchor="ctr"/>
+          <a:lstStyle/>
+          <a:p>
+            <a:pPr algn="ctr" indent="0" marL="0">
+              <a:buNone/>
+            </a:pPr>
+            <a:r>
+              <a:rPr lang="en-US" sz="2000" b="1" dirty="0">
+                <a:solidFill>
+                  <a:srgbClr val="0A7D2A"/>
+                </a:solidFill>
+              </a:rPr>
+              <a:t>16</a:t>
+            </a:r>
+            <a:endParaRPr lang="en-US" sz="2000" dirty="0"/>
+          </a:p>
+          <a:p>
+            <a:pPr algn="ctr" indent="0" marL="0">
+              <a:buNone/>
+            </a:pPr>
+            <a:r>
+              <a:rPr lang="en-US" sz="900" dirty="0">
+                <a:solidFill>
+                  <a:srgbClr val="666666"/>
+                </a:solidFill>
+              </a:rPr>
+              <a:t>TP</a:t>
+            </a:r>
+            <a:endParaRPr lang="en-US" sz="2000" dirty="0"/>
+          </a:p>
+        </p:txBody>
+      </p:sp>
+      <p:sp>
+        <p:nvSpPr>
+          <p:cNvPr id="11" name="Shape 9"/>
+          <p:cNvSpPr/>
+          <p:nvPr/>
+        </p:nvSpPr>
+        <p:spPr>
+          <a:xfrm>
+            <a:off x="2331720" y="1426464"/>
+            <a:ext cx="1143000" cy="548640"/>
+          </a:xfrm>
+          <a:prstGeom prst="rect">
+            <a:avLst/>
+          </a:prstGeom>
+          <a:solidFill>
+            <a:srgbClr val="F5D5CE"/>
+          </a:solidFill>
+          <a:ln w="6350">
+            <a:solidFill>
+              <a:srgbClr val="999999"/>
+            </a:solidFill>
+            <a:prstDash val="solid"/>
+          </a:ln>
+        </p:spPr>
+      </p:sp>
+      <p:sp>
+        <p:nvSpPr>
+          <p:cNvPr id="12" name="Text 10"/>
+          <p:cNvSpPr/>
+          <p:nvPr/>
+        </p:nvSpPr>
+        <p:spPr>
+          <a:xfrm>
+            <a:off x="2331720" y="1426464"/>
+            <a:ext cx="1143000" cy="548640"/>
+          </a:xfrm>
+          <a:prstGeom prst="rect">
+            <a:avLst/>
+          </a:prstGeom>
+          <a:noFill/>
+          <a:ln/>
+        </p:spPr>
+        <p:txBody>
+          <a:bodyPr wrap="square" lIns="0" tIns="0" rIns="0" bIns="0" rtlCol="0" anchor="ctr"/>
+          <a:lstStyle/>
+          <a:p>
+            <a:pPr algn="ctr" indent="0" marL="0">
+              <a:buNone/>
+            </a:pPr>
+            <a:r>
+              <a:rPr lang="en-US" sz="2000" b="1" dirty="0">
+                <a:solidFill>
+                  <a:srgbClr val="B33A1E"/>
+                </a:solidFill>
+              </a:rPr>
+              <a:t>5</a:t>
+            </a:r>
+            <a:endParaRPr lang="en-US" sz="2000" dirty="0"/>
+          </a:p>
+          <a:p>
+            <a:pPr algn="ctr" indent="0" marL="0">
+              <a:buNone/>
+            </a:pPr>
+            <a:r>
+              <a:rPr lang="en-US" sz="900" dirty="0">
+                <a:solidFill>
+                  <a:srgbClr val="666666"/>
+                </a:solidFill>
+              </a:rPr>
+              <a:t>FN</a:t>
+            </a:r>
+            <a:endParaRPr lang="en-US" sz="2000" dirty="0"/>
+          </a:p>
+        </p:txBody>
+      </p:sp>
+      <p:sp>
+        <p:nvSpPr>
+          <p:cNvPr id="13" name="Shape 11"/>
+          <p:cNvSpPr/>
+          <p:nvPr/>
+        </p:nvSpPr>
+        <p:spPr>
+          <a:xfrm>
+            <a:off x="1188720" y="1975104"/>
+            <a:ext cx="1143000" cy="548640"/>
+          </a:xfrm>
+          <a:prstGeom prst="rect">
+            <a:avLst/>
+          </a:prstGeom>
+          <a:solidFill>
+            <a:srgbClr val="F2F2F2"/>
+          </a:solidFill>
+          <a:ln w="6350">
+            <a:solidFill>
+              <a:srgbClr val="999999"/>
+            </a:solidFill>
+            <a:prstDash val="solid"/>
+          </a:ln>
+        </p:spPr>
+      </p:sp>
+      <p:sp>
+        <p:nvSpPr>
+          <p:cNvPr id="14" name="Text 12"/>
+          <p:cNvSpPr/>
+          <p:nvPr/>
+        </p:nvSpPr>
+        <p:spPr>
+          <a:xfrm>
+            <a:off x="1188720" y="1975104"/>
+            <a:ext cx="1143000" cy="548640"/>
+          </a:xfrm>
+          <a:prstGeom prst="rect">
+            <a:avLst/>
+          </a:prstGeom>
+          <a:noFill/>
+          <a:ln/>
+        </p:spPr>
+        <p:txBody>
+          <a:bodyPr wrap="square" lIns="0" tIns="0" rIns="0" bIns="0" rtlCol="0" anchor="ctr"/>
+          <a:lstStyle/>
+          <a:p>
+            <a:pPr algn="ctr" indent="0" marL="0">
+              <a:buNone/>
+            </a:pPr>
+            <a:r>
+              <a:rPr lang="en-US" sz="2000" b="1" dirty="0">
+                <a:solidFill>
+                  <a:srgbClr val="888888"/>
+                </a:solidFill>
+              </a:rPr>
+              <a:t>0</a:t>
+            </a:r>
+            <a:endParaRPr lang="en-US" sz="2000" dirty="0"/>
+          </a:p>
+          <a:p>
+            <a:pPr algn="ctr" indent="0" marL="0">
+              <a:buNone/>
+            </a:pPr>
+            <a:r>
+              <a:rPr lang="en-US" sz="900" dirty="0">
+                <a:solidFill>
+                  <a:srgbClr val="666666"/>
+                </a:solidFill>
+              </a:rPr>
+              <a:t>FP</a:t>
+            </a:r>
+            <a:endParaRPr lang="en-US" sz="2000" dirty="0"/>
+          </a:p>
+        </p:txBody>
+      </p:sp>
+      <p:sp>
+        <p:nvSpPr>
+          <p:cNvPr id="15" name="Shape 13"/>
+          <p:cNvSpPr/>
+          <p:nvPr/>
+        </p:nvSpPr>
+        <p:spPr>
+          <a:xfrm>
+            <a:off x="2331720" y="1975104"/>
+            <a:ext cx="1143000" cy="548640"/>
+          </a:xfrm>
+          <a:prstGeom prst="rect">
+            <a:avLst/>
+          </a:prstGeom>
+          <a:solidFill>
+            <a:srgbClr val="EAEAEA"/>
+          </a:solidFill>
+          <a:ln w="6350">
+            <a:solidFill>
+              <a:srgbClr val="999999"/>
+            </a:solidFill>
+            <a:prstDash val="solid"/>
+          </a:ln>
+        </p:spPr>
+      </p:sp>
+      <p:sp>
+        <p:nvSpPr>
+          <p:cNvPr id="16" name="Text 14"/>
+          <p:cNvSpPr/>
+          <p:nvPr/>
+        </p:nvSpPr>
+        <p:spPr>
+          <a:xfrm>
+            <a:off x="2331720" y="1975104"/>
+            <a:ext cx="1143000" cy="548640"/>
+          </a:xfrm>
+          <a:prstGeom prst="rect">
+            <a:avLst/>
+          </a:prstGeom>
+          <a:noFill/>
+          <a:ln/>
+        </p:spPr>
+        <p:txBody>
+          <a:bodyPr wrap="square" lIns="0" tIns="0" rIns="0" bIns="0" rtlCol="0" anchor="ctr"/>
+          <a:lstStyle/>
+          <a:p>
+            <a:pPr algn="ctr" indent="0" marL="0">
+              <a:buNone/>
+            </a:pPr>
+            <a:r>
+              <a:rPr lang="en-US" sz="2000" b="1" dirty="0">
+                <a:solidFill>
+                  <a:srgbClr val="555555"/>
+                </a:solidFill>
+              </a:rPr>
+              <a:t>24</a:t>
+            </a:r>
+            <a:endParaRPr lang="en-US" sz="2000" dirty="0"/>
+          </a:p>
+          <a:p>
+            <a:pPr algn="ctr" indent="0" marL="0">
+              <a:buNone/>
+            </a:pPr>
+            <a:r>
+              <a:rPr lang="en-US" sz="900" dirty="0">
+                <a:solidFill>
+                  <a:srgbClr val="666666"/>
+                </a:solidFill>
+              </a:rPr>
+              <a:t>TN</a:t>
+            </a:r>
+            <a:endParaRPr lang="en-US" sz="2000" dirty="0"/>
+          </a:p>
+        </p:txBody>
+      </p:sp>
+      <p:sp>
+        <p:nvSpPr>
+          <p:cNvPr id="17" name="Text 15"/>
+          <p:cNvSpPr/>
+          <p:nvPr/>
+        </p:nvSpPr>
+        <p:spPr>
+          <a:xfrm>
+            <a:off x="640080" y="2542032"/>
+            <a:ext cx="2834640" cy="201168"/>
+          </a:xfrm>
+          <a:prstGeom prst="rect">
+            <a:avLst/>
+          </a:prstGeom>
+          <a:noFill/>
+          <a:ln/>
+        </p:spPr>
+        <p:txBody>
+          <a:bodyPr wrap="square" lIns="0" tIns="0" rIns="0" bIns="0" rtlCol="0" anchor="ctr"/>
+          <a:lstStyle/>
+          <a:p>
+            <a:pPr algn="ctr" indent="0" marL="0">
+              <a:buNone/>
+            </a:pPr>
+            <a:r>
+              <a:rPr lang="en-US" sz="1100" i="1" dirty="0">
+                <a:solidFill>
+                  <a:srgbClr val="555555"/>
+                </a:solidFill>
+              </a:rPr>
+              <a:t>Precision </a:t>
+            </a:r>
+            <a:pPr algn="ctr" indent="0" marL="0">
+              <a:buNone/>
+            </a:pPr>
+            <a:r>
+              <a:rPr lang="en-US" sz="1100" b="1" i="1" dirty="0">
+                <a:solidFill>
+                  <a:srgbClr val="1A1A1A"/>
+                </a:solidFill>
+              </a:rPr>
+              <a:t>1.00</a:t>
+            </a:r>
+            <a:pPr algn="ctr" indent="0" marL="0">
+              <a:buNone/>
+            </a:pPr>
+            <a:r>
+              <a:rPr lang="en-US" sz="1100" i="1" dirty="0">
+                <a:solidFill>
+                  <a:srgbClr val="555555"/>
+                </a:solidFill>
+              </a:rPr>
+              <a:t>   ·   Recall </a:t>
+            </a:r>
+            <a:pPr algn="ctr" indent="0" marL="0">
+              <a:buNone/>
+            </a:pPr>
+            <a:r>
+              <a:rPr lang="en-US" sz="1100" b="1" i="1" dirty="0">
+                <a:solidFill>
+                  <a:srgbClr val="1A1A1A"/>
+                </a:solidFill>
+              </a:rPr>
+              <a:t>0.76</a:t>
+            </a:r>
+            <a:endParaRPr lang="en-US" sz="1100" dirty="0"/>
+          </a:p>
+        </p:txBody>
+      </p:sp>
+      <p:sp>
+        <p:nvSpPr>
+          <p:cNvPr id="18" name="Text 16"/>
+          <p:cNvSpPr/>
+          <p:nvPr/>
+        </p:nvSpPr>
+        <p:spPr>
+          <a:xfrm>
+            <a:off x="4754880" y="914400"/>
+            <a:ext cx="2834640" cy="201168"/>
+          </a:xfrm>
+          <a:prstGeom prst="rect">
+            <a:avLst/>
+          </a:prstGeom>
+          <a:noFill/>
+          <a:ln/>
+        </p:spPr>
+        <p:txBody>
+          <a:bodyPr wrap="square" lIns="0" tIns="0" rIns="0" bIns="0" rtlCol="0" anchor="b"/>
+          <a:lstStyle/>
+          <a:p>
+            <a:pPr algn="ctr" indent="0" marL="0">
+              <a:buNone/>
+            </a:pPr>
+            <a:r>
+              <a:rPr lang="en-US" sz="1400" b="1" dirty="0">
                 <a:solidFill>
                   <a:srgbClr val="000000"/>
                 </a:solidFill>
               </a:rPr>
-              <a:t>Multi-knob Monte Carlo (200 samples): top-1 stability drops to 84.6%; mean Kendall τ = 0.586.</a:t>
-            </a:r>
-            <a:endParaRPr lang="en-US" sz="1600" dirty="0"/>
-          </a:p>
-          <a:p>
-            <a:pPr marL="342900" indent="-342900">
-              <a:spcAft>
-                <a:spcPts val="600"/>
-              </a:spcAft>
-              <a:buSzPct val="100000"/>
-              <a:buChar char="•"/>
-            </a:pPr>
-            <a:r>
-              <a:rPr lang="en-US" sz="1600" dirty="0">
+              <a:t>Ordering</a:t>
+            </a:r>
+            <a:endParaRPr lang="en-US" sz="1400" dirty="0"/>
+          </a:p>
+        </p:txBody>
+      </p:sp>
+      <p:sp>
+        <p:nvSpPr>
+          <p:cNvPr id="19" name="Text 17"/>
+          <p:cNvSpPr/>
+          <p:nvPr/>
+        </p:nvSpPr>
+        <p:spPr>
+          <a:xfrm>
+            <a:off x="5303520" y="1133856"/>
+            <a:ext cx="1143000" cy="201168"/>
+          </a:xfrm>
+          <a:prstGeom prst="rect">
+            <a:avLst/>
+          </a:prstGeom>
+          <a:noFill/>
+          <a:ln/>
+        </p:spPr>
+        <p:txBody>
+          <a:bodyPr wrap="square" lIns="0" tIns="0" rIns="0" bIns="0" rtlCol="0" anchor="ctr"/>
+          <a:lstStyle/>
+          <a:p>
+            <a:pPr algn="ctr" indent="0" marL="0">
+              <a:buNone/>
+            </a:pPr>
+            <a:r>
+              <a:rPr lang="en-US" sz="900" i="1" dirty="0">
+                <a:solidFill>
+                  <a:srgbClr val="555555"/>
+                </a:solidFill>
+              </a:rPr>
+              <a:t>Predicted +</a:t>
+            </a:r>
+            <a:endParaRPr lang="en-US" sz="900" dirty="0"/>
+          </a:p>
+        </p:txBody>
+      </p:sp>
+      <p:sp>
+        <p:nvSpPr>
+          <p:cNvPr id="20" name="Text 18"/>
+          <p:cNvSpPr/>
+          <p:nvPr/>
+        </p:nvSpPr>
+        <p:spPr>
+          <a:xfrm>
+            <a:off x="6446520" y="1133856"/>
+            <a:ext cx="1143000" cy="201168"/>
+          </a:xfrm>
+          <a:prstGeom prst="rect">
+            <a:avLst/>
+          </a:prstGeom>
+          <a:noFill/>
+          <a:ln/>
+        </p:spPr>
+        <p:txBody>
+          <a:bodyPr wrap="square" lIns="0" tIns="0" rIns="0" bIns="0" rtlCol="0" anchor="ctr"/>
+          <a:lstStyle/>
+          <a:p>
+            <a:pPr algn="ctr" indent="0" marL="0">
+              <a:buNone/>
+            </a:pPr>
+            <a:r>
+              <a:rPr lang="en-US" sz="900" i="1" dirty="0">
+                <a:solidFill>
+                  <a:srgbClr val="555555"/>
+                </a:solidFill>
+              </a:rPr>
+              <a:t>Predicted −</a:t>
+            </a:r>
+            <a:endParaRPr lang="en-US" sz="900" dirty="0"/>
+          </a:p>
+        </p:txBody>
+      </p:sp>
+      <p:sp>
+        <p:nvSpPr>
+          <p:cNvPr id="21" name="Text 19"/>
+          <p:cNvSpPr/>
+          <p:nvPr/>
+        </p:nvSpPr>
+        <p:spPr>
+          <a:xfrm>
+            <a:off x="4754880" y="1353312"/>
+            <a:ext cx="548640" cy="548640"/>
+          </a:xfrm>
+          <a:prstGeom prst="rect">
+            <a:avLst/>
+          </a:prstGeom>
+          <a:noFill/>
+          <a:ln/>
+        </p:spPr>
+        <p:txBody>
+          <a:bodyPr wrap="square" lIns="508" tIns="508" rIns="508" bIns="508" rtlCol="0" anchor="ctr"/>
+          <a:lstStyle/>
+          <a:p>
+            <a:pPr algn="r" indent="0" marL="0">
+              <a:buNone/>
+            </a:pPr>
+            <a:r>
+              <a:rPr lang="en-US" sz="900" i="1" dirty="0">
+                <a:solidFill>
+                  <a:srgbClr val="555555"/>
+                </a:solidFill>
+              </a:rPr>
+              <a:t>Actual +</a:t>
+            </a:r>
+            <a:endParaRPr lang="en-US" sz="900" dirty="0"/>
+          </a:p>
+        </p:txBody>
+      </p:sp>
+      <p:sp>
+        <p:nvSpPr>
+          <p:cNvPr id="22" name="Text 20"/>
+          <p:cNvSpPr/>
+          <p:nvPr/>
+        </p:nvSpPr>
+        <p:spPr>
+          <a:xfrm>
+            <a:off x="4754880" y="1901952"/>
+            <a:ext cx="548640" cy="548640"/>
+          </a:xfrm>
+          <a:prstGeom prst="rect">
+            <a:avLst/>
+          </a:prstGeom>
+          <a:noFill/>
+          <a:ln/>
+        </p:spPr>
+        <p:txBody>
+          <a:bodyPr wrap="square" lIns="508" tIns="508" rIns="508" bIns="508" rtlCol="0" anchor="ctr"/>
+          <a:lstStyle/>
+          <a:p>
+            <a:pPr algn="r" indent="0" marL="0">
+              <a:buNone/>
+            </a:pPr>
+            <a:r>
+              <a:rPr lang="en-US" sz="900" i="1" dirty="0">
+                <a:solidFill>
+                  <a:srgbClr val="555555"/>
+                </a:solidFill>
+              </a:rPr>
+              <a:t>Actual −</a:t>
+            </a:r>
+            <a:endParaRPr lang="en-US" sz="900" dirty="0"/>
+          </a:p>
+        </p:txBody>
+      </p:sp>
+      <p:sp>
+        <p:nvSpPr>
+          <p:cNvPr id="23" name="Shape 21"/>
+          <p:cNvSpPr/>
+          <p:nvPr/>
+        </p:nvSpPr>
+        <p:spPr>
+          <a:xfrm>
+            <a:off x="5303520" y="1426464"/>
+            <a:ext cx="1143000" cy="548640"/>
+          </a:xfrm>
+          <a:prstGeom prst="rect">
+            <a:avLst/>
+          </a:prstGeom>
+          <a:solidFill>
+            <a:srgbClr val="D4F0DC"/>
+          </a:solidFill>
+          <a:ln w="6350">
+            <a:solidFill>
+              <a:srgbClr val="999999"/>
+            </a:solidFill>
+            <a:prstDash val="solid"/>
+          </a:ln>
+        </p:spPr>
+      </p:sp>
+      <p:sp>
+        <p:nvSpPr>
+          <p:cNvPr id="24" name="Text 22"/>
+          <p:cNvSpPr/>
+          <p:nvPr/>
+        </p:nvSpPr>
+        <p:spPr>
+          <a:xfrm>
+            <a:off x="5303520" y="1426464"/>
+            <a:ext cx="1143000" cy="548640"/>
+          </a:xfrm>
+          <a:prstGeom prst="rect">
+            <a:avLst/>
+          </a:prstGeom>
+          <a:noFill/>
+          <a:ln/>
+        </p:spPr>
+        <p:txBody>
+          <a:bodyPr wrap="square" lIns="0" tIns="0" rIns="0" bIns="0" rtlCol="0" anchor="ctr"/>
+          <a:lstStyle/>
+          <a:p>
+            <a:pPr algn="ctr" indent="0" marL="0">
+              <a:buNone/>
+            </a:pPr>
+            <a:r>
+              <a:rPr lang="en-US" sz="2000" b="1" dirty="0">
+                <a:solidFill>
+                  <a:srgbClr val="0A7D2A"/>
+                </a:solidFill>
+              </a:rPr>
+              <a:t>14</a:t>
+            </a:r>
+            <a:endParaRPr lang="en-US" sz="2000" dirty="0"/>
+          </a:p>
+          <a:p>
+            <a:pPr algn="ctr" indent="0" marL="0">
+              <a:buNone/>
+            </a:pPr>
+            <a:r>
+              <a:rPr lang="en-US" sz="900" dirty="0">
+                <a:solidFill>
+                  <a:srgbClr val="666666"/>
+                </a:solidFill>
+              </a:rPr>
+              <a:t>TP</a:t>
+            </a:r>
+            <a:endParaRPr lang="en-US" sz="2000" dirty="0"/>
+          </a:p>
+        </p:txBody>
+      </p:sp>
+      <p:sp>
+        <p:nvSpPr>
+          <p:cNvPr id="25" name="Shape 23"/>
+          <p:cNvSpPr/>
+          <p:nvPr/>
+        </p:nvSpPr>
+        <p:spPr>
+          <a:xfrm>
+            <a:off x="6446520" y="1426464"/>
+            <a:ext cx="1143000" cy="548640"/>
+          </a:xfrm>
+          <a:prstGeom prst="rect">
+            <a:avLst/>
+          </a:prstGeom>
+          <a:solidFill>
+            <a:srgbClr val="F5D5CE"/>
+          </a:solidFill>
+          <a:ln w="6350">
+            <a:solidFill>
+              <a:srgbClr val="999999"/>
+            </a:solidFill>
+            <a:prstDash val="solid"/>
+          </a:ln>
+        </p:spPr>
+      </p:sp>
+      <p:sp>
+        <p:nvSpPr>
+          <p:cNvPr id="26" name="Text 24"/>
+          <p:cNvSpPr/>
+          <p:nvPr/>
+        </p:nvSpPr>
+        <p:spPr>
+          <a:xfrm>
+            <a:off x="6446520" y="1426464"/>
+            <a:ext cx="1143000" cy="548640"/>
+          </a:xfrm>
+          <a:prstGeom prst="rect">
+            <a:avLst/>
+          </a:prstGeom>
+          <a:noFill/>
+          <a:ln/>
+        </p:spPr>
+        <p:txBody>
+          <a:bodyPr wrap="square" lIns="0" tIns="0" rIns="0" bIns="0" rtlCol="0" anchor="ctr"/>
+          <a:lstStyle/>
+          <a:p>
+            <a:pPr algn="ctr" indent="0" marL="0">
+              <a:buNone/>
+            </a:pPr>
+            <a:r>
+              <a:rPr lang="en-US" sz="2000" b="1" dirty="0">
+                <a:solidFill>
+                  <a:srgbClr val="B33A1E"/>
+                </a:solidFill>
+              </a:rPr>
+              <a:t>24</a:t>
+            </a:r>
+            <a:endParaRPr lang="en-US" sz="2000" dirty="0"/>
+          </a:p>
+          <a:p>
+            <a:pPr algn="ctr" indent="0" marL="0">
+              <a:buNone/>
+            </a:pPr>
+            <a:r>
+              <a:rPr lang="en-US" sz="900" dirty="0">
+                <a:solidFill>
+                  <a:srgbClr val="666666"/>
+                </a:solidFill>
+              </a:rPr>
+              <a:t>FN</a:t>
+            </a:r>
+            <a:endParaRPr lang="en-US" sz="2000" dirty="0"/>
+          </a:p>
+        </p:txBody>
+      </p:sp>
+      <p:sp>
+        <p:nvSpPr>
+          <p:cNvPr id="27" name="Shape 25"/>
+          <p:cNvSpPr/>
+          <p:nvPr/>
+        </p:nvSpPr>
+        <p:spPr>
+          <a:xfrm>
+            <a:off x="5303520" y="1975104"/>
+            <a:ext cx="1143000" cy="548640"/>
+          </a:xfrm>
+          <a:prstGeom prst="rect">
+            <a:avLst/>
+          </a:prstGeom>
+          <a:solidFill>
+            <a:srgbClr val="F2F2F2"/>
+          </a:solidFill>
+          <a:ln w="6350">
+            <a:solidFill>
+              <a:srgbClr val="999999"/>
+            </a:solidFill>
+            <a:prstDash val="solid"/>
+          </a:ln>
+        </p:spPr>
+      </p:sp>
+      <p:sp>
+        <p:nvSpPr>
+          <p:cNvPr id="28" name="Text 26"/>
+          <p:cNvSpPr/>
+          <p:nvPr/>
+        </p:nvSpPr>
+        <p:spPr>
+          <a:xfrm>
+            <a:off x="5303520" y="1975104"/>
+            <a:ext cx="1143000" cy="548640"/>
+          </a:xfrm>
+          <a:prstGeom prst="rect">
+            <a:avLst/>
+          </a:prstGeom>
+          <a:noFill/>
+          <a:ln/>
+        </p:spPr>
+        <p:txBody>
+          <a:bodyPr wrap="square" lIns="0" tIns="0" rIns="0" bIns="0" rtlCol="0" anchor="ctr"/>
+          <a:lstStyle/>
+          <a:p>
+            <a:pPr algn="ctr" indent="0" marL="0">
+              <a:buNone/>
+            </a:pPr>
+            <a:r>
+              <a:rPr lang="en-US" sz="2000" b="1" dirty="0">
+                <a:solidFill>
+                  <a:srgbClr val="888888"/>
+                </a:solidFill>
+              </a:rPr>
+              <a:t>0</a:t>
+            </a:r>
+            <a:endParaRPr lang="en-US" sz="2000" dirty="0"/>
+          </a:p>
+          <a:p>
+            <a:pPr algn="ctr" indent="0" marL="0">
+              <a:buNone/>
+            </a:pPr>
+            <a:r>
+              <a:rPr lang="en-US" sz="900" dirty="0">
+                <a:solidFill>
+                  <a:srgbClr val="666666"/>
+                </a:solidFill>
+              </a:rPr>
+              <a:t>FP</a:t>
+            </a:r>
+            <a:endParaRPr lang="en-US" sz="2000" dirty="0"/>
+          </a:p>
+        </p:txBody>
+      </p:sp>
+      <p:sp>
+        <p:nvSpPr>
+          <p:cNvPr id="29" name="Shape 27"/>
+          <p:cNvSpPr/>
+          <p:nvPr/>
+        </p:nvSpPr>
+        <p:spPr>
+          <a:xfrm>
+            <a:off x="6446520" y="1975104"/>
+            <a:ext cx="1143000" cy="548640"/>
+          </a:xfrm>
+          <a:prstGeom prst="rect">
+            <a:avLst/>
+          </a:prstGeom>
+          <a:solidFill>
+            <a:srgbClr val="EAEAEA"/>
+          </a:solidFill>
+          <a:ln w="6350">
+            <a:solidFill>
+              <a:srgbClr val="999999"/>
+            </a:solidFill>
+            <a:prstDash val="solid"/>
+          </a:ln>
+        </p:spPr>
+      </p:sp>
+      <p:sp>
+        <p:nvSpPr>
+          <p:cNvPr id="30" name="Text 28"/>
+          <p:cNvSpPr/>
+          <p:nvPr/>
+        </p:nvSpPr>
+        <p:spPr>
+          <a:xfrm>
+            <a:off x="6446520" y="1975104"/>
+            <a:ext cx="1143000" cy="548640"/>
+          </a:xfrm>
+          <a:prstGeom prst="rect">
+            <a:avLst/>
+          </a:prstGeom>
+          <a:noFill/>
+          <a:ln/>
+        </p:spPr>
+        <p:txBody>
+          <a:bodyPr wrap="square" lIns="0" tIns="0" rIns="0" bIns="0" rtlCol="0" anchor="ctr"/>
+          <a:lstStyle/>
+          <a:p>
+            <a:pPr algn="ctr" indent="0" marL="0">
+              <a:buNone/>
+            </a:pPr>
+            <a:r>
+              <a:rPr lang="en-US" sz="2000" b="1" dirty="0">
+                <a:solidFill>
+                  <a:srgbClr val="555555"/>
+                </a:solidFill>
+              </a:rPr>
+              <a:t>7</a:t>
+            </a:r>
+            <a:endParaRPr lang="en-US" sz="2000" dirty="0"/>
+          </a:p>
+          <a:p>
+            <a:pPr algn="ctr" indent="0" marL="0">
+              <a:buNone/>
+            </a:pPr>
+            <a:r>
+              <a:rPr lang="en-US" sz="900" dirty="0">
+                <a:solidFill>
+                  <a:srgbClr val="666666"/>
+                </a:solidFill>
+              </a:rPr>
+              <a:t>TN</a:t>
+            </a:r>
+            <a:endParaRPr lang="en-US" sz="2000" dirty="0"/>
+          </a:p>
+        </p:txBody>
+      </p:sp>
+      <p:sp>
+        <p:nvSpPr>
+          <p:cNvPr id="31" name="Text 29"/>
+          <p:cNvSpPr/>
+          <p:nvPr/>
+        </p:nvSpPr>
+        <p:spPr>
+          <a:xfrm>
+            <a:off x="4754880" y="2542032"/>
+            <a:ext cx="2834640" cy="201168"/>
+          </a:xfrm>
+          <a:prstGeom prst="rect">
+            <a:avLst/>
+          </a:prstGeom>
+          <a:noFill/>
+          <a:ln/>
+        </p:spPr>
+        <p:txBody>
+          <a:bodyPr wrap="square" lIns="0" tIns="0" rIns="0" bIns="0" rtlCol="0" anchor="ctr"/>
+          <a:lstStyle/>
+          <a:p>
+            <a:pPr algn="ctr" indent="0" marL="0">
+              <a:buNone/>
+            </a:pPr>
+            <a:r>
+              <a:rPr lang="en-US" sz="1100" i="1" dirty="0">
+                <a:solidFill>
+                  <a:srgbClr val="555555"/>
+                </a:solidFill>
+              </a:rPr>
+              <a:t>Precision </a:t>
+            </a:r>
+            <a:pPr algn="ctr" indent="0" marL="0">
+              <a:buNone/>
+            </a:pPr>
+            <a:r>
+              <a:rPr lang="en-US" sz="1100" b="1" i="1" dirty="0">
+                <a:solidFill>
+                  <a:srgbClr val="1A1A1A"/>
+                </a:solidFill>
+              </a:rPr>
+              <a:t>1.00</a:t>
+            </a:r>
+            <a:pPr algn="ctr" indent="0" marL="0">
+              <a:buNone/>
+            </a:pPr>
+            <a:r>
+              <a:rPr lang="en-US" sz="1100" i="1" dirty="0">
+                <a:solidFill>
+                  <a:srgbClr val="555555"/>
+                </a:solidFill>
+              </a:rPr>
+              <a:t>   ·   Recall </a:t>
+            </a:r>
+            <a:pPr algn="ctr" indent="0" marL="0">
+              <a:buNone/>
+            </a:pPr>
+            <a:r>
+              <a:rPr lang="en-US" sz="1100" b="1" i="1" dirty="0">
+                <a:solidFill>
+                  <a:srgbClr val="1A1A1A"/>
+                </a:solidFill>
+              </a:rPr>
+              <a:t>0.36</a:t>
+            </a:r>
+            <a:endParaRPr lang="en-US" sz="1100" dirty="0"/>
+          </a:p>
+        </p:txBody>
+      </p:sp>
+      <p:sp>
+        <p:nvSpPr>
+          <p:cNvPr id="32" name="Text 30"/>
+          <p:cNvSpPr/>
+          <p:nvPr/>
+        </p:nvSpPr>
+        <p:spPr>
+          <a:xfrm>
+            <a:off x="640080" y="2926080"/>
+            <a:ext cx="2834640" cy="201168"/>
+          </a:xfrm>
+          <a:prstGeom prst="rect">
+            <a:avLst/>
+          </a:prstGeom>
+          <a:noFill/>
+          <a:ln/>
+        </p:spPr>
+        <p:txBody>
+          <a:bodyPr wrap="square" lIns="0" tIns="0" rIns="0" bIns="0" rtlCol="0" anchor="b"/>
+          <a:lstStyle/>
+          <a:p>
+            <a:pPr algn="ctr" indent="0" marL="0">
+              <a:buNone/>
+            </a:pPr>
+            <a:r>
+              <a:rPr lang="en-US" sz="1400" b="1" dirty="0">
                 <a:solidFill>
                   <a:srgbClr val="000000"/>
                 </a:solidFill>
               </a:rPr>
-              <a:t>Honest framing - stable near the chosen weights, less stable under arbitrary joint perturbations.</a:t>
-            </a:r>
-            <a:endParaRPr lang="en-US" sz="1600" dirty="0"/>
-          </a:p>
-          <a:p>
-            <a:pPr marL="342900" indent="-342900">
-              <a:spcAft>
-                <a:spcPts val="600"/>
-              </a:spcAft>
-              <a:buSzPct val="100000"/>
-              <a:buChar char="•"/>
-            </a:pPr>
-            <a:r>
-              <a:rPr lang="en-US" sz="1600" dirty="0">
+              <a:t>Rework</a:t>
+            </a:r>
+            <a:endParaRPr lang="en-US" sz="1400" dirty="0"/>
+          </a:p>
+        </p:txBody>
+      </p:sp>
+      <p:sp>
+        <p:nvSpPr>
+          <p:cNvPr id="33" name="Text 31"/>
+          <p:cNvSpPr/>
+          <p:nvPr/>
+        </p:nvSpPr>
+        <p:spPr>
+          <a:xfrm>
+            <a:off x="1188720" y="3145536"/>
+            <a:ext cx="1143000" cy="201168"/>
+          </a:xfrm>
+          <a:prstGeom prst="rect">
+            <a:avLst/>
+          </a:prstGeom>
+          <a:noFill/>
+          <a:ln/>
+        </p:spPr>
+        <p:txBody>
+          <a:bodyPr wrap="square" lIns="0" tIns="0" rIns="0" bIns="0" rtlCol="0" anchor="ctr"/>
+          <a:lstStyle/>
+          <a:p>
+            <a:pPr algn="ctr" indent="0" marL="0">
+              <a:buNone/>
+            </a:pPr>
+            <a:r>
+              <a:rPr lang="en-US" sz="900" i="1" dirty="0">
+                <a:solidFill>
+                  <a:srgbClr val="555555"/>
+                </a:solidFill>
+              </a:rPr>
+              <a:t>Predicted +</a:t>
+            </a:r>
+            <a:endParaRPr lang="en-US" sz="900" dirty="0"/>
+          </a:p>
+        </p:txBody>
+      </p:sp>
+      <p:sp>
+        <p:nvSpPr>
+          <p:cNvPr id="34" name="Text 32"/>
+          <p:cNvSpPr/>
+          <p:nvPr/>
+        </p:nvSpPr>
+        <p:spPr>
+          <a:xfrm>
+            <a:off x="2331720" y="3145536"/>
+            <a:ext cx="1143000" cy="201168"/>
+          </a:xfrm>
+          <a:prstGeom prst="rect">
+            <a:avLst/>
+          </a:prstGeom>
+          <a:noFill/>
+          <a:ln/>
+        </p:spPr>
+        <p:txBody>
+          <a:bodyPr wrap="square" lIns="0" tIns="0" rIns="0" bIns="0" rtlCol="0" anchor="ctr"/>
+          <a:lstStyle/>
+          <a:p>
+            <a:pPr algn="ctr" indent="0" marL="0">
+              <a:buNone/>
+            </a:pPr>
+            <a:r>
+              <a:rPr lang="en-US" sz="900" i="1" dirty="0">
+                <a:solidFill>
+                  <a:srgbClr val="555555"/>
+                </a:solidFill>
+              </a:rPr>
+              <a:t>Predicted −</a:t>
+            </a:r>
+            <a:endParaRPr lang="en-US" sz="900" dirty="0"/>
+          </a:p>
+        </p:txBody>
+      </p:sp>
+      <p:sp>
+        <p:nvSpPr>
+          <p:cNvPr id="35" name="Text 33"/>
+          <p:cNvSpPr/>
+          <p:nvPr/>
+        </p:nvSpPr>
+        <p:spPr>
+          <a:xfrm>
+            <a:off x="640080" y="3364992"/>
+            <a:ext cx="548640" cy="548640"/>
+          </a:xfrm>
+          <a:prstGeom prst="rect">
+            <a:avLst/>
+          </a:prstGeom>
+          <a:noFill/>
+          <a:ln/>
+        </p:spPr>
+        <p:txBody>
+          <a:bodyPr wrap="square" lIns="508" tIns="508" rIns="508" bIns="508" rtlCol="0" anchor="ctr"/>
+          <a:lstStyle/>
+          <a:p>
+            <a:pPr algn="r" indent="0" marL="0">
+              <a:buNone/>
+            </a:pPr>
+            <a:r>
+              <a:rPr lang="en-US" sz="900" i="1" dirty="0">
+                <a:solidFill>
+                  <a:srgbClr val="555555"/>
+                </a:solidFill>
+              </a:rPr>
+              <a:t>Actual +</a:t>
+            </a:r>
+            <a:endParaRPr lang="en-US" sz="900" dirty="0"/>
+          </a:p>
+        </p:txBody>
+      </p:sp>
+      <p:sp>
+        <p:nvSpPr>
+          <p:cNvPr id="36" name="Text 34"/>
+          <p:cNvSpPr/>
+          <p:nvPr/>
+        </p:nvSpPr>
+        <p:spPr>
+          <a:xfrm>
+            <a:off x="640080" y="3913632"/>
+            <a:ext cx="548640" cy="548640"/>
+          </a:xfrm>
+          <a:prstGeom prst="rect">
+            <a:avLst/>
+          </a:prstGeom>
+          <a:noFill/>
+          <a:ln/>
+        </p:spPr>
+        <p:txBody>
+          <a:bodyPr wrap="square" lIns="508" tIns="508" rIns="508" bIns="508" rtlCol="0" anchor="ctr"/>
+          <a:lstStyle/>
+          <a:p>
+            <a:pPr algn="r" indent="0" marL="0">
+              <a:buNone/>
+            </a:pPr>
+            <a:r>
+              <a:rPr lang="en-US" sz="900" i="1" dirty="0">
+                <a:solidFill>
+                  <a:srgbClr val="555555"/>
+                </a:solidFill>
+              </a:rPr>
+              <a:t>Actual −</a:t>
+            </a:r>
+            <a:endParaRPr lang="en-US" sz="900" dirty="0"/>
+          </a:p>
+        </p:txBody>
+      </p:sp>
+      <p:sp>
+        <p:nvSpPr>
+          <p:cNvPr id="37" name="Shape 35"/>
+          <p:cNvSpPr/>
+          <p:nvPr/>
+        </p:nvSpPr>
+        <p:spPr>
+          <a:xfrm>
+            <a:off x="1188720" y="3438144"/>
+            <a:ext cx="1143000" cy="548640"/>
+          </a:xfrm>
+          <a:prstGeom prst="rect">
+            <a:avLst/>
+          </a:prstGeom>
+          <a:solidFill>
+            <a:srgbClr val="D4F0DC"/>
+          </a:solidFill>
+          <a:ln w="6350">
+            <a:solidFill>
+              <a:srgbClr val="999999"/>
+            </a:solidFill>
+            <a:prstDash val="solid"/>
+          </a:ln>
+        </p:spPr>
+      </p:sp>
+      <p:sp>
+        <p:nvSpPr>
+          <p:cNvPr id="38" name="Text 36"/>
+          <p:cNvSpPr/>
+          <p:nvPr/>
+        </p:nvSpPr>
+        <p:spPr>
+          <a:xfrm>
+            <a:off x="1188720" y="3438144"/>
+            <a:ext cx="1143000" cy="548640"/>
+          </a:xfrm>
+          <a:prstGeom prst="rect">
+            <a:avLst/>
+          </a:prstGeom>
+          <a:noFill/>
+          <a:ln/>
+        </p:spPr>
+        <p:txBody>
+          <a:bodyPr wrap="square" lIns="0" tIns="0" rIns="0" bIns="0" rtlCol="0" anchor="ctr"/>
+          <a:lstStyle/>
+          <a:p>
+            <a:pPr algn="ctr" indent="0" marL="0">
+              <a:buNone/>
+            </a:pPr>
+            <a:r>
+              <a:rPr lang="en-US" sz="2000" b="1" dirty="0">
+                <a:solidFill>
+                  <a:srgbClr val="0A7D2A"/>
+                </a:solidFill>
+              </a:rPr>
+              <a:t>9</a:t>
+            </a:r>
+            <a:endParaRPr lang="en-US" sz="2000" dirty="0"/>
+          </a:p>
+          <a:p>
+            <a:pPr algn="ctr" indent="0" marL="0">
+              <a:buNone/>
+            </a:pPr>
+            <a:r>
+              <a:rPr lang="en-US" sz="900" dirty="0">
+                <a:solidFill>
+                  <a:srgbClr val="666666"/>
+                </a:solidFill>
+              </a:rPr>
+              <a:t>TP</a:t>
+            </a:r>
+            <a:endParaRPr lang="en-US" sz="2000" dirty="0"/>
+          </a:p>
+        </p:txBody>
+      </p:sp>
+      <p:sp>
+        <p:nvSpPr>
+          <p:cNvPr id="39" name="Shape 37"/>
+          <p:cNvSpPr/>
+          <p:nvPr/>
+        </p:nvSpPr>
+        <p:spPr>
+          <a:xfrm>
+            <a:off x="2331720" y="3438144"/>
+            <a:ext cx="1143000" cy="548640"/>
+          </a:xfrm>
+          <a:prstGeom prst="rect">
+            <a:avLst/>
+          </a:prstGeom>
+          <a:solidFill>
+            <a:srgbClr val="F5D5CE"/>
+          </a:solidFill>
+          <a:ln w="6350">
+            <a:solidFill>
+              <a:srgbClr val="999999"/>
+            </a:solidFill>
+            <a:prstDash val="solid"/>
+          </a:ln>
+        </p:spPr>
+      </p:sp>
+      <p:sp>
+        <p:nvSpPr>
+          <p:cNvPr id="40" name="Text 38"/>
+          <p:cNvSpPr/>
+          <p:nvPr/>
+        </p:nvSpPr>
+        <p:spPr>
+          <a:xfrm>
+            <a:off x="2331720" y="3438144"/>
+            <a:ext cx="1143000" cy="548640"/>
+          </a:xfrm>
+          <a:prstGeom prst="rect">
+            <a:avLst/>
+          </a:prstGeom>
+          <a:noFill/>
+          <a:ln/>
+        </p:spPr>
+        <p:txBody>
+          <a:bodyPr wrap="square" lIns="0" tIns="0" rIns="0" bIns="0" rtlCol="0" anchor="ctr"/>
+          <a:lstStyle/>
+          <a:p>
+            <a:pPr algn="ctr" indent="0" marL="0">
+              <a:buNone/>
+            </a:pPr>
+            <a:r>
+              <a:rPr lang="en-US" sz="2000" b="1" dirty="0">
+                <a:solidFill>
+                  <a:srgbClr val="B33A1E"/>
+                </a:solidFill>
+              </a:rPr>
+              <a:t>0</a:t>
+            </a:r>
+            <a:endParaRPr lang="en-US" sz="2000" dirty="0"/>
+          </a:p>
+          <a:p>
+            <a:pPr algn="ctr" indent="0" marL="0">
+              <a:buNone/>
+            </a:pPr>
+            <a:r>
+              <a:rPr lang="en-US" sz="900" dirty="0">
+                <a:solidFill>
+                  <a:srgbClr val="666666"/>
+                </a:solidFill>
+              </a:rPr>
+              <a:t>FN</a:t>
+            </a:r>
+            <a:endParaRPr lang="en-US" sz="2000" dirty="0"/>
+          </a:p>
+        </p:txBody>
+      </p:sp>
+      <p:sp>
+        <p:nvSpPr>
+          <p:cNvPr id="41" name="Shape 39"/>
+          <p:cNvSpPr/>
+          <p:nvPr/>
+        </p:nvSpPr>
+        <p:spPr>
+          <a:xfrm>
+            <a:off x="1188720" y="3986784"/>
+            <a:ext cx="1143000" cy="548640"/>
+          </a:xfrm>
+          <a:prstGeom prst="rect">
+            <a:avLst/>
+          </a:prstGeom>
+          <a:solidFill>
+            <a:srgbClr val="F2F2F2"/>
+          </a:solidFill>
+          <a:ln w="6350">
+            <a:solidFill>
+              <a:srgbClr val="999999"/>
+            </a:solidFill>
+            <a:prstDash val="solid"/>
+          </a:ln>
+        </p:spPr>
+      </p:sp>
+      <p:sp>
+        <p:nvSpPr>
+          <p:cNvPr id="42" name="Text 40"/>
+          <p:cNvSpPr/>
+          <p:nvPr/>
+        </p:nvSpPr>
+        <p:spPr>
+          <a:xfrm>
+            <a:off x="1188720" y="3986784"/>
+            <a:ext cx="1143000" cy="548640"/>
+          </a:xfrm>
+          <a:prstGeom prst="rect">
+            <a:avLst/>
+          </a:prstGeom>
+          <a:noFill/>
+          <a:ln/>
+        </p:spPr>
+        <p:txBody>
+          <a:bodyPr wrap="square" lIns="0" tIns="0" rIns="0" bIns="0" rtlCol="0" anchor="ctr"/>
+          <a:lstStyle/>
+          <a:p>
+            <a:pPr algn="ctr" indent="0" marL="0">
+              <a:buNone/>
+            </a:pPr>
+            <a:r>
+              <a:rPr lang="en-US" sz="2000" b="1" dirty="0">
+                <a:solidFill>
+                  <a:srgbClr val="888888"/>
+                </a:solidFill>
+              </a:rPr>
+              <a:t>0</a:t>
+            </a:r>
+            <a:endParaRPr lang="en-US" sz="2000" dirty="0"/>
+          </a:p>
+          <a:p>
+            <a:pPr algn="ctr" indent="0" marL="0">
+              <a:buNone/>
+            </a:pPr>
+            <a:r>
+              <a:rPr lang="en-US" sz="900" dirty="0">
+                <a:solidFill>
+                  <a:srgbClr val="666666"/>
+                </a:solidFill>
+              </a:rPr>
+              <a:t>FP</a:t>
+            </a:r>
+            <a:endParaRPr lang="en-US" sz="2000" dirty="0"/>
+          </a:p>
+        </p:txBody>
+      </p:sp>
+      <p:sp>
+        <p:nvSpPr>
+          <p:cNvPr id="43" name="Shape 41"/>
+          <p:cNvSpPr/>
+          <p:nvPr/>
+        </p:nvSpPr>
+        <p:spPr>
+          <a:xfrm>
+            <a:off x="2331720" y="3986784"/>
+            <a:ext cx="1143000" cy="548640"/>
+          </a:xfrm>
+          <a:prstGeom prst="rect">
+            <a:avLst/>
+          </a:prstGeom>
+          <a:solidFill>
+            <a:srgbClr val="EAEAEA"/>
+          </a:solidFill>
+          <a:ln w="6350">
+            <a:solidFill>
+              <a:srgbClr val="999999"/>
+            </a:solidFill>
+            <a:prstDash val="solid"/>
+          </a:ln>
+        </p:spPr>
+      </p:sp>
+      <p:sp>
+        <p:nvSpPr>
+          <p:cNvPr id="44" name="Text 42"/>
+          <p:cNvSpPr/>
+          <p:nvPr/>
+        </p:nvSpPr>
+        <p:spPr>
+          <a:xfrm>
+            <a:off x="2331720" y="3986784"/>
+            <a:ext cx="1143000" cy="548640"/>
+          </a:xfrm>
+          <a:prstGeom prst="rect">
+            <a:avLst/>
+          </a:prstGeom>
+          <a:noFill/>
+          <a:ln/>
+        </p:spPr>
+        <p:txBody>
+          <a:bodyPr wrap="square" lIns="0" tIns="0" rIns="0" bIns="0" rtlCol="0" anchor="ctr"/>
+          <a:lstStyle/>
+          <a:p>
+            <a:pPr algn="ctr" indent="0" marL="0">
+              <a:buNone/>
+            </a:pPr>
+            <a:r>
+              <a:rPr lang="en-US" sz="2000" b="1" dirty="0">
+                <a:solidFill>
+                  <a:srgbClr val="555555"/>
+                </a:solidFill>
+              </a:rPr>
+              <a:t>36</a:t>
+            </a:r>
+            <a:endParaRPr lang="en-US" sz="2000" dirty="0"/>
+          </a:p>
+          <a:p>
+            <a:pPr algn="ctr" indent="0" marL="0">
+              <a:buNone/>
+            </a:pPr>
+            <a:r>
+              <a:rPr lang="en-US" sz="900" dirty="0">
+                <a:solidFill>
+                  <a:srgbClr val="666666"/>
+                </a:solidFill>
+              </a:rPr>
+              <a:t>TN</a:t>
+            </a:r>
+            <a:endParaRPr lang="en-US" sz="2000" dirty="0"/>
+          </a:p>
+        </p:txBody>
+      </p:sp>
+      <p:sp>
+        <p:nvSpPr>
+          <p:cNvPr id="45" name="Text 43"/>
+          <p:cNvSpPr/>
+          <p:nvPr/>
+        </p:nvSpPr>
+        <p:spPr>
+          <a:xfrm>
+            <a:off x="640080" y="4553712"/>
+            <a:ext cx="2834640" cy="201168"/>
+          </a:xfrm>
+          <a:prstGeom prst="rect">
+            <a:avLst/>
+          </a:prstGeom>
+          <a:noFill/>
+          <a:ln/>
+        </p:spPr>
+        <p:txBody>
+          <a:bodyPr wrap="square" lIns="0" tIns="0" rIns="0" bIns="0" rtlCol="0" anchor="ctr"/>
+          <a:lstStyle/>
+          <a:p>
+            <a:pPr algn="ctr" indent="0" marL="0">
+              <a:buNone/>
+            </a:pPr>
+            <a:r>
+              <a:rPr lang="en-US" sz="1100" i="1" dirty="0">
+                <a:solidFill>
+                  <a:srgbClr val="555555"/>
+                </a:solidFill>
+              </a:rPr>
+              <a:t>Precision </a:t>
+            </a:r>
+            <a:pPr algn="ctr" indent="0" marL="0">
+              <a:buNone/>
+            </a:pPr>
+            <a:r>
+              <a:rPr lang="en-US" sz="1100" b="1" i="1" dirty="0">
+                <a:solidFill>
+                  <a:srgbClr val="1A1A1A"/>
+                </a:solidFill>
+              </a:rPr>
+              <a:t>1.00</a:t>
+            </a:r>
+            <a:pPr algn="ctr" indent="0" marL="0">
+              <a:buNone/>
+            </a:pPr>
+            <a:r>
+              <a:rPr lang="en-US" sz="1100" i="1" dirty="0">
+                <a:solidFill>
+                  <a:srgbClr val="555555"/>
+                </a:solidFill>
+              </a:rPr>
+              <a:t>   ·   Recall </a:t>
+            </a:r>
+            <a:pPr algn="ctr" indent="0" marL="0">
+              <a:buNone/>
+            </a:pPr>
+            <a:r>
+              <a:rPr lang="en-US" sz="1100" b="1" i="1" dirty="0">
+                <a:solidFill>
+                  <a:srgbClr val="1A1A1A"/>
+                </a:solidFill>
+              </a:rPr>
+              <a:t>1.00</a:t>
+            </a:r>
+            <a:endParaRPr lang="en-US" sz="1100" dirty="0"/>
+          </a:p>
+        </p:txBody>
+      </p:sp>
+      <p:sp>
+        <p:nvSpPr>
+          <p:cNvPr id="46" name="Text 44"/>
+          <p:cNvSpPr/>
+          <p:nvPr/>
+        </p:nvSpPr>
+        <p:spPr>
+          <a:xfrm>
+            <a:off x="4754880" y="2926080"/>
+            <a:ext cx="2834640" cy="201168"/>
+          </a:xfrm>
+          <a:prstGeom prst="rect">
+            <a:avLst/>
+          </a:prstGeom>
+          <a:noFill/>
+          <a:ln/>
+        </p:spPr>
+        <p:txBody>
+          <a:bodyPr wrap="square" lIns="0" tIns="0" rIns="0" bIns="0" rtlCol="0" anchor="b"/>
+          <a:lstStyle/>
+          <a:p>
+            <a:pPr algn="ctr" indent="0" marL="0">
+              <a:buNone/>
+            </a:pPr>
+            <a:r>
+              <a:rPr lang="en-US" sz="1400" b="1" dirty="0">
                 <a:solidFill>
                   <a:srgbClr val="000000"/>
                 </a:solidFill>
               </a:rPr>
-              <a:t>Ablation confirms each process term contributes real signal; endpoint gain alone does not recover the ranking.</a:t>
-            </a:r>
-            <a:endParaRPr lang="en-US" sz="1600" dirty="0"/>
+              <a:t>Hygiene</a:t>
+            </a:r>
+            <a:endParaRPr lang="en-US" sz="1400" dirty="0"/>
+          </a:p>
+        </p:txBody>
+      </p:sp>
+      <p:sp>
+        <p:nvSpPr>
+          <p:cNvPr id="47" name="Text 45"/>
+          <p:cNvSpPr/>
+          <p:nvPr/>
+        </p:nvSpPr>
+        <p:spPr>
+          <a:xfrm>
+            <a:off x="5303520" y="3145536"/>
+            <a:ext cx="1143000" cy="201168"/>
+          </a:xfrm>
+          <a:prstGeom prst="rect">
+            <a:avLst/>
+          </a:prstGeom>
+          <a:noFill/>
+          <a:ln/>
+        </p:spPr>
+        <p:txBody>
+          <a:bodyPr wrap="square" lIns="0" tIns="0" rIns="0" bIns="0" rtlCol="0" anchor="ctr"/>
+          <a:lstStyle/>
+          <a:p>
+            <a:pPr algn="ctr" indent="0" marL="0">
+              <a:buNone/>
+            </a:pPr>
+            <a:r>
+              <a:rPr lang="en-US" sz="900" i="1" dirty="0">
+                <a:solidFill>
+                  <a:srgbClr val="555555"/>
+                </a:solidFill>
+              </a:rPr>
+              <a:t>Predicted +</a:t>
+            </a:r>
+            <a:endParaRPr lang="en-US" sz="900" dirty="0"/>
+          </a:p>
+        </p:txBody>
+      </p:sp>
+      <p:sp>
+        <p:nvSpPr>
+          <p:cNvPr id="48" name="Text 46"/>
+          <p:cNvSpPr/>
+          <p:nvPr/>
+        </p:nvSpPr>
+        <p:spPr>
+          <a:xfrm>
+            <a:off x="6446520" y="3145536"/>
+            <a:ext cx="1143000" cy="201168"/>
+          </a:xfrm>
+          <a:prstGeom prst="rect">
+            <a:avLst/>
+          </a:prstGeom>
+          <a:noFill/>
+          <a:ln/>
+        </p:spPr>
+        <p:txBody>
+          <a:bodyPr wrap="square" lIns="0" tIns="0" rIns="0" bIns="0" rtlCol="0" anchor="ctr"/>
+          <a:lstStyle/>
+          <a:p>
+            <a:pPr algn="ctr" indent="0" marL="0">
+              <a:buNone/>
+            </a:pPr>
+            <a:r>
+              <a:rPr lang="en-US" sz="900" i="1" dirty="0">
+                <a:solidFill>
+                  <a:srgbClr val="555555"/>
+                </a:solidFill>
+              </a:rPr>
+              <a:t>Predicted −</a:t>
+            </a:r>
+            <a:endParaRPr lang="en-US" sz="900" dirty="0"/>
+          </a:p>
+        </p:txBody>
+      </p:sp>
+      <p:sp>
+        <p:nvSpPr>
+          <p:cNvPr id="49" name="Text 47"/>
+          <p:cNvSpPr/>
+          <p:nvPr/>
+        </p:nvSpPr>
+        <p:spPr>
+          <a:xfrm>
+            <a:off x="4754880" y="3364992"/>
+            <a:ext cx="548640" cy="548640"/>
+          </a:xfrm>
+          <a:prstGeom prst="rect">
+            <a:avLst/>
+          </a:prstGeom>
+          <a:noFill/>
+          <a:ln/>
+        </p:spPr>
+        <p:txBody>
+          <a:bodyPr wrap="square" lIns="508" tIns="508" rIns="508" bIns="508" rtlCol="0" anchor="ctr"/>
+          <a:lstStyle/>
+          <a:p>
+            <a:pPr algn="r" indent="0" marL="0">
+              <a:buNone/>
+            </a:pPr>
+            <a:r>
+              <a:rPr lang="en-US" sz="900" i="1" dirty="0">
+                <a:solidFill>
+                  <a:srgbClr val="555555"/>
+                </a:solidFill>
+              </a:rPr>
+              <a:t>Actual +</a:t>
+            </a:r>
+            <a:endParaRPr lang="en-US" sz="900" dirty="0"/>
+          </a:p>
+        </p:txBody>
+      </p:sp>
+      <p:sp>
+        <p:nvSpPr>
+          <p:cNvPr id="50" name="Text 48"/>
+          <p:cNvSpPr/>
+          <p:nvPr/>
+        </p:nvSpPr>
+        <p:spPr>
+          <a:xfrm>
+            <a:off x="4754880" y="3913632"/>
+            <a:ext cx="548640" cy="548640"/>
+          </a:xfrm>
+          <a:prstGeom prst="rect">
+            <a:avLst/>
+          </a:prstGeom>
+          <a:noFill/>
+          <a:ln/>
+        </p:spPr>
+        <p:txBody>
+          <a:bodyPr wrap="square" lIns="508" tIns="508" rIns="508" bIns="508" rtlCol="0" anchor="ctr"/>
+          <a:lstStyle/>
+          <a:p>
+            <a:pPr algn="r" indent="0" marL="0">
+              <a:buNone/>
+            </a:pPr>
+            <a:r>
+              <a:rPr lang="en-US" sz="900" i="1" dirty="0">
+                <a:solidFill>
+                  <a:srgbClr val="555555"/>
+                </a:solidFill>
+              </a:rPr>
+              <a:t>Actual −</a:t>
+            </a:r>
+            <a:endParaRPr lang="en-US" sz="900" dirty="0"/>
+          </a:p>
+        </p:txBody>
+      </p:sp>
+      <p:sp>
+        <p:nvSpPr>
+          <p:cNvPr id="51" name="Shape 49"/>
+          <p:cNvSpPr/>
+          <p:nvPr/>
+        </p:nvSpPr>
+        <p:spPr>
+          <a:xfrm>
+            <a:off x="5303520" y="3438144"/>
+            <a:ext cx="1143000" cy="548640"/>
+          </a:xfrm>
+          <a:prstGeom prst="rect">
+            <a:avLst/>
+          </a:prstGeom>
+          <a:solidFill>
+            <a:srgbClr val="D4F0DC"/>
+          </a:solidFill>
+          <a:ln w="6350">
+            <a:solidFill>
+              <a:srgbClr val="999999"/>
+            </a:solidFill>
+            <a:prstDash val="solid"/>
+          </a:ln>
+        </p:spPr>
+      </p:sp>
+      <p:sp>
+        <p:nvSpPr>
+          <p:cNvPr id="52" name="Text 50"/>
+          <p:cNvSpPr/>
+          <p:nvPr/>
+        </p:nvSpPr>
+        <p:spPr>
+          <a:xfrm>
+            <a:off x="5303520" y="3438144"/>
+            <a:ext cx="1143000" cy="548640"/>
+          </a:xfrm>
+          <a:prstGeom prst="rect">
+            <a:avLst/>
+          </a:prstGeom>
+          <a:noFill/>
+          <a:ln/>
+        </p:spPr>
+        <p:txBody>
+          <a:bodyPr wrap="square" lIns="0" tIns="0" rIns="0" bIns="0" rtlCol="0" anchor="ctr"/>
+          <a:lstStyle/>
+          <a:p>
+            <a:pPr algn="ctr" indent="0" marL="0">
+              <a:buNone/>
+            </a:pPr>
+            <a:r>
+              <a:rPr lang="en-US" sz="2000" b="1" dirty="0">
+                <a:solidFill>
+                  <a:srgbClr val="0A7D2A"/>
+                </a:solidFill>
+              </a:rPr>
+              <a:t>8</a:t>
+            </a:r>
+            <a:endParaRPr lang="en-US" sz="2000" dirty="0"/>
+          </a:p>
+          <a:p>
+            <a:pPr algn="ctr" indent="0" marL="0">
+              <a:buNone/>
+            </a:pPr>
+            <a:r>
+              <a:rPr lang="en-US" sz="900" dirty="0">
+                <a:solidFill>
+                  <a:srgbClr val="666666"/>
+                </a:solidFill>
+              </a:rPr>
+              <a:t>TP</a:t>
+            </a:r>
+            <a:endParaRPr lang="en-US" sz="2000" dirty="0"/>
+          </a:p>
+        </p:txBody>
+      </p:sp>
+      <p:sp>
+        <p:nvSpPr>
+          <p:cNvPr id="53" name="Shape 51"/>
+          <p:cNvSpPr/>
+          <p:nvPr/>
+        </p:nvSpPr>
+        <p:spPr>
+          <a:xfrm>
+            <a:off x="6446520" y="3438144"/>
+            <a:ext cx="1143000" cy="548640"/>
+          </a:xfrm>
+          <a:prstGeom prst="rect">
+            <a:avLst/>
+          </a:prstGeom>
+          <a:solidFill>
+            <a:srgbClr val="F5D5CE"/>
+          </a:solidFill>
+          <a:ln w="6350">
+            <a:solidFill>
+              <a:srgbClr val="999999"/>
+            </a:solidFill>
+            <a:prstDash val="solid"/>
+          </a:ln>
+        </p:spPr>
+      </p:sp>
+      <p:sp>
+        <p:nvSpPr>
+          <p:cNvPr id="54" name="Text 52"/>
+          <p:cNvSpPr/>
+          <p:nvPr/>
+        </p:nvSpPr>
+        <p:spPr>
+          <a:xfrm>
+            <a:off x="6446520" y="3438144"/>
+            <a:ext cx="1143000" cy="548640"/>
+          </a:xfrm>
+          <a:prstGeom prst="rect">
+            <a:avLst/>
+          </a:prstGeom>
+          <a:noFill/>
+          <a:ln/>
+        </p:spPr>
+        <p:txBody>
+          <a:bodyPr wrap="square" lIns="0" tIns="0" rIns="0" bIns="0" rtlCol="0" anchor="ctr"/>
+          <a:lstStyle/>
+          <a:p>
+            <a:pPr algn="ctr" indent="0" marL="0">
+              <a:buNone/>
+            </a:pPr>
+            <a:r>
+              <a:rPr lang="en-US" sz="2000" b="1" dirty="0">
+                <a:solidFill>
+                  <a:srgbClr val="B33A1E"/>
+                </a:solidFill>
+              </a:rPr>
+              <a:t>0</a:t>
+            </a:r>
+            <a:endParaRPr lang="en-US" sz="2000" dirty="0"/>
+          </a:p>
+          <a:p>
+            <a:pPr algn="ctr" indent="0" marL="0">
+              <a:buNone/>
+            </a:pPr>
+            <a:r>
+              <a:rPr lang="en-US" sz="900" dirty="0">
+                <a:solidFill>
+                  <a:srgbClr val="666666"/>
+                </a:solidFill>
+              </a:rPr>
+              <a:t>FN</a:t>
+            </a:r>
+            <a:endParaRPr lang="en-US" sz="2000" dirty="0"/>
+          </a:p>
+        </p:txBody>
+      </p:sp>
+      <p:sp>
+        <p:nvSpPr>
+          <p:cNvPr id="55" name="Shape 53"/>
+          <p:cNvSpPr/>
+          <p:nvPr/>
+        </p:nvSpPr>
+        <p:spPr>
+          <a:xfrm>
+            <a:off x="5303520" y="3986784"/>
+            <a:ext cx="1143000" cy="548640"/>
+          </a:xfrm>
+          <a:prstGeom prst="rect">
+            <a:avLst/>
+          </a:prstGeom>
+          <a:solidFill>
+            <a:srgbClr val="F2F2F2"/>
+          </a:solidFill>
+          <a:ln w="6350">
+            <a:solidFill>
+              <a:srgbClr val="999999"/>
+            </a:solidFill>
+            <a:prstDash val="solid"/>
+          </a:ln>
+        </p:spPr>
+      </p:sp>
+      <p:sp>
+        <p:nvSpPr>
+          <p:cNvPr id="56" name="Text 54"/>
+          <p:cNvSpPr/>
+          <p:nvPr/>
+        </p:nvSpPr>
+        <p:spPr>
+          <a:xfrm>
+            <a:off x="5303520" y="3986784"/>
+            <a:ext cx="1143000" cy="548640"/>
+          </a:xfrm>
+          <a:prstGeom prst="rect">
+            <a:avLst/>
+          </a:prstGeom>
+          <a:noFill/>
+          <a:ln/>
+        </p:spPr>
+        <p:txBody>
+          <a:bodyPr wrap="square" lIns="0" tIns="0" rIns="0" bIns="0" rtlCol="0" anchor="ctr"/>
+          <a:lstStyle/>
+          <a:p>
+            <a:pPr algn="ctr" indent="0" marL="0">
+              <a:buNone/>
+            </a:pPr>
+            <a:r>
+              <a:rPr lang="en-US" sz="2000" b="1" dirty="0">
+                <a:solidFill>
+                  <a:srgbClr val="888888"/>
+                </a:solidFill>
+              </a:rPr>
+              <a:t>0</a:t>
+            </a:r>
+            <a:endParaRPr lang="en-US" sz="2000" dirty="0"/>
+          </a:p>
+          <a:p>
+            <a:pPr algn="ctr" indent="0" marL="0">
+              <a:buNone/>
+            </a:pPr>
+            <a:r>
+              <a:rPr lang="en-US" sz="900" dirty="0">
+                <a:solidFill>
+                  <a:srgbClr val="666666"/>
+                </a:solidFill>
+              </a:rPr>
+              <a:t>FP</a:t>
+            </a:r>
+            <a:endParaRPr lang="en-US" sz="2000" dirty="0"/>
+          </a:p>
+        </p:txBody>
+      </p:sp>
+      <p:sp>
+        <p:nvSpPr>
+          <p:cNvPr id="57" name="Shape 55"/>
+          <p:cNvSpPr/>
+          <p:nvPr/>
+        </p:nvSpPr>
+        <p:spPr>
+          <a:xfrm>
+            <a:off x="6446520" y="3986784"/>
+            <a:ext cx="1143000" cy="548640"/>
+          </a:xfrm>
+          <a:prstGeom prst="rect">
+            <a:avLst/>
+          </a:prstGeom>
+          <a:solidFill>
+            <a:srgbClr val="EAEAEA"/>
+          </a:solidFill>
+          <a:ln w="6350">
+            <a:solidFill>
+              <a:srgbClr val="999999"/>
+            </a:solidFill>
+            <a:prstDash val="solid"/>
+          </a:ln>
+        </p:spPr>
+      </p:sp>
+      <p:sp>
+        <p:nvSpPr>
+          <p:cNvPr id="58" name="Text 56"/>
+          <p:cNvSpPr/>
+          <p:nvPr/>
+        </p:nvSpPr>
+        <p:spPr>
+          <a:xfrm>
+            <a:off x="6446520" y="3986784"/>
+            <a:ext cx="1143000" cy="548640"/>
+          </a:xfrm>
+          <a:prstGeom prst="rect">
+            <a:avLst/>
+          </a:prstGeom>
+          <a:noFill/>
+          <a:ln/>
+        </p:spPr>
+        <p:txBody>
+          <a:bodyPr wrap="square" lIns="0" tIns="0" rIns="0" bIns="0" rtlCol="0" anchor="ctr"/>
+          <a:lstStyle/>
+          <a:p>
+            <a:pPr algn="ctr" indent="0" marL="0">
+              <a:buNone/>
+            </a:pPr>
+            <a:r>
+              <a:rPr lang="en-US" sz="2000" b="1" dirty="0">
+                <a:solidFill>
+                  <a:srgbClr val="555555"/>
+                </a:solidFill>
+              </a:rPr>
+              <a:t>37</a:t>
+            </a:r>
+            <a:endParaRPr lang="en-US" sz="2000" dirty="0"/>
+          </a:p>
+          <a:p>
+            <a:pPr algn="ctr" indent="0" marL="0">
+              <a:buNone/>
+            </a:pPr>
+            <a:r>
+              <a:rPr lang="en-US" sz="900" dirty="0">
+                <a:solidFill>
+                  <a:srgbClr val="666666"/>
+                </a:solidFill>
+              </a:rPr>
+              <a:t>TN</a:t>
+            </a:r>
+            <a:endParaRPr lang="en-US" sz="2000" dirty="0"/>
+          </a:p>
+        </p:txBody>
+      </p:sp>
+      <p:sp>
+        <p:nvSpPr>
+          <p:cNvPr id="59" name="Text 57"/>
+          <p:cNvSpPr/>
+          <p:nvPr/>
+        </p:nvSpPr>
+        <p:spPr>
+          <a:xfrm>
+            <a:off x="4754880" y="4553712"/>
+            <a:ext cx="2834640" cy="201168"/>
+          </a:xfrm>
+          <a:prstGeom prst="rect">
+            <a:avLst/>
+          </a:prstGeom>
+          <a:noFill/>
+          <a:ln/>
+        </p:spPr>
+        <p:txBody>
+          <a:bodyPr wrap="square" lIns="0" tIns="0" rIns="0" bIns="0" rtlCol="0" anchor="ctr"/>
+          <a:lstStyle/>
+          <a:p>
+            <a:pPr algn="ctr" indent="0" marL="0">
+              <a:buNone/>
+            </a:pPr>
+            <a:r>
+              <a:rPr lang="en-US" sz="1100" i="1" dirty="0">
+                <a:solidFill>
+                  <a:srgbClr val="555555"/>
+                </a:solidFill>
+              </a:rPr>
+              <a:t>Precision </a:t>
+            </a:r>
+            <a:pPr algn="ctr" indent="0" marL="0">
+              <a:buNone/>
+            </a:pPr>
+            <a:r>
+              <a:rPr lang="en-US" sz="1100" b="1" i="1" dirty="0">
+                <a:solidFill>
+                  <a:srgbClr val="1A1A1A"/>
+                </a:solidFill>
+              </a:rPr>
+              <a:t>1.00</a:t>
+            </a:r>
+            <a:pPr algn="ctr" indent="0" marL="0">
+              <a:buNone/>
+            </a:pPr>
+            <a:r>
+              <a:rPr lang="en-US" sz="1100" i="1" dirty="0">
+                <a:solidFill>
+                  <a:srgbClr val="555555"/>
+                </a:solidFill>
+              </a:rPr>
+              <a:t>   ·   Recall </a:t>
+            </a:r>
+            <a:pPr algn="ctr" indent="0" marL="0">
+              <a:buNone/>
+            </a:pPr>
+            <a:r>
+              <a:rPr lang="en-US" sz="1100" b="1" i="1" dirty="0">
+                <a:solidFill>
+                  <a:srgbClr val="1A1A1A"/>
+                </a:solidFill>
+              </a:rPr>
+              <a:t>1.00</a:t>
+            </a:r>
+            <a:endParaRPr lang="en-US" sz="1100" dirty="0"/>
+          </a:p>
+        </p:txBody>
+      </p:sp>
+      <p:sp>
+        <p:nvSpPr>
+          <p:cNvPr id="60" name="Text 58"/>
+          <p:cNvSpPr/>
+          <p:nvPr/>
+        </p:nvSpPr>
+        <p:spPr>
+          <a:xfrm>
+            <a:off x="365760" y="4846320"/>
+            <a:ext cx="8412480" cy="256032"/>
+          </a:xfrm>
+          <a:prstGeom prst="rect">
+            <a:avLst/>
+          </a:prstGeom>
+          <a:noFill/>
+          <a:ln/>
+        </p:spPr>
+        <p:txBody>
+          <a:bodyPr wrap="square" lIns="0" tIns="0" rIns="0" bIns="0" rtlCol="0" anchor="ctr"/>
+          <a:lstStyle/>
+          <a:p>
+            <a:pPr algn="ctr" indent="0" marL="0">
+              <a:buNone/>
+            </a:pPr>
+            <a:r>
+              <a:rPr lang="en-US" sz="900" i="1" dirty="0">
+                <a:solidFill>
+                  <a:srgbClr val="555555"/>
+                </a:solidFill>
+              </a:rPr>
+              <a:t>Ordering recall is the outlier: the reorder synthesiser's splitOnInvalid validator rejects any window containing a step it cannot safely.</a:t>
+            </a:r>
+            <a:endParaRPr lang="en-US" sz="900" dirty="0"/>
           </a:p>
         </p:txBody>
       </p:sp>
@@ -4445,7 +6796,7 @@
                   <a:srgbClr val="000000"/>
                 </a:solidFill>
               </a:rPr>
-              <a:t>User study: does feedback change behaviour?</a:t>
+              <a:t>Score robustness</a:t>
             </a:r>
             <a:endParaRPr lang="en-US" sz="2800" dirty="0"/>
           </a:p>
@@ -4485,7 +6836,7 @@
                   <a:srgbClr val="000000"/>
                 </a:solidFill>
               </a:rPr>
-              <a:t>With-feedback group: 2.7 divergence points per session.</a:t>
+              <a:t>Single-knob sensitivity sweep: scale any one weight by {0.1×–10×}, top-1 recommendation is preserved in 96.5% of user-study cases.</a:t>
             </a:r>
             <a:endParaRPr lang="en-US" sz="1600" dirty="0"/>
           </a:p>
@@ -4503,7 +6854,7 @@
                   <a:srgbClr val="000000"/>
                 </a:solidFill>
               </a:rPr>
-              <a:t>No-feedback baseline: 6.0 divergence points per session -2.2× difference.</a:t>
+              <a:t>Multi-knob Monte Carlo (200 samples): top-1 stability drops to 84.6%; mean Kendall τ = 0.586.</a:t>
             </a:r>
             <a:endParaRPr lang="en-US" sz="1600" dirty="0"/>
           </a:p>
@@ -4521,7 +6872,7 @@
                   <a:srgbClr val="000000"/>
                 </a:solidFill>
               </a:rPr>
-              <a:t>Gain-stripped process-score slope across the 6-session arc -+4.47 per session with feedback, −0.40 per session without.</a:t>
+              <a:t>Honest framing - stable near the chosen weights, less stable under arbitrary joint perturbations.</a:t>
             </a:r>
             <a:endParaRPr lang="en-US" sz="1600" dirty="0"/>
           </a:p>
@@ -4539,7 +6890,7 @@
                   <a:srgbClr val="000000"/>
                 </a:solidFill>
               </a:rPr>
-              <a:t>Caveat: n=3 vs n=2 is directional evidence, not a hypothesis test.</a:t>
+              <a:t>Ablation confirms each process term contributes real signal; endpoint gain alone does not recover the ranking.</a:t>
             </a:r>
             <a:endParaRPr lang="en-US" sz="1600" dirty="0"/>
           </a:p>
@@ -4600,7 +6951,7 @@
                   <a:srgbClr val="000000"/>
                 </a:solidFill>
               </a:rPr>
-              <a:t>Contributions</a:t>
+              <a:t>User study: does feedback change behaviour?</a:t>
             </a:r>
             <a:endParaRPr lang="en-US" sz="2800" dirty="0"/>
           </a:p>
@@ -4640,7 +6991,7 @@
                   <a:srgbClr val="000000"/>
                 </a:solidFill>
               </a:rPr>
-              <a:t>A process-quality metric J(τ) combining endpoint, process, and safety signals in one principled score.</a:t>
+              <a:t>With-feedback group: 2.7 divergence points per session.</a:t>
             </a:r>
             <a:endParaRPr lang="en-US" sz="1600" dirty="0"/>
           </a:p>
@@ -4658,7 +7009,7 @@
                   <a:srgbClr val="000000"/>
                 </a:solidFill>
               </a:rPr>
-              <a:t>A divergence-point detector with four actionable kinds, each with a per-kind synthesiser that constructs a concrete alternative trajectory.</a:t>
+              <a:t>No-feedback baseline: 6.0 divergence points per session -2.2× difference.</a:t>
             </a:r>
             <a:endParaRPr lang="en-US" sz="1600" dirty="0"/>
           </a:p>
@@ -4676,7 +7027,7 @@
                   <a:srgbClr val="000000"/>
                 </a:solidFill>
               </a:rPr>
-              <a:t>Three datasets -45 injection sessions, 30-session user study, 48-session agent extension - with reproducible analysis (Jupyter notebook reproduces every table and figure).</a:t>
+              <a:t>Gain-stripped process-score slope across the 6-session arc -+4.47 per session with feedback, −0.40 per session without.</a:t>
             </a:r>
             <a:endParaRPr lang="en-US" sz="1600" dirty="0"/>
           </a:p>
@@ -4694,7 +7045,7 @@
                   <a:srgbClr val="000000"/>
                 </a:solidFill>
               </a:rPr>
-              <a:t>A deployable end-to-end system: IntelliJ plugin, analysis backend, and dashboard.</a:t>
+              <a:t>Caveat: n=3 vs n=2 is directional evidence, not a hypothesis test.</a:t>
             </a:r>
             <a:endParaRPr lang="en-US" sz="1600" dirty="0"/>
           </a:p>
@@ -4890,6 +7241,161 @@
                 </a:solidFill>
               </a:rPr>
               <a:t>Endpoint-only evaluation cannot tell them apart.</a:t>
+            </a:r>
+            <a:endParaRPr lang="en-US" sz="1600" dirty="0"/>
+          </a:p>
+        </p:txBody>
+      </p:sp>
+    </p:spTree>
+  </p:cSld>
+  <p:clrMapOvr>
+    <a:masterClrMapping/>
+  </p:clrMapOvr>
+</p:sld>
+</file>
+
+<file path=ppt/slides/slide20.xml><?xml version="1.0" encoding="utf-8"?>
+<p:sld xmlns:a="http://schemas.openxmlformats.org/drawingml/2006/main" xmlns:r="http://schemas.openxmlformats.org/officeDocument/2006/relationships" xmlns:p="http://schemas.openxmlformats.org/presentationml/2006/main">
+  <p:cSld name="Slide 20">
+    <p:spTree>
+      <p:nvGrpSpPr>
+        <p:cNvPr id="1" name=""/>
+        <p:cNvGrpSpPr/>
+        <p:nvPr/>
+      </p:nvGrpSpPr>
+      <p:grpSpPr>
+        <a:xfrm>
+          <a:off x="0" y="0"/>
+          <a:ext cx="0" cy="0"/>
+          <a:chOff x="0" y="0"/>
+          <a:chExt cx="0" cy="0"/>
+        </a:xfrm>
+      </p:grpSpPr>
+      <p:sp>
+        <p:nvSpPr>
+          <p:cNvPr id="2" name="Text 0"/>
+          <p:cNvSpPr/>
+          <p:nvPr/>
+        </p:nvSpPr>
+        <p:spPr>
+          <a:xfrm>
+            <a:off x="457200" y="274320"/>
+            <a:ext cx="8229600" cy="640080"/>
+          </a:xfrm>
+          <a:prstGeom prst="rect">
+            <a:avLst/>
+          </a:prstGeom>
+          <a:noFill/>
+          <a:ln/>
+        </p:spPr>
+        <p:txBody>
+          <a:bodyPr wrap="square" lIns="0" tIns="0" rIns="0" bIns="0" rtlCol="0" anchor="ctr"/>
+          <a:lstStyle/>
+          <a:p>
+            <a:pPr indent="0" marL="0">
+              <a:buNone/>
+            </a:pPr>
+            <a:r>
+              <a:rPr lang="en-US" sz="2800" b="1" dirty="0">
+                <a:solidFill>
+                  <a:srgbClr val="000000"/>
+                </a:solidFill>
+              </a:rPr>
+              <a:t>Contributions</a:t>
+            </a:r>
+            <a:endParaRPr lang="en-US" sz="2800" dirty="0"/>
+          </a:p>
+        </p:txBody>
+      </p:sp>
+      <p:sp>
+        <p:nvSpPr>
+          <p:cNvPr id="3" name="Text 1"/>
+          <p:cNvSpPr/>
+          <p:nvPr/>
+        </p:nvSpPr>
+        <p:spPr>
+          <a:xfrm>
+            <a:off x="457200" y="1188720"/>
+            <a:ext cx="8229600" cy="3657600"/>
+          </a:xfrm>
+          <a:prstGeom prst="rect">
+            <a:avLst/>
+          </a:prstGeom>
+          <a:noFill/>
+          <a:ln/>
+        </p:spPr>
+        <p:txBody>
+          <a:bodyPr wrap="square" rtlCol="0" anchor="t"/>
+          <a:lstStyle/>
+          <a:p>
+            <a:pPr marL="342900" indent="-342900">
+              <a:spcAft>
+                <a:spcPts val="600"/>
+              </a:spcAft>
+              <a:buSzPct val="100000"/>
+              <a:buChar char="•"/>
+            </a:pPr>
+            <a:r>
+              <a:rPr lang="en-US" sz="1600" dirty="0">
+                <a:solidFill>
+                  <a:srgbClr val="000000"/>
+                </a:solidFill>
+              </a:rPr>
+              <a:t>A process-quality metric J(τ) combining endpoint, process, and safety signals in one principled score.</a:t>
+            </a:r>
+            <a:endParaRPr lang="en-US" sz="1600" dirty="0"/>
+          </a:p>
+          <a:p>
+            <a:pPr marL="342900" indent="-342900">
+              <a:spcAft>
+                <a:spcPts val="600"/>
+              </a:spcAft>
+              <a:buSzPct val="100000"/>
+              <a:buChar char="•"/>
+            </a:pPr>
+            <a:r>
+              <a:rPr lang="en-US" sz="1600" dirty="0">
+                <a:solidFill>
+                  <a:srgbClr val="000000"/>
+                </a:solidFill>
+              </a:rPr>
+              <a:t>A divergence-point detector with four actionable kinds, each with a per-kind synthesiser that constructs a concrete alternative trajectory.</a:t>
+            </a:r>
+            <a:endParaRPr lang="en-US" sz="1600" dirty="0"/>
+          </a:p>
+          <a:p>
+            <a:pPr marL="342900" indent="-342900">
+              <a:spcAft>
+                <a:spcPts val="600"/>
+              </a:spcAft>
+              <a:buSzPct val="100000"/>
+              <a:buChar char="•"/>
+            </a:pPr>
+            <a:r>
+              <a:rPr lang="en-US" sz="1600" dirty="0">
+                <a:solidFill>
+                  <a:srgbClr val="000000"/>
+                </a:solidFill>
+              </a:rPr>
+              <a:t>Three datasets -45 injection sessions, 30-session user study, 48-session agent extension - with reproducible analysis (Jupyter notebook reproduces every table and figure).</a:t>
+            </a:r>
+            <a:endParaRPr lang="en-US" sz="1600" dirty="0"/>
+          </a:p>
+          <a:p>
+            <a:pPr marL="342900" indent="-342900">
+              <a:spcAft>
+                <a:spcPts val="600"/>
+              </a:spcAft>
+              <a:buSzPct val="100000"/>
+              <a:buChar char="•"/>
+            </a:pPr>
+            <a:r>
+              <a:rPr lang="en-US" sz="1600" dirty="0">
+                <a:solidFill>
+                  <a:srgbClr val="000000"/>
+                </a:solidFill>
+              </a:rPr>
+              <a:t>A deployable end-to-end system: IntelliJ plugin, analysis backend, and dashboard.</a:t>
             </a:r>
             <a:endParaRPr lang="en-US" sz="1600" dirty="0"/>
           </a:p>

</xml_diff>

<commit_message>
feat: add Are the alternatives actually better slide
</commit_message>
<xml_diff>
--- a/presentation/slides.pptx
+++ b/presentation/slides.pptx
@@ -25,9 +25,10 @@
     <p:sldId id="273" r:id="rId19"/>
     <p:sldId id="274" r:id="rId20"/>
     <p:sldId id="275" r:id="rId21"/>
+    <p:sldId id="276" r:id="rId22"/>
   </p:sldIdLst>
   <p:notesMasterIdLst>
-    <p:notesMasterId r:id="rId22"/>
+    <p:notesMasterId r:id="rId23"/>
   </p:notesMasterIdLst>
   <p:sldSz cx="9144000" cy="5143500"/>
   <p:notesSz cx="5143500" cy="9144000"/>
@@ -1601,6 +1602,94 @@
             <a:fld id="{F7021451-1387-4CA6-816F-3879F97B5CBC}" type="slidenum">
               <a:rPr lang="en-US"/>
               <a:t>20</a:t>
+            </a:fld>
+            <a:endParaRPr lang="en-US"/>
+          </a:p>
+        </p:txBody>
+      </p:sp>
+    </p:spTree>
+    <p:extLst>
+      <p:ext uri="{BB962C8B-B14F-4D97-AF65-F5344CB8AC3E}">
+        <p14:creationId xmlns:p14="http://schemas.microsoft.com/office/powerpoint/2010/main" val="1024086991"/>
+      </p:ext>
+    </p:extLst>
+  </p:cSld>
+  <p:clrMapOvr>
+    <a:masterClrMapping/>
+  </p:clrMapOvr>
+</p:notes>
+</file>
+
+<file path=ppt/notesSlides/notesSlide21.xml><?xml version="1.0" encoding="utf-8"?>
+<p:notes xmlns:a="http://schemas.openxmlformats.org/drawingml/2006/main" xmlns:r="http://schemas.openxmlformats.org/officeDocument/2006/relationships" xmlns:p="http://schemas.openxmlformats.org/presentationml/2006/main">
+  <p:cSld>
+    <p:spTree>
+      <p:nvGrpSpPr>
+        <p:cNvPr id="1" name=""/>
+        <p:cNvGrpSpPr/>
+        <p:nvPr/>
+      </p:nvGrpSpPr>
+      <p:grpSpPr>
+        <a:xfrm>
+          <a:off x="0" y="0"/>
+          <a:ext cx="0" cy="0"/>
+          <a:chOff x="0" y="0"/>
+          <a:chExt cx="0" cy="0"/>
+        </a:xfrm>
+      </p:grpSpPr>
+      <p:sp>
+        <p:nvSpPr>
+          <p:cNvPr id="2" name="Slide Image Placeholder 1"/>
+          <p:cNvSpPr>
+            <a:spLocks noGrp="1" noRot="1" noChangeAspect="1"/>
+          </p:cNvSpPr>
+          <p:nvPr>
+            <p:ph type="sldImg"/>
+          </p:nvPr>
+        </p:nvSpPr>
+        <p:spPr/>
+      </p:sp>
+      <p:sp>
+        <p:nvSpPr>
+          <p:cNvPr id="3" name="Notes Placeholder 2"/>
+          <p:cNvSpPr>
+            <a:spLocks noGrp="1"/>
+          </p:cNvSpPr>
+          <p:nvPr>
+            <p:ph type="body" idx="1"/>
+          </p:nvPr>
+        </p:nvSpPr>
+        <p:spPr/>
+        <p:txBody>
+          <a:bodyPr/>
+          <a:lstStyle/>
+          <a:p>
+            <a:r>
+              <a:rPr lang="en-US" dirty="0"/>
+              <a:t/>
+            </a:r>
+            <a:endParaRPr lang="en-US" dirty="0"/>
+          </a:p>
+        </p:txBody>
+      </p:sp>
+      <p:sp>
+        <p:nvSpPr>
+          <p:cNvPr id="4" name="Slide Number Placeholder 3"/>
+          <p:cNvSpPr>
+            <a:spLocks noGrp="1"/>
+          </p:cNvSpPr>
+          <p:nvPr>
+            <p:ph type="sldNum" sz="quarter" idx="10"/>
+          </p:nvPr>
+        </p:nvSpPr>
+        <p:spPr/>
+        <p:txBody>
+          <a:bodyPr/>
+          <a:lstStyle/>
+          <a:p>
+            <a:fld id="{F7021451-1387-4CA6-816F-3879F97B5CBC}" type="slidenum">
+              <a:rPr lang="en-US"/>
+              <a:t>21</a:t>
             </a:fld>
             <a:endParaRPr lang="en-US"/>
           </a:p>
@@ -3009,7 +3098,7 @@
                   <a:srgbClr val="000000"/>
                 </a:solidFill>
               </a:rPr>
-              <a:t>Detect: run RefactoringMiner on sliding commit windows; cross-check against the IDE event stream — anything RefactoringMiner finds that the IDE did not emit is a manual refactoring.</a:t>
+              <a:t>Detect: run RefactoringMiner on sliding commit windows; cross-check against the IDE event stream - anything RefactoringMiner finds that the IDE did not emit is a manual refactoring.</a:t>
             </a:r>
             <a:endParaRPr lang="en-US" sz="1300" dirty="0"/>
           </a:p>
@@ -3826,7 +3915,7 @@
                             <a:srgbClr val="1A1A1A"/>
                           </a:solidFill>
                         </a:rPr>
-                        <a:t>Is the tool accurate? Does it detect real divergences without false positives?</a:t>
+                        <a:t>Is the tool accurate? Are the alternatives it generates actually better?</a:t>
                       </a:r>
                       <a:endParaRPr lang="en-US" sz="1300" dirty="0"/>
                     </a:p>
@@ -6774,8 +6863,8 @@
         </p:nvSpPr>
         <p:spPr>
           <a:xfrm>
-            <a:off x="457200" y="274320"/>
-            <a:ext cx="8229600" cy="640080"/>
+            <a:off x="457200" y="91440"/>
+            <a:ext cx="8229600" cy="548640"/>
           </a:xfrm>
           <a:prstGeom prst="rect">
             <a:avLst/>
@@ -6796,7 +6885,7 @@
                   <a:srgbClr val="000000"/>
                 </a:solidFill>
               </a:rPr>
-              <a:t>Score robustness</a:t>
+              <a:t>Are the alternatives actually better?</a:t>
             </a:r>
             <a:endParaRPr lang="en-US" sz="2800" dirty="0"/>
           </a:p>
@@ -6810,8 +6899,8 @@
         </p:nvSpPr>
         <p:spPr>
           <a:xfrm>
-            <a:off x="457200" y="1188720"/>
-            <a:ext cx="8229600" cy="3657600"/>
+            <a:off x="457200" y="713232"/>
+            <a:ext cx="8229600" cy="274320"/>
           </a:xfrm>
           <a:prstGeom prst="rect">
             <a:avLst/>
@@ -6820,79 +6909,2200 @@
           <a:ln/>
         </p:spPr>
         <p:txBody>
-          <a:bodyPr wrap="square" rtlCol="0" anchor="t"/>
-          <a:lstStyle/>
-          <a:p>
-            <a:pPr marL="342900" indent="-342900">
-              <a:spcAft>
-                <a:spcPts val="600"/>
-              </a:spcAft>
-              <a:buSzPct val="100000"/>
-              <a:buChar char="•"/>
-            </a:pPr>
-            <a:r>
-              <a:rPr lang="en-US" sz="1600" dirty="0">
-                <a:solidFill>
-                  <a:srgbClr val="000000"/>
-                </a:solidFill>
-              </a:rPr>
-              <a:t>Single-knob sensitivity sweep: scale any one weight by {0.1×–10×}, top-1 recommendation is preserved in 96.5% of user-study cases.</a:t>
-            </a:r>
-            <a:endParaRPr lang="en-US" sz="1600" dirty="0"/>
-          </a:p>
-          <a:p>
-            <a:pPr marL="342900" indent="-342900">
-              <a:spcAft>
-                <a:spcPts val="600"/>
-              </a:spcAft>
-              <a:buSzPct val="100000"/>
-              <a:buChar char="•"/>
-            </a:pPr>
-            <a:r>
-              <a:rPr lang="en-US" sz="1600" dirty="0">
-                <a:solidFill>
-                  <a:srgbClr val="000000"/>
-                </a:solidFill>
-              </a:rPr>
-              <a:t>Multi-knob Monte Carlo (200 samples): top-1 stability drops to 84.6%; mean Kendall τ = 0.586.</a:t>
-            </a:r>
-            <a:endParaRPr lang="en-US" sz="1600" dirty="0"/>
-          </a:p>
-          <a:p>
-            <a:pPr marL="342900" indent="-342900">
-              <a:spcAft>
-                <a:spcPts val="600"/>
-              </a:spcAft>
-              <a:buSzPct val="100000"/>
-              <a:buChar char="•"/>
-            </a:pPr>
-            <a:r>
-              <a:rPr lang="en-US" sz="1600" dirty="0">
-                <a:solidFill>
-                  <a:srgbClr val="000000"/>
-                </a:solidFill>
-              </a:rPr>
-              <a:t>Honest framing - stable near the chosen weights, less stable under arbitrary joint perturbations.</a:t>
-            </a:r>
-            <a:endParaRPr lang="en-US" sz="1600" dirty="0"/>
-          </a:p>
-          <a:p>
-            <a:pPr marL="342900" indent="-342900">
-              <a:spcAft>
-                <a:spcPts val="600"/>
-              </a:spcAft>
-              <a:buSzPct val="100000"/>
-              <a:buChar char="•"/>
-            </a:pPr>
-            <a:r>
-              <a:rPr lang="en-US" sz="1600" dirty="0">
-                <a:solidFill>
-                  <a:srgbClr val="000000"/>
-                </a:solidFill>
-              </a:rPr>
-              <a:t>Ablation confirms each process term contributes real signal; endpoint gain alone does not recover the ranking.</a:t>
-            </a:r>
-            <a:endParaRPr lang="en-US" sz="1600" dirty="0"/>
+          <a:bodyPr wrap="square" lIns="0" tIns="0" rIns="0" bIns="0" rtlCol="0" anchor="ctr"/>
+          <a:lstStyle/>
+          <a:p>
+            <a:pPr algn="ctr" indent="0" marL="0">
+              <a:buNone/>
+            </a:pPr>
+            <a:r>
+              <a:rPr lang="en-US" sz="1300" i="1" dirty="0">
+                <a:solidFill>
+                  <a:srgbClr val="555555"/>
+                </a:solidFill>
+              </a:rPr>
+              <a:t>41 of 66 synthesised alternatives strictly beat the user's trajectory (~62%). Quality varies sharply by kind.</a:t>
+            </a:r>
+            <a:endParaRPr lang="en-US" sz="1300" dirty="0"/>
+          </a:p>
+        </p:txBody>
+      </p:sp>
+      <p:graphicFrame>
+        <p:nvGraphicFramePr>
+          <p:cNvPr id="19" name="Table 0"/>
+          <p:cNvGraphicFramePr>
+            <a:graphicFrameLocks noGrp="1"/>
+          </p:cNvGraphicFramePr>
+          <p:nvPr>
+            <p:extLst>
+              <p:ext uri="{D42A27DB-BD31-4B8C-83A1-F6EECF244321}">
+                <p14:modId xmlns:p14="http://schemas.microsoft.com/office/powerpoint/2010/main" val="1579011935"/>
+              </p:ext>
+            </p:extLst>
+          </p:nvPr>
+        </p:nvGraphicFramePr>
+        <p:xfrm>
+          <a:off x="640080" y="1188720"/>
+          <a:ext cx="7863840" cy="914400"/>
+        </p:xfrm>
+        <a:graphic>
+          <a:graphicData uri="http://schemas.openxmlformats.org/drawingml/2006/table">
+            <a:tbl>
+              <a:tblPr/>
+              <a:tblGrid>
+                <a:gridCol w="1737360"/>
+                <a:gridCol w="640080"/>
+                <a:gridCol w="1005840"/>
+                <a:gridCol w="914400"/>
+                <a:gridCol w="1005840"/>
+                <a:gridCol w="1097280"/>
+                <a:gridCol w="1463040"/>
+              </a:tblGrid>
+              <a:tr h="411480">
+                <a:tc>
+                  <a:txBody>
+                    <a:bodyPr/>
+                    <a:lstStyle/>
+                    <a:p>
+                      <a:pPr algn="l" indent="0" marL="0">
+                        <a:buNone/>
+                      </a:pPr>
+                      <a:r>
+                        <a:rPr lang="en-US" sz="1400" b="1" dirty="0">
+                          <a:solidFill>
+                            <a:srgbClr val="1A1A1A"/>
+                          </a:solidFill>
+                        </a:rPr>
+                        <a:t>Kind</a:t>
+                      </a:r>
+                      <a:endParaRPr lang="en-US" sz="1400" dirty="0"/>
+                    </a:p>
+                  </a:txBody>
+                  <a:tcPr marL="73152" marR="73152" marT="73152" marB="73152" anchor="ctr">
+                    <a:lnL w="6350" cap="flat" cmpd="sng" algn="ctr">
+                      <a:solidFill>
+                        <a:srgbClr val="CCCCCC"/>
+                      </a:solidFill>
+                      <a:prstDash val="solid"/>
+                      <a:round/>
+                      <a:headEnd type="none" w="med" len="med"/>
+                      <a:tailEnd type="none" w="med" len="med"/>
+                    </a:lnL>
+                    <a:lnR w="6350" cap="flat" cmpd="sng" algn="ctr">
+                      <a:solidFill>
+                        <a:srgbClr val="CCCCCC"/>
+                      </a:solidFill>
+                      <a:prstDash val="solid"/>
+                      <a:round/>
+                      <a:headEnd type="none" w="med" len="med"/>
+                      <a:tailEnd type="none" w="med" len="med"/>
+                    </a:lnR>
+                    <a:lnT w="6350" cap="flat" cmpd="sng" algn="ctr">
+                      <a:solidFill>
+                        <a:srgbClr val="CCCCCC"/>
+                      </a:solidFill>
+                      <a:prstDash val="solid"/>
+                      <a:round/>
+                      <a:headEnd type="none" w="med" len="med"/>
+                      <a:tailEnd type="none" w="med" len="med"/>
+                    </a:lnT>
+                    <a:lnB w="6350" cap="flat" cmpd="sng" algn="ctr">
+                      <a:solidFill>
+                        <a:srgbClr val="CCCCCC"/>
+                      </a:solidFill>
+                      <a:prstDash val="solid"/>
+                      <a:round/>
+                      <a:headEnd type="none" w="med" len="med"/>
+                      <a:tailEnd type="none" w="med" len="med"/>
+                    </a:lnB>
+                    <a:solidFill>
+                      <a:srgbClr val="F0F0F0"/>
+                    </a:solidFill>
+                  </a:tcPr>
+                </a:tc>
+                <a:tc>
+                  <a:txBody>
+                    <a:bodyPr/>
+                    <a:lstStyle/>
+                    <a:p>
+                      <a:pPr algn="ctr" indent="0" marL="0">
+                        <a:buNone/>
+                      </a:pPr>
+                      <a:r>
+                        <a:rPr lang="en-US" sz="1400" b="1" dirty="0">
+                          <a:solidFill>
+                            <a:srgbClr val="1A1A1A"/>
+                          </a:solidFill>
+                        </a:rPr>
+                        <a:t>DPs</a:t>
+                      </a:r>
+                      <a:endParaRPr lang="en-US" sz="1400" dirty="0"/>
+                    </a:p>
+                  </a:txBody>
+                  <a:tcPr marL="73152" marR="73152" marT="73152" marB="73152" anchor="ctr">
+                    <a:lnL w="6350" cap="flat" cmpd="sng" algn="ctr">
+                      <a:solidFill>
+                        <a:srgbClr val="CCCCCC"/>
+                      </a:solidFill>
+                      <a:prstDash val="solid"/>
+                      <a:round/>
+                      <a:headEnd type="none" w="med" len="med"/>
+                      <a:tailEnd type="none" w="med" len="med"/>
+                    </a:lnL>
+                    <a:lnR w="6350" cap="flat" cmpd="sng" algn="ctr">
+                      <a:solidFill>
+                        <a:srgbClr val="CCCCCC"/>
+                      </a:solidFill>
+                      <a:prstDash val="solid"/>
+                      <a:round/>
+                      <a:headEnd type="none" w="med" len="med"/>
+                      <a:tailEnd type="none" w="med" len="med"/>
+                    </a:lnR>
+                    <a:lnT w="6350" cap="flat" cmpd="sng" algn="ctr">
+                      <a:solidFill>
+                        <a:srgbClr val="CCCCCC"/>
+                      </a:solidFill>
+                      <a:prstDash val="solid"/>
+                      <a:round/>
+                      <a:headEnd type="none" w="med" len="med"/>
+                      <a:tailEnd type="none" w="med" len="med"/>
+                    </a:lnT>
+                    <a:lnB w="6350" cap="flat" cmpd="sng" algn="ctr">
+                      <a:solidFill>
+                        <a:srgbClr val="CCCCCC"/>
+                      </a:solidFill>
+                      <a:prstDash val="solid"/>
+                      <a:round/>
+                      <a:headEnd type="none" w="med" len="med"/>
+                      <a:tailEnd type="none" w="med" len="med"/>
+                    </a:lnB>
+                    <a:solidFill>
+                      <a:srgbClr val="F0F0F0"/>
+                    </a:solidFill>
+                  </a:tcPr>
+                </a:tc>
+                <a:tc>
+                  <a:txBody>
+                    <a:bodyPr/>
+                    <a:lstStyle/>
+                    <a:p>
+                      <a:pPr algn="ctr" indent="0" marL="0">
+                        <a:buNone/>
+                      </a:pPr>
+                      <a:r>
+                        <a:rPr lang="en-US" sz="1400" b="1" dirty="0">
+                          <a:solidFill>
+                            <a:srgbClr val="1A1A1A"/>
+                          </a:solidFill>
+                        </a:rPr>
+                        <a:t>Beats ✓</a:t>
+                      </a:r>
+                      <a:endParaRPr lang="en-US" sz="1400" dirty="0"/>
+                    </a:p>
+                  </a:txBody>
+                  <a:tcPr marL="73152" marR="73152" marT="73152" marB="73152" anchor="ctr">
+                    <a:lnL w="6350" cap="flat" cmpd="sng" algn="ctr">
+                      <a:solidFill>
+                        <a:srgbClr val="CCCCCC"/>
+                      </a:solidFill>
+                      <a:prstDash val="solid"/>
+                      <a:round/>
+                      <a:headEnd type="none" w="med" len="med"/>
+                      <a:tailEnd type="none" w="med" len="med"/>
+                    </a:lnL>
+                    <a:lnR w="6350" cap="flat" cmpd="sng" algn="ctr">
+                      <a:solidFill>
+                        <a:srgbClr val="CCCCCC"/>
+                      </a:solidFill>
+                      <a:prstDash val="solid"/>
+                      <a:round/>
+                      <a:headEnd type="none" w="med" len="med"/>
+                      <a:tailEnd type="none" w="med" len="med"/>
+                    </a:lnR>
+                    <a:lnT w="6350" cap="flat" cmpd="sng" algn="ctr">
+                      <a:solidFill>
+                        <a:srgbClr val="CCCCCC"/>
+                      </a:solidFill>
+                      <a:prstDash val="solid"/>
+                      <a:round/>
+                      <a:headEnd type="none" w="med" len="med"/>
+                      <a:tailEnd type="none" w="med" len="med"/>
+                    </a:lnT>
+                    <a:lnB w="6350" cap="flat" cmpd="sng" algn="ctr">
+                      <a:solidFill>
+                        <a:srgbClr val="CCCCCC"/>
+                      </a:solidFill>
+                      <a:prstDash val="solid"/>
+                      <a:round/>
+                      <a:headEnd type="none" w="med" len="med"/>
+                      <a:tailEnd type="none" w="med" len="med"/>
+                    </a:lnB>
+                    <a:solidFill>
+                      <a:srgbClr val="F0F0F0"/>
+                    </a:solidFill>
+                  </a:tcPr>
+                </a:tc>
+                <a:tc>
+                  <a:txBody>
+                    <a:bodyPr/>
+                    <a:lstStyle/>
+                    <a:p>
+                      <a:pPr algn="ctr" indent="0" marL="0">
+                        <a:buNone/>
+                      </a:pPr>
+                      <a:r>
+                        <a:rPr lang="en-US" sz="1400" b="1" dirty="0">
+                          <a:solidFill>
+                            <a:srgbClr val="1A1A1A"/>
+                          </a:solidFill>
+                        </a:rPr>
+                        <a:t>Ties =</a:t>
+                      </a:r>
+                      <a:endParaRPr lang="en-US" sz="1400" dirty="0"/>
+                    </a:p>
+                  </a:txBody>
+                  <a:tcPr marL="73152" marR="73152" marT="73152" marB="73152" anchor="ctr">
+                    <a:lnL w="6350" cap="flat" cmpd="sng" algn="ctr">
+                      <a:solidFill>
+                        <a:srgbClr val="CCCCCC"/>
+                      </a:solidFill>
+                      <a:prstDash val="solid"/>
+                      <a:round/>
+                      <a:headEnd type="none" w="med" len="med"/>
+                      <a:tailEnd type="none" w="med" len="med"/>
+                    </a:lnL>
+                    <a:lnR w="6350" cap="flat" cmpd="sng" algn="ctr">
+                      <a:solidFill>
+                        <a:srgbClr val="CCCCCC"/>
+                      </a:solidFill>
+                      <a:prstDash val="solid"/>
+                      <a:round/>
+                      <a:headEnd type="none" w="med" len="med"/>
+                      <a:tailEnd type="none" w="med" len="med"/>
+                    </a:lnR>
+                    <a:lnT w="6350" cap="flat" cmpd="sng" algn="ctr">
+                      <a:solidFill>
+                        <a:srgbClr val="CCCCCC"/>
+                      </a:solidFill>
+                      <a:prstDash val="solid"/>
+                      <a:round/>
+                      <a:headEnd type="none" w="med" len="med"/>
+                      <a:tailEnd type="none" w="med" len="med"/>
+                    </a:lnT>
+                    <a:lnB w="6350" cap="flat" cmpd="sng" algn="ctr">
+                      <a:solidFill>
+                        <a:srgbClr val="CCCCCC"/>
+                      </a:solidFill>
+                      <a:prstDash val="solid"/>
+                      <a:round/>
+                      <a:headEnd type="none" w="med" len="med"/>
+                      <a:tailEnd type="none" w="med" len="med"/>
+                    </a:lnB>
+                    <a:solidFill>
+                      <a:srgbClr val="F0F0F0"/>
+                    </a:solidFill>
+                  </a:tcPr>
+                </a:tc>
+                <a:tc>
+                  <a:txBody>
+                    <a:bodyPr/>
+                    <a:lstStyle/>
+                    <a:p>
+                      <a:pPr algn="ctr" indent="0" marL="0">
+                        <a:buNone/>
+                      </a:pPr>
+                      <a:r>
+                        <a:rPr lang="en-US" sz="1400" b="1" dirty="0">
+                          <a:solidFill>
+                            <a:srgbClr val="1A1A1A"/>
+                          </a:solidFill>
+                        </a:rPr>
+                        <a:t>Loses ✗</a:t>
+                      </a:r>
+                      <a:endParaRPr lang="en-US" sz="1400" dirty="0"/>
+                    </a:p>
+                  </a:txBody>
+                  <a:tcPr marL="73152" marR="73152" marT="73152" marB="73152" anchor="ctr">
+                    <a:lnL w="6350" cap="flat" cmpd="sng" algn="ctr">
+                      <a:solidFill>
+                        <a:srgbClr val="CCCCCC"/>
+                      </a:solidFill>
+                      <a:prstDash val="solid"/>
+                      <a:round/>
+                      <a:headEnd type="none" w="med" len="med"/>
+                      <a:tailEnd type="none" w="med" len="med"/>
+                    </a:lnL>
+                    <a:lnR w="6350" cap="flat" cmpd="sng" algn="ctr">
+                      <a:solidFill>
+                        <a:srgbClr val="CCCCCC"/>
+                      </a:solidFill>
+                      <a:prstDash val="solid"/>
+                      <a:round/>
+                      <a:headEnd type="none" w="med" len="med"/>
+                      <a:tailEnd type="none" w="med" len="med"/>
+                    </a:lnR>
+                    <a:lnT w="6350" cap="flat" cmpd="sng" algn="ctr">
+                      <a:solidFill>
+                        <a:srgbClr val="CCCCCC"/>
+                      </a:solidFill>
+                      <a:prstDash val="solid"/>
+                      <a:round/>
+                      <a:headEnd type="none" w="med" len="med"/>
+                      <a:tailEnd type="none" w="med" len="med"/>
+                    </a:lnT>
+                    <a:lnB w="6350" cap="flat" cmpd="sng" algn="ctr">
+                      <a:solidFill>
+                        <a:srgbClr val="CCCCCC"/>
+                      </a:solidFill>
+                      <a:prstDash val="solid"/>
+                      <a:round/>
+                      <a:headEnd type="none" w="med" len="med"/>
+                      <a:tailEnd type="none" w="med" len="med"/>
+                    </a:lnB>
+                    <a:solidFill>
+                      <a:srgbClr val="F0F0F0"/>
+                    </a:solidFill>
+                  </a:tcPr>
+                </a:tc>
+                <a:tc>
+                  <a:txBody>
+                    <a:bodyPr/>
+                    <a:lstStyle/>
+                    <a:p>
+                      <a:pPr algn="ctr" indent="0" marL="0">
+                        <a:buNone/>
+                      </a:pPr>
+                      <a:r>
+                        <a:rPr lang="en-US" sz="1400" b="1" dirty="0">
+                          <a:solidFill>
+                            <a:srgbClr val="1A1A1A"/>
+                          </a:solidFill>
+                        </a:rPr>
+                        <a:t>Beat rate</a:t>
+                      </a:r>
+                      <a:endParaRPr lang="en-US" sz="1400" dirty="0"/>
+                    </a:p>
+                  </a:txBody>
+                  <a:tcPr marL="73152" marR="73152" marT="73152" marB="73152" anchor="ctr">
+                    <a:lnL w="6350" cap="flat" cmpd="sng" algn="ctr">
+                      <a:solidFill>
+                        <a:srgbClr val="CCCCCC"/>
+                      </a:solidFill>
+                      <a:prstDash val="solid"/>
+                      <a:round/>
+                      <a:headEnd type="none" w="med" len="med"/>
+                      <a:tailEnd type="none" w="med" len="med"/>
+                    </a:lnL>
+                    <a:lnR w="6350" cap="flat" cmpd="sng" algn="ctr">
+                      <a:solidFill>
+                        <a:srgbClr val="CCCCCC"/>
+                      </a:solidFill>
+                      <a:prstDash val="solid"/>
+                      <a:round/>
+                      <a:headEnd type="none" w="med" len="med"/>
+                      <a:tailEnd type="none" w="med" len="med"/>
+                    </a:lnR>
+                    <a:lnT w="6350" cap="flat" cmpd="sng" algn="ctr">
+                      <a:solidFill>
+                        <a:srgbClr val="CCCCCC"/>
+                      </a:solidFill>
+                      <a:prstDash val="solid"/>
+                      <a:round/>
+                      <a:headEnd type="none" w="med" len="med"/>
+                      <a:tailEnd type="none" w="med" len="med"/>
+                    </a:lnT>
+                    <a:lnB w="6350" cap="flat" cmpd="sng" algn="ctr">
+                      <a:solidFill>
+                        <a:srgbClr val="CCCCCC"/>
+                      </a:solidFill>
+                      <a:prstDash val="solid"/>
+                      <a:round/>
+                      <a:headEnd type="none" w="med" len="med"/>
+                      <a:tailEnd type="none" w="med" len="med"/>
+                    </a:lnB>
+                    <a:solidFill>
+                      <a:srgbClr val="F0F0F0"/>
+                    </a:solidFill>
+                  </a:tcPr>
+                </a:tc>
+                <a:tc>
+                  <a:txBody>
+                    <a:bodyPr/>
+                    <a:lstStyle/>
+                    <a:p>
+                      <a:pPr algn="ctr" indent="0" marL="0">
+                        <a:buNone/>
+                      </a:pPr>
+                      <a:r>
+                        <a:rPr lang="en-US" sz="1400" b="1" dirty="0">
+                          <a:solidFill>
+                            <a:srgbClr val="1A1A1A"/>
+                          </a:solidFill>
+                        </a:rPr>
+                        <a:t>Max Δ</a:t>
+                      </a:r>
+                      <a:endParaRPr lang="en-US" sz="1400" dirty="0"/>
+                    </a:p>
+                  </a:txBody>
+                  <a:tcPr marL="73152" marR="73152" marT="73152" marB="73152" anchor="ctr">
+                    <a:lnL w="6350" cap="flat" cmpd="sng" algn="ctr">
+                      <a:solidFill>
+                        <a:srgbClr val="CCCCCC"/>
+                      </a:solidFill>
+                      <a:prstDash val="solid"/>
+                      <a:round/>
+                      <a:headEnd type="none" w="med" len="med"/>
+                      <a:tailEnd type="none" w="med" len="med"/>
+                    </a:lnL>
+                    <a:lnR w="6350" cap="flat" cmpd="sng" algn="ctr">
+                      <a:solidFill>
+                        <a:srgbClr val="CCCCCC"/>
+                      </a:solidFill>
+                      <a:prstDash val="solid"/>
+                      <a:round/>
+                      <a:headEnd type="none" w="med" len="med"/>
+                      <a:tailEnd type="none" w="med" len="med"/>
+                    </a:lnR>
+                    <a:lnT w="6350" cap="flat" cmpd="sng" algn="ctr">
+                      <a:solidFill>
+                        <a:srgbClr val="CCCCCC"/>
+                      </a:solidFill>
+                      <a:prstDash val="solid"/>
+                      <a:round/>
+                      <a:headEnd type="none" w="med" len="med"/>
+                      <a:tailEnd type="none" w="med" len="med"/>
+                    </a:lnT>
+                    <a:lnB w="6350" cap="flat" cmpd="sng" algn="ctr">
+                      <a:solidFill>
+                        <a:srgbClr val="CCCCCC"/>
+                      </a:solidFill>
+                      <a:prstDash val="solid"/>
+                      <a:round/>
+                      <a:headEnd type="none" w="med" len="med"/>
+                      <a:tailEnd type="none" w="med" len="med"/>
+                    </a:lnB>
+                    <a:solidFill>
+                      <a:srgbClr val="F0F0F0"/>
+                    </a:solidFill>
+                  </a:tcPr>
+                </a:tc>
+              </a:tr>
+              <a:tr h="411480">
+                <a:tc>
+                  <a:txBody>
+                    <a:bodyPr/>
+                    <a:lstStyle/>
+                    <a:p>
+                      <a:pPr algn="l" indent="0" marL="0">
+                        <a:buNone/>
+                      </a:pPr>
+                      <a:r>
+                        <a:rPr lang="en-US" sz="1400" b="1" dirty="0">
+                          <a:solidFill>
+                            <a:srgbClr val="1A1A1A"/>
+                          </a:solidFill>
+                        </a:rPr>
+                        <a:t>Hygiene</a:t>
+                      </a:r>
+                      <a:endParaRPr lang="en-US" sz="1400" dirty="0"/>
+                    </a:p>
+                  </a:txBody>
+                  <a:tcPr marL="73152" marR="73152" marT="73152" marB="73152" anchor="ctr">
+                    <a:lnL w="6350" cap="flat" cmpd="sng" algn="ctr">
+                      <a:solidFill>
+                        <a:srgbClr val="CCCCCC"/>
+                      </a:solidFill>
+                      <a:prstDash val="solid"/>
+                      <a:round/>
+                      <a:headEnd type="none" w="med" len="med"/>
+                      <a:tailEnd type="none" w="med" len="med"/>
+                    </a:lnL>
+                    <a:lnR w="6350" cap="flat" cmpd="sng" algn="ctr">
+                      <a:solidFill>
+                        <a:srgbClr val="CCCCCC"/>
+                      </a:solidFill>
+                      <a:prstDash val="solid"/>
+                      <a:round/>
+                      <a:headEnd type="none" w="med" len="med"/>
+                      <a:tailEnd type="none" w="med" len="med"/>
+                    </a:lnR>
+                    <a:lnT w="6350" cap="flat" cmpd="sng" algn="ctr">
+                      <a:solidFill>
+                        <a:srgbClr val="CCCCCC"/>
+                      </a:solidFill>
+                      <a:prstDash val="solid"/>
+                      <a:round/>
+                      <a:headEnd type="none" w="med" len="med"/>
+                      <a:tailEnd type="none" w="med" len="med"/>
+                    </a:lnT>
+                    <a:lnB w="6350" cap="flat" cmpd="sng" algn="ctr">
+                      <a:solidFill>
+                        <a:srgbClr val="CCCCCC"/>
+                      </a:solidFill>
+                      <a:prstDash val="solid"/>
+                      <a:round/>
+                      <a:headEnd type="none" w="med" len="med"/>
+                      <a:tailEnd type="none" w="med" len="med"/>
+                    </a:lnB>
+                  </a:tcPr>
+                </a:tc>
+                <a:tc>
+                  <a:txBody>
+                    <a:bodyPr/>
+                    <a:lstStyle/>
+                    <a:p>
+                      <a:pPr algn="ctr" indent="0" marL="0">
+                        <a:buNone/>
+                      </a:pPr>
+                      <a:r>
+                        <a:rPr lang="en-US" sz="1400" dirty="0">
+                          <a:solidFill>
+                            <a:srgbClr val="1A1A1A"/>
+                          </a:solidFill>
+                        </a:rPr>
+                        <a:t>13</a:t>
+                      </a:r>
+                      <a:endParaRPr lang="en-US" sz="1400" dirty="0"/>
+                    </a:p>
+                  </a:txBody>
+                  <a:tcPr marL="73152" marR="73152" marT="73152" marB="73152" anchor="ctr">
+                    <a:lnL w="6350" cap="flat" cmpd="sng" algn="ctr">
+                      <a:solidFill>
+                        <a:srgbClr val="CCCCCC"/>
+                      </a:solidFill>
+                      <a:prstDash val="solid"/>
+                      <a:round/>
+                      <a:headEnd type="none" w="med" len="med"/>
+                      <a:tailEnd type="none" w="med" len="med"/>
+                    </a:lnL>
+                    <a:lnR w="6350" cap="flat" cmpd="sng" algn="ctr">
+                      <a:solidFill>
+                        <a:srgbClr val="CCCCCC"/>
+                      </a:solidFill>
+                      <a:prstDash val="solid"/>
+                      <a:round/>
+                      <a:headEnd type="none" w="med" len="med"/>
+                      <a:tailEnd type="none" w="med" len="med"/>
+                    </a:lnR>
+                    <a:lnT w="6350" cap="flat" cmpd="sng" algn="ctr">
+                      <a:solidFill>
+                        <a:srgbClr val="CCCCCC"/>
+                      </a:solidFill>
+                      <a:prstDash val="solid"/>
+                      <a:round/>
+                      <a:headEnd type="none" w="med" len="med"/>
+                      <a:tailEnd type="none" w="med" len="med"/>
+                    </a:lnT>
+                    <a:lnB w="6350" cap="flat" cmpd="sng" algn="ctr">
+                      <a:solidFill>
+                        <a:srgbClr val="CCCCCC"/>
+                      </a:solidFill>
+                      <a:prstDash val="solid"/>
+                      <a:round/>
+                      <a:headEnd type="none" w="med" len="med"/>
+                      <a:tailEnd type="none" w="med" len="med"/>
+                    </a:lnB>
+                  </a:tcPr>
+                </a:tc>
+                <a:tc>
+                  <a:txBody>
+                    <a:bodyPr/>
+                    <a:lstStyle/>
+                    <a:p>
+                      <a:pPr algn="ctr" indent="0" marL="0">
+                        <a:buNone/>
+                      </a:pPr>
+                      <a:r>
+                        <a:rPr lang="en-US" sz="1400" b="1" dirty="0">
+                          <a:solidFill>
+                            <a:srgbClr val="0A7D2A"/>
+                          </a:solidFill>
+                        </a:rPr>
+                        <a:t>13</a:t>
+                      </a:r>
+                      <a:endParaRPr lang="en-US" sz="1400" dirty="0"/>
+                    </a:p>
+                  </a:txBody>
+                  <a:tcPr marL="73152" marR="73152" marT="73152" marB="73152" anchor="ctr">
+                    <a:lnL w="6350" cap="flat" cmpd="sng" algn="ctr">
+                      <a:solidFill>
+                        <a:srgbClr val="CCCCCC"/>
+                      </a:solidFill>
+                      <a:prstDash val="solid"/>
+                      <a:round/>
+                      <a:headEnd type="none" w="med" len="med"/>
+                      <a:tailEnd type="none" w="med" len="med"/>
+                    </a:lnL>
+                    <a:lnR w="6350" cap="flat" cmpd="sng" algn="ctr">
+                      <a:solidFill>
+                        <a:srgbClr val="CCCCCC"/>
+                      </a:solidFill>
+                      <a:prstDash val="solid"/>
+                      <a:round/>
+                      <a:headEnd type="none" w="med" len="med"/>
+                      <a:tailEnd type="none" w="med" len="med"/>
+                    </a:lnR>
+                    <a:lnT w="6350" cap="flat" cmpd="sng" algn="ctr">
+                      <a:solidFill>
+                        <a:srgbClr val="CCCCCC"/>
+                      </a:solidFill>
+                      <a:prstDash val="solid"/>
+                      <a:round/>
+                      <a:headEnd type="none" w="med" len="med"/>
+                      <a:tailEnd type="none" w="med" len="med"/>
+                    </a:lnT>
+                    <a:lnB w="6350" cap="flat" cmpd="sng" algn="ctr">
+                      <a:solidFill>
+                        <a:srgbClr val="CCCCCC"/>
+                      </a:solidFill>
+                      <a:prstDash val="solid"/>
+                      <a:round/>
+                      <a:headEnd type="none" w="med" len="med"/>
+                      <a:tailEnd type="none" w="med" len="med"/>
+                    </a:lnB>
+                    <a:solidFill>
+                      <a:srgbClr val="D4F0DC"/>
+                    </a:solidFill>
+                  </a:tcPr>
+                </a:tc>
+                <a:tc>
+                  <a:txBody>
+                    <a:bodyPr/>
+                    <a:lstStyle/>
+                    <a:p>
+                      <a:pPr algn="ctr" indent="0" marL="0">
+                        <a:buNone/>
+                      </a:pPr>
+                      <a:r>
+                        <a:rPr lang="en-US" sz="1400" b="1" dirty="0">
+                          <a:solidFill>
+                            <a:srgbClr val="8A6A00"/>
+                          </a:solidFill>
+                        </a:rPr>
+                        <a:t>0</a:t>
+                      </a:r>
+                      <a:endParaRPr lang="en-US" sz="1400" dirty="0"/>
+                    </a:p>
+                  </a:txBody>
+                  <a:tcPr marL="73152" marR="73152" marT="73152" marB="73152" anchor="ctr">
+                    <a:lnL w="6350" cap="flat" cmpd="sng" algn="ctr">
+                      <a:solidFill>
+                        <a:srgbClr val="CCCCCC"/>
+                      </a:solidFill>
+                      <a:prstDash val="solid"/>
+                      <a:round/>
+                      <a:headEnd type="none" w="med" len="med"/>
+                      <a:tailEnd type="none" w="med" len="med"/>
+                    </a:lnL>
+                    <a:lnR w="6350" cap="flat" cmpd="sng" algn="ctr">
+                      <a:solidFill>
+                        <a:srgbClr val="CCCCCC"/>
+                      </a:solidFill>
+                      <a:prstDash val="solid"/>
+                      <a:round/>
+                      <a:headEnd type="none" w="med" len="med"/>
+                      <a:tailEnd type="none" w="med" len="med"/>
+                    </a:lnR>
+                    <a:lnT w="6350" cap="flat" cmpd="sng" algn="ctr">
+                      <a:solidFill>
+                        <a:srgbClr val="CCCCCC"/>
+                      </a:solidFill>
+                      <a:prstDash val="solid"/>
+                      <a:round/>
+                      <a:headEnd type="none" w="med" len="med"/>
+                      <a:tailEnd type="none" w="med" len="med"/>
+                    </a:lnT>
+                    <a:lnB w="6350" cap="flat" cmpd="sng" algn="ctr">
+                      <a:solidFill>
+                        <a:srgbClr val="CCCCCC"/>
+                      </a:solidFill>
+                      <a:prstDash val="solid"/>
+                      <a:round/>
+                      <a:headEnd type="none" w="med" len="med"/>
+                      <a:tailEnd type="none" w="med" len="med"/>
+                    </a:lnB>
+                    <a:solidFill>
+                      <a:srgbClr val="FFF4D6"/>
+                    </a:solidFill>
+                  </a:tcPr>
+                </a:tc>
+                <a:tc>
+                  <a:txBody>
+                    <a:bodyPr/>
+                    <a:lstStyle/>
+                    <a:p>
+                      <a:pPr algn="ctr" indent="0" marL="0">
+                        <a:buNone/>
+                      </a:pPr>
+                      <a:r>
+                        <a:rPr lang="en-US" sz="1400" b="1" dirty="0">
+                          <a:solidFill>
+                            <a:srgbClr val="B33A1E"/>
+                          </a:solidFill>
+                        </a:rPr>
+                        <a:t>0</a:t>
+                      </a:r>
+                      <a:endParaRPr lang="en-US" sz="1400" dirty="0"/>
+                    </a:p>
+                  </a:txBody>
+                  <a:tcPr marL="73152" marR="73152" marT="73152" marB="73152" anchor="ctr">
+                    <a:lnL w="6350" cap="flat" cmpd="sng" algn="ctr">
+                      <a:solidFill>
+                        <a:srgbClr val="CCCCCC"/>
+                      </a:solidFill>
+                      <a:prstDash val="solid"/>
+                      <a:round/>
+                      <a:headEnd type="none" w="med" len="med"/>
+                      <a:tailEnd type="none" w="med" len="med"/>
+                    </a:lnL>
+                    <a:lnR w="6350" cap="flat" cmpd="sng" algn="ctr">
+                      <a:solidFill>
+                        <a:srgbClr val="CCCCCC"/>
+                      </a:solidFill>
+                      <a:prstDash val="solid"/>
+                      <a:round/>
+                      <a:headEnd type="none" w="med" len="med"/>
+                      <a:tailEnd type="none" w="med" len="med"/>
+                    </a:lnR>
+                    <a:lnT w="6350" cap="flat" cmpd="sng" algn="ctr">
+                      <a:solidFill>
+                        <a:srgbClr val="CCCCCC"/>
+                      </a:solidFill>
+                      <a:prstDash val="solid"/>
+                      <a:round/>
+                      <a:headEnd type="none" w="med" len="med"/>
+                      <a:tailEnd type="none" w="med" len="med"/>
+                    </a:lnT>
+                    <a:lnB w="6350" cap="flat" cmpd="sng" algn="ctr">
+                      <a:solidFill>
+                        <a:srgbClr val="CCCCCC"/>
+                      </a:solidFill>
+                      <a:prstDash val="solid"/>
+                      <a:round/>
+                      <a:headEnd type="none" w="med" len="med"/>
+                      <a:tailEnd type="none" w="med" len="med"/>
+                    </a:lnB>
+                    <a:solidFill>
+                      <a:srgbClr val="F5D5CE"/>
+                    </a:solidFill>
+                  </a:tcPr>
+                </a:tc>
+                <a:tc>
+                  <a:txBody>
+                    <a:bodyPr/>
+                    <a:lstStyle/>
+                    <a:p>
+                      <a:pPr algn="ctr" indent="0" marL="0">
+                        <a:buNone/>
+                      </a:pPr>
+                      <a:r>
+                        <a:rPr lang="en-US" sz="1400" b="1" dirty="0">
+                          <a:solidFill>
+                            <a:srgbClr val="0A7D2A"/>
+                          </a:solidFill>
+                        </a:rPr>
+                        <a:t>100%</a:t>
+                      </a:r>
+                      <a:endParaRPr lang="en-US" sz="1400" dirty="0"/>
+                    </a:p>
+                  </a:txBody>
+                  <a:tcPr marL="73152" marR="73152" marT="73152" marB="73152" anchor="ctr">
+                    <a:lnL w="6350" cap="flat" cmpd="sng" algn="ctr">
+                      <a:solidFill>
+                        <a:srgbClr val="CCCCCC"/>
+                      </a:solidFill>
+                      <a:prstDash val="solid"/>
+                      <a:round/>
+                      <a:headEnd type="none" w="med" len="med"/>
+                      <a:tailEnd type="none" w="med" len="med"/>
+                    </a:lnL>
+                    <a:lnR w="6350" cap="flat" cmpd="sng" algn="ctr">
+                      <a:solidFill>
+                        <a:srgbClr val="CCCCCC"/>
+                      </a:solidFill>
+                      <a:prstDash val="solid"/>
+                      <a:round/>
+                      <a:headEnd type="none" w="med" len="med"/>
+                      <a:tailEnd type="none" w="med" len="med"/>
+                    </a:lnR>
+                    <a:lnT w="6350" cap="flat" cmpd="sng" algn="ctr">
+                      <a:solidFill>
+                        <a:srgbClr val="CCCCCC"/>
+                      </a:solidFill>
+                      <a:prstDash val="solid"/>
+                      <a:round/>
+                      <a:headEnd type="none" w="med" len="med"/>
+                      <a:tailEnd type="none" w="med" len="med"/>
+                    </a:lnT>
+                    <a:lnB w="6350" cap="flat" cmpd="sng" algn="ctr">
+                      <a:solidFill>
+                        <a:srgbClr val="CCCCCC"/>
+                      </a:solidFill>
+                      <a:prstDash val="solid"/>
+                      <a:round/>
+                      <a:headEnd type="none" w="med" len="med"/>
+                      <a:tailEnd type="none" w="med" len="med"/>
+                    </a:lnB>
+                  </a:tcPr>
+                </a:tc>
+                <a:tc>
+                  <a:txBody>
+                    <a:bodyPr/>
+                    <a:lstStyle/>
+                    <a:p>
+                      <a:pPr algn="ctr" indent="0" marL="0">
+                        <a:buNone/>
+                      </a:pPr>
+                      <a:r>
+                        <a:rPr lang="en-US" sz="1400" dirty="0">
+                          <a:solidFill>
+                            <a:srgbClr val="1A1A1A"/>
+                          </a:solidFill>
+                        </a:rPr>
+                        <a:t>+9</a:t>
+                      </a:r>
+                      <a:endParaRPr lang="en-US" sz="1400" dirty="0"/>
+                    </a:p>
+                  </a:txBody>
+                  <a:tcPr marL="73152" marR="73152" marT="73152" marB="73152" anchor="ctr">
+                    <a:lnL w="6350" cap="flat" cmpd="sng" algn="ctr">
+                      <a:solidFill>
+                        <a:srgbClr val="CCCCCC"/>
+                      </a:solidFill>
+                      <a:prstDash val="solid"/>
+                      <a:round/>
+                      <a:headEnd type="none" w="med" len="med"/>
+                      <a:tailEnd type="none" w="med" len="med"/>
+                    </a:lnL>
+                    <a:lnR w="6350" cap="flat" cmpd="sng" algn="ctr">
+                      <a:solidFill>
+                        <a:srgbClr val="CCCCCC"/>
+                      </a:solidFill>
+                      <a:prstDash val="solid"/>
+                      <a:round/>
+                      <a:headEnd type="none" w="med" len="med"/>
+                      <a:tailEnd type="none" w="med" len="med"/>
+                    </a:lnR>
+                    <a:lnT w="6350" cap="flat" cmpd="sng" algn="ctr">
+                      <a:solidFill>
+                        <a:srgbClr val="CCCCCC"/>
+                      </a:solidFill>
+                      <a:prstDash val="solid"/>
+                      <a:round/>
+                      <a:headEnd type="none" w="med" len="med"/>
+                      <a:tailEnd type="none" w="med" len="med"/>
+                    </a:lnT>
+                    <a:lnB w="6350" cap="flat" cmpd="sng" algn="ctr">
+                      <a:solidFill>
+                        <a:srgbClr val="CCCCCC"/>
+                      </a:solidFill>
+                      <a:prstDash val="solid"/>
+                      <a:round/>
+                      <a:headEnd type="none" w="med" len="med"/>
+                      <a:tailEnd type="none" w="med" len="med"/>
+                    </a:lnB>
+                  </a:tcPr>
+                </a:tc>
+              </a:tr>
+              <a:tr h="411480">
+                <a:tc>
+                  <a:txBody>
+                    <a:bodyPr/>
+                    <a:lstStyle/>
+                    <a:p>
+                      <a:pPr algn="l" indent="0" marL="0">
+                        <a:buNone/>
+                      </a:pPr>
+                      <a:r>
+                        <a:rPr lang="en-US" sz="1400" b="1" dirty="0">
+                          <a:solidFill>
+                            <a:srgbClr val="1A1A1A"/>
+                          </a:solidFill>
+                        </a:rPr>
+                        <a:t>Manual-Refactor</a:t>
+                      </a:r>
+                      <a:endParaRPr lang="en-US" sz="1400" dirty="0"/>
+                    </a:p>
+                  </a:txBody>
+                  <a:tcPr marL="73152" marR="73152" marT="73152" marB="73152" anchor="ctr">
+                    <a:lnL w="6350" cap="flat" cmpd="sng" algn="ctr">
+                      <a:solidFill>
+                        <a:srgbClr val="CCCCCC"/>
+                      </a:solidFill>
+                      <a:prstDash val="solid"/>
+                      <a:round/>
+                      <a:headEnd type="none" w="med" len="med"/>
+                      <a:tailEnd type="none" w="med" len="med"/>
+                    </a:lnL>
+                    <a:lnR w="6350" cap="flat" cmpd="sng" algn="ctr">
+                      <a:solidFill>
+                        <a:srgbClr val="CCCCCC"/>
+                      </a:solidFill>
+                      <a:prstDash val="solid"/>
+                      <a:round/>
+                      <a:headEnd type="none" w="med" len="med"/>
+                      <a:tailEnd type="none" w="med" len="med"/>
+                    </a:lnR>
+                    <a:lnT w="6350" cap="flat" cmpd="sng" algn="ctr">
+                      <a:solidFill>
+                        <a:srgbClr val="CCCCCC"/>
+                      </a:solidFill>
+                      <a:prstDash val="solid"/>
+                      <a:round/>
+                      <a:headEnd type="none" w="med" len="med"/>
+                      <a:tailEnd type="none" w="med" len="med"/>
+                    </a:lnT>
+                    <a:lnB w="6350" cap="flat" cmpd="sng" algn="ctr">
+                      <a:solidFill>
+                        <a:srgbClr val="CCCCCC"/>
+                      </a:solidFill>
+                      <a:prstDash val="solid"/>
+                      <a:round/>
+                      <a:headEnd type="none" w="med" len="med"/>
+                      <a:tailEnd type="none" w="med" len="med"/>
+                    </a:lnB>
+                  </a:tcPr>
+                </a:tc>
+                <a:tc>
+                  <a:txBody>
+                    <a:bodyPr/>
+                    <a:lstStyle/>
+                    <a:p>
+                      <a:pPr algn="ctr" indent="0" marL="0">
+                        <a:buNone/>
+                      </a:pPr>
+                      <a:r>
+                        <a:rPr lang="en-US" sz="1400" dirty="0">
+                          <a:solidFill>
+                            <a:srgbClr val="1A1A1A"/>
+                          </a:solidFill>
+                        </a:rPr>
+                        <a:t>16</a:t>
+                      </a:r>
+                      <a:endParaRPr lang="en-US" sz="1400" dirty="0"/>
+                    </a:p>
+                  </a:txBody>
+                  <a:tcPr marL="73152" marR="73152" marT="73152" marB="73152" anchor="ctr">
+                    <a:lnL w="6350" cap="flat" cmpd="sng" algn="ctr">
+                      <a:solidFill>
+                        <a:srgbClr val="CCCCCC"/>
+                      </a:solidFill>
+                      <a:prstDash val="solid"/>
+                      <a:round/>
+                      <a:headEnd type="none" w="med" len="med"/>
+                      <a:tailEnd type="none" w="med" len="med"/>
+                    </a:lnL>
+                    <a:lnR w="6350" cap="flat" cmpd="sng" algn="ctr">
+                      <a:solidFill>
+                        <a:srgbClr val="CCCCCC"/>
+                      </a:solidFill>
+                      <a:prstDash val="solid"/>
+                      <a:round/>
+                      <a:headEnd type="none" w="med" len="med"/>
+                      <a:tailEnd type="none" w="med" len="med"/>
+                    </a:lnR>
+                    <a:lnT w="6350" cap="flat" cmpd="sng" algn="ctr">
+                      <a:solidFill>
+                        <a:srgbClr val="CCCCCC"/>
+                      </a:solidFill>
+                      <a:prstDash val="solid"/>
+                      <a:round/>
+                      <a:headEnd type="none" w="med" len="med"/>
+                      <a:tailEnd type="none" w="med" len="med"/>
+                    </a:lnT>
+                    <a:lnB w="6350" cap="flat" cmpd="sng" algn="ctr">
+                      <a:solidFill>
+                        <a:srgbClr val="CCCCCC"/>
+                      </a:solidFill>
+                      <a:prstDash val="solid"/>
+                      <a:round/>
+                      <a:headEnd type="none" w="med" len="med"/>
+                      <a:tailEnd type="none" w="med" len="med"/>
+                    </a:lnB>
+                  </a:tcPr>
+                </a:tc>
+                <a:tc>
+                  <a:txBody>
+                    <a:bodyPr/>
+                    <a:lstStyle/>
+                    <a:p>
+                      <a:pPr algn="ctr" indent="0" marL="0">
+                        <a:buNone/>
+                      </a:pPr>
+                      <a:r>
+                        <a:rPr lang="en-US" sz="1400" b="1" dirty="0">
+                          <a:solidFill>
+                            <a:srgbClr val="0A7D2A"/>
+                          </a:solidFill>
+                        </a:rPr>
+                        <a:t>12</a:t>
+                      </a:r>
+                      <a:endParaRPr lang="en-US" sz="1400" dirty="0"/>
+                    </a:p>
+                  </a:txBody>
+                  <a:tcPr marL="73152" marR="73152" marT="73152" marB="73152" anchor="ctr">
+                    <a:lnL w="6350" cap="flat" cmpd="sng" algn="ctr">
+                      <a:solidFill>
+                        <a:srgbClr val="CCCCCC"/>
+                      </a:solidFill>
+                      <a:prstDash val="solid"/>
+                      <a:round/>
+                      <a:headEnd type="none" w="med" len="med"/>
+                      <a:tailEnd type="none" w="med" len="med"/>
+                    </a:lnL>
+                    <a:lnR w="6350" cap="flat" cmpd="sng" algn="ctr">
+                      <a:solidFill>
+                        <a:srgbClr val="CCCCCC"/>
+                      </a:solidFill>
+                      <a:prstDash val="solid"/>
+                      <a:round/>
+                      <a:headEnd type="none" w="med" len="med"/>
+                      <a:tailEnd type="none" w="med" len="med"/>
+                    </a:lnR>
+                    <a:lnT w="6350" cap="flat" cmpd="sng" algn="ctr">
+                      <a:solidFill>
+                        <a:srgbClr val="CCCCCC"/>
+                      </a:solidFill>
+                      <a:prstDash val="solid"/>
+                      <a:round/>
+                      <a:headEnd type="none" w="med" len="med"/>
+                      <a:tailEnd type="none" w="med" len="med"/>
+                    </a:lnT>
+                    <a:lnB w="6350" cap="flat" cmpd="sng" algn="ctr">
+                      <a:solidFill>
+                        <a:srgbClr val="CCCCCC"/>
+                      </a:solidFill>
+                      <a:prstDash val="solid"/>
+                      <a:round/>
+                      <a:headEnd type="none" w="med" len="med"/>
+                      <a:tailEnd type="none" w="med" len="med"/>
+                    </a:lnB>
+                    <a:solidFill>
+                      <a:srgbClr val="D4F0DC"/>
+                    </a:solidFill>
+                  </a:tcPr>
+                </a:tc>
+                <a:tc>
+                  <a:txBody>
+                    <a:bodyPr/>
+                    <a:lstStyle/>
+                    <a:p>
+                      <a:pPr algn="ctr" indent="0" marL="0">
+                        <a:buNone/>
+                      </a:pPr>
+                      <a:r>
+                        <a:rPr lang="en-US" sz="1400" b="1" dirty="0">
+                          <a:solidFill>
+                            <a:srgbClr val="8A6A00"/>
+                          </a:solidFill>
+                        </a:rPr>
+                        <a:t>3</a:t>
+                      </a:r>
+                      <a:endParaRPr lang="en-US" sz="1400" dirty="0"/>
+                    </a:p>
+                  </a:txBody>
+                  <a:tcPr marL="73152" marR="73152" marT="73152" marB="73152" anchor="ctr">
+                    <a:lnL w="6350" cap="flat" cmpd="sng" algn="ctr">
+                      <a:solidFill>
+                        <a:srgbClr val="CCCCCC"/>
+                      </a:solidFill>
+                      <a:prstDash val="solid"/>
+                      <a:round/>
+                      <a:headEnd type="none" w="med" len="med"/>
+                      <a:tailEnd type="none" w="med" len="med"/>
+                    </a:lnL>
+                    <a:lnR w="6350" cap="flat" cmpd="sng" algn="ctr">
+                      <a:solidFill>
+                        <a:srgbClr val="CCCCCC"/>
+                      </a:solidFill>
+                      <a:prstDash val="solid"/>
+                      <a:round/>
+                      <a:headEnd type="none" w="med" len="med"/>
+                      <a:tailEnd type="none" w="med" len="med"/>
+                    </a:lnR>
+                    <a:lnT w="6350" cap="flat" cmpd="sng" algn="ctr">
+                      <a:solidFill>
+                        <a:srgbClr val="CCCCCC"/>
+                      </a:solidFill>
+                      <a:prstDash val="solid"/>
+                      <a:round/>
+                      <a:headEnd type="none" w="med" len="med"/>
+                      <a:tailEnd type="none" w="med" len="med"/>
+                    </a:lnT>
+                    <a:lnB w="6350" cap="flat" cmpd="sng" algn="ctr">
+                      <a:solidFill>
+                        <a:srgbClr val="CCCCCC"/>
+                      </a:solidFill>
+                      <a:prstDash val="solid"/>
+                      <a:round/>
+                      <a:headEnd type="none" w="med" len="med"/>
+                      <a:tailEnd type="none" w="med" len="med"/>
+                    </a:lnB>
+                    <a:solidFill>
+                      <a:srgbClr val="FFF4D6"/>
+                    </a:solidFill>
+                  </a:tcPr>
+                </a:tc>
+                <a:tc>
+                  <a:txBody>
+                    <a:bodyPr/>
+                    <a:lstStyle/>
+                    <a:p>
+                      <a:pPr algn="ctr" indent="0" marL="0">
+                        <a:buNone/>
+                      </a:pPr>
+                      <a:r>
+                        <a:rPr lang="en-US" sz="1400" b="1" dirty="0">
+                          <a:solidFill>
+                            <a:srgbClr val="B33A1E"/>
+                          </a:solidFill>
+                        </a:rPr>
+                        <a:t>1</a:t>
+                      </a:r>
+                      <a:endParaRPr lang="en-US" sz="1400" dirty="0"/>
+                    </a:p>
+                  </a:txBody>
+                  <a:tcPr marL="73152" marR="73152" marT="73152" marB="73152" anchor="ctr">
+                    <a:lnL w="6350" cap="flat" cmpd="sng" algn="ctr">
+                      <a:solidFill>
+                        <a:srgbClr val="CCCCCC"/>
+                      </a:solidFill>
+                      <a:prstDash val="solid"/>
+                      <a:round/>
+                      <a:headEnd type="none" w="med" len="med"/>
+                      <a:tailEnd type="none" w="med" len="med"/>
+                    </a:lnL>
+                    <a:lnR w="6350" cap="flat" cmpd="sng" algn="ctr">
+                      <a:solidFill>
+                        <a:srgbClr val="CCCCCC"/>
+                      </a:solidFill>
+                      <a:prstDash val="solid"/>
+                      <a:round/>
+                      <a:headEnd type="none" w="med" len="med"/>
+                      <a:tailEnd type="none" w="med" len="med"/>
+                    </a:lnR>
+                    <a:lnT w="6350" cap="flat" cmpd="sng" algn="ctr">
+                      <a:solidFill>
+                        <a:srgbClr val="CCCCCC"/>
+                      </a:solidFill>
+                      <a:prstDash val="solid"/>
+                      <a:round/>
+                      <a:headEnd type="none" w="med" len="med"/>
+                      <a:tailEnd type="none" w="med" len="med"/>
+                    </a:lnT>
+                    <a:lnB w="6350" cap="flat" cmpd="sng" algn="ctr">
+                      <a:solidFill>
+                        <a:srgbClr val="CCCCCC"/>
+                      </a:solidFill>
+                      <a:prstDash val="solid"/>
+                      <a:round/>
+                      <a:headEnd type="none" w="med" len="med"/>
+                      <a:tailEnd type="none" w="med" len="med"/>
+                    </a:lnB>
+                    <a:solidFill>
+                      <a:srgbClr val="F5D5CE"/>
+                    </a:solidFill>
+                  </a:tcPr>
+                </a:tc>
+                <a:tc>
+                  <a:txBody>
+                    <a:bodyPr/>
+                    <a:lstStyle/>
+                    <a:p>
+                      <a:pPr algn="ctr" indent="0" marL="0">
+                        <a:buNone/>
+                      </a:pPr>
+                      <a:r>
+                        <a:rPr lang="en-US" sz="1400" b="1" dirty="0">
+                          <a:solidFill>
+                            <a:srgbClr val="0A7D2A"/>
+                          </a:solidFill>
+                        </a:rPr>
+                        <a:t>75%</a:t>
+                      </a:r>
+                      <a:endParaRPr lang="en-US" sz="1400" dirty="0"/>
+                    </a:p>
+                  </a:txBody>
+                  <a:tcPr marL="73152" marR="73152" marT="73152" marB="73152" anchor="ctr">
+                    <a:lnL w="6350" cap="flat" cmpd="sng" algn="ctr">
+                      <a:solidFill>
+                        <a:srgbClr val="CCCCCC"/>
+                      </a:solidFill>
+                      <a:prstDash val="solid"/>
+                      <a:round/>
+                      <a:headEnd type="none" w="med" len="med"/>
+                      <a:tailEnd type="none" w="med" len="med"/>
+                    </a:lnL>
+                    <a:lnR w="6350" cap="flat" cmpd="sng" algn="ctr">
+                      <a:solidFill>
+                        <a:srgbClr val="CCCCCC"/>
+                      </a:solidFill>
+                      <a:prstDash val="solid"/>
+                      <a:round/>
+                      <a:headEnd type="none" w="med" len="med"/>
+                      <a:tailEnd type="none" w="med" len="med"/>
+                    </a:lnR>
+                    <a:lnT w="6350" cap="flat" cmpd="sng" algn="ctr">
+                      <a:solidFill>
+                        <a:srgbClr val="CCCCCC"/>
+                      </a:solidFill>
+                      <a:prstDash val="solid"/>
+                      <a:round/>
+                      <a:headEnd type="none" w="med" len="med"/>
+                      <a:tailEnd type="none" w="med" len="med"/>
+                    </a:lnT>
+                    <a:lnB w="6350" cap="flat" cmpd="sng" algn="ctr">
+                      <a:solidFill>
+                        <a:srgbClr val="CCCCCC"/>
+                      </a:solidFill>
+                      <a:prstDash val="solid"/>
+                      <a:round/>
+                      <a:headEnd type="none" w="med" len="med"/>
+                      <a:tailEnd type="none" w="med" len="med"/>
+                    </a:lnB>
+                  </a:tcPr>
+                </a:tc>
+                <a:tc>
+                  <a:txBody>
+                    <a:bodyPr/>
+                    <a:lstStyle/>
+                    <a:p>
+                      <a:pPr algn="ctr" indent="0" marL="0">
+                        <a:buNone/>
+                      </a:pPr>
+                      <a:r>
+                        <a:rPr lang="en-US" sz="1400" b="1" dirty="0">
+                          <a:solidFill>
+                            <a:srgbClr val="0A7D2A"/>
+                          </a:solidFill>
+                        </a:rPr>
+                        <a:t>+23</a:t>
+                      </a:r>
+                      <a:endParaRPr lang="en-US" sz="1400" dirty="0"/>
+                    </a:p>
+                  </a:txBody>
+                  <a:tcPr marL="73152" marR="73152" marT="73152" marB="73152" anchor="ctr">
+                    <a:lnL w="6350" cap="flat" cmpd="sng" algn="ctr">
+                      <a:solidFill>
+                        <a:srgbClr val="CCCCCC"/>
+                      </a:solidFill>
+                      <a:prstDash val="solid"/>
+                      <a:round/>
+                      <a:headEnd type="none" w="med" len="med"/>
+                      <a:tailEnd type="none" w="med" len="med"/>
+                    </a:lnL>
+                    <a:lnR w="6350" cap="flat" cmpd="sng" algn="ctr">
+                      <a:solidFill>
+                        <a:srgbClr val="CCCCCC"/>
+                      </a:solidFill>
+                      <a:prstDash val="solid"/>
+                      <a:round/>
+                      <a:headEnd type="none" w="med" len="med"/>
+                      <a:tailEnd type="none" w="med" len="med"/>
+                    </a:lnR>
+                    <a:lnT w="6350" cap="flat" cmpd="sng" algn="ctr">
+                      <a:solidFill>
+                        <a:srgbClr val="CCCCCC"/>
+                      </a:solidFill>
+                      <a:prstDash val="solid"/>
+                      <a:round/>
+                      <a:headEnd type="none" w="med" len="med"/>
+                      <a:tailEnd type="none" w="med" len="med"/>
+                    </a:lnT>
+                    <a:lnB w="6350" cap="flat" cmpd="sng" algn="ctr">
+                      <a:solidFill>
+                        <a:srgbClr val="CCCCCC"/>
+                      </a:solidFill>
+                      <a:prstDash val="solid"/>
+                      <a:round/>
+                      <a:headEnd type="none" w="med" len="med"/>
+                      <a:tailEnd type="none" w="med" len="med"/>
+                    </a:lnB>
+                  </a:tcPr>
+                </a:tc>
+              </a:tr>
+              <a:tr h="411480">
+                <a:tc>
+                  <a:txBody>
+                    <a:bodyPr/>
+                    <a:lstStyle/>
+                    <a:p>
+                      <a:pPr algn="l" indent="0" marL="0">
+                        <a:buNone/>
+                      </a:pPr>
+                      <a:r>
+                        <a:rPr lang="en-US" sz="1400" b="1" dirty="0">
+                          <a:solidFill>
+                            <a:srgbClr val="1A1A1A"/>
+                          </a:solidFill>
+                        </a:rPr>
+                        <a:t>Rework</a:t>
+                      </a:r>
+                      <a:endParaRPr lang="en-US" sz="1400" dirty="0"/>
+                    </a:p>
+                  </a:txBody>
+                  <a:tcPr marL="73152" marR="73152" marT="73152" marB="73152" anchor="ctr">
+                    <a:lnL w="6350" cap="flat" cmpd="sng" algn="ctr">
+                      <a:solidFill>
+                        <a:srgbClr val="CCCCCC"/>
+                      </a:solidFill>
+                      <a:prstDash val="solid"/>
+                      <a:round/>
+                      <a:headEnd type="none" w="med" len="med"/>
+                      <a:tailEnd type="none" w="med" len="med"/>
+                    </a:lnL>
+                    <a:lnR w="6350" cap="flat" cmpd="sng" algn="ctr">
+                      <a:solidFill>
+                        <a:srgbClr val="CCCCCC"/>
+                      </a:solidFill>
+                      <a:prstDash val="solid"/>
+                      <a:round/>
+                      <a:headEnd type="none" w="med" len="med"/>
+                      <a:tailEnd type="none" w="med" len="med"/>
+                    </a:lnR>
+                    <a:lnT w="6350" cap="flat" cmpd="sng" algn="ctr">
+                      <a:solidFill>
+                        <a:srgbClr val="CCCCCC"/>
+                      </a:solidFill>
+                      <a:prstDash val="solid"/>
+                      <a:round/>
+                      <a:headEnd type="none" w="med" len="med"/>
+                      <a:tailEnd type="none" w="med" len="med"/>
+                    </a:lnT>
+                    <a:lnB w="6350" cap="flat" cmpd="sng" algn="ctr">
+                      <a:solidFill>
+                        <a:srgbClr val="CCCCCC"/>
+                      </a:solidFill>
+                      <a:prstDash val="solid"/>
+                      <a:round/>
+                      <a:headEnd type="none" w="med" len="med"/>
+                      <a:tailEnd type="none" w="med" len="med"/>
+                    </a:lnB>
+                  </a:tcPr>
+                </a:tc>
+                <a:tc>
+                  <a:txBody>
+                    <a:bodyPr/>
+                    <a:lstStyle/>
+                    <a:p>
+                      <a:pPr algn="ctr" indent="0" marL="0">
+                        <a:buNone/>
+                      </a:pPr>
+                      <a:r>
+                        <a:rPr lang="en-US" sz="1400" dirty="0">
+                          <a:solidFill>
+                            <a:srgbClr val="1A1A1A"/>
+                          </a:solidFill>
+                        </a:rPr>
+                        <a:t>13</a:t>
+                      </a:r>
+                      <a:endParaRPr lang="en-US" sz="1400" dirty="0"/>
+                    </a:p>
+                  </a:txBody>
+                  <a:tcPr marL="73152" marR="73152" marT="73152" marB="73152" anchor="ctr">
+                    <a:lnL w="6350" cap="flat" cmpd="sng" algn="ctr">
+                      <a:solidFill>
+                        <a:srgbClr val="CCCCCC"/>
+                      </a:solidFill>
+                      <a:prstDash val="solid"/>
+                      <a:round/>
+                      <a:headEnd type="none" w="med" len="med"/>
+                      <a:tailEnd type="none" w="med" len="med"/>
+                    </a:lnL>
+                    <a:lnR w="6350" cap="flat" cmpd="sng" algn="ctr">
+                      <a:solidFill>
+                        <a:srgbClr val="CCCCCC"/>
+                      </a:solidFill>
+                      <a:prstDash val="solid"/>
+                      <a:round/>
+                      <a:headEnd type="none" w="med" len="med"/>
+                      <a:tailEnd type="none" w="med" len="med"/>
+                    </a:lnR>
+                    <a:lnT w="6350" cap="flat" cmpd="sng" algn="ctr">
+                      <a:solidFill>
+                        <a:srgbClr val="CCCCCC"/>
+                      </a:solidFill>
+                      <a:prstDash val="solid"/>
+                      <a:round/>
+                      <a:headEnd type="none" w="med" len="med"/>
+                      <a:tailEnd type="none" w="med" len="med"/>
+                    </a:lnT>
+                    <a:lnB w="6350" cap="flat" cmpd="sng" algn="ctr">
+                      <a:solidFill>
+                        <a:srgbClr val="CCCCCC"/>
+                      </a:solidFill>
+                      <a:prstDash val="solid"/>
+                      <a:round/>
+                      <a:headEnd type="none" w="med" len="med"/>
+                      <a:tailEnd type="none" w="med" len="med"/>
+                    </a:lnB>
+                  </a:tcPr>
+                </a:tc>
+                <a:tc>
+                  <a:txBody>
+                    <a:bodyPr/>
+                    <a:lstStyle/>
+                    <a:p>
+                      <a:pPr algn="ctr" indent="0" marL="0">
+                        <a:buNone/>
+                      </a:pPr>
+                      <a:r>
+                        <a:rPr lang="en-US" sz="1400" b="1" dirty="0">
+                          <a:solidFill>
+                            <a:srgbClr val="0A7D2A"/>
+                          </a:solidFill>
+                        </a:rPr>
+                        <a:t>6</a:t>
+                      </a:r>
+                      <a:endParaRPr lang="en-US" sz="1400" dirty="0"/>
+                    </a:p>
+                  </a:txBody>
+                  <a:tcPr marL="73152" marR="73152" marT="73152" marB="73152" anchor="ctr">
+                    <a:lnL w="6350" cap="flat" cmpd="sng" algn="ctr">
+                      <a:solidFill>
+                        <a:srgbClr val="CCCCCC"/>
+                      </a:solidFill>
+                      <a:prstDash val="solid"/>
+                      <a:round/>
+                      <a:headEnd type="none" w="med" len="med"/>
+                      <a:tailEnd type="none" w="med" len="med"/>
+                    </a:lnL>
+                    <a:lnR w="6350" cap="flat" cmpd="sng" algn="ctr">
+                      <a:solidFill>
+                        <a:srgbClr val="CCCCCC"/>
+                      </a:solidFill>
+                      <a:prstDash val="solid"/>
+                      <a:round/>
+                      <a:headEnd type="none" w="med" len="med"/>
+                      <a:tailEnd type="none" w="med" len="med"/>
+                    </a:lnR>
+                    <a:lnT w="6350" cap="flat" cmpd="sng" algn="ctr">
+                      <a:solidFill>
+                        <a:srgbClr val="CCCCCC"/>
+                      </a:solidFill>
+                      <a:prstDash val="solid"/>
+                      <a:round/>
+                      <a:headEnd type="none" w="med" len="med"/>
+                      <a:tailEnd type="none" w="med" len="med"/>
+                    </a:lnT>
+                    <a:lnB w="6350" cap="flat" cmpd="sng" algn="ctr">
+                      <a:solidFill>
+                        <a:srgbClr val="CCCCCC"/>
+                      </a:solidFill>
+                      <a:prstDash val="solid"/>
+                      <a:round/>
+                      <a:headEnd type="none" w="med" len="med"/>
+                      <a:tailEnd type="none" w="med" len="med"/>
+                    </a:lnB>
+                    <a:solidFill>
+                      <a:srgbClr val="D4F0DC"/>
+                    </a:solidFill>
+                  </a:tcPr>
+                </a:tc>
+                <a:tc>
+                  <a:txBody>
+                    <a:bodyPr/>
+                    <a:lstStyle/>
+                    <a:p>
+                      <a:pPr algn="ctr" indent="0" marL="0">
+                        <a:buNone/>
+                      </a:pPr>
+                      <a:r>
+                        <a:rPr lang="en-US" sz="1400" b="1" dirty="0">
+                          <a:solidFill>
+                            <a:srgbClr val="8A6A00"/>
+                          </a:solidFill>
+                        </a:rPr>
+                        <a:t>1</a:t>
+                      </a:r>
+                      <a:endParaRPr lang="en-US" sz="1400" dirty="0"/>
+                    </a:p>
+                  </a:txBody>
+                  <a:tcPr marL="73152" marR="73152" marT="73152" marB="73152" anchor="ctr">
+                    <a:lnL w="6350" cap="flat" cmpd="sng" algn="ctr">
+                      <a:solidFill>
+                        <a:srgbClr val="CCCCCC"/>
+                      </a:solidFill>
+                      <a:prstDash val="solid"/>
+                      <a:round/>
+                      <a:headEnd type="none" w="med" len="med"/>
+                      <a:tailEnd type="none" w="med" len="med"/>
+                    </a:lnL>
+                    <a:lnR w="6350" cap="flat" cmpd="sng" algn="ctr">
+                      <a:solidFill>
+                        <a:srgbClr val="CCCCCC"/>
+                      </a:solidFill>
+                      <a:prstDash val="solid"/>
+                      <a:round/>
+                      <a:headEnd type="none" w="med" len="med"/>
+                      <a:tailEnd type="none" w="med" len="med"/>
+                    </a:lnR>
+                    <a:lnT w="6350" cap="flat" cmpd="sng" algn="ctr">
+                      <a:solidFill>
+                        <a:srgbClr val="CCCCCC"/>
+                      </a:solidFill>
+                      <a:prstDash val="solid"/>
+                      <a:round/>
+                      <a:headEnd type="none" w="med" len="med"/>
+                      <a:tailEnd type="none" w="med" len="med"/>
+                    </a:lnT>
+                    <a:lnB w="6350" cap="flat" cmpd="sng" algn="ctr">
+                      <a:solidFill>
+                        <a:srgbClr val="CCCCCC"/>
+                      </a:solidFill>
+                      <a:prstDash val="solid"/>
+                      <a:round/>
+                      <a:headEnd type="none" w="med" len="med"/>
+                      <a:tailEnd type="none" w="med" len="med"/>
+                    </a:lnB>
+                    <a:solidFill>
+                      <a:srgbClr val="FFF4D6"/>
+                    </a:solidFill>
+                  </a:tcPr>
+                </a:tc>
+                <a:tc>
+                  <a:txBody>
+                    <a:bodyPr/>
+                    <a:lstStyle/>
+                    <a:p>
+                      <a:pPr algn="ctr" indent="0" marL="0">
+                        <a:buNone/>
+                      </a:pPr>
+                      <a:r>
+                        <a:rPr lang="en-US" sz="1400" b="1" dirty="0">
+                          <a:solidFill>
+                            <a:srgbClr val="B33A1E"/>
+                          </a:solidFill>
+                        </a:rPr>
+                        <a:t>6</a:t>
+                      </a:r>
+                      <a:endParaRPr lang="en-US" sz="1400" dirty="0"/>
+                    </a:p>
+                  </a:txBody>
+                  <a:tcPr marL="73152" marR="73152" marT="73152" marB="73152" anchor="ctr">
+                    <a:lnL w="6350" cap="flat" cmpd="sng" algn="ctr">
+                      <a:solidFill>
+                        <a:srgbClr val="CCCCCC"/>
+                      </a:solidFill>
+                      <a:prstDash val="solid"/>
+                      <a:round/>
+                      <a:headEnd type="none" w="med" len="med"/>
+                      <a:tailEnd type="none" w="med" len="med"/>
+                    </a:lnL>
+                    <a:lnR w="6350" cap="flat" cmpd="sng" algn="ctr">
+                      <a:solidFill>
+                        <a:srgbClr val="CCCCCC"/>
+                      </a:solidFill>
+                      <a:prstDash val="solid"/>
+                      <a:round/>
+                      <a:headEnd type="none" w="med" len="med"/>
+                      <a:tailEnd type="none" w="med" len="med"/>
+                    </a:lnR>
+                    <a:lnT w="6350" cap="flat" cmpd="sng" algn="ctr">
+                      <a:solidFill>
+                        <a:srgbClr val="CCCCCC"/>
+                      </a:solidFill>
+                      <a:prstDash val="solid"/>
+                      <a:round/>
+                      <a:headEnd type="none" w="med" len="med"/>
+                      <a:tailEnd type="none" w="med" len="med"/>
+                    </a:lnT>
+                    <a:lnB w="6350" cap="flat" cmpd="sng" algn="ctr">
+                      <a:solidFill>
+                        <a:srgbClr val="CCCCCC"/>
+                      </a:solidFill>
+                      <a:prstDash val="solid"/>
+                      <a:round/>
+                      <a:headEnd type="none" w="med" len="med"/>
+                      <a:tailEnd type="none" w="med" len="med"/>
+                    </a:lnB>
+                    <a:solidFill>
+                      <a:srgbClr val="F5D5CE"/>
+                    </a:solidFill>
+                  </a:tcPr>
+                </a:tc>
+                <a:tc>
+                  <a:txBody>
+                    <a:bodyPr/>
+                    <a:lstStyle/>
+                    <a:p>
+                      <a:pPr algn="ctr" indent="0" marL="0">
+                        <a:buNone/>
+                      </a:pPr>
+                      <a:r>
+                        <a:rPr lang="en-US" sz="1400" b="1" dirty="0">
+                          <a:solidFill>
+                            <a:srgbClr val="1A1A1A"/>
+                          </a:solidFill>
+                        </a:rPr>
+                        <a:t>46%</a:t>
+                      </a:r>
+                      <a:endParaRPr lang="en-US" sz="1400" dirty="0"/>
+                    </a:p>
+                  </a:txBody>
+                  <a:tcPr marL="73152" marR="73152" marT="73152" marB="73152" anchor="ctr">
+                    <a:lnL w="6350" cap="flat" cmpd="sng" algn="ctr">
+                      <a:solidFill>
+                        <a:srgbClr val="CCCCCC"/>
+                      </a:solidFill>
+                      <a:prstDash val="solid"/>
+                      <a:round/>
+                      <a:headEnd type="none" w="med" len="med"/>
+                      <a:tailEnd type="none" w="med" len="med"/>
+                    </a:lnL>
+                    <a:lnR w="6350" cap="flat" cmpd="sng" algn="ctr">
+                      <a:solidFill>
+                        <a:srgbClr val="CCCCCC"/>
+                      </a:solidFill>
+                      <a:prstDash val="solid"/>
+                      <a:round/>
+                      <a:headEnd type="none" w="med" len="med"/>
+                      <a:tailEnd type="none" w="med" len="med"/>
+                    </a:lnR>
+                    <a:lnT w="6350" cap="flat" cmpd="sng" algn="ctr">
+                      <a:solidFill>
+                        <a:srgbClr val="CCCCCC"/>
+                      </a:solidFill>
+                      <a:prstDash val="solid"/>
+                      <a:round/>
+                      <a:headEnd type="none" w="med" len="med"/>
+                      <a:tailEnd type="none" w="med" len="med"/>
+                    </a:lnT>
+                    <a:lnB w="6350" cap="flat" cmpd="sng" algn="ctr">
+                      <a:solidFill>
+                        <a:srgbClr val="CCCCCC"/>
+                      </a:solidFill>
+                      <a:prstDash val="solid"/>
+                      <a:round/>
+                      <a:headEnd type="none" w="med" len="med"/>
+                      <a:tailEnd type="none" w="med" len="med"/>
+                    </a:lnB>
+                  </a:tcPr>
+                </a:tc>
+                <a:tc>
+                  <a:txBody>
+                    <a:bodyPr/>
+                    <a:lstStyle/>
+                    <a:p>
+                      <a:pPr algn="ctr" indent="0" marL="0">
+                        <a:buNone/>
+                      </a:pPr>
+                      <a:r>
+                        <a:rPr lang="en-US" sz="1400" dirty="0">
+                          <a:solidFill>
+                            <a:srgbClr val="1A1A1A"/>
+                          </a:solidFill>
+                        </a:rPr>
+                        <a:t>+8</a:t>
+                      </a:r>
+                      <a:endParaRPr lang="en-US" sz="1400" dirty="0"/>
+                    </a:p>
+                  </a:txBody>
+                  <a:tcPr marL="73152" marR="73152" marT="73152" marB="73152" anchor="ctr">
+                    <a:lnL w="6350" cap="flat" cmpd="sng" algn="ctr">
+                      <a:solidFill>
+                        <a:srgbClr val="CCCCCC"/>
+                      </a:solidFill>
+                      <a:prstDash val="solid"/>
+                      <a:round/>
+                      <a:headEnd type="none" w="med" len="med"/>
+                      <a:tailEnd type="none" w="med" len="med"/>
+                    </a:lnL>
+                    <a:lnR w="6350" cap="flat" cmpd="sng" algn="ctr">
+                      <a:solidFill>
+                        <a:srgbClr val="CCCCCC"/>
+                      </a:solidFill>
+                      <a:prstDash val="solid"/>
+                      <a:round/>
+                      <a:headEnd type="none" w="med" len="med"/>
+                      <a:tailEnd type="none" w="med" len="med"/>
+                    </a:lnR>
+                    <a:lnT w="6350" cap="flat" cmpd="sng" algn="ctr">
+                      <a:solidFill>
+                        <a:srgbClr val="CCCCCC"/>
+                      </a:solidFill>
+                      <a:prstDash val="solid"/>
+                      <a:round/>
+                      <a:headEnd type="none" w="med" len="med"/>
+                      <a:tailEnd type="none" w="med" len="med"/>
+                    </a:lnT>
+                    <a:lnB w="6350" cap="flat" cmpd="sng" algn="ctr">
+                      <a:solidFill>
+                        <a:srgbClr val="CCCCCC"/>
+                      </a:solidFill>
+                      <a:prstDash val="solid"/>
+                      <a:round/>
+                      <a:headEnd type="none" w="med" len="med"/>
+                      <a:tailEnd type="none" w="med" len="med"/>
+                    </a:lnB>
+                  </a:tcPr>
+                </a:tc>
+              </a:tr>
+              <a:tr h="411480">
+                <a:tc>
+                  <a:txBody>
+                    <a:bodyPr/>
+                    <a:lstStyle/>
+                    <a:p>
+                      <a:pPr algn="l" indent="0" marL="0">
+                        <a:buNone/>
+                      </a:pPr>
+                      <a:r>
+                        <a:rPr lang="en-US" sz="1400" b="1" dirty="0">
+                          <a:solidFill>
+                            <a:srgbClr val="1A1A1A"/>
+                          </a:solidFill>
+                        </a:rPr>
+                        <a:t>Ordering</a:t>
+                      </a:r>
+                      <a:endParaRPr lang="en-US" sz="1400" dirty="0"/>
+                    </a:p>
+                  </a:txBody>
+                  <a:tcPr marL="73152" marR="73152" marT="73152" marB="73152" anchor="ctr">
+                    <a:lnL w="6350" cap="flat" cmpd="sng" algn="ctr">
+                      <a:solidFill>
+                        <a:srgbClr val="CCCCCC"/>
+                      </a:solidFill>
+                      <a:prstDash val="solid"/>
+                      <a:round/>
+                      <a:headEnd type="none" w="med" len="med"/>
+                      <a:tailEnd type="none" w="med" len="med"/>
+                    </a:lnL>
+                    <a:lnR w="6350" cap="flat" cmpd="sng" algn="ctr">
+                      <a:solidFill>
+                        <a:srgbClr val="CCCCCC"/>
+                      </a:solidFill>
+                      <a:prstDash val="solid"/>
+                      <a:round/>
+                      <a:headEnd type="none" w="med" len="med"/>
+                      <a:tailEnd type="none" w="med" len="med"/>
+                    </a:lnR>
+                    <a:lnT w="6350" cap="flat" cmpd="sng" algn="ctr">
+                      <a:solidFill>
+                        <a:srgbClr val="CCCCCC"/>
+                      </a:solidFill>
+                      <a:prstDash val="solid"/>
+                      <a:round/>
+                      <a:headEnd type="none" w="med" len="med"/>
+                      <a:tailEnd type="none" w="med" len="med"/>
+                    </a:lnT>
+                    <a:lnB w="6350" cap="flat" cmpd="sng" algn="ctr">
+                      <a:solidFill>
+                        <a:srgbClr val="CCCCCC"/>
+                      </a:solidFill>
+                      <a:prstDash val="solid"/>
+                      <a:round/>
+                      <a:headEnd type="none" w="med" len="med"/>
+                      <a:tailEnd type="none" w="med" len="med"/>
+                    </a:lnB>
+                  </a:tcPr>
+                </a:tc>
+                <a:tc>
+                  <a:txBody>
+                    <a:bodyPr/>
+                    <a:lstStyle/>
+                    <a:p>
+                      <a:pPr algn="ctr" indent="0" marL="0">
+                        <a:buNone/>
+                      </a:pPr>
+                      <a:r>
+                        <a:rPr lang="en-US" sz="1400" dirty="0">
+                          <a:solidFill>
+                            <a:srgbClr val="1A1A1A"/>
+                          </a:solidFill>
+                        </a:rPr>
+                        <a:t>24</a:t>
+                      </a:r>
+                      <a:endParaRPr lang="en-US" sz="1400" dirty="0"/>
+                    </a:p>
+                  </a:txBody>
+                  <a:tcPr marL="73152" marR="73152" marT="73152" marB="73152" anchor="ctr">
+                    <a:lnL w="6350" cap="flat" cmpd="sng" algn="ctr">
+                      <a:solidFill>
+                        <a:srgbClr val="CCCCCC"/>
+                      </a:solidFill>
+                      <a:prstDash val="solid"/>
+                      <a:round/>
+                      <a:headEnd type="none" w="med" len="med"/>
+                      <a:tailEnd type="none" w="med" len="med"/>
+                    </a:lnL>
+                    <a:lnR w="6350" cap="flat" cmpd="sng" algn="ctr">
+                      <a:solidFill>
+                        <a:srgbClr val="CCCCCC"/>
+                      </a:solidFill>
+                      <a:prstDash val="solid"/>
+                      <a:round/>
+                      <a:headEnd type="none" w="med" len="med"/>
+                      <a:tailEnd type="none" w="med" len="med"/>
+                    </a:lnR>
+                    <a:lnT w="6350" cap="flat" cmpd="sng" algn="ctr">
+                      <a:solidFill>
+                        <a:srgbClr val="CCCCCC"/>
+                      </a:solidFill>
+                      <a:prstDash val="solid"/>
+                      <a:round/>
+                      <a:headEnd type="none" w="med" len="med"/>
+                      <a:tailEnd type="none" w="med" len="med"/>
+                    </a:lnT>
+                    <a:lnB w="6350" cap="flat" cmpd="sng" algn="ctr">
+                      <a:solidFill>
+                        <a:srgbClr val="CCCCCC"/>
+                      </a:solidFill>
+                      <a:prstDash val="solid"/>
+                      <a:round/>
+                      <a:headEnd type="none" w="med" len="med"/>
+                      <a:tailEnd type="none" w="med" len="med"/>
+                    </a:lnB>
+                  </a:tcPr>
+                </a:tc>
+                <a:tc>
+                  <a:txBody>
+                    <a:bodyPr/>
+                    <a:lstStyle/>
+                    <a:p>
+                      <a:pPr algn="ctr" indent="0" marL="0">
+                        <a:buNone/>
+                      </a:pPr>
+                      <a:r>
+                        <a:rPr lang="en-US" sz="1400" b="1" dirty="0">
+                          <a:solidFill>
+                            <a:srgbClr val="0A7D2A"/>
+                          </a:solidFill>
+                        </a:rPr>
+                        <a:t>10</a:t>
+                      </a:r>
+                      <a:endParaRPr lang="en-US" sz="1400" dirty="0"/>
+                    </a:p>
+                  </a:txBody>
+                  <a:tcPr marL="73152" marR="73152" marT="73152" marB="73152" anchor="ctr">
+                    <a:lnL w="6350" cap="flat" cmpd="sng" algn="ctr">
+                      <a:solidFill>
+                        <a:srgbClr val="CCCCCC"/>
+                      </a:solidFill>
+                      <a:prstDash val="solid"/>
+                      <a:round/>
+                      <a:headEnd type="none" w="med" len="med"/>
+                      <a:tailEnd type="none" w="med" len="med"/>
+                    </a:lnL>
+                    <a:lnR w="6350" cap="flat" cmpd="sng" algn="ctr">
+                      <a:solidFill>
+                        <a:srgbClr val="CCCCCC"/>
+                      </a:solidFill>
+                      <a:prstDash val="solid"/>
+                      <a:round/>
+                      <a:headEnd type="none" w="med" len="med"/>
+                      <a:tailEnd type="none" w="med" len="med"/>
+                    </a:lnR>
+                    <a:lnT w="6350" cap="flat" cmpd="sng" algn="ctr">
+                      <a:solidFill>
+                        <a:srgbClr val="CCCCCC"/>
+                      </a:solidFill>
+                      <a:prstDash val="solid"/>
+                      <a:round/>
+                      <a:headEnd type="none" w="med" len="med"/>
+                      <a:tailEnd type="none" w="med" len="med"/>
+                    </a:lnT>
+                    <a:lnB w="6350" cap="flat" cmpd="sng" algn="ctr">
+                      <a:solidFill>
+                        <a:srgbClr val="CCCCCC"/>
+                      </a:solidFill>
+                      <a:prstDash val="solid"/>
+                      <a:round/>
+                      <a:headEnd type="none" w="med" len="med"/>
+                      <a:tailEnd type="none" w="med" len="med"/>
+                    </a:lnB>
+                    <a:solidFill>
+                      <a:srgbClr val="D4F0DC"/>
+                    </a:solidFill>
+                  </a:tcPr>
+                </a:tc>
+                <a:tc>
+                  <a:txBody>
+                    <a:bodyPr/>
+                    <a:lstStyle/>
+                    <a:p>
+                      <a:pPr algn="ctr" indent="0" marL="0">
+                        <a:buNone/>
+                      </a:pPr>
+                      <a:r>
+                        <a:rPr lang="en-US" sz="1400" b="1" dirty="0">
+                          <a:solidFill>
+                            <a:srgbClr val="8A6A00"/>
+                          </a:solidFill>
+                        </a:rPr>
+                        <a:t>12</a:t>
+                      </a:r>
+                      <a:endParaRPr lang="en-US" sz="1400" dirty="0"/>
+                    </a:p>
+                  </a:txBody>
+                  <a:tcPr marL="73152" marR="73152" marT="73152" marB="73152" anchor="ctr">
+                    <a:lnL w="6350" cap="flat" cmpd="sng" algn="ctr">
+                      <a:solidFill>
+                        <a:srgbClr val="CCCCCC"/>
+                      </a:solidFill>
+                      <a:prstDash val="solid"/>
+                      <a:round/>
+                      <a:headEnd type="none" w="med" len="med"/>
+                      <a:tailEnd type="none" w="med" len="med"/>
+                    </a:lnL>
+                    <a:lnR w="6350" cap="flat" cmpd="sng" algn="ctr">
+                      <a:solidFill>
+                        <a:srgbClr val="CCCCCC"/>
+                      </a:solidFill>
+                      <a:prstDash val="solid"/>
+                      <a:round/>
+                      <a:headEnd type="none" w="med" len="med"/>
+                      <a:tailEnd type="none" w="med" len="med"/>
+                    </a:lnR>
+                    <a:lnT w="6350" cap="flat" cmpd="sng" algn="ctr">
+                      <a:solidFill>
+                        <a:srgbClr val="CCCCCC"/>
+                      </a:solidFill>
+                      <a:prstDash val="solid"/>
+                      <a:round/>
+                      <a:headEnd type="none" w="med" len="med"/>
+                      <a:tailEnd type="none" w="med" len="med"/>
+                    </a:lnT>
+                    <a:lnB w="6350" cap="flat" cmpd="sng" algn="ctr">
+                      <a:solidFill>
+                        <a:srgbClr val="CCCCCC"/>
+                      </a:solidFill>
+                      <a:prstDash val="solid"/>
+                      <a:round/>
+                      <a:headEnd type="none" w="med" len="med"/>
+                      <a:tailEnd type="none" w="med" len="med"/>
+                    </a:lnB>
+                    <a:solidFill>
+                      <a:srgbClr val="FFF4D6"/>
+                    </a:solidFill>
+                  </a:tcPr>
+                </a:tc>
+                <a:tc>
+                  <a:txBody>
+                    <a:bodyPr/>
+                    <a:lstStyle/>
+                    <a:p>
+                      <a:pPr algn="ctr" indent="0" marL="0">
+                        <a:buNone/>
+                      </a:pPr>
+                      <a:r>
+                        <a:rPr lang="en-US" sz="1400" b="1" dirty="0">
+                          <a:solidFill>
+                            <a:srgbClr val="B33A1E"/>
+                          </a:solidFill>
+                        </a:rPr>
+                        <a:t>2</a:t>
+                      </a:r>
+                      <a:endParaRPr lang="en-US" sz="1400" dirty="0"/>
+                    </a:p>
+                  </a:txBody>
+                  <a:tcPr marL="73152" marR="73152" marT="73152" marB="73152" anchor="ctr">
+                    <a:lnL w="6350" cap="flat" cmpd="sng" algn="ctr">
+                      <a:solidFill>
+                        <a:srgbClr val="CCCCCC"/>
+                      </a:solidFill>
+                      <a:prstDash val="solid"/>
+                      <a:round/>
+                      <a:headEnd type="none" w="med" len="med"/>
+                      <a:tailEnd type="none" w="med" len="med"/>
+                    </a:lnL>
+                    <a:lnR w="6350" cap="flat" cmpd="sng" algn="ctr">
+                      <a:solidFill>
+                        <a:srgbClr val="CCCCCC"/>
+                      </a:solidFill>
+                      <a:prstDash val="solid"/>
+                      <a:round/>
+                      <a:headEnd type="none" w="med" len="med"/>
+                      <a:tailEnd type="none" w="med" len="med"/>
+                    </a:lnR>
+                    <a:lnT w="6350" cap="flat" cmpd="sng" algn="ctr">
+                      <a:solidFill>
+                        <a:srgbClr val="CCCCCC"/>
+                      </a:solidFill>
+                      <a:prstDash val="solid"/>
+                      <a:round/>
+                      <a:headEnd type="none" w="med" len="med"/>
+                      <a:tailEnd type="none" w="med" len="med"/>
+                    </a:lnT>
+                    <a:lnB w="6350" cap="flat" cmpd="sng" algn="ctr">
+                      <a:solidFill>
+                        <a:srgbClr val="CCCCCC"/>
+                      </a:solidFill>
+                      <a:prstDash val="solid"/>
+                      <a:round/>
+                      <a:headEnd type="none" w="med" len="med"/>
+                      <a:tailEnd type="none" w="med" len="med"/>
+                    </a:lnB>
+                    <a:solidFill>
+                      <a:srgbClr val="F5D5CE"/>
+                    </a:solidFill>
+                  </a:tcPr>
+                </a:tc>
+                <a:tc>
+                  <a:txBody>
+                    <a:bodyPr/>
+                    <a:lstStyle/>
+                    <a:p>
+                      <a:pPr algn="ctr" indent="0" marL="0">
+                        <a:buNone/>
+                      </a:pPr>
+                      <a:r>
+                        <a:rPr lang="en-US" sz="1400" b="1" dirty="0">
+                          <a:solidFill>
+                            <a:srgbClr val="1A1A1A"/>
+                          </a:solidFill>
+                        </a:rPr>
+                        <a:t>42%</a:t>
+                      </a:r>
+                      <a:endParaRPr lang="en-US" sz="1400" dirty="0"/>
+                    </a:p>
+                  </a:txBody>
+                  <a:tcPr marL="73152" marR="73152" marT="73152" marB="73152" anchor="ctr">
+                    <a:lnL w="6350" cap="flat" cmpd="sng" algn="ctr">
+                      <a:solidFill>
+                        <a:srgbClr val="CCCCCC"/>
+                      </a:solidFill>
+                      <a:prstDash val="solid"/>
+                      <a:round/>
+                      <a:headEnd type="none" w="med" len="med"/>
+                      <a:tailEnd type="none" w="med" len="med"/>
+                    </a:lnL>
+                    <a:lnR w="6350" cap="flat" cmpd="sng" algn="ctr">
+                      <a:solidFill>
+                        <a:srgbClr val="CCCCCC"/>
+                      </a:solidFill>
+                      <a:prstDash val="solid"/>
+                      <a:round/>
+                      <a:headEnd type="none" w="med" len="med"/>
+                      <a:tailEnd type="none" w="med" len="med"/>
+                    </a:lnR>
+                    <a:lnT w="6350" cap="flat" cmpd="sng" algn="ctr">
+                      <a:solidFill>
+                        <a:srgbClr val="CCCCCC"/>
+                      </a:solidFill>
+                      <a:prstDash val="solid"/>
+                      <a:round/>
+                      <a:headEnd type="none" w="med" len="med"/>
+                      <a:tailEnd type="none" w="med" len="med"/>
+                    </a:lnT>
+                    <a:lnB w="6350" cap="flat" cmpd="sng" algn="ctr">
+                      <a:solidFill>
+                        <a:srgbClr val="CCCCCC"/>
+                      </a:solidFill>
+                      <a:prstDash val="solid"/>
+                      <a:round/>
+                      <a:headEnd type="none" w="med" len="med"/>
+                      <a:tailEnd type="none" w="med" len="med"/>
+                    </a:lnB>
+                  </a:tcPr>
+                </a:tc>
+                <a:tc>
+                  <a:txBody>
+                    <a:bodyPr/>
+                    <a:lstStyle/>
+                    <a:p>
+                      <a:pPr algn="ctr" indent="0" marL="0">
+                        <a:buNone/>
+                      </a:pPr>
+                      <a:r>
+                        <a:rPr lang="en-US" sz="1400" dirty="0">
+                          <a:solidFill>
+                            <a:srgbClr val="1A1A1A"/>
+                          </a:solidFill>
+                        </a:rPr>
+                        <a:t>+9</a:t>
+                      </a:r>
+                      <a:endParaRPr lang="en-US" sz="1400" dirty="0"/>
+                    </a:p>
+                  </a:txBody>
+                  <a:tcPr marL="73152" marR="73152" marT="73152" marB="73152" anchor="ctr">
+                    <a:lnL w="6350" cap="flat" cmpd="sng" algn="ctr">
+                      <a:solidFill>
+                        <a:srgbClr val="CCCCCC"/>
+                      </a:solidFill>
+                      <a:prstDash val="solid"/>
+                      <a:round/>
+                      <a:headEnd type="none" w="med" len="med"/>
+                      <a:tailEnd type="none" w="med" len="med"/>
+                    </a:lnL>
+                    <a:lnR w="6350" cap="flat" cmpd="sng" algn="ctr">
+                      <a:solidFill>
+                        <a:srgbClr val="CCCCCC"/>
+                      </a:solidFill>
+                      <a:prstDash val="solid"/>
+                      <a:round/>
+                      <a:headEnd type="none" w="med" len="med"/>
+                      <a:tailEnd type="none" w="med" len="med"/>
+                    </a:lnR>
+                    <a:lnT w="6350" cap="flat" cmpd="sng" algn="ctr">
+                      <a:solidFill>
+                        <a:srgbClr val="CCCCCC"/>
+                      </a:solidFill>
+                      <a:prstDash val="solid"/>
+                      <a:round/>
+                      <a:headEnd type="none" w="med" len="med"/>
+                      <a:tailEnd type="none" w="med" len="med"/>
+                    </a:lnT>
+                    <a:lnB w="6350" cap="flat" cmpd="sng" algn="ctr">
+                      <a:solidFill>
+                        <a:srgbClr val="CCCCCC"/>
+                      </a:solidFill>
+                      <a:prstDash val="solid"/>
+                      <a:round/>
+                      <a:headEnd type="none" w="med" len="med"/>
+                      <a:tailEnd type="none" w="med" len="med"/>
+                    </a:lnB>
+                  </a:tcPr>
+                </a:tc>
+              </a:tr>
+            </a:tbl>
+          </a:graphicData>
+        </a:graphic>
+      </p:graphicFrame>
+      <p:sp>
+        <p:nvSpPr>
+          <p:cNvPr id="5" name="Text 2"/>
+          <p:cNvSpPr/>
+          <p:nvPr/>
+        </p:nvSpPr>
+        <p:spPr>
+          <a:xfrm>
+            <a:off x="365760" y="4206240"/>
+            <a:ext cx="8412480" cy="548640"/>
+          </a:xfrm>
+          <a:prstGeom prst="rect">
+            <a:avLst/>
+          </a:prstGeom>
+          <a:noFill/>
+          <a:ln/>
+        </p:spPr>
+        <p:txBody>
+          <a:bodyPr wrap="square" lIns="0" tIns="0" rIns="0" bIns="0" rtlCol="0" anchor="ctr"/>
+          <a:lstStyle/>
+          <a:p>
+            <a:pPr algn="ctr" indent="0" marL="0">
+              <a:buNone/>
+            </a:pPr>
+            <a:r>
+              <a:rPr lang="en-US" sz="1000" i="1" dirty="0">
+                <a:solidFill>
+                  <a:srgbClr val="777777"/>
+                </a:solidFill>
+              </a:rPr>
+              <a:t>Ordering alternatives share the end state, so only W_lag (intermediate cleanliness) can separate them. They tie when intermediate cleanliness is identical - often when build/tests broke and cleanliness stats are frozen at the last trustworthy value. </a:t>
+            </a:r>
+            <a:pPr algn="ctr" indent="0" marL="0">
+              <a:buNone/>
+            </a:pPr>
+            <a:r>
+              <a:rPr lang="en-US" sz="1000" i="1" dirty="0">
+                <a:solidFill>
+                  <a:srgbClr val="777777"/>
+                </a:solidFill>
+              </a:rPr>
+              <a:t>Manual-Refactor's 3 ties + 1 loss come from the [0,100] score clamp - the user's score is pinned at the floor, so the IDE alternative can't score lower either.</a:t>
+            </a:r>
+            <a:endParaRPr lang="en-US" sz="1000" dirty="0"/>
           </a:p>
         </p:txBody>
       </p:sp>
@@ -6951,7 +9161,7 @@
                   <a:srgbClr val="000000"/>
                 </a:solidFill>
               </a:rPr>
-              <a:t>User study: does feedback change behaviour?</a:t>
+              <a:t>Score robustness</a:t>
             </a:r>
             <a:endParaRPr lang="en-US" sz="2800" dirty="0"/>
           </a:p>
@@ -6991,7 +9201,7 @@
                   <a:srgbClr val="000000"/>
                 </a:solidFill>
               </a:rPr>
-              <a:t>With-feedback group: 2.7 divergence points per session.</a:t>
+              <a:t>Single-knob sensitivity sweep: scale any one weight by {0.1×–10×}, top-1 recommendation is preserved in 96.5% of user-study cases.</a:t>
             </a:r>
             <a:endParaRPr lang="en-US" sz="1600" dirty="0"/>
           </a:p>
@@ -7009,7 +9219,7 @@
                   <a:srgbClr val="000000"/>
                 </a:solidFill>
               </a:rPr>
-              <a:t>No-feedback baseline: 6.0 divergence points per session -2.2× difference.</a:t>
+              <a:t>Multi-knob Monte Carlo (200 samples): top-1 stability drops to 84.6%; mean Kendall τ = 0.586.</a:t>
             </a:r>
             <a:endParaRPr lang="en-US" sz="1600" dirty="0"/>
           </a:p>
@@ -7027,7 +9237,7 @@
                   <a:srgbClr val="000000"/>
                 </a:solidFill>
               </a:rPr>
-              <a:t>Gain-stripped process-score slope across the 6-session arc -+4.47 per session with feedback, −0.40 per session without.</a:t>
+              <a:t>Honest framing - stable near the chosen weights, less stable under arbitrary joint perturbations.</a:t>
             </a:r>
             <a:endParaRPr lang="en-US" sz="1600" dirty="0"/>
           </a:p>
@@ -7045,7 +9255,7 @@
                   <a:srgbClr val="000000"/>
                 </a:solidFill>
               </a:rPr>
-              <a:t>Caveat: n=3 vs n=2 is directional evidence, not a hypothesis test.</a:t>
+              <a:t>Ablation confirms each process term contributes real signal; endpoint gain alone does not recover the ranking.</a:t>
             </a:r>
             <a:endParaRPr lang="en-US" sz="1600" dirty="0"/>
           </a:p>
@@ -7257,6 +9467,161 @@
 <file path=ppt/slides/slide20.xml><?xml version="1.0" encoding="utf-8"?>
 <p:sld xmlns:a="http://schemas.openxmlformats.org/drawingml/2006/main" xmlns:r="http://schemas.openxmlformats.org/officeDocument/2006/relationships" xmlns:p="http://schemas.openxmlformats.org/presentationml/2006/main">
   <p:cSld name="Slide 20">
+    <p:spTree>
+      <p:nvGrpSpPr>
+        <p:cNvPr id="1" name=""/>
+        <p:cNvGrpSpPr/>
+        <p:nvPr/>
+      </p:nvGrpSpPr>
+      <p:grpSpPr>
+        <a:xfrm>
+          <a:off x="0" y="0"/>
+          <a:ext cx="0" cy="0"/>
+          <a:chOff x="0" y="0"/>
+          <a:chExt cx="0" cy="0"/>
+        </a:xfrm>
+      </p:grpSpPr>
+      <p:sp>
+        <p:nvSpPr>
+          <p:cNvPr id="2" name="Text 0"/>
+          <p:cNvSpPr/>
+          <p:nvPr/>
+        </p:nvSpPr>
+        <p:spPr>
+          <a:xfrm>
+            <a:off x="457200" y="274320"/>
+            <a:ext cx="8229600" cy="640080"/>
+          </a:xfrm>
+          <a:prstGeom prst="rect">
+            <a:avLst/>
+          </a:prstGeom>
+          <a:noFill/>
+          <a:ln/>
+        </p:spPr>
+        <p:txBody>
+          <a:bodyPr wrap="square" lIns="0" tIns="0" rIns="0" bIns="0" rtlCol="0" anchor="ctr"/>
+          <a:lstStyle/>
+          <a:p>
+            <a:pPr indent="0" marL="0">
+              <a:buNone/>
+            </a:pPr>
+            <a:r>
+              <a:rPr lang="en-US" sz="2800" b="1" dirty="0">
+                <a:solidFill>
+                  <a:srgbClr val="000000"/>
+                </a:solidFill>
+              </a:rPr>
+              <a:t>User study: does feedback change behaviour?</a:t>
+            </a:r>
+            <a:endParaRPr lang="en-US" sz="2800" dirty="0"/>
+          </a:p>
+        </p:txBody>
+      </p:sp>
+      <p:sp>
+        <p:nvSpPr>
+          <p:cNvPr id="3" name="Text 1"/>
+          <p:cNvSpPr/>
+          <p:nvPr/>
+        </p:nvSpPr>
+        <p:spPr>
+          <a:xfrm>
+            <a:off x="457200" y="1188720"/>
+            <a:ext cx="8229600" cy="3657600"/>
+          </a:xfrm>
+          <a:prstGeom prst="rect">
+            <a:avLst/>
+          </a:prstGeom>
+          <a:noFill/>
+          <a:ln/>
+        </p:spPr>
+        <p:txBody>
+          <a:bodyPr wrap="square" rtlCol="0" anchor="t"/>
+          <a:lstStyle/>
+          <a:p>
+            <a:pPr marL="342900" indent="-342900">
+              <a:spcAft>
+                <a:spcPts val="600"/>
+              </a:spcAft>
+              <a:buSzPct val="100000"/>
+              <a:buChar char="•"/>
+            </a:pPr>
+            <a:r>
+              <a:rPr lang="en-US" sz="1600" dirty="0">
+                <a:solidFill>
+                  <a:srgbClr val="000000"/>
+                </a:solidFill>
+              </a:rPr>
+              <a:t>With-feedback group: 2.7 divergence points per session.</a:t>
+            </a:r>
+            <a:endParaRPr lang="en-US" sz="1600" dirty="0"/>
+          </a:p>
+          <a:p>
+            <a:pPr marL="342900" indent="-342900">
+              <a:spcAft>
+                <a:spcPts val="600"/>
+              </a:spcAft>
+              <a:buSzPct val="100000"/>
+              <a:buChar char="•"/>
+            </a:pPr>
+            <a:r>
+              <a:rPr lang="en-US" sz="1600" dirty="0">
+                <a:solidFill>
+                  <a:srgbClr val="000000"/>
+                </a:solidFill>
+              </a:rPr>
+              <a:t>No-feedback baseline: 6.0 divergence points per session -2.2× difference.</a:t>
+            </a:r>
+            <a:endParaRPr lang="en-US" sz="1600" dirty="0"/>
+          </a:p>
+          <a:p>
+            <a:pPr marL="342900" indent="-342900">
+              <a:spcAft>
+                <a:spcPts val="600"/>
+              </a:spcAft>
+              <a:buSzPct val="100000"/>
+              <a:buChar char="•"/>
+            </a:pPr>
+            <a:r>
+              <a:rPr lang="en-US" sz="1600" dirty="0">
+                <a:solidFill>
+                  <a:srgbClr val="000000"/>
+                </a:solidFill>
+              </a:rPr>
+              <a:t>Gain-stripped process-score slope across the 6-session arc -+4.47 per session with feedback, −0.40 per session without.</a:t>
+            </a:r>
+            <a:endParaRPr lang="en-US" sz="1600" dirty="0"/>
+          </a:p>
+          <a:p>
+            <a:pPr marL="342900" indent="-342900">
+              <a:spcAft>
+                <a:spcPts val="600"/>
+              </a:spcAft>
+              <a:buSzPct val="100000"/>
+              <a:buChar char="•"/>
+            </a:pPr>
+            <a:r>
+              <a:rPr lang="en-US" sz="1600" dirty="0">
+                <a:solidFill>
+                  <a:srgbClr val="000000"/>
+                </a:solidFill>
+              </a:rPr>
+              <a:t>Caveat: n=3 vs n=2 is directional evidence, not a hypothesis test.</a:t>
+            </a:r>
+            <a:endParaRPr lang="en-US" sz="1600" dirty="0"/>
+          </a:p>
+        </p:txBody>
+      </p:sp>
+    </p:spTree>
+  </p:cSld>
+  <p:clrMapOvr>
+    <a:masterClrMapping/>
+  </p:clrMapOvr>
+</p:sld>
+</file>
+
+<file path=ppt/slides/slide21.xml><?xml version="1.0" encoding="utf-8"?>
+<p:sld xmlns:a="http://schemas.openxmlformats.org/drawingml/2006/main" xmlns:r="http://schemas.openxmlformats.org/officeDocument/2006/relationships" xmlns:p="http://schemas.openxmlformats.org/presentationml/2006/main">
+  <p:cSld name="Slide 21">
     <p:spTree>
       <p:nvGrpSpPr>
         <p:cNvPr id="1" name=""/>

</xml_diff>

<commit_message>
feat: add temp score reliability results slide
</commit_message>
<xml_diff>
--- a/presentation/slides.pptx
+++ b/presentation/slides.pptx
@@ -26,9 +26,10 @@
     <p:sldId id="274" r:id="rId20"/>
     <p:sldId id="275" r:id="rId21"/>
     <p:sldId id="276" r:id="rId22"/>
+    <p:sldId id="277" r:id="rId23"/>
   </p:sldIdLst>
   <p:notesMasterIdLst>
-    <p:notesMasterId r:id="rId23"/>
+    <p:notesMasterId r:id="rId24"/>
   </p:notesMasterIdLst>
   <p:sldSz cx="9144000" cy="5143500"/>
   <p:notesSz cx="5143500" cy="9144000"/>
@@ -1690,6 +1691,94 @@
             <a:fld id="{F7021451-1387-4CA6-816F-3879F97B5CBC}" type="slidenum">
               <a:rPr lang="en-US"/>
               <a:t>21</a:t>
+            </a:fld>
+            <a:endParaRPr lang="en-US"/>
+          </a:p>
+        </p:txBody>
+      </p:sp>
+    </p:spTree>
+    <p:extLst>
+      <p:ext uri="{BB962C8B-B14F-4D97-AF65-F5344CB8AC3E}">
+        <p14:creationId xmlns:p14="http://schemas.microsoft.com/office/powerpoint/2010/main" val="1024086991"/>
+      </p:ext>
+    </p:extLst>
+  </p:cSld>
+  <p:clrMapOvr>
+    <a:masterClrMapping/>
+  </p:clrMapOvr>
+</p:notes>
+</file>
+
+<file path=ppt/notesSlides/notesSlide22.xml><?xml version="1.0" encoding="utf-8"?>
+<p:notes xmlns:a="http://schemas.openxmlformats.org/drawingml/2006/main" xmlns:r="http://schemas.openxmlformats.org/officeDocument/2006/relationships" xmlns:p="http://schemas.openxmlformats.org/presentationml/2006/main">
+  <p:cSld>
+    <p:spTree>
+      <p:nvGrpSpPr>
+        <p:cNvPr id="1" name=""/>
+        <p:cNvGrpSpPr/>
+        <p:nvPr/>
+      </p:nvGrpSpPr>
+      <p:grpSpPr>
+        <a:xfrm>
+          <a:off x="0" y="0"/>
+          <a:ext cx="0" cy="0"/>
+          <a:chOff x="0" y="0"/>
+          <a:chExt cx="0" cy="0"/>
+        </a:xfrm>
+      </p:grpSpPr>
+      <p:sp>
+        <p:nvSpPr>
+          <p:cNvPr id="2" name="Slide Image Placeholder 1"/>
+          <p:cNvSpPr>
+            <a:spLocks noGrp="1" noRot="1" noChangeAspect="1"/>
+          </p:cNvSpPr>
+          <p:nvPr>
+            <p:ph type="sldImg"/>
+          </p:nvPr>
+        </p:nvSpPr>
+        <p:spPr/>
+      </p:sp>
+      <p:sp>
+        <p:nvSpPr>
+          <p:cNvPr id="3" name="Notes Placeholder 2"/>
+          <p:cNvSpPr>
+            <a:spLocks noGrp="1"/>
+          </p:cNvSpPr>
+          <p:nvPr>
+            <p:ph type="body" idx="1"/>
+          </p:nvPr>
+        </p:nvSpPr>
+        <p:spPr/>
+        <p:txBody>
+          <a:bodyPr/>
+          <a:lstStyle/>
+          <a:p>
+            <a:r>
+              <a:rPr lang="en-US" dirty="0"/>
+              <a:t/>
+            </a:r>
+            <a:endParaRPr lang="en-US" dirty="0"/>
+          </a:p>
+        </p:txBody>
+      </p:sp>
+      <p:sp>
+        <p:nvSpPr>
+          <p:cNvPr id="4" name="Slide Number Placeholder 3"/>
+          <p:cNvSpPr>
+            <a:spLocks noGrp="1"/>
+          </p:cNvSpPr>
+          <p:nvPr>
+            <p:ph type="sldNum" sz="quarter" idx="10"/>
+          </p:nvPr>
+        </p:nvSpPr>
+        <p:spPr/>
+        <p:txBody>
+          <a:bodyPr/>
+          <a:lstStyle/>
+          <a:p>
+            <a:fld id="{F7021451-1387-4CA6-816F-3879F97B5CBC}" type="slidenum">
+              <a:rPr lang="en-US"/>
+              <a:t>22</a:t>
             </a:fld>
             <a:endParaRPr lang="en-US"/>
           </a:p>
@@ -4449,7 +4538,7 @@
                   <a:srgbClr val="000000"/>
                 </a:solidFill>
               </a:rPr>
-              <a:t>Track all ordering points detected </a:t>
+              <a:t>Track all divergence points detected </a:t>
             </a:r>
             <a:pPr indent="0" marL="0">
               <a:spcAft>
@@ -9161,7 +9250,7 @@
                   <a:srgbClr val="000000"/>
                 </a:solidFill>
               </a:rPr>
-              <a:t>Score robustness</a:t>
+              <a:t>Is the process score reliable?</a:t>
             </a:r>
             <a:endParaRPr lang="en-US" sz="2800" dirty="0"/>
           </a:p>
@@ -9196,14 +9285,78 @@
               <a:buChar char="•"/>
             </a:pPr>
             <a:r>
-              <a:rPr lang="en-US" sz="1600" dirty="0">
+              <a:rPr lang="en-US" sz="1500" b="1" dirty="0">
                 <a:solidFill>
                   <a:srgbClr val="000000"/>
                 </a:solidFill>
               </a:rPr>
-              <a:t>Single-knob sensitivity sweep: scale any one weight by {0.1×–10×}, top-1 recommendation is preserved in 96.5% of user-study cases.</a:t>
-            </a:r>
-            <a:endParaRPr lang="en-US" sz="1600" dirty="0"/>
+              <a:t>How stable is the score?</a:t>
+            </a:r>
+            <a:endParaRPr lang="en-US" sz="1500" dirty="0"/>
+          </a:p>
+          <a:p>
+            <a:pPr lvl="1" marL="762000" indent="-381000">
+              <a:spcAft>
+                <a:spcPts val="600"/>
+              </a:spcAft>
+              <a:buSzPct val="100000"/>
+              <a:buChar char="•"/>
+            </a:pPr>
+            <a:r>
+              <a:rPr lang="en-US" sz="1500" dirty="0">
+                <a:solidFill>
+                  <a:srgbClr val="000000"/>
+                </a:solidFill>
+              </a:rPr>
+              <a:t>Two perturbation sweeps </a:t>
+            </a:r>
+            <a:pPr indent="0" marL="0">
+              <a:spcAft>
+                <a:spcPts val="600"/>
+              </a:spcAft>
+              <a:buNone/>
+            </a:pPr>
+            <a:r>
+              <a:rPr lang="en-US" sz="1500" dirty="0">
+                <a:solidFill>
+                  <a:srgbClr val="888888"/>
+                </a:solidFill>
+              </a:rPr>
+              <a:t>- single-knob (one weight scaled ×0.1 to ×10) + multi-knob Monte Carlo (200 samples, σ = ln 2, so ~×0.25 to ×4 of production).</a:t>
+            </a:r>
+            <a:endParaRPr lang="en-US" sz="1500" dirty="0"/>
+          </a:p>
+          <a:p>
+            <a:pPr lvl="1" marL="762000" indent="-381000">
+              <a:spcAft>
+                <a:spcPts val="1800"/>
+              </a:spcAft>
+              <a:buSzPct val="100000"/>
+              <a:buChar char="•"/>
+            </a:pPr>
+            <a:r>
+              <a:rPr lang="en-US" sz="1500" dirty="0">
+                <a:solidFill>
+                  <a:srgbClr val="000000"/>
+                </a:solidFill>
+              </a:rPr>
+              <a:t>Stability metrics </a:t>
+            </a:r>
+            <a:pPr indent="0" marL="0">
+              <a:spcAft>
+                <a:spcPts val="1800"/>
+              </a:spcAft>
+              <a:buNone/>
+            </a:pPr>
+            <a:r>
+              <a:rPr lang="en-US" sz="1500" dirty="0">
+                <a:solidFill>
+                  <a:srgbClr val="888888"/>
+                </a:solidFill>
+              </a:rPr>
+              <a:t>- top-1 hit rate (does the top-ranked DP stay on top?) + Kendall's τ-b on per-session rankings.</a:t>
+            </a:r>
+            <a:endParaRPr lang="en-US" sz="1500" dirty="0"/>
           </a:p>
           <a:p>
             <a:pPr marL="342900" indent="-342900">
@@ -9214,17 +9367,17 @@
               <a:buChar char="•"/>
             </a:pPr>
             <a:r>
-              <a:rPr lang="en-US" sz="1600" dirty="0">
+              <a:rPr lang="en-US" sz="1500" b="1" dirty="0">
                 <a:solidFill>
                   <a:srgbClr val="000000"/>
                 </a:solidFill>
               </a:rPr>
-              <a:t>Multi-knob Monte Carlo (200 samples): top-1 stability drops to 84.6%; mean Kendall τ = 0.586.</a:t>
-            </a:r>
-            <a:endParaRPr lang="en-US" sz="1600" dirty="0"/>
-          </a:p>
-          <a:p>
-            <a:pPr marL="342900" indent="-342900">
+              <a:t>Does every component of the process score hold weight?</a:t>
+            </a:r>
+            <a:endParaRPr lang="en-US" sz="1500" dirty="0"/>
+          </a:p>
+          <a:p>
+            <a:pPr lvl="1" marL="762000" indent="-381000">
               <a:spcAft>
                 <a:spcPts val="600"/>
               </a:spcAft>
@@ -9232,17 +9385,31 @@
               <a:buChar char="•"/>
             </a:pPr>
             <a:r>
-              <a:rPr lang="en-US" sz="1600" dirty="0">
+              <a:rPr lang="en-US" sz="1500" dirty="0">
                 <a:solidFill>
                   <a:srgbClr val="000000"/>
                 </a:solidFill>
               </a:rPr>
-              <a:t>Honest framing - stable near the chosen weights, less stable under arbitrary joint perturbations.</a:t>
-            </a:r>
-            <a:endParaRPr lang="en-US" sz="1600" dirty="0"/>
-          </a:p>
-          <a:p>
-            <a:pPr marL="342900" indent="-342900">
+              <a:t>Process-side ablation </a:t>
+            </a:r>
+            <a:pPr indent="0" marL="0">
+              <a:spcAft>
+                <a:spcPts val="600"/>
+              </a:spcAft>
+              <a:buNone/>
+            </a:pPr>
+            <a:r>
+              <a:rPr lang="en-US" sz="1500" dirty="0">
+                <a:solidFill>
+                  <a:srgbClr val="888888"/>
+                </a:solidFill>
+              </a:rPr>
+              <a:t>- enumerate all 2⁷ = 128 subsets of the 7 process weights → 5,760 cases per session set.</a:t>
+            </a:r>
+            <a:endParaRPr lang="en-US" sz="1500" dirty="0"/>
+          </a:p>
+          <a:p>
+            <a:pPr lvl="1" marL="762000" indent="-381000">
               <a:spcAft>
                 <a:spcPts val="600"/>
               </a:spcAft>
@@ -9250,14 +9417,28 @@
               <a:buChar char="•"/>
             </a:pPr>
             <a:r>
-              <a:rPr lang="en-US" sz="1600" dirty="0">
+              <a:rPr lang="en-US" sz="1500" dirty="0">
                 <a:solidFill>
                   <a:srgbClr val="000000"/>
                 </a:solidFill>
               </a:rPr>
-              <a:t>Ablation confirms each process term contributes real signal; endpoint gain alone does not recover the ranking.</a:t>
-            </a:r>
-            <a:endParaRPr lang="en-US" sz="1600" dirty="0"/>
+              <a:t>Recovery metrics </a:t>
+            </a:r>
+            <a:pPr indent="0" marL="0">
+              <a:spcAft>
+                <a:spcPts val="600"/>
+              </a:spcAft>
+              <a:buNone/>
+            </a:pPr>
+            <a:r>
+              <a:rPr lang="en-US" sz="1500" dirty="0">
+                <a:solidFill>
+                  <a:srgbClr val="888888"/>
+                </a:solidFill>
+              </a:rPr>
+              <a:t>- sum-over-sum magnitude recovery (does the term carry signal?) + leave-one-out Kendall's τ-b (does removing it reshuffle rankings?).</a:t>
+            </a:r>
+            <a:endParaRPr lang="en-US" sz="1500" dirty="0"/>
           </a:p>
         </p:txBody>
       </p:sp>
@@ -9511,7 +9692,7 @@
                   <a:srgbClr val="000000"/>
                 </a:solidFill>
               </a:rPr>
-              <a:t>User study: does feedback change behaviour?</a:t>
+              <a:t>Score is locally robust</a:t>
             </a:r>
             <a:endParaRPr lang="en-US" sz="2800" dirty="0"/>
           </a:p>
@@ -9546,14 +9727,78 @@
               <a:buChar char="•"/>
             </a:pPr>
             <a:r>
-              <a:rPr lang="en-US" sz="1600" dirty="0">
+              <a:rPr lang="en-US" sz="1500" b="1" dirty="0">
                 <a:solidFill>
                   <a:srgbClr val="000000"/>
                 </a:solidFill>
               </a:rPr>
-              <a:t>With-feedback group: 2.7 divergence points per session.</a:t>
-            </a:r>
-            <a:endParaRPr lang="en-US" sz="1600" dirty="0"/>
+              <a:t>How stable is the score?</a:t>
+            </a:r>
+            <a:endParaRPr lang="en-US" sz="1500" dirty="0"/>
+          </a:p>
+          <a:p>
+            <a:pPr lvl="1" marL="762000" indent="-381000">
+              <a:spcAft>
+                <a:spcPts val="600"/>
+              </a:spcAft>
+              <a:buSzPct val="100000"/>
+              <a:buChar char="•"/>
+            </a:pPr>
+            <a:r>
+              <a:rPr lang="en-US" sz="1500" dirty="0">
+                <a:solidFill>
+                  <a:srgbClr val="000000"/>
+                </a:solidFill>
+              </a:rPr>
+              <a:t>Single-knob: 96.5% top-1 preserved </a:t>
+            </a:r>
+            <a:pPr indent="0" marL="0">
+              <a:spcAft>
+                <a:spcPts val="600"/>
+              </a:spcAft>
+              <a:buNone/>
+            </a:pPr>
+            <a:r>
+              <a:rPr lang="en-US" sz="1500" dirty="0">
+                <a:solidFill>
+                  <a:srgbClr val="888888"/>
+                </a:solidFill>
+              </a:rPr>
+              <a:t>- top-ranked DP rarely changes under any one-weight perturbation. Only 1.8% of cases are clamp-frozen, so this is genuine response - not a clamp artefact.</a:t>
+            </a:r>
+            <a:endParaRPr lang="en-US" sz="1500" dirty="0"/>
+          </a:p>
+          <a:p>
+            <a:pPr lvl="1" marL="762000" indent="-381000">
+              <a:spcAft>
+                <a:spcPts val="1800"/>
+              </a:spcAft>
+              <a:buSzPct val="100000"/>
+              <a:buChar char="•"/>
+            </a:pPr>
+            <a:r>
+              <a:rPr lang="en-US" sz="1500" dirty="0">
+                <a:solidFill>
+                  <a:srgbClr val="000000"/>
+                </a:solidFill>
+              </a:rPr>
+              <a:t>Multi-knob: 84.6% top-1 preserved (τ-b = 0.586) </a:t>
+            </a:r>
+            <a:pPr indent="0" marL="0">
+              <a:spcAft>
+                <a:spcPts val="1800"/>
+              </a:spcAft>
+              <a:buNone/>
+            </a:pPr>
+            <a:r>
+              <a:rPr lang="en-US" sz="1500" dirty="0">
+                <a:solidFill>
+                  <a:srgbClr val="888888"/>
+                </a:solidFill>
+              </a:rPr>
+              <a:t>- when all weights move at once, top-1 holds in ~85% of cases and ~79% of pairs still rank in the same order. Meaningful correlation, not full preservation.</a:t>
+            </a:r>
+            <a:endParaRPr lang="en-US" sz="1500" dirty="0"/>
           </a:p>
           <a:p>
             <a:pPr marL="342900" indent="-342900">
@@ -9564,17 +9809,17 @@
               <a:buChar char="•"/>
             </a:pPr>
             <a:r>
-              <a:rPr lang="en-US" sz="1600" dirty="0">
+              <a:rPr lang="en-US" sz="1500" b="1" dirty="0">
                 <a:solidFill>
                   <a:srgbClr val="000000"/>
                 </a:solidFill>
               </a:rPr>
-              <a:t>No-feedback baseline: 6.0 divergence points per session -2.2× difference.</a:t>
-            </a:r>
-            <a:endParaRPr lang="en-US" sz="1600" dirty="0"/>
-          </a:p>
-          <a:p>
-            <a:pPr marL="342900" indent="-342900">
+              <a:t>Does every component of the process score hold weight?</a:t>
+            </a:r>
+            <a:endParaRPr lang="en-US" sz="1500" dirty="0"/>
+          </a:p>
+          <a:p>
+            <a:pPr lvl="1" marL="762000" indent="-381000">
               <a:spcAft>
                 <a:spcPts val="600"/>
               </a:spcAft>
@@ -9582,17 +9827,31 @@
               <a:buChar char="•"/>
             </a:pPr>
             <a:r>
-              <a:rPr lang="en-US" sz="1600" dirty="0">
+              <a:rPr lang="en-US" sz="1500" dirty="0">
                 <a:solidFill>
                   <a:srgbClr val="000000"/>
                 </a:solidFill>
               </a:rPr>
-              <a:t>Gain-stripped process-score slope across the 6-session arc -+4.47 per session with feedback, −0.40 per session without.</a:t>
-            </a:r>
-            <a:endParaRPr lang="en-US" sz="1600" dirty="0"/>
-          </a:p>
-          <a:p>
-            <a:pPr marL="342900" indent="-342900">
+              <a:t>Length is the rank-carrier (LOO τ-b = 0.527) </a:t>
+            </a:r>
+            <a:pPr indent="0" marL="0">
+              <a:spcAft>
+                <a:spcPts val="600"/>
+              </a:spcAft>
+              <a:buNone/>
+            </a:pPr>
+            <a:r>
+              <a:rPr lang="en-US" sz="1500" dirty="0">
+                <a:solidFill>
+                  <a:srgbClr val="888888"/>
+                </a:solidFill>
+              </a:rPr>
+              <a:t>- removing length reshuffles the per-session ranking more than removing any other process term - the most influential term.</a:t>
+            </a:r>
+            <a:endParaRPr lang="en-US" sz="1500" dirty="0"/>
+          </a:p>
+          <a:p>
+            <a:pPr lvl="1" marL="762000" indent="-381000">
               <a:spcAft>
                 <a:spcPts val="600"/>
               </a:spcAft>
@@ -9600,14 +9859,28 @@
               <a:buChar char="•"/>
             </a:pPr>
             <a:r>
-              <a:rPr lang="en-US" sz="1600" dirty="0">
+              <a:rPr lang="en-US" sz="1500" dirty="0">
                 <a:solidFill>
                   <a:srgbClr val="000000"/>
                 </a:solidFill>
               </a:rPr>
-              <a:t>Caveat: n=3 vs n=2 is directional evidence, not a hypothesis test.</a:t>
-            </a:r>
-            <a:endParaRPr lang="en-US" sz="1600" dirty="0"/>
+              <a:t>Cleanliness sub-weights: ≤ 0.9% top-1 disruption </a:t>
+            </a:r>
+            <a:pPr indent="0" marL="0">
+              <a:spcAft>
+                <a:spcPts val="600"/>
+              </a:spcAft>
+              <a:buNone/>
+            </a:pPr>
+            <a:r>
+              <a:rPr lang="en-US" sz="1500" dirty="0">
+                <a:solidFill>
+                  <a:srgbClr val="888888"/>
+                </a:solidFill>
+              </a:rPr>
+              <a:t>- perturbing any single one of the 6 cleanliness signals barely shifts the ranking (~10× less than process weights), so equal-weights for the sub-signals is defensible.</a:t>
+            </a:r>
+            <a:endParaRPr lang="en-US" sz="1500" dirty="0"/>
           </a:p>
         </p:txBody>
       </p:sp>
@@ -9622,6 +9895,161 @@
 <file path=ppt/slides/slide21.xml><?xml version="1.0" encoding="utf-8"?>
 <p:sld xmlns:a="http://schemas.openxmlformats.org/drawingml/2006/main" xmlns:r="http://schemas.openxmlformats.org/officeDocument/2006/relationships" xmlns:p="http://schemas.openxmlformats.org/presentationml/2006/main">
   <p:cSld name="Slide 21">
+    <p:spTree>
+      <p:nvGrpSpPr>
+        <p:cNvPr id="1" name=""/>
+        <p:cNvGrpSpPr/>
+        <p:nvPr/>
+      </p:nvGrpSpPr>
+      <p:grpSpPr>
+        <a:xfrm>
+          <a:off x="0" y="0"/>
+          <a:ext cx="0" cy="0"/>
+          <a:chOff x="0" y="0"/>
+          <a:chExt cx="0" cy="0"/>
+        </a:xfrm>
+      </p:grpSpPr>
+      <p:sp>
+        <p:nvSpPr>
+          <p:cNvPr id="2" name="Text 0"/>
+          <p:cNvSpPr/>
+          <p:nvPr/>
+        </p:nvSpPr>
+        <p:spPr>
+          <a:xfrm>
+            <a:off x="457200" y="274320"/>
+            <a:ext cx="8229600" cy="640080"/>
+          </a:xfrm>
+          <a:prstGeom prst="rect">
+            <a:avLst/>
+          </a:prstGeom>
+          <a:noFill/>
+          <a:ln/>
+        </p:spPr>
+        <p:txBody>
+          <a:bodyPr wrap="square" lIns="0" tIns="0" rIns="0" bIns="0" rtlCol="0" anchor="ctr"/>
+          <a:lstStyle/>
+          <a:p>
+            <a:pPr indent="0" marL="0">
+              <a:buNone/>
+            </a:pPr>
+            <a:r>
+              <a:rPr lang="en-US" sz="2800" b="1" dirty="0">
+                <a:solidFill>
+                  <a:srgbClr val="000000"/>
+                </a:solidFill>
+              </a:rPr>
+              <a:t>User study: does feedback change behaviour?</a:t>
+            </a:r>
+            <a:endParaRPr lang="en-US" sz="2800" dirty="0"/>
+          </a:p>
+        </p:txBody>
+      </p:sp>
+      <p:sp>
+        <p:nvSpPr>
+          <p:cNvPr id="3" name="Text 1"/>
+          <p:cNvSpPr/>
+          <p:nvPr/>
+        </p:nvSpPr>
+        <p:spPr>
+          <a:xfrm>
+            <a:off x="457200" y="1188720"/>
+            <a:ext cx="8229600" cy="3657600"/>
+          </a:xfrm>
+          <a:prstGeom prst="rect">
+            <a:avLst/>
+          </a:prstGeom>
+          <a:noFill/>
+          <a:ln/>
+        </p:spPr>
+        <p:txBody>
+          <a:bodyPr wrap="square" rtlCol="0" anchor="t"/>
+          <a:lstStyle/>
+          <a:p>
+            <a:pPr marL="342900" indent="-342900">
+              <a:spcAft>
+                <a:spcPts val="600"/>
+              </a:spcAft>
+              <a:buSzPct val="100000"/>
+              <a:buChar char="•"/>
+            </a:pPr>
+            <a:r>
+              <a:rPr lang="en-US" sz="1600" dirty="0">
+                <a:solidFill>
+                  <a:srgbClr val="000000"/>
+                </a:solidFill>
+              </a:rPr>
+              <a:t>With-feedback group: 2.7 divergence points per session.</a:t>
+            </a:r>
+            <a:endParaRPr lang="en-US" sz="1600" dirty="0"/>
+          </a:p>
+          <a:p>
+            <a:pPr marL="342900" indent="-342900">
+              <a:spcAft>
+                <a:spcPts val="600"/>
+              </a:spcAft>
+              <a:buSzPct val="100000"/>
+              <a:buChar char="•"/>
+            </a:pPr>
+            <a:r>
+              <a:rPr lang="en-US" sz="1600" dirty="0">
+                <a:solidFill>
+                  <a:srgbClr val="000000"/>
+                </a:solidFill>
+              </a:rPr>
+              <a:t>No-feedback baseline: 6.0 divergence points per session -2.2× difference.</a:t>
+            </a:r>
+            <a:endParaRPr lang="en-US" sz="1600" dirty="0"/>
+          </a:p>
+          <a:p>
+            <a:pPr marL="342900" indent="-342900">
+              <a:spcAft>
+                <a:spcPts val="600"/>
+              </a:spcAft>
+              <a:buSzPct val="100000"/>
+              <a:buChar char="•"/>
+            </a:pPr>
+            <a:r>
+              <a:rPr lang="en-US" sz="1600" dirty="0">
+                <a:solidFill>
+                  <a:srgbClr val="000000"/>
+                </a:solidFill>
+              </a:rPr>
+              <a:t>Gain-stripped process-score slope across the 6-session arc -+4.47 per session with feedback, −0.40 per session without.</a:t>
+            </a:r>
+            <a:endParaRPr lang="en-US" sz="1600" dirty="0"/>
+          </a:p>
+          <a:p>
+            <a:pPr marL="342900" indent="-342900">
+              <a:spcAft>
+                <a:spcPts val="600"/>
+              </a:spcAft>
+              <a:buSzPct val="100000"/>
+              <a:buChar char="•"/>
+            </a:pPr>
+            <a:r>
+              <a:rPr lang="en-US" sz="1600" dirty="0">
+                <a:solidFill>
+                  <a:srgbClr val="000000"/>
+                </a:solidFill>
+              </a:rPr>
+              <a:t>Caveat: n=3 vs n=2 is directional evidence, not a hypothesis test.</a:t>
+            </a:r>
+            <a:endParaRPr lang="en-US" sz="1600" dirty="0"/>
+          </a:p>
+        </p:txBody>
+      </p:sp>
+    </p:spTree>
+  </p:cSld>
+  <p:clrMapOvr>
+    <a:masterClrMapping/>
+  </p:clrMapOvr>
+</p:sld>
+</file>
+
+<file path=ppt/slides/slide22.xml><?xml version="1.0" encoding="utf-8"?>
+<p:sld xmlns:a="http://schemas.openxmlformats.org/drawingml/2006/main" xmlns:r="http://schemas.openxmlformats.org/officeDocument/2006/relationships" xmlns:p="http://schemas.openxmlformats.org/presentationml/2006/main">
+  <p:cSld name="Slide 22">
     <p:spTree>
       <p:nvGrpSpPr>
         <p:cNvPr id="1" name=""/>

</xml_diff>

<commit_message>
feat: add user study + agent slides
</commit_message>
<xml_diff>
--- a/presentation/slides.pptx
+++ b/presentation/slides.pptx
@@ -27,9 +27,12 @@
     <p:sldId id="275" r:id="rId21"/>
     <p:sldId id="276" r:id="rId22"/>
     <p:sldId id="277" r:id="rId23"/>
+    <p:sldId id="278" r:id="rId24"/>
+    <p:sldId id="279" r:id="rId25"/>
+    <p:sldId id="280" r:id="rId26"/>
   </p:sldIdLst>
   <p:notesMasterIdLst>
-    <p:notesMasterId r:id="rId24"/>
+    <p:notesMasterId r:id="rId27"/>
   </p:notesMasterIdLst>
   <p:sldSz cx="9144000" cy="5143500"/>
   <p:notesSz cx="5143500" cy="9144000"/>
@@ -126,6 +129,1814 @@
     </a:lvl9pPr>
   </p:defaultTextStyle>
 </p:presentation>
+</file>
+
+<file path=ppt/charts/chart1.xml><?xml version="1.0" encoding="utf-8"?>
+<c:chartSpace xmlns:c="http://schemas.openxmlformats.org/drawingml/2006/chart" xmlns:a="http://schemas.openxmlformats.org/drawingml/2006/main" xmlns:r="http://schemas.openxmlformats.org/officeDocument/2006/relationships">
+  <c:date1904 val="0"/>
+  <c:roundedCorners val="1"/>
+  <c:chart>
+    <c:title>
+      <c:tx>
+        <c:rich>
+          <a:bodyPr/>
+          <a:lstStyle/>
+          <a:p>
+            <a:pPr>
+              <a:defRPr sz="1100" b="0" i="0" u="none" strike="noStrike">
+                <a:solidFill>
+                  <a:srgbClr val="333333"/>
+                </a:solidFill>
+                <a:latin typeface="Arial"/>
+              </a:defRPr>
+            </a:pPr>
+            <a:r>
+              <a:rPr sz="1100" b="0" i="0" u="none" strike="noStrike">
+                <a:solidFill>
+                  <a:srgbClr val="333333"/>
+                </a:solidFill>
+                <a:latin typeface="Arial"/>
+              </a:rPr>
+              <a:t>Divergence points per session (per participant)</a:t>
+            </a:r>
+          </a:p>
+        </c:rich>
+      </c:tx>
+      <c:layout/>
+      <c:overlay val="0"/>
+    </c:title>
+    <c:autoTitleDeleted val="0"/>
+    <c:plotArea>
+      <c:layout/>
+      <c:lineChart>
+        <c:varyColors val="0"/>
+        <c:ser>
+          <c:idx val="0"/>
+          <c:order val="0"/>
+          <c:tx>
+            <c:strRef>
+              <c:f>Sheet1!$B$1</c:f>
+              <c:strCache>
+                <c:ptCount val="1"/>
+                <c:pt idx="0">
+                  <c:v>Feedback (per participant)</c:v>
+                </c:pt>
+              </c:strCache>
+            </c:strRef>
+          </c:tx>
+          <c:spPr>
+            <a:solidFill>
+              <a:srgbClr val="1F3F6F"/>
+            </a:solidFill>
+            <a:ln w="31750" cap="flat">
+              <a:solidFill>
+                <a:srgbClr val="1F3F6F"/>
+              </a:solidFill>
+              <a:prstDash val="solid"/>
+              <a:round/>
+            </a:ln>
+            <a:effectLst/>
+          </c:spPr>
+          <c:invertIfNegative val="0"/>
+          <c:dLbls>
+            <c:numFmt formatCode="#,##0" sourceLinked="0"/>
+            <c:txPr>
+              <a:bodyPr/>
+              <a:lstStyle/>
+              <a:p>
+                <a:pPr>
+                  <a:defRPr b="0" i="0" strike="noStrike" sz="1200" u="none">
+                    <a:solidFill>
+                      <a:srgbClr val="000000"/>
+                    </a:solidFill>
+                    <a:latin typeface="Arial"/>
+                  </a:defRPr>
+                </a:pPr>
+              </a:p>
+            </c:txPr>
+            <c:showLegendKey val="0"/>
+            <c:showVal val="0"/>
+            <c:showCatName val="0"/>
+            <c:showSerName val="0"/>
+            <c:showPercent val="0"/>
+            <c:showBubbleSize val="0"/>
+            <c:showLeaderLines val="0"/>
+          </c:dLbls>
+          <c:marker>
+            <c:symbol val="circle"/>
+            <c:size val="6"/>
+            <c:spPr>
+              <a:solidFill>
+                <a:srgbClr val="1F3F6F"/>
+              </a:solidFill>
+              <a:ln w="9525" cap="flat">
+                <a:solidFill>
+                  <a:srgbClr val="1F3F6F"/>
+                </a:solidFill>
+                <a:prstDash val="solid"/>
+                <a:round/>
+              </a:ln>
+              <a:effectLst/>
+            </c:spPr>
+          </c:marker>
+          <c:cat>
+            <c:multiLvlStrRef>
+              <c:f>Sheet1!$A$2:$A$7</c:f>
+              <c:multiLvlStrCache>
+                <c:ptCount val="6"/>
+                <c:lvl>
+                  <c:pt idx="0">
+                    <c:v>S1</c:v>
+                  </c:pt>
+                  <c:pt idx="1">
+                    <c:v>S2</c:v>
+                  </c:pt>
+                  <c:pt idx="2">
+                    <c:v>S3</c:v>
+                  </c:pt>
+                  <c:pt idx="3">
+                    <c:v>S4</c:v>
+                  </c:pt>
+                  <c:pt idx="4">
+                    <c:v>S5</c:v>
+                  </c:pt>
+                  <c:pt idx="5">
+                    <c:v>S6</c:v>
+                  </c:pt>
+                </c:lvl>
+              </c:multiLvlStrCache>
+            </c:multiLvlStrRef>
+          </c:cat>
+          <c:val>
+            <c:numRef>
+              <c:f>Sheet1!$B$2:$B$7</c:f>
+              <c:numCache>
+                <c:formatCode>General</c:formatCode>
+                <c:ptCount val="6"/>
+                <c:pt idx="0">
+                  <c:v>4</c:v>
+                </c:pt>
+                <c:pt idx="1">
+                  <c:v>5.67</c:v>
+                </c:pt>
+                <c:pt idx="2">
+                  <c:v>3.67</c:v>
+                </c:pt>
+                <c:pt idx="3">
+                  <c:v>0</c:v>
+                </c:pt>
+                <c:pt idx="4">
+                  <c:v>2.33</c:v>
+                </c:pt>
+                <c:pt idx="5">
+                  <c:v>0.67</c:v>
+                </c:pt>
+              </c:numCache>
+            </c:numRef>
+          </c:val>
+          <c:smooth val="0"/>
+        </c:ser>
+        <c:ser>
+          <c:idx val="1"/>
+          <c:order val="1"/>
+          <c:tx>
+            <c:strRef>
+              <c:f>Sheet1!$C$1</c:f>
+              <c:strCache>
+                <c:ptCount val="1"/>
+                <c:pt idx="0">
+                  <c:v>Baseline (per participant)</c:v>
+                </c:pt>
+              </c:strCache>
+            </c:strRef>
+          </c:tx>
+          <c:spPr>
+            <a:solidFill>
+              <a:srgbClr val="B25500"/>
+            </a:solidFill>
+            <a:ln w="31750" cap="flat">
+              <a:solidFill>
+                <a:srgbClr val="B25500"/>
+              </a:solidFill>
+              <a:prstDash val="solid"/>
+              <a:round/>
+            </a:ln>
+            <a:effectLst/>
+          </c:spPr>
+          <c:invertIfNegative val="0"/>
+          <c:dLbls>
+            <c:numFmt formatCode="#,##0" sourceLinked="0"/>
+            <c:txPr>
+              <a:bodyPr/>
+              <a:lstStyle/>
+              <a:p>
+                <a:pPr>
+                  <a:defRPr b="0" i="0" strike="noStrike" sz="1200" u="none">
+                    <a:solidFill>
+                      <a:srgbClr val="000000"/>
+                    </a:solidFill>
+                    <a:latin typeface="Arial"/>
+                  </a:defRPr>
+                </a:pPr>
+              </a:p>
+            </c:txPr>
+            <c:showLegendKey val="0"/>
+            <c:showVal val="0"/>
+            <c:showCatName val="0"/>
+            <c:showSerName val="0"/>
+            <c:showPercent val="0"/>
+            <c:showBubbleSize val="0"/>
+            <c:showLeaderLines val="0"/>
+          </c:dLbls>
+          <c:marker>
+            <c:symbol val="circle"/>
+            <c:size val="6"/>
+            <c:spPr>
+              <a:solidFill>
+                <a:srgbClr val="B25500"/>
+              </a:solidFill>
+              <a:ln w="9525" cap="flat">
+                <a:solidFill>
+                  <a:srgbClr val="B25500"/>
+                </a:solidFill>
+                <a:prstDash val="solid"/>
+                <a:round/>
+              </a:ln>
+              <a:effectLst/>
+            </c:spPr>
+          </c:marker>
+          <c:cat>
+            <c:multiLvlStrRef>
+              <c:f>Sheet1!$A$2:$A$7</c:f>
+              <c:multiLvlStrCache>
+                <c:ptCount val="6"/>
+                <c:lvl>
+                  <c:pt idx="0">
+                    <c:v>S1</c:v>
+                  </c:pt>
+                  <c:pt idx="1">
+                    <c:v>S2</c:v>
+                  </c:pt>
+                  <c:pt idx="2">
+                    <c:v>S3</c:v>
+                  </c:pt>
+                  <c:pt idx="3">
+                    <c:v>S4</c:v>
+                  </c:pt>
+                  <c:pt idx="4">
+                    <c:v>S5</c:v>
+                  </c:pt>
+                  <c:pt idx="5">
+                    <c:v>S6</c:v>
+                  </c:pt>
+                </c:lvl>
+              </c:multiLvlStrCache>
+            </c:multiLvlStrRef>
+          </c:cat>
+          <c:val>
+            <c:numRef>
+              <c:f>Sheet1!$C$2:$C$7</c:f>
+              <c:numCache>
+                <c:formatCode>General</c:formatCode>
+                <c:ptCount val="6"/>
+                <c:pt idx="0">
+                  <c:v>5</c:v>
+                </c:pt>
+                <c:pt idx="1">
+                  <c:v>7.5</c:v>
+                </c:pt>
+                <c:pt idx="2">
+                  <c:v>9.5</c:v>
+                </c:pt>
+                <c:pt idx="3">
+                  <c:v>0</c:v>
+                </c:pt>
+                <c:pt idx="4">
+                  <c:v>6.5</c:v>
+                </c:pt>
+                <c:pt idx="5">
+                  <c:v>7.5</c:v>
+                </c:pt>
+              </c:numCache>
+            </c:numRef>
+          </c:val>
+          <c:smooth val="0"/>
+        </c:ser>
+        <c:dLbls>
+          <c:numFmt formatCode="#,##0" sourceLinked="0"/>
+          <c:txPr>
+            <a:bodyPr/>
+            <a:lstStyle/>
+            <a:p>
+              <a:pPr>
+                <a:defRPr b="0" i="0" strike="noStrike" sz="1200" u="none">
+                  <a:solidFill>
+                    <a:srgbClr val="000000"/>
+                  </a:solidFill>
+                  <a:latin typeface="Arial"/>
+                </a:defRPr>
+              </a:pPr>
+            </a:p>
+          </c:txPr>
+          <c:showLegendKey val="0"/>
+          <c:showVal val="0"/>
+          <c:showCatName val="0"/>
+          <c:showSerName val="0"/>
+          <c:showPercent val="0"/>
+          <c:showBubbleSize val="0"/>
+          <c:showLeaderLines val="0"/>
+        </c:dLbls>
+        <c:marker val="1"/>
+        <c:axId val="2094734554"/>
+        <c:axId val="2094734552"/>
+        <c:axId val="2094734556"/>
+      </c:lineChart>
+      <c:catAx>
+        <c:axId val="2094734554"/>
+        <c:scaling>
+          <c:orientation val="minMax"/>
+        </c:scaling>
+        <c:delete val="0"/>
+        <c:axPos val="b"/>
+        <c:numFmt formatCode="General" sourceLinked="1"/>
+        <c:majorTickMark val="out"/>
+        <c:minorTickMark val="none"/>
+        <c:tickLblPos val="low"/>
+        <c:spPr>
+          <a:ln w="12700" cap="flat">
+            <a:solidFill>
+              <a:srgbClr val="888888"/>
+            </a:solidFill>
+            <a:prstDash val="solid"/>
+            <a:round/>
+          </a:ln>
+        </c:spPr>
+        <c:txPr>
+          <a:bodyPr/>
+          <a:lstStyle/>
+          <a:p>
+            <a:pPr>
+              <a:defRPr sz="900" b="0" i="0" u="none" strike="noStrike">
+                <a:solidFill>
+                  <a:srgbClr val="000000"/>
+                </a:solidFill>
+                <a:latin typeface="Arial"/>
+              </a:defRPr>
+            </a:pPr>
+            <a:endParaRPr lang="en-US"/>
+          </a:p>
+        </c:txPr>
+        <c:crossAx val="2094734552"/>
+        <c:crosses val="autoZero"/>
+        <c:auto val="1"/>
+        <c:lblAlgn val="ctr"/>
+        <c:noMultiLvlLbl val="1"/>
+      </c:catAx>
+      <c:valAx>
+        <c:axId val="2094734552"/>
+        <c:scaling>
+          <c:orientation val="minMax"/>
+          <c:max val="10"/>
+          <c:min val="0"/>
+        </c:scaling>
+        <c:delete val="0"/>
+        <c:axPos val="l"/>
+        <c:majorGridlines>
+          <c:spPr>
+            <a:ln w="12700" cap="flat">
+              <a:solidFill>
+                <a:srgbClr val="888888"/>
+              </a:solidFill>
+              <a:prstDash val="solid"/>
+              <a:round/>
+            </a:ln>
+          </c:spPr>
+        </c:majorGridlines>
+        <c:numFmt formatCode="General" sourceLinked="0"/>
+        <c:majorTickMark val="out"/>
+        <c:minorTickMark val="none"/>
+        <c:tickLblPos val="nextTo"/>
+        <c:spPr>
+          <a:ln w="12700" cap="flat">
+            <a:solidFill>
+              <a:srgbClr val="888888"/>
+            </a:solidFill>
+            <a:prstDash val="solid"/>
+            <a:round/>
+          </a:ln>
+        </c:spPr>
+        <c:txPr>
+          <a:bodyPr/>
+          <a:lstStyle/>
+          <a:p>
+            <a:pPr>
+              <a:defRPr sz="900" b="0" i="0" u="none" strike="noStrike">
+                <a:solidFill>
+                  <a:srgbClr val="000000"/>
+                </a:solidFill>
+                <a:latin typeface="Arial"/>
+              </a:defRPr>
+            </a:pPr>
+            <a:endParaRPr lang="en-US"/>
+          </a:p>
+        </c:txPr>
+        <c:crossAx val="2094734554"/>
+        <c:crosses val="autoZero"/>
+        <c:crossBetween val="between"/>
+        <c:majorUnit val="2"/>
+      </c:valAx>
+      <c:spPr>
+        <a:noFill/>
+        <a:ln>
+          <a:noFill/>
+        </a:ln>
+        <a:effectLst/>
+      </c:spPr>
+    </c:plotArea>
+    <c:legend>
+      <c:legendPos val="b"/>
+      <c:overlay val="0"/>
+      <c:txPr>
+        <a:bodyPr/>
+        <a:lstStyle/>
+        <a:p>
+          <a:pPr>
+            <a:defRPr sz="900">      </a:defRPr>
+          </a:pPr>
+          <a:endParaRPr lang="en-US"/>
+        </a:p>
+      </c:txPr>
+    </c:legend>
+    <c:plotVisOnly val="1"/>
+    <c:dispBlanksAs val="span"/>
+  </c:chart>
+  <c:spPr>
+    <a:noFill/>
+    <a:ln>
+      <a:noFill/>
+    </a:ln>
+    <a:effectLst/>
+  </c:spPr>
+  <c:externalData r:id="rId1">
+    <c:autoUpdate val="0"/>
+  </c:externalData>
+</c:chartSpace>
+</file>
+
+<file path=ppt/charts/chart2.xml><?xml version="1.0" encoding="utf-8"?>
+<c:chartSpace xmlns:c="http://schemas.openxmlformats.org/drawingml/2006/chart" xmlns:a="http://schemas.openxmlformats.org/drawingml/2006/main" xmlns:r="http://schemas.openxmlformats.org/officeDocument/2006/relationships">
+  <c:date1904 val="0"/>
+  <c:roundedCorners val="1"/>
+  <c:chart>
+    <c:title>
+      <c:tx>
+        <c:rich>
+          <a:bodyPr/>
+          <a:lstStyle/>
+          <a:p>
+            <a:pPr>
+              <a:defRPr sz="1100" b="0" i="0" u="none" strike="noStrike">
+                <a:solidFill>
+                  <a:srgbClr val="333333"/>
+                </a:solidFill>
+                <a:latin typeface="Arial"/>
+              </a:defRPr>
+            </a:pPr>
+            <a:r>
+              <a:rPr sz="1100" b="0" i="0" u="none" strike="noStrike">
+                <a:solidFill>
+                  <a:srgbClr val="333333"/>
+                </a:solidFill>
+                <a:latin typeface="Arial"/>
+              </a:rPr>
+              <a:t>Production-weighted process score (with cleanliness gain)</a:t>
+            </a:r>
+          </a:p>
+        </c:rich>
+      </c:tx>
+      <c:layout/>
+      <c:overlay val="0"/>
+    </c:title>
+    <c:autoTitleDeleted val="0"/>
+    <c:plotArea>
+      <c:layout/>
+      <c:lineChart>
+        <c:varyColors val="0"/>
+        <c:ser>
+          <c:idx val="0"/>
+          <c:order val="0"/>
+          <c:tx>
+            <c:strRef>
+              <c:f>Sheet1!$B$1</c:f>
+              <c:strCache>
+                <c:ptCount val="1"/>
+                <c:pt idx="0">
+                  <c:v>Feedback mean</c:v>
+                </c:pt>
+              </c:strCache>
+            </c:strRef>
+          </c:tx>
+          <c:spPr>
+            <a:solidFill>
+              <a:srgbClr val="1F3F6F"/>
+            </a:solidFill>
+            <a:ln w="31750" cap="flat">
+              <a:solidFill>
+                <a:srgbClr val="1F3F6F"/>
+              </a:solidFill>
+              <a:prstDash val="solid"/>
+              <a:round/>
+            </a:ln>
+            <a:effectLst/>
+          </c:spPr>
+          <c:invertIfNegative val="0"/>
+          <c:dLbls>
+            <c:numFmt formatCode="#,##0" sourceLinked="0"/>
+            <c:txPr>
+              <a:bodyPr/>
+              <a:lstStyle/>
+              <a:p>
+                <a:pPr>
+                  <a:defRPr b="0" i="0" strike="noStrike" sz="1200" u="none">
+                    <a:solidFill>
+                      <a:srgbClr val="000000"/>
+                    </a:solidFill>
+                    <a:latin typeface="Arial"/>
+                  </a:defRPr>
+                </a:pPr>
+              </a:p>
+            </c:txPr>
+            <c:showLegendKey val="0"/>
+            <c:showVal val="0"/>
+            <c:showCatName val="0"/>
+            <c:showSerName val="0"/>
+            <c:showPercent val="0"/>
+            <c:showBubbleSize val="0"/>
+            <c:showLeaderLines val="0"/>
+          </c:dLbls>
+          <c:marker>
+            <c:symbol val="circle"/>
+            <c:size val="6"/>
+            <c:spPr>
+              <a:solidFill>
+                <a:srgbClr val="1F3F6F"/>
+              </a:solidFill>
+              <a:ln w="9525" cap="flat">
+                <a:solidFill>
+                  <a:srgbClr val="1F3F6F"/>
+                </a:solidFill>
+                <a:prstDash val="solid"/>
+                <a:round/>
+              </a:ln>
+              <a:effectLst/>
+            </c:spPr>
+          </c:marker>
+          <c:cat>
+            <c:multiLvlStrRef>
+              <c:f>Sheet1!$A$2:$A$7</c:f>
+              <c:multiLvlStrCache>
+                <c:ptCount val="6"/>
+                <c:lvl>
+                  <c:pt idx="0">
+                    <c:v>S1</c:v>
+                  </c:pt>
+                  <c:pt idx="1">
+                    <c:v>S2</c:v>
+                  </c:pt>
+                  <c:pt idx="2">
+                    <c:v>S3</c:v>
+                  </c:pt>
+                  <c:pt idx="3">
+                    <c:v>S4</c:v>
+                  </c:pt>
+                  <c:pt idx="4">
+                    <c:v>S5</c:v>
+                  </c:pt>
+                  <c:pt idx="5">
+                    <c:v>S6</c:v>
+                  </c:pt>
+                </c:lvl>
+              </c:multiLvlStrCache>
+            </c:multiLvlStrRef>
+          </c:cat>
+          <c:val>
+            <c:numRef>
+              <c:f>Sheet1!$B$2:$B$7</c:f>
+              <c:numCache>
+                <c:formatCode>General</c:formatCode>
+                <c:ptCount val="6"/>
+                <c:pt idx="0">
+                  <c:v>13.7</c:v>
+                </c:pt>
+                <c:pt idx="1">
+                  <c:v>66.7</c:v>
+                </c:pt>
+                <c:pt idx="2">
+                  <c:v>33</c:v>
+                </c:pt>
+                <c:pt idx="3">
+                  <c:v>89.7</c:v>
+                </c:pt>
+                <c:pt idx="4">
+                  <c:v>32</c:v>
+                </c:pt>
+                <c:pt idx="5">
+                  <c:v>48.3</c:v>
+                </c:pt>
+              </c:numCache>
+            </c:numRef>
+          </c:val>
+          <c:smooth val="0"/>
+        </c:ser>
+        <c:ser>
+          <c:idx val="1"/>
+          <c:order val="1"/>
+          <c:tx>
+            <c:strRef>
+              <c:f>Sheet1!$C$1</c:f>
+              <c:strCache>
+                <c:ptCount val="1"/>
+                <c:pt idx="0">
+                  <c:v>Baseline mean</c:v>
+                </c:pt>
+              </c:strCache>
+            </c:strRef>
+          </c:tx>
+          <c:spPr>
+            <a:solidFill>
+              <a:srgbClr val="B25500"/>
+            </a:solidFill>
+            <a:ln w="31750" cap="flat">
+              <a:solidFill>
+                <a:srgbClr val="B25500"/>
+              </a:solidFill>
+              <a:prstDash val="solid"/>
+              <a:round/>
+            </a:ln>
+            <a:effectLst/>
+          </c:spPr>
+          <c:invertIfNegative val="0"/>
+          <c:dLbls>
+            <c:numFmt formatCode="#,##0" sourceLinked="0"/>
+            <c:txPr>
+              <a:bodyPr/>
+              <a:lstStyle/>
+              <a:p>
+                <a:pPr>
+                  <a:defRPr b="0" i="0" strike="noStrike" sz="1200" u="none">
+                    <a:solidFill>
+                      <a:srgbClr val="000000"/>
+                    </a:solidFill>
+                    <a:latin typeface="Arial"/>
+                  </a:defRPr>
+                </a:pPr>
+              </a:p>
+            </c:txPr>
+            <c:showLegendKey val="0"/>
+            <c:showVal val="0"/>
+            <c:showCatName val="0"/>
+            <c:showSerName val="0"/>
+            <c:showPercent val="0"/>
+            <c:showBubbleSize val="0"/>
+            <c:showLeaderLines val="0"/>
+          </c:dLbls>
+          <c:marker>
+            <c:symbol val="circle"/>
+            <c:size val="6"/>
+            <c:spPr>
+              <a:solidFill>
+                <a:srgbClr val="B25500"/>
+              </a:solidFill>
+              <a:ln w="9525" cap="flat">
+                <a:solidFill>
+                  <a:srgbClr val="B25500"/>
+                </a:solidFill>
+                <a:prstDash val="solid"/>
+                <a:round/>
+              </a:ln>
+              <a:effectLst/>
+            </c:spPr>
+          </c:marker>
+          <c:cat>
+            <c:multiLvlStrRef>
+              <c:f>Sheet1!$A$2:$A$7</c:f>
+              <c:multiLvlStrCache>
+                <c:ptCount val="6"/>
+                <c:lvl>
+                  <c:pt idx="0">
+                    <c:v>S1</c:v>
+                  </c:pt>
+                  <c:pt idx="1">
+                    <c:v>S2</c:v>
+                  </c:pt>
+                  <c:pt idx="2">
+                    <c:v>S3</c:v>
+                  </c:pt>
+                  <c:pt idx="3">
+                    <c:v>S4</c:v>
+                  </c:pt>
+                  <c:pt idx="4">
+                    <c:v>S5</c:v>
+                  </c:pt>
+                  <c:pt idx="5">
+                    <c:v>S6</c:v>
+                  </c:pt>
+                </c:lvl>
+              </c:multiLvlStrCache>
+            </c:multiLvlStrRef>
+          </c:cat>
+          <c:val>
+            <c:numRef>
+              <c:f>Sheet1!$C$2:$C$7</c:f>
+              <c:numCache>
+                <c:formatCode>General</c:formatCode>
+                <c:ptCount val="6"/>
+                <c:pt idx="0">
+                  <c:v>11.5</c:v>
+                </c:pt>
+                <c:pt idx="1">
+                  <c:v>20</c:v>
+                </c:pt>
+                <c:pt idx="2">
+                  <c:v>15.5</c:v>
+                </c:pt>
+                <c:pt idx="3">
+                  <c:v>76.5</c:v>
+                </c:pt>
+                <c:pt idx="4">
+                  <c:v>44.5</c:v>
+                </c:pt>
+                <c:pt idx="5">
+                  <c:v>27</c:v>
+                </c:pt>
+              </c:numCache>
+            </c:numRef>
+          </c:val>
+          <c:smooth val="0"/>
+        </c:ser>
+        <c:dLbls>
+          <c:numFmt formatCode="#,##0" sourceLinked="0"/>
+          <c:txPr>
+            <a:bodyPr/>
+            <a:lstStyle/>
+            <a:p>
+              <a:pPr>
+                <a:defRPr b="0" i="0" strike="noStrike" sz="1200" u="none">
+                  <a:solidFill>
+                    <a:srgbClr val="000000"/>
+                  </a:solidFill>
+                  <a:latin typeface="Arial"/>
+                </a:defRPr>
+              </a:pPr>
+            </a:p>
+          </c:txPr>
+          <c:showLegendKey val="0"/>
+          <c:showVal val="0"/>
+          <c:showCatName val="0"/>
+          <c:showSerName val="0"/>
+          <c:showPercent val="0"/>
+          <c:showBubbleSize val="0"/>
+          <c:showLeaderLines val="0"/>
+        </c:dLbls>
+        <c:marker val="1"/>
+        <c:axId val="2094734554"/>
+        <c:axId val="2094734552"/>
+        <c:axId val="2094734556"/>
+      </c:lineChart>
+      <c:catAx>
+        <c:axId val="2094734554"/>
+        <c:scaling>
+          <c:orientation val="minMax"/>
+        </c:scaling>
+        <c:delete val="0"/>
+        <c:axPos val="b"/>
+        <c:numFmt formatCode="General" sourceLinked="1"/>
+        <c:majorTickMark val="out"/>
+        <c:minorTickMark val="none"/>
+        <c:tickLblPos val="low"/>
+        <c:spPr>
+          <a:ln w="12700" cap="flat">
+            <a:solidFill>
+              <a:srgbClr val="888888"/>
+            </a:solidFill>
+            <a:prstDash val="solid"/>
+            <a:round/>
+          </a:ln>
+        </c:spPr>
+        <c:txPr>
+          <a:bodyPr/>
+          <a:lstStyle/>
+          <a:p>
+            <a:pPr>
+              <a:defRPr sz="900" b="0" i="0" u="none" strike="noStrike">
+                <a:solidFill>
+                  <a:srgbClr val="000000"/>
+                </a:solidFill>
+                <a:latin typeface="Arial"/>
+              </a:defRPr>
+            </a:pPr>
+            <a:endParaRPr lang="en-US"/>
+          </a:p>
+        </c:txPr>
+        <c:crossAx val="2094734552"/>
+        <c:crosses val="autoZero"/>
+        <c:auto val="1"/>
+        <c:lblAlgn val="ctr"/>
+        <c:noMultiLvlLbl val="1"/>
+      </c:catAx>
+      <c:valAx>
+        <c:axId val="2094734552"/>
+        <c:scaling>
+          <c:orientation val="minMax"/>
+          <c:max val="100"/>
+          <c:min val="0"/>
+        </c:scaling>
+        <c:delete val="0"/>
+        <c:axPos val="l"/>
+        <c:majorGridlines>
+          <c:spPr>
+            <a:ln w="12700" cap="flat">
+              <a:solidFill>
+                <a:srgbClr val="888888"/>
+              </a:solidFill>
+              <a:prstDash val="solid"/>
+              <a:round/>
+            </a:ln>
+          </c:spPr>
+        </c:majorGridlines>
+        <c:numFmt formatCode="General" sourceLinked="0"/>
+        <c:majorTickMark val="out"/>
+        <c:minorTickMark val="none"/>
+        <c:tickLblPos val="nextTo"/>
+        <c:spPr>
+          <a:ln w="12700" cap="flat">
+            <a:solidFill>
+              <a:srgbClr val="888888"/>
+            </a:solidFill>
+            <a:prstDash val="solid"/>
+            <a:round/>
+          </a:ln>
+        </c:spPr>
+        <c:txPr>
+          <a:bodyPr/>
+          <a:lstStyle/>
+          <a:p>
+            <a:pPr>
+              <a:defRPr sz="900" b="0" i="0" u="none" strike="noStrike">
+                <a:solidFill>
+                  <a:srgbClr val="000000"/>
+                </a:solidFill>
+                <a:latin typeface="Arial"/>
+              </a:defRPr>
+            </a:pPr>
+            <a:endParaRPr lang="en-US"/>
+          </a:p>
+        </c:txPr>
+        <c:crossAx val="2094734554"/>
+        <c:crosses val="autoZero"/>
+        <c:crossBetween val="between"/>
+        <c:majorUnit val="25"/>
+      </c:valAx>
+      <c:spPr>
+        <a:noFill/>
+        <a:ln>
+          <a:noFill/>
+        </a:ln>
+        <a:effectLst/>
+      </c:spPr>
+    </c:plotArea>
+    <c:legend>
+      <c:legendPos val="b"/>
+      <c:overlay val="0"/>
+      <c:txPr>
+        <a:bodyPr/>
+        <a:lstStyle/>
+        <a:p>
+          <a:pPr>
+            <a:defRPr sz="900">      </a:defRPr>
+          </a:pPr>
+          <a:endParaRPr lang="en-US"/>
+        </a:p>
+      </c:txPr>
+    </c:legend>
+    <c:plotVisOnly val="1"/>
+    <c:dispBlanksAs val="span"/>
+  </c:chart>
+  <c:spPr>
+    <a:noFill/>
+    <a:ln>
+      <a:noFill/>
+    </a:ln>
+    <a:effectLst/>
+  </c:spPr>
+  <c:externalData r:id="rId1">
+    <c:autoUpdate val="0"/>
+  </c:externalData>
+</c:chartSpace>
+</file>
+
+<file path=ppt/charts/chart3.xml><?xml version="1.0" encoding="utf-8"?>
+<c:chartSpace xmlns:c="http://schemas.openxmlformats.org/drawingml/2006/chart" xmlns:a="http://schemas.openxmlformats.org/drawingml/2006/main" xmlns:r="http://schemas.openxmlformats.org/officeDocument/2006/relationships">
+  <c:date1904 val="0"/>
+  <c:roundedCorners val="1"/>
+  <c:chart>
+    <c:title>
+      <c:tx>
+        <c:rich>
+          <a:bodyPr/>
+          <a:lstStyle/>
+          <a:p>
+            <a:pPr>
+              <a:defRPr sz="1200" b="0" i="0" u="none" strike="noStrike">
+                <a:solidFill>
+                  <a:srgbClr val="333333"/>
+                </a:solidFill>
+                <a:latin typeface="Arial"/>
+              </a:defRPr>
+            </a:pPr>
+            <a:r>
+              <a:rPr sz="1200" b="0" i="0" u="none" strike="noStrike">
+                <a:solidFill>
+                  <a:srgbClr val="333333"/>
+                </a:solidFill>
+                <a:latin typeface="Arial"/>
+              </a:rPr>
+              <a:t>Gain-stripped process score (W_g = W_lag = 0)</a:t>
+            </a:r>
+          </a:p>
+        </c:rich>
+      </c:tx>
+      <c:layout/>
+      <c:overlay val="0"/>
+    </c:title>
+    <c:autoTitleDeleted val="0"/>
+    <c:plotArea>
+      <c:layout/>
+      <c:lineChart>
+        <c:varyColors val="0"/>
+        <c:ser>
+          <c:idx val="0"/>
+          <c:order val="0"/>
+          <c:tx>
+            <c:strRef>
+              <c:f>Sheet1!$B$1</c:f>
+              <c:strCache>
+                <c:ptCount val="1"/>
+                <c:pt idx="0">
+                  <c:v>Feedback mean</c:v>
+                </c:pt>
+              </c:strCache>
+            </c:strRef>
+          </c:tx>
+          <c:spPr>
+            <a:solidFill>
+              <a:srgbClr val="1F3F6F"/>
+            </a:solidFill>
+            <a:ln w="38100" cap="flat">
+              <a:solidFill>
+                <a:srgbClr val="1F3F6F"/>
+              </a:solidFill>
+              <a:prstDash val="solid"/>
+              <a:round/>
+            </a:ln>
+            <a:effectLst/>
+          </c:spPr>
+          <c:invertIfNegative val="0"/>
+          <c:dLbls>
+            <c:numFmt formatCode="#,##0" sourceLinked="0"/>
+            <c:txPr>
+              <a:bodyPr/>
+              <a:lstStyle/>
+              <a:p>
+                <a:pPr>
+                  <a:defRPr b="0" i="0" strike="noStrike" sz="1200" u="none">
+                    <a:solidFill>
+                      <a:srgbClr val="000000"/>
+                    </a:solidFill>
+                    <a:latin typeface="Arial"/>
+                  </a:defRPr>
+                </a:pPr>
+              </a:p>
+            </c:txPr>
+            <c:showLegendKey val="0"/>
+            <c:showVal val="0"/>
+            <c:showCatName val="0"/>
+            <c:showSerName val="0"/>
+            <c:showPercent val="0"/>
+            <c:showBubbleSize val="0"/>
+            <c:showLeaderLines val="0"/>
+          </c:dLbls>
+          <c:marker>
+            <c:symbol val="circle"/>
+            <c:size val="7"/>
+            <c:spPr>
+              <a:solidFill>
+                <a:srgbClr val="1F3F6F"/>
+              </a:solidFill>
+              <a:ln w="9525" cap="flat">
+                <a:solidFill>
+                  <a:srgbClr val="1F3F6F"/>
+                </a:solidFill>
+                <a:prstDash val="solid"/>
+                <a:round/>
+              </a:ln>
+              <a:effectLst/>
+            </c:spPr>
+          </c:marker>
+          <c:cat>
+            <c:multiLvlStrRef>
+              <c:f>Sheet1!$A$2:$A$7</c:f>
+              <c:multiLvlStrCache>
+                <c:ptCount val="6"/>
+                <c:lvl>
+                  <c:pt idx="0">
+                    <c:v>S1</c:v>
+                  </c:pt>
+                  <c:pt idx="1">
+                    <c:v>S2</c:v>
+                  </c:pt>
+                  <c:pt idx="2">
+                    <c:v>S3</c:v>
+                  </c:pt>
+                  <c:pt idx="3">
+                    <c:v>S4</c:v>
+                  </c:pt>
+                  <c:pt idx="4">
+                    <c:v>S5</c:v>
+                  </c:pt>
+                  <c:pt idx="5">
+                    <c:v>S6</c:v>
+                  </c:pt>
+                </c:lvl>
+              </c:multiLvlStrCache>
+            </c:multiLvlStrRef>
+          </c:cat>
+          <c:val>
+            <c:numRef>
+              <c:f>Sheet1!$B$2:$B$7</c:f>
+              <c:numCache>
+                <c:formatCode>General</c:formatCode>
+                <c:ptCount val="6"/>
+                <c:pt idx="0">
+                  <c:v>26.7</c:v>
+                </c:pt>
+                <c:pt idx="1">
+                  <c:v>22</c:v>
+                </c:pt>
+                <c:pt idx="2">
+                  <c:v>38.7</c:v>
+                </c:pt>
+                <c:pt idx="3">
+                  <c:v>47.7</c:v>
+                </c:pt>
+                <c:pt idx="4">
+                  <c:v>36.7</c:v>
+                </c:pt>
+                <c:pt idx="5">
+                  <c:v>49</c:v>
+                </c:pt>
+              </c:numCache>
+            </c:numRef>
+          </c:val>
+          <c:smooth val="0"/>
+        </c:ser>
+        <c:ser>
+          <c:idx val="1"/>
+          <c:order val="1"/>
+          <c:tx>
+            <c:strRef>
+              <c:f>Sheet1!$C$1</c:f>
+              <c:strCache>
+                <c:ptCount val="1"/>
+                <c:pt idx="0">
+                  <c:v>Baseline mean</c:v>
+                </c:pt>
+              </c:strCache>
+            </c:strRef>
+          </c:tx>
+          <c:spPr>
+            <a:solidFill>
+              <a:srgbClr val="B25500"/>
+            </a:solidFill>
+            <a:ln w="38100" cap="flat">
+              <a:solidFill>
+                <a:srgbClr val="B25500"/>
+              </a:solidFill>
+              <a:prstDash val="solid"/>
+              <a:round/>
+            </a:ln>
+            <a:effectLst/>
+          </c:spPr>
+          <c:invertIfNegative val="0"/>
+          <c:dLbls>
+            <c:numFmt formatCode="#,##0" sourceLinked="0"/>
+            <c:txPr>
+              <a:bodyPr/>
+              <a:lstStyle/>
+              <a:p>
+                <a:pPr>
+                  <a:defRPr b="0" i="0" strike="noStrike" sz="1200" u="none">
+                    <a:solidFill>
+                      <a:srgbClr val="000000"/>
+                    </a:solidFill>
+                    <a:latin typeface="Arial"/>
+                  </a:defRPr>
+                </a:pPr>
+              </a:p>
+            </c:txPr>
+            <c:showLegendKey val="0"/>
+            <c:showVal val="0"/>
+            <c:showCatName val="0"/>
+            <c:showSerName val="0"/>
+            <c:showPercent val="0"/>
+            <c:showBubbleSize val="0"/>
+            <c:showLeaderLines val="0"/>
+          </c:dLbls>
+          <c:marker>
+            <c:symbol val="circle"/>
+            <c:size val="7"/>
+            <c:spPr>
+              <a:solidFill>
+                <a:srgbClr val="B25500"/>
+              </a:solidFill>
+              <a:ln w="9525" cap="flat">
+                <a:solidFill>
+                  <a:srgbClr val="B25500"/>
+                </a:solidFill>
+                <a:prstDash val="solid"/>
+                <a:round/>
+              </a:ln>
+              <a:effectLst/>
+            </c:spPr>
+          </c:marker>
+          <c:cat>
+            <c:multiLvlStrRef>
+              <c:f>Sheet1!$A$2:$A$7</c:f>
+              <c:multiLvlStrCache>
+                <c:ptCount val="6"/>
+                <c:lvl>
+                  <c:pt idx="0">
+                    <c:v>S1</c:v>
+                  </c:pt>
+                  <c:pt idx="1">
+                    <c:v>S2</c:v>
+                  </c:pt>
+                  <c:pt idx="2">
+                    <c:v>S3</c:v>
+                  </c:pt>
+                  <c:pt idx="3">
+                    <c:v>S4</c:v>
+                  </c:pt>
+                  <c:pt idx="4">
+                    <c:v>S5</c:v>
+                  </c:pt>
+                  <c:pt idx="5">
+                    <c:v>S6</c:v>
+                  </c:pt>
+                </c:lvl>
+              </c:multiLvlStrCache>
+            </c:multiLvlStrRef>
+          </c:cat>
+          <c:val>
+            <c:numRef>
+              <c:f>Sheet1!$C$2:$C$7</c:f>
+              <c:numCache>
+                <c:formatCode>General</c:formatCode>
+                <c:ptCount val="6"/>
+                <c:pt idx="0">
+                  <c:v>22.5</c:v>
+                </c:pt>
+                <c:pt idx="1">
+                  <c:v>17.5</c:v>
+                </c:pt>
+                <c:pt idx="2">
+                  <c:v>11</c:v>
+                </c:pt>
+                <c:pt idx="3">
+                  <c:v>39</c:v>
+                </c:pt>
+                <c:pt idx="4">
+                  <c:v>16.5</c:v>
+                </c:pt>
+                <c:pt idx="5">
+                  <c:v>20.5</c:v>
+                </c:pt>
+              </c:numCache>
+            </c:numRef>
+          </c:val>
+          <c:smooth val="0"/>
+        </c:ser>
+        <c:dLbls>
+          <c:numFmt formatCode="#,##0" sourceLinked="0"/>
+          <c:txPr>
+            <a:bodyPr/>
+            <a:lstStyle/>
+            <a:p>
+              <a:pPr>
+                <a:defRPr b="0" i="0" strike="noStrike" sz="1200" u="none">
+                  <a:solidFill>
+                    <a:srgbClr val="000000"/>
+                  </a:solidFill>
+                  <a:latin typeface="Arial"/>
+                </a:defRPr>
+              </a:pPr>
+            </a:p>
+          </c:txPr>
+          <c:showLegendKey val="0"/>
+          <c:showVal val="0"/>
+          <c:showCatName val="0"/>
+          <c:showSerName val="0"/>
+          <c:showPercent val="0"/>
+          <c:showBubbleSize val="0"/>
+          <c:showLeaderLines val="0"/>
+        </c:dLbls>
+        <c:marker val="1"/>
+        <c:axId val="2094734554"/>
+        <c:axId val="2094734552"/>
+        <c:axId val="2094734556"/>
+      </c:lineChart>
+      <c:catAx>
+        <c:axId val="2094734554"/>
+        <c:scaling>
+          <c:orientation val="minMax"/>
+        </c:scaling>
+        <c:delete val="0"/>
+        <c:axPos val="b"/>
+        <c:numFmt formatCode="General" sourceLinked="1"/>
+        <c:majorTickMark val="out"/>
+        <c:minorTickMark val="none"/>
+        <c:tickLblPos val="low"/>
+        <c:spPr>
+          <a:ln w="12700" cap="flat">
+            <a:solidFill>
+              <a:srgbClr val="888888"/>
+            </a:solidFill>
+            <a:prstDash val="solid"/>
+            <a:round/>
+          </a:ln>
+        </c:spPr>
+        <c:txPr>
+          <a:bodyPr/>
+          <a:lstStyle/>
+          <a:p>
+            <a:pPr>
+              <a:defRPr sz="1000" b="0" i="0" u="none" strike="noStrike">
+                <a:solidFill>
+                  <a:srgbClr val="000000"/>
+                </a:solidFill>
+                <a:latin typeface="Arial"/>
+              </a:defRPr>
+            </a:pPr>
+            <a:endParaRPr lang="en-US"/>
+          </a:p>
+        </c:txPr>
+        <c:crossAx val="2094734552"/>
+        <c:crosses val="autoZero"/>
+        <c:auto val="1"/>
+        <c:lblAlgn val="ctr"/>
+        <c:noMultiLvlLbl val="1"/>
+      </c:catAx>
+      <c:valAx>
+        <c:axId val="2094734552"/>
+        <c:scaling>
+          <c:orientation val="minMax"/>
+          <c:max val="60"/>
+          <c:min val="0"/>
+        </c:scaling>
+        <c:delete val="0"/>
+        <c:axPos val="l"/>
+        <c:majorGridlines>
+          <c:spPr>
+            <a:ln w="12700" cap="flat">
+              <a:solidFill>
+                <a:srgbClr val="888888"/>
+              </a:solidFill>
+              <a:prstDash val="solid"/>
+              <a:round/>
+            </a:ln>
+          </c:spPr>
+        </c:majorGridlines>
+        <c:numFmt formatCode="General" sourceLinked="0"/>
+        <c:majorTickMark val="out"/>
+        <c:minorTickMark val="none"/>
+        <c:tickLblPos val="nextTo"/>
+        <c:spPr>
+          <a:ln w="12700" cap="flat">
+            <a:solidFill>
+              <a:srgbClr val="888888"/>
+            </a:solidFill>
+            <a:prstDash val="solid"/>
+            <a:round/>
+          </a:ln>
+        </c:spPr>
+        <c:txPr>
+          <a:bodyPr/>
+          <a:lstStyle/>
+          <a:p>
+            <a:pPr>
+              <a:defRPr sz="1000" b="0" i="0" u="none" strike="noStrike">
+                <a:solidFill>
+                  <a:srgbClr val="000000"/>
+                </a:solidFill>
+                <a:latin typeface="Arial"/>
+              </a:defRPr>
+            </a:pPr>
+            <a:endParaRPr lang="en-US"/>
+          </a:p>
+        </c:txPr>
+        <c:crossAx val="2094734554"/>
+        <c:crosses val="autoZero"/>
+        <c:crossBetween val="between"/>
+        <c:majorUnit val="10"/>
+      </c:valAx>
+      <c:spPr>
+        <a:noFill/>
+        <a:ln>
+          <a:noFill/>
+        </a:ln>
+        <a:effectLst/>
+      </c:spPr>
+    </c:plotArea>
+    <c:legend>
+      <c:legendPos val="b"/>
+      <c:overlay val="0"/>
+      <c:txPr>
+        <a:bodyPr/>
+        <a:lstStyle/>
+        <a:p>
+          <a:pPr>
+            <a:defRPr sz="1000">      </a:defRPr>
+          </a:pPr>
+          <a:endParaRPr lang="en-US"/>
+        </a:p>
+      </c:txPr>
+    </c:legend>
+    <c:plotVisOnly val="1"/>
+    <c:dispBlanksAs val="span"/>
+  </c:chart>
+  <c:spPr>
+    <a:noFill/>
+    <a:ln>
+      <a:noFill/>
+    </a:ln>
+    <a:effectLst/>
+  </c:spPr>
+  <c:externalData r:id="rId1">
+    <c:autoUpdate val="0"/>
+  </c:externalData>
+</c:chartSpace>
+</file>
+
+<file path=ppt/charts/chart4.xml><?xml version="1.0" encoding="utf-8"?>
+<c:chartSpace xmlns:c="http://schemas.openxmlformats.org/drawingml/2006/chart" xmlns:a="http://schemas.openxmlformats.org/drawingml/2006/main" xmlns:r="http://schemas.openxmlformats.org/officeDocument/2006/relationships">
+  <c:date1904 val="0"/>
+  <c:roundedCorners val="1"/>
+  <c:chart>
+    <c:title>
+      <c:tx>
+        <c:rich>
+          <a:bodyPr/>
+          <a:lstStyle/>
+          <a:p>
+            <a:pPr>
+              <a:defRPr sz="1100" b="0" i="0" u="none" strike="noStrike">
+                <a:solidFill>
+                  <a:srgbClr val="333333"/>
+                </a:solidFill>
+                <a:latin typeface="Arial"/>
+              </a:defRPr>
+            </a:pPr>
+            <a:r>
+              <a:rPr sz="1100" b="0" i="0" u="none" strike="noStrike">
+                <a:solidFill>
+                  <a:srgbClr val="333333"/>
+                </a:solidFill>
+                <a:latin typeface="Arial"/>
+              </a:rPr>
+              <a:t>Gain-stripped score (same scale as user study)</a:t>
+            </a:r>
+          </a:p>
+        </c:rich>
+      </c:tx>
+      <c:layout/>
+      <c:overlay val="0"/>
+    </c:title>
+    <c:autoTitleDeleted val="0"/>
+    <c:plotArea>
+      <c:layout/>
+      <c:lineChart>
+        <c:varyColors val="0"/>
+        <c:ser>
+          <c:idx val="0"/>
+          <c:order val="0"/>
+          <c:tx>
+            <c:strRef>
+              <c:f>Sheet1!$B$1</c:f>
+              <c:strCache>
+                <c:ptCount val="1"/>
+                <c:pt idx="0">
+                  <c:v>Feedback mean (n=6)</c:v>
+                </c:pt>
+              </c:strCache>
+            </c:strRef>
+          </c:tx>
+          <c:spPr>
+            <a:solidFill>
+              <a:srgbClr val="1F3F6F"/>
+            </a:solidFill>
+            <a:ln w="31750" cap="flat">
+              <a:solidFill>
+                <a:srgbClr val="1F3F6F"/>
+              </a:solidFill>
+              <a:prstDash val="solid"/>
+              <a:round/>
+            </a:ln>
+            <a:effectLst/>
+          </c:spPr>
+          <c:invertIfNegative val="0"/>
+          <c:dLbls>
+            <c:numFmt formatCode="#,##0" sourceLinked="0"/>
+            <c:txPr>
+              <a:bodyPr/>
+              <a:lstStyle/>
+              <a:p>
+                <a:pPr>
+                  <a:defRPr b="0" i="0" strike="noStrike" sz="1200" u="none">
+                    <a:solidFill>
+                      <a:srgbClr val="000000"/>
+                    </a:solidFill>
+                    <a:latin typeface="Arial"/>
+                  </a:defRPr>
+                </a:pPr>
+              </a:p>
+            </c:txPr>
+            <c:showLegendKey val="0"/>
+            <c:showVal val="0"/>
+            <c:showCatName val="0"/>
+            <c:showSerName val="0"/>
+            <c:showPercent val="0"/>
+            <c:showBubbleSize val="0"/>
+            <c:showLeaderLines val="0"/>
+          </c:dLbls>
+          <c:marker>
+            <c:symbol val="circle"/>
+            <c:size val="6"/>
+            <c:spPr>
+              <a:solidFill>
+                <a:srgbClr val="1F3F6F"/>
+              </a:solidFill>
+              <a:ln w="9525" cap="flat">
+                <a:solidFill>
+                  <a:srgbClr val="1F3F6F"/>
+                </a:solidFill>
+                <a:prstDash val="solid"/>
+                <a:round/>
+              </a:ln>
+              <a:effectLst/>
+            </c:spPr>
+          </c:marker>
+          <c:cat>
+            <c:multiLvlStrRef>
+              <c:f>Sheet1!$A$2:$A$7</c:f>
+              <c:multiLvlStrCache>
+                <c:ptCount val="6"/>
+                <c:lvl>
+                  <c:pt idx="0">
+                    <c:v>S1</c:v>
+                  </c:pt>
+                  <c:pt idx="1">
+                    <c:v>S2</c:v>
+                  </c:pt>
+                  <c:pt idx="2">
+                    <c:v>S3</c:v>
+                  </c:pt>
+                  <c:pt idx="3">
+                    <c:v>S4</c:v>
+                  </c:pt>
+                  <c:pt idx="4">
+                    <c:v>S5</c:v>
+                  </c:pt>
+                  <c:pt idx="5">
+                    <c:v>S6</c:v>
+                  </c:pt>
+                </c:lvl>
+              </c:multiLvlStrCache>
+            </c:multiLvlStrRef>
+          </c:cat>
+          <c:val>
+            <c:numRef>
+              <c:f>Sheet1!$B$2:$B$7</c:f>
+              <c:numCache>
+                <c:formatCode>General</c:formatCode>
+                <c:ptCount val="6"/>
+                <c:pt idx="0">
+                  <c:v>36.7</c:v>
+                </c:pt>
+                <c:pt idx="1">
+                  <c:v>40</c:v>
+                </c:pt>
+                <c:pt idx="2">
+                  <c:v>40</c:v>
+                </c:pt>
+                <c:pt idx="3">
+                  <c:v>50</c:v>
+                </c:pt>
+                <c:pt idx="4">
+                  <c:v>42</c:v>
+                </c:pt>
+                <c:pt idx="5">
+                  <c:v>39.7</c:v>
+                </c:pt>
+              </c:numCache>
+            </c:numRef>
+          </c:val>
+          <c:smooth val="0"/>
+        </c:ser>
+        <c:ser>
+          <c:idx val="1"/>
+          <c:order val="1"/>
+          <c:tx>
+            <c:strRef>
+              <c:f>Sheet1!$C$1</c:f>
+              <c:strCache>
+                <c:ptCount val="1"/>
+                <c:pt idx="0">
+                  <c:v>Baseline mean (n=2)</c:v>
+                </c:pt>
+              </c:strCache>
+            </c:strRef>
+          </c:tx>
+          <c:spPr>
+            <a:solidFill>
+              <a:srgbClr val="B25500"/>
+            </a:solidFill>
+            <a:ln w="31750" cap="flat">
+              <a:solidFill>
+                <a:srgbClr val="B25500"/>
+              </a:solidFill>
+              <a:prstDash val="solid"/>
+              <a:round/>
+            </a:ln>
+            <a:effectLst/>
+          </c:spPr>
+          <c:invertIfNegative val="0"/>
+          <c:dLbls>
+            <c:numFmt formatCode="#,##0" sourceLinked="0"/>
+            <c:txPr>
+              <a:bodyPr/>
+              <a:lstStyle/>
+              <a:p>
+                <a:pPr>
+                  <a:defRPr b="0" i="0" strike="noStrike" sz="1200" u="none">
+                    <a:solidFill>
+                      <a:srgbClr val="000000"/>
+                    </a:solidFill>
+                    <a:latin typeface="Arial"/>
+                  </a:defRPr>
+                </a:pPr>
+              </a:p>
+            </c:txPr>
+            <c:showLegendKey val="0"/>
+            <c:showVal val="0"/>
+            <c:showCatName val="0"/>
+            <c:showSerName val="0"/>
+            <c:showPercent val="0"/>
+            <c:showBubbleSize val="0"/>
+            <c:showLeaderLines val="0"/>
+          </c:dLbls>
+          <c:marker>
+            <c:symbol val="circle"/>
+            <c:size val="6"/>
+            <c:spPr>
+              <a:solidFill>
+                <a:srgbClr val="B25500"/>
+              </a:solidFill>
+              <a:ln w="9525" cap="flat">
+                <a:solidFill>
+                  <a:srgbClr val="B25500"/>
+                </a:solidFill>
+                <a:prstDash val="solid"/>
+                <a:round/>
+              </a:ln>
+              <a:effectLst/>
+            </c:spPr>
+          </c:marker>
+          <c:cat>
+            <c:multiLvlStrRef>
+              <c:f>Sheet1!$A$2:$A$7</c:f>
+              <c:multiLvlStrCache>
+                <c:ptCount val="6"/>
+                <c:lvl>
+                  <c:pt idx="0">
+                    <c:v>S1</c:v>
+                  </c:pt>
+                  <c:pt idx="1">
+                    <c:v>S2</c:v>
+                  </c:pt>
+                  <c:pt idx="2">
+                    <c:v>S3</c:v>
+                  </c:pt>
+                  <c:pt idx="3">
+                    <c:v>S4</c:v>
+                  </c:pt>
+                  <c:pt idx="4">
+                    <c:v>S5</c:v>
+                  </c:pt>
+                  <c:pt idx="5">
+                    <c:v>S6</c:v>
+                  </c:pt>
+                </c:lvl>
+              </c:multiLvlStrCache>
+            </c:multiLvlStrRef>
+          </c:cat>
+          <c:val>
+            <c:numRef>
+              <c:f>Sheet1!$C$2:$C$7</c:f>
+              <c:numCache>
+                <c:formatCode>General</c:formatCode>
+                <c:ptCount val="6"/>
+                <c:pt idx="0">
+                  <c:v>34.5</c:v>
+                </c:pt>
+                <c:pt idx="1">
+                  <c:v>40</c:v>
+                </c:pt>
+                <c:pt idx="2">
+                  <c:v>40</c:v>
+                </c:pt>
+                <c:pt idx="3">
+                  <c:v>50</c:v>
+                </c:pt>
+                <c:pt idx="4">
+                  <c:v>42</c:v>
+                </c:pt>
+                <c:pt idx="5">
+                  <c:v>41</c:v>
+                </c:pt>
+              </c:numCache>
+            </c:numRef>
+          </c:val>
+          <c:smooth val="0"/>
+        </c:ser>
+        <c:dLbls>
+          <c:numFmt formatCode="#,##0" sourceLinked="0"/>
+          <c:txPr>
+            <a:bodyPr/>
+            <a:lstStyle/>
+            <a:p>
+              <a:pPr>
+                <a:defRPr b="0" i="0" strike="noStrike" sz="1200" u="none">
+                  <a:solidFill>
+                    <a:srgbClr val="000000"/>
+                  </a:solidFill>
+                  <a:latin typeface="Arial"/>
+                </a:defRPr>
+              </a:pPr>
+            </a:p>
+          </c:txPr>
+          <c:showLegendKey val="0"/>
+          <c:showVal val="0"/>
+          <c:showCatName val="0"/>
+          <c:showSerName val="0"/>
+          <c:showPercent val="0"/>
+          <c:showBubbleSize val="0"/>
+          <c:showLeaderLines val="0"/>
+        </c:dLbls>
+        <c:marker val="1"/>
+        <c:axId val="2094734554"/>
+        <c:axId val="2094734552"/>
+        <c:axId val="2094734556"/>
+      </c:lineChart>
+      <c:catAx>
+        <c:axId val="2094734554"/>
+        <c:scaling>
+          <c:orientation val="minMax"/>
+        </c:scaling>
+        <c:delete val="0"/>
+        <c:axPos val="b"/>
+        <c:numFmt formatCode="General" sourceLinked="1"/>
+        <c:majorTickMark val="out"/>
+        <c:minorTickMark val="none"/>
+        <c:tickLblPos val="low"/>
+        <c:spPr>
+          <a:ln w="12700" cap="flat">
+            <a:solidFill>
+              <a:srgbClr val="888888"/>
+            </a:solidFill>
+            <a:prstDash val="solid"/>
+            <a:round/>
+          </a:ln>
+        </c:spPr>
+        <c:txPr>
+          <a:bodyPr/>
+          <a:lstStyle/>
+          <a:p>
+            <a:pPr>
+              <a:defRPr sz="900" b="0" i="0" u="none" strike="noStrike">
+                <a:solidFill>
+                  <a:srgbClr val="000000"/>
+                </a:solidFill>
+                <a:latin typeface="Arial"/>
+              </a:defRPr>
+            </a:pPr>
+            <a:endParaRPr lang="en-US"/>
+          </a:p>
+        </c:txPr>
+        <c:crossAx val="2094734552"/>
+        <c:crosses val="autoZero"/>
+        <c:auto val="1"/>
+        <c:lblAlgn val="ctr"/>
+        <c:noMultiLvlLbl val="1"/>
+      </c:catAx>
+      <c:valAx>
+        <c:axId val="2094734552"/>
+        <c:scaling>
+          <c:orientation val="minMax"/>
+          <c:max val="60"/>
+          <c:min val="0"/>
+        </c:scaling>
+        <c:delete val="0"/>
+        <c:axPos val="l"/>
+        <c:majorGridlines>
+          <c:spPr>
+            <a:ln w="12700" cap="flat">
+              <a:solidFill>
+                <a:srgbClr val="888888"/>
+              </a:solidFill>
+              <a:prstDash val="solid"/>
+              <a:round/>
+            </a:ln>
+          </c:spPr>
+        </c:majorGridlines>
+        <c:numFmt formatCode="General" sourceLinked="0"/>
+        <c:majorTickMark val="out"/>
+        <c:minorTickMark val="none"/>
+        <c:tickLblPos val="nextTo"/>
+        <c:spPr>
+          <a:ln w="12700" cap="flat">
+            <a:solidFill>
+              <a:srgbClr val="888888"/>
+            </a:solidFill>
+            <a:prstDash val="solid"/>
+            <a:round/>
+          </a:ln>
+        </c:spPr>
+        <c:txPr>
+          <a:bodyPr/>
+          <a:lstStyle/>
+          <a:p>
+            <a:pPr>
+              <a:defRPr sz="900" b="0" i="0" u="none" strike="noStrike">
+                <a:solidFill>
+                  <a:srgbClr val="000000"/>
+                </a:solidFill>
+                <a:latin typeface="Arial"/>
+              </a:defRPr>
+            </a:pPr>
+            <a:endParaRPr lang="en-US"/>
+          </a:p>
+        </c:txPr>
+        <c:crossAx val="2094734554"/>
+        <c:crosses val="autoZero"/>
+        <c:crossBetween val="between"/>
+        <c:majorUnit val="10"/>
+      </c:valAx>
+      <c:spPr>
+        <a:noFill/>
+        <a:ln>
+          <a:noFill/>
+        </a:ln>
+        <a:effectLst/>
+      </c:spPr>
+    </c:plotArea>
+    <c:legend>
+      <c:legendPos val="b"/>
+      <c:overlay val="0"/>
+      <c:txPr>
+        <a:bodyPr/>
+        <a:lstStyle/>
+        <a:p>
+          <a:pPr>
+            <a:defRPr sz="900">      </a:defRPr>
+          </a:pPr>
+          <a:endParaRPr lang="en-US"/>
+        </a:p>
+      </c:txPr>
+    </c:legend>
+    <c:plotVisOnly val="1"/>
+    <c:dispBlanksAs val="span"/>
+  </c:chart>
+  <c:spPr>
+    <a:noFill/>
+    <a:ln>
+      <a:noFill/>
+    </a:ln>
+    <a:effectLst/>
+  </c:spPr>
+  <c:externalData r:id="rId1">
+    <c:autoUpdate val="0"/>
+  </c:externalData>
+</c:chartSpace>
 </file>
 
 <file path=ppt/notesMasters/notesMaster1.xml><?xml version="1.0" encoding="utf-8"?>
@@ -1779,6 +3590,270 @@
             <a:fld id="{F7021451-1387-4CA6-816F-3879F97B5CBC}" type="slidenum">
               <a:rPr lang="en-US"/>
               <a:t>22</a:t>
+            </a:fld>
+            <a:endParaRPr lang="en-US"/>
+          </a:p>
+        </p:txBody>
+      </p:sp>
+    </p:spTree>
+    <p:extLst>
+      <p:ext uri="{BB962C8B-B14F-4D97-AF65-F5344CB8AC3E}">
+        <p14:creationId xmlns:p14="http://schemas.microsoft.com/office/powerpoint/2010/main" val="1024086991"/>
+      </p:ext>
+    </p:extLst>
+  </p:cSld>
+  <p:clrMapOvr>
+    <a:masterClrMapping/>
+  </p:clrMapOvr>
+</p:notes>
+</file>
+
+<file path=ppt/notesSlides/notesSlide23.xml><?xml version="1.0" encoding="utf-8"?>
+<p:notes xmlns:a="http://schemas.openxmlformats.org/drawingml/2006/main" xmlns:r="http://schemas.openxmlformats.org/officeDocument/2006/relationships" xmlns:p="http://schemas.openxmlformats.org/presentationml/2006/main">
+  <p:cSld>
+    <p:spTree>
+      <p:nvGrpSpPr>
+        <p:cNvPr id="1" name=""/>
+        <p:cNvGrpSpPr/>
+        <p:nvPr/>
+      </p:nvGrpSpPr>
+      <p:grpSpPr>
+        <a:xfrm>
+          <a:off x="0" y="0"/>
+          <a:ext cx="0" cy="0"/>
+          <a:chOff x="0" y="0"/>
+          <a:chExt cx="0" cy="0"/>
+        </a:xfrm>
+      </p:grpSpPr>
+      <p:sp>
+        <p:nvSpPr>
+          <p:cNvPr id="2" name="Slide Image Placeholder 1"/>
+          <p:cNvSpPr>
+            <a:spLocks noGrp="1" noRot="1" noChangeAspect="1"/>
+          </p:cNvSpPr>
+          <p:nvPr>
+            <p:ph type="sldImg"/>
+          </p:nvPr>
+        </p:nvSpPr>
+        <p:spPr/>
+      </p:sp>
+      <p:sp>
+        <p:nvSpPr>
+          <p:cNvPr id="3" name="Notes Placeholder 2"/>
+          <p:cNvSpPr>
+            <a:spLocks noGrp="1"/>
+          </p:cNvSpPr>
+          <p:nvPr>
+            <p:ph type="body" idx="1"/>
+          </p:nvPr>
+        </p:nvSpPr>
+        <p:spPr/>
+        <p:txBody>
+          <a:bodyPr/>
+          <a:lstStyle/>
+          <a:p>
+            <a:r>
+              <a:rPr lang="en-US" dirty="0"/>
+              <a:t/>
+            </a:r>
+            <a:endParaRPr lang="en-US" dirty="0"/>
+          </a:p>
+        </p:txBody>
+      </p:sp>
+      <p:sp>
+        <p:nvSpPr>
+          <p:cNvPr id="4" name="Slide Number Placeholder 3"/>
+          <p:cNvSpPr>
+            <a:spLocks noGrp="1"/>
+          </p:cNvSpPr>
+          <p:nvPr>
+            <p:ph type="sldNum" sz="quarter" idx="10"/>
+          </p:nvPr>
+        </p:nvSpPr>
+        <p:spPr/>
+        <p:txBody>
+          <a:bodyPr/>
+          <a:lstStyle/>
+          <a:p>
+            <a:fld id="{F7021451-1387-4CA6-816F-3879F97B5CBC}" type="slidenum">
+              <a:rPr lang="en-US"/>
+              <a:t>23</a:t>
+            </a:fld>
+            <a:endParaRPr lang="en-US"/>
+          </a:p>
+        </p:txBody>
+      </p:sp>
+    </p:spTree>
+    <p:extLst>
+      <p:ext uri="{BB962C8B-B14F-4D97-AF65-F5344CB8AC3E}">
+        <p14:creationId xmlns:p14="http://schemas.microsoft.com/office/powerpoint/2010/main" val="1024086991"/>
+      </p:ext>
+    </p:extLst>
+  </p:cSld>
+  <p:clrMapOvr>
+    <a:masterClrMapping/>
+  </p:clrMapOvr>
+</p:notes>
+</file>
+
+<file path=ppt/notesSlides/notesSlide24.xml><?xml version="1.0" encoding="utf-8"?>
+<p:notes xmlns:a="http://schemas.openxmlformats.org/drawingml/2006/main" xmlns:r="http://schemas.openxmlformats.org/officeDocument/2006/relationships" xmlns:p="http://schemas.openxmlformats.org/presentationml/2006/main">
+  <p:cSld>
+    <p:spTree>
+      <p:nvGrpSpPr>
+        <p:cNvPr id="1" name=""/>
+        <p:cNvGrpSpPr/>
+        <p:nvPr/>
+      </p:nvGrpSpPr>
+      <p:grpSpPr>
+        <a:xfrm>
+          <a:off x="0" y="0"/>
+          <a:ext cx="0" cy="0"/>
+          <a:chOff x="0" y="0"/>
+          <a:chExt cx="0" cy="0"/>
+        </a:xfrm>
+      </p:grpSpPr>
+      <p:sp>
+        <p:nvSpPr>
+          <p:cNvPr id="2" name="Slide Image Placeholder 1"/>
+          <p:cNvSpPr>
+            <a:spLocks noGrp="1" noRot="1" noChangeAspect="1"/>
+          </p:cNvSpPr>
+          <p:nvPr>
+            <p:ph type="sldImg"/>
+          </p:nvPr>
+        </p:nvSpPr>
+        <p:spPr/>
+      </p:sp>
+      <p:sp>
+        <p:nvSpPr>
+          <p:cNvPr id="3" name="Notes Placeholder 2"/>
+          <p:cNvSpPr>
+            <a:spLocks noGrp="1"/>
+          </p:cNvSpPr>
+          <p:nvPr>
+            <p:ph type="body" idx="1"/>
+          </p:nvPr>
+        </p:nvSpPr>
+        <p:spPr/>
+        <p:txBody>
+          <a:bodyPr/>
+          <a:lstStyle/>
+          <a:p>
+            <a:r>
+              <a:rPr lang="en-US" dirty="0"/>
+              <a:t/>
+            </a:r>
+            <a:endParaRPr lang="en-US" dirty="0"/>
+          </a:p>
+        </p:txBody>
+      </p:sp>
+      <p:sp>
+        <p:nvSpPr>
+          <p:cNvPr id="4" name="Slide Number Placeholder 3"/>
+          <p:cNvSpPr>
+            <a:spLocks noGrp="1"/>
+          </p:cNvSpPr>
+          <p:nvPr>
+            <p:ph type="sldNum" sz="quarter" idx="10"/>
+          </p:nvPr>
+        </p:nvSpPr>
+        <p:spPr/>
+        <p:txBody>
+          <a:bodyPr/>
+          <a:lstStyle/>
+          <a:p>
+            <a:fld id="{F7021451-1387-4CA6-816F-3879F97B5CBC}" type="slidenum">
+              <a:rPr lang="en-US"/>
+              <a:t>24</a:t>
+            </a:fld>
+            <a:endParaRPr lang="en-US"/>
+          </a:p>
+        </p:txBody>
+      </p:sp>
+    </p:spTree>
+    <p:extLst>
+      <p:ext uri="{BB962C8B-B14F-4D97-AF65-F5344CB8AC3E}">
+        <p14:creationId xmlns:p14="http://schemas.microsoft.com/office/powerpoint/2010/main" val="1024086991"/>
+      </p:ext>
+    </p:extLst>
+  </p:cSld>
+  <p:clrMapOvr>
+    <a:masterClrMapping/>
+  </p:clrMapOvr>
+</p:notes>
+</file>
+
+<file path=ppt/notesSlides/notesSlide25.xml><?xml version="1.0" encoding="utf-8"?>
+<p:notes xmlns:a="http://schemas.openxmlformats.org/drawingml/2006/main" xmlns:r="http://schemas.openxmlformats.org/officeDocument/2006/relationships" xmlns:p="http://schemas.openxmlformats.org/presentationml/2006/main">
+  <p:cSld>
+    <p:spTree>
+      <p:nvGrpSpPr>
+        <p:cNvPr id="1" name=""/>
+        <p:cNvGrpSpPr/>
+        <p:nvPr/>
+      </p:nvGrpSpPr>
+      <p:grpSpPr>
+        <a:xfrm>
+          <a:off x="0" y="0"/>
+          <a:ext cx="0" cy="0"/>
+          <a:chOff x="0" y="0"/>
+          <a:chExt cx="0" cy="0"/>
+        </a:xfrm>
+      </p:grpSpPr>
+      <p:sp>
+        <p:nvSpPr>
+          <p:cNvPr id="2" name="Slide Image Placeholder 1"/>
+          <p:cNvSpPr>
+            <a:spLocks noGrp="1" noRot="1" noChangeAspect="1"/>
+          </p:cNvSpPr>
+          <p:nvPr>
+            <p:ph type="sldImg"/>
+          </p:nvPr>
+        </p:nvSpPr>
+        <p:spPr/>
+      </p:sp>
+      <p:sp>
+        <p:nvSpPr>
+          <p:cNvPr id="3" name="Notes Placeholder 2"/>
+          <p:cNvSpPr>
+            <a:spLocks noGrp="1"/>
+          </p:cNvSpPr>
+          <p:nvPr>
+            <p:ph type="body" idx="1"/>
+          </p:nvPr>
+        </p:nvSpPr>
+        <p:spPr/>
+        <p:txBody>
+          <a:bodyPr/>
+          <a:lstStyle/>
+          <a:p>
+            <a:r>
+              <a:rPr lang="en-US" dirty="0"/>
+              <a:t/>
+            </a:r>
+            <a:endParaRPr lang="en-US" dirty="0"/>
+          </a:p>
+        </p:txBody>
+      </p:sp>
+      <p:sp>
+        <p:nvSpPr>
+          <p:cNvPr id="4" name="Slide Number Placeholder 3"/>
+          <p:cNvSpPr>
+            <a:spLocks noGrp="1"/>
+          </p:cNvSpPr>
+          <p:nvPr>
+            <p:ph type="sldNum" sz="quarter" idx="10"/>
+          </p:nvPr>
+        </p:nvSpPr>
+        <p:spPr/>
+        <p:txBody>
+          <a:bodyPr/>
+          <a:lstStyle/>
+          <a:p>
+            <a:fld id="{F7021451-1387-4CA6-816F-3879F97B5CBC}" type="slidenum">
+              <a:rPr lang="en-US"/>
+              <a:t>25</a:t>
             </a:fld>
             <a:endParaRPr lang="en-US"/>
           </a:p>
@@ -4004,7 +6079,7 @@
                             <a:srgbClr val="1A1A1A"/>
                           </a:solidFill>
                         </a:rPr>
-                        <a:t>Is the tool accurate? Are the alternatives it generates actually better?</a:t>
+                        <a:t>Is the tool accurate? Are the synthesised alternatives actually better than what the user did?</a:t>
                       </a:r>
                       <a:endParaRPr lang="en-US" sz="1300" dirty="0"/>
                     </a:p>
@@ -4062,7 +6137,7 @@
                             <a:srgbClr val="555555"/>
                           </a:solidFill>
                         </a:rPr>
-                        <a:t>45 labelled injection sessions, scored against per-kind precision and recall (Slide 16).</a:t>
+                        <a:t>45 labelled injection sessions: per-kind precision and recall (Slides 16-17) plus beat/tie/lose breakdown across all 66 detected divergence points (Slide 18).</a:t>
                       </a:r>
                       <a:endParaRPr lang="en-US" sz="1300" dirty="0"/>
                     </a:p>
@@ -4180,7 +6255,7 @@
                             <a:srgbClr val="555555"/>
                           </a:solidFill>
                         </a:rPr>
-                        <a:t>Injection set + user-study rankable subset, used for the sensitivity sweep and ablation study (Slide 17).</a:t>
+                        <a:t>Sensitivity sweep + ablation, headline on the 25-session user-study rankable subset (Slides 19-20).</a:t>
                       </a:r>
                       <a:endParaRPr lang="en-US" sz="1300" dirty="0"/>
                     </a:p>
@@ -4298,7 +6373,7 @@
                             <a:srgbClr val="555555"/>
                           </a:solidFill>
                         </a:rPr>
-                        <a:t>30-session randomised user study, plus a 48-session agent extension as motivation for future work (Slide 18).</a:t>
+                        <a:t>30-session randomised user study, 5 participants split between feedback and no-feedback arms (Slide 21).</a:t>
                       </a:r>
                       <a:endParaRPr lang="en-US" sz="1300" dirty="0"/>
                     </a:p>
@@ -9939,7 +12014,7 @@
                   <a:srgbClr val="000000"/>
                 </a:solidFill>
               </a:rPr>
-              <a:t>User study: does feedback change behaviour?</a:t>
+              <a:t>Does dashboard feedback change developer behaviour?</a:t>
             </a:r>
             <a:endParaRPr lang="en-US" sz="2800" dirty="0"/>
           </a:p>
@@ -9954,7 +12029,7 @@
         <p:spPr>
           <a:xfrm>
             <a:off x="457200" y="1188720"/>
-            <a:ext cx="8229600" cy="3657600"/>
+            <a:ext cx="8229600" cy="3291840"/>
           </a:xfrm>
           <a:prstGeom prst="rect">
             <a:avLst/>
@@ -9974,14 +12049,78 @@
               <a:buChar char="•"/>
             </a:pPr>
             <a:r>
-              <a:rPr lang="en-US" sz="1600" dirty="0">
+              <a:rPr lang="en-US" sz="1500" b="1" dirty="0">
                 <a:solidFill>
                   <a:srgbClr val="000000"/>
                 </a:solidFill>
               </a:rPr>
-              <a:t>With-feedback group: 2.7 divergence points per session.</a:t>
-            </a:r>
-            <a:endParaRPr lang="en-US" sz="1600" dirty="0"/>
+              <a:t>How did we design the study?</a:t>
+            </a:r>
+            <a:endParaRPr lang="en-US" sz="1500" dirty="0"/>
+          </a:p>
+          <a:p>
+            <a:pPr lvl="1" marL="762000" indent="-381000">
+              <a:spcAft>
+                <a:spcPts val="600"/>
+              </a:spcAft>
+              <a:buSzPct val="100000"/>
+              <a:buChar char="•"/>
+            </a:pPr>
+            <a:r>
+              <a:rPr lang="en-US" sz="1500" dirty="0">
+                <a:solidFill>
+                  <a:srgbClr val="000000"/>
+                </a:solidFill>
+              </a:rPr>
+              <a:t>5 MEng Computing participants, 6 sessions each, on an order-processing codebase </a:t>
+            </a:r>
+            <a:pPr indent="0" marL="0">
+              <a:spcAft>
+                <a:spcPts val="600"/>
+              </a:spcAft>
+              <a:buNone/>
+            </a:pPr>
+            <a:r>
+              <a:rPr lang="en-US" sz="1500" dirty="0">
+                <a:solidFill>
+                  <a:srgbClr val="888888"/>
+                </a:solidFill>
+              </a:rPr>
+              <a:t>- 30 sessions total on user-study-fixture/ (separate from the labelled-injection codebase).</a:t>
+            </a:r>
+            <a:endParaRPr lang="en-US" sz="1500" dirty="0"/>
+          </a:p>
+          <a:p>
+            <a:pPr lvl="1" marL="762000" indent="-381000">
+              <a:spcAft>
+                <a:spcPts val="1800"/>
+              </a:spcAft>
+              <a:buSzPct val="100000"/>
+              <a:buChar char="•"/>
+            </a:pPr>
+            <a:r>
+              <a:rPr lang="en-US" sz="1500" dirty="0">
+                <a:solidFill>
+                  <a:srgbClr val="000000"/>
+                </a:solidFill>
+              </a:rPr>
+              <a:t>Randomised into 2 arms </a:t>
+            </a:r>
+            <a:pPr indent="0" marL="0">
+              <a:spcAft>
+                <a:spcPts val="1800"/>
+              </a:spcAft>
+              <a:buNone/>
+            </a:pPr>
+            <a:r>
+              <a:rPr lang="en-US" sz="1500" dirty="0">
+                <a:solidFill>
+                  <a:srgbClr val="888888"/>
+                </a:solidFill>
+              </a:rPr>
+              <a:t>- P1, P2, P3 see dashboard feedback between sessions; P4 and P5 don't. Same playbook, codebase, instrumentation.</a:t>
+            </a:r>
+            <a:endParaRPr lang="en-US" sz="1500" dirty="0"/>
           </a:p>
           <a:p>
             <a:pPr marL="342900" indent="-342900">
@@ -9992,17 +12131,17 @@
               <a:buChar char="•"/>
             </a:pPr>
             <a:r>
-              <a:rPr lang="en-US" sz="1600" dirty="0">
+              <a:rPr lang="en-US" sz="1500" b="1" dirty="0">
                 <a:solidFill>
                   <a:srgbClr val="000000"/>
                 </a:solidFill>
               </a:rPr>
-              <a:t>No-feedback baseline: 6.0 divergence points per session -2.2× difference.</a:t>
-            </a:r>
-            <a:endParaRPr lang="en-US" sz="1600" dirty="0"/>
-          </a:p>
-          <a:p>
-            <a:pPr marL="342900" indent="-342900">
+              <a:t>What did we measure?</a:t>
+            </a:r>
+            <a:endParaRPr lang="en-US" sz="1500" dirty="0"/>
+          </a:p>
+          <a:p>
+            <a:pPr lvl="1" marL="762000" indent="-381000">
               <a:spcAft>
                 <a:spcPts val="600"/>
               </a:spcAft>
@@ -10010,17 +12149,31 @@
               <a:buChar char="•"/>
             </a:pPr>
             <a:r>
-              <a:rPr lang="en-US" sz="1600" dirty="0">
+              <a:rPr lang="en-US" sz="1500" dirty="0">
                 <a:solidFill>
                   <a:srgbClr val="000000"/>
                 </a:solidFill>
               </a:rPr>
-              <a:t>Gain-stripped process-score slope across the 6-session arc -+4.47 per session with feedback, −0.40 per session without.</a:t>
-            </a:r>
-            <a:endParaRPr lang="en-US" sz="1600" dirty="0"/>
-          </a:p>
-          <a:p>
-            <a:pPr marL="342900" indent="-342900">
+              <a:t>Divergence-point count per session </a:t>
+            </a:r>
+            <a:pPr indent="0" marL="0">
+              <a:spcAft>
+                <a:spcPts val="600"/>
+              </a:spcAft>
+              <a:buNone/>
+            </a:pPr>
+            <a:r>
+              <a:rPr lang="en-US" sz="1500" dirty="0">
+                <a:solidFill>
+                  <a:srgbClr val="888888"/>
+                </a:solidFill>
+              </a:rPr>
+              <a:t>- does the detector still surface the same kinds of friction over time?</a:t>
+            </a:r>
+            <a:endParaRPr lang="en-US" sz="1500" dirty="0"/>
+          </a:p>
+          <a:p>
+            <a:pPr lvl="1" marL="762000" indent="-381000">
               <a:spcAft>
                 <a:spcPts val="600"/>
               </a:spcAft>
@@ -10028,14 +12181,64 @@
               <a:buChar char="•"/>
             </a:pPr>
             <a:r>
-              <a:rPr lang="en-US" sz="1600" dirty="0">
+              <a:rPr lang="en-US" sz="1500" dirty="0">
                 <a:solidFill>
                   <a:srgbClr val="000000"/>
                 </a:solidFill>
               </a:rPr>
-              <a:t>Caveat: n=3 vs n=2 is directional evidence, not a hypothesis test.</a:t>
-            </a:r>
-            <a:endParaRPr lang="en-US" sz="1600" dirty="0"/>
+              <a:t>Process score across the arc, two views </a:t>
+            </a:r>
+            <a:pPr indent="0" marL="0">
+              <a:spcAft>
+                <a:spcPts val="600"/>
+              </a:spcAft>
+              <a:buNone/>
+            </a:pPr>
+            <a:r>
+              <a:rPr lang="en-US" sz="1500" dirty="0">
+                <a:solidFill>
+                  <a:srgbClr val="888888"/>
+                </a:solidFill>
+              </a:rPr>
+              <a:t>- the production score, plus a gain-stripped variant (W_g = W_lag = 0) that isolates how the participant worked from how much cleaner the code ended up.</a:t>
+            </a:r>
+            <a:endParaRPr lang="en-US" sz="1500" dirty="0"/>
+          </a:p>
+        </p:txBody>
+      </p:sp>
+      <p:sp>
+        <p:nvSpPr>
+          <p:cNvPr id="4" name="Text 2"/>
+          <p:cNvSpPr/>
+          <p:nvPr/>
+        </p:nvSpPr>
+        <p:spPr>
+          <a:xfrm>
+            <a:off x="457200" y="4617720"/>
+            <a:ext cx="8229600" cy="274320"/>
+          </a:xfrm>
+          <a:prstGeom prst="rect">
+            <a:avLst/>
+          </a:prstGeom>
+          <a:noFill/>
+          <a:ln/>
+        </p:spPr>
+        <p:txBody>
+          <a:bodyPr wrap="square" rtlCol="0" anchor="ctr"/>
+          <a:lstStyle/>
+          <a:p>
+            <a:pPr algn="ctr" indent="0" marL="0">
+              <a:buNone/>
+            </a:pPr>
+            <a:r>
+              <a:rPr lang="en-US" sz="1100" i="1" dirty="0">
+                <a:solidFill>
+                  <a:srgbClr val="888888"/>
+                </a:solidFill>
+              </a:rPr>
+              <a:t>Random assignment, n = 3 vs n = 2. Treated as a directional finding, not a hypothesis test.</a:t>
+            </a:r>
+            <a:endParaRPr lang="en-US" sz="1100" dirty="0"/>
           </a:p>
         </p:txBody>
       </p:sp>
@@ -10050,6 +12253,1300 @@
 <file path=ppt/slides/slide22.xml><?xml version="1.0" encoding="utf-8"?>
 <p:sld xmlns:a="http://schemas.openxmlformats.org/drawingml/2006/main" xmlns:r="http://schemas.openxmlformats.org/officeDocument/2006/relationships" xmlns:p="http://schemas.openxmlformats.org/presentationml/2006/main">
   <p:cSld name="Slide 22">
+    <p:spTree>
+      <p:nvGrpSpPr>
+        <p:cNvPr id="1" name=""/>
+        <p:cNvGrpSpPr/>
+        <p:nvPr/>
+      </p:nvGrpSpPr>
+      <p:grpSpPr>
+        <a:xfrm>
+          <a:off x="0" y="0"/>
+          <a:ext cx="0" cy="0"/>
+          <a:chOff x="0" y="0"/>
+          <a:chExt cx="0" cy="0"/>
+        </a:xfrm>
+      </p:grpSpPr>
+      <p:sp>
+        <p:nvSpPr>
+          <p:cNvPr id="2" name="Text 0"/>
+          <p:cNvSpPr/>
+          <p:nvPr/>
+        </p:nvSpPr>
+        <p:spPr>
+          <a:xfrm>
+            <a:off x="457200" y="137160"/>
+            <a:ext cx="8229600" cy="502920"/>
+          </a:xfrm>
+          <a:prstGeom prst="rect">
+            <a:avLst/>
+          </a:prstGeom>
+          <a:noFill/>
+          <a:ln/>
+        </p:spPr>
+        <p:txBody>
+          <a:bodyPr wrap="square" lIns="0" tIns="0" rIns="0" bIns="0" rtlCol="0" anchor="ctr"/>
+          <a:lstStyle/>
+          <a:p>
+            <a:pPr algn="ctr" indent="0" marL="0">
+              <a:buNone/>
+            </a:pPr>
+            <a:r>
+              <a:rPr lang="en-US" sz="2400" b="1" dirty="0">
+                <a:solidFill>
+                  <a:srgbClr val="000000"/>
+                </a:solidFill>
+              </a:rPr>
+              <a:t>Fewer divergences with feedback - but the raw score is noisy</a:t>
+            </a:r>
+            <a:endParaRPr lang="en-US" sz="2400" dirty="0"/>
+          </a:p>
+        </p:txBody>
+      </p:sp>
+      <p:graphicFrame>
+        <p:nvGraphicFramePr>
+          <p:cNvPr id="3" name="Chart 0" descr=""/>
+          <p:cNvGraphicFramePr/>
+          <p:nvPr/>
+        </p:nvGraphicFramePr>
+        <p:xfrm>
+          <a:off x="274320" y="868680"/>
+          <a:ext cx="4206240" cy="3017520"/>
+        </p:xfrm>
+        <a:graphic xmlns:a="http://schemas.openxmlformats.org/drawingml/2006/main">
+          <a:graphicData uri="http://schemas.openxmlformats.org/drawingml/2006/chart">
+            <c:chart xmlns:c="http://schemas.openxmlformats.org/drawingml/2006/chart" r:id="rId1"/>
+          </a:graphicData>
+        </a:graphic>
+      </p:graphicFrame>
+      <p:graphicFrame>
+        <p:nvGraphicFramePr>
+          <p:cNvPr id="4" name="Chart 1" descr=""/>
+          <p:cNvGraphicFramePr/>
+          <p:nvPr/>
+        </p:nvGraphicFramePr>
+        <p:xfrm>
+          <a:off x="4663440" y="868680"/>
+          <a:ext cx="4206240" cy="3017520"/>
+        </p:xfrm>
+        <a:graphic xmlns:a="http://schemas.openxmlformats.org/drawingml/2006/main">
+          <a:graphicData uri="http://schemas.openxmlformats.org/drawingml/2006/chart">
+            <c:chart xmlns:c="http://schemas.openxmlformats.org/drawingml/2006/chart" r:id="rId2"/>
+          </a:graphicData>
+        </a:graphic>
+      </p:graphicFrame>
+      <p:sp>
+        <p:nvSpPr>
+          <p:cNvPr id="5" name="Text 1"/>
+          <p:cNvSpPr/>
+          <p:nvPr/>
+        </p:nvSpPr>
+        <p:spPr>
+          <a:xfrm>
+            <a:off x="457200" y="4069080"/>
+            <a:ext cx="8229600" cy="868680"/>
+          </a:xfrm>
+          <a:prstGeom prst="rect">
+            <a:avLst/>
+          </a:prstGeom>
+          <a:noFill/>
+          <a:ln/>
+        </p:spPr>
+        <p:txBody>
+          <a:bodyPr wrap="square" lIns="50800" tIns="50800" rIns="50800" bIns="50800" rtlCol="0" anchor="t"/>
+          <a:lstStyle/>
+          <a:p>
+            <a:pPr algn="ctr" indent="0" marL="0">
+              <a:buNone/>
+            </a:pPr>
+            <a:r>
+              <a:rPr lang="en-US" sz="1200" dirty="0">
+                <a:solidFill>
+                  <a:srgbClr val="000000"/>
+                </a:solidFill>
+              </a:rPr>
+              <a:t>DP rate separates clearly: </a:t>
+            </a:r>
+            <a:pPr algn="ctr" indent="0" marL="0">
+              <a:buNone/>
+            </a:pPr>
+            <a:r>
+              <a:rPr lang="en-US" sz="1200" b="1" dirty="0">
+                <a:solidFill>
+                  <a:srgbClr val="1F3F6F"/>
+                </a:solidFill>
+              </a:rPr>
+              <a:t>2.7</a:t>
+            </a:r>
+            <a:pPr algn="ctr" indent="0" marL="0">
+              <a:buNone/>
+            </a:pPr>
+            <a:r>
+              <a:rPr lang="en-US" sz="1200" dirty="0">
+                <a:solidFill>
+                  <a:srgbClr val="000000"/>
+                </a:solidFill>
+              </a:rPr>
+              <a:t> (feedback) vs </a:t>
+            </a:r>
+            <a:pPr algn="ctr" indent="0" marL="0">
+              <a:buNone/>
+            </a:pPr>
+            <a:r>
+              <a:rPr lang="en-US" sz="1200" b="1" dirty="0">
+                <a:solidFill>
+                  <a:srgbClr val="B25500"/>
+                </a:solidFill>
+              </a:rPr>
+              <a:t>6.0</a:t>
+            </a:r>
+            <a:pPr algn="ctr" indent="0" marL="0">
+              <a:spcAft>
+                <a:spcPts val="400"/>
+              </a:spcAft>
+              <a:buNone/>
+            </a:pPr>
+            <a:r>
+              <a:rPr lang="en-US" sz="1200" dirty="0">
+                <a:solidFill>
+                  <a:srgbClr val="000000"/>
+                </a:solidFill>
+              </a:rPr>
+              <a:t> DPs per session per participant - 2.2× difference.</a:t>
+            </a:r>
+            <a:endParaRPr lang="en-US" sz="1200" dirty="0"/>
+          </a:p>
+          <a:p>
+            <a:pPr algn="ctr" indent="0" marL="0">
+              <a:buNone/>
+            </a:pPr>
+            <a:r>
+              <a:rPr lang="en-US" sz="1200" dirty="0">
+                <a:solidFill>
+                  <a:srgbClr val="000000"/>
+                </a:solidFill>
+              </a:rPr>
+              <a:t>But the production-weighted score is dominated by </a:t>
+            </a:r>
+            <a:pPr algn="ctr" indent="0" marL="0">
+              <a:buNone/>
+            </a:pPr>
+            <a:r>
+              <a:rPr lang="en-US" sz="1200" i="1" dirty="0">
+                <a:solidFill>
+                  <a:srgbClr val="000000"/>
+                </a:solidFill>
+              </a:rPr>
+              <a:t>task difficulty</a:t>
+            </a:r>
+            <a:pPr algn="ctr" indent="0" marL="0">
+              <a:buNone/>
+            </a:pPr>
+            <a:r>
+              <a:rPr lang="en-US" sz="1200" dirty="0">
+                <a:solidFill>
+                  <a:srgbClr val="000000"/>
+                </a:solidFill>
+              </a:rPr>
+              <a:t> - both groups peak at S4 (a short, mechanical task) and dip together at S2/S5. The behavioural signal is buried in the cleanliness gain.</a:t>
+            </a:r>
+            <a:endParaRPr lang="en-US" sz="1200" dirty="0"/>
+          </a:p>
+        </p:txBody>
+      </p:sp>
+    </p:spTree>
+  </p:cSld>
+  <p:clrMapOvr>
+    <a:masterClrMapping/>
+  </p:clrMapOvr>
+</p:sld>
+</file>
+
+<file path=ppt/slides/slide23.xml><?xml version="1.0" encoding="utf-8"?>
+<p:sld xmlns:a="http://schemas.openxmlformats.org/drawingml/2006/main" xmlns:r="http://schemas.openxmlformats.org/officeDocument/2006/relationships" xmlns:p="http://schemas.openxmlformats.org/presentationml/2006/main">
+  <p:cSld name="Slide 23">
+    <p:spTree>
+      <p:nvGrpSpPr>
+        <p:cNvPr id="1" name=""/>
+        <p:cNvGrpSpPr/>
+        <p:nvPr/>
+      </p:nvGrpSpPr>
+      <p:grpSpPr>
+        <a:xfrm>
+          <a:off x="0" y="0"/>
+          <a:ext cx="0" cy="0"/>
+          <a:chOff x="0" y="0"/>
+          <a:chExt cx="0" cy="0"/>
+        </a:xfrm>
+      </p:grpSpPr>
+      <p:sp>
+        <p:nvSpPr>
+          <p:cNvPr id="2" name="Text 0"/>
+          <p:cNvSpPr/>
+          <p:nvPr/>
+        </p:nvSpPr>
+        <p:spPr>
+          <a:xfrm>
+            <a:off x="457200" y="137160"/>
+            <a:ext cx="8229600" cy="502920"/>
+          </a:xfrm>
+          <a:prstGeom prst="rect">
+            <a:avLst/>
+          </a:prstGeom>
+          <a:noFill/>
+          <a:ln/>
+        </p:spPr>
+        <p:txBody>
+          <a:bodyPr wrap="square" lIns="0" tIns="0" rIns="0" bIns="0" rtlCol="0" anchor="ctr"/>
+          <a:lstStyle/>
+          <a:p>
+            <a:pPr algn="ctr" indent="0" marL="0">
+              <a:buNone/>
+            </a:pPr>
+            <a:r>
+              <a:rPr lang="en-US" sz="2400" b="1" dirty="0">
+                <a:solidFill>
+                  <a:srgbClr val="000000"/>
+                </a:solidFill>
+              </a:rPr>
+              <a:t>Strip the task signal - process discipline emerges</a:t>
+            </a:r>
+            <a:endParaRPr lang="en-US" sz="2400" dirty="0"/>
+          </a:p>
+        </p:txBody>
+      </p:sp>
+      <p:graphicFrame>
+        <p:nvGraphicFramePr>
+          <p:cNvPr id="3" name="Chart 0" descr=""/>
+          <p:cNvGraphicFramePr/>
+          <p:nvPr/>
+        </p:nvGraphicFramePr>
+        <p:xfrm>
+          <a:off x="1554480" y="777240"/>
+          <a:ext cx="6035040" cy="3108960"/>
+        </p:xfrm>
+        <a:graphic xmlns:a="http://schemas.openxmlformats.org/drawingml/2006/main">
+          <a:graphicData uri="http://schemas.openxmlformats.org/drawingml/2006/chart">
+            <c:chart xmlns:c="http://schemas.openxmlformats.org/drawingml/2006/chart" r:id="rId1"/>
+          </a:graphicData>
+        </a:graphic>
+      </p:graphicFrame>
+      <p:sp>
+        <p:nvSpPr>
+          <p:cNvPr id="4" name="Text 1"/>
+          <p:cNvSpPr/>
+          <p:nvPr/>
+        </p:nvSpPr>
+        <p:spPr>
+          <a:xfrm>
+            <a:off x="457200" y="4069080"/>
+            <a:ext cx="8229600" cy="868680"/>
+          </a:xfrm>
+          <a:prstGeom prst="rect">
+            <a:avLst/>
+          </a:prstGeom>
+          <a:noFill/>
+          <a:ln/>
+        </p:spPr>
+        <p:txBody>
+          <a:bodyPr wrap="square" lIns="50800" tIns="50800" rIns="50800" bIns="50800" rtlCol="0" anchor="t"/>
+          <a:lstStyle/>
+          <a:p>
+            <a:pPr algn="ctr" indent="0" marL="0">
+              <a:buNone/>
+            </a:pPr>
+            <a:r>
+              <a:rPr lang="en-US" sz="1200" dirty="0">
+                <a:solidFill>
+                  <a:srgbClr val="000000"/>
+                </a:solidFill>
+              </a:rPr>
+              <a:t>Once cleanliness gain is removed, the score reflects </a:t>
+            </a:r>
+            <a:pPr algn="ctr" indent="0" marL="0">
+              <a:buNone/>
+            </a:pPr>
+            <a:r>
+              <a:rPr lang="en-US" sz="1200" i="1" dirty="0">
+                <a:solidFill>
+                  <a:srgbClr val="000000"/>
+                </a:solidFill>
+              </a:rPr>
+              <a:t>how disciplined the process was</a:t>
+            </a:r>
+            <a:pPr algn="ctr" indent="0" marL="0">
+              <a:buNone/>
+            </a:pPr>
+            <a:r>
+              <a:rPr lang="en-US" sz="1200" dirty="0">
+                <a:solidFill>
+                  <a:srgbClr val="000000"/>
+                </a:solidFill>
+              </a:rPr>
+              <a:t> - tests run, IDE refactorings used, commits at sensible points. The feedback group climbs </a:t>
+            </a:r>
+            <a:pPr algn="ctr" indent="0" marL="0">
+              <a:buNone/>
+            </a:pPr>
+            <a:r>
+              <a:rPr lang="en-US" sz="1200" b="1" dirty="0">
+                <a:solidFill>
+                  <a:srgbClr val="1F3F6F"/>
+                </a:solidFill>
+              </a:rPr>
+              <a:t>+22.3</a:t>
+            </a:r>
+            <a:pPr algn="ctr" indent="0" marL="0">
+              <a:buNone/>
+            </a:pPr>
+            <a:r>
+              <a:rPr lang="en-US" sz="1200" dirty="0">
+                <a:solidFill>
+                  <a:srgbClr val="000000"/>
+                </a:solidFill>
+              </a:rPr>
+              <a:t> across the arc; the baseline group moves </a:t>
+            </a:r>
+            <a:pPr algn="ctr" indent="0" marL="0">
+              <a:buNone/>
+            </a:pPr>
+            <a:r>
+              <a:rPr lang="en-US" sz="1200" b="1" dirty="0">
+                <a:solidFill>
+                  <a:srgbClr val="B25500"/>
+                </a:solidFill>
+              </a:rPr>
+              <a:t>−2.0</a:t>
+            </a:r>
+            <a:pPr algn="ctr" indent="0" marL="0">
+              <a:spcAft>
+                <a:spcPts val="600"/>
+              </a:spcAft>
+              <a:buNone/>
+            </a:pPr>
+            <a:r>
+              <a:rPr lang="en-US" sz="1200" dirty="0">
+                <a:solidFill>
+                  <a:srgbClr val="000000"/>
+                </a:solidFill>
+              </a:rPr>
+              <a:t>.</a:t>
+            </a:r>
+            <a:endParaRPr lang="en-US" sz="1200" dirty="0"/>
+          </a:p>
+          <a:p>
+            <a:pPr algn="ctr" indent="0" marL="0">
+              <a:buNone/>
+            </a:pPr>
+            <a:r>
+              <a:rPr lang="en-US" sz="1200" i="1" dirty="0">
+                <a:solidFill>
+                  <a:srgbClr val="888888"/>
+                </a:solidFill>
+              </a:rPr>
+              <a:t>n = 3 vs n = 2 - directional finding, not a hypothesis test.</a:t>
+            </a:r>
+            <a:endParaRPr lang="en-US" sz="1200" dirty="0"/>
+          </a:p>
+        </p:txBody>
+      </p:sp>
+    </p:spTree>
+  </p:cSld>
+  <p:clrMapOvr>
+    <a:masterClrMapping/>
+  </p:clrMapOvr>
+</p:sld>
+</file>
+
+<file path=ppt/slides/slide24.xml><?xml version="1.0" encoding="utf-8"?>
+<p:sld xmlns:a="http://schemas.openxmlformats.org/drawingml/2006/main" xmlns:r="http://schemas.openxmlformats.org/officeDocument/2006/relationships" xmlns:p="http://schemas.openxmlformats.org/presentationml/2006/main">
+  <p:cSld name="Slide 24">
+    <p:spTree>
+      <p:nvGrpSpPr>
+        <p:cNvPr id="1" name=""/>
+        <p:cNvGrpSpPr/>
+        <p:nvPr/>
+      </p:nvGrpSpPr>
+      <p:grpSpPr>
+        <a:xfrm>
+          <a:off x="0" y="0"/>
+          <a:ext cx="0" cy="0"/>
+          <a:chOff x="0" y="0"/>
+          <a:chExt cx="0" cy="0"/>
+        </a:xfrm>
+      </p:grpSpPr>
+      <p:sp>
+        <p:nvSpPr>
+          <p:cNvPr id="2" name="Text 0"/>
+          <p:cNvSpPr/>
+          <p:nvPr/>
+        </p:nvSpPr>
+        <p:spPr>
+          <a:xfrm>
+            <a:off x="457200" y="137160"/>
+            <a:ext cx="8229600" cy="457200"/>
+          </a:xfrm>
+          <a:prstGeom prst="rect">
+            <a:avLst/>
+          </a:prstGeom>
+          <a:noFill/>
+          <a:ln/>
+        </p:spPr>
+        <p:txBody>
+          <a:bodyPr wrap="square" lIns="0" tIns="0" rIns="0" bIns="0" rtlCol="0" anchor="ctr"/>
+          <a:lstStyle/>
+          <a:p>
+            <a:pPr algn="ctr" indent="0" marL="0">
+              <a:buNone/>
+            </a:pPr>
+            <a:r>
+              <a:rPr lang="en-US" sz="2400" b="1" dirty="0">
+                <a:solidFill>
+                  <a:srgbClr val="000000"/>
+                </a:solidFill>
+              </a:rPr>
+              <a:t>Tool doesn't transfer cleanly to agent traces</a:t>
+            </a:r>
+            <a:endParaRPr lang="en-US" sz="2400" dirty="0"/>
+          </a:p>
+        </p:txBody>
+      </p:sp>
+      <p:sp>
+        <p:nvSpPr>
+          <p:cNvPr id="3" name="Text 1"/>
+          <p:cNvSpPr/>
+          <p:nvPr/>
+        </p:nvSpPr>
+        <p:spPr>
+          <a:xfrm>
+            <a:off x="457200" y="640080"/>
+            <a:ext cx="8229600" cy="274320"/>
+          </a:xfrm>
+          <a:prstGeom prst="rect">
+            <a:avLst/>
+          </a:prstGeom>
+          <a:noFill/>
+          <a:ln/>
+        </p:spPr>
+        <p:txBody>
+          <a:bodyPr wrap="square" rtlCol="0" anchor="ctr"/>
+          <a:lstStyle/>
+          <a:p>
+            <a:pPr algn="ctr" indent="0" marL="0">
+              <a:buNone/>
+            </a:pPr>
+            <a:r>
+              <a:rPr lang="en-US" sz="1100" i="1" dirty="0">
+                <a:solidFill>
+                  <a:srgbClr val="555555"/>
+                </a:solidFill>
+              </a:rPr>
+              <a:t>48 sessions, 8 agents (Claude / GPT / Gemini × Claude Code / OpenCode / Cursor CLI), same playbook as the user study.</a:t>
+            </a:r>
+            <a:endParaRPr lang="en-US" sz="1100" dirty="0"/>
+          </a:p>
+        </p:txBody>
+      </p:sp>
+      <p:graphicFrame>
+        <p:nvGraphicFramePr>
+          <p:cNvPr id="4" name="Chart 0" descr=""/>
+          <p:cNvGraphicFramePr/>
+          <p:nvPr/>
+        </p:nvGraphicFramePr>
+        <p:xfrm>
+          <a:off x="274320" y="1051560"/>
+          <a:ext cx="4206240" cy="2697480"/>
+        </p:xfrm>
+        <a:graphic xmlns:a="http://schemas.openxmlformats.org/drawingml/2006/main">
+          <a:graphicData uri="http://schemas.openxmlformats.org/drawingml/2006/chart">
+            <c:chart xmlns:c="http://schemas.openxmlformats.org/drawingml/2006/chart" r:id="rId1"/>
+          </a:graphicData>
+        </a:graphic>
+      </p:graphicFrame>
+      <p:graphicFrame>
+        <p:nvGraphicFramePr>
+          <p:cNvPr id="25" name="Table 0"/>
+          <p:cNvGraphicFramePr>
+            <a:graphicFrameLocks noGrp="1"/>
+          </p:cNvGraphicFramePr>
+          <p:nvPr>
+            <p:extLst>
+              <p:ext uri="{D42A27DB-BD31-4B8C-83A1-F6EECF244321}">
+                <p14:modId xmlns:p14="http://schemas.microsoft.com/office/powerpoint/2010/main" val="1579011935"/>
+              </p:ext>
+            </p:extLst>
+          </p:nvPr>
+        </p:nvGraphicFramePr>
+        <p:xfrm>
+          <a:off x="4663440" y="1051560"/>
+          <a:ext cx="4251960" cy="914400"/>
+        </p:xfrm>
+        <a:graphic>
+          <a:graphicData uri="http://schemas.openxmlformats.org/drawingml/2006/table">
+            <a:tbl>
+              <a:tblPr/>
+              <a:tblGrid>
+                <a:gridCol w="1417320"/>
+                <a:gridCol w="502920"/>
+                <a:gridCol w="2331720"/>
+              </a:tblGrid>
+              <a:tr h="457200">
+                <a:tc>
+                  <a:txBody>
+                    <a:bodyPr/>
+                    <a:lstStyle/>
+                    <a:p>
+                      <a:pPr algn="ctr" indent="0" marL="0">
+                        <a:buNone/>
+                      </a:pPr>
+                      <a:r>
+                        <a:rPr lang="en-US" sz="1000" b="1" dirty="0">
+                          <a:solidFill>
+                            <a:srgbClr val="000000"/>
+                          </a:solidFill>
+                          <a:latin typeface="Calibri" pitchFamily="34" charset="0"/>
+                          <a:ea typeface="Calibri" pitchFamily="34" charset="-122"/>
+                          <a:cs typeface="Calibri" pitchFamily="34" charset="-120"/>
+                        </a:rPr>
+                        <a:t>Kind</a:t>
+                      </a:r>
+                      <a:endParaRPr lang="en-US" sz="1000" dirty="0">
+                        <a:latin typeface="Calibri" charset="0"/>
+                        <a:ea typeface="Calibri" charset="0"/>
+                        <a:cs typeface="Calibri" charset="0"/>
+                      </a:endParaRPr>
+                    </a:p>
+                  </a:txBody>
+                  <a:tcPr marL="54864" marR="54864" marT="54864" marB="54864" anchor="ctr">
+                    <a:lnL w="0" cap="flat" cmpd="sng" algn="ctr">
+                      <a:noFill/>
+                    </a:lnL>
+                    <a:lnR w="0" cap="flat" cmpd="sng" algn="ctr">
+                      <a:noFill/>
+                    </a:lnR>
+                    <a:lnT w="0" cap="flat" cmpd="sng" algn="ctr">
+                      <a:noFill/>
+                    </a:lnT>
+                    <a:lnB w="0" cap="flat" cmpd="sng" algn="ctr">
+                      <a:noFill/>
+                    </a:lnB>
+                    <a:solidFill>
+                      <a:srgbClr val="F0F0F0"/>
+                    </a:solidFill>
+                  </a:tcPr>
+                </a:tc>
+                <a:tc>
+                  <a:txBody>
+                    <a:bodyPr/>
+                    <a:lstStyle/>
+                    <a:p>
+                      <a:pPr algn="ctr" indent="0" marL="0">
+                        <a:buNone/>
+                      </a:pPr>
+                      <a:r>
+                        <a:rPr lang="en-US" sz="1000" b="1" dirty="0">
+                          <a:solidFill>
+                            <a:srgbClr val="000000"/>
+                          </a:solidFill>
+                          <a:latin typeface="Calibri" pitchFamily="34" charset="0"/>
+                          <a:ea typeface="Calibri" pitchFamily="34" charset="-122"/>
+                          <a:cs typeface="Calibri" pitchFamily="34" charset="-120"/>
+                        </a:rPr>
+                        <a:t>DPs</a:t>
+                      </a:r>
+                      <a:endParaRPr lang="en-US" sz="1000" dirty="0">
+                        <a:latin typeface="Calibri" charset="0"/>
+                        <a:ea typeface="Calibri" charset="0"/>
+                        <a:cs typeface="Calibri" charset="0"/>
+                      </a:endParaRPr>
+                    </a:p>
+                  </a:txBody>
+                  <a:tcPr marL="54864" marR="54864" marT="54864" marB="54864" anchor="ctr">
+                    <a:lnL w="0" cap="flat" cmpd="sng" algn="ctr">
+                      <a:noFill/>
+                    </a:lnL>
+                    <a:lnR w="0" cap="flat" cmpd="sng" algn="ctr">
+                      <a:noFill/>
+                    </a:lnR>
+                    <a:lnT w="0" cap="flat" cmpd="sng" algn="ctr">
+                      <a:noFill/>
+                    </a:lnT>
+                    <a:lnB w="0" cap="flat" cmpd="sng" algn="ctr">
+                      <a:noFill/>
+                    </a:lnB>
+                    <a:solidFill>
+                      <a:srgbClr val="F0F0F0"/>
+                    </a:solidFill>
+                  </a:tcPr>
+                </a:tc>
+                <a:tc>
+                  <a:txBody>
+                    <a:bodyPr/>
+                    <a:lstStyle/>
+                    <a:p>
+                      <a:pPr algn="ctr" indent="0" marL="0">
+                        <a:buNone/>
+                      </a:pPr>
+                      <a:r>
+                        <a:rPr lang="en-US" sz="1000" b="1" dirty="0">
+                          <a:solidFill>
+                            <a:srgbClr val="000000"/>
+                          </a:solidFill>
+                          <a:latin typeface="Calibri" pitchFamily="34" charset="0"/>
+                          <a:ea typeface="Calibri" pitchFamily="34" charset="-122"/>
+                          <a:cs typeface="Calibri" pitchFamily="34" charset="-120"/>
+                        </a:rPr>
+                        <a:t>Why under-fires</a:t>
+                      </a:r>
+                      <a:endParaRPr lang="en-US" sz="1000" dirty="0">
+                        <a:latin typeface="Calibri" charset="0"/>
+                        <a:ea typeface="Calibri" charset="0"/>
+                        <a:cs typeface="Calibri" charset="0"/>
+                      </a:endParaRPr>
+                    </a:p>
+                  </a:txBody>
+                  <a:tcPr marL="54864" marR="54864" marT="54864" marB="54864" anchor="ctr">
+                    <a:lnL w="0" cap="flat" cmpd="sng" algn="ctr">
+                      <a:noFill/>
+                    </a:lnL>
+                    <a:lnR w="0" cap="flat" cmpd="sng" algn="ctr">
+                      <a:noFill/>
+                    </a:lnR>
+                    <a:lnT w="0" cap="flat" cmpd="sng" algn="ctr">
+                      <a:noFill/>
+                    </a:lnT>
+                    <a:lnB w="0" cap="flat" cmpd="sng" algn="ctr">
+                      <a:noFill/>
+                    </a:lnB>
+                    <a:solidFill>
+                      <a:srgbClr val="F0F0F0"/>
+                    </a:solidFill>
+                  </a:tcPr>
+                </a:tc>
+              </a:tr>
+              <a:tr h="457200">
+                <a:tc>
+                  <a:txBody>
+                    <a:bodyPr/>
+                    <a:lstStyle/>
+                    <a:p>
+                      <a:pPr algn="l" indent="0" marL="0">
+                        <a:buNone/>
+                      </a:pPr>
+                      <a:r>
+                        <a:rPr lang="en-US" sz="1100" b="1" dirty="0">
+                          <a:solidFill>
+                            <a:srgbClr val="000000"/>
+                          </a:solidFill>
+                          <a:latin typeface="Calibri" pitchFamily="34" charset="0"/>
+                          <a:ea typeface="Calibri" pitchFamily="34" charset="-122"/>
+                          <a:cs typeface="Calibri" pitchFamily="34" charset="-120"/>
+                        </a:rPr>
+                        <a:t>Manual-Refactor</a:t>
+                      </a:r>
+                      <a:endParaRPr lang="en-US" sz="1100" dirty="0">
+                        <a:latin typeface="Calibri" charset="0"/>
+                        <a:ea typeface="Calibri" charset="0"/>
+                        <a:cs typeface="Calibri" charset="0"/>
+                      </a:endParaRPr>
+                    </a:p>
+                  </a:txBody>
+                  <a:tcPr marL="54864" marR="54864" marT="54864" marB="54864" anchor="ctr">
+                    <a:lnL w="0" cap="flat" cmpd="sng" algn="ctr">
+                      <a:noFill/>
+                    </a:lnL>
+                    <a:lnR w="0" cap="flat" cmpd="sng" algn="ctr">
+                      <a:noFill/>
+                    </a:lnR>
+                    <a:lnT w="0" cap="flat" cmpd="sng" algn="ctr">
+                      <a:noFill/>
+                    </a:lnT>
+                    <a:lnB w="0" cap="flat" cmpd="sng" algn="ctr">
+                      <a:noFill/>
+                    </a:lnB>
+                  </a:tcPr>
+                </a:tc>
+                <a:tc>
+                  <a:txBody>
+                    <a:bodyPr/>
+                    <a:lstStyle/>
+                    <a:p>
+                      <a:pPr algn="ctr" indent="0" marL="0">
+                        <a:buNone/>
+                      </a:pPr>
+                      <a:r>
+                        <a:rPr lang="en-US" sz="1600" b="1" dirty="0">
+                          <a:solidFill>
+                            <a:srgbClr val="0A7D2A"/>
+                          </a:solidFill>
+                          <a:latin typeface="Calibri" pitchFamily="34" charset="0"/>
+                          <a:ea typeface="Calibri" pitchFamily="34" charset="-122"/>
+                          <a:cs typeface="Calibri" pitchFamily="34" charset="-120"/>
+                        </a:rPr>
+                        <a:t>41</a:t>
+                      </a:r>
+                      <a:endParaRPr lang="en-US" sz="1600" dirty="0">
+                        <a:latin typeface="Calibri" charset="0"/>
+                        <a:ea typeface="Calibri" charset="0"/>
+                        <a:cs typeface="Calibri" charset="0"/>
+                      </a:endParaRPr>
+                    </a:p>
+                  </a:txBody>
+                  <a:tcPr marL="54864" marR="54864" marT="54864" marB="54864" anchor="ctr">
+                    <a:lnL w="0" cap="flat" cmpd="sng" algn="ctr">
+                      <a:noFill/>
+                    </a:lnL>
+                    <a:lnR w="0" cap="flat" cmpd="sng" algn="ctr">
+                      <a:noFill/>
+                    </a:lnR>
+                    <a:lnT w="0" cap="flat" cmpd="sng" algn="ctr">
+                      <a:noFill/>
+                    </a:lnT>
+                    <a:lnB w="0" cap="flat" cmpd="sng" algn="ctr">
+                      <a:noFill/>
+                    </a:lnB>
+                  </a:tcPr>
+                </a:tc>
+                <a:tc>
+                  <a:txBody>
+                    <a:bodyPr/>
+                    <a:lstStyle/>
+                    <a:p>
+                      <a:pPr algn="l" indent="0" marL="0">
+                        <a:buNone/>
+                      </a:pPr>
+                      <a:r>
+                        <a:rPr lang="en-US" sz="1000" dirty="0">
+                          <a:solidFill>
+                            <a:srgbClr val="555555"/>
+                          </a:solidFill>
+                          <a:latin typeface="Calibri" pitchFamily="34" charset="0"/>
+                          <a:ea typeface="Calibri" pitchFamily="34" charset="-122"/>
+                          <a:cs typeface="Calibri" pitchFamily="34" charset="-120"/>
+                        </a:rPr>
+                        <a:t>text edits, not IDE menu</a:t>
+                      </a:r>
+                      <a:endParaRPr lang="en-US" sz="1000" dirty="0">
+                        <a:latin typeface="Calibri" charset="0"/>
+                        <a:ea typeface="Calibri" charset="0"/>
+                        <a:cs typeface="Calibri" charset="0"/>
+                      </a:endParaRPr>
+                    </a:p>
+                  </a:txBody>
+                  <a:tcPr marL="54864" marR="54864" marT="54864" marB="54864" anchor="ctr">
+                    <a:lnL w="0" cap="flat" cmpd="sng" algn="ctr">
+                      <a:noFill/>
+                    </a:lnL>
+                    <a:lnR w="0" cap="flat" cmpd="sng" algn="ctr">
+                      <a:noFill/>
+                    </a:lnR>
+                    <a:lnT w="0" cap="flat" cmpd="sng" algn="ctr">
+                      <a:noFill/>
+                    </a:lnT>
+                    <a:lnB w="0" cap="flat" cmpd="sng" algn="ctr">
+                      <a:noFill/>
+                    </a:lnB>
+                  </a:tcPr>
+                </a:tc>
+              </a:tr>
+              <a:tr h="457200">
+                <a:tc>
+                  <a:txBody>
+                    <a:bodyPr/>
+                    <a:lstStyle/>
+                    <a:p>
+                      <a:pPr algn="l" indent="0" marL="0">
+                        <a:buNone/>
+                      </a:pPr>
+                      <a:r>
+                        <a:rPr lang="en-US" sz="1100" b="1" dirty="0">
+                          <a:solidFill>
+                            <a:srgbClr val="000000"/>
+                          </a:solidFill>
+                          <a:latin typeface="Calibri" pitchFamily="34" charset="0"/>
+                          <a:ea typeface="Calibri" pitchFamily="34" charset="-122"/>
+                          <a:cs typeface="Calibri" pitchFamily="34" charset="-120"/>
+                        </a:rPr>
+                        <a:t>Hygiene</a:t>
+                      </a:r>
+                      <a:endParaRPr lang="en-US" sz="1100" dirty="0">
+                        <a:latin typeface="Calibri" charset="0"/>
+                        <a:ea typeface="Calibri" charset="0"/>
+                        <a:cs typeface="Calibri" charset="0"/>
+                      </a:endParaRPr>
+                    </a:p>
+                  </a:txBody>
+                  <a:tcPr marL="54864" marR="54864" marT="54864" marB="54864" anchor="ctr">
+                    <a:lnL w="0" cap="flat" cmpd="sng" algn="ctr">
+                      <a:noFill/>
+                    </a:lnL>
+                    <a:lnR w="0" cap="flat" cmpd="sng" algn="ctr">
+                      <a:noFill/>
+                    </a:lnR>
+                    <a:lnT w="0" cap="flat" cmpd="sng" algn="ctr">
+                      <a:noFill/>
+                    </a:lnT>
+                    <a:lnB w="0" cap="flat" cmpd="sng" algn="ctr">
+                      <a:noFill/>
+                    </a:lnB>
+                  </a:tcPr>
+                </a:tc>
+                <a:tc>
+                  <a:txBody>
+                    <a:bodyPr/>
+                    <a:lstStyle/>
+                    <a:p>
+                      <a:pPr algn="ctr" indent="0" marL="0">
+                        <a:buNone/>
+                      </a:pPr>
+                      <a:r>
+                        <a:rPr lang="en-US" sz="1400" dirty="0">
+                          <a:solidFill>
+                            <a:srgbClr val="999999"/>
+                          </a:solidFill>
+                          <a:latin typeface="Calibri" pitchFamily="34" charset="0"/>
+                          <a:ea typeface="Calibri" pitchFamily="34" charset="-122"/>
+                          <a:cs typeface="Calibri" pitchFamily="34" charset="-120"/>
+                        </a:rPr>
+                        <a:t>0</a:t>
+                      </a:r>
+                      <a:endParaRPr lang="en-US" sz="1400" dirty="0">
+                        <a:latin typeface="Calibri" charset="0"/>
+                        <a:ea typeface="Calibri" charset="0"/>
+                        <a:cs typeface="Calibri" charset="0"/>
+                      </a:endParaRPr>
+                    </a:p>
+                  </a:txBody>
+                  <a:tcPr marL="54864" marR="54864" marT="54864" marB="54864" anchor="ctr">
+                    <a:lnL w="0" cap="flat" cmpd="sng" algn="ctr">
+                      <a:noFill/>
+                    </a:lnL>
+                    <a:lnR w="0" cap="flat" cmpd="sng" algn="ctr">
+                      <a:noFill/>
+                    </a:lnR>
+                    <a:lnT w="0" cap="flat" cmpd="sng" algn="ctr">
+                      <a:noFill/>
+                    </a:lnT>
+                    <a:lnB w="0" cap="flat" cmpd="sng" algn="ctr">
+                      <a:noFill/>
+                    </a:lnB>
+                  </a:tcPr>
+                </a:tc>
+                <a:tc>
+                  <a:txBody>
+                    <a:bodyPr/>
+                    <a:lstStyle/>
+                    <a:p>
+                      <a:pPr algn="l" indent="0" marL="0">
+                        <a:buNone/>
+                      </a:pPr>
+                      <a:r>
+                        <a:rPr lang="en-US" sz="1000" dirty="0">
+                          <a:solidFill>
+                            <a:srgbClr val="555555"/>
+                          </a:solidFill>
+                          <a:latin typeface="Calibri" pitchFamily="34" charset="0"/>
+                          <a:ea typeface="Calibri" pitchFamily="34" charset="-122"/>
+                          <a:cs typeface="Calibri" pitchFamily="34" charset="-120"/>
+                        </a:rPr>
+                        <a:t>batched commits don't trip threshold</a:t>
+                      </a:r>
+                      <a:endParaRPr lang="en-US" sz="1000" dirty="0">
+                        <a:latin typeface="Calibri" charset="0"/>
+                        <a:ea typeface="Calibri" charset="0"/>
+                        <a:cs typeface="Calibri" charset="0"/>
+                      </a:endParaRPr>
+                    </a:p>
+                  </a:txBody>
+                  <a:tcPr marL="54864" marR="54864" marT="54864" marB="54864" anchor="ctr">
+                    <a:lnL w="0" cap="flat" cmpd="sng" algn="ctr">
+                      <a:noFill/>
+                    </a:lnL>
+                    <a:lnR w="0" cap="flat" cmpd="sng" algn="ctr">
+                      <a:noFill/>
+                    </a:lnR>
+                    <a:lnT w="0" cap="flat" cmpd="sng" algn="ctr">
+                      <a:noFill/>
+                    </a:lnT>
+                    <a:lnB w="0" cap="flat" cmpd="sng" algn="ctr">
+                      <a:noFill/>
+                    </a:lnB>
+                  </a:tcPr>
+                </a:tc>
+              </a:tr>
+              <a:tr h="457200">
+                <a:tc>
+                  <a:txBody>
+                    <a:bodyPr/>
+                    <a:lstStyle/>
+                    <a:p>
+                      <a:pPr algn="l" indent="0" marL="0">
+                        <a:buNone/>
+                      </a:pPr>
+                      <a:r>
+                        <a:rPr lang="en-US" sz="1100" b="1" dirty="0">
+                          <a:solidFill>
+                            <a:srgbClr val="000000"/>
+                          </a:solidFill>
+                          <a:latin typeface="Calibri" pitchFamily="34" charset="0"/>
+                          <a:ea typeface="Calibri" pitchFamily="34" charset="-122"/>
+                          <a:cs typeface="Calibri" pitchFamily="34" charset="-120"/>
+                        </a:rPr>
+                        <a:t>Rework</a:t>
+                      </a:r>
+                      <a:endParaRPr lang="en-US" sz="1100" dirty="0">
+                        <a:latin typeface="Calibri" charset="0"/>
+                        <a:ea typeface="Calibri" charset="0"/>
+                        <a:cs typeface="Calibri" charset="0"/>
+                      </a:endParaRPr>
+                    </a:p>
+                  </a:txBody>
+                  <a:tcPr marL="54864" marR="54864" marT="54864" marB="54864" anchor="ctr">
+                    <a:lnL w="0" cap="flat" cmpd="sng" algn="ctr">
+                      <a:noFill/>
+                    </a:lnL>
+                    <a:lnR w="0" cap="flat" cmpd="sng" algn="ctr">
+                      <a:noFill/>
+                    </a:lnR>
+                    <a:lnT w="0" cap="flat" cmpd="sng" algn="ctr">
+                      <a:noFill/>
+                    </a:lnT>
+                    <a:lnB w="0" cap="flat" cmpd="sng" algn="ctr">
+                      <a:noFill/>
+                    </a:lnB>
+                  </a:tcPr>
+                </a:tc>
+                <a:tc>
+                  <a:txBody>
+                    <a:bodyPr/>
+                    <a:lstStyle/>
+                    <a:p>
+                      <a:pPr algn="ctr" indent="0" marL="0">
+                        <a:buNone/>
+                      </a:pPr>
+                      <a:r>
+                        <a:rPr lang="en-US" sz="1400" dirty="0">
+                          <a:solidFill>
+                            <a:srgbClr val="999999"/>
+                          </a:solidFill>
+                          <a:latin typeface="Calibri" pitchFamily="34" charset="0"/>
+                          <a:ea typeface="Calibri" pitchFamily="34" charset="-122"/>
+                          <a:cs typeface="Calibri" pitchFamily="34" charset="-120"/>
+                        </a:rPr>
+                        <a:t>0</a:t>
+                      </a:r>
+                      <a:endParaRPr lang="en-US" sz="1400" dirty="0">
+                        <a:latin typeface="Calibri" charset="0"/>
+                        <a:ea typeface="Calibri" charset="0"/>
+                        <a:cs typeface="Calibri" charset="0"/>
+                      </a:endParaRPr>
+                    </a:p>
+                  </a:txBody>
+                  <a:tcPr marL="54864" marR="54864" marT="54864" marB="54864" anchor="ctr">
+                    <a:lnL w="0" cap="flat" cmpd="sng" algn="ctr">
+                      <a:noFill/>
+                    </a:lnL>
+                    <a:lnR w="0" cap="flat" cmpd="sng" algn="ctr">
+                      <a:noFill/>
+                    </a:lnR>
+                    <a:lnT w="0" cap="flat" cmpd="sng" algn="ctr">
+                      <a:noFill/>
+                    </a:lnT>
+                    <a:lnB w="0" cap="flat" cmpd="sng" algn="ctr">
+                      <a:noFill/>
+                    </a:lnB>
+                  </a:tcPr>
+                </a:tc>
+                <a:tc>
+                  <a:txBody>
+                    <a:bodyPr/>
+                    <a:lstStyle/>
+                    <a:p>
+                      <a:pPr algn="l" indent="0" marL="0">
+                        <a:buNone/>
+                      </a:pPr>
+                      <a:r>
+                        <a:rPr lang="en-US" sz="1000" dirty="0">
+                          <a:solidFill>
+                            <a:srgbClr val="555555"/>
+                          </a:solidFill>
+                          <a:latin typeface="Calibri" pitchFamily="34" charset="0"/>
+                          <a:ea typeface="Calibri" pitchFamily="34" charset="-122"/>
+                          <a:cs typeface="Calibri" pitchFamily="34" charset="-120"/>
+                        </a:rPr>
+                        <a:t>edit bursts collapse to one</a:t>
+                      </a:r>
+                      <a:endParaRPr lang="en-US" sz="1000" dirty="0">
+                        <a:latin typeface="Calibri" charset="0"/>
+                        <a:ea typeface="Calibri" charset="0"/>
+                        <a:cs typeface="Calibri" charset="0"/>
+                      </a:endParaRPr>
+                    </a:p>
+                  </a:txBody>
+                  <a:tcPr marL="54864" marR="54864" marT="54864" marB="54864" anchor="ctr">
+                    <a:lnL w="0" cap="flat" cmpd="sng" algn="ctr">
+                      <a:noFill/>
+                    </a:lnL>
+                    <a:lnR w="0" cap="flat" cmpd="sng" algn="ctr">
+                      <a:noFill/>
+                    </a:lnR>
+                    <a:lnT w="0" cap="flat" cmpd="sng" algn="ctr">
+                      <a:noFill/>
+                    </a:lnT>
+                    <a:lnB w="0" cap="flat" cmpd="sng" algn="ctr">
+                      <a:noFill/>
+                    </a:lnB>
+                  </a:tcPr>
+                </a:tc>
+              </a:tr>
+              <a:tr h="457200">
+                <a:tc>
+                  <a:txBody>
+                    <a:bodyPr/>
+                    <a:lstStyle/>
+                    <a:p>
+                      <a:pPr algn="l" indent="0" marL="0">
+                        <a:buNone/>
+                      </a:pPr>
+                      <a:r>
+                        <a:rPr lang="en-US" sz="1100" b="1" dirty="0">
+                          <a:solidFill>
+                            <a:srgbClr val="000000"/>
+                          </a:solidFill>
+                          <a:latin typeface="Calibri" pitchFamily="34" charset="0"/>
+                          <a:ea typeface="Calibri" pitchFamily="34" charset="-122"/>
+                          <a:cs typeface="Calibri" pitchFamily="34" charset="-120"/>
+                        </a:rPr>
+                        <a:t>Ordering</a:t>
+                      </a:r>
+                      <a:endParaRPr lang="en-US" sz="1100" dirty="0">
+                        <a:latin typeface="Calibri" charset="0"/>
+                        <a:ea typeface="Calibri" charset="0"/>
+                        <a:cs typeface="Calibri" charset="0"/>
+                      </a:endParaRPr>
+                    </a:p>
+                  </a:txBody>
+                  <a:tcPr marL="54864" marR="54864" marT="54864" marB="54864" anchor="ctr">
+                    <a:lnL w="0" cap="flat" cmpd="sng" algn="ctr">
+                      <a:noFill/>
+                    </a:lnL>
+                    <a:lnR w="0" cap="flat" cmpd="sng" algn="ctr">
+                      <a:noFill/>
+                    </a:lnR>
+                    <a:lnT w="0" cap="flat" cmpd="sng" algn="ctr">
+                      <a:noFill/>
+                    </a:lnT>
+                    <a:lnB w="0" cap="flat" cmpd="sng" algn="ctr">
+                      <a:noFill/>
+                    </a:lnB>
+                  </a:tcPr>
+                </a:tc>
+                <a:tc>
+                  <a:txBody>
+                    <a:bodyPr/>
+                    <a:lstStyle/>
+                    <a:p>
+                      <a:pPr algn="ctr" indent="0" marL="0">
+                        <a:buNone/>
+                      </a:pPr>
+                      <a:r>
+                        <a:rPr lang="en-US" sz="1400" dirty="0">
+                          <a:solidFill>
+                            <a:srgbClr val="999999"/>
+                          </a:solidFill>
+                          <a:latin typeface="Calibri" pitchFamily="34" charset="0"/>
+                          <a:ea typeface="Calibri" pitchFamily="34" charset="-122"/>
+                          <a:cs typeface="Calibri" pitchFamily="34" charset="-120"/>
+                        </a:rPr>
+                        <a:t>1</a:t>
+                      </a:r>
+                      <a:endParaRPr lang="en-US" sz="1400" dirty="0">
+                        <a:latin typeface="Calibri" charset="0"/>
+                        <a:ea typeface="Calibri" charset="0"/>
+                        <a:cs typeface="Calibri" charset="0"/>
+                      </a:endParaRPr>
+                    </a:p>
+                  </a:txBody>
+                  <a:tcPr marL="54864" marR="54864" marT="54864" marB="54864" anchor="ctr">
+                    <a:lnL w="0" cap="flat" cmpd="sng" algn="ctr">
+                      <a:noFill/>
+                    </a:lnL>
+                    <a:lnR w="0" cap="flat" cmpd="sng" algn="ctr">
+                      <a:noFill/>
+                    </a:lnR>
+                    <a:lnT w="0" cap="flat" cmpd="sng" algn="ctr">
+                      <a:noFill/>
+                    </a:lnT>
+                    <a:lnB w="0" cap="flat" cmpd="sng" algn="ctr">
+                      <a:noFill/>
+                    </a:lnB>
+                  </a:tcPr>
+                </a:tc>
+                <a:tc>
+                  <a:txBody>
+                    <a:bodyPr/>
+                    <a:lstStyle/>
+                    <a:p>
+                      <a:pPr algn="l" indent="0" marL="0">
+                        <a:buNone/>
+                      </a:pPr>
+                      <a:r>
+                        <a:rPr lang="en-US" sz="1000" dirty="0">
+                          <a:solidFill>
+                            <a:srgbClr val="555555"/>
+                          </a:solidFill>
+                          <a:latin typeface="Calibri" pitchFamily="34" charset="0"/>
+                          <a:ea typeface="Calibri" pitchFamily="34" charset="-122"/>
+                          <a:cs typeface="Calibri" pitchFamily="34" charset="-120"/>
+                        </a:rPr>
+                        <a:t>same burst-collapse</a:t>
+                      </a:r>
+                      <a:endParaRPr lang="en-US" sz="1000" dirty="0">
+                        <a:latin typeface="Calibri" charset="0"/>
+                        <a:ea typeface="Calibri" charset="0"/>
+                        <a:cs typeface="Calibri" charset="0"/>
+                      </a:endParaRPr>
+                    </a:p>
+                  </a:txBody>
+                  <a:tcPr marL="54864" marR="54864" marT="54864" marB="54864" anchor="ctr">
+                    <a:lnL w="0" cap="flat" cmpd="sng" algn="ctr">
+                      <a:noFill/>
+                    </a:lnL>
+                    <a:lnR w="0" cap="flat" cmpd="sng" algn="ctr">
+                      <a:noFill/>
+                    </a:lnR>
+                    <a:lnT w="0" cap="flat" cmpd="sng" algn="ctr">
+                      <a:noFill/>
+                    </a:lnT>
+                    <a:lnB w="0" cap="flat" cmpd="sng" algn="ctr">
+                      <a:noFill/>
+                    </a:lnB>
+                  </a:tcPr>
+                </a:tc>
+              </a:tr>
+            </a:tbl>
+          </a:graphicData>
+        </a:graphic>
+      </p:graphicFrame>
+      <p:sp>
+        <p:nvSpPr>
+          <p:cNvPr id="6" name="Text 2"/>
+          <p:cNvSpPr/>
+          <p:nvPr/>
+        </p:nvSpPr>
+        <p:spPr>
+          <a:xfrm>
+            <a:off x="457200" y="3931920"/>
+            <a:ext cx="8229600" cy="1097280"/>
+          </a:xfrm>
+          <a:prstGeom prst="rect">
+            <a:avLst/>
+          </a:prstGeom>
+          <a:noFill/>
+          <a:ln/>
+        </p:spPr>
+        <p:txBody>
+          <a:bodyPr wrap="square" lIns="50800" tIns="50800" rIns="50800" bIns="50800" rtlCol="0" anchor="t"/>
+          <a:lstStyle/>
+          <a:p>
+            <a:pPr algn="ctr" indent="0" marL="0">
+              <a:buNone/>
+            </a:pPr>
+            <a:r>
+              <a:rPr lang="en-US" sz="1200" b="1" dirty="0">
+                <a:solidFill>
+                  <a:srgbClr val="000000"/>
+                </a:solidFill>
+              </a:rPr>
+              <a:t>Score is blind to the difference: </a:t>
+            </a:r>
+            <a:pPr algn="ctr" indent="0" marL="0">
+              <a:buNone/>
+            </a:pPr>
+            <a:r>
+              <a:rPr lang="en-US" sz="1200" dirty="0">
+                <a:solidFill>
+                  <a:srgbClr val="000000"/>
+                </a:solidFill>
+              </a:rPr>
+              <a:t>feedback ΔJ </a:t>
+            </a:r>
+            <a:pPr algn="ctr" indent="0" marL="0">
+              <a:buNone/>
+            </a:pPr>
+            <a:r>
+              <a:rPr lang="en-US" sz="1200" b="1" dirty="0">
+                <a:solidFill>
+                  <a:srgbClr val="1F3F6F"/>
+                </a:solidFill>
+              </a:rPr>
+              <a:t>+3.0</a:t>
+            </a:r>
+            <a:pPr algn="ctr" indent="0" marL="0">
+              <a:buNone/>
+            </a:pPr>
+            <a:r>
+              <a:rPr lang="en-US" sz="1200" dirty="0">
+                <a:solidFill>
+                  <a:srgbClr val="000000"/>
+                </a:solidFill>
+              </a:rPr>
+              <a:t> vs baseline </a:t>
+            </a:r>
+            <a:pPr algn="ctr" indent="0" marL="0">
+              <a:buNone/>
+            </a:pPr>
+            <a:r>
+              <a:rPr lang="en-US" sz="1200" b="1" dirty="0">
+                <a:solidFill>
+                  <a:srgbClr val="B25500"/>
+                </a:solidFill>
+              </a:rPr>
+              <a:t>+6.5</a:t>
+            </a:r>
+            <a:pPr algn="ctr" indent="0" marL="0">
+              <a:spcAft>
+                <a:spcPts val="600"/>
+              </a:spcAft>
+              <a:buNone/>
+            </a:pPr>
+            <a:r>
+              <a:rPr lang="en-US" sz="1200" dirty="0">
+                <a:solidFill>
+                  <a:srgbClr val="000000"/>
+                </a:solidFill>
+              </a:rPr>
+              <a:t>. Yet 5 of 6 agents wrote explicit "I'll do X next session" plans citing prior warnings - the detectors just can't see those changes happen.</a:t>
+            </a:r>
+            <a:endParaRPr lang="en-US" sz="1200" dirty="0"/>
+          </a:p>
+          <a:p>
+            <a:pPr algn="ctr" indent="0" marL="0">
+              <a:buNone/>
+            </a:pPr>
+            <a:r>
+              <a:rPr lang="en-US" sz="1200" i="1" dirty="0">
+                <a:solidFill>
+                  <a:srgbClr val="888888"/>
+                </a:solidFill>
+              </a:rPr>
+              <a:t>Scope limit by design - adapting detectors for agent traces is future work.</a:t>
+            </a:r>
+            <a:endParaRPr lang="en-US" sz="1200" dirty="0"/>
+          </a:p>
+        </p:txBody>
+      </p:sp>
+    </p:spTree>
+  </p:cSld>
+  <p:clrMapOvr>
+    <a:masterClrMapping/>
+  </p:clrMapOvr>
+</p:sld>
+</file>
+
+<file path=ppt/slides/slide25.xml><?xml version="1.0" encoding="utf-8"?>
+<p:sld xmlns:a="http://schemas.openxmlformats.org/drawingml/2006/main" xmlns:r="http://schemas.openxmlformats.org/officeDocument/2006/relationships" xmlns:p="http://schemas.openxmlformats.org/presentationml/2006/main">
+  <p:cSld name="Slide 25">
     <p:spTree>
       <p:nvGrpSpPr>
         <p:cNvPr id="1" name=""/>

</xml_diff>

<commit_message>
feat: minor changes to start of pres
</commit_message>
<xml_diff>
--- a/presentation/slides.pptx
+++ b/presentation/slides.pptx
@@ -13458,7 +13458,7 @@
         <p:spPr>
           <a:xfrm>
             <a:off x="457200" y="1645920"/>
-            <a:ext cx="8229600" cy="3291840"/>
+            <a:ext cx="8229600" cy="2926080"/>
           </a:xfrm>
           <a:prstGeom prst="rect">
             <a:avLst/>
@@ -13478,7 +13478,7 @@
               <a:buChar char="•"/>
             </a:pPr>
             <a:r>
-              <a:rPr lang="en-US" sz="1300" b="1" dirty="0">
+              <a:rPr lang="en-US" sz="1400" b="1" dirty="0">
                 <a:solidFill>
                   <a:srgbClr val="000000"/>
                 </a:solidFill>
@@ -13492,12 +13492,12 @@
               <a:buNone/>
             </a:pPr>
             <a:r>
-              <a:rPr lang="en-US" sz="1300" dirty="0">
+              <a:rPr lang="en-US" sz="1400" dirty="0">
                 <a:solidFill>
                   <a:srgbClr val="000000"/>
                 </a:solidFill>
               </a:rPr>
-              <a:t>- one number per trajectory so sessions can be compared. </a:t>
+              <a:t>- one number per trajectory so sessions can be compared.</a:t>
             </a:r>
             <a:pPr indent="0" marL="0">
               <a:spcAft>
@@ -13506,14 +13506,14 @@
               <a:buNone/>
             </a:pPr>
             <a:r>
-              <a:rPr lang="en-US" sz="1300" dirty="0">
+              <a:rPr lang="en-US" sz="1400" dirty="0">
                 <a:solidFill>
                   <a:srgbClr val="888888"/>
                 </a:solidFill>
               </a:rPr>
-              <a:t>Builds on composite quality models (Quamoco, QMOOD), adapted from snapshot- to trajectory-level.</a:t>
-            </a:r>
-            <a:endParaRPr lang="en-US" sz="1300" dirty="0"/>
+              <a:t> [1]</a:t>
+            </a:r>
+            <a:endParaRPr lang="en-US" sz="1400" dirty="0"/>
           </a:p>
           <a:p>
             <a:pPr marL="342900" indent="-342900">
@@ -13524,7 +13524,7 @@
               <a:buChar char="•"/>
             </a:pPr>
             <a:r>
-              <a:rPr lang="en-US" sz="1300" b="1" dirty="0">
+              <a:rPr lang="en-US" sz="1400" b="1" dirty="0">
                 <a:solidFill>
                   <a:srgbClr val="000000"/>
                 </a:solidFill>
@@ -13538,12 +13538,12 @@
               <a:buNone/>
             </a:pPr>
             <a:r>
-              <a:rPr lang="en-US" sz="1300" dirty="0">
+              <a:rPr lang="en-US" sz="1400" dirty="0">
                 <a:solidFill>
                   <a:srgbClr val="000000"/>
                 </a:solidFill>
               </a:rPr>
-              <a:t>- zero extra developer effort to use the tool. </a:t>
+              <a:t>- zero extra developer effort to use the tool.</a:t>
             </a:r>
             <a:pPr indent="0" marL="0">
               <a:spcAft>
@@ -13552,14 +13552,14 @@
               <a:buNone/>
             </a:pPr>
             <a:r>
-              <a:rPr lang="en-US" sz="1300" dirty="0">
+              <a:rPr lang="en-US" sz="1400" dirty="0">
                 <a:solidFill>
                   <a:srgbClr val="888888"/>
                 </a:solidFill>
               </a:rPr>
-              <a:t>IDE-event logging is a known-feasible approach (Damevski et al., CodeWatcher).</a:t>
-            </a:r>
-            <a:endParaRPr lang="en-US" sz="1300" dirty="0"/>
+              <a:t> [2]</a:t>
+            </a:r>
+            <a:endParaRPr lang="en-US" sz="1400" dirty="0"/>
           </a:p>
           <a:p>
             <a:pPr marL="342900" indent="-342900">
@@ -13570,7 +13570,7 @@
               <a:buChar char="•"/>
             </a:pPr>
             <a:r>
-              <a:rPr lang="en-US" sz="1300" b="1" dirty="0">
+              <a:rPr lang="en-US" sz="1400" b="1" dirty="0">
                 <a:solidFill>
                   <a:srgbClr val="000000"/>
                 </a:solidFill>
@@ -13584,12 +13584,12 @@
               <a:buNone/>
             </a:pPr>
             <a:r>
-              <a:rPr lang="en-US" sz="1300" dirty="0">
+              <a:rPr lang="en-US" sz="1400" dirty="0">
                 <a:solidFill>
                   <a:srgbClr val="000000"/>
                 </a:solidFill>
               </a:rPr>
-              <a:t>- point to a specific moment AND a "what you could have done instead" alternative. </a:t>
+              <a:t>- point to a specific moment AND a "what you could have done instead" alternative.</a:t>
             </a:r>
             <a:pPr indent="0" marL="0">
               <a:spcAft>
@@ -13598,14 +13598,14 @@
               <a:buNone/>
             </a:pPr>
             <a:r>
-              <a:rPr lang="en-US" sz="1300" dirty="0">
+              <a:rPr lang="en-US" sz="1400" dirty="0">
                 <a:solidFill>
                   <a:srgbClr val="888888"/>
                 </a:solidFill>
               </a:rPr>
-              <a:t>Inverts prior refactoring recommenders (ReSynth, Refactoring Navigator, search-based refactoring): the synthesised sequence becomes the comparison point against an observed trace.</a:t>
-            </a:r>
-            <a:endParaRPr lang="en-US" sz="1300" dirty="0"/>
+              <a:t> [3]</a:t>
+            </a:r>
+            <a:endParaRPr lang="en-US" sz="1400" dirty="0"/>
           </a:p>
           <a:p>
             <a:pPr marL="342900" indent="-342900">
@@ -13616,7 +13616,7 @@
               <a:buChar char="•"/>
             </a:pPr>
             <a:r>
-              <a:rPr lang="en-US" sz="1300" b="1" dirty="0">
+              <a:rPr lang="en-US" sz="1400" b="1" dirty="0">
                 <a:solidFill>
                   <a:srgbClr val="000000"/>
                 </a:solidFill>
@@ -13630,14 +13630,72 @@
               <a:buNone/>
             </a:pPr>
             <a:r>
-              <a:rPr lang="en-US" sz="1300" dirty="0">
+              <a:rPr lang="en-US" sz="1400" dirty="0">
                 <a:solidFill>
                   <a:srgbClr val="000000"/>
                 </a:solidFill>
               </a:rPr>
               <a:t>- the state-action space over a real codebase is too large to enumerate, so we must find efficient methods of identifying "better" alternatives.</a:t>
             </a:r>
-            <a:endParaRPr lang="en-US" sz="1300" dirty="0"/>
+            <a:endParaRPr lang="en-US" sz="1400" dirty="0"/>
+          </a:p>
+        </p:txBody>
+      </p:sp>
+      <p:sp>
+        <p:nvSpPr>
+          <p:cNvPr id="5" name="Text 3"/>
+          <p:cNvSpPr/>
+          <p:nvPr/>
+        </p:nvSpPr>
+        <p:spPr>
+          <a:xfrm>
+            <a:off x="457200" y="4663440"/>
+            <a:ext cx="8229600" cy="411480"/>
+          </a:xfrm>
+          <a:prstGeom prst="rect">
+            <a:avLst/>
+          </a:prstGeom>
+          <a:noFill/>
+          <a:ln/>
+        </p:spPr>
+        <p:txBody>
+          <a:bodyPr wrap="square" lIns="0" tIns="0" rIns="0" bIns="0" rtlCol="0" anchor="t"/>
+          <a:lstStyle/>
+          <a:p>
+            <a:pPr algn="l" indent="0" marL="0">
+              <a:buNone/>
+            </a:pPr>
+            <a:r>
+              <a:rPr lang="en-US" sz="900" i="1" dirty="0">
+                <a:solidFill>
+                  <a:srgbClr val="888888"/>
+                </a:solidFill>
+              </a:rPr>
+              <a:t>[1] Composite quality models (Quamoco, QMOOD), adapted from snapshot- to trajectory-level.   </a:t>
+            </a:r>
+            <a:pPr algn="l" indent="0" marL="0">
+              <a:buNone/>
+            </a:pPr>
+            <a:r>
+              <a:rPr lang="en-US" sz="900" i="1" dirty="0">
+                <a:solidFill>
+                  <a:srgbClr val="888888"/>
+                </a:solidFill>
+              </a:rPr>
+              <a:t>[2] IDE-event logging (Damevski et al., CodeWatcher).   </a:t>
+            </a:r>
+            <a:pPr algn="l" indent="0" marL="0">
+              <a:buNone/>
+            </a:pPr>
+            <a:r>
+              <a:rPr lang="en-US" sz="900" i="1" dirty="0">
+                <a:solidFill>
+                  <a:srgbClr val="888888"/>
+                </a:solidFill>
+              </a:rPr>
+              <a:t>[3] Inverts prior refactoring recommenders (ReSynth, Refactoring Navigator, search-based refactoring).</a:t>
+            </a:r>
+            <a:endParaRPr lang="en-US" sz="900" dirty="0"/>
           </a:p>
         </p:txBody>
       </p:sp>
@@ -14374,217 +14432,6 @@
         </p:nvSpPr>
         <p:spPr>
           <a:xfrm>
-            <a:off x="457200" y="274320"/>
-            <a:ext cx="8229600" cy="640080"/>
-          </a:xfrm>
-          <a:prstGeom prst="rect">
-            <a:avLst/>
-          </a:prstGeom>
-          <a:noFill/>
-          <a:ln/>
-        </p:spPr>
-        <p:txBody>
-          <a:bodyPr wrap="square" lIns="0" tIns="0" rIns="0" bIns="0" rtlCol="0" anchor="ctr"/>
-          <a:lstStyle/>
-          <a:p>
-            <a:pPr indent="0" marL="0">
-              <a:buNone/>
-            </a:pPr>
-            <a:r>
-              <a:rPr lang="en-US" sz="2800" b="1" dirty="0">
-                <a:solidFill>
-                  <a:srgbClr val="000000"/>
-                </a:solidFill>
-              </a:rPr>
-              <a:t>Four kinds of divergence</a:t>
-            </a:r>
-            <a:endParaRPr lang="en-US" sz="2800" dirty="0"/>
-          </a:p>
-        </p:txBody>
-      </p:sp>
-      <p:sp>
-        <p:nvSpPr>
-          <p:cNvPr id="3" name="Text 1"/>
-          <p:cNvSpPr/>
-          <p:nvPr/>
-        </p:nvSpPr>
-        <p:spPr>
-          <a:xfrm>
-            <a:off x="457200" y="1371600"/>
-            <a:ext cx="8229600" cy="3200400"/>
-          </a:xfrm>
-          <a:prstGeom prst="rect">
-            <a:avLst/>
-          </a:prstGeom>
-          <a:noFill/>
-          <a:ln/>
-        </p:spPr>
-        <p:txBody>
-          <a:bodyPr wrap="square" rtlCol="0" anchor="t"/>
-          <a:lstStyle/>
-          <a:p>
-            <a:pPr marL="342900" indent="-342900">
-              <a:spcAft>
-                <a:spcPts val="1000"/>
-              </a:spcAft>
-              <a:buSzPct val="100000"/>
-              <a:buChar char="•"/>
-            </a:pPr>
-            <a:r>
-              <a:rPr lang="en-US" sz="1800" dirty="0">
-                <a:solidFill>
-                  <a:srgbClr val="000000"/>
-                </a:solidFill>
-              </a:rPr>
-              <a:t>Manual-Refactor </a:t>
-            </a:r>
-            <a:pPr indent="0" marL="0">
-              <a:spcAft>
-                <a:spcPts val="1000"/>
-              </a:spcAft>
-              <a:buNone/>
-            </a:pPr>
-            <a:r>
-              <a:rPr lang="en-US" sz="1800" dirty="0">
-                <a:solidFill>
-                  <a:srgbClr val="888888"/>
-                </a:solidFill>
-              </a:rPr>
-              <a:t>- unnecessary risk (hand-edit when the IDE could have safely done it).</a:t>
-            </a:r>
-            <a:endParaRPr lang="en-US" sz="1800" dirty="0"/>
-          </a:p>
-          <a:p>
-            <a:pPr marL="342900" indent="-342900">
-              <a:spcAft>
-                <a:spcPts val="1000"/>
-              </a:spcAft>
-              <a:buSzPct val="100000"/>
-              <a:buChar char="•"/>
-            </a:pPr>
-            <a:r>
-              <a:rPr lang="en-US" sz="1800" dirty="0">
-                <a:solidFill>
-                  <a:srgbClr val="000000"/>
-                </a:solidFill>
-              </a:rPr>
-              <a:t>Ordering </a:t>
-            </a:r>
-            <a:pPr indent="0" marL="0">
-              <a:spcAft>
-                <a:spcPts val="1000"/>
-              </a:spcAft>
-              <a:buNone/>
-            </a:pPr>
-            <a:r>
-              <a:rPr lang="en-US" sz="1800" dirty="0">
-                <a:solidFill>
-                  <a:srgbClr val="888888"/>
-                </a:solidFill>
-              </a:rPr>
-              <a:t>- right refactorings, wrong sequence.</a:t>
-            </a:r>
-            <a:endParaRPr lang="en-US" sz="1800" dirty="0"/>
-          </a:p>
-          <a:p>
-            <a:pPr marL="342900" indent="-342900">
-              <a:spcAft>
-                <a:spcPts val="1000"/>
-              </a:spcAft>
-              <a:buSzPct val="100000"/>
-              <a:buChar char="•"/>
-            </a:pPr>
-            <a:r>
-              <a:rPr lang="en-US" sz="1800" dirty="0">
-                <a:solidFill>
-                  <a:srgbClr val="000000"/>
-                </a:solidFill>
-              </a:rPr>
-              <a:t>Rework </a:t>
-            </a:r>
-            <a:pPr indent="0" marL="0">
-              <a:spcAft>
-                <a:spcPts val="1000"/>
-              </a:spcAft>
-              <a:buNone/>
-            </a:pPr>
-            <a:r>
-              <a:rPr lang="en-US" sz="1800" dirty="0">
-                <a:solidFill>
-                  <a:srgbClr val="888888"/>
-                </a:solidFill>
-              </a:rPr>
-              <a:t>- unnecessary churn (added then removed).</a:t>
-            </a:r>
-            <a:endParaRPr lang="en-US" sz="1800" dirty="0"/>
-          </a:p>
-          <a:p>
-            <a:pPr marL="342900" indent="-342900">
-              <a:spcAft>
-                <a:spcPts val="1000"/>
-              </a:spcAft>
-              <a:buSzPct val="100000"/>
-              <a:buChar char="•"/>
-            </a:pPr>
-            <a:r>
-              <a:rPr lang="en-US" sz="1800" dirty="0">
-                <a:solidFill>
-                  <a:srgbClr val="000000"/>
-                </a:solidFill>
-              </a:rPr>
-              <a:t>Hygiene </a:t>
-            </a:r>
-            <a:pPr indent="0" marL="0">
-              <a:spcAft>
-                <a:spcPts val="1000"/>
-              </a:spcAft>
-              <a:buNone/>
-            </a:pPr>
-            <a:r>
-              <a:rPr lang="en-US" sz="1800" dirty="0">
-                <a:solidFill>
-                  <a:srgbClr val="888888"/>
-                </a:solidFill>
-              </a:rPr>
-              <a:t>- missing safety checkpoints (no tests, no commits).</a:t>
-            </a:r>
-            <a:endParaRPr lang="en-US" sz="1800" dirty="0"/>
-          </a:p>
-        </p:txBody>
-      </p:sp>
-    </p:spTree>
-  </p:cSld>
-  <p:clrMapOvr>
-    <a:masterClrMapping/>
-  </p:clrMapOvr>
-</p:sld>
-</file>
-
-<file path=ppt/slides/slide8.xml><?xml version="1.0" encoding="utf-8"?>
-<p:sld xmlns:a="http://schemas.openxmlformats.org/drawingml/2006/main" xmlns:r="http://schemas.openxmlformats.org/officeDocument/2006/relationships" xmlns:p="http://schemas.openxmlformats.org/presentationml/2006/main">
-  <p:cSld name="Slide 8">
-    <p:spTree>
-      <p:nvGrpSpPr>
-        <p:cNvPr id="1" name=""/>
-        <p:cNvGrpSpPr/>
-        <p:nvPr/>
-      </p:nvGrpSpPr>
-      <p:grpSpPr>
-        <a:xfrm>
-          <a:off x="0" y="0"/>
-          <a:ext cx="0" cy="0"/>
-          <a:chOff x="0" y="0"/>
-          <a:chExt cx="0" cy="0"/>
-        </a:xfrm>
-      </p:grpSpPr>
-      <p:sp>
-        <p:nvSpPr>
-          <p:cNvPr id="2" name="Text 0"/>
-          <p:cNvSpPr/>
-          <p:nvPr/>
-        </p:nvSpPr>
-        <p:spPr>
-          <a:xfrm>
             <a:off x="457200" y="137160"/>
             <a:ext cx="8229600" cy="640080"/>
           </a:xfrm>
@@ -14695,7 +14542,7 @@
       </p:sp>
       <p:graphicFrame>
         <p:nvGraphicFramePr>
-          <p:cNvPr id="9" name="Table 0"/>
+          <p:cNvPr id="8" name="Table 0"/>
           <p:cNvGraphicFramePr>
             <a:graphicFrameLocks noGrp="1"/>
           </p:cNvGraphicFramePr>
@@ -15546,6 +15393,217 @@
 </p:sld>
 </file>
 
+<file path=ppt/slides/slide8.xml><?xml version="1.0" encoding="utf-8"?>
+<p:sld xmlns:a="http://schemas.openxmlformats.org/drawingml/2006/main" xmlns:r="http://schemas.openxmlformats.org/officeDocument/2006/relationships" xmlns:p="http://schemas.openxmlformats.org/presentationml/2006/main">
+  <p:cSld name="Slide 8">
+    <p:spTree>
+      <p:nvGrpSpPr>
+        <p:cNvPr id="1" name=""/>
+        <p:cNvGrpSpPr/>
+        <p:nvPr/>
+      </p:nvGrpSpPr>
+      <p:grpSpPr>
+        <a:xfrm>
+          <a:off x="0" y="0"/>
+          <a:ext cx="0" cy="0"/>
+          <a:chOff x="0" y="0"/>
+          <a:chExt cx="0" cy="0"/>
+        </a:xfrm>
+      </p:grpSpPr>
+      <p:sp>
+        <p:nvSpPr>
+          <p:cNvPr id="2" name="Text 0"/>
+          <p:cNvSpPr/>
+          <p:nvPr/>
+        </p:nvSpPr>
+        <p:spPr>
+          <a:xfrm>
+            <a:off x="457200" y="274320"/>
+            <a:ext cx="8229600" cy="640080"/>
+          </a:xfrm>
+          <a:prstGeom prst="rect">
+            <a:avLst/>
+          </a:prstGeom>
+          <a:noFill/>
+          <a:ln/>
+        </p:spPr>
+        <p:txBody>
+          <a:bodyPr wrap="square" lIns="0" tIns="0" rIns="0" bIns="0" rtlCol="0" anchor="ctr"/>
+          <a:lstStyle/>
+          <a:p>
+            <a:pPr indent="0" marL="0">
+              <a:buNone/>
+            </a:pPr>
+            <a:r>
+              <a:rPr lang="en-US" sz="2800" b="1" dirty="0">
+                <a:solidFill>
+                  <a:srgbClr val="000000"/>
+                </a:solidFill>
+              </a:rPr>
+              <a:t>Four kinds of divergence</a:t>
+            </a:r>
+            <a:endParaRPr lang="en-US" sz="2800" dirty="0"/>
+          </a:p>
+        </p:txBody>
+      </p:sp>
+      <p:sp>
+        <p:nvSpPr>
+          <p:cNvPr id="3" name="Text 1"/>
+          <p:cNvSpPr/>
+          <p:nvPr/>
+        </p:nvSpPr>
+        <p:spPr>
+          <a:xfrm>
+            <a:off x="457200" y="1371600"/>
+            <a:ext cx="8229600" cy="3200400"/>
+          </a:xfrm>
+          <a:prstGeom prst="rect">
+            <a:avLst/>
+          </a:prstGeom>
+          <a:noFill/>
+          <a:ln/>
+        </p:spPr>
+        <p:txBody>
+          <a:bodyPr wrap="square" rtlCol="0" anchor="t"/>
+          <a:lstStyle/>
+          <a:p>
+            <a:pPr marL="342900" indent="-342900">
+              <a:spcAft>
+                <a:spcPts val="1000"/>
+              </a:spcAft>
+              <a:buSzPct val="100000"/>
+              <a:buChar char="•"/>
+            </a:pPr>
+            <a:r>
+              <a:rPr lang="en-US" sz="1800" dirty="0">
+                <a:solidFill>
+                  <a:srgbClr val="000000"/>
+                </a:solidFill>
+              </a:rPr>
+              <a:t>Manual-Refactor </a:t>
+            </a:r>
+            <a:pPr indent="0" marL="0">
+              <a:spcAft>
+                <a:spcPts val="1000"/>
+              </a:spcAft>
+              <a:buNone/>
+            </a:pPr>
+            <a:r>
+              <a:rPr lang="en-US" sz="1800" dirty="0">
+                <a:solidFill>
+                  <a:srgbClr val="888888"/>
+                </a:solidFill>
+              </a:rPr>
+              <a:t>- unnecessary risk (hand-edit when the IDE could have safely done it).</a:t>
+            </a:r>
+            <a:endParaRPr lang="en-US" sz="1800" dirty="0"/>
+          </a:p>
+          <a:p>
+            <a:pPr marL="342900" indent="-342900">
+              <a:spcAft>
+                <a:spcPts val="1000"/>
+              </a:spcAft>
+              <a:buSzPct val="100000"/>
+              <a:buChar char="•"/>
+            </a:pPr>
+            <a:r>
+              <a:rPr lang="en-US" sz="1800" dirty="0">
+                <a:solidFill>
+                  <a:srgbClr val="000000"/>
+                </a:solidFill>
+              </a:rPr>
+              <a:t>Ordering </a:t>
+            </a:r>
+            <a:pPr indent="0" marL="0">
+              <a:spcAft>
+                <a:spcPts val="1000"/>
+              </a:spcAft>
+              <a:buNone/>
+            </a:pPr>
+            <a:r>
+              <a:rPr lang="en-US" sz="1800" dirty="0">
+                <a:solidFill>
+                  <a:srgbClr val="888888"/>
+                </a:solidFill>
+              </a:rPr>
+              <a:t>- right refactorings, wrong sequence.</a:t>
+            </a:r>
+            <a:endParaRPr lang="en-US" sz="1800" dirty="0"/>
+          </a:p>
+          <a:p>
+            <a:pPr marL="342900" indent="-342900">
+              <a:spcAft>
+                <a:spcPts val="1000"/>
+              </a:spcAft>
+              <a:buSzPct val="100000"/>
+              <a:buChar char="•"/>
+            </a:pPr>
+            <a:r>
+              <a:rPr lang="en-US" sz="1800" dirty="0">
+                <a:solidFill>
+                  <a:srgbClr val="000000"/>
+                </a:solidFill>
+              </a:rPr>
+              <a:t>Rework </a:t>
+            </a:r>
+            <a:pPr indent="0" marL="0">
+              <a:spcAft>
+                <a:spcPts val="1000"/>
+              </a:spcAft>
+              <a:buNone/>
+            </a:pPr>
+            <a:r>
+              <a:rPr lang="en-US" sz="1800" dirty="0">
+                <a:solidFill>
+                  <a:srgbClr val="888888"/>
+                </a:solidFill>
+              </a:rPr>
+              <a:t>- unnecessary churn (added then removed).</a:t>
+            </a:r>
+            <a:endParaRPr lang="en-US" sz="1800" dirty="0"/>
+          </a:p>
+          <a:p>
+            <a:pPr marL="342900" indent="-342900">
+              <a:spcAft>
+                <a:spcPts val="1000"/>
+              </a:spcAft>
+              <a:buSzPct val="100000"/>
+              <a:buChar char="•"/>
+            </a:pPr>
+            <a:r>
+              <a:rPr lang="en-US" sz="1800" dirty="0">
+                <a:solidFill>
+                  <a:srgbClr val="000000"/>
+                </a:solidFill>
+              </a:rPr>
+              <a:t>Hygiene </a:t>
+            </a:r>
+            <a:pPr indent="0" marL="0">
+              <a:spcAft>
+                <a:spcPts val="1000"/>
+              </a:spcAft>
+              <a:buNone/>
+            </a:pPr>
+            <a:r>
+              <a:rPr lang="en-US" sz="1800" dirty="0">
+                <a:solidFill>
+                  <a:srgbClr val="888888"/>
+                </a:solidFill>
+              </a:rPr>
+              <a:t>- missing safety checkpoints (no tests, no commits).</a:t>
+            </a:r>
+            <a:endParaRPr lang="en-US" sz="1800" dirty="0"/>
+          </a:p>
+        </p:txBody>
+      </p:sp>
+    </p:spTree>
+  </p:cSld>
+  <p:clrMapOvr>
+    <a:masterClrMapping/>
+  </p:clrMapOvr>
+</p:sld>
+</file>
+
 <file path=ppt/slides/slide9.xml><?xml version="1.0" encoding="utf-8"?>
 <p:sld xmlns:a="http://schemas.openxmlformats.org/drawingml/2006/main" xmlns:r="http://schemas.openxmlformats.org/officeDocument/2006/relationships" xmlns:p="http://schemas.openxmlformats.org/presentationml/2006/main">
   <p:cSld name="Slide 9">

</xml_diff>

<commit_message>
feat: add user quotes for divergence + alter the title page
</commit_message>
<xml_diff>
--- a/presentation/slides.pptx
+++ b/presentation/slides.pptx
@@ -5087,8 +5087,8 @@
         </p:nvSpPr>
         <p:spPr>
           <a:xfrm>
-            <a:off x="457200" y="1188720"/>
-            <a:ext cx="8229600" cy="1463040"/>
+            <a:off x="457200" y="1234440"/>
+            <a:ext cx="8229600" cy="365760"/>
           </a:xfrm>
           <a:prstGeom prst="rect">
             <a:avLst/>
@@ -5104,28 +5104,14 @@
               <a:buNone/>
             </a:pPr>
             <a:r>
-              <a:rPr lang="en-US" sz="3200" b="1" dirty="0">
-                <a:solidFill>
-                  <a:srgbClr val="000000"/>
-                </a:solidFill>
-              </a:rPr>
-              <a:t>Beyond Before-and-After</a:t>
-            </a:r>
-            <a:endParaRPr lang="en-US" sz="3200" dirty="0"/>
-          </a:p>
-          <a:p>
-            <a:pPr algn="ctr" indent="0" marL="0">
-              <a:buNone/>
-            </a:pPr>
-            <a:r>
-              <a:rPr lang="en-US" sz="3200" b="1" dirty="0">
-                <a:solidFill>
-                  <a:srgbClr val="000000"/>
-                </a:solidFill>
-              </a:rPr>
-              <a:t>Process-Quality Evaluation of Refactoring Sessions</a:t>
-            </a:r>
-            <a:endParaRPr lang="en-US" sz="3200" dirty="0"/>
+              <a:rPr lang="en-US" sz="1800" i="1" dirty="0">
+                <a:solidFill>
+                  <a:srgbClr val="555555"/>
+                </a:solidFill>
+              </a:rPr>
+              <a:t>Beyond Before-and-After:</a:t>
+            </a:r>
+            <a:endParaRPr lang="en-US" sz="1800" dirty="0"/>
           </a:p>
         </p:txBody>
       </p:sp>
@@ -5137,7 +5123,7 @@
         </p:nvSpPr>
         <p:spPr>
           <a:xfrm>
-            <a:off x="457200" y="2834640"/>
+            <a:off x="457200" y="1783080"/>
             <a:ext cx="8229600" cy="822960"/>
           </a:xfrm>
           <a:prstGeom prst="rect">
@@ -5147,6 +5133,42 @@
           <a:ln/>
         </p:spPr>
         <p:txBody>
+          <a:bodyPr wrap="square" lIns="0" tIns="0" rIns="0" bIns="0" rtlCol="0" anchor="ctr"/>
+          <a:lstStyle/>
+          <a:p>
+            <a:pPr algn="ctr" indent="0" marL="0">
+              <a:buNone/>
+            </a:pPr>
+            <a:r>
+              <a:rPr lang="en-US" sz="3200" b="1" dirty="0">
+                <a:solidFill>
+                  <a:srgbClr val="000000"/>
+                </a:solidFill>
+              </a:rPr>
+              <a:t>Process-Quality Evaluation of Refactoring Sessions</a:t>
+            </a:r>
+            <a:endParaRPr lang="en-US" sz="3200" dirty="0"/>
+          </a:p>
+        </p:txBody>
+      </p:sp>
+      <p:sp>
+        <p:nvSpPr>
+          <p:cNvPr id="4" name="Text 2"/>
+          <p:cNvSpPr/>
+          <p:nvPr/>
+        </p:nvSpPr>
+        <p:spPr>
+          <a:xfrm>
+            <a:off x="457200" y="2788920"/>
+            <a:ext cx="8229600" cy="822960"/>
+          </a:xfrm>
+          <a:prstGeom prst="rect">
+            <a:avLst/>
+          </a:prstGeom>
+          <a:noFill/>
+          <a:ln/>
+        </p:spPr>
+        <p:txBody>
           <a:bodyPr wrap="square" rtlCol="0" anchor="ctr"/>
           <a:lstStyle/>
           <a:p>
@@ -5167,7 +5189,7 @@
       </p:sp>
       <p:sp>
         <p:nvSpPr>
-          <p:cNvPr id="4" name="Text 2"/>
+          <p:cNvPr id="5" name="Text 3"/>
           <p:cNvSpPr/>
           <p:nvPr/>
         </p:nvSpPr>
@@ -5203,7 +5225,7 @@
       </p:sp>
       <p:sp>
         <p:nvSpPr>
-          <p:cNvPr id="5" name="Text 3"/>
+          <p:cNvPr id="6" name="Text 4"/>
           <p:cNvSpPr/>
           <p:nvPr/>
         </p:nvSpPr>
@@ -5231,7 +5253,7 @@
                   <a:srgbClr val="777777"/>
                 </a:solidFill>
               </a:rPr>
-              <a:t>Supervisor: [Robert Chatley]  ·  Second marker: [Cristian Cadar]</a:t>
+              <a:t>Supervisor: Dr Robert Chatley  ·  Second marker: Dr Cristian Cadar</a:t>
             </a:r>
             <a:endParaRPr lang="en-US" sz="1200" dirty="0"/>
           </a:p>
@@ -5271,7 +5293,7 @@
         <p:spPr>
           <a:xfrm>
             <a:off x="457200" y="274320"/>
-            <a:ext cx="8229600" cy="640080"/>
+            <a:ext cx="5760720" cy="640080"/>
           </a:xfrm>
           <a:prstGeom prst="rect">
             <a:avLst/>
@@ -5287,14 +5309,14 @@
               <a:buNone/>
             </a:pPr>
             <a:r>
-              <a:rPr lang="en-US" sz="2800" b="1" dirty="0">
+              <a:rPr lang="en-US" sz="2400" b="1" dirty="0">
                 <a:solidFill>
                   <a:srgbClr val="000000"/>
                 </a:solidFill>
               </a:rPr>
               <a:t>Manual-Refactor: detect + synthesise</a:t>
             </a:r>
-            <a:endParaRPr lang="en-US" sz="2800" dirty="0"/>
+            <a:endParaRPr lang="en-US" sz="2400" dirty="0"/>
           </a:p>
         </p:txBody>
       </p:sp>
@@ -5414,9 +5436,64 @@
           </a:p>
         </p:txBody>
       </p:sp>
+      <p:sp>
+        <p:nvSpPr>
+          <p:cNvPr id="4" name="Text 2"/>
+          <p:cNvSpPr/>
+          <p:nvPr/>
+        </p:nvSpPr>
+        <p:spPr>
+          <a:xfrm>
+            <a:off x="6446520" y="274320"/>
+            <a:ext cx="2560320" cy="640080"/>
+          </a:xfrm>
+          <a:prstGeom prst="rect">
+            <a:avLst/>
+          </a:prstGeom>
+          <a:solidFill>
+            <a:srgbClr val="F5F5F5"/>
+          </a:solidFill>
+          <a:ln/>
+        </p:spPr>
+        <p:txBody>
+          <a:bodyPr wrap="square" lIns="38100" tIns="38100" rIns="38100" bIns="38100" rtlCol="0" anchor="t"/>
+          <a:lstStyle/>
+          <a:p>
+            <a:pPr indent="0" marL="0">
+              <a:spcAft>
+                <a:spcPts val="200"/>
+              </a:spcAft>
+              <a:buNone/>
+            </a:pPr>
+            <a:r>
+              <a:rPr lang="en-US" sz="1100" i="1" dirty="0">
+                <a:solidFill>
+                  <a:srgbClr val="333333"/>
+                </a:solidFill>
+              </a:rPr>
+              <a:t>“ Very actionable - at the start I didn't know most IntelliJ actions. ”</a:t>
+            </a:r>
+            <a:endParaRPr lang="en-US" sz="1100" dirty="0"/>
+          </a:p>
+          <a:p>
+            <a:pPr indent="0" marL="0">
+              <a:buNone/>
+            </a:pPr>
+            <a:r>
+              <a:rPr lang="en-US" sz="1100" i="1" dirty="0">
+                <a:solidFill>
+                  <a:srgbClr val="888888"/>
+                </a:solidFill>
+              </a:rPr>
+              <a:t>— P2</a:t>
+            </a:r>
+            <a:endParaRPr lang="en-US" sz="1100" dirty="0"/>
+          </a:p>
+        </p:txBody>
+      </p:sp>
       <p:pic>
         <p:nvPicPr>
-          <p:cNvPr id="4" name="Image 0" descr="images/manual-refactor.png">    </p:cNvPr>
+          <p:cNvPr id="5" name="Image 0" descr="images/manual-refactor.png">    </p:cNvPr>
           <p:cNvPicPr>
             <a:picLocks noChangeAspect="1"/>
           </p:cNvPicPr>
@@ -5472,7 +5549,7 @@
         <p:spPr>
           <a:xfrm>
             <a:off x="457200" y="274320"/>
-            <a:ext cx="8229600" cy="640080"/>
+            <a:ext cx="5760720" cy="640080"/>
           </a:xfrm>
           <a:prstGeom prst="rect">
             <a:avLst/>
@@ -5488,14 +5565,14 @@
               <a:buNone/>
             </a:pPr>
             <a:r>
-              <a:rPr lang="en-US" sz="2800" b="1" dirty="0">
+              <a:rPr lang="en-US" sz="2400" b="1" dirty="0">
                 <a:solidFill>
                   <a:srgbClr val="000000"/>
                 </a:solidFill>
               </a:rPr>
               <a:t>Ordering: detect + synthesise</a:t>
             </a:r>
-            <a:endParaRPr lang="en-US" sz="2800" dirty="0"/>
+            <a:endParaRPr lang="en-US" sz="2400" dirty="0"/>
           </a:p>
         </p:txBody>
       </p:sp>
@@ -5615,9 +5692,64 @@
           </a:p>
         </p:txBody>
       </p:sp>
+      <p:sp>
+        <p:nvSpPr>
+          <p:cNvPr id="4" name="Text 2"/>
+          <p:cNvSpPr/>
+          <p:nvPr/>
+        </p:nvSpPr>
+        <p:spPr>
+          <a:xfrm>
+            <a:off x="6446520" y="274320"/>
+            <a:ext cx="2560320" cy="640080"/>
+          </a:xfrm>
+          <a:prstGeom prst="rect">
+            <a:avLst/>
+          </a:prstGeom>
+          <a:solidFill>
+            <a:srgbClr val="F5F5F5"/>
+          </a:solidFill>
+          <a:ln/>
+        </p:spPr>
+        <p:txBody>
+          <a:bodyPr wrap="square" lIns="38100" tIns="38100" rIns="38100" bIns="38100" rtlCol="0" anchor="t"/>
+          <a:lstStyle/>
+          <a:p>
+            <a:pPr indent="0" marL="0">
+              <a:spcAft>
+                <a:spcPts val="200"/>
+              </a:spcAft>
+              <a:buNone/>
+            </a:pPr>
+            <a:r>
+              <a:rPr lang="en-US" sz="1100" i="1" dirty="0">
+                <a:solidFill>
+                  <a:srgbClr val="333333"/>
+                </a:solidFill>
+              </a:rPr>
+              <a:t>“ How can you actually apply that in the future without knowing beforehand? ”</a:t>
+            </a:r>
+            <a:endParaRPr lang="en-US" sz="1100" dirty="0"/>
+          </a:p>
+          <a:p>
+            <a:pPr indent="0" marL="0">
+              <a:buNone/>
+            </a:pPr>
+            <a:r>
+              <a:rPr lang="en-US" sz="1100" i="1" dirty="0">
+                <a:solidFill>
+                  <a:srgbClr val="888888"/>
+                </a:solidFill>
+              </a:rPr>
+              <a:t>— P2</a:t>
+            </a:r>
+            <a:endParaRPr lang="en-US" sz="1100" dirty="0"/>
+          </a:p>
+        </p:txBody>
+      </p:sp>
       <p:pic>
         <p:nvPicPr>
-          <p:cNvPr id="4" name="Image 0" descr="images/reorder-synthesis.png">    </p:cNvPr>
+          <p:cNvPr id="5" name="Image 0" descr="images/reorder-synthesis.png">    </p:cNvPr>
           <p:cNvPicPr>
             <a:picLocks noChangeAspect="1"/>
           </p:cNvPicPr>
@@ -5673,7 +5805,7 @@
         <p:spPr>
           <a:xfrm>
             <a:off x="457200" y="274320"/>
-            <a:ext cx="8229600" cy="640080"/>
+            <a:ext cx="5760720" cy="640080"/>
           </a:xfrm>
           <a:prstGeom prst="rect">
             <a:avLst/>
@@ -5689,14 +5821,14 @@
               <a:buNone/>
             </a:pPr>
             <a:r>
-              <a:rPr lang="en-US" sz="2800" b="1" dirty="0">
+              <a:rPr lang="en-US" sz="2400" b="1" dirty="0">
                 <a:solidFill>
                   <a:srgbClr val="000000"/>
                 </a:solidFill>
               </a:rPr>
               <a:t>Rework: detect + synthesise</a:t>
             </a:r>
-            <a:endParaRPr lang="en-US" sz="2800" dirty="0"/>
+            <a:endParaRPr lang="en-US" sz="2400" dirty="0"/>
           </a:p>
         </p:txBody>
       </p:sp>
@@ -5797,9 +5929,64 @@
           </a:p>
         </p:txBody>
       </p:sp>
+      <p:sp>
+        <p:nvSpPr>
+          <p:cNvPr id="4" name="Text 2"/>
+          <p:cNvSpPr/>
+          <p:nvPr/>
+        </p:nvSpPr>
+        <p:spPr>
+          <a:xfrm>
+            <a:off x="6446520" y="274320"/>
+            <a:ext cx="2560320" cy="640080"/>
+          </a:xfrm>
+          <a:prstGeom prst="rect">
+            <a:avLst/>
+          </a:prstGeom>
+          <a:solidFill>
+            <a:srgbClr val="F5F5F5"/>
+          </a:solidFill>
+          <a:ln/>
+        </p:spPr>
+        <p:txBody>
+          <a:bodyPr wrap="square" lIns="38100" tIns="38100" rIns="38100" bIns="38100" rtlCol="0" anchor="t"/>
+          <a:lstStyle/>
+          <a:p>
+            <a:pPr indent="0" marL="0">
+              <a:spcAft>
+                <a:spcPts val="200"/>
+              </a:spcAft>
+              <a:buNone/>
+            </a:pPr>
+            <a:r>
+              <a:rPr lang="en-US" sz="1100" i="1" dirty="0">
+                <a:solidFill>
+                  <a:srgbClr val="333333"/>
+                </a:solidFill>
+              </a:rPr>
+              <a:t>“ Over-penalised undos + redos. ”</a:t>
+            </a:r>
+            <a:endParaRPr lang="en-US" sz="1100" dirty="0"/>
+          </a:p>
+          <a:p>
+            <a:pPr indent="0" marL="0">
+              <a:buNone/>
+            </a:pPr>
+            <a:r>
+              <a:rPr lang="en-US" sz="1100" i="1" dirty="0">
+                <a:solidFill>
+                  <a:srgbClr val="888888"/>
+                </a:solidFill>
+              </a:rPr>
+              <a:t>— P1</a:t>
+            </a:r>
+            <a:endParaRPr lang="en-US" sz="1100" dirty="0"/>
+          </a:p>
+        </p:txBody>
+      </p:sp>
       <p:pic>
         <p:nvPicPr>
-          <p:cNvPr id="4" name="Image 0" descr="images/rework.png">    </p:cNvPr>
+          <p:cNvPr id="5" name="Image 0" descr="images/rework.png">    </p:cNvPr>
           <p:cNvPicPr>
             <a:picLocks noChangeAspect="1"/>
           </p:cNvPicPr>
@@ -5855,7 +6042,7 @@
         <p:spPr>
           <a:xfrm>
             <a:off x="457200" y="274320"/>
-            <a:ext cx="8229600" cy="640080"/>
+            <a:ext cx="5760720" cy="640080"/>
           </a:xfrm>
           <a:prstGeom prst="rect">
             <a:avLst/>
@@ -5871,14 +6058,14 @@
               <a:buNone/>
             </a:pPr>
             <a:r>
-              <a:rPr lang="en-US" sz="2800" b="1" dirty="0">
+              <a:rPr lang="en-US" sz="2400" b="1" dirty="0">
                 <a:solidFill>
                   <a:srgbClr val="000000"/>
                 </a:solidFill>
               </a:rPr>
               <a:t>Hygiene: detect + synthesise</a:t>
             </a:r>
-            <a:endParaRPr lang="en-US" sz="2800" dirty="0"/>
+            <a:endParaRPr lang="en-US" sz="2400" dirty="0"/>
           </a:p>
         </p:txBody>
       </p:sp>
@@ -6013,6 +6200,61 @@
               <a:t>Very cheap to compute.</a:t>
             </a:r>
             <a:endParaRPr lang="en-US" sz="1400" dirty="0"/>
+          </a:p>
+        </p:txBody>
+      </p:sp>
+      <p:sp>
+        <p:nvSpPr>
+          <p:cNvPr id="4" name="Text 2"/>
+          <p:cNvSpPr/>
+          <p:nvPr/>
+        </p:nvSpPr>
+        <p:spPr>
+          <a:xfrm>
+            <a:off x="6446520" y="274320"/>
+            <a:ext cx="2560320" cy="640080"/>
+          </a:xfrm>
+          <a:prstGeom prst="rect">
+            <a:avLst/>
+          </a:prstGeom>
+          <a:solidFill>
+            <a:srgbClr val="F5F5F5"/>
+          </a:solidFill>
+          <a:ln/>
+        </p:spPr>
+        <p:txBody>
+          <a:bodyPr wrap="square" lIns="38100" tIns="38100" rIns="38100" bIns="38100" rtlCol="0" anchor="t"/>
+          <a:lstStyle/>
+          <a:p>
+            <a:pPr indent="0" marL="0">
+              <a:spcAft>
+                <a:spcPts val="200"/>
+              </a:spcAft>
+              <a:buNone/>
+            </a:pPr>
+            <a:r>
+              <a:rPr lang="en-US" sz="1100" i="1" dirty="0">
+                <a:solidFill>
+                  <a:srgbClr val="333333"/>
+                </a:solidFill>
+              </a:rPr>
+              <a:t>“ The most actionable kind - committing more frequently in particular. ”</a:t>
+            </a:r>
+            <a:endParaRPr lang="en-US" sz="1100" dirty="0"/>
+          </a:p>
+          <a:p>
+            <a:pPr indent="0" marL="0">
+              <a:buNone/>
+            </a:pPr>
+            <a:r>
+              <a:rPr lang="en-US" sz="1100" i="1" dirty="0">
+                <a:solidFill>
+                  <a:srgbClr val="888888"/>
+                </a:solidFill>
+              </a:rPr>
+              <a:t>— P1</a:t>
+            </a:r>
+            <a:endParaRPr lang="en-US" sz="1100" dirty="0"/>
           </a:p>
         </p:txBody>
       </p:sp>
@@ -6077,514 +6319,182 @@
           </a:p>
         </p:txBody>
       </p:sp>
-      <p:graphicFrame>
-        <p:nvGraphicFramePr>
-          <p:cNvPr id="15" name="Table 0"/>
-          <p:cNvGraphicFramePr>
-            <a:graphicFrameLocks noGrp="1"/>
-          </p:cNvGraphicFramePr>
-          <p:nvPr>
-            <p:extLst>
-              <p:ext uri="{D42A27DB-BD31-4B8C-83A1-F6EECF244321}">
-                <p14:modId xmlns:p14="http://schemas.microsoft.com/office/powerpoint/2010/main" val="1579011935"/>
-              </p:ext>
-            </p:extLst>
-          </p:nvPr>
-        </p:nvGraphicFramePr>
-        <p:xfrm>
-          <a:off x="457200" y="1280160"/>
-          <a:ext cx="8229600" cy="914400"/>
-        </p:xfrm>
-        <a:graphic>
-          <a:graphicData uri="http://schemas.openxmlformats.org/drawingml/2006/table">
-            <a:tbl>
-              <a:tblPr/>
-              <a:tblGrid>
-                <a:gridCol w="3474720"/>
-                <a:gridCol w="4754880"/>
-              </a:tblGrid>
-              <a:tr h="0">
-                <a:tc>
-                  <a:txBody>
-                    <a:bodyPr/>
-                    <a:lstStyle/>
-                    <a:p>
-                      <a:pPr algn="l" indent="0" marL="0">
-                        <a:buNone/>
-                      </a:pPr>
-                      <a:r>
-                        <a:rPr lang="en-US" sz="1300" b="1" dirty="0">
-                          <a:solidFill>
-                            <a:srgbClr val="1A1A1A"/>
-                          </a:solidFill>
-                        </a:rPr>
-                        <a:t>Question</a:t>
-                      </a:r>
-                      <a:endParaRPr lang="en-US" sz="1300" dirty="0"/>
-                    </a:p>
-                  </a:txBody>
-                  <a:tcPr marL="73152" marR="73152" marT="73152" marB="73152" anchor="ctr">
-                    <a:lnL w="6350" cap="flat" cmpd="sng" algn="ctr">
-                      <a:solidFill>
-                        <a:srgbClr val="CCCCCC"/>
-                      </a:solidFill>
-                      <a:prstDash val="solid"/>
-                      <a:round/>
-                      <a:headEnd type="none" w="med" len="med"/>
-                      <a:tailEnd type="none" w="med" len="med"/>
-                    </a:lnL>
-                    <a:lnR w="6350" cap="flat" cmpd="sng" algn="ctr">
-                      <a:solidFill>
-                        <a:srgbClr val="CCCCCC"/>
-                      </a:solidFill>
-                      <a:prstDash val="solid"/>
-                      <a:round/>
-                      <a:headEnd type="none" w="med" len="med"/>
-                      <a:tailEnd type="none" w="med" len="med"/>
-                    </a:lnR>
-                    <a:lnT w="6350" cap="flat" cmpd="sng" algn="ctr">
-                      <a:solidFill>
-                        <a:srgbClr val="CCCCCC"/>
-                      </a:solidFill>
-                      <a:prstDash val="solid"/>
-                      <a:round/>
-                      <a:headEnd type="none" w="med" len="med"/>
-                      <a:tailEnd type="none" w="med" len="med"/>
-                    </a:lnT>
-                    <a:lnB w="6350" cap="flat" cmpd="sng" algn="ctr">
-                      <a:solidFill>
-                        <a:srgbClr val="CCCCCC"/>
-                      </a:solidFill>
-                      <a:prstDash val="solid"/>
-                      <a:round/>
-                      <a:headEnd type="none" w="med" len="med"/>
-                      <a:tailEnd type="none" w="med" len="med"/>
-                    </a:lnB>
-                    <a:solidFill>
-                      <a:srgbClr val="F0F0F0"/>
-                    </a:solidFill>
-                  </a:tcPr>
-                </a:tc>
-                <a:tc>
-                  <a:txBody>
-                    <a:bodyPr/>
-                    <a:lstStyle/>
-                    <a:p>
-                      <a:pPr algn="l" indent="0" marL="0">
-                        <a:buNone/>
-                      </a:pPr>
-                      <a:r>
-                        <a:rPr lang="en-US" sz="1300" b="1" dirty="0">
-                          <a:solidFill>
-                            <a:srgbClr val="1A1A1A"/>
-                          </a:solidFill>
-                        </a:rPr>
-                        <a:t>Answered by</a:t>
-                      </a:r>
-                      <a:endParaRPr lang="en-US" sz="1300" dirty="0"/>
-                    </a:p>
-                  </a:txBody>
-                  <a:tcPr marL="73152" marR="73152" marT="73152" marB="73152" anchor="ctr">
-                    <a:lnL w="6350" cap="flat" cmpd="sng" algn="ctr">
-                      <a:solidFill>
-                        <a:srgbClr val="CCCCCC"/>
-                      </a:solidFill>
-                      <a:prstDash val="solid"/>
-                      <a:round/>
-                      <a:headEnd type="none" w="med" len="med"/>
-                      <a:tailEnd type="none" w="med" len="med"/>
-                    </a:lnL>
-                    <a:lnR w="6350" cap="flat" cmpd="sng" algn="ctr">
-                      <a:solidFill>
-                        <a:srgbClr val="CCCCCC"/>
-                      </a:solidFill>
-                      <a:prstDash val="solid"/>
-                      <a:round/>
-                      <a:headEnd type="none" w="med" len="med"/>
-                      <a:tailEnd type="none" w="med" len="med"/>
-                    </a:lnR>
-                    <a:lnT w="6350" cap="flat" cmpd="sng" algn="ctr">
-                      <a:solidFill>
-                        <a:srgbClr val="CCCCCC"/>
-                      </a:solidFill>
-                      <a:prstDash val="solid"/>
-                      <a:round/>
-                      <a:headEnd type="none" w="med" len="med"/>
-                      <a:tailEnd type="none" w="med" len="med"/>
-                    </a:lnT>
-                    <a:lnB w="6350" cap="flat" cmpd="sng" algn="ctr">
-                      <a:solidFill>
-                        <a:srgbClr val="CCCCCC"/>
-                      </a:solidFill>
-                      <a:prstDash val="solid"/>
-                      <a:round/>
-                      <a:headEnd type="none" w="med" len="med"/>
-                      <a:tailEnd type="none" w="med" len="med"/>
-                    </a:lnB>
-                    <a:solidFill>
-                      <a:srgbClr val="F0F0F0"/>
-                    </a:solidFill>
-                  </a:tcPr>
-                </a:tc>
-              </a:tr>
-              <a:tr h="0">
-                <a:tc>
-                  <a:txBody>
-                    <a:bodyPr/>
-                    <a:lstStyle/>
-                    <a:p>
-                      <a:pPr algn="l" indent="0" marL="0">
-                        <a:buNone/>
-                      </a:pPr>
-                      <a:r>
-                        <a:rPr lang="en-US" sz="1300" b="1" dirty="0">
-                          <a:solidFill>
-                            <a:srgbClr val="1A1A1A"/>
-                          </a:solidFill>
-                        </a:rPr>
-                        <a:t>Is the tool accurate? Are the synthesised alternatives actually better than what the user did?</a:t>
-                      </a:r>
-                      <a:endParaRPr lang="en-US" sz="1300" dirty="0"/>
-                    </a:p>
-                  </a:txBody>
-                  <a:tcPr marL="91440" marR="91440" marT="91440" marB="91440" anchor="ctr">
-                    <a:lnL w="6350" cap="flat" cmpd="sng" algn="ctr">
-                      <a:solidFill>
-                        <a:srgbClr val="CCCCCC"/>
-                      </a:solidFill>
-                      <a:prstDash val="solid"/>
-                      <a:round/>
-                      <a:headEnd type="none" w="med" len="med"/>
-                      <a:tailEnd type="none" w="med" len="med"/>
-                    </a:lnL>
-                    <a:lnR w="6350" cap="flat" cmpd="sng" algn="ctr">
-                      <a:solidFill>
-                        <a:srgbClr val="CCCCCC"/>
-                      </a:solidFill>
-                      <a:prstDash val="solid"/>
-                      <a:round/>
-                      <a:headEnd type="none" w="med" len="med"/>
-                      <a:tailEnd type="none" w="med" len="med"/>
-                    </a:lnR>
-                    <a:lnT w="6350" cap="flat" cmpd="sng" algn="ctr">
-                      <a:solidFill>
-                        <a:srgbClr val="CCCCCC"/>
-                      </a:solidFill>
-                      <a:prstDash val="solid"/>
-                      <a:round/>
-                      <a:headEnd type="none" w="med" len="med"/>
-                      <a:tailEnd type="none" w="med" len="med"/>
-                    </a:lnT>
-                    <a:lnB w="6350" cap="flat" cmpd="sng" algn="ctr">
-                      <a:solidFill>
-                        <a:srgbClr val="CCCCCC"/>
-                      </a:solidFill>
-                      <a:prstDash val="solid"/>
-                      <a:round/>
-                      <a:headEnd type="none" w="med" len="med"/>
-                      <a:tailEnd type="none" w="med" len="med"/>
-                    </a:lnB>
-                  </a:tcPr>
-                </a:tc>
-                <a:tc>
-                  <a:txBody>
-                    <a:bodyPr/>
-                    <a:lstStyle/>
-                    <a:p>
-                      <a:pPr algn="l" indent="0" marL="0">
-                        <a:buNone/>
-                      </a:pPr>
-                      <a:r>
-                        <a:rPr lang="en-US" sz="1300" dirty="0">
-                          <a:solidFill>
-                            <a:srgbClr val="555555"/>
-                          </a:solidFill>
-                        </a:rPr>
-                        <a:t>45 labelled injection sessions: per-kind precision and recall (Slides 16-17) plus beat/tie/lose breakdown across all 66 detected divergence points (Slide 18).</a:t>
-                      </a:r>
-                      <a:endParaRPr lang="en-US" sz="1300" dirty="0"/>
-                    </a:p>
-                  </a:txBody>
-                  <a:tcPr marL="91440" marR="91440" marT="91440" marB="91440" anchor="ctr">
-                    <a:lnL w="6350" cap="flat" cmpd="sng" algn="ctr">
-                      <a:solidFill>
-                        <a:srgbClr val="CCCCCC"/>
-                      </a:solidFill>
-                      <a:prstDash val="solid"/>
-                      <a:round/>
-                      <a:headEnd type="none" w="med" len="med"/>
-                      <a:tailEnd type="none" w="med" len="med"/>
-                    </a:lnL>
-                    <a:lnR w="6350" cap="flat" cmpd="sng" algn="ctr">
-                      <a:solidFill>
-                        <a:srgbClr val="CCCCCC"/>
-                      </a:solidFill>
-                      <a:prstDash val="solid"/>
-                      <a:round/>
-                      <a:headEnd type="none" w="med" len="med"/>
-                      <a:tailEnd type="none" w="med" len="med"/>
-                    </a:lnR>
-                    <a:lnT w="6350" cap="flat" cmpd="sng" algn="ctr">
-                      <a:solidFill>
-                        <a:srgbClr val="CCCCCC"/>
-                      </a:solidFill>
-                      <a:prstDash val="solid"/>
-                      <a:round/>
-                      <a:headEnd type="none" w="med" len="med"/>
-                      <a:tailEnd type="none" w="med" len="med"/>
-                    </a:lnT>
-                    <a:lnB w="6350" cap="flat" cmpd="sng" algn="ctr">
-                      <a:solidFill>
-                        <a:srgbClr val="CCCCCC"/>
-                      </a:solidFill>
-                      <a:prstDash val="solid"/>
-                      <a:round/>
-                      <a:headEnd type="none" w="med" len="med"/>
-                      <a:tailEnd type="none" w="med" len="med"/>
-                    </a:lnB>
-                  </a:tcPr>
-                </a:tc>
-              </a:tr>
-              <a:tr h="0">
-                <a:tc>
-                  <a:txBody>
-                    <a:bodyPr/>
-                    <a:lstStyle/>
-                    <a:p>
-                      <a:pPr algn="l" indent="0" marL="0">
-                        <a:buNone/>
-                      </a:pPr>
-                      <a:r>
-                        <a:rPr lang="en-US" sz="1300" b="1" dirty="0">
-                          <a:solidFill>
-                            <a:srgbClr val="1A1A1A"/>
-                          </a:solidFill>
-                        </a:rPr>
-                        <a:t>Is the process score reliable? Does the ranking hold up when the weights are perturbed?</a:t>
-                      </a:r>
-                      <a:endParaRPr lang="en-US" sz="1300" dirty="0"/>
-                    </a:p>
-                  </a:txBody>
-                  <a:tcPr marL="91440" marR="91440" marT="91440" marB="91440" anchor="ctr">
-                    <a:lnL w="6350" cap="flat" cmpd="sng" algn="ctr">
-                      <a:solidFill>
-                        <a:srgbClr val="CCCCCC"/>
-                      </a:solidFill>
-                      <a:prstDash val="solid"/>
-                      <a:round/>
-                      <a:headEnd type="none" w="med" len="med"/>
-                      <a:tailEnd type="none" w="med" len="med"/>
-                    </a:lnL>
-                    <a:lnR w="6350" cap="flat" cmpd="sng" algn="ctr">
-                      <a:solidFill>
-                        <a:srgbClr val="CCCCCC"/>
-                      </a:solidFill>
-                      <a:prstDash val="solid"/>
-                      <a:round/>
-                      <a:headEnd type="none" w="med" len="med"/>
-                      <a:tailEnd type="none" w="med" len="med"/>
-                    </a:lnR>
-                    <a:lnT w="6350" cap="flat" cmpd="sng" algn="ctr">
-                      <a:solidFill>
-                        <a:srgbClr val="CCCCCC"/>
-                      </a:solidFill>
-                      <a:prstDash val="solid"/>
-                      <a:round/>
-                      <a:headEnd type="none" w="med" len="med"/>
-                      <a:tailEnd type="none" w="med" len="med"/>
-                    </a:lnT>
-                    <a:lnB w="6350" cap="flat" cmpd="sng" algn="ctr">
-                      <a:solidFill>
-                        <a:srgbClr val="CCCCCC"/>
-                      </a:solidFill>
-                      <a:prstDash val="solid"/>
-                      <a:round/>
-                      <a:headEnd type="none" w="med" len="med"/>
-                      <a:tailEnd type="none" w="med" len="med"/>
-                    </a:lnB>
-                  </a:tcPr>
-                </a:tc>
-                <a:tc>
-                  <a:txBody>
-                    <a:bodyPr/>
-                    <a:lstStyle/>
-                    <a:p>
-                      <a:pPr algn="l" indent="0" marL="0">
-                        <a:buNone/>
-                      </a:pPr>
-                      <a:r>
-                        <a:rPr lang="en-US" sz="1300" dirty="0">
-                          <a:solidFill>
-                            <a:srgbClr val="555555"/>
-                          </a:solidFill>
-                        </a:rPr>
-                        <a:t>Sensitivity sweep + ablation, headline on the 25-session user-study rankable subset (Slides 20-21).</a:t>
-                      </a:r>
-                      <a:endParaRPr lang="en-US" sz="1300" dirty="0"/>
-                    </a:p>
-                  </a:txBody>
-                  <a:tcPr marL="91440" marR="91440" marT="91440" marB="91440" anchor="ctr">
-                    <a:lnL w="6350" cap="flat" cmpd="sng" algn="ctr">
-                      <a:solidFill>
-                        <a:srgbClr val="CCCCCC"/>
-                      </a:solidFill>
-                      <a:prstDash val="solid"/>
-                      <a:round/>
-                      <a:headEnd type="none" w="med" len="med"/>
-                      <a:tailEnd type="none" w="med" len="med"/>
-                    </a:lnL>
-                    <a:lnR w="6350" cap="flat" cmpd="sng" algn="ctr">
-                      <a:solidFill>
-                        <a:srgbClr val="CCCCCC"/>
-                      </a:solidFill>
-                      <a:prstDash val="solid"/>
-                      <a:round/>
-                      <a:headEnd type="none" w="med" len="med"/>
-                      <a:tailEnd type="none" w="med" len="med"/>
-                    </a:lnR>
-                    <a:lnT w="6350" cap="flat" cmpd="sng" algn="ctr">
-                      <a:solidFill>
-                        <a:srgbClr val="CCCCCC"/>
-                      </a:solidFill>
-                      <a:prstDash val="solid"/>
-                      <a:round/>
-                      <a:headEnd type="none" w="med" len="med"/>
-                      <a:tailEnd type="none" w="med" len="med"/>
-                    </a:lnT>
-                    <a:lnB w="6350" cap="flat" cmpd="sng" algn="ctr">
-                      <a:solidFill>
-                        <a:srgbClr val="CCCCCC"/>
-                      </a:solidFill>
-                      <a:prstDash val="solid"/>
-                      <a:round/>
-                      <a:headEnd type="none" w="med" len="med"/>
-                      <a:tailEnd type="none" w="med" len="med"/>
-                    </a:lnB>
-                  </a:tcPr>
-                </a:tc>
-              </a:tr>
-              <a:tr h="0">
-                <a:tc>
-                  <a:txBody>
-                    <a:bodyPr/>
-                    <a:lstStyle/>
-                    <a:p>
-                      <a:pPr algn="l" indent="0" marL="0">
-                        <a:buNone/>
-                      </a:pPr>
-                      <a:r>
-                        <a:rPr lang="en-US" sz="1300" b="1" dirty="0">
-                          <a:solidFill>
-                            <a:srgbClr val="1A1A1A"/>
-                          </a:solidFill>
-                        </a:rPr>
-                        <a:t>Does the tool change developer behaviour? Fewer divergences over time when feedback is shown?</a:t>
-                      </a:r>
-                      <a:endParaRPr lang="en-US" sz="1300" dirty="0"/>
-                    </a:p>
-                  </a:txBody>
-                  <a:tcPr marL="91440" marR="91440" marT="91440" marB="91440" anchor="ctr">
-                    <a:lnL w="6350" cap="flat" cmpd="sng" algn="ctr">
-                      <a:solidFill>
-                        <a:srgbClr val="CCCCCC"/>
-                      </a:solidFill>
-                      <a:prstDash val="solid"/>
-                      <a:round/>
-                      <a:headEnd type="none" w="med" len="med"/>
-                      <a:tailEnd type="none" w="med" len="med"/>
-                    </a:lnL>
-                    <a:lnR w="6350" cap="flat" cmpd="sng" algn="ctr">
-                      <a:solidFill>
-                        <a:srgbClr val="CCCCCC"/>
-                      </a:solidFill>
-                      <a:prstDash val="solid"/>
-                      <a:round/>
-                      <a:headEnd type="none" w="med" len="med"/>
-                      <a:tailEnd type="none" w="med" len="med"/>
-                    </a:lnR>
-                    <a:lnT w="6350" cap="flat" cmpd="sng" algn="ctr">
-                      <a:solidFill>
-                        <a:srgbClr val="CCCCCC"/>
-                      </a:solidFill>
-                      <a:prstDash val="solid"/>
-                      <a:round/>
-                      <a:headEnd type="none" w="med" len="med"/>
-                      <a:tailEnd type="none" w="med" len="med"/>
-                    </a:lnT>
-                    <a:lnB w="6350" cap="flat" cmpd="sng" algn="ctr">
-                      <a:solidFill>
-                        <a:srgbClr val="CCCCCC"/>
-                      </a:solidFill>
-                      <a:prstDash val="solid"/>
-                      <a:round/>
-                      <a:headEnd type="none" w="med" len="med"/>
-                      <a:tailEnd type="none" w="med" len="med"/>
-                    </a:lnB>
-                  </a:tcPr>
-                </a:tc>
-                <a:tc>
-                  <a:txBody>
-                    <a:bodyPr/>
-                    <a:lstStyle/>
-                    <a:p>
-                      <a:pPr algn="l" indent="0" marL="0">
-                        <a:buNone/>
-                      </a:pPr>
-                      <a:r>
-                        <a:rPr lang="en-US" sz="1300" dirty="0">
-                          <a:solidFill>
-                            <a:srgbClr val="555555"/>
-                          </a:solidFill>
-                        </a:rPr>
-                        <a:t>30-session randomised user study, 5 participants split between feedback and no-feedback arms (Slide 23).</a:t>
-                      </a:r>
-                      <a:endParaRPr lang="en-US" sz="1300" dirty="0"/>
-                    </a:p>
-                  </a:txBody>
-                  <a:tcPr marL="91440" marR="91440" marT="91440" marB="91440" anchor="ctr">
-                    <a:lnL w="6350" cap="flat" cmpd="sng" algn="ctr">
-                      <a:solidFill>
-                        <a:srgbClr val="CCCCCC"/>
-                      </a:solidFill>
-                      <a:prstDash val="solid"/>
-                      <a:round/>
-                      <a:headEnd type="none" w="med" len="med"/>
-                      <a:tailEnd type="none" w="med" len="med"/>
-                    </a:lnL>
-                    <a:lnR w="6350" cap="flat" cmpd="sng" algn="ctr">
-                      <a:solidFill>
-                        <a:srgbClr val="CCCCCC"/>
-                      </a:solidFill>
-                      <a:prstDash val="solid"/>
-                      <a:round/>
-                      <a:headEnd type="none" w="med" len="med"/>
-                      <a:tailEnd type="none" w="med" len="med"/>
-                    </a:lnR>
-                    <a:lnT w="6350" cap="flat" cmpd="sng" algn="ctr">
-                      <a:solidFill>
-                        <a:srgbClr val="CCCCCC"/>
-                      </a:solidFill>
-                      <a:prstDash val="solid"/>
-                      <a:round/>
-                      <a:headEnd type="none" w="med" len="med"/>
-                      <a:tailEnd type="none" w="med" len="med"/>
-                    </a:lnT>
-                    <a:lnB w="6350" cap="flat" cmpd="sng" algn="ctr">
-                      <a:solidFill>
-                        <a:srgbClr val="CCCCCC"/>
-                      </a:solidFill>
-                      <a:prstDash val="solid"/>
-                      <a:round/>
-                      <a:headEnd type="none" w="med" len="med"/>
-                      <a:tailEnd type="none" w="med" len="med"/>
-                    </a:lnB>
-                  </a:tcPr>
-                </a:tc>
-              </a:tr>
-            </a:tbl>
-          </a:graphicData>
-        </a:graphic>
-      </p:graphicFrame>
+      <p:sp>
+        <p:nvSpPr>
+          <p:cNvPr id="3" name="Text 1"/>
+          <p:cNvSpPr/>
+          <p:nvPr/>
+        </p:nvSpPr>
+        <p:spPr>
+          <a:xfrm>
+            <a:off x="457200" y="1188720"/>
+            <a:ext cx="8229600" cy="3657600"/>
+          </a:xfrm>
+          <a:prstGeom prst="rect">
+            <a:avLst/>
+          </a:prstGeom>
+          <a:noFill/>
+          <a:ln/>
+        </p:spPr>
+        <p:txBody>
+          <a:bodyPr wrap="square" rtlCol="0" anchor="t"/>
+          <a:lstStyle/>
+          <a:p>
+            <a:pPr marL="342900" indent="-342900">
+              <a:spcAft>
+                <a:spcPts val="800"/>
+              </a:spcAft>
+              <a:buSzPct val="100000"/>
+              <a:buChar char="•"/>
+            </a:pPr>
+            <a:r>
+              <a:rPr lang="en-US" sz="1600" b="1" dirty="0">
+                <a:solidFill>
+                  <a:srgbClr val="000000"/>
+                </a:solidFill>
+              </a:rPr>
+              <a:t>3 Questions</a:t>
+            </a:r>
+            <a:endParaRPr lang="en-US" sz="1600" dirty="0"/>
+          </a:p>
+          <a:p>
+            <a:pPr lvl="1" marL="762000" indent="-381000">
+              <a:spcAft>
+                <a:spcPts val="600"/>
+              </a:spcAft>
+              <a:buSzPct val="100000"/>
+              <a:buChar char="•"/>
+            </a:pPr>
+            <a:r>
+              <a:rPr lang="en-US" sz="1600" dirty="0">
+                <a:solidFill>
+                  <a:srgbClr val="000000"/>
+                </a:solidFill>
+              </a:rPr>
+              <a:t>Is the tool accurate?</a:t>
+            </a:r>
+            <a:endParaRPr lang="en-US" sz="1600" dirty="0"/>
+          </a:p>
+          <a:p>
+            <a:pPr lvl="1" marL="762000" indent="-381000">
+              <a:spcAft>
+                <a:spcPts val="600"/>
+              </a:spcAft>
+              <a:buSzPct val="100000"/>
+              <a:buChar char="•"/>
+            </a:pPr>
+            <a:r>
+              <a:rPr lang="en-US" sz="1600" dirty="0">
+                <a:solidFill>
+                  <a:srgbClr val="000000"/>
+                </a:solidFill>
+              </a:rPr>
+              <a:t>Is the process score reliable?</a:t>
+            </a:r>
+            <a:endParaRPr lang="en-US" sz="1600" dirty="0"/>
+          </a:p>
+          <a:p>
+            <a:pPr lvl="1" marL="762000" indent="-381000">
+              <a:spcAft>
+                <a:spcPts val="2000"/>
+              </a:spcAft>
+              <a:buSzPct val="100000"/>
+              <a:buChar char="•"/>
+            </a:pPr>
+            <a:r>
+              <a:rPr lang="en-US" sz="1600" dirty="0">
+                <a:solidFill>
+                  <a:srgbClr val="000000"/>
+                </a:solidFill>
+              </a:rPr>
+              <a:t>Does the tool change developer behaviour?</a:t>
+            </a:r>
+            <a:endParaRPr lang="en-US" sz="1600" dirty="0"/>
+          </a:p>
+          <a:p>
+            <a:pPr marL="342900" indent="-342900">
+              <a:spcAft>
+                <a:spcPts val="800"/>
+              </a:spcAft>
+              <a:buSzPct val="100000"/>
+              <a:buChar char="•"/>
+            </a:pPr>
+            <a:r>
+              <a:rPr lang="en-US" sz="1600" b="1" dirty="0">
+                <a:solidFill>
+                  <a:srgbClr val="000000"/>
+                </a:solidFill>
+              </a:rPr>
+              <a:t>2 Datasets</a:t>
+            </a:r>
+            <a:endParaRPr lang="en-US" sz="1600" dirty="0"/>
+          </a:p>
+          <a:p>
+            <a:pPr lvl="1" marL="762000" indent="-381000">
+              <a:spcAft>
+                <a:spcPts val="600"/>
+              </a:spcAft>
+              <a:buSzPct val="100000"/>
+              <a:buChar char="•"/>
+            </a:pPr>
+            <a:r>
+              <a:rPr lang="en-US" sz="1600" dirty="0">
+                <a:solidFill>
+                  <a:srgbClr val="000000"/>
+                </a:solidFill>
+              </a:rPr>
+              <a:t>45-session labelled injection set </a:t>
+            </a:r>
+            <a:pPr indent="0" marL="0">
+              <a:spcAft>
+                <a:spcPts val="600"/>
+              </a:spcAft>
+              <a:buNone/>
+            </a:pPr>
+            <a:r>
+              <a:rPr lang="en-US" sz="1600" dirty="0">
+                <a:solidFill>
+                  <a:srgbClr val="555555"/>
+                </a:solidFill>
+              </a:rPr>
+              <a:t>- controlled, balanced per-kind coverage; ground-truth labels at κ ≥ 0.72.</a:t>
+            </a:r>
+            <a:endParaRPr lang="en-US" sz="1600" dirty="0"/>
+          </a:p>
+          <a:p>
+            <a:pPr lvl="1" marL="762000" indent="-381000">
+              <a:spcAft>
+                <a:spcPts val="600"/>
+              </a:spcAft>
+              <a:buSzPct val="100000"/>
+              <a:buChar char="•"/>
+            </a:pPr>
+            <a:r>
+              <a:rPr lang="en-US" sz="1600" dirty="0">
+                <a:solidFill>
+                  <a:srgbClr val="000000"/>
+                </a:solidFill>
+              </a:rPr>
+              <a:t>30-session randomised user study </a:t>
+            </a:r>
+            <a:pPr indent="0" marL="0">
+              <a:spcAft>
+                <a:spcPts val="600"/>
+              </a:spcAft>
+              <a:buNone/>
+            </a:pPr>
+            <a:r>
+              <a:rPr lang="en-US" sz="1600" dirty="0">
+                <a:solidFill>
+                  <a:srgbClr val="555555"/>
+                </a:solidFill>
+              </a:rPr>
+              <a:t>- 5 MEng participants × 6 sessions, 2 arms (feedback vs no-feedback).</a:t>
+            </a:r>
+            <a:endParaRPr lang="en-US" sz="1600" dirty="0"/>
+          </a:p>
+        </p:txBody>
+      </p:sp>
     </p:spTree>
   </p:cSld>
   <p:clrMapOvr>
@@ -15009,14 +14919,14 @@
               <a:buNone/>
             </a:pPr>
             <a:r>
-              <a:rPr lang="en-US" sz="8000" b="1" dirty="0">
+              <a:rPr lang="en-US" sz="6000" b="1" dirty="0">
                 <a:solidFill>
                   <a:srgbClr val="000000"/>
                 </a:solidFill>
               </a:rPr>
               <a:t>Demo</a:t>
             </a:r>
-            <a:endParaRPr lang="en-US" sz="8000" dirty="0"/>
+            <a:endParaRPr lang="en-US" sz="6000" dirty="0"/>
           </a:p>
         </p:txBody>
       </p:sp>

</xml_diff>

<commit_message>
feat: slide motivation updates
</commit_message>
<xml_diff>
--- a/presentation/slides.pptx
+++ b/presentation/slides.pptx
@@ -5258,7 +5258,7 @@
                   <a:srgbClr val="555555"/>
                 </a:solidFill>
               </a:rPr>
-              <a:t>Scoring the path a developer takes through a refactoring session, and pointing to where a better path existed.</a:t>
+              <a:t>Scoring the path a developer takes through a refactoring session, and generating reference trajectories where a better path existed.</a:t>
             </a:r>
             <a:endParaRPr lang="en-US" sz="1800" dirty="0"/>
           </a:p>
@@ -11752,7 +11752,29 @@
                   <a:srgbClr val="555555"/>
                 </a:solidFill>
               </a:rPr>
-              <a:t>Two developers refactor the same code and arrive at the same final state.</a:t>
+              <a:t>Two developers refactor the same code </a:t>
+            </a:r>
+            <a:pPr algn="ctr" indent="0" marL="0">
+              <a:buNone/>
+            </a:pPr>
+            <a:r>
+              <a:rPr lang="en-US" sz="1600" b="1" i="1" dirty="0">
+                <a:solidFill>
+                  <a:srgbClr val="555555"/>
+                </a:solidFill>
+              </a:rPr>
+              <a:t>and arrive at the same final state</a:t>
+            </a:r>
+            <a:pPr algn="ctr" indent="0" marL="0">
+              <a:buNone/>
+            </a:pPr>
+            <a:r>
+              <a:rPr lang="en-US" sz="1600" i="1" dirty="0">
+                <a:solidFill>
+                  <a:srgbClr val="555555"/>
+                </a:solidFill>
+              </a:rPr>
+              <a:t>.</a:t>
             </a:r>
             <a:endParaRPr lang="en-US" sz="1600" dirty="0"/>
           </a:p>
@@ -16161,7 +16183,7 @@
         </p:nvSpPr>
         <p:spPr>
           <a:xfrm>
-            <a:off x="457200" y="640080"/>
+            <a:off x="457200" y="411480"/>
             <a:ext cx="8229600" cy="640080"/>
           </a:xfrm>
           <a:prstGeom prst="rect">
@@ -16183,7 +16205,7 @@
                   <a:srgbClr val="000000"/>
                 </a:solidFill>
               </a:rPr>
-              <a:t>Evaluating the refactoring process: what's missing in prior work</a:t>
+              <a:t>Motivation: what's missing in prior work</a:t>
             </a:r>
             <a:endParaRPr lang="en-US" sz="2800" dirty="0"/>
           </a:p>
@@ -16197,8 +16219,102 @@
         </p:nvSpPr>
         <p:spPr>
           <a:xfrm>
+            <a:off x="548640" y="1097280"/>
+            <a:ext cx="8046720" cy="640080"/>
+          </a:xfrm>
+          <a:prstGeom prst="rect">
+            <a:avLst/>
+          </a:prstGeom>
+          <a:noFill/>
+          <a:ln/>
+        </p:spPr>
+        <p:txBody>
+          <a:bodyPr wrap="square" lIns="0" tIns="0" rIns="0" bIns="0" rtlCol="0" anchor="ctr"/>
+          <a:lstStyle/>
+          <a:p>
+            <a:pPr algn="ctr" indent="0" marL="0">
+              <a:buNone/>
+            </a:pPr>
+            <a:r>
+              <a:rPr lang="en-US" sz="1500" i="1" dirty="0">
+                <a:solidFill>
+                  <a:srgbClr val="333333"/>
+                </a:solidFill>
+              </a:rPr>
+              <a:t>To help developers refactor better, we need to measure what a </a:t>
+            </a:r>
+            <a:pPr algn="ctr" indent="0" marL="0">
+              <a:buNone/>
+            </a:pPr>
+            <a:r>
+              <a:rPr lang="en-US" sz="1500" i="1" dirty="0">
+                <a:solidFill>
+                  <a:srgbClr val="333333"/>
+                </a:solidFill>
+              </a:rPr>
+              <a:t>good refactoring session</a:t>
+            </a:r>
+            <a:pPr algn="ctr" indent="0" marL="0">
+              <a:buNone/>
+            </a:pPr>
+            <a:r>
+              <a:rPr lang="en-US" sz="1500" i="1" dirty="0">
+                <a:solidFill>
+                  <a:srgbClr val="333333"/>
+                </a:solidFill>
+              </a:rPr>
+              <a:t> actually looks like - not just what code it produces.</a:t>
+            </a:r>
+            <a:endParaRPr lang="en-US" sz="1500" dirty="0"/>
+          </a:p>
+        </p:txBody>
+      </p:sp>
+      <p:sp>
+        <p:nvSpPr>
+          <p:cNvPr id="4" name="Text 2"/>
+          <p:cNvSpPr/>
+          <p:nvPr/>
+        </p:nvSpPr>
+        <p:spPr>
+          <a:xfrm>
             <a:off x="457200" y="1783080"/>
-            <a:ext cx="8229600" cy="3657600"/>
+            <a:ext cx="8229600" cy="320040"/>
+          </a:xfrm>
+          <a:prstGeom prst="rect">
+            <a:avLst/>
+          </a:prstGeom>
+          <a:noFill/>
+          <a:ln/>
+        </p:spPr>
+        <p:txBody>
+          <a:bodyPr wrap="square" lIns="0" tIns="0" rIns="0" bIns="0" rtlCol="0" anchor="ctr"/>
+          <a:lstStyle/>
+          <a:p>
+            <a:pPr algn="ctr" indent="0" marL="0">
+              <a:buNone/>
+            </a:pPr>
+            <a:r>
+              <a:rPr lang="en-US" sz="1400" b="1" dirty="0">
+                <a:solidFill>
+                  <a:srgbClr val="1A1A1A"/>
+                </a:solidFill>
+              </a:rPr>
+              <a:t>But prior work mostly measures outcomes, not the process:</a:t>
+            </a:r>
+            <a:endParaRPr lang="en-US" sz="1400" dirty="0"/>
+          </a:p>
+        </p:txBody>
+      </p:sp>
+      <p:sp>
+        <p:nvSpPr>
+          <p:cNvPr id="5" name="Text 3"/>
+          <p:cNvSpPr/>
+          <p:nvPr/>
+        </p:nvSpPr>
+        <p:spPr>
+          <a:xfrm>
+            <a:off x="457200" y="2240280"/>
+            <a:ext cx="8229600" cy="2743200"/>
           </a:xfrm>
           <a:prstGeom prst="rect">
             <a:avLst/>
@@ -16211,109 +16327,161 @@
           <a:lstStyle/>
           <a:p>
             <a:pPr marL="342900" indent="-342900">
+              <a:spcAft>
+                <a:spcPts val="800"/>
+              </a:spcAft>
               <a:buSzPct val="100000"/>
               <a:buChar char="•"/>
             </a:pPr>
             <a:r>
-              <a:rPr lang="en-US" sz="1600" b="1" dirty="0">
+              <a:rPr lang="en-US" sz="1300" b="1" dirty="0">
                 <a:solidFill>
                   <a:srgbClr val="000000"/>
                 </a:solidFill>
               </a:rPr>
-              <a:t>Endpoint quality metrics (CK, smells, readability):</a:t>
+              <a:t>Endpoint quality metrics </a:t>
             </a:r>
             <a:pPr indent="0" marL="0">
-              <a:buNone/>
-            </a:pPr>
-            <a:r>
-              <a:rPr lang="en-US" sz="1600" dirty="0">
+              <a:spcAft>
+                <a:spcPts val="800"/>
+              </a:spcAft>
+              <a:buNone/>
+            </a:pPr>
+            <a:r>
+              <a:rPr lang="en-US" sz="1300" i="1" dirty="0">
+                <a:solidFill>
+                  <a:srgbClr val="555555"/>
+                </a:solidFill>
+              </a:rPr>
+              <a:t>(CK, smells, cohesion, coupling)</a:t>
+            </a:r>
+            <a:pPr indent="0" marL="0">
+              <a:spcAft>
+                <a:spcPts val="800"/>
+              </a:spcAft>
+              <a:buNone/>
+            </a:pPr>
+            <a:r>
+              <a:rPr lang="en-US" sz="1300" dirty="0">
+                <a:solidFill>
+                  <a:srgbClr val="555555"/>
+                </a:solidFill>
+              </a:rPr>
+              <a:t> - compare before vs after; ignore the path between, and can't distinguish two sessions ending at the same code.</a:t>
+            </a:r>
+            <a:endParaRPr lang="en-US" sz="1300" dirty="0"/>
+          </a:p>
+          <a:p>
+            <a:pPr indent="0" marL="0">
+              <a:spcAft>
+                <a:spcPts val="800"/>
+              </a:spcAft>
+              <a:buNone/>
+            </a:pPr>
+            <a:r>
+              <a:rPr lang="en-US" sz="1300" dirty="0">
                 <a:solidFill>
                   <a:srgbClr val="000000"/>
                 </a:solidFill>
               </a:rPr>
-              <a:t> compare before vs after, ignore the path taken.</a:t>
-            </a:r>
-            <a:endParaRPr lang="en-US" sz="1600" dirty="0"/>
-          </a:p>
-          <a:p>
-            <a:pPr indent="0" marL="0">
-              <a:buNone/>
-            </a:pPr>
-            <a:r>
-              <a:rPr lang="en-US" sz="1600" dirty="0">
-                <a:solidFill>
-                  <a:srgbClr val="000000"/>
-                </a:solidFill>
-              </a:rPr>
               <a:t> </a:t>
             </a:r>
-            <a:endParaRPr lang="en-US" sz="1600" dirty="0"/>
+            <a:endParaRPr lang="en-US" sz="1300" dirty="0"/>
           </a:p>
           <a:p>
             <a:pPr marL="342900" indent="-342900">
+              <a:spcAft>
+                <a:spcPts val="800"/>
+              </a:spcAft>
               <a:buSzPct val="100000"/>
               <a:buChar char="•"/>
             </a:pPr>
             <a:r>
-              <a:rPr lang="en-US" sz="1600" b="1" dirty="0">
+              <a:rPr lang="en-US" sz="1300" b="1" dirty="0">
                 <a:solidFill>
                   <a:srgbClr val="000000"/>
                 </a:solidFill>
               </a:rPr>
-              <a:t>Refactoring recommenders / sequence generators</a:t>
+              <a:t>Refactoring recommenders / sequence generators </a:t>
             </a:r>
             <a:pPr indent="0" marL="0">
-              <a:buNone/>
-            </a:pPr>
-            <a:r>
-              <a:rPr lang="en-US" sz="1600" dirty="0">
+              <a:spcAft>
+                <a:spcPts val="800"/>
+              </a:spcAft>
+              <a:buNone/>
+            </a:pPr>
+            <a:r>
+              <a:rPr lang="en-US" sz="1300" i="1" dirty="0">
+                <a:solidFill>
+                  <a:srgbClr val="555555"/>
+                </a:solidFill>
+              </a:rPr>
+              <a:t>(search-based, ReSynth)</a:t>
+            </a:r>
+            <a:pPr indent="0" marL="0">
+              <a:spcAft>
+                <a:spcPts val="800"/>
+              </a:spcAft>
+              <a:buNone/>
+            </a:pPr>
+            <a:r>
+              <a:rPr lang="en-US" sz="1300" dirty="0">
+                <a:solidFill>
+                  <a:srgbClr val="555555"/>
+                </a:solidFill>
+              </a:rPr>
+              <a:t> - generate paths toward a target end state; don't score the developer's own path.</a:t>
+            </a:r>
+            <a:endParaRPr lang="en-US" sz="1300" dirty="0"/>
+          </a:p>
+          <a:p>
+            <a:pPr indent="0" marL="0">
+              <a:spcAft>
+                <a:spcPts val="800"/>
+              </a:spcAft>
+              <a:buNone/>
+            </a:pPr>
+            <a:r>
+              <a:rPr lang="en-US" sz="1300" dirty="0">
                 <a:solidFill>
                   <a:srgbClr val="000000"/>
                 </a:solidFill>
               </a:rPr>
-              <a:t>: produce new sequences (typically at small scale), but do not evaluate the one the developer actually walked.</a:t>
-            </a:r>
-            <a:endParaRPr lang="en-US" sz="1600" dirty="0"/>
-          </a:p>
-          <a:p>
-            <a:pPr indent="0" marL="0">
-              <a:buNone/>
-            </a:pPr>
-            <a:r>
-              <a:rPr lang="en-US" sz="1600" dirty="0">
-                <a:solidFill>
-                  <a:srgbClr val="000000"/>
-                </a:solidFill>
-              </a:rPr>
               <a:t> </a:t>
             </a:r>
-            <a:endParaRPr lang="en-US" sz="1600" dirty="0"/>
+            <a:endParaRPr lang="en-US" sz="1300" dirty="0"/>
           </a:p>
           <a:p>
             <a:pPr marL="342900" indent="-342900">
+              <a:spcAft>
+                <a:spcPts val="800"/>
+              </a:spcAft>
               <a:buSzPct val="100000"/>
               <a:buChar char="•"/>
             </a:pPr>
             <a:r>
-              <a:rPr lang="en-US" sz="1600" b="1" dirty="0">
+              <a:rPr lang="en-US" sz="1300" b="1" dirty="0">
                 <a:solidFill>
                   <a:srgbClr val="000000"/>
                 </a:solidFill>
               </a:rPr>
-              <a:t>Exercise-scoped feedback tools:</a:t>
+              <a:t>Exercise-scoped feedback tools </a:t>
             </a:r>
             <a:pPr indent="0" marL="0">
-              <a:buNone/>
-            </a:pPr>
-            <a:r>
-              <a:rPr lang="en-US" sz="1600" dirty="0">
-                <a:solidFill>
-                  <a:srgbClr val="000000"/>
-                </a:solidFill>
-              </a:rPr>
-              <a:t> one or two look for explicit events inside predefined exercises - but don't generalise to arbitrary refactoring sessions.</a:t>
-            </a:r>
-            <a:endParaRPr lang="en-US" sz="1600" dirty="0"/>
+              <a:spcAft>
+                <a:spcPts val="800"/>
+              </a:spcAft>
+              <a:buNone/>
+            </a:pPr>
+            <a:r>
+              <a:rPr lang="en-US" sz="1300" dirty="0">
+                <a:solidFill>
+                  <a:srgbClr val="555555"/>
+                </a:solidFill>
+              </a:rPr>
+              <a:t>- match explicit events inside predefined exercises; don't generalise to arbitrary sessions.</a:t>
+            </a:r>
+            <a:endParaRPr lang="en-US" sz="1300" dirty="0"/>
           </a:p>
         </p:txBody>
       </p:sp>
@@ -16795,7 +16963,7 @@
                   <a:srgbClr val="000000"/>
                 </a:solidFill>
               </a:rPr>
-              <a:t>Seamless, in-workflow capture </a:t>
+              <a:t>Actionable, moment-specific feedback </a:t>
             </a:r>
             <a:pPr indent="0" marL="0">
               <a:buNone/>
@@ -16806,7 +16974,7 @@
                   <a:srgbClr val="888888"/>
                 </a:solidFill>
               </a:rPr>
-              <a:t>- zero extra developer effort to use the tool.</a:t>
+              <a:t>- point to a specific moment AND a "what you could have done instead" alternative.</a:t>
             </a:r>
             <a:pPr indent="0" marL="0">
               <a:buNone/>
@@ -16846,7 +17014,7 @@
                   <a:srgbClr val="000000"/>
                 </a:solidFill>
               </a:rPr>
-              <a:t>Actionable, moment-specific feedback </a:t>
+              <a:t>Efficient alternative synthesis </a:t>
             </a:r>
             <a:pPr indent="0" marL="0">
               <a:buNone/>
@@ -16857,18 +17025,7 @@
                   <a:srgbClr val="888888"/>
                 </a:solidFill>
               </a:rPr>
-              <a:t>- point to a specific moment AND a "what you could have done instead" alternative.</a:t>
-            </a:r>
-            <a:pPr indent="0" marL="0">
-              <a:buNone/>
-            </a:pPr>
-            <a:r>
-              <a:rPr lang="en-US" sz="1400" dirty="0">
-                <a:solidFill>
-                  <a:srgbClr val="888888"/>
-                </a:solidFill>
-              </a:rPr>
-              <a:t> [3]</a:t>
+              <a:t>- the state-action space over a real codebase is too large to enumerate, so we must find efficient methods of identifying "better" alternatives.</a:t>
             </a:r>
             <a:endParaRPr lang="en-US" sz="1400" dirty="0"/>
           </a:p>
@@ -16897,7 +17054,7 @@
                   <a:srgbClr val="000000"/>
                 </a:solidFill>
               </a:rPr>
-              <a:t>Efficient alternative synthesis </a:t>
+              <a:t>Seamless, in-workflow capture </a:t>
             </a:r>
             <a:pPr indent="0" marL="0">
               <a:buNone/>
@@ -16908,7 +17065,18 @@
                   <a:srgbClr val="888888"/>
                 </a:solidFill>
               </a:rPr>
-              <a:t>- the state-action space over a real codebase is too large to enumerate, so we must find efficient methods of identifying "better" alternatives.</a:t>
+              <a:t>- zero extra developer effort to use the tool.</a:t>
+            </a:r>
+            <a:pPr indent="0" marL="0">
+              <a:buNone/>
+            </a:pPr>
+            <a:r>
+              <a:rPr lang="en-US" sz="1400" dirty="0">
+                <a:solidFill>
+                  <a:srgbClr val="888888"/>
+                </a:solidFill>
+              </a:rPr>
+              <a:t> [3]</a:t>
             </a:r>
             <a:endParaRPr lang="en-US" sz="1400" dirty="0"/>
           </a:p>
@@ -16955,7 +17123,7 @@
                   <a:srgbClr val="888888"/>
                 </a:solidFill>
               </a:rPr>
-              <a:t>[2] IDE-event logging (Damevski et al., CodeWatcher).   </a:t>
+              <a:t>[2] Inverts prior refactoring recommenders (ReSynth, Refactoring Navigator, search-based refactoring).   </a:t>
             </a:r>
             <a:pPr algn="l" indent="0" marL="0">
               <a:buNone/>
@@ -16966,7 +17134,7 @@
                   <a:srgbClr val="888888"/>
                 </a:solidFill>
               </a:rPr>
-              <a:t>[3] Inverts prior refactoring recommenders (ReSynth, Refactoring Navigator, search-based refactoring).</a:t>
+              <a:t>[3] IDE-event logging (Damevski et al., CodeWatcher).</a:t>
             </a:r>
             <a:endParaRPr lang="en-US" sz="900" dirty="0"/>
           </a:p>

</xml_diff>

<commit_message>
minor changes: move tool e2e slide before demo
</commit_message>
<xml_diff>
--- a/presentation/slides.pptx
+++ b/presentation/slides.pptx
@@ -17173,8 +17173,8 @@
         </p:nvSpPr>
         <p:spPr>
           <a:xfrm>
-            <a:off x="457200" y="1783080"/>
-            <a:ext cx="8229600" cy="1097280"/>
+            <a:off x="457200" y="274320"/>
+            <a:ext cx="8229600" cy="640080"/>
           </a:xfrm>
           <a:prstGeom prst="rect">
             <a:avLst/>
@@ -17186,31 +17186,56 @@
           <a:bodyPr wrap="square" lIns="0" tIns="0" rIns="0" bIns="0" rtlCol="0" anchor="ctr"/>
           <a:lstStyle/>
           <a:p>
-            <a:pPr algn="ctr" indent="0" marL="0">
-              <a:buNone/>
-            </a:pPr>
-            <a:r>
-              <a:rPr lang="en-US" sz="6000" b="1" dirty="0">
+            <a:pPr indent="0" marL="0">
+              <a:buNone/>
+            </a:pPr>
+            <a:r>
+              <a:rPr lang="en-US" sz="2800" b="1" dirty="0">
                 <a:solidFill>
                   <a:srgbClr val="000000"/>
                 </a:solidFill>
               </a:rPr>
-              <a:t>Demo</a:t>
-            </a:r>
-            <a:endParaRPr lang="en-US" sz="6000" dirty="0"/>
+              <a:t>The tool, end to end: actionable refactoring process analysis</a:t>
+            </a:r>
+            <a:endParaRPr lang="en-US" sz="2800" dirty="0"/>
           </a:p>
         </p:txBody>
       </p:sp>
       <p:sp>
         <p:nvSpPr>
-          <p:cNvPr id="3" name="Text 1"/>
+          <p:cNvPr id="3" name="Shape 1"/>
           <p:cNvSpPr/>
           <p:nvPr/>
         </p:nvSpPr>
         <p:spPr>
           <a:xfrm>
-            <a:off x="457200" y="2971800"/>
-            <a:ext cx="8229600" cy="457200"/>
+            <a:off x="182880" y="1463040"/>
+            <a:ext cx="2377440" cy="2377440"/>
+          </a:xfrm>
+          <a:prstGeom prst="rect">
+            <a:avLst/>
+          </a:prstGeom>
+          <a:solidFill>
+            <a:srgbClr val="FFFFFF"/>
+          </a:solidFill>
+          <a:ln w="12700">
+            <a:solidFill>
+              <a:srgbClr val="000000"/>
+            </a:solidFill>
+            <a:prstDash val="solid"/>
+          </a:ln>
+        </p:spPr>
+      </p:sp>
+      <p:sp>
+        <p:nvSpPr>
+          <p:cNvPr id="4" name="Text 2"/>
+          <p:cNvSpPr/>
+          <p:nvPr/>
+        </p:nvSpPr>
+        <p:spPr>
+          <a:xfrm>
+            <a:off x="274320" y="1645920"/>
+            <a:ext cx="2194560" cy="457200"/>
           </a:xfrm>
           <a:prstGeom prst="rect">
             <a:avLst/>
@@ -17226,14 +17251,531 @@
               <a:buNone/>
             </a:pPr>
             <a:r>
-              <a:rPr lang="en-US" sz="2000" i="1" dirty="0">
+              <a:rPr lang="en-US" sz="1600" b="1" dirty="0">
+                <a:solidFill>
+                  <a:srgbClr val="000000"/>
+                </a:solidFill>
+              </a:rPr>
+              <a:t>IntelliJ Plugin</a:t>
+            </a:r>
+            <a:endParaRPr lang="en-US" sz="1600" dirty="0"/>
+          </a:p>
+        </p:txBody>
+      </p:sp>
+      <p:sp>
+        <p:nvSpPr>
+          <p:cNvPr id="5" name="Shape 3"/>
+          <p:cNvSpPr/>
+          <p:nvPr/>
+        </p:nvSpPr>
+        <p:spPr>
+          <a:xfrm>
+            <a:off x="457200" y="2194560"/>
+            <a:ext cx="1828800" cy="0"/>
+          </a:xfrm>
+          <a:prstGeom prst="line">
+            <a:avLst/>
+          </a:prstGeom>
+          <a:noFill/>
+          <a:ln w="9525">
+            <a:solidFill>
+              <a:srgbClr val="999999"/>
+            </a:solidFill>
+            <a:prstDash val="solid"/>
+          </a:ln>
+        </p:spPr>
+      </p:sp>
+      <p:sp>
+        <p:nvSpPr>
+          <p:cNvPr id="6" name="Text 4"/>
+          <p:cNvSpPr/>
+          <p:nvPr/>
+        </p:nvSpPr>
+        <p:spPr>
+          <a:xfrm>
+            <a:off x="411480" y="2377440"/>
+            <a:ext cx="2011680" cy="1371600"/>
+          </a:xfrm>
+          <a:prstGeom prst="rect">
+            <a:avLst/>
+          </a:prstGeom>
+          <a:noFill/>
+          <a:ln/>
+        </p:spPr>
+        <p:txBody>
+          <a:bodyPr wrap="square" rtlCol="0" anchor="t"/>
+          <a:lstStyle/>
+          <a:p>
+            <a:pPr marL="342900" indent="-342900">
+              <a:spcAft>
+                <a:spcPts val="800"/>
+              </a:spcAft>
+              <a:buSzPct val="100000"/>
+              <a:buChar char="•"/>
+            </a:pPr>
+            <a:r>
+              <a:rPr lang="en-US" sz="1200" dirty="0">
+                <a:solidFill>
+                  <a:srgbClr val="333333"/>
+                </a:solidFill>
+              </a:rPr>
+              <a:t>Records developer events</a:t>
+            </a:r>
+            <a:endParaRPr lang="en-US" sz="1200" dirty="0"/>
+          </a:p>
+          <a:p>
+            <a:pPr marL="342900" indent="-342900">
+              <a:spcAft>
+                <a:spcPts val="800"/>
+              </a:spcAft>
+              <a:buSzPct val="100000"/>
+              <a:buChar char="•"/>
+            </a:pPr>
+            <a:r>
+              <a:rPr lang="en-US" sz="1200" dirty="0">
+                <a:solidFill>
+                  <a:srgbClr val="333333"/>
+                </a:solidFill>
+              </a:rPr>
+              <a:t>Captures initial codebase</a:t>
+            </a:r>
+            <a:endParaRPr lang="en-US" sz="1200" dirty="0"/>
+          </a:p>
+        </p:txBody>
+      </p:sp>
+      <p:sp>
+        <p:nvSpPr>
+          <p:cNvPr id="7" name="Shape 5"/>
+          <p:cNvSpPr/>
+          <p:nvPr/>
+        </p:nvSpPr>
+        <p:spPr>
+          <a:xfrm>
+            <a:off x="3383280" y="1463040"/>
+            <a:ext cx="2377440" cy="2377440"/>
+          </a:xfrm>
+          <a:prstGeom prst="rect">
+            <a:avLst/>
+          </a:prstGeom>
+          <a:solidFill>
+            <a:srgbClr val="FFFFFF"/>
+          </a:solidFill>
+          <a:ln w="12700">
+            <a:solidFill>
+              <a:srgbClr val="000000"/>
+            </a:solidFill>
+            <a:prstDash val="solid"/>
+          </a:ln>
+        </p:spPr>
+      </p:sp>
+      <p:sp>
+        <p:nvSpPr>
+          <p:cNvPr id="8" name="Text 6"/>
+          <p:cNvSpPr/>
+          <p:nvPr/>
+        </p:nvSpPr>
+        <p:spPr>
+          <a:xfrm>
+            <a:off x="3474720" y="1645920"/>
+            <a:ext cx="2194560" cy="457200"/>
+          </a:xfrm>
+          <a:prstGeom prst="rect">
+            <a:avLst/>
+          </a:prstGeom>
+          <a:noFill/>
+          <a:ln/>
+        </p:spPr>
+        <p:txBody>
+          <a:bodyPr wrap="square" lIns="0" tIns="0" rIns="0" bIns="0" rtlCol="0" anchor="ctr"/>
+          <a:lstStyle/>
+          <a:p>
+            <a:pPr algn="ctr" indent="0" marL="0">
+              <a:buNone/>
+            </a:pPr>
+            <a:r>
+              <a:rPr lang="en-US" sz="1600" b="1" dirty="0">
+                <a:solidFill>
+                  <a:srgbClr val="000000"/>
+                </a:solidFill>
+              </a:rPr>
+              <a:t>Analysis Backend</a:t>
+            </a:r>
+            <a:endParaRPr lang="en-US" sz="1600" dirty="0"/>
+          </a:p>
+        </p:txBody>
+      </p:sp>
+      <p:sp>
+        <p:nvSpPr>
+          <p:cNvPr id="9" name="Shape 7"/>
+          <p:cNvSpPr/>
+          <p:nvPr/>
+        </p:nvSpPr>
+        <p:spPr>
+          <a:xfrm>
+            <a:off x="3657600" y="2194560"/>
+            <a:ext cx="1828800" cy="0"/>
+          </a:xfrm>
+          <a:prstGeom prst="line">
+            <a:avLst/>
+          </a:prstGeom>
+          <a:noFill/>
+          <a:ln w="9525">
+            <a:solidFill>
+              <a:srgbClr val="999999"/>
+            </a:solidFill>
+            <a:prstDash val="solid"/>
+          </a:ln>
+        </p:spPr>
+      </p:sp>
+      <p:sp>
+        <p:nvSpPr>
+          <p:cNvPr id="10" name="Text 8"/>
+          <p:cNvSpPr/>
+          <p:nvPr/>
+        </p:nvSpPr>
+        <p:spPr>
+          <a:xfrm>
+            <a:off x="3611880" y="2377440"/>
+            <a:ext cx="2011680" cy="1371600"/>
+          </a:xfrm>
+          <a:prstGeom prst="rect">
+            <a:avLst/>
+          </a:prstGeom>
+          <a:noFill/>
+          <a:ln/>
+        </p:spPr>
+        <p:txBody>
+          <a:bodyPr wrap="square" rtlCol="0" anchor="t"/>
+          <a:lstStyle/>
+          <a:p>
+            <a:pPr marL="342900" indent="-342900">
+              <a:spcAft>
+                <a:spcPts val="800"/>
+              </a:spcAft>
+              <a:buSzPct val="100000"/>
+              <a:buChar char="•"/>
+            </a:pPr>
+            <a:r>
+              <a:rPr lang="en-US" sz="1200" dirty="0">
+                <a:solidFill>
+                  <a:srgbClr val="333333"/>
+                </a:solidFill>
+              </a:rPr>
+              <a:t>Shadow repo reconstruction</a:t>
+            </a:r>
+            <a:endParaRPr lang="en-US" sz="1200" dirty="0"/>
+          </a:p>
+          <a:p>
+            <a:pPr marL="342900" indent="-342900">
+              <a:spcAft>
+                <a:spcPts val="800"/>
+              </a:spcAft>
+              <a:buSzPct val="100000"/>
+              <a:buChar char="•"/>
+            </a:pPr>
+            <a:r>
+              <a:rPr lang="en-US" sz="1200" dirty="0">
+                <a:solidFill>
+                  <a:srgbClr val="333333"/>
+                </a:solidFill>
+              </a:rPr>
+              <a:t>Metric calculation</a:t>
+            </a:r>
+            <a:endParaRPr lang="en-US" sz="1200" dirty="0"/>
+          </a:p>
+          <a:p>
+            <a:pPr marL="342900" indent="-342900">
+              <a:spcAft>
+                <a:spcPts val="800"/>
+              </a:spcAft>
+              <a:buSzPct val="100000"/>
+              <a:buChar char="•"/>
+            </a:pPr>
+            <a:r>
+              <a:rPr lang="en-US" sz="1200" dirty="0">
+                <a:solidFill>
+                  <a:srgbClr val="333333"/>
+                </a:solidFill>
+              </a:rPr>
+              <a:t>Divergence detection &amp; synthesis</a:t>
+            </a:r>
+            <a:endParaRPr lang="en-US" sz="1200" dirty="0"/>
+          </a:p>
+        </p:txBody>
+      </p:sp>
+      <p:sp>
+        <p:nvSpPr>
+          <p:cNvPr id="11" name="Shape 9"/>
+          <p:cNvSpPr/>
+          <p:nvPr/>
+        </p:nvSpPr>
+        <p:spPr>
+          <a:xfrm>
+            <a:off x="6583680" y="1463040"/>
+            <a:ext cx="2377440" cy="2377440"/>
+          </a:xfrm>
+          <a:prstGeom prst="rect">
+            <a:avLst/>
+          </a:prstGeom>
+          <a:solidFill>
+            <a:srgbClr val="FFFFFF"/>
+          </a:solidFill>
+          <a:ln w="12700">
+            <a:solidFill>
+              <a:srgbClr val="000000"/>
+            </a:solidFill>
+            <a:prstDash val="solid"/>
+          </a:ln>
+        </p:spPr>
+      </p:sp>
+      <p:sp>
+        <p:nvSpPr>
+          <p:cNvPr id="12" name="Text 10"/>
+          <p:cNvSpPr/>
+          <p:nvPr/>
+        </p:nvSpPr>
+        <p:spPr>
+          <a:xfrm>
+            <a:off x="6675120" y="1645920"/>
+            <a:ext cx="2194560" cy="457200"/>
+          </a:xfrm>
+          <a:prstGeom prst="rect">
+            <a:avLst/>
+          </a:prstGeom>
+          <a:noFill/>
+          <a:ln/>
+        </p:spPr>
+        <p:txBody>
+          <a:bodyPr wrap="square" lIns="0" tIns="0" rIns="0" bIns="0" rtlCol="0" anchor="ctr"/>
+          <a:lstStyle/>
+          <a:p>
+            <a:pPr algn="ctr" indent="0" marL="0">
+              <a:buNone/>
+            </a:pPr>
+            <a:r>
+              <a:rPr lang="en-US" sz="1600" b="1" dirty="0">
+                <a:solidFill>
+                  <a:srgbClr val="000000"/>
+                </a:solidFill>
+              </a:rPr>
+              <a:t>Dashboard</a:t>
+            </a:r>
+            <a:endParaRPr lang="en-US" sz="1600" dirty="0"/>
+          </a:p>
+        </p:txBody>
+      </p:sp>
+      <p:sp>
+        <p:nvSpPr>
+          <p:cNvPr id="13" name="Shape 11"/>
+          <p:cNvSpPr/>
+          <p:nvPr/>
+        </p:nvSpPr>
+        <p:spPr>
+          <a:xfrm>
+            <a:off x="6858000" y="2194560"/>
+            <a:ext cx="1828800" cy="0"/>
+          </a:xfrm>
+          <a:prstGeom prst="line">
+            <a:avLst/>
+          </a:prstGeom>
+          <a:noFill/>
+          <a:ln w="9525">
+            <a:solidFill>
+              <a:srgbClr val="999999"/>
+            </a:solidFill>
+            <a:prstDash val="solid"/>
+          </a:ln>
+        </p:spPr>
+      </p:sp>
+      <p:sp>
+        <p:nvSpPr>
+          <p:cNvPr id="14" name="Text 12"/>
+          <p:cNvSpPr/>
+          <p:nvPr/>
+        </p:nvSpPr>
+        <p:spPr>
+          <a:xfrm>
+            <a:off x="6812280" y="2377440"/>
+            <a:ext cx="2011680" cy="1371600"/>
+          </a:xfrm>
+          <a:prstGeom prst="rect">
+            <a:avLst/>
+          </a:prstGeom>
+          <a:noFill/>
+          <a:ln/>
+        </p:spPr>
+        <p:txBody>
+          <a:bodyPr wrap="square" rtlCol="0" anchor="t"/>
+          <a:lstStyle/>
+          <a:p>
+            <a:pPr marL="342900" indent="-342900">
+              <a:spcAft>
+                <a:spcPts val="800"/>
+              </a:spcAft>
+              <a:buSzPct val="100000"/>
+              <a:buChar char="•"/>
+            </a:pPr>
+            <a:r>
+              <a:rPr lang="en-US" sz="1200" dirty="0">
+                <a:solidFill>
+                  <a:srgbClr val="333333"/>
+                </a:solidFill>
+              </a:rPr>
+              <a:t>Surfaces divergence points in context</a:t>
+            </a:r>
+            <a:endParaRPr lang="en-US" sz="1200" dirty="0"/>
+          </a:p>
+          <a:p>
+            <a:pPr marL="342900" indent="-342900">
+              <a:spcAft>
+                <a:spcPts val="800"/>
+              </a:spcAft>
+              <a:buSzPct val="100000"/>
+              <a:buChar char="•"/>
+            </a:pPr>
+            <a:r>
+              <a:rPr lang="en-US" sz="1200" dirty="0">
+                <a:solidFill>
+                  <a:srgbClr val="333333"/>
+                </a:solidFill>
+              </a:rPr>
+              <a:t>Explains alternative paths</a:t>
+            </a:r>
+            <a:endParaRPr lang="en-US" sz="1200" dirty="0"/>
+          </a:p>
+        </p:txBody>
+      </p:sp>
+      <p:sp>
+        <p:nvSpPr>
+          <p:cNvPr id="15" name="Shape 13"/>
+          <p:cNvSpPr/>
+          <p:nvPr/>
+        </p:nvSpPr>
+        <p:spPr>
+          <a:xfrm>
+            <a:off x="2560320" y="2651760"/>
+            <a:ext cx="822960" cy="0"/>
+          </a:xfrm>
+          <a:prstGeom prst="line">
+            <a:avLst/>
+          </a:prstGeom>
+          <a:noFill/>
+          <a:ln w="19050">
+            <a:solidFill>
+              <a:srgbClr val="000000"/>
+            </a:solidFill>
+            <a:prstDash val="solid"/>
+            <a:tailEnd type="triangle"/>
+          </a:ln>
+        </p:spPr>
+      </p:sp>
+      <p:sp>
+        <p:nvSpPr>
+          <p:cNvPr id="16" name="Text 14"/>
+          <p:cNvSpPr/>
+          <p:nvPr/>
+        </p:nvSpPr>
+        <p:spPr>
+          <a:xfrm>
+            <a:off x="2514600" y="2148840"/>
+            <a:ext cx="914400" cy="457200"/>
+          </a:xfrm>
+          <a:prstGeom prst="rect">
+            <a:avLst/>
+          </a:prstGeom>
+          <a:noFill/>
+          <a:ln/>
+        </p:spPr>
+        <p:txBody>
+          <a:bodyPr wrap="square" lIns="0" tIns="0" rIns="0" bIns="0" rtlCol="0" anchor="b"/>
+          <a:lstStyle/>
+          <a:p>
+            <a:pPr algn="ctr" indent="0" marL="0">
+              <a:buNone/>
+            </a:pPr>
+            <a:r>
+              <a:rPr lang="en-US" sz="900" i="1" dirty="0">
                 <a:solidFill>
                   <a:srgbClr val="555555"/>
                 </a:solidFill>
               </a:rPr>
-              <a:t>OrderProcessor: Breaking up a long method into smaller methods</a:t>
-            </a:r>
-            <a:endParaRPr lang="en-US" sz="2000" dirty="0"/>
+              <a:t>events.jsonl + initial-src/</a:t>
+            </a:r>
+            <a:endParaRPr lang="en-US" sz="900" dirty="0"/>
+          </a:p>
+        </p:txBody>
+      </p:sp>
+      <p:sp>
+        <p:nvSpPr>
+          <p:cNvPr id="17" name="Shape 15"/>
+          <p:cNvSpPr/>
+          <p:nvPr/>
+        </p:nvSpPr>
+        <p:spPr>
+          <a:xfrm>
+            <a:off x="5760720" y="2651760"/>
+            <a:ext cx="822960" cy="0"/>
+          </a:xfrm>
+          <a:prstGeom prst="line">
+            <a:avLst/>
+          </a:prstGeom>
+          <a:noFill/>
+          <a:ln w="19050">
+            <a:solidFill>
+              <a:srgbClr val="000000"/>
+            </a:solidFill>
+            <a:prstDash val="solid"/>
+            <a:tailEnd type="triangle"/>
+          </a:ln>
+        </p:spPr>
+      </p:sp>
+      <p:sp>
+        <p:nvSpPr>
+          <p:cNvPr id="18" name="Text 16"/>
+          <p:cNvSpPr/>
+          <p:nvPr/>
+        </p:nvSpPr>
+        <p:spPr>
+          <a:xfrm>
+            <a:off x="5715000" y="2148840"/>
+            <a:ext cx="914400" cy="457200"/>
+          </a:xfrm>
+          <a:prstGeom prst="rect">
+            <a:avLst/>
+          </a:prstGeom>
+          <a:noFill/>
+          <a:ln/>
+        </p:spPr>
+        <p:txBody>
+          <a:bodyPr wrap="square" lIns="0" tIns="0" rIns="0" bIns="0" rtlCol="0" anchor="b"/>
+          <a:lstStyle/>
+          <a:p>
+            <a:pPr algn="ctr" indent="0" marL="0">
+              <a:buNone/>
+            </a:pPr>
+            <a:r>
+              <a:rPr lang="en-US" sz="900" i="1" dirty="0">
+                <a:solidFill>
+                  <a:srgbClr val="555555"/>
+                </a:solidFill>
+              </a:rPr>
+              <a:t>analysis</a:t>
+            </a:r>
+            <a:endParaRPr lang="en-US" sz="900" dirty="0"/>
+          </a:p>
+          <a:p>
+            <a:pPr algn="ctr" indent="0" marL="0">
+              <a:buNone/>
+            </a:pPr>
+            <a:r>
+              <a:rPr lang="en-US" sz="900" i="1" dirty="0">
+                <a:solidFill>
+                  <a:srgbClr val="555555"/>
+                </a:solidFill>
+              </a:rPr>
+              <a:t>-report.json</a:t>
+            </a:r>
+            <a:endParaRPr lang="en-US" sz="900" dirty="0"/>
           </a:p>
         </p:txBody>
       </p:sp>
@@ -17270,8 +17812,8 @@
         </p:nvSpPr>
         <p:spPr>
           <a:xfrm>
-            <a:off x="457200" y="274320"/>
-            <a:ext cx="8229600" cy="640080"/>
+            <a:off x="457200" y="1783080"/>
+            <a:ext cx="8229600" cy="1097280"/>
           </a:xfrm>
           <a:prstGeom prst="rect">
             <a:avLst/>
@@ -17283,56 +17825,31 @@
           <a:bodyPr wrap="square" lIns="0" tIns="0" rIns="0" bIns="0" rtlCol="0" anchor="ctr"/>
           <a:lstStyle/>
           <a:p>
-            <a:pPr indent="0" marL="0">
-              <a:buNone/>
-            </a:pPr>
-            <a:r>
-              <a:rPr lang="en-US" sz="2800" b="1" dirty="0">
+            <a:pPr algn="ctr" indent="0" marL="0">
+              <a:buNone/>
+            </a:pPr>
+            <a:r>
+              <a:rPr lang="en-US" sz="6000" b="1" dirty="0">
                 <a:solidFill>
                   <a:srgbClr val="000000"/>
                 </a:solidFill>
               </a:rPr>
-              <a:t>What the tool does, end to end</a:t>
-            </a:r>
-            <a:endParaRPr lang="en-US" sz="2800" dirty="0"/>
+              <a:t>Demo</a:t>
+            </a:r>
+            <a:endParaRPr lang="en-US" sz="6000" dirty="0"/>
           </a:p>
         </p:txBody>
       </p:sp>
       <p:sp>
         <p:nvSpPr>
-          <p:cNvPr id="3" name="Shape 1"/>
+          <p:cNvPr id="3" name="Text 1"/>
           <p:cNvSpPr/>
           <p:nvPr/>
         </p:nvSpPr>
         <p:spPr>
           <a:xfrm>
-            <a:off x="182880" y="1463040"/>
-            <a:ext cx="2377440" cy="2377440"/>
-          </a:xfrm>
-          <a:prstGeom prst="rect">
-            <a:avLst/>
-          </a:prstGeom>
-          <a:solidFill>
-            <a:srgbClr val="FFFFFF"/>
-          </a:solidFill>
-          <a:ln w="12700">
-            <a:solidFill>
-              <a:srgbClr val="000000"/>
-            </a:solidFill>
-            <a:prstDash val="solid"/>
-          </a:ln>
-        </p:spPr>
-      </p:sp>
-      <p:sp>
-        <p:nvSpPr>
-          <p:cNvPr id="4" name="Text 2"/>
-          <p:cNvSpPr/>
-          <p:nvPr/>
-        </p:nvSpPr>
-        <p:spPr>
-          <a:xfrm>
-            <a:off x="274320" y="1645920"/>
-            <a:ext cx="2194560" cy="457200"/>
+            <a:off x="457200" y="2971800"/>
+            <a:ext cx="8229600" cy="457200"/>
           </a:xfrm>
           <a:prstGeom prst="rect">
             <a:avLst/>
@@ -17348,531 +17865,14 @@
               <a:buNone/>
             </a:pPr>
             <a:r>
-              <a:rPr lang="en-US" sz="1600" b="1" dirty="0">
-                <a:solidFill>
-                  <a:srgbClr val="000000"/>
-                </a:solidFill>
-              </a:rPr>
-              <a:t>IntelliJ Plugin</a:t>
-            </a:r>
-            <a:endParaRPr lang="en-US" sz="1600" dirty="0"/>
-          </a:p>
-        </p:txBody>
-      </p:sp>
-      <p:sp>
-        <p:nvSpPr>
-          <p:cNvPr id="5" name="Shape 3"/>
-          <p:cNvSpPr/>
-          <p:nvPr/>
-        </p:nvSpPr>
-        <p:spPr>
-          <a:xfrm>
-            <a:off x="457200" y="2194560"/>
-            <a:ext cx="1828800" cy="0"/>
-          </a:xfrm>
-          <a:prstGeom prst="line">
-            <a:avLst/>
-          </a:prstGeom>
-          <a:noFill/>
-          <a:ln w="9525">
-            <a:solidFill>
-              <a:srgbClr val="999999"/>
-            </a:solidFill>
-            <a:prstDash val="solid"/>
-          </a:ln>
-        </p:spPr>
-      </p:sp>
-      <p:sp>
-        <p:nvSpPr>
-          <p:cNvPr id="6" name="Text 4"/>
-          <p:cNvSpPr/>
-          <p:nvPr/>
-        </p:nvSpPr>
-        <p:spPr>
-          <a:xfrm>
-            <a:off x="411480" y="2377440"/>
-            <a:ext cx="2011680" cy="1371600"/>
-          </a:xfrm>
-          <a:prstGeom prst="rect">
-            <a:avLst/>
-          </a:prstGeom>
-          <a:noFill/>
-          <a:ln/>
-        </p:spPr>
-        <p:txBody>
-          <a:bodyPr wrap="square" rtlCol="0" anchor="t"/>
-          <a:lstStyle/>
-          <a:p>
-            <a:pPr marL="342900" indent="-342900">
-              <a:spcAft>
-                <a:spcPts val="800"/>
-              </a:spcAft>
-              <a:buSzPct val="100000"/>
-              <a:buChar char="•"/>
-            </a:pPr>
-            <a:r>
-              <a:rPr lang="en-US" sz="1200" dirty="0">
-                <a:solidFill>
-                  <a:srgbClr val="333333"/>
-                </a:solidFill>
-              </a:rPr>
-              <a:t>Records developer events</a:t>
-            </a:r>
-            <a:endParaRPr lang="en-US" sz="1200" dirty="0"/>
-          </a:p>
-          <a:p>
-            <a:pPr marL="342900" indent="-342900">
-              <a:spcAft>
-                <a:spcPts val="800"/>
-              </a:spcAft>
-              <a:buSzPct val="100000"/>
-              <a:buChar char="•"/>
-            </a:pPr>
-            <a:r>
-              <a:rPr lang="en-US" sz="1200" dirty="0">
-                <a:solidFill>
-                  <a:srgbClr val="333333"/>
-                </a:solidFill>
-              </a:rPr>
-              <a:t>Captures initial codebase</a:t>
-            </a:r>
-            <a:endParaRPr lang="en-US" sz="1200" dirty="0"/>
-          </a:p>
-        </p:txBody>
-      </p:sp>
-      <p:sp>
-        <p:nvSpPr>
-          <p:cNvPr id="7" name="Shape 5"/>
-          <p:cNvSpPr/>
-          <p:nvPr/>
-        </p:nvSpPr>
-        <p:spPr>
-          <a:xfrm>
-            <a:off x="3383280" y="1463040"/>
-            <a:ext cx="2377440" cy="2377440"/>
-          </a:xfrm>
-          <a:prstGeom prst="rect">
-            <a:avLst/>
-          </a:prstGeom>
-          <a:solidFill>
-            <a:srgbClr val="FFFFFF"/>
-          </a:solidFill>
-          <a:ln w="12700">
-            <a:solidFill>
-              <a:srgbClr val="000000"/>
-            </a:solidFill>
-            <a:prstDash val="solid"/>
-          </a:ln>
-        </p:spPr>
-      </p:sp>
-      <p:sp>
-        <p:nvSpPr>
-          <p:cNvPr id="8" name="Text 6"/>
-          <p:cNvSpPr/>
-          <p:nvPr/>
-        </p:nvSpPr>
-        <p:spPr>
-          <a:xfrm>
-            <a:off x="3474720" y="1645920"/>
-            <a:ext cx="2194560" cy="457200"/>
-          </a:xfrm>
-          <a:prstGeom prst="rect">
-            <a:avLst/>
-          </a:prstGeom>
-          <a:noFill/>
-          <a:ln/>
-        </p:spPr>
-        <p:txBody>
-          <a:bodyPr wrap="square" lIns="0" tIns="0" rIns="0" bIns="0" rtlCol="0" anchor="ctr"/>
-          <a:lstStyle/>
-          <a:p>
-            <a:pPr algn="ctr" indent="0" marL="0">
-              <a:buNone/>
-            </a:pPr>
-            <a:r>
-              <a:rPr lang="en-US" sz="1600" b="1" dirty="0">
-                <a:solidFill>
-                  <a:srgbClr val="000000"/>
-                </a:solidFill>
-              </a:rPr>
-              <a:t>Analysis Backend</a:t>
-            </a:r>
-            <a:endParaRPr lang="en-US" sz="1600" dirty="0"/>
-          </a:p>
-        </p:txBody>
-      </p:sp>
-      <p:sp>
-        <p:nvSpPr>
-          <p:cNvPr id="9" name="Shape 7"/>
-          <p:cNvSpPr/>
-          <p:nvPr/>
-        </p:nvSpPr>
-        <p:spPr>
-          <a:xfrm>
-            <a:off x="3657600" y="2194560"/>
-            <a:ext cx="1828800" cy="0"/>
-          </a:xfrm>
-          <a:prstGeom prst="line">
-            <a:avLst/>
-          </a:prstGeom>
-          <a:noFill/>
-          <a:ln w="9525">
-            <a:solidFill>
-              <a:srgbClr val="999999"/>
-            </a:solidFill>
-            <a:prstDash val="solid"/>
-          </a:ln>
-        </p:spPr>
-      </p:sp>
-      <p:sp>
-        <p:nvSpPr>
-          <p:cNvPr id="10" name="Text 8"/>
-          <p:cNvSpPr/>
-          <p:nvPr/>
-        </p:nvSpPr>
-        <p:spPr>
-          <a:xfrm>
-            <a:off x="3611880" y="2377440"/>
-            <a:ext cx="2011680" cy="1371600"/>
-          </a:xfrm>
-          <a:prstGeom prst="rect">
-            <a:avLst/>
-          </a:prstGeom>
-          <a:noFill/>
-          <a:ln/>
-        </p:spPr>
-        <p:txBody>
-          <a:bodyPr wrap="square" rtlCol="0" anchor="t"/>
-          <a:lstStyle/>
-          <a:p>
-            <a:pPr marL="342900" indent="-342900">
-              <a:spcAft>
-                <a:spcPts val="800"/>
-              </a:spcAft>
-              <a:buSzPct val="100000"/>
-              <a:buChar char="•"/>
-            </a:pPr>
-            <a:r>
-              <a:rPr lang="en-US" sz="1200" dirty="0">
-                <a:solidFill>
-                  <a:srgbClr val="333333"/>
-                </a:solidFill>
-              </a:rPr>
-              <a:t>Shadow repo reconstruction</a:t>
-            </a:r>
-            <a:endParaRPr lang="en-US" sz="1200" dirty="0"/>
-          </a:p>
-          <a:p>
-            <a:pPr marL="342900" indent="-342900">
-              <a:spcAft>
-                <a:spcPts val="800"/>
-              </a:spcAft>
-              <a:buSzPct val="100000"/>
-              <a:buChar char="•"/>
-            </a:pPr>
-            <a:r>
-              <a:rPr lang="en-US" sz="1200" dirty="0">
-                <a:solidFill>
-                  <a:srgbClr val="333333"/>
-                </a:solidFill>
-              </a:rPr>
-              <a:t>Metric calculation</a:t>
-            </a:r>
-            <a:endParaRPr lang="en-US" sz="1200" dirty="0"/>
-          </a:p>
-          <a:p>
-            <a:pPr marL="342900" indent="-342900">
-              <a:spcAft>
-                <a:spcPts val="800"/>
-              </a:spcAft>
-              <a:buSzPct val="100000"/>
-              <a:buChar char="•"/>
-            </a:pPr>
-            <a:r>
-              <a:rPr lang="en-US" sz="1200" dirty="0">
-                <a:solidFill>
-                  <a:srgbClr val="333333"/>
-                </a:solidFill>
-              </a:rPr>
-              <a:t>Divergence detection &amp; synthesis</a:t>
-            </a:r>
-            <a:endParaRPr lang="en-US" sz="1200" dirty="0"/>
-          </a:p>
-        </p:txBody>
-      </p:sp>
-      <p:sp>
-        <p:nvSpPr>
-          <p:cNvPr id="11" name="Shape 9"/>
-          <p:cNvSpPr/>
-          <p:nvPr/>
-        </p:nvSpPr>
-        <p:spPr>
-          <a:xfrm>
-            <a:off x="6583680" y="1463040"/>
-            <a:ext cx="2377440" cy="2377440"/>
-          </a:xfrm>
-          <a:prstGeom prst="rect">
-            <a:avLst/>
-          </a:prstGeom>
-          <a:solidFill>
-            <a:srgbClr val="FFFFFF"/>
-          </a:solidFill>
-          <a:ln w="12700">
-            <a:solidFill>
-              <a:srgbClr val="000000"/>
-            </a:solidFill>
-            <a:prstDash val="solid"/>
-          </a:ln>
-        </p:spPr>
-      </p:sp>
-      <p:sp>
-        <p:nvSpPr>
-          <p:cNvPr id="12" name="Text 10"/>
-          <p:cNvSpPr/>
-          <p:nvPr/>
-        </p:nvSpPr>
-        <p:spPr>
-          <a:xfrm>
-            <a:off x="6675120" y="1645920"/>
-            <a:ext cx="2194560" cy="457200"/>
-          </a:xfrm>
-          <a:prstGeom prst="rect">
-            <a:avLst/>
-          </a:prstGeom>
-          <a:noFill/>
-          <a:ln/>
-        </p:spPr>
-        <p:txBody>
-          <a:bodyPr wrap="square" lIns="0" tIns="0" rIns="0" bIns="0" rtlCol="0" anchor="ctr"/>
-          <a:lstStyle/>
-          <a:p>
-            <a:pPr algn="ctr" indent="0" marL="0">
-              <a:buNone/>
-            </a:pPr>
-            <a:r>
-              <a:rPr lang="en-US" sz="1600" b="1" dirty="0">
-                <a:solidFill>
-                  <a:srgbClr val="000000"/>
-                </a:solidFill>
-              </a:rPr>
-              <a:t>Dashboard</a:t>
-            </a:r>
-            <a:endParaRPr lang="en-US" sz="1600" dirty="0"/>
-          </a:p>
-        </p:txBody>
-      </p:sp>
-      <p:sp>
-        <p:nvSpPr>
-          <p:cNvPr id="13" name="Shape 11"/>
-          <p:cNvSpPr/>
-          <p:nvPr/>
-        </p:nvSpPr>
-        <p:spPr>
-          <a:xfrm>
-            <a:off x="6858000" y="2194560"/>
-            <a:ext cx="1828800" cy="0"/>
-          </a:xfrm>
-          <a:prstGeom prst="line">
-            <a:avLst/>
-          </a:prstGeom>
-          <a:noFill/>
-          <a:ln w="9525">
-            <a:solidFill>
-              <a:srgbClr val="999999"/>
-            </a:solidFill>
-            <a:prstDash val="solid"/>
-          </a:ln>
-        </p:spPr>
-      </p:sp>
-      <p:sp>
-        <p:nvSpPr>
-          <p:cNvPr id="14" name="Text 12"/>
-          <p:cNvSpPr/>
-          <p:nvPr/>
-        </p:nvSpPr>
-        <p:spPr>
-          <a:xfrm>
-            <a:off x="6812280" y="2377440"/>
-            <a:ext cx="2011680" cy="1371600"/>
-          </a:xfrm>
-          <a:prstGeom prst="rect">
-            <a:avLst/>
-          </a:prstGeom>
-          <a:noFill/>
-          <a:ln/>
-        </p:spPr>
-        <p:txBody>
-          <a:bodyPr wrap="square" rtlCol="0" anchor="t"/>
-          <a:lstStyle/>
-          <a:p>
-            <a:pPr marL="342900" indent="-342900">
-              <a:spcAft>
-                <a:spcPts val="800"/>
-              </a:spcAft>
-              <a:buSzPct val="100000"/>
-              <a:buChar char="•"/>
-            </a:pPr>
-            <a:r>
-              <a:rPr lang="en-US" sz="1200" dirty="0">
-                <a:solidFill>
-                  <a:srgbClr val="333333"/>
-                </a:solidFill>
-              </a:rPr>
-              <a:t>Surfaces divergence points in context</a:t>
-            </a:r>
-            <a:endParaRPr lang="en-US" sz="1200" dirty="0"/>
-          </a:p>
-          <a:p>
-            <a:pPr marL="342900" indent="-342900">
-              <a:spcAft>
-                <a:spcPts val="800"/>
-              </a:spcAft>
-              <a:buSzPct val="100000"/>
-              <a:buChar char="•"/>
-            </a:pPr>
-            <a:r>
-              <a:rPr lang="en-US" sz="1200" dirty="0">
-                <a:solidFill>
-                  <a:srgbClr val="333333"/>
-                </a:solidFill>
-              </a:rPr>
-              <a:t>Explains alternative paths</a:t>
-            </a:r>
-            <a:endParaRPr lang="en-US" sz="1200" dirty="0"/>
-          </a:p>
-        </p:txBody>
-      </p:sp>
-      <p:sp>
-        <p:nvSpPr>
-          <p:cNvPr id="15" name="Shape 13"/>
-          <p:cNvSpPr/>
-          <p:nvPr/>
-        </p:nvSpPr>
-        <p:spPr>
-          <a:xfrm>
-            <a:off x="2560320" y="2651760"/>
-            <a:ext cx="822960" cy="0"/>
-          </a:xfrm>
-          <a:prstGeom prst="line">
-            <a:avLst/>
-          </a:prstGeom>
-          <a:noFill/>
-          <a:ln w="19050">
-            <a:solidFill>
-              <a:srgbClr val="000000"/>
-            </a:solidFill>
-            <a:prstDash val="solid"/>
-            <a:tailEnd type="triangle"/>
-          </a:ln>
-        </p:spPr>
-      </p:sp>
-      <p:sp>
-        <p:nvSpPr>
-          <p:cNvPr id="16" name="Text 14"/>
-          <p:cNvSpPr/>
-          <p:nvPr/>
-        </p:nvSpPr>
-        <p:spPr>
-          <a:xfrm>
-            <a:off x="2514600" y="2148840"/>
-            <a:ext cx="914400" cy="457200"/>
-          </a:xfrm>
-          <a:prstGeom prst="rect">
-            <a:avLst/>
-          </a:prstGeom>
-          <a:noFill/>
-          <a:ln/>
-        </p:spPr>
-        <p:txBody>
-          <a:bodyPr wrap="square" lIns="0" tIns="0" rIns="0" bIns="0" rtlCol="0" anchor="b"/>
-          <a:lstStyle/>
-          <a:p>
-            <a:pPr algn="ctr" indent="0" marL="0">
-              <a:buNone/>
-            </a:pPr>
-            <a:r>
-              <a:rPr lang="en-US" sz="900" i="1" dirty="0">
+              <a:rPr lang="en-US" sz="2000" i="1" dirty="0">
                 <a:solidFill>
                   <a:srgbClr val="555555"/>
                 </a:solidFill>
               </a:rPr>
-              <a:t>events.jsonl + initial-src/</a:t>
-            </a:r>
-            <a:endParaRPr lang="en-US" sz="900" dirty="0"/>
-          </a:p>
-        </p:txBody>
-      </p:sp>
-      <p:sp>
-        <p:nvSpPr>
-          <p:cNvPr id="17" name="Shape 15"/>
-          <p:cNvSpPr/>
-          <p:nvPr/>
-        </p:nvSpPr>
-        <p:spPr>
-          <a:xfrm>
-            <a:off x="5760720" y="2651760"/>
-            <a:ext cx="822960" cy="0"/>
-          </a:xfrm>
-          <a:prstGeom prst="line">
-            <a:avLst/>
-          </a:prstGeom>
-          <a:noFill/>
-          <a:ln w="19050">
-            <a:solidFill>
-              <a:srgbClr val="000000"/>
-            </a:solidFill>
-            <a:prstDash val="solid"/>
-            <a:tailEnd type="triangle"/>
-          </a:ln>
-        </p:spPr>
-      </p:sp>
-      <p:sp>
-        <p:nvSpPr>
-          <p:cNvPr id="18" name="Text 16"/>
-          <p:cNvSpPr/>
-          <p:nvPr/>
-        </p:nvSpPr>
-        <p:spPr>
-          <a:xfrm>
-            <a:off x="5715000" y="2148840"/>
-            <a:ext cx="914400" cy="457200"/>
-          </a:xfrm>
-          <a:prstGeom prst="rect">
-            <a:avLst/>
-          </a:prstGeom>
-          <a:noFill/>
-          <a:ln/>
-        </p:spPr>
-        <p:txBody>
-          <a:bodyPr wrap="square" lIns="0" tIns="0" rIns="0" bIns="0" rtlCol="0" anchor="b"/>
-          <a:lstStyle/>
-          <a:p>
-            <a:pPr algn="ctr" indent="0" marL="0">
-              <a:buNone/>
-            </a:pPr>
-            <a:r>
-              <a:rPr lang="en-US" sz="900" i="1" dirty="0">
-                <a:solidFill>
-                  <a:srgbClr val="555555"/>
-                </a:solidFill>
-              </a:rPr>
-              <a:t>analysis</a:t>
-            </a:r>
-            <a:endParaRPr lang="en-US" sz="900" dirty="0"/>
-          </a:p>
-          <a:p>
-            <a:pPr algn="ctr" indent="0" marL="0">
-              <a:buNone/>
-            </a:pPr>
-            <a:r>
-              <a:rPr lang="en-US" sz="900" i="1" dirty="0">
-                <a:solidFill>
-                  <a:srgbClr val="555555"/>
-                </a:solidFill>
-              </a:rPr>
-              <a:t>-report.json</a:t>
-            </a:r>
-            <a:endParaRPr lang="en-US" sz="900" dirty="0"/>
+              <a:t>OrderProcessor: Breaking up a long method into smaller methods</a:t>
+            </a:r>
+            <a:endParaRPr lang="en-US" sz="2000" dirty="0"/>
           </a:p>
         </p:txBody>
       </p:sp>

</xml_diff>

<commit_message>
feat: add sumary slide for is the tool accurate
</commit_message>
<xml_diff>
--- a/presentation/slides.pptx
+++ b/presentation/slides.pptx
@@ -33,9 +33,10 @@
     <p:sldId id="281" r:id="rId27"/>
     <p:sldId id="282" r:id="rId28"/>
     <p:sldId id="283" r:id="rId29"/>
+    <p:sldId id="284" r:id="rId30"/>
   </p:sldIdLst>
   <p:notesMasterIdLst>
-    <p:notesMasterId r:id="rId30"/>
+    <p:notesMasterId r:id="rId31"/>
   </p:notesMasterIdLst>
   <p:sldSz cx="9144000" cy="5143500"/>
   <p:notesSz cx="5143500" cy="9144000"/>
@@ -4121,6 +4122,94 @@
             <a:fld id="{F7021451-1387-4CA6-816F-3879F97B5CBC}" type="slidenum">
               <a:rPr lang="en-US"/>
               <a:t>28</a:t>
+            </a:fld>
+            <a:endParaRPr lang="en-US"/>
+          </a:p>
+        </p:txBody>
+      </p:sp>
+    </p:spTree>
+    <p:extLst>
+      <p:ext uri="{BB962C8B-B14F-4D97-AF65-F5344CB8AC3E}">
+        <p14:creationId xmlns:p14="http://schemas.microsoft.com/office/powerpoint/2010/main" val="1024086991"/>
+      </p:ext>
+    </p:extLst>
+  </p:cSld>
+  <p:clrMapOvr>
+    <a:masterClrMapping/>
+  </p:clrMapOvr>
+</p:notes>
+</file>
+
+<file path=ppt/notesSlides/notesSlide29.xml><?xml version="1.0" encoding="utf-8"?>
+<p:notes xmlns:a="http://schemas.openxmlformats.org/drawingml/2006/main" xmlns:r="http://schemas.openxmlformats.org/officeDocument/2006/relationships" xmlns:p="http://schemas.openxmlformats.org/presentationml/2006/main">
+  <p:cSld>
+    <p:spTree>
+      <p:nvGrpSpPr>
+        <p:cNvPr id="1" name=""/>
+        <p:cNvGrpSpPr/>
+        <p:nvPr/>
+      </p:nvGrpSpPr>
+      <p:grpSpPr>
+        <a:xfrm>
+          <a:off x="0" y="0"/>
+          <a:ext cx="0" cy="0"/>
+          <a:chOff x="0" y="0"/>
+          <a:chExt cx="0" cy="0"/>
+        </a:xfrm>
+      </p:grpSpPr>
+      <p:sp>
+        <p:nvSpPr>
+          <p:cNvPr id="2" name="Slide Image Placeholder 1"/>
+          <p:cNvSpPr>
+            <a:spLocks noGrp="1" noRot="1" noChangeAspect="1"/>
+          </p:cNvSpPr>
+          <p:nvPr>
+            <p:ph type="sldImg"/>
+          </p:nvPr>
+        </p:nvSpPr>
+        <p:spPr/>
+      </p:sp>
+      <p:sp>
+        <p:nvSpPr>
+          <p:cNvPr id="3" name="Notes Placeholder 2"/>
+          <p:cNvSpPr>
+            <a:spLocks noGrp="1"/>
+          </p:cNvSpPr>
+          <p:nvPr>
+            <p:ph type="body" idx="1"/>
+          </p:nvPr>
+        </p:nvSpPr>
+        <p:spPr/>
+        <p:txBody>
+          <a:bodyPr/>
+          <a:lstStyle/>
+          <a:p>
+            <a:r>
+              <a:rPr lang="en-US" dirty="0"/>
+              <a:t/>
+            </a:r>
+            <a:endParaRPr lang="en-US" dirty="0"/>
+          </a:p>
+        </p:txBody>
+      </p:sp>
+      <p:sp>
+        <p:nvSpPr>
+          <p:cNvPr id="4" name="Slide Number Placeholder 3"/>
+          <p:cNvSpPr>
+            <a:spLocks noGrp="1"/>
+          </p:cNvSpPr>
+          <p:nvPr>
+            <p:ph type="sldNum" sz="quarter" idx="10"/>
+          </p:nvPr>
+        </p:nvSpPr>
+        <p:spPr/>
+        <p:txBody>
+          <a:bodyPr/>
+          <a:lstStyle/>
+          <a:p>
+            <a:fld id="{F7021451-1387-4CA6-816F-3879F97B5CBC}" type="slidenum">
+              <a:rPr lang="en-US"/>
+              <a:t>29</a:t>
             </a:fld>
             <a:endParaRPr lang="en-US"/>
           </a:p>
@@ -6689,7 +6778,7 @@
 </file>
 
 <file path=ppt/slides/slide16.xml><?xml version="1.0" encoding="utf-8"?>
-<p:sld xmlns:a="http://schemas.openxmlformats.org/drawingml/2006/main" xmlns:r="http://schemas.openxmlformats.org/officeDocument/2006/relationships" xmlns:p="http://schemas.openxmlformats.org/presentationml/2006/main">
+<p:sld xmlns:a="http://schemas.openxmlformats.org/drawingml/2006/main" xmlns:r="http://schemas.openxmlformats.org/officeDocument/2006/relationships" xmlns:p="http://schemas.openxmlformats.org/presentationml/2006/main" show="0">
   <p:cSld name="Slide 16">
     <p:spTree>
       <p:nvGrpSpPr>
@@ -6956,6 +7045,543 @@
         </p:nvSpPr>
         <p:spPr>
           <a:xfrm>
+            <a:off x="457200" y="137160"/>
+            <a:ext cx="8229600" cy="502920"/>
+          </a:xfrm>
+          <a:prstGeom prst="rect">
+            <a:avLst/>
+          </a:prstGeom>
+          <a:noFill/>
+          <a:ln/>
+        </p:spPr>
+        <p:txBody>
+          <a:bodyPr wrap="square" lIns="0" tIns="0" rIns="0" bIns="0" rtlCol="0" anchor="ctr"/>
+          <a:lstStyle/>
+          <a:p>
+            <a:pPr algn="ctr" indent="0" marL="0">
+              <a:buNone/>
+            </a:pPr>
+            <a:r>
+              <a:rPr lang="en-US" sz="2400" b="1" dirty="0">
+                <a:solidFill>
+                  <a:srgbClr val="000000"/>
+                </a:solidFill>
+              </a:rPr>
+              <a:t>Experiment 1: Is the tool accurate?</a:t>
+            </a:r>
+            <a:endParaRPr lang="en-US" sz="2400" dirty="0"/>
+          </a:p>
+        </p:txBody>
+      </p:sp>
+      <p:sp>
+        <p:nvSpPr>
+          <p:cNvPr id="3" name="Text 1"/>
+          <p:cNvSpPr/>
+          <p:nvPr/>
+        </p:nvSpPr>
+        <p:spPr>
+          <a:xfrm>
+            <a:off x="274320" y="731520"/>
+            <a:ext cx="4160520" cy="228600"/>
+          </a:xfrm>
+          <a:prstGeom prst="rect">
+            <a:avLst/>
+          </a:prstGeom>
+          <a:noFill/>
+          <a:ln/>
+        </p:spPr>
+        <p:txBody>
+          <a:bodyPr wrap="square" lIns="0" tIns="0" rIns="0" bIns="0" rtlCol="0" anchor="ctr"/>
+          <a:lstStyle/>
+          <a:p>
+            <a:pPr algn="ctr" indent="0" marL="0">
+              <a:buNone/>
+            </a:pPr>
+            <a:r>
+              <a:rPr lang="en-US" sz="1000" b="1" spc="200" kern="0" dirty="0">
+                <a:solidFill>
+                  <a:srgbClr val="888888"/>
+                </a:solidFill>
+              </a:rPr>
+              <a:t>DETECTION</a:t>
+            </a:r>
+            <a:endParaRPr lang="en-US" sz="1000" dirty="0"/>
+          </a:p>
+        </p:txBody>
+      </p:sp>
+      <p:sp>
+        <p:nvSpPr>
+          <p:cNvPr id="4" name="Text 2"/>
+          <p:cNvSpPr/>
+          <p:nvPr/>
+        </p:nvSpPr>
+        <p:spPr>
+          <a:xfrm>
+            <a:off x="4709160" y="731520"/>
+            <a:ext cx="4160520" cy="228600"/>
+          </a:xfrm>
+          <a:prstGeom prst="rect">
+            <a:avLst/>
+          </a:prstGeom>
+          <a:noFill/>
+          <a:ln/>
+        </p:spPr>
+        <p:txBody>
+          <a:bodyPr wrap="square" lIns="0" tIns="0" rIns="0" bIns="0" rtlCol="0" anchor="ctr"/>
+          <a:lstStyle/>
+          <a:p>
+            <a:pPr algn="ctr" indent="0" marL="0">
+              <a:buNone/>
+            </a:pPr>
+            <a:r>
+              <a:rPr lang="en-US" sz="1000" b="1" spc="200" kern="0" dirty="0">
+                <a:solidFill>
+                  <a:srgbClr val="888888"/>
+                </a:solidFill>
+              </a:rPr>
+              <a:t>SYNTHESIS</a:t>
+            </a:r>
+            <a:endParaRPr lang="en-US" sz="1000" dirty="0"/>
+          </a:p>
+        </p:txBody>
+      </p:sp>
+      <p:sp>
+        <p:nvSpPr>
+          <p:cNvPr id="5" name="Shape 3"/>
+          <p:cNvSpPr/>
+          <p:nvPr/>
+        </p:nvSpPr>
+        <p:spPr>
+          <a:xfrm>
+            <a:off x="274320" y="1005840"/>
+            <a:ext cx="4160520" cy="1783080"/>
+          </a:xfrm>
+          <a:prstGeom prst="roundRect">
+            <a:avLst>
+              <a:gd name="adj" fmla="val 4103"/>
+            </a:avLst>
+          </a:prstGeom>
+          <a:solidFill>
+            <a:srgbClr val="F5F5F5"/>
+          </a:solidFill>
+          <a:ln/>
+        </p:spPr>
+      </p:sp>
+      <p:sp>
+        <p:nvSpPr>
+          <p:cNvPr id="6" name="Text 4"/>
+          <p:cNvSpPr/>
+          <p:nvPr/>
+        </p:nvSpPr>
+        <p:spPr>
+          <a:xfrm>
+            <a:off x="457200" y="1097280"/>
+            <a:ext cx="3794760" cy="1600200"/>
+          </a:xfrm>
+          <a:prstGeom prst="rect">
+            <a:avLst/>
+          </a:prstGeom>
+          <a:noFill/>
+          <a:ln/>
+        </p:spPr>
+        <p:txBody>
+          <a:bodyPr wrap="square" lIns="0" tIns="0" rIns="0" bIns="0" rtlCol="0" anchor="ctr"/>
+          <a:lstStyle/>
+          <a:p>
+            <a:pPr algn="ctr" indent="0" marL="0">
+              <a:spcAft>
+                <a:spcPts val="600"/>
+              </a:spcAft>
+              <a:buNone/>
+            </a:pPr>
+            <a:r>
+              <a:rPr lang="en-US" sz="4400" b="1" dirty="0">
+                <a:solidFill>
+                  <a:srgbClr val="0000CD"/>
+                </a:solidFill>
+              </a:rPr>
+              <a:t>1.00</a:t>
+            </a:r>
+            <a:endParaRPr lang="en-US" sz="4400" dirty="0"/>
+          </a:p>
+          <a:p>
+            <a:pPr algn="ctr" indent="0" marL="0">
+              <a:spcAft>
+                <a:spcPts val="800"/>
+              </a:spcAft>
+              <a:buNone/>
+            </a:pPr>
+            <a:r>
+              <a:rPr lang="en-US" sz="1100" b="1" dirty="0">
+                <a:solidFill>
+                  <a:srgbClr val="1A1A1A"/>
+                </a:solidFill>
+              </a:rPr>
+              <a:t>Precision  ·  all four kinds</a:t>
+            </a:r>
+            <a:endParaRPr lang="en-US" sz="4400" dirty="0"/>
+          </a:p>
+          <a:p>
+            <a:pPr algn="ctr" indent="0" marL="0">
+              <a:buNone/>
+            </a:pPr>
+            <a:r>
+              <a:rPr lang="en-US" sz="1000" i="1" dirty="0">
+                <a:solidFill>
+                  <a:srgbClr val="555555"/>
+                </a:solidFill>
+              </a:rPr>
+              <a:t>When the detector flags a divergence, it's never a false positive. (45 labelled sessions, three raters at Cohen's κ ≥ 0.72.)</a:t>
+            </a:r>
+            <a:endParaRPr lang="en-US" sz="4400" dirty="0"/>
+          </a:p>
+        </p:txBody>
+      </p:sp>
+      <p:sp>
+        <p:nvSpPr>
+          <p:cNvPr id="7" name="Shape 5"/>
+          <p:cNvSpPr/>
+          <p:nvPr/>
+        </p:nvSpPr>
+        <p:spPr>
+          <a:xfrm>
+            <a:off x="4709160" y="1005840"/>
+            <a:ext cx="4160520" cy="1783080"/>
+          </a:xfrm>
+          <a:prstGeom prst="roundRect">
+            <a:avLst>
+              <a:gd name="adj" fmla="val 4103"/>
+            </a:avLst>
+          </a:prstGeom>
+          <a:solidFill>
+            <a:srgbClr val="F5F5F5"/>
+          </a:solidFill>
+          <a:ln/>
+        </p:spPr>
+      </p:sp>
+      <p:sp>
+        <p:nvSpPr>
+          <p:cNvPr id="8" name="Text 6"/>
+          <p:cNvSpPr/>
+          <p:nvPr/>
+        </p:nvSpPr>
+        <p:spPr>
+          <a:xfrm>
+            <a:off x="4892040" y="1097280"/>
+            <a:ext cx="3794760" cy="1600200"/>
+          </a:xfrm>
+          <a:prstGeom prst="rect">
+            <a:avLst/>
+          </a:prstGeom>
+          <a:noFill/>
+          <a:ln/>
+        </p:spPr>
+        <p:txBody>
+          <a:bodyPr wrap="square" lIns="0" tIns="0" rIns="0" bIns="0" rtlCol="0" anchor="ctr"/>
+          <a:lstStyle/>
+          <a:p>
+            <a:pPr algn="ctr" indent="0" marL="0">
+              <a:spcAft>
+                <a:spcPts val="600"/>
+              </a:spcAft>
+              <a:buNone/>
+            </a:pPr>
+            <a:r>
+              <a:rPr lang="en-US" sz="4400" b="1" dirty="0">
+                <a:solidFill>
+                  <a:srgbClr val="0000CD"/>
+                </a:solidFill>
+              </a:rPr>
+              <a:t>62%</a:t>
+            </a:r>
+            <a:endParaRPr lang="en-US" sz="4400" dirty="0"/>
+          </a:p>
+          <a:p>
+            <a:pPr algn="ctr" indent="0" marL="0">
+              <a:spcAft>
+                <a:spcPts val="800"/>
+              </a:spcAft>
+              <a:buNone/>
+            </a:pPr>
+            <a:r>
+              <a:rPr lang="en-US" sz="1100" b="1" dirty="0">
+                <a:solidFill>
+                  <a:srgbClr val="1A1A1A"/>
+                </a:solidFill>
+              </a:rPr>
+              <a:t>Alternatives beat user trajectory  ·  41 of 66</a:t>
+            </a:r>
+            <a:endParaRPr lang="en-US" sz="4400" dirty="0"/>
+          </a:p>
+          <a:p>
+            <a:pPr algn="ctr" indent="0" marL="0">
+              <a:buNone/>
+            </a:pPr>
+            <a:r>
+              <a:rPr lang="en-US" sz="1000" i="1" dirty="0">
+                <a:solidFill>
+                  <a:srgbClr val="555555"/>
+                </a:solidFill>
+              </a:rPr>
+              <a:t>When the tool flags a divergence, the synthesised alternative usually scores higher than the path the user actually took.</a:t>
+            </a:r>
+            <a:endParaRPr lang="en-US" sz="4400" dirty="0"/>
+          </a:p>
+        </p:txBody>
+      </p:sp>
+      <p:sp>
+        <p:nvSpPr>
+          <p:cNvPr id="9" name="Shape 7"/>
+          <p:cNvSpPr/>
+          <p:nvPr/>
+        </p:nvSpPr>
+        <p:spPr>
+          <a:xfrm>
+            <a:off x="274320" y="2926080"/>
+            <a:ext cx="4160520" cy="1691640"/>
+          </a:xfrm>
+          <a:prstGeom prst="roundRect">
+            <a:avLst>
+              <a:gd name="adj" fmla="val 4324"/>
+            </a:avLst>
+          </a:prstGeom>
+          <a:solidFill>
+            <a:srgbClr val="F5F5F5"/>
+          </a:solidFill>
+          <a:ln/>
+        </p:spPr>
+      </p:sp>
+      <p:sp>
+        <p:nvSpPr>
+          <p:cNvPr id="10" name="Text 8"/>
+          <p:cNvSpPr/>
+          <p:nvPr/>
+        </p:nvSpPr>
+        <p:spPr>
+          <a:xfrm>
+            <a:off x="457200" y="3017520"/>
+            <a:ext cx="3794760" cy="1508760"/>
+          </a:xfrm>
+          <a:prstGeom prst="rect">
+            <a:avLst/>
+          </a:prstGeom>
+          <a:noFill/>
+          <a:ln/>
+        </p:spPr>
+        <p:txBody>
+          <a:bodyPr wrap="square" lIns="0" tIns="0" rIns="0" bIns="0" rtlCol="0" anchor="ctr"/>
+          <a:lstStyle/>
+          <a:p>
+            <a:pPr algn="ctr" indent="0" marL="0">
+              <a:spcAft>
+                <a:spcPts val="600"/>
+              </a:spcAft>
+              <a:buNone/>
+            </a:pPr>
+            <a:r>
+              <a:rPr lang="en-US" sz="2200" b="1" dirty="0">
+                <a:solidFill>
+                  <a:srgbClr val="0000CD"/>
+                </a:solidFill>
+              </a:rPr>
+              <a:t>1.00  /  1.00  /  0.76  /  0.36</a:t>
+            </a:r>
+            <a:endParaRPr lang="en-US" sz="2200" dirty="0"/>
+          </a:p>
+          <a:p>
+            <a:pPr algn="ctr" indent="0" marL="0">
+              <a:spcAft>
+                <a:spcPts val="800"/>
+              </a:spcAft>
+              <a:buNone/>
+            </a:pPr>
+            <a:r>
+              <a:rPr lang="en-US" sz="1100" b="1" dirty="0">
+                <a:solidFill>
+                  <a:srgbClr val="1A1A1A"/>
+                </a:solidFill>
+              </a:rPr>
+              <a:t>Recall  ·  Hygiene / Rework / MR / Ordering</a:t>
+            </a:r>
+            <a:endParaRPr lang="en-US" sz="2200" dirty="0"/>
+          </a:p>
+          <a:p>
+            <a:pPr algn="ctr" indent="0" marL="0">
+              <a:buNone/>
+            </a:pPr>
+            <a:r>
+              <a:rPr lang="en-US" sz="1000" i="1" dirty="0">
+                <a:solidFill>
+                  <a:srgbClr val="555555"/>
+                </a:solidFill>
+              </a:rPr>
+              <a:t>Three kinds catch everything; Ordering's validator is deliberately conservative - a known scope limit.</a:t>
+            </a:r>
+            <a:endParaRPr lang="en-US" sz="2200" dirty="0"/>
+          </a:p>
+        </p:txBody>
+      </p:sp>
+      <p:sp>
+        <p:nvSpPr>
+          <p:cNvPr id="11" name="Shape 9"/>
+          <p:cNvSpPr/>
+          <p:nvPr/>
+        </p:nvSpPr>
+        <p:spPr>
+          <a:xfrm>
+            <a:off x="4709160" y="2926080"/>
+            <a:ext cx="4160520" cy="1691640"/>
+          </a:xfrm>
+          <a:prstGeom prst="roundRect">
+            <a:avLst>
+              <a:gd name="adj" fmla="val 4324"/>
+            </a:avLst>
+          </a:prstGeom>
+          <a:solidFill>
+            <a:srgbClr val="F5F5F5"/>
+          </a:solidFill>
+          <a:ln/>
+        </p:spPr>
+      </p:sp>
+      <p:sp>
+        <p:nvSpPr>
+          <p:cNvPr id="12" name="Text 10"/>
+          <p:cNvSpPr/>
+          <p:nvPr/>
+        </p:nvSpPr>
+        <p:spPr>
+          <a:xfrm>
+            <a:off x="4892040" y="3017520"/>
+            <a:ext cx="3794760" cy="1508760"/>
+          </a:xfrm>
+          <a:prstGeom prst="rect">
+            <a:avLst/>
+          </a:prstGeom>
+          <a:noFill/>
+          <a:ln/>
+        </p:spPr>
+        <p:txBody>
+          <a:bodyPr wrap="square" lIns="0" tIns="0" rIns="0" bIns="0" rtlCol="0" anchor="ctr"/>
+          <a:lstStyle/>
+          <a:p>
+            <a:pPr algn="ctr" indent="0" marL="0">
+              <a:spcAft>
+                <a:spcPts val="600"/>
+              </a:spcAft>
+              <a:buNone/>
+            </a:pPr>
+            <a:r>
+              <a:rPr lang="en-US" sz="2200" b="1" dirty="0">
+                <a:solidFill>
+                  <a:srgbClr val="0000CD"/>
+                </a:solidFill>
+              </a:rPr>
+              <a:t>100%  /  75%  /  46%  /  42%</a:t>
+            </a:r>
+            <a:endParaRPr lang="en-US" sz="2200" dirty="0"/>
+          </a:p>
+          <a:p>
+            <a:pPr algn="ctr" indent="0" marL="0">
+              <a:spcAft>
+                <a:spcPts val="800"/>
+              </a:spcAft>
+              <a:buNone/>
+            </a:pPr>
+            <a:r>
+              <a:rPr lang="en-US" sz="1100" b="1" dirty="0">
+                <a:solidFill>
+                  <a:srgbClr val="1A1A1A"/>
+                </a:solidFill>
+              </a:rPr>
+              <a:t>Beat rate by kind  ·  Hygiene / MR / Rework / Ordering</a:t>
+            </a:r>
+            <a:endParaRPr lang="en-US" sz="2200" dirty="0"/>
+          </a:p>
+          <a:p>
+            <a:pPr algn="ctr" indent="0" marL="0">
+              <a:buNone/>
+            </a:pPr>
+            <a:r>
+              <a:rPr lang="en-US" sz="1000" i="1" dirty="0">
+                <a:solidFill>
+                  <a:srgbClr val="555555"/>
+                </a:solidFill>
+              </a:rPr>
+              <a:t>Hygiene and Manual-Refactor reliably improve the score; Ordering ties often because alternatives reach the same end state.</a:t>
+            </a:r>
+            <a:endParaRPr lang="en-US" sz="2200" dirty="0"/>
+          </a:p>
+        </p:txBody>
+      </p:sp>
+      <p:sp>
+        <p:nvSpPr>
+          <p:cNvPr id="13" name="Text 11"/>
+          <p:cNvSpPr/>
+          <p:nvPr/>
+        </p:nvSpPr>
+        <p:spPr>
+          <a:xfrm>
+            <a:off x="457200" y="4709160"/>
+            <a:ext cx="8229600" cy="365760"/>
+          </a:xfrm>
+          <a:prstGeom prst="rect">
+            <a:avLst/>
+          </a:prstGeom>
+          <a:noFill/>
+          <a:ln/>
+        </p:spPr>
+        <p:txBody>
+          <a:bodyPr wrap="square" lIns="0" tIns="0" rIns="0" bIns="0" rtlCol="0" anchor="ctr"/>
+          <a:lstStyle/>
+          <a:p>
+            <a:pPr algn="ctr" indent="0" marL="0">
+              <a:buNone/>
+            </a:pPr>
+            <a:r>
+              <a:rPr lang="en-US" sz="1100" i="1" dirty="0">
+                <a:solidFill>
+                  <a:srgbClr val="0000CD"/>
+                </a:solidFill>
+              </a:rPr>
+              <a:t>Precision-perfect detection, balanced recall (one known scope limit on Ordering), and a higher-scoring alternative in roughly two-thirds of detected moments.</a:t>
+            </a:r>
+            <a:endParaRPr lang="en-US" sz="1100" dirty="0"/>
+          </a:p>
+        </p:txBody>
+      </p:sp>
+    </p:spTree>
+  </p:cSld>
+  <p:clrMapOvr>
+    <a:masterClrMapping/>
+  </p:clrMapOvr>
+</p:sld>
+</file>
+
+<file path=ppt/slides/slide18.xml><?xml version="1.0" encoding="utf-8"?>
+<p:sld xmlns:a="http://schemas.openxmlformats.org/drawingml/2006/main" xmlns:r="http://schemas.openxmlformats.org/officeDocument/2006/relationships" xmlns:p="http://schemas.openxmlformats.org/presentationml/2006/main" show="0">
+  <p:cSld name="Slide 18">
+    <p:spTree>
+      <p:nvGrpSpPr>
+        <p:cNvPr id="1" name=""/>
+        <p:cNvGrpSpPr/>
+        <p:nvPr/>
+      </p:nvGrpSpPr>
+      <p:grpSpPr>
+        <a:xfrm>
+          <a:off x="0" y="0"/>
+          <a:ext cx="0" cy="0"/>
+          <a:chOff x="0" y="0"/>
+          <a:chExt cx="0" cy="0"/>
+        </a:xfrm>
+      </p:grpSpPr>
+      <p:sp>
+        <p:nvSpPr>
+          <p:cNvPr id="2" name="Text 0"/>
+          <p:cNvSpPr/>
+          <p:nvPr/>
+        </p:nvSpPr>
+        <p:spPr>
+          <a:xfrm>
             <a:off x="457200" y="45720"/>
             <a:ext cx="8229600" cy="457200"/>
           </a:xfrm>
@@ -9296,9 +9922,9 @@
 </p:sld>
 </file>
 
-<file path=ppt/slides/slide18.xml><?xml version="1.0" encoding="utf-8"?>
-<p:sld xmlns:a="http://schemas.openxmlformats.org/drawingml/2006/main" xmlns:r="http://schemas.openxmlformats.org/officeDocument/2006/relationships" xmlns:p="http://schemas.openxmlformats.org/presentationml/2006/main">
-  <p:cSld name="Slide 18">
+<file path=ppt/slides/slide19.xml><?xml version="1.0" encoding="utf-8"?>
+<p:sld xmlns:a="http://schemas.openxmlformats.org/drawingml/2006/main" xmlns:r="http://schemas.openxmlformats.org/officeDocument/2006/relationships" xmlns:p="http://schemas.openxmlformats.org/presentationml/2006/main" show="0">
+  <p:cSld name="Slide 19">
     <p:spTree>
       <p:nvGrpSpPr>
         <p:cNvPr id="1" name=""/>
@@ -9387,7 +10013,7 @@
       </p:sp>
       <p:graphicFrame>
         <p:nvGraphicFramePr>
-          <p:cNvPr id="19" name="Table 0"/>
+          <p:cNvPr id="20" name="Table 0"/>
           <p:cNvGraphicFramePr>
             <a:graphicFrameLocks noGrp="1"/>
           </p:cNvGraphicFramePr>
@@ -11608,67 +12234,6 @@
 </p:sld>
 </file>
 
-<file path=ppt/slides/slide19.xml><?xml version="1.0" encoding="utf-8"?>
-<p:sld xmlns:a="http://schemas.openxmlformats.org/drawingml/2006/main" xmlns:r="http://schemas.openxmlformats.org/officeDocument/2006/relationships" xmlns:p="http://schemas.openxmlformats.org/presentationml/2006/main">
-  <p:cSld name="Slide 19">
-    <p:spTree>
-      <p:nvGrpSpPr>
-        <p:cNvPr id="1" name=""/>
-        <p:cNvGrpSpPr/>
-        <p:nvPr/>
-      </p:nvGrpSpPr>
-      <p:grpSpPr>
-        <a:xfrm>
-          <a:off x="0" y="0"/>
-          <a:ext cx="0" cy="0"/>
-          <a:chOff x="0" y="0"/>
-          <a:chExt cx="0" cy="0"/>
-        </a:xfrm>
-      </p:grpSpPr>
-      <p:sp>
-        <p:nvSpPr>
-          <p:cNvPr id="2" name="Text 0"/>
-          <p:cNvSpPr/>
-          <p:nvPr/>
-        </p:nvSpPr>
-        <p:spPr>
-          <a:xfrm>
-            <a:off x="457200" y="2011680"/>
-            <a:ext cx="8229600" cy="1097280"/>
-          </a:xfrm>
-          <a:prstGeom prst="rect">
-            <a:avLst/>
-          </a:prstGeom>
-          <a:noFill/>
-          <a:ln/>
-        </p:spPr>
-        <p:txBody>
-          <a:bodyPr wrap="square" lIns="0" tIns="0" rIns="0" bIns="0" rtlCol="0" anchor="ctr"/>
-          <a:lstStyle/>
-          <a:p>
-            <a:pPr algn="ctr" indent="0" marL="0">
-              <a:buNone/>
-            </a:pPr>
-            <a:r>
-              <a:rPr lang="en-US" sz="3600" b="1" dirty="0">
-                <a:solidFill>
-                  <a:srgbClr val="1A1A1A"/>
-                </a:solidFill>
-              </a:rPr>
-              <a:t>Experiment 2: Is the process score reliable?</a:t>
-            </a:r>
-            <a:endParaRPr lang="en-US" sz="3600" dirty="0"/>
-          </a:p>
-        </p:txBody>
-      </p:sp>
-    </p:spTree>
-  </p:cSld>
-  <p:clrMapOvr>
-    <a:masterClrMapping/>
-  </p:clrMapOvr>
-</p:sld>
-</file>
-
 <file path=ppt/slides/slide2.xml><?xml version="1.0" encoding="utf-8"?>
 <p:sld xmlns:a="http://schemas.openxmlformats.org/drawingml/2006/main" xmlns:r="http://schemas.openxmlformats.org/officeDocument/2006/relationships" xmlns:p="http://schemas.openxmlformats.org/presentationml/2006/main">
   <p:cSld name="Slide 2">
@@ -12149,8 +12714,8 @@
         </p:nvSpPr>
         <p:spPr>
           <a:xfrm>
-            <a:off x="457200" y="274320"/>
-            <a:ext cx="8229600" cy="640080"/>
+            <a:off x="457200" y="2011680"/>
+            <a:ext cx="8229600" cy="1097280"/>
           </a:xfrm>
           <a:prstGeom prst="rect">
             <a:avLst/>
@@ -12162,204 +12727,18 @@
           <a:bodyPr wrap="square" lIns="0" tIns="0" rIns="0" bIns="0" rtlCol="0" anchor="ctr"/>
           <a:lstStyle/>
           <a:p>
-            <a:pPr indent="0" marL="0">
-              <a:buNone/>
-            </a:pPr>
-            <a:r>
-              <a:rPr lang="en-US" sz="2800" b="1" dirty="0">
-                <a:solidFill>
-                  <a:srgbClr val="000000"/>
-                </a:solidFill>
-              </a:rPr>
-              <a:t>Is the process score reliable?</a:t>
-            </a:r>
-            <a:endParaRPr lang="en-US" sz="2800" dirty="0"/>
-          </a:p>
-        </p:txBody>
-      </p:sp>
-      <p:sp>
-        <p:nvSpPr>
-          <p:cNvPr id="3" name="Text 1"/>
-          <p:cNvSpPr/>
-          <p:nvPr/>
-        </p:nvSpPr>
-        <p:spPr>
-          <a:xfrm>
-            <a:off x="457200" y="1188720"/>
-            <a:ext cx="8229600" cy="3657600"/>
-          </a:xfrm>
-          <a:prstGeom prst="rect">
-            <a:avLst/>
-          </a:prstGeom>
-          <a:noFill/>
-          <a:ln/>
-        </p:spPr>
-        <p:txBody>
-          <a:bodyPr wrap="square" rtlCol="0" anchor="t"/>
-          <a:lstStyle/>
-          <a:p>
-            <a:pPr marL="342900" indent="-342900">
-              <a:spcAft>
-                <a:spcPts val="600"/>
-              </a:spcAft>
-              <a:buSzPct val="100000"/>
-              <a:buChar char="•"/>
-            </a:pPr>
-            <a:r>
-              <a:rPr lang="en-US" sz="1500" b="1" dirty="0">
-                <a:solidFill>
-                  <a:srgbClr val="000000"/>
-                </a:solidFill>
-              </a:rPr>
-              <a:t>How stable is the score?</a:t>
-            </a:r>
-            <a:endParaRPr lang="en-US" sz="1500" dirty="0"/>
-          </a:p>
-          <a:p>
-            <a:pPr lvl="1" marL="762000" indent="-381000">
-              <a:spcAft>
-                <a:spcPts val="600"/>
-              </a:spcAft>
-              <a:buSzPct val="100000"/>
-              <a:buChar char="•"/>
-            </a:pPr>
-            <a:r>
-              <a:rPr lang="en-US" sz="1500" dirty="0">
-                <a:solidFill>
-                  <a:srgbClr val="000000"/>
-                </a:solidFill>
-              </a:rPr>
-              <a:t>Two perturbation sweeps </a:t>
-            </a:r>
-            <a:pPr indent="0" marL="0">
-              <a:spcAft>
-                <a:spcPts val="600"/>
-              </a:spcAft>
-              <a:buNone/>
-            </a:pPr>
-            <a:r>
-              <a:rPr lang="en-US" sz="1500" dirty="0">
-                <a:solidFill>
-                  <a:srgbClr val="888888"/>
-                </a:solidFill>
-              </a:rPr>
-              <a:t>- single-knob (one weight scaled ×0.1 to ×10) + multi-knob Monte Carlo (200 samples, σ = ln 2, so ~×0.25 to ×4 of production).</a:t>
-            </a:r>
-            <a:endParaRPr lang="en-US" sz="1500" dirty="0"/>
-          </a:p>
-          <a:p>
-            <a:pPr lvl="1" marL="762000" indent="-381000">
-              <a:spcAft>
-                <a:spcPts val="1800"/>
-              </a:spcAft>
-              <a:buSzPct val="100000"/>
-              <a:buChar char="•"/>
-            </a:pPr>
-            <a:r>
-              <a:rPr lang="en-US" sz="1500" dirty="0">
-                <a:solidFill>
-                  <a:srgbClr val="000000"/>
-                </a:solidFill>
-              </a:rPr>
-              <a:t>Stability metrics </a:t>
-            </a:r>
-            <a:pPr indent="0" marL="0">
-              <a:spcAft>
-                <a:spcPts val="1800"/>
-              </a:spcAft>
-              <a:buNone/>
-            </a:pPr>
-            <a:r>
-              <a:rPr lang="en-US" sz="1500" dirty="0">
-                <a:solidFill>
-                  <a:srgbClr val="888888"/>
-                </a:solidFill>
-              </a:rPr>
-              <a:t>- top-1 hit rate (does the top-ranked DP stay on top?) + Kendall's τ-b on per-session rankings.</a:t>
-            </a:r>
-            <a:endParaRPr lang="en-US" sz="1500" dirty="0"/>
-          </a:p>
-          <a:p>
-            <a:pPr marL="342900" indent="-342900">
-              <a:spcAft>
-                <a:spcPts val="600"/>
-              </a:spcAft>
-              <a:buSzPct val="100000"/>
-              <a:buChar char="•"/>
-            </a:pPr>
-            <a:r>
-              <a:rPr lang="en-US" sz="1500" b="1" dirty="0">
-                <a:solidFill>
-                  <a:srgbClr val="000000"/>
-                </a:solidFill>
-              </a:rPr>
-              <a:t>Does every component of the process score hold weight?</a:t>
-            </a:r>
-            <a:endParaRPr lang="en-US" sz="1500" dirty="0"/>
-          </a:p>
-          <a:p>
-            <a:pPr lvl="1" marL="762000" indent="-381000">
-              <a:spcAft>
-                <a:spcPts val="600"/>
-              </a:spcAft>
-              <a:buSzPct val="100000"/>
-              <a:buChar char="•"/>
-            </a:pPr>
-            <a:r>
-              <a:rPr lang="en-US" sz="1500" dirty="0">
-                <a:solidFill>
-                  <a:srgbClr val="000000"/>
-                </a:solidFill>
-              </a:rPr>
-              <a:t>Process-side ablation </a:t>
-            </a:r>
-            <a:pPr indent="0" marL="0">
-              <a:spcAft>
-                <a:spcPts val="600"/>
-              </a:spcAft>
-              <a:buNone/>
-            </a:pPr>
-            <a:r>
-              <a:rPr lang="en-US" sz="1500" dirty="0">
-                <a:solidFill>
-                  <a:srgbClr val="888888"/>
-                </a:solidFill>
-              </a:rPr>
-              <a:t>- enumerate all 2⁷ = 128 subsets of the 7 process weights → 5,760 cases per session set.</a:t>
-            </a:r>
-            <a:endParaRPr lang="en-US" sz="1500" dirty="0"/>
-          </a:p>
-          <a:p>
-            <a:pPr lvl="1" marL="762000" indent="-381000">
-              <a:spcAft>
-                <a:spcPts val="600"/>
-              </a:spcAft>
-              <a:buSzPct val="100000"/>
-              <a:buChar char="•"/>
-            </a:pPr>
-            <a:r>
-              <a:rPr lang="en-US" sz="1500" dirty="0">
-                <a:solidFill>
-                  <a:srgbClr val="000000"/>
-                </a:solidFill>
-              </a:rPr>
-              <a:t>Recovery metrics </a:t>
-            </a:r>
-            <a:pPr indent="0" marL="0">
-              <a:spcAft>
-                <a:spcPts val="600"/>
-              </a:spcAft>
-              <a:buNone/>
-            </a:pPr>
-            <a:r>
-              <a:rPr lang="en-US" sz="1500" dirty="0">
-                <a:solidFill>
-                  <a:srgbClr val="888888"/>
-                </a:solidFill>
-              </a:rPr>
-              <a:t>- sum-over-sum magnitude recovery (does the term carry signal?) + leave-one-out Kendall's τ-b (does removing it reshuffle rankings?).</a:t>
-            </a:r>
-            <a:endParaRPr lang="en-US" sz="1500" dirty="0"/>
+            <a:pPr algn="ctr" indent="0" marL="0">
+              <a:buNone/>
+            </a:pPr>
+            <a:r>
+              <a:rPr lang="en-US" sz="3600" b="1" dirty="0">
+                <a:solidFill>
+                  <a:srgbClr val="1A1A1A"/>
+                </a:solidFill>
+              </a:rPr>
+              <a:t>Experiment 2: Is the process score reliable?</a:t>
+            </a:r>
+            <a:endParaRPr lang="en-US" sz="3600" dirty="0"/>
           </a:p>
         </p:txBody>
       </p:sp>
@@ -12372,7 +12751,7 @@
 </file>
 
 <file path=ppt/slides/slide21.xml><?xml version="1.0" encoding="utf-8"?>
-<p:sld xmlns:a="http://schemas.openxmlformats.org/drawingml/2006/main" xmlns:r="http://schemas.openxmlformats.org/officeDocument/2006/relationships" xmlns:p="http://schemas.openxmlformats.org/presentationml/2006/main">
+<p:sld xmlns:a="http://schemas.openxmlformats.org/drawingml/2006/main" xmlns:r="http://schemas.openxmlformats.org/officeDocument/2006/relationships" xmlns:p="http://schemas.openxmlformats.org/presentationml/2006/main" show="0">
   <p:cSld name="Slide 21">
     <p:spTree>
       <p:nvGrpSpPr>
@@ -12418,6 +12797,253 @@
                   <a:srgbClr val="000000"/>
                 </a:solidFill>
               </a:rPr>
+              <a:t>Is the process score reliable?</a:t>
+            </a:r>
+            <a:endParaRPr lang="en-US" sz="2800" dirty="0"/>
+          </a:p>
+        </p:txBody>
+      </p:sp>
+      <p:sp>
+        <p:nvSpPr>
+          <p:cNvPr id="3" name="Text 1"/>
+          <p:cNvSpPr/>
+          <p:nvPr/>
+        </p:nvSpPr>
+        <p:spPr>
+          <a:xfrm>
+            <a:off x="457200" y="1188720"/>
+            <a:ext cx="8229600" cy="3657600"/>
+          </a:xfrm>
+          <a:prstGeom prst="rect">
+            <a:avLst/>
+          </a:prstGeom>
+          <a:noFill/>
+          <a:ln/>
+        </p:spPr>
+        <p:txBody>
+          <a:bodyPr wrap="square" rtlCol="0" anchor="t"/>
+          <a:lstStyle/>
+          <a:p>
+            <a:pPr marL="342900" indent="-342900">
+              <a:spcAft>
+                <a:spcPts val="600"/>
+              </a:spcAft>
+              <a:buSzPct val="100000"/>
+              <a:buChar char="•"/>
+            </a:pPr>
+            <a:r>
+              <a:rPr lang="en-US" sz="1500" b="1" dirty="0">
+                <a:solidFill>
+                  <a:srgbClr val="000000"/>
+                </a:solidFill>
+              </a:rPr>
+              <a:t>How stable is the score?</a:t>
+            </a:r>
+            <a:endParaRPr lang="en-US" sz="1500" dirty="0"/>
+          </a:p>
+          <a:p>
+            <a:pPr lvl="1" marL="762000" indent="-381000">
+              <a:spcAft>
+                <a:spcPts val="600"/>
+              </a:spcAft>
+              <a:buSzPct val="100000"/>
+              <a:buChar char="•"/>
+            </a:pPr>
+            <a:r>
+              <a:rPr lang="en-US" sz="1500" dirty="0">
+                <a:solidFill>
+                  <a:srgbClr val="000000"/>
+                </a:solidFill>
+              </a:rPr>
+              <a:t>Two perturbation sweeps </a:t>
+            </a:r>
+            <a:pPr indent="0" marL="0">
+              <a:spcAft>
+                <a:spcPts val="600"/>
+              </a:spcAft>
+              <a:buNone/>
+            </a:pPr>
+            <a:r>
+              <a:rPr lang="en-US" sz="1500" dirty="0">
+                <a:solidFill>
+                  <a:srgbClr val="888888"/>
+                </a:solidFill>
+              </a:rPr>
+              <a:t>- single-knob (one weight scaled ×0.1 to ×10) + multi-knob Monte Carlo (200 samples, σ = ln 2, so ~×0.25 to ×4 of production).</a:t>
+            </a:r>
+            <a:endParaRPr lang="en-US" sz="1500" dirty="0"/>
+          </a:p>
+          <a:p>
+            <a:pPr lvl="1" marL="762000" indent="-381000">
+              <a:spcAft>
+                <a:spcPts val="1800"/>
+              </a:spcAft>
+              <a:buSzPct val="100000"/>
+              <a:buChar char="•"/>
+            </a:pPr>
+            <a:r>
+              <a:rPr lang="en-US" sz="1500" dirty="0">
+                <a:solidFill>
+                  <a:srgbClr val="000000"/>
+                </a:solidFill>
+              </a:rPr>
+              <a:t>Stability metrics </a:t>
+            </a:r>
+            <a:pPr indent="0" marL="0">
+              <a:spcAft>
+                <a:spcPts val="1800"/>
+              </a:spcAft>
+              <a:buNone/>
+            </a:pPr>
+            <a:r>
+              <a:rPr lang="en-US" sz="1500" dirty="0">
+                <a:solidFill>
+                  <a:srgbClr val="888888"/>
+                </a:solidFill>
+              </a:rPr>
+              <a:t>- top-1 hit rate (does the top-ranked DP stay on top?) + Kendall's τ-b on per-session rankings.</a:t>
+            </a:r>
+            <a:endParaRPr lang="en-US" sz="1500" dirty="0"/>
+          </a:p>
+          <a:p>
+            <a:pPr marL="342900" indent="-342900">
+              <a:spcAft>
+                <a:spcPts val="600"/>
+              </a:spcAft>
+              <a:buSzPct val="100000"/>
+              <a:buChar char="•"/>
+            </a:pPr>
+            <a:r>
+              <a:rPr lang="en-US" sz="1500" b="1" dirty="0">
+                <a:solidFill>
+                  <a:srgbClr val="000000"/>
+                </a:solidFill>
+              </a:rPr>
+              <a:t>Does every component of the process score hold weight?</a:t>
+            </a:r>
+            <a:endParaRPr lang="en-US" sz="1500" dirty="0"/>
+          </a:p>
+          <a:p>
+            <a:pPr lvl="1" marL="762000" indent="-381000">
+              <a:spcAft>
+                <a:spcPts val="600"/>
+              </a:spcAft>
+              <a:buSzPct val="100000"/>
+              <a:buChar char="•"/>
+            </a:pPr>
+            <a:r>
+              <a:rPr lang="en-US" sz="1500" dirty="0">
+                <a:solidFill>
+                  <a:srgbClr val="000000"/>
+                </a:solidFill>
+              </a:rPr>
+              <a:t>Process-side ablation </a:t>
+            </a:r>
+            <a:pPr indent="0" marL="0">
+              <a:spcAft>
+                <a:spcPts val="600"/>
+              </a:spcAft>
+              <a:buNone/>
+            </a:pPr>
+            <a:r>
+              <a:rPr lang="en-US" sz="1500" dirty="0">
+                <a:solidFill>
+                  <a:srgbClr val="888888"/>
+                </a:solidFill>
+              </a:rPr>
+              <a:t>- enumerate all 2⁷ = 128 subsets of the 7 process weights → 5,760 cases per session set.</a:t>
+            </a:r>
+            <a:endParaRPr lang="en-US" sz="1500" dirty="0"/>
+          </a:p>
+          <a:p>
+            <a:pPr lvl="1" marL="762000" indent="-381000">
+              <a:spcAft>
+                <a:spcPts val="600"/>
+              </a:spcAft>
+              <a:buSzPct val="100000"/>
+              <a:buChar char="•"/>
+            </a:pPr>
+            <a:r>
+              <a:rPr lang="en-US" sz="1500" dirty="0">
+                <a:solidFill>
+                  <a:srgbClr val="000000"/>
+                </a:solidFill>
+              </a:rPr>
+              <a:t>Recovery metrics </a:t>
+            </a:r>
+            <a:pPr indent="0" marL="0">
+              <a:spcAft>
+                <a:spcPts val="600"/>
+              </a:spcAft>
+              <a:buNone/>
+            </a:pPr>
+            <a:r>
+              <a:rPr lang="en-US" sz="1500" dirty="0">
+                <a:solidFill>
+                  <a:srgbClr val="888888"/>
+                </a:solidFill>
+              </a:rPr>
+              <a:t>- sum-over-sum magnitude recovery (does the term carry signal?) + leave-one-out Kendall's τ-b (does removing it reshuffle rankings?).</a:t>
+            </a:r>
+            <a:endParaRPr lang="en-US" sz="1500" dirty="0"/>
+          </a:p>
+        </p:txBody>
+      </p:sp>
+    </p:spTree>
+  </p:cSld>
+  <p:clrMapOvr>
+    <a:masterClrMapping/>
+  </p:clrMapOvr>
+</p:sld>
+</file>
+
+<file path=ppt/slides/slide22.xml><?xml version="1.0" encoding="utf-8"?>
+<p:sld xmlns:a="http://schemas.openxmlformats.org/drawingml/2006/main" xmlns:r="http://schemas.openxmlformats.org/officeDocument/2006/relationships" xmlns:p="http://schemas.openxmlformats.org/presentationml/2006/main">
+  <p:cSld name="Slide 22">
+    <p:spTree>
+      <p:nvGrpSpPr>
+        <p:cNvPr id="1" name=""/>
+        <p:cNvGrpSpPr/>
+        <p:nvPr/>
+      </p:nvGrpSpPr>
+      <p:grpSpPr>
+        <a:xfrm>
+          <a:off x="0" y="0"/>
+          <a:ext cx="0" cy="0"/>
+          <a:chOff x="0" y="0"/>
+          <a:chExt cx="0" cy="0"/>
+        </a:xfrm>
+      </p:grpSpPr>
+      <p:sp>
+        <p:nvSpPr>
+          <p:cNvPr id="2" name="Text 0"/>
+          <p:cNvSpPr/>
+          <p:nvPr/>
+        </p:nvSpPr>
+        <p:spPr>
+          <a:xfrm>
+            <a:off x="457200" y="274320"/>
+            <a:ext cx="8229600" cy="640080"/>
+          </a:xfrm>
+          <a:prstGeom prst="rect">
+            <a:avLst/>
+          </a:prstGeom>
+          <a:noFill/>
+          <a:ln/>
+        </p:spPr>
+        <p:txBody>
+          <a:bodyPr wrap="square" lIns="0" tIns="0" rIns="0" bIns="0" rtlCol="0" anchor="ctr"/>
+          <a:lstStyle/>
+          <a:p>
+            <a:pPr indent="0" marL="0">
+              <a:buNone/>
+            </a:pPr>
+            <a:r>
+              <a:rPr lang="en-US" sz="2800" b="1" dirty="0">
+                <a:solidFill>
+                  <a:srgbClr val="000000"/>
+                </a:solidFill>
+              </a:rPr>
               <a:t>Score is locally robust</a:t>
             </a:r>
             <a:endParaRPr lang="en-US" sz="2800" dirty="0"/>
@@ -12563,7 +13189,7 @@
       </p:sp>
       <p:graphicFrame>
         <p:nvGraphicFramePr>
-          <p:cNvPr id="22" name="Table 0"/>
+          <p:cNvPr id="23" name="Table 0"/>
           <p:cNvGraphicFramePr>
             <a:graphicFrameLocks noGrp="1"/>
           </p:cNvGraphicFramePr>
@@ -14221,67 +14847,6 @@
 </p:sld>
 </file>
 
-<file path=ppt/slides/slide22.xml><?xml version="1.0" encoding="utf-8"?>
-<p:sld xmlns:a="http://schemas.openxmlformats.org/drawingml/2006/main" xmlns:r="http://schemas.openxmlformats.org/officeDocument/2006/relationships" xmlns:p="http://schemas.openxmlformats.org/presentationml/2006/main">
-  <p:cSld name="Slide 22">
-    <p:spTree>
-      <p:nvGrpSpPr>
-        <p:cNvPr id="1" name=""/>
-        <p:cNvGrpSpPr/>
-        <p:nvPr/>
-      </p:nvGrpSpPr>
-      <p:grpSpPr>
-        <a:xfrm>
-          <a:off x="0" y="0"/>
-          <a:ext cx="0" cy="0"/>
-          <a:chOff x="0" y="0"/>
-          <a:chExt cx="0" cy="0"/>
-        </a:xfrm>
-      </p:grpSpPr>
-      <p:sp>
-        <p:nvSpPr>
-          <p:cNvPr id="2" name="Text 0"/>
-          <p:cNvSpPr/>
-          <p:nvPr/>
-        </p:nvSpPr>
-        <p:spPr>
-          <a:xfrm>
-            <a:off x="457200" y="2011680"/>
-            <a:ext cx="8229600" cy="1097280"/>
-          </a:xfrm>
-          <a:prstGeom prst="rect">
-            <a:avLst/>
-          </a:prstGeom>
-          <a:noFill/>
-          <a:ln/>
-        </p:spPr>
-        <p:txBody>
-          <a:bodyPr wrap="square" lIns="0" tIns="0" rIns="0" bIns="0" rtlCol="0" anchor="ctr"/>
-          <a:lstStyle/>
-          <a:p>
-            <a:pPr algn="ctr" indent="0" marL="0">
-              <a:buNone/>
-            </a:pPr>
-            <a:r>
-              <a:rPr lang="en-US" sz="3200" b="1" dirty="0">
-                <a:solidFill>
-                  <a:srgbClr val="1A1A1A"/>
-                </a:solidFill>
-              </a:rPr>
-              <a:t>Experiment 3: Does feedback change developer behaviour?</a:t>
-            </a:r>
-            <a:endParaRPr lang="en-US" sz="3200" dirty="0"/>
-          </a:p>
-        </p:txBody>
-      </p:sp>
-    </p:spTree>
-  </p:cSld>
-  <p:clrMapOvr>
-    <a:masterClrMapping/>
-  </p:clrMapOvr>
-</p:sld>
-</file>
-
 <file path=ppt/slides/slide23.xml><?xml version="1.0" encoding="utf-8"?>
 <p:sld xmlns:a="http://schemas.openxmlformats.org/drawingml/2006/main" xmlns:r="http://schemas.openxmlformats.org/officeDocument/2006/relationships" xmlns:p="http://schemas.openxmlformats.org/presentationml/2006/main">
   <p:cSld name="Slide 23">
@@ -14307,6 +14872,67 @@
         </p:nvSpPr>
         <p:spPr>
           <a:xfrm>
+            <a:off x="457200" y="2011680"/>
+            <a:ext cx="8229600" cy="1097280"/>
+          </a:xfrm>
+          <a:prstGeom prst="rect">
+            <a:avLst/>
+          </a:prstGeom>
+          <a:noFill/>
+          <a:ln/>
+        </p:spPr>
+        <p:txBody>
+          <a:bodyPr wrap="square" lIns="0" tIns="0" rIns="0" bIns="0" rtlCol="0" anchor="ctr"/>
+          <a:lstStyle/>
+          <a:p>
+            <a:pPr algn="ctr" indent="0" marL="0">
+              <a:buNone/>
+            </a:pPr>
+            <a:r>
+              <a:rPr lang="en-US" sz="3200" b="1" dirty="0">
+                <a:solidFill>
+                  <a:srgbClr val="1A1A1A"/>
+                </a:solidFill>
+              </a:rPr>
+              <a:t>Experiment 3: Does feedback change developer behaviour?</a:t>
+            </a:r>
+            <a:endParaRPr lang="en-US" sz="3200" dirty="0"/>
+          </a:p>
+        </p:txBody>
+      </p:sp>
+    </p:spTree>
+  </p:cSld>
+  <p:clrMapOvr>
+    <a:masterClrMapping/>
+  </p:clrMapOvr>
+</p:sld>
+</file>
+
+<file path=ppt/slides/slide24.xml><?xml version="1.0" encoding="utf-8"?>
+<p:sld xmlns:a="http://schemas.openxmlformats.org/drawingml/2006/main" xmlns:r="http://schemas.openxmlformats.org/officeDocument/2006/relationships" xmlns:p="http://schemas.openxmlformats.org/presentationml/2006/main" show="0">
+  <p:cSld name="Slide 24">
+    <p:spTree>
+      <p:nvGrpSpPr>
+        <p:cNvPr id="1" name=""/>
+        <p:cNvGrpSpPr/>
+        <p:nvPr/>
+      </p:nvGrpSpPr>
+      <p:grpSpPr>
+        <a:xfrm>
+          <a:off x="0" y="0"/>
+          <a:ext cx="0" cy="0"/>
+          <a:chOff x="0" y="0"/>
+          <a:chExt cx="0" cy="0"/>
+        </a:xfrm>
+      </p:grpSpPr>
+      <p:sp>
+        <p:nvSpPr>
+          <p:cNvPr id="2" name="Text 0"/>
+          <p:cNvSpPr/>
+          <p:nvPr/>
+        </p:nvSpPr>
+        <p:spPr>
+          <a:xfrm>
             <a:off x="457200" y="274320"/>
             <a:ext cx="8229600" cy="640080"/>
           </a:xfrm>
@@ -14537,9 +15163,9 @@
 </p:sld>
 </file>
 
-<file path=ppt/slides/slide24.xml><?xml version="1.0" encoding="utf-8"?>
+<file path=ppt/slides/slide25.xml><?xml version="1.0" encoding="utf-8"?>
 <p:sld xmlns:a="http://schemas.openxmlformats.org/drawingml/2006/main" xmlns:r="http://schemas.openxmlformats.org/officeDocument/2006/relationships" xmlns:p="http://schemas.openxmlformats.org/presentationml/2006/main">
-  <p:cSld name="Slide 24">
+  <p:cSld name="Slide 25">
     <p:spTree>
       <p:nvGrpSpPr>
         <p:cNvPr id="1" name=""/>
@@ -14749,202 +15375,6 @@
 </p:sld>
 </file>
 
-<file path=ppt/slides/slide25.xml><?xml version="1.0" encoding="utf-8"?>
-<p:sld xmlns:a="http://schemas.openxmlformats.org/drawingml/2006/main" xmlns:r="http://schemas.openxmlformats.org/officeDocument/2006/relationships" xmlns:p="http://schemas.openxmlformats.org/presentationml/2006/main">
-  <p:cSld name="Slide 25">
-    <p:spTree>
-      <p:nvGrpSpPr>
-        <p:cNvPr id="1" name=""/>
-        <p:cNvGrpSpPr/>
-        <p:nvPr/>
-      </p:nvGrpSpPr>
-      <p:grpSpPr>
-        <a:xfrm>
-          <a:off x="0" y="0"/>
-          <a:ext cx="0" cy="0"/>
-          <a:chOff x="0" y="0"/>
-          <a:chExt cx="0" cy="0"/>
-        </a:xfrm>
-      </p:grpSpPr>
-      <p:sp>
-        <p:nvSpPr>
-          <p:cNvPr id="2" name="Text 0"/>
-          <p:cNvSpPr/>
-          <p:nvPr/>
-        </p:nvSpPr>
-        <p:spPr>
-          <a:xfrm>
-            <a:off x="457200" y="137160"/>
-            <a:ext cx="8229600" cy="502920"/>
-          </a:xfrm>
-          <a:prstGeom prst="rect">
-            <a:avLst/>
-          </a:prstGeom>
-          <a:noFill/>
-          <a:ln/>
-        </p:spPr>
-        <p:txBody>
-          <a:bodyPr wrap="square" lIns="0" tIns="0" rIns="0" bIns="0" rtlCol="0" anchor="ctr"/>
-          <a:lstStyle/>
-          <a:p>
-            <a:pPr algn="ctr" indent="0" marL="0">
-              <a:buNone/>
-            </a:pPr>
-            <a:r>
-              <a:rPr lang="en-US" sz="2400" b="1" dirty="0">
-                <a:solidFill>
-                  <a:srgbClr val="000000"/>
-                </a:solidFill>
-              </a:rPr>
-              <a:t>Strip the task signal - process discipline emerges</a:t>
-            </a:r>
-            <a:endParaRPr lang="en-US" sz="2400" dirty="0"/>
-          </a:p>
-        </p:txBody>
-      </p:sp>
-      <p:graphicFrame>
-        <p:nvGraphicFramePr>
-          <p:cNvPr id="3" name="Chart 0" descr=""/>
-          <p:cNvGraphicFramePr/>
-          <p:nvPr/>
-        </p:nvGraphicFramePr>
-        <p:xfrm>
-          <a:off x="1554480" y="777240"/>
-          <a:ext cx="6035040" cy="3108960"/>
-        </p:xfrm>
-        <a:graphic xmlns:a="http://schemas.openxmlformats.org/drawingml/2006/main">
-          <a:graphicData uri="http://schemas.openxmlformats.org/drawingml/2006/chart">
-            <c:chart xmlns:c="http://schemas.openxmlformats.org/drawingml/2006/chart" r:id="rId1"/>
-          </a:graphicData>
-        </a:graphic>
-      </p:graphicFrame>
-      <p:sp>
-        <p:nvSpPr>
-          <p:cNvPr id="4" name="Text 1"/>
-          <p:cNvSpPr/>
-          <p:nvPr/>
-        </p:nvSpPr>
-        <p:spPr>
-          <a:xfrm>
-            <a:off x="457200" y="4069080"/>
-            <a:ext cx="8229600" cy="868680"/>
-          </a:xfrm>
-          <a:prstGeom prst="rect">
-            <a:avLst/>
-          </a:prstGeom>
-          <a:noFill/>
-          <a:ln/>
-        </p:spPr>
-        <p:txBody>
-          <a:bodyPr wrap="square" lIns="50800" tIns="50800" rIns="50800" bIns="50800" rtlCol="0" anchor="t"/>
-          <a:lstStyle/>
-          <a:p>
-            <a:pPr algn="ctr" indent="0" marL="0">
-              <a:buNone/>
-            </a:pPr>
-            <a:r>
-              <a:rPr lang="en-US" sz="1200" dirty="0">
-                <a:solidFill>
-                  <a:srgbClr val="000000"/>
-                </a:solidFill>
-              </a:rPr>
-              <a:t>Once cleanliness gain is removed, the score reflects </a:t>
-            </a:r>
-            <a:pPr algn="ctr" indent="0" marL="0">
-              <a:buNone/>
-            </a:pPr>
-            <a:r>
-              <a:rPr lang="en-US" sz="1200" i="1" dirty="0">
-                <a:solidFill>
-                  <a:srgbClr val="000000"/>
-                </a:solidFill>
-              </a:rPr>
-              <a:t>how disciplined the process was</a:t>
-            </a:r>
-            <a:pPr algn="ctr" indent="0" marL="0">
-              <a:buNone/>
-            </a:pPr>
-            <a:r>
-              <a:rPr lang="en-US" sz="1200" dirty="0">
-                <a:solidFill>
-                  <a:srgbClr val="000000"/>
-                </a:solidFill>
-              </a:rPr>
-              <a:t> - tests run, IDE refactorings used, commits at sensible points. The feedback group climbs </a:t>
-            </a:r>
-            <a:pPr algn="ctr" indent="0" marL="0">
-              <a:buNone/>
-            </a:pPr>
-            <a:r>
-              <a:rPr lang="en-US" sz="1200" b="1" dirty="0">
-                <a:solidFill>
-                  <a:srgbClr val="0000CD"/>
-                </a:solidFill>
-              </a:rPr>
-              <a:t>+22.3</a:t>
-            </a:r>
-            <a:pPr algn="ctr" indent="0" marL="0">
-              <a:buNone/>
-            </a:pPr>
-            <a:r>
-              <a:rPr lang="en-US" sz="1200" dirty="0">
-                <a:solidFill>
-                  <a:srgbClr val="000000"/>
-                </a:solidFill>
-              </a:rPr>
-              <a:t> across the arc; the baseline group moves </a:t>
-            </a:r>
-            <a:pPr algn="ctr" indent="0" marL="0">
-              <a:buNone/>
-            </a:pPr>
-            <a:r>
-              <a:rPr lang="en-US" sz="1200" b="1" dirty="0">
-                <a:solidFill>
-                  <a:srgbClr val="B25500"/>
-                </a:solidFill>
-              </a:rPr>
-              <a:t>−2.0</a:t>
-            </a:r>
-            <a:pPr algn="ctr" indent="0" marL="0">
-              <a:spcAft>
-                <a:spcPts val="600"/>
-              </a:spcAft>
-              <a:buNone/>
-            </a:pPr>
-            <a:r>
-              <a:rPr lang="en-US" sz="1200" dirty="0">
-                <a:solidFill>
-                  <a:srgbClr val="000000"/>
-                </a:solidFill>
-              </a:rPr>
-              <a:t>.</a:t>
-            </a:r>
-            <a:endParaRPr lang="en-US" sz="1200" dirty="0"/>
-          </a:p>
-          <a:p>
-            <a:pPr algn="ctr" indent="0" marL="0">
-              <a:buNone/>
-            </a:pPr>
-            <a:r>
-              <a:rPr lang="en-US" sz="1200" i="1" dirty="0">
-                <a:solidFill>
-                  <a:srgbClr val="888888"/>
-                </a:solidFill>
-              </a:rPr>
-              <a:t>n = 3 vs n = 2 - directional finding, not a hypothesis test.</a:t>
-            </a:r>
-            <a:endParaRPr lang="en-US" sz="1200" dirty="0"/>
-          </a:p>
-        </p:txBody>
-      </p:sp>
-    </p:spTree>
-  </p:cSld>
-  <p:clrMapOvr>
-    <a:masterClrMapping/>
-  </p:clrMapOvr>
-</p:sld>
-</file>
-
 <file path=ppt/slides/slide26.xml><?xml version="1.0" encoding="utf-8"?>
 <p:sld xmlns:a="http://schemas.openxmlformats.org/drawingml/2006/main" xmlns:r="http://schemas.openxmlformats.org/officeDocument/2006/relationships" xmlns:p="http://schemas.openxmlformats.org/presentationml/2006/main">
   <p:cSld name="Slide 26">
@@ -14970,8 +15400,8 @@
         </p:nvSpPr>
         <p:spPr>
           <a:xfrm>
-            <a:off x="457200" y="2011680"/>
-            <a:ext cx="8229600" cy="1097280"/>
+            <a:off x="457200" y="137160"/>
+            <a:ext cx="8229600" cy="502920"/>
           </a:xfrm>
           <a:prstGeom prst="rect">
             <a:avLst/>
@@ -14987,14 +15417,149 @@
               <a:buNone/>
             </a:pPr>
             <a:r>
-              <a:rPr lang="en-US" sz="3600" b="1" dirty="0">
-                <a:solidFill>
-                  <a:srgbClr val="1A1A1A"/>
-                </a:solidFill>
-              </a:rPr>
-              <a:t>Extension: Agent Traces</a:t>
-            </a:r>
-            <a:endParaRPr lang="en-US" sz="3600" dirty="0"/>
+              <a:rPr lang="en-US" sz="2400" b="1" dirty="0">
+                <a:solidFill>
+                  <a:srgbClr val="000000"/>
+                </a:solidFill>
+              </a:rPr>
+              <a:t>Strip the task signal - process discipline emerges</a:t>
+            </a:r>
+            <a:endParaRPr lang="en-US" sz="2400" dirty="0"/>
+          </a:p>
+        </p:txBody>
+      </p:sp>
+      <p:graphicFrame>
+        <p:nvGraphicFramePr>
+          <p:cNvPr id="3" name="Chart 0" descr=""/>
+          <p:cNvGraphicFramePr/>
+          <p:nvPr/>
+        </p:nvGraphicFramePr>
+        <p:xfrm>
+          <a:off x="1554480" y="777240"/>
+          <a:ext cx="6035040" cy="3108960"/>
+        </p:xfrm>
+        <a:graphic xmlns:a="http://schemas.openxmlformats.org/drawingml/2006/main">
+          <a:graphicData uri="http://schemas.openxmlformats.org/drawingml/2006/chart">
+            <c:chart xmlns:c="http://schemas.openxmlformats.org/drawingml/2006/chart" r:id="rId1"/>
+          </a:graphicData>
+        </a:graphic>
+      </p:graphicFrame>
+      <p:sp>
+        <p:nvSpPr>
+          <p:cNvPr id="4" name="Text 1"/>
+          <p:cNvSpPr/>
+          <p:nvPr/>
+        </p:nvSpPr>
+        <p:spPr>
+          <a:xfrm>
+            <a:off x="457200" y="4069080"/>
+            <a:ext cx="8229600" cy="868680"/>
+          </a:xfrm>
+          <a:prstGeom prst="rect">
+            <a:avLst/>
+          </a:prstGeom>
+          <a:noFill/>
+          <a:ln/>
+        </p:spPr>
+        <p:txBody>
+          <a:bodyPr wrap="square" lIns="50800" tIns="50800" rIns="50800" bIns="50800" rtlCol="0" anchor="t"/>
+          <a:lstStyle/>
+          <a:p>
+            <a:pPr algn="ctr" indent="0" marL="0">
+              <a:buNone/>
+            </a:pPr>
+            <a:r>
+              <a:rPr lang="en-US" sz="1200" dirty="0">
+                <a:solidFill>
+                  <a:srgbClr val="000000"/>
+                </a:solidFill>
+              </a:rPr>
+              <a:t>Once cleanliness gain is removed, the score reflects </a:t>
+            </a:r>
+            <a:pPr algn="ctr" indent="0" marL="0">
+              <a:buNone/>
+            </a:pPr>
+            <a:r>
+              <a:rPr lang="en-US" sz="1200" i="1" dirty="0">
+                <a:solidFill>
+                  <a:srgbClr val="000000"/>
+                </a:solidFill>
+              </a:rPr>
+              <a:t>how disciplined the process was</a:t>
+            </a:r>
+            <a:pPr algn="ctr" indent="0" marL="0">
+              <a:buNone/>
+            </a:pPr>
+            <a:r>
+              <a:rPr lang="en-US" sz="1200" dirty="0">
+                <a:solidFill>
+                  <a:srgbClr val="000000"/>
+                </a:solidFill>
+              </a:rPr>
+              <a:t> - tests run, IDE refactorings used, commits at sensible points. The feedback group climbs </a:t>
+            </a:r>
+            <a:pPr algn="ctr" indent="0" marL="0">
+              <a:buNone/>
+            </a:pPr>
+            <a:r>
+              <a:rPr lang="en-US" sz="1200" b="1" dirty="0">
+                <a:solidFill>
+                  <a:srgbClr val="0000CD"/>
+                </a:solidFill>
+              </a:rPr>
+              <a:t>+22.3</a:t>
+            </a:r>
+            <a:pPr algn="ctr" indent="0" marL="0">
+              <a:buNone/>
+            </a:pPr>
+            <a:r>
+              <a:rPr lang="en-US" sz="1200" dirty="0">
+                <a:solidFill>
+                  <a:srgbClr val="000000"/>
+                </a:solidFill>
+              </a:rPr>
+              <a:t> across the arc; the baseline group moves </a:t>
+            </a:r>
+            <a:pPr algn="ctr" indent="0" marL="0">
+              <a:buNone/>
+            </a:pPr>
+            <a:r>
+              <a:rPr lang="en-US" sz="1200" b="1" dirty="0">
+                <a:solidFill>
+                  <a:srgbClr val="B25500"/>
+                </a:solidFill>
+              </a:rPr>
+              <a:t>−2.0</a:t>
+            </a:r>
+            <a:pPr algn="ctr" indent="0" marL="0">
+              <a:spcAft>
+                <a:spcPts val="600"/>
+              </a:spcAft>
+              <a:buNone/>
+            </a:pPr>
+            <a:r>
+              <a:rPr lang="en-US" sz="1200" dirty="0">
+                <a:solidFill>
+                  <a:srgbClr val="000000"/>
+                </a:solidFill>
+              </a:rPr>
+              <a:t>.</a:t>
+            </a:r>
+            <a:endParaRPr lang="en-US" sz="1200" dirty="0"/>
+          </a:p>
+          <a:p>
+            <a:pPr algn="ctr" indent="0" marL="0">
+              <a:buNone/>
+            </a:pPr>
+            <a:r>
+              <a:rPr lang="en-US" sz="1200" i="1" dirty="0">
+                <a:solidFill>
+                  <a:srgbClr val="888888"/>
+                </a:solidFill>
+              </a:rPr>
+              <a:t>n = 3 vs n = 2 - directional finding, not a hypothesis test.</a:t>
+            </a:r>
+            <a:endParaRPr lang="en-US" sz="1200" dirty="0"/>
           </a:p>
         </p:txBody>
       </p:sp>
@@ -15031,6 +15596,67 @@
         </p:nvSpPr>
         <p:spPr>
           <a:xfrm>
+            <a:off x="457200" y="2011680"/>
+            <a:ext cx="8229600" cy="1097280"/>
+          </a:xfrm>
+          <a:prstGeom prst="rect">
+            <a:avLst/>
+          </a:prstGeom>
+          <a:noFill/>
+          <a:ln/>
+        </p:spPr>
+        <p:txBody>
+          <a:bodyPr wrap="square" lIns="0" tIns="0" rIns="0" bIns="0" rtlCol="0" anchor="ctr"/>
+          <a:lstStyle/>
+          <a:p>
+            <a:pPr algn="ctr" indent="0" marL="0">
+              <a:buNone/>
+            </a:pPr>
+            <a:r>
+              <a:rPr lang="en-US" sz="3600" b="1" dirty="0">
+                <a:solidFill>
+                  <a:srgbClr val="1A1A1A"/>
+                </a:solidFill>
+              </a:rPr>
+              <a:t>Extension: Agent Traces</a:t>
+            </a:r>
+            <a:endParaRPr lang="en-US" sz="3600" dirty="0"/>
+          </a:p>
+        </p:txBody>
+      </p:sp>
+    </p:spTree>
+  </p:cSld>
+  <p:clrMapOvr>
+    <a:masterClrMapping/>
+  </p:clrMapOvr>
+</p:sld>
+</file>
+
+<file path=ppt/slides/slide28.xml><?xml version="1.0" encoding="utf-8"?>
+<p:sld xmlns:a="http://schemas.openxmlformats.org/drawingml/2006/main" xmlns:r="http://schemas.openxmlformats.org/officeDocument/2006/relationships" xmlns:p="http://schemas.openxmlformats.org/presentationml/2006/main">
+  <p:cSld name="Slide 28">
+    <p:spTree>
+      <p:nvGrpSpPr>
+        <p:cNvPr id="1" name=""/>
+        <p:cNvGrpSpPr/>
+        <p:nvPr/>
+      </p:nvGrpSpPr>
+      <p:grpSpPr>
+        <a:xfrm>
+          <a:off x="0" y="0"/>
+          <a:ext cx="0" cy="0"/>
+          <a:chOff x="0" y="0"/>
+          <a:chExt cx="0" cy="0"/>
+        </a:xfrm>
+      </p:grpSpPr>
+      <p:sp>
+        <p:nvSpPr>
+          <p:cNvPr id="2" name="Text 0"/>
+          <p:cNvSpPr/>
+          <p:nvPr/>
+        </p:nvSpPr>
+        <p:spPr>
+          <a:xfrm>
             <a:off x="457200" y="137160"/>
             <a:ext cx="8229600" cy="457200"/>
           </a:xfrm>
@@ -15113,7 +15739,7 @@
       </p:graphicFrame>
       <p:graphicFrame>
         <p:nvGraphicFramePr>
-          <p:cNvPr id="28" name="Table 0"/>
+          <p:cNvPr id="29" name="Table 0"/>
           <p:cNvGraphicFramePr>
             <a:graphicFrameLocks noGrp="1"/>
           </p:cNvGraphicFramePr>
@@ -15892,9 +16518,9 @@
 </p:sld>
 </file>
 
-<file path=ppt/slides/slide28.xml><?xml version="1.0" encoding="utf-8"?>
+<file path=ppt/slides/slide29.xml><?xml version="1.0" encoding="utf-8"?>
 <p:sld xmlns:a="http://schemas.openxmlformats.org/drawingml/2006/main" xmlns:r="http://schemas.openxmlformats.org/officeDocument/2006/relationships" xmlns:p="http://schemas.openxmlformats.org/presentationml/2006/main">
-  <p:cSld name="Slide 28">
+  <p:cSld name="Slide 29">
     <p:spTree>
       <p:nvGrpSpPr>
         <p:cNvPr id="1" name=""/>

</xml_diff>

<commit_message>
feat: add process score reliable slide
</commit_message>
<xml_diff>
--- a/presentation/slides.pptx
+++ b/presentation/slides.pptx
@@ -34,9 +34,10 @@
     <p:sldId id="282" r:id="rId28"/>
     <p:sldId id="283" r:id="rId29"/>
     <p:sldId id="284" r:id="rId30"/>
+    <p:sldId id="285" r:id="rId31"/>
   </p:sldIdLst>
   <p:notesMasterIdLst>
-    <p:notesMasterId r:id="rId31"/>
+    <p:notesMasterId r:id="rId32"/>
   </p:notesMasterIdLst>
   <p:sldSz cx="9144000" cy="5143500"/>
   <p:notesSz cx="5143500" cy="9144000"/>
@@ -4298,6 +4299,94 @@
             <a:fld id="{F7021451-1387-4CA6-816F-3879F97B5CBC}" type="slidenum">
               <a:rPr lang="en-US"/>
               <a:t>3</a:t>
+            </a:fld>
+            <a:endParaRPr lang="en-US"/>
+          </a:p>
+        </p:txBody>
+      </p:sp>
+    </p:spTree>
+    <p:extLst>
+      <p:ext uri="{BB962C8B-B14F-4D97-AF65-F5344CB8AC3E}">
+        <p14:creationId xmlns:p14="http://schemas.microsoft.com/office/powerpoint/2010/main" val="1024086991"/>
+      </p:ext>
+    </p:extLst>
+  </p:cSld>
+  <p:clrMapOvr>
+    <a:masterClrMapping/>
+  </p:clrMapOvr>
+</p:notes>
+</file>
+
+<file path=ppt/notesSlides/notesSlide30.xml><?xml version="1.0" encoding="utf-8"?>
+<p:notes xmlns:a="http://schemas.openxmlformats.org/drawingml/2006/main" xmlns:r="http://schemas.openxmlformats.org/officeDocument/2006/relationships" xmlns:p="http://schemas.openxmlformats.org/presentationml/2006/main">
+  <p:cSld>
+    <p:spTree>
+      <p:nvGrpSpPr>
+        <p:cNvPr id="1" name=""/>
+        <p:cNvGrpSpPr/>
+        <p:nvPr/>
+      </p:nvGrpSpPr>
+      <p:grpSpPr>
+        <a:xfrm>
+          <a:off x="0" y="0"/>
+          <a:ext cx="0" cy="0"/>
+          <a:chOff x="0" y="0"/>
+          <a:chExt cx="0" cy="0"/>
+        </a:xfrm>
+      </p:grpSpPr>
+      <p:sp>
+        <p:nvSpPr>
+          <p:cNvPr id="2" name="Slide Image Placeholder 1"/>
+          <p:cNvSpPr>
+            <a:spLocks noGrp="1" noRot="1" noChangeAspect="1"/>
+          </p:cNvSpPr>
+          <p:nvPr>
+            <p:ph type="sldImg"/>
+          </p:nvPr>
+        </p:nvSpPr>
+        <p:spPr/>
+      </p:sp>
+      <p:sp>
+        <p:nvSpPr>
+          <p:cNvPr id="3" name="Notes Placeholder 2"/>
+          <p:cNvSpPr>
+            <a:spLocks noGrp="1"/>
+          </p:cNvSpPr>
+          <p:nvPr>
+            <p:ph type="body" idx="1"/>
+          </p:nvPr>
+        </p:nvSpPr>
+        <p:spPr/>
+        <p:txBody>
+          <a:bodyPr/>
+          <a:lstStyle/>
+          <a:p>
+            <a:r>
+              <a:rPr lang="en-US" dirty="0"/>
+              <a:t/>
+            </a:r>
+            <a:endParaRPr lang="en-US" dirty="0"/>
+          </a:p>
+        </p:txBody>
+      </p:sp>
+      <p:sp>
+        <p:nvSpPr>
+          <p:cNvPr id="4" name="Slide Number Placeholder 3"/>
+          <p:cNvSpPr>
+            <a:spLocks noGrp="1"/>
+          </p:cNvSpPr>
+          <p:nvPr>
+            <p:ph type="sldNum" sz="quarter" idx="10"/>
+          </p:nvPr>
+        </p:nvSpPr>
+        <p:spPr/>
+        <p:txBody>
+          <a:bodyPr/>
+          <a:lstStyle/>
+          <a:p>
+            <a:fld id="{F7021451-1387-4CA6-816F-3879F97B5CBC}" type="slidenum">
+              <a:rPr lang="en-US"/>
+              <a:t>30</a:t>
             </a:fld>
             <a:endParaRPr lang="en-US"/>
           </a:p>
@@ -13022,6 +13111,543 @@
         </p:nvSpPr>
         <p:spPr>
           <a:xfrm>
+            <a:off x="457200" y="137160"/>
+            <a:ext cx="8229600" cy="502920"/>
+          </a:xfrm>
+          <a:prstGeom prst="rect">
+            <a:avLst/>
+          </a:prstGeom>
+          <a:noFill/>
+          <a:ln/>
+        </p:spPr>
+        <p:txBody>
+          <a:bodyPr wrap="square" lIns="0" tIns="0" rIns="0" bIns="0" rtlCol="0" anchor="ctr"/>
+          <a:lstStyle/>
+          <a:p>
+            <a:pPr algn="ctr" indent="0" marL="0">
+              <a:buNone/>
+            </a:pPr>
+            <a:r>
+              <a:rPr lang="en-US" sz="2400" b="1" dirty="0">
+                <a:solidFill>
+                  <a:srgbClr val="000000"/>
+                </a:solidFill>
+              </a:rPr>
+              <a:t>Experiment 2: Is the process score reliable?</a:t>
+            </a:r>
+            <a:endParaRPr lang="en-US" sz="2400" dirty="0"/>
+          </a:p>
+        </p:txBody>
+      </p:sp>
+      <p:sp>
+        <p:nvSpPr>
+          <p:cNvPr id="3" name="Text 1"/>
+          <p:cNvSpPr/>
+          <p:nvPr/>
+        </p:nvSpPr>
+        <p:spPr>
+          <a:xfrm>
+            <a:off x="274320" y="731520"/>
+            <a:ext cx="4160520" cy="228600"/>
+          </a:xfrm>
+          <a:prstGeom prst="rect">
+            <a:avLst/>
+          </a:prstGeom>
+          <a:noFill/>
+          <a:ln/>
+        </p:spPr>
+        <p:txBody>
+          <a:bodyPr wrap="square" lIns="0" tIns="0" rIns="0" bIns="0" rtlCol="0" anchor="ctr"/>
+          <a:lstStyle/>
+          <a:p>
+            <a:pPr algn="ctr" indent="0" marL="0">
+              <a:buNone/>
+            </a:pPr>
+            <a:r>
+              <a:rPr lang="en-US" sz="1000" b="1" spc="200" kern="0" dirty="0">
+                <a:solidFill>
+                  <a:srgbClr val="888888"/>
+                </a:solidFill>
+              </a:rPr>
+              <a:t>STABILITY</a:t>
+            </a:r>
+            <a:endParaRPr lang="en-US" sz="1000" dirty="0"/>
+          </a:p>
+        </p:txBody>
+      </p:sp>
+      <p:sp>
+        <p:nvSpPr>
+          <p:cNvPr id="4" name="Text 2"/>
+          <p:cNvSpPr/>
+          <p:nvPr/>
+        </p:nvSpPr>
+        <p:spPr>
+          <a:xfrm>
+            <a:off x="4709160" y="731520"/>
+            <a:ext cx="4160520" cy="228600"/>
+          </a:xfrm>
+          <a:prstGeom prst="rect">
+            <a:avLst/>
+          </a:prstGeom>
+          <a:noFill/>
+          <a:ln/>
+        </p:spPr>
+        <p:txBody>
+          <a:bodyPr wrap="square" lIns="0" tIns="0" rIns="0" bIns="0" rtlCol="0" anchor="ctr"/>
+          <a:lstStyle/>
+          <a:p>
+            <a:pPr algn="ctr" indent="0" marL="0">
+              <a:buNone/>
+            </a:pPr>
+            <a:r>
+              <a:rPr lang="en-US" sz="1000" b="1" spc="200" kern="0" dirty="0">
+                <a:solidFill>
+                  <a:srgbClr val="888888"/>
+                </a:solidFill>
+              </a:rPr>
+              <a:t>ABLATION</a:t>
+            </a:r>
+            <a:endParaRPr lang="en-US" sz="1000" dirty="0"/>
+          </a:p>
+        </p:txBody>
+      </p:sp>
+      <p:sp>
+        <p:nvSpPr>
+          <p:cNvPr id="5" name="Shape 3"/>
+          <p:cNvSpPr/>
+          <p:nvPr/>
+        </p:nvSpPr>
+        <p:spPr>
+          <a:xfrm>
+            <a:off x="274320" y="1005840"/>
+            <a:ext cx="4160520" cy="1783080"/>
+          </a:xfrm>
+          <a:prstGeom prst="roundRect">
+            <a:avLst>
+              <a:gd name="adj" fmla="val 4103"/>
+            </a:avLst>
+          </a:prstGeom>
+          <a:solidFill>
+            <a:srgbClr val="F5F5F5"/>
+          </a:solidFill>
+          <a:ln/>
+        </p:spPr>
+      </p:sp>
+      <p:sp>
+        <p:nvSpPr>
+          <p:cNvPr id="6" name="Text 4"/>
+          <p:cNvSpPr/>
+          <p:nvPr/>
+        </p:nvSpPr>
+        <p:spPr>
+          <a:xfrm>
+            <a:off x="457200" y="1097280"/>
+            <a:ext cx="3794760" cy="1600200"/>
+          </a:xfrm>
+          <a:prstGeom prst="rect">
+            <a:avLst/>
+          </a:prstGeom>
+          <a:noFill/>
+          <a:ln/>
+        </p:spPr>
+        <p:txBody>
+          <a:bodyPr wrap="square" lIns="0" tIns="0" rIns="0" bIns="0" rtlCol="0" anchor="ctr"/>
+          <a:lstStyle/>
+          <a:p>
+            <a:pPr algn="ctr" indent="0" marL="0">
+              <a:spcAft>
+                <a:spcPts val="600"/>
+              </a:spcAft>
+              <a:buNone/>
+            </a:pPr>
+            <a:r>
+              <a:rPr lang="en-US" sz="4400" b="1" dirty="0">
+                <a:solidFill>
+                  <a:srgbClr val="0000CD"/>
+                </a:solidFill>
+              </a:rPr>
+              <a:t>96.5%</a:t>
+            </a:r>
+            <a:endParaRPr lang="en-US" sz="4400" dirty="0"/>
+          </a:p>
+          <a:p>
+            <a:pPr algn="ctr" indent="0" marL="0">
+              <a:spcAft>
+                <a:spcPts val="800"/>
+              </a:spcAft>
+              <a:buNone/>
+            </a:pPr>
+            <a:r>
+              <a:rPr lang="en-US" sz="1100" b="1" dirty="0">
+                <a:solidFill>
+                  <a:srgbClr val="1A1A1A"/>
+                </a:solidFill>
+              </a:rPr>
+              <a:t>Single-knob top-1 preserved</a:t>
+            </a:r>
+            <a:endParaRPr lang="en-US" sz="4400" dirty="0"/>
+          </a:p>
+          <a:p>
+            <a:pPr algn="ctr" indent="0" marL="0">
+              <a:buNone/>
+            </a:pPr>
+            <a:r>
+              <a:rPr lang="en-US" sz="1000" i="1" dirty="0">
+                <a:solidFill>
+                  <a:srgbClr val="555555"/>
+                </a:solidFill>
+              </a:rPr>
+              <a:t>Top-ranked divergence rarely changes under any one-weight perturbation. Only 1.8% of cases are clamp-frozen, so this is genuine response - not a clamp artefact.</a:t>
+            </a:r>
+            <a:endParaRPr lang="en-US" sz="4400" dirty="0"/>
+          </a:p>
+        </p:txBody>
+      </p:sp>
+      <p:sp>
+        <p:nvSpPr>
+          <p:cNvPr id="7" name="Shape 5"/>
+          <p:cNvSpPr/>
+          <p:nvPr/>
+        </p:nvSpPr>
+        <p:spPr>
+          <a:xfrm>
+            <a:off x="4709160" y="1005840"/>
+            <a:ext cx="4160520" cy="1783080"/>
+          </a:xfrm>
+          <a:prstGeom prst="roundRect">
+            <a:avLst>
+              <a:gd name="adj" fmla="val 4103"/>
+            </a:avLst>
+          </a:prstGeom>
+          <a:solidFill>
+            <a:srgbClr val="F5F5F5"/>
+          </a:solidFill>
+          <a:ln/>
+        </p:spPr>
+      </p:sp>
+      <p:sp>
+        <p:nvSpPr>
+          <p:cNvPr id="8" name="Text 6"/>
+          <p:cNvSpPr/>
+          <p:nvPr/>
+        </p:nvSpPr>
+        <p:spPr>
+          <a:xfrm>
+            <a:off x="4892040" y="1097280"/>
+            <a:ext cx="3794760" cy="1600200"/>
+          </a:xfrm>
+          <a:prstGeom prst="rect">
+            <a:avLst/>
+          </a:prstGeom>
+          <a:noFill/>
+          <a:ln/>
+        </p:spPr>
+        <p:txBody>
+          <a:bodyPr wrap="square" lIns="0" tIns="0" rIns="0" bIns="0" rtlCol="0" anchor="ctr"/>
+          <a:lstStyle/>
+          <a:p>
+            <a:pPr algn="ctr" indent="0" marL="0">
+              <a:spcAft>
+                <a:spcPts val="600"/>
+              </a:spcAft>
+              <a:buNone/>
+            </a:pPr>
+            <a:r>
+              <a:rPr lang="en-US" sz="4400" b="1" dirty="0">
+                <a:solidFill>
+                  <a:srgbClr val="0000CD"/>
+                </a:solidFill>
+              </a:rPr>
+              <a:t>7 / 7</a:t>
+            </a:r>
+            <a:endParaRPr lang="en-US" sz="4400" dirty="0"/>
+          </a:p>
+          <a:p>
+            <a:pPr algn="ctr" indent="0" marL="0">
+              <a:spcAft>
+                <a:spcPts val="800"/>
+              </a:spcAft>
+              <a:buNone/>
+            </a:pPr>
+            <a:r>
+              <a:rPr lang="en-US" sz="1100" b="1" dirty="0">
+                <a:solidFill>
+                  <a:srgbClr val="1A1A1A"/>
+                </a:solidFill>
+              </a:rPr>
+              <a:t>Process terms with measurable rank effect  ·  LOO τ-b range 0.527 - 0.784</a:t>
+            </a:r>
+            <a:endParaRPr lang="en-US" sz="4400" dirty="0"/>
+          </a:p>
+          <a:p>
+            <a:pPr algn="ctr" indent="0" marL="0">
+              <a:buNone/>
+            </a:pPr>
+            <a:r>
+              <a:rPr lang="en-US" sz="1000" i="1" dirty="0">
+                <a:solidFill>
+                  <a:srgbClr val="555555"/>
+                </a:solidFill>
+              </a:rPr>
+              <a:t>Length is the strongest rank-carrier (0.527); lag the weakest (0.784, but contributes via magnitude). No process term is redundant.</a:t>
+            </a:r>
+            <a:endParaRPr lang="en-US" sz="4400" dirty="0"/>
+          </a:p>
+        </p:txBody>
+      </p:sp>
+      <p:sp>
+        <p:nvSpPr>
+          <p:cNvPr id="9" name="Shape 7"/>
+          <p:cNvSpPr/>
+          <p:nvPr/>
+        </p:nvSpPr>
+        <p:spPr>
+          <a:xfrm>
+            <a:off x="274320" y="2926080"/>
+            <a:ext cx="4160520" cy="1691640"/>
+          </a:xfrm>
+          <a:prstGeom prst="roundRect">
+            <a:avLst>
+              <a:gd name="adj" fmla="val 4324"/>
+            </a:avLst>
+          </a:prstGeom>
+          <a:solidFill>
+            <a:srgbClr val="F5F5F5"/>
+          </a:solidFill>
+          <a:ln/>
+        </p:spPr>
+      </p:sp>
+      <p:sp>
+        <p:nvSpPr>
+          <p:cNvPr id="10" name="Text 8"/>
+          <p:cNvSpPr/>
+          <p:nvPr/>
+        </p:nvSpPr>
+        <p:spPr>
+          <a:xfrm>
+            <a:off x="457200" y="3017520"/>
+            <a:ext cx="3794760" cy="1508760"/>
+          </a:xfrm>
+          <a:prstGeom prst="rect">
+            <a:avLst/>
+          </a:prstGeom>
+          <a:noFill/>
+          <a:ln/>
+        </p:spPr>
+        <p:txBody>
+          <a:bodyPr wrap="square" lIns="0" tIns="0" rIns="0" bIns="0" rtlCol="0" anchor="ctr"/>
+          <a:lstStyle/>
+          <a:p>
+            <a:pPr algn="ctr" indent="0" marL="0">
+              <a:spcAft>
+                <a:spcPts val="600"/>
+              </a:spcAft>
+              <a:buNone/>
+            </a:pPr>
+            <a:r>
+              <a:rPr lang="en-US" sz="4400" b="1" dirty="0">
+                <a:solidFill>
+                  <a:srgbClr val="0000CD"/>
+                </a:solidFill>
+              </a:rPr>
+              <a:t>84.6%</a:t>
+            </a:r>
+            <a:endParaRPr lang="en-US" sz="4400" dirty="0"/>
+          </a:p>
+          <a:p>
+            <a:pPr algn="ctr" indent="0" marL="0">
+              <a:spcAft>
+                <a:spcPts val="800"/>
+              </a:spcAft>
+              <a:buNone/>
+            </a:pPr>
+            <a:r>
+              <a:rPr lang="en-US" sz="1100" b="1" dirty="0">
+                <a:solidFill>
+                  <a:srgbClr val="1A1A1A"/>
+                </a:solidFill>
+              </a:rPr>
+              <a:t>Multi-knob top-1 preserved  ·  mean τ-b = 0.586</a:t>
+            </a:r>
+            <a:endParaRPr lang="en-US" sz="4400" dirty="0"/>
+          </a:p>
+          <a:p>
+            <a:pPr algn="ctr" indent="0" marL="0">
+              <a:buNone/>
+            </a:pPr>
+            <a:r>
+              <a:rPr lang="en-US" sz="1000" i="1" dirty="0">
+                <a:solidFill>
+                  <a:srgbClr val="555555"/>
+                </a:solidFill>
+              </a:rPr>
+              <a:t>When all 7 weights move at once (σ = ln 2 ≈ ×0.25 to ×4), the top-ranked divergence holds in ~85% of samples. Meaningful rank correlation, not full preservation.</a:t>
+            </a:r>
+            <a:endParaRPr lang="en-US" sz="4400" dirty="0"/>
+          </a:p>
+        </p:txBody>
+      </p:sp>
+      <p:sp>
+        <p:nvSpPr>
+          <p:cNvPr id="11" name="Shape 9"/>
+          <p:cNvSpPr/>
+          <p:nvPr/>
+        </p:nvSpPr>
+        <p:spPr>
+          <a:xfrm>
+            <a:off x="4709160" y="2926080"/>
+            <a:ext cx="4160520" cy="1691640"/>
+          </a:xfrm>
+          <a:prstGeom prst="roundRect">
+            <a:avLst>
+              <a:gd name="adj" fmla="val 4324"/>
+            </a:avLst>
+          </a:prstGeom>
+          <a:solidFill>
+            <a:srgbClr val="F5F5F5"/>
+          </a:solidFill>
+          <a:ln/>
+        </p:spPr>
+      </p:sp>
+      <p:sp>
+        <p:nvSpPr>
+          <p:cNvPr id="12" name="Text 10"/>
+          <p:cNvSpPr/>
+          <p:nvPr/>
+        </p:nvSpPr>
+        <p:spPr>
+          <a:xfrm>
+            <a:off x="4892040" y="3017520"/>
+            <a:ext cx="3794760" cy="1508760"/>
+          </a:xfrm>
+          <a:prstGeom prst="rect">
+            <a:avLst/>
+          </a:prstGeom>
+          <a:noFill/>
+          <a:ln/>
+        </p:spPr>
+        <p:txBody>
+          <a:bodyPr wrap="square" lIns="0" tIns="0" rIns="0" bIns="0" rtlCol="0" anchor="ctr"/>
+          <a:lstStyle/>
+          <a:p>
+            <a:pPr algn="ctr" indent="0" marL="0">
+              <a:spcAft>
+                <a:spcPts val="600"/>
+              </a:spcAft>
+              <a:buNone/>
+            </a:pPr>
+            <a:r>
+              <a:rPr lang="en-US" sz="4400" b="1" dirty="0">
+                <a:solidFill>
+                  <a:srgbClr val="0000CD"/>
+                </a:solidFill>
+              </a:rPr>
+              <a:t>≤ 0.9%</a:t>
+            </a:r>
+            <a:endParaRPr lang="en-US" sz="4400" dirty="0"/>
+          </a:p>
+          <a:p>
+            <a:pPr algn="ctr" indent="0" marL="0">
+              <a:spcAft>
+                <a:spcPts val="800"/>
+              </a:spcAft>
+              <a:buNone/>
+            </a:pPr>
+            <a:r>
+              <a:rPr lang="en-US" sz="1100" b="1" dirty="0">
+                <a:solidFill>
+                  <a:srgbClr val="1A1A1A"/>
+                </a:solidFill>
+              </a:rPr>
+              <a:t>Top-1 disruption from any single cleanliness sub-weight</a:t>
+            </a:r>
+            <a:endParaRPr lang="en-US" sz="4400" dirty="0"/>
+          </a:p>
+          <a:p>
+            <a:pPr algn="ctr" indent="0" marL="0">
+              <a:buNone/>
+            </a:pPr>
+            <a:r>
+              <a:rPr lang="en-US" sz="1000" i="1" dirty="0">
+                <a:solidFill>
+                  <a:srgbClr val="555555"/>
+                </a:solidFill>
+              </a:rPr>
+              <a:t>Perturbing any of the 6 cleanliness signals (complexity, coupling, duplication, readability, smells, cohesion) barely shifts the ranking - ~10× less than process weights. Equal weights are defensible.</a:t>
+            </a:r>
+            <a:endParaRPr lang="en-US" sz="4400" dirty="0"/>
+          </a:p>
+        </p:txBody>
+      </p:sp>
+      <p:sp>
+        <p:nvSpPr>
+          <p:cNvPr id="13" name="Text 11"/>
+          <p:cNvSpPr/>
+          <p:nvPr/>
+        </p:nvSpPr>
+        <p:spPr>
+          <a:xfrm>
+            <a:off x="457200" y="4709160"/>
+            <a:ext cx="8229600" cy="365760"/>
+          </a:xfrm>
+          <a:prstGeom prst="rect">
+            <a:avLst/>
+          </a:prstGeom>
+          <a:noFill/>
+          <a:ln/>
+        </p:spPr>
+        <p:txBody>
+          <a:bodyPr wrap="square" lIns="0" tIns="0" rIns="0" bIns="0" rtlCol="0" anchor="ctr"/>
+          <a:lstStyle/>
+          <a:p>
+            <a:pPr algn="ctr" indent="0" marL="0">
+              <a:buNone/>
+            </a:pPr>
+            <a:r>
+              <a:rPr lang="en-US" sz="1100" i="1" dirty="0">
+                <a:solidFill>
+                  <a:srgbClr val="0000CD"/>
+                </a:solidFill>
+              </a:rPr>
+              <a:t>Top-1 holds under both single- and multi-knob perturbation, and every process term carries measurable rank effect. Robustness ≠ calibration: weights aren't validated against downstream outcomes.</a:t>
+            </a:r>
+            <a:endParaRPr lang="en-US" sz="1100" dirty="0"/>
+          </a:p>
+        </p:txBody>
+      </p:sp>
+    </p:spTree>
+  </p:cSld>
+  <p:clrMapOvr>
+    <a:masterClrMapping/>
+  </p:clrMapOvr>
+</p:sld>
+</file>
+
+<file path=ppt/slides/slide23.xml><?xml version="1.0" encoding="utf-8"?>
+<p:sld xmlns:a="http://schemas.openxmlformats.org/drawingml/2006/main" xmlns:r="http://schemas.openxmlformats.org/officeDocument/2006/relationships" xmlns:p="http://schemas.openxmlformats.org/presentationml/2006/main" show="0">
+  <p:cSld name="Slide 23">
+    <p:spTree>
+      <p:nvGrpSpPr>
+        <p:cNvPr id="1" name=""/>
+        <p:cNvGrpSpPr/>
+        <p:nvPr/>
+      </p:nvGrpSpPr>
+      <p:grpSpPr>
+        <a:xfrm>
+          <a:off x="0" y="0"/>
+          <a:ext cx="0" cy="0"/>
+          <a:chOff x="0" y="0"/>
+          <a:chExt cx="0" cy="0"/>
+        </a:xfrm>
+      </p:grpSpPr>
+      <p:sp>
+        <p:nvSpPr>
+          <p:cNvPr id="2" name="Text 0"/>
+          <p:cNvSpPr/>
+          <p:nvPr/>
+        </p:nvSpPr>
+        <p:spPr>
+          <a:xfrm>
             <a:off x="457200" y="274320"/>
             <a:ext cx="8229600" cy="640080"/>
           </a:xfrm>
@@ -13189,7 +13815,7 @@
       </p:sp>
       <p:graphicFrame>
         <p:nvGraphicFramePr>
-          <p:cNvPr id="23" name="Table 0"/>
+          <p:cNvPr id="24" name="Table 0"/>
           <p:cNvGraphicFramePr>
             <a:graphicFrameLocks noGrp="1"/>
           </p:cNvGraphicFramePr>
@@ -14847,69 +15473,8 @@
 </p:sld>
 </file>
 
-<file path=ppt/slides/slide23.xml><?xml version="1.0" encoding="utf-8"?>
+<file path=ppt/slides/slide24.xml><?xml version="1.0" encoding="utf-8"?>
 <p:sld xmlns:a="http://schemas.openxmlformats.org/drawingml/2006/main" xmlns:r="http://schemas.openxmlformats.org/officeDocument/2006/relationships" xmlns:p="http://schemas.openxmlformats.org/presentationml/2006/main">
-  <p:cSld name="Slide 23">
-    <p:spTree>
-      <p:nvGrpSpPr>
-        <p:cNvPr id="1" name=""/>
-        <p:cNvGrpSpPr/>
-        <p:nvPr/>
-      </p:nvGrpSpPr>
-      <p:grpSpPr>
-        <a:xfrm>
-          <a:off x="0" y="0"/>
-          <a:ext cx="0" cy="0"/>
-          <a:chOff x="0" y="0"/>
-          <a:chExt cx="0" cy="0"/>
-        </a:xfrm>
-      </p:grpSpPr>
-      <p:sp>
-        <p:nvSpPr>
-          <p:cNvPr id="2" name="Text 0"/>
-          <p:cNvSpPr/>
-          <p:nvPr/>
-        </p:nvSpPr>
-        <p:spPr>
-          <a:xfrm>
-            <a:off x="457200" y="2011680"/>
-            <a:ext cx="8229600" cy="1097280"/>
-          </a:xfrm>
-          <a:prstGeom prst="rect">
-            <a:avLst/>
-          </a:prstGeom>
-          <a:noFill/>
-          <a:ln/>
-        </p:spPr>
-        <p:txBody>
-          <a:bodyPr wrap="square" lIns="0" tIns="0" rIns="0" bIns="0" rtlCol="0" anchor="ctr"/>
-          <a:lstStyle/>
-          <a:p>
-            <a:pPr algn="ctr" indent="0" marL="0">
-              <a:buNone/>
-            </a:pPr>
-            <a:r>
-              <a:rPr lang="en-US" sz="3200" b="1" dirty="0">
-                <a:solidFill>
-                  <a:srgbClr val="1A1A1A"/>
-                </a:solidFill>
-              </a:rPr>
-              <a:t>Experiment 3: Does feedback change developer behaviour?</a:t>
-            </a:r>
-            <a:endParaRPr lang="en-US" sz="3200" dirty="0"/>
-          </a:p>
-        </p:txBody>
-      </p:sp>
-    </p:spTree>
-  </p:cSld>
-  <p:clrMapOvr>
-    <a:masterClrMapping/>
-  </p:clrMapOvr>
-</p:sld>
-</file>
-
-<file path=ppt/slides/slide24.xml><?xml version="1.0" encoding="utf-8"?>
-<p:sld xmlns:a="http://schemas.openxmlformats.org/drawingml/2006/main" xmlns:r="http://schemas.openxmlformats.org/officeDocument/2006/relationships" xmlns:p="http://schemas.openxmlformats.org/presentationml/2006/main" show="0">
   <p:cSld name="Slide 24">
     <p:spTree>
       <p:nvGrpSpPr>
@@ -14933,6 +15498,67 @@
         </p:nvSpPr>
         <p:spPr>
           <a:xfrm>
+            <a:off x="457200" y="2011680"/>
+            <a:ext cx="8229600" cy="1097280"/>
+          </a:xfrm>
+          <a:prstGeom prst="rect">
+            <a:avLst/>
+          </a:prstGeom>
+          <a:noFill/>
+          <a:ln/>
+        </p:spPr>
+        <p:txBody>
+          <a:bodyPr wrap="square" lIns="0" tIns="0" rIns="0" bIns="0" rtlCol="0" anchor="ctr"/>
+          <a:lstStyle/>
+          <a:p>
+            <a:pPr algn="ctr" indent="0" marL="0">
+              <a:buNone/>
+            </a:pPr>
+            <a:r>
+              <a:rPr lang="en-US" sz="3200" b="1" dirty="0">
+                <a:solidFill>
+                  <a:srgbClr val="1A1A1A"/>
+                </a:solidFill>
+              </a:rPr>
+              <a:t>Experiment 3: Does feedback change developer behaviour?</a:t>
+            </a:r>
+            <a:endParaRPr lang="en-US" sz="3200" dirty="0"/>
+          </a:p>
+        </p:txBody>
+      </p:sp>
+    </p:spTree>
+  </p:cSld>
+  <p:clrMapOvr>
+    <a:masterClrMapping/>
+  </p:clrMapOvr>
+</p:sld>
+</file>
+
+<file path=ppt/slides/slide25.xml><?xml version="1.0" encoding="utf-8"?>
+<p:sld xmlns:a="http://schemas.openxmlformats.org/drawingml/2006/main" xmlns:r="http://schemas.openxmlformats.org/officeDocument/2006/relationships" xmlns:p="http://schemas.openxmlformats.org/presentationml/2006/main" show="0">
+  <p:cSld name="Slide 25">
+    <p:spTree>
+      <p:nvGrpSpPr>
+        <p:cNvPr id="1" name=""/>
+        <p:cNvGrpSpPr/>
+        <p:nvPr/>
+      </p:nvGrpSpPr>
+      <p:grpSpPr>
+        <a:xfrm>
+          <a:off x="0" y="0"/>
+          <a:ext cx="0" cy="0"/>
+          <a:chOff x="0" y="0"/>
+          <a:chExt cx="0" cy="0"/>
+        </a:xfrm>
+      </p:grpSpPr>
+      <p:sp>
+        <p:nvSpPr>
+          <p:cNvPr id="2" name="Text 0"/>
+          <p:cNvSpPr/>
+          <p:nvPr/>
+        </p:nvSpPr>
+        <p:spPr>
+          <a:xfrm>
             <a:off x="457200" y="274320"/>
             <a:ext cx="8229600" cy="640080"/>
           </a:xfrm>
@@ -15163,9 +15789,9 @@
 </p:sld>
 </file>
 
-<file path=ppt/slides/slide25.xml><?xml version="1.0" encoding="utf-8"?>
+<file path=ppt/slides/slide26.xml><?xml version="1.0" encoding="utf-8"?>
 <p:sld xmlns:a="http://schemas.openxmlformats.org/drawingml/2006/main" xmlns:r="http://schemas.openxmlformats.org/officeDocument/2006/relationships" xmlns:p="http://schemas.openxmlformats.org/presentationml/2006/main">
-  <p:cSld name="Slide 25">
+  <p:cSld name="Slide 26">
     <p:spTree>
       <p:nvGrpSpPr>
         <p:cNvPr id="1" name=""/>
@@ -15375,202 +16001,6 @@
 </p:sld>
 </file>
 
-<file path=ppt/slides/slide26.xml><?xml version="1.0" encoding="utf-8"?>
-<p:sld xmlns:a="http://schemas.openxmlformats.org/drawingml/2006/main" xmlns:r="http://schemas.openxmlformats.org/officeDocument/2006/relationships" xmlns:p="http://schemas.openxmlformats.org/presentationml/2006/main">
-  <p:cSld name="Slide 26">
-    <p:spTree>
-      <p:nvGrpSpPr>
-        <p:cNvPr id="1" name=""/>
-        <p:cNvGrpSpPr/>
-        <p:nvPr/>
-      </p:nvGrpSpPr>
-      <p:grpSpPr>
-        <a:xfrm>
-          <a:off x="0" y="0"/>
-          <a:ext cx="0" cy="0"/>
-          <a:chOff x="0" y="0"/>
-          <a:chExt cx="0" cy="0"/>
-        </a:xfrm>
-      </p:grpSpPr>
-      <p:sp>
-        <p:nvSpPr>
-          <p:cNvPr id="2" name="Text 0"/>
-          <p:cNvSpPr/>
-          <p:nvPr/>
-        </p:nvSpPr>
-        <p:spPr>
-          <a:xfrm>
-            <a:off x="457200" y="137160"/>
-            <a:ext cx="8229600" cy="502920"/>
-          </a:xfrm>
-          <a:prstGeom prst="rect">
-            <a:avLst/>
-          </a:prstGeom>
-          <a:noFill/>
-          <a:ln/>
-        </p:spPr>
-        <p:txBody>
-          <a:bodyPr wrap="square" lIns="0" tIns="0" rIns="0" bIns="0" rtlCol="0" anchor="ctr"/>
-          <a:lstStyle/>
-          <a:p>
-            <a:pPr algn="ctr" indent="0" marL="0">
-              <a:buNone/>
-            </a:pPr>
-            <a:r>
-              <a:rPr lang="en-US" sz="2400" b="1" dirty="0">
-                <a:solidFill>
-                  <a:srgbClr val="000000"/>
-                </a:solidFill>
-              </a:rPr>
-              <a:t>Strip the task signal - process discipline emerges</a:t>
-            </a:r>
-            <a:endParaRPr lang="en-US" sz="2400" dirty="0"/>
-          </a:p>
-        </p:txBody>
-      </p:sp>
-      <p:graphicFrame>
-        <p:nvGraphicFramePr>
-          <p:cNvPr id="3" name="Chart 0" descr=""/>
-          <p:cNvGraphicFramePr/>
-          <p:nvPr/>
-        </p:nvGraphicFramePr>
-        <p:xfrm>
-          <a:off x="1554480" y="777240"/>
-          <a:ext cx="6035040" cy="3108960"/>
-        </p:xfrm>
-        <a:graphic xmlns:a="http://schemas.openxmlformats.org/drawingml/2006/main">
-          <a:graphicData uri="http://schemas.openxmlformats.org/drawingml/2006/chart">
-            <c:chart xmlns:c="http://schemas.openxmlformats.org/drawingml/2006/chart" r:id="rId1"/>
-          </a:graphicData>
-        </a:graphic>
-      </p:graphicFrame>
-      <p:sp>
-        <p:nvSpPr>
-          <p:cNvPr id="4" name="Text 1"/>
-          <p:cNvSpPr/>
-          <p:nvPr/>
-        </p:nvSpPr>
-        <p:spPr>
-          <a:xfrm>
-            <a:off x="457200" y="4069080"/>
-            <a:ext cx="8229600" cy="868680"/>
-          </a:xfrm>
-          <a:prstGeom prst="rect">
-            <a:avLst/>
-          </a:prstGeom>
-          <a:noFill/>
-          <a:ln/>
-        </p:spPr>
-        <p:txBody>
-          <a:bodyPr wrap="square" lIns="50800" tIns="50800" rIns="50800" bIns="50800" rtlCol="0" anchor="t"/>
-          <a:lstStyle/>
-          <a:p>
-            <a:pPr algn="ctr" indent="0" marL="0">
-              <a:buNone/>
-            </a:pPr>
-            <a:r>
-              <a:rPr lang="en-US" sz="1200" dirty="0">
-                <a:solidFill>
-                  <a:srgbClr val="000000"/>
-                </a:solidFill>
-              </a:rPr>
-              <a:t>Once cleanliness gain is removed, the score reflects </a:t>
-            </a:r>
-            <a:pPr algn="ctr" indent="0" marL="0">
-              <a:buNone/>
-            </a:pPr>
-            <a:r>
-              <a:rPr lang="en-US" sz="1200" i="1" dirty="0">
-                <a:solidFill>
-                  <a:srgbClr val="000000"/>
-                </a:solidFill>
-              </a:rPr>
-              <a:t>how disciplined the process was</a:t>
-            </a:r>
-            <a:pPr algn="ctr" indent="0" marL="0">
-              <a:buNone/>
-            </a:pPr>
-            <a:r>
-              <a:rPr lang="en-US" sz="1200" dirty="0">
-                <a:solidFill>
-                  <a:srgbClr val="000000"/>
-                </a:solidFill>
-              </a:rPr>
-              <a:t> - tests run, IDE refactorings used, commits at sensible points. The feedback group climbs </a:t>
-            </a:r>
-            <a:pPr algn="ctr" indent="0" marL="0">
-              <a:buNone/>
-            </a:pPr>
-            <a:r>
-              <a:rPr lang="en-US" sz="1200" b="1" dirty="0">
-                <a:solidFill>
-                  <a:srgbClr val="0000CD"/>
-                </a:solidFill>
-              </a:rPr>
-              <a:t>+22.3</a:t>
-            </a:r>
-            <a:pPr algn="ctr" indent="0" marL="0">
-              <a:buNone/>
-            </a:pPr>
-            <a:r>
-              <a:rPr lang="en-US" sz="1200" dirty="0">
-                <a:solidFill>
-                  <a:srgbClr val="000000"/>
-                </a:solidFill>
-              </a:rPr>
-              <a:t> across the arc; the baseline group moves </a:t>
-            </a:r>
-            <a:pPr algn="ctr" indent="0" marL="0">
-              <a:buNone/>
-            </a:pPr>
-            <a:r>
-              <a:rPr lang="en-US" sz="1200" b="1" dirty="0">
-                <a:solidFill>
-                  <a:srgbClr val="B25500"/>
-                </a:solidFill>
-              </a:rPr>
-              <a:t>−2.0</a:t>
-            </a:r>
-            <a:pPr algn="ctr" indent="0" marL="0">
-              <a:spcAft>
-                <a:spcPts val="600"/>
-              </a:spcAft>
-              <a:buNone/>
-            </a:pPr>
-            <a:r>
-              <a:rPr lang="en-US" sz="1200" dirty="0">
-                <a:solidFill>
-                  <a:srgbClr val="000000"/>
-                </a:solidFill>
-              </a:rPr>
-              <a:t>.</a:t>
-            </a:r>
-            <a:endParaRPr lang="en-US" sz="1200" dirty="0"/>
-          </a:p>
-          <a:p>
-            <a:pPr algn="ctr" indent="0" marL="0">
-              <a:buNone/>
-            </a:pPr>
-            <a:r>
-              <a:rPr lang="en-US" sz="1200" i="1" dirty="0">
-                <a:solidFill>
-                  <a:srgbClr val="888888"/>
-                </a:solidFill>
-              </a:rPr>
-              <a:t>n = 3 vs n = 2 - directional finding, not a hypothesis test.</a:t>
-            </a:r>
-            <a:endParaRPr lang="en-US" sz="1200" dirty="0"/>
-          </a:p>
-        </p:txBody>
-      </p:sp>
-    </p:spTree>
-  </p:cSld>
-  <p:clrMapOvr>
-    <a:masterClrMapping/>
-  </p:clrMapOvr>
-</p:sld>
-</file>
-
 <file path=ppt/slides/slide27.xml><?xml version="1.0" encoding="utf-8"?>
 <p:sld xmlns:a="http://schemas.openxmlformats.org/drawingml/2006/main" xmlns:r="http://schemas.openxmlformats.org/officeDocument/2006/relationships" xmlns:p="http://schemas.openxmlformats.org/presentationml/2006/main">
   <p:cSld name="Slide 27">
@@ -15596,8 +16026,8 @@
         </p:nvSpPr>
         <p:spPr>
           <a:xfrm>
-            <a:off x="457200" y="2011680"/>
-            <a:ext cx="8229600" cy="1097280"/>
+            <a:off x="457200" y="137160"/>
+            <a:ext cx="8229600" cy="502920"/>
           </a:xfrm>
           <a:prstGeom prst="rect">
             <a:avLst/>
@@ -15613,14 +16043,149 @@
               <a:buNone/>
             </a:pPr>
             <a:r>
-              <a:rPr lang="en-US" sz="3600" b="1" dirty="0">
-                <a:solidFill>
-                  <a:srgbClr val="1A1A1A"/>
-                </a:solidFill>
-              </a:rPr>
-              <a:t>Extension: Agent Traces</a:t>
-            </a:r>
-            <a:endParaRPr lang="en-US" sz="3600" dirty="0"/>
+              <a:rPr lang="en-US" sz="2400" b="1" dirty="0">
+                <a:solidFill>
+                  <a:srgbClr val="000000"/>
+                </a:solidFill>
+              </a:rPr>
+              <a:t>Strip the task signal - process discipline emerges</a:t>
+            </a:r>
+            <a:endParaRPr lang="en-US" sz="2400" dirty="0"/>
+          </a:p>
+        </p:txBody>
+      </p:sp>
+      <p:graphicFrame>
+        <p:nvGraphicFramePr>
+          <p:cNvPr id="3" name="Chart 0" descr=""/>
+          <p:cNvGraphicFramePr/>
+          <p:nvPr/>
+        </p:nvGraphicFramePr>
+        <p:xfrm>
+          <a:off x="1554480" y="777240"/>
+          <a:ext cx="6035040" cy="3108960"/>
+        </p:xfrm>
+        <a:graphic xmlns:a="http://schemas.openxmlformats.org/drawingml/2006/main">
+          <a:graphicData uri="http://schemas.openxmlformats.org/drawingml/2006/chart">
+            <c:chart xmlns:c="http://schemas.openxmlformats.org/drawingml/2006/chart" r:id="rId1"/>
+          </a:graphicData>
+        </a:graphic>
+      </p:graphicFrame>
+      <p:sp>
+        <p:nvSpPr>
+          <p:cNvPr id="4" name="Text 1"/>
+          <p:cNvSpPr/>
+          <p:nvPr/>
+        </p:nvSpPr>
+        <p:spPr>
+          <a:xfrm>
+            <a:off x="457200" y="4069080"/>
+            <a:ext cx="8229600" cy="868680"/>
+          </a:xfrm>
+          <a:prstGeom prst="rect">
+            <a:avLst/>
+          </a:prstGeom>
+          <a:noFill/>
+          <a:ln/>
+        </p:spPr>
+        <p:txBody>
+          <a:bodyPr wrap="square" lIns="50800" tIns="50800" rIns="50800" bIns="50800" rtlCol="0" anchor="t"/>
+          <a:lstStyle/>
+          <a:p>
+            <a:pPr algn="ctr" indent="0" marL="0">
+              <a:buNone/>
+            </a:pPr>
+            <a:r>
+              <a:rPr lang="en-US" sz="1200" dirty="0">
+                <a:solidFill>
+                  <a:srgbClr val="000000"/>
+                </a:solidFill>
+              </a:rPr>
+              <a:t>Once cleanliness gain is removed, the score reflects </a:t>
+            </a:r>
+            <a:pPr algn="ctr" indent="0" marL="0">
+              <a:buNone/>
+            </a:pPr>
+            <a:r>
+              <a:rPr lang="en-US" sz="1200" i="1" dirty="0">
+                <a:solidFill>
+                  <a:srgbClr val="000000"/>
+                </a:solidFill>
+              </a:rPr>
+              <a:t>how disciplined the process was</a:t>
+            </a:r>
+            <a:pPr algn="ctr" indent="0" marL="0">
+              <a:buNone/>
+            </a:pPr>
+            <a:r>
+              <a:rPr lang="en-US" sz="1200" dirty="0">
+                <a:solidFill>
+                  <a:srgbClr val="000000"/>
+                </a:solidFill>
+              </a:rPr>
+              <a:t> - tests run, IDE refactorings used, commits at sensible points. The feedback group climbs </a:t>
+            </a:r>
+            <a:pPr algn="ctr" indent="0" marL="0">
+              <a:buNone/>
+            </a:pPr>
+            <a:r>
+              <a:rPr lang="en-US" sz="1200" b="1" dirty="0">
+                <a:solidFill>
+                  <a:srgbClr val="0000CD"/>
+                </a:solidFill>
+              </a:rPr>
+              <a:t>+22.3</a:t>
+            </a:r>
+            <a:pPr algn="ctr" indent="0" marL="0">
+              <a:buNone/>
+            </a:pPr>
+            <a:r>
+              <a:rPr lang="en-US" sz="1200" dirty="0">
+                <a:solidFill>
+                  <a:srgbClr val="000000"/>
+                </a:solidFill>
+              </a:rPr>
+              <a:t> across the arc; the baseline group moves </a:t>
+            </a:r>
+            <a:pPr algn="ctr" indent="0" marL="0">
+              <a:buNone/>
+            </a:pPr>
+            <a:r>
+              <a:rPr lang="en-US" sz="1200" b="1" dirty="0">
+                <a:solidFill>
+                  <a:srgbClr val="B25500"/>
+                </a:solidFill>
+              </a:rPr>
+              <a:t>−2.0</a:t>
+            </a:r>
+            <a:pPr algn="ctr" indent="0" marL="0">
+              <a:spcAft>
+                <a:spcPts val="600"/>
+              </a:spcAft>
+              <a:buNone/>
+            </a:pPr>
+            <a:r>
+              <a:rPr lang="en-US" sz="1200" dirty="0">
+                <a:solidFill>
+                  <a:srgbClr val="000000"/>
+                </a:solidFill>
+              </a:rPr>
+              <a:t>.</a:t>
+            </a:r>
+            <a:endParaRPr lang="en-US" sz="1200" dirty="0"/>
+          </a:p>
+          <a:p>
+            <a:pPr algn="ctr" indent="0" marL="0">
+              <a:buNone/>
+            </a:pPr>
+            <a:r>
+              <a:rPr lang="en-US" sz="1200" i="1" dirty="0">
+                <a:solidFill>
+                  <a:srgbClr val="888888"/>
+                </a:solidFill>
+              </a:rPr>
+              <a:t>n = 3 vs n = 2 - directional finding, not a hypothesis test.</a:t>
+            </a:r>
+            <a:endParaRPr lang="en-US" sz="1200" dirty="0"/>
           </a:p>
         </p:txBody>
       </p:sp>
@@ -15657,6 +16222,67 @@
         </p:nvSpPr>
         <p:spPr>
           <a:xfrm>
+            <a:off x="457200" y="2011680"/>
+            <a:ext cx="8229600" cy="1097280"/>
+          </a:xfrm>
+          <a:prstGeom prst="rect">
+            <a:avLst/>
+          </a:prstGeom>
+          <a:noFill/>
+          <a:ln/>
+        </p:spPr>
+        <p:txBody>
+          <a:bodyPr wrap="square" lIns="0" tIns="0" rIns="0" bIns="0" rtlCol="0" anchor="ctr"/>
+          <a:lstStyle/>
+          <a:p>
+            <a:pPr algn="ctr" indent="0" marL="0">
+              <a:buNone/>
+            </a:pPr>
+            <a:r>
+              <a:rPr lang="en-US" sz="3600" b="1" dirty="0">
+                <a:solidFill>
+                  <a:srgbClr val="1A1A1A"/>
+                </a:solidFill>
+              </a:rPr>
+              <a:t>Extension: Agent Traces</a:t>
+            </a:r>
+            <a:endParaRPr lang="en-US" sz="3600" dirty="0"/>
+          </a:p>
+        </p:txBody>
+      </p:sp>
+    </p:spTree>
+  </p:cSld>
+  <p:clrMapOvr>
+    <a:masterClrMapping/>
+  </p:clrMapOvr>
+</p:sld>
+</file>
+
+<file path=ppt/slides/slide29.xml><?xml version="1.0" encoding="utf-8"?>
+<p:sld xmlns:a="http://schemas.openxmlformats.org/drawingml/2006/main" xmlns:r="http://schemas.openxmlformats.org/officeDocument/2006/relationships" xmlns:p="http://schemas.openxmlformats.org/presentationml/2006/main">
+  <p:cSld name="Slide 29">
+    <p:spTree>
+      <p:nvGrpSpPr>
+        <p:cNvPr id="1" name=""/>
+        <p:cNvGrpSpPr/>
+        <p:nvPr/>
+      </p:nvGrpSpPr>
+      <p:grpSpPr>
+        <a:xfrm>
+          <a:off x="0" y="0"/>
+          <a:ext cx="0" cy="0"/>
+          <a:chOff x="0" y="0"/>
+          <a:chExt cx="0" cy="0"/>
+        </a:xfrm>
+      </p:grpSpPr>
+      <p:sp>
+        <p:nvSpPr>
+          <p:cNvPr id="2" name="Text 0"/>
+          <p:cNvSpPr/>
+          <p:nvPr/>
+        </p:nvSpPr>
+        <p:spPr>
+          <a:xfrm>
             <a:off x="457200" y="137160"/>
             <a:ext cx="8229600" cy="457200"/>
           </a:xfrm>
@@ -15739,7 +16365,7 @@
       </p:graphicFrame>
       <p:graphicFrame>
         <p:nvGraphicFramePr>
-          <p:cNvPr id="29" name="Table 0"/>
+          <p:cNvPr id="30" name="Table 0"/>
           <p:cNvGraphicFramePr>
             <a:graphicFrameLocks noGrp="1"/>
           </p:cNvGraphicFramePr>
@@ -16518,272 +17144,6 @@
 </p:sld>
 </file>
 
-<file path=ppt/slides/slide29.xml><?xml version="1.0" encoding="utf-8"?>
-<p:sld xmlns:a="http://schemas.openxmlformats.org/drawingml/2006/main" xmlns:r="http://schemas.openxmlformats.org/officeDocument/2006/relationships" xmlns:p="http://schemas.openxmlformats.org/presentationml/2006/main">
-  <p:cSld name="Slide 29">
-    <p:spTree>
-      <p:nvGrpSpPr>
-        <p:cNvPr id="1" name=""/>
-        <p:cNvGrpSpPr/>
-        <p:nvPr/>
-      </p:nvGrpSpPr>
-      <p:grpSpPr>
-        <a:xfrm>
-          <a:off x="0" y="0"/>
-          <a:ext cx="0" cy="0"/>
-          <a:chOff x="0" y="0"/>
-          <a:chExt cx="0" cy="0"/>
-        </a:xfrm>
-      </p:grpSpPr>
-      <p:sp>
-        <p:nvSpPr>
-          <p:cNvPr id="2" name="Text 0"/>
-          <p:cNvSpPr/>
-          <p:nvPr/>
-        </p:nvSpPr>
-        <p:spPr>
-          <a:xfrm>
-            <a:off x="457200" y="274320"/>
-            <a:ext cx="8229600" cy="640080"/>
-          </a:xfrm>
-          <a:prstGeom prst="rect">
-            <a:avLst/>
-          </a:prstGeom>
-          <a:noFill/>
-          <a:ln/>
-        </p:spPr>
-        <p:txBody>
-          <a:bodyPr wrap="square" lIns="0" tIns="0" rIns="0" bIns="0" rtlCol="0" anchor="ctr"/>
-          <a:lstStyle/>
-          <a:p>
-            <a:pPr indent="0" marL="0">
-              <a:buNone/>
-            </a:pPr>
-            <a:r>
-              <a:rPr lang="en-US" sz="2800" b="1" dirty="0">
-                <a:solidFill>
-                  <a:srgbClr val="000000"/>
-                </a:solidFill>
-              </a:rPr>
-              <a:t>Conclusion</a:t>
-            </a:r>
-            <a:endParaRPr lang="en-US" sz="2800" dirty="0"/>
-          </a:p>
-        </p:txBody>
-      </p:sp>
-      <p:sp>
-        <p:nvSpPr>
-          <p:cNvPr id="3" name="Text 1"/>
-          <p:cNvSpPr/>
-          <p:nvPr/>
-        </p:nvSpPr>
-        <p:spPr>
-          <a:xfrm>
-            <a:off x="457200" y="1005840"/>
-            <a:ext cx="8229600" cy="777240"/>
-          </a:xfrm>
-          <a:prstGeom prst="rect">
-            <a:avLst/>
-          </a:prstGeom>
-          <a:noFill/>
-          <a:ln/>
-        </p:spPr>
-        <p:txBody>
-          <a:bodyPr wrap="square" rtlCol="0" anchor="ctr"/>
-          <a:lstStyle/>
-          <a:p>
-            <a:pPr algn="ctr" indent="0" marL="0">
-              <a:buNone/>
-            </a:pPr>
-            <a:r>
-              <a:rPr lang="en-US" sz="1500" i="1" dirty="0">
-                <a:solidFill>
-                  <a:srgbClr val="0000CD"/>
-                </a:solidFill>
-              </a:rPr>
-              <a:t>Process-aware refactoring evaluation is tractable, and a small randomised study gives directional evidence that feedback improves measured process discipline.</a:t>
-            </a:r>
-            <a:endParaRPr lang="en-US" sz="1500" dirty="0"/>
-          </a:p>
-        </p:txBody>
-      </p:sp>
-      <p:sp>
-        <p:nvSpPr>
-          <p:cNvPr id="4" name="Text 2"/>
-          <p:cNvSpPr/>
-          <p:nvPr/>
-        </p:nvSpPr>
-        <p:spPr>
-          <a:xfrm>
-            <a:off x="457200" y="1920240"/>
-            <a:ext cx="8229600" cy="2651760"/>
-          </a:xfrm>
-          <a:prstGeom prst="rect">
-            <a:avLst/>
-          </a:prstGeom>
-          <a:noFill/>
-          <a:ln/>
-        </p:spPr>
-        <p:txBody>
-          <a:bodyPr wrap="square" rtlCol="0" anchor="t"/>
-          <a:lstStyle/>
-          <a:p>
-            <a:pPr marL="342900" indent="-342900">
-              <a:spcAft>
-                <a:spcPts val="600"/>
-              </a:spcAft>
-              <a:buSzPct val="100000"/>
-              <a:buChar char="•"/>
-            </a:pPr>
-            <a:r>
-              <a:rPr lang="en-US" sz="1600" dirty="0">
-                <a:solidFill>
-                  <a:srgbClr val="000000"/>
-                </a:solidFill>
-              </a:rPr>
-              <a:t>A process-quality metric on </a:t>
-            </a:r>
-            <a:pPr indent="0" marL="0">
-              <a:spcAft>
-                <a:spcPts val="600"/>
-              </a:spcAft>
-              <a:buNone/>
-            </a:pPr>
-            <a:r>
-              <a:rPr lang="en-US" sz="1600" i="1" dirty="0">
-                <a:solidFill>
-                  <a:srgbClr val="000000"/>
-                </a:solidFill>
-              </a:rPr>
-              <a:t>arbitrary sessions</a:t>
-            </a:r>
-            <a:pPr indent="0" marL="0">
-              <a:spcAft>
-                <a:spcPts val="600"/>
-              </a:spcAft>
-              <a:buNone/>
-            </a:pPr>
-            <a:r>
-              <a:rPr lang="en-US" sz="1600" dirty="0">
-                <a:solidFill>
-                  <a:srgbClr val="000000"/>
-                </a:solidFill>
-              </a:rPr>
-              <a:t> combining endpoint, process, and safety signals in one principled score.</a:t>
-            </a:r>
-            <a:endParaRPr lang="en-US" sz="1600" dirty="0"/>
-          </a:p>
-          <a:p>
-            <a:pPr marL="342900" indent="-342900">
-              <a:spcAft>
-                <a:spcPts val="600"/>
-              </a:spcAft>
-              <a:buSzPct val="100000"/>
-              <a:buChar char="•"/>
-            </a:pPr>
-            <a:r>
-              <a:rPr lang="en-US" sz="1600" dirty="0">
-                <a:solidFill>
-                  <a:srgbClr val="000000"/>
-                </a:solidFill>
-              </a:rPr>
-              <a:t>A divergence-point detector with four actionable kinds, each with a per-kind synthesiser that constructs a concrete alternative trajectory.</a:t>
-            </a:r>
-            <a:endParaRPr lang="en-US" sz="1600" dirty="0"/>
-          </a:p>
-          <a:p>
-            <a:pPr marL="342900" indent="-342900">
-              <a:spcAft>
-                <a:spcPts val="600"/>
-              </a:spcAft>
-              <a:buSzPct val="100000"/>
-              <a:buChar char="•"/>
-            </a:pPr>
-            <a:r>
-              <a:rPr lang="en-US" sz="1600" dirty="0">
-                <a:solidFill>
-                  <a:srgbClr val="000000"/>
-                </a:solidFill>
-              </a:rPr>
-              <a:t>Three datasets -45 injection sessions, 30-session user study, 48-session agent extension - with reproducible analysis (Jupyter notebook reproduces every table and figure).</a:t>
-            </a:r>
-            <a:endParaRPr lang="en-US" sz="1600" dirty="0"/>
-          </a:p>
-          <a:p>
-            <a:pPr marL="342900" indent="-342900">
-              <a:spcAft>
-                <a:spcPts val="600"/>
-              </a:spcAft>
-              <a:buSzPct val="100000"/>
-              <a:buChar char="•"/>
-            </a:pPr>
-            <a:r>
-              <a:rPr lang="en-US" sz="1600" dirty="0">
-                <a:solidFill>
-                  <a:srgbClr val="000000"/>
-                </a:solidFill>
-              </a:rPr>
-              <a:t>A working end-to-end research prototype: IntelliJ plugin, analysis backend, and dashboard.</a:t>
-            </a:r>
-            <a:endParaRPr lang="en-US" sz="1600" dirty="0"/>
-          </a:p>
-        </p:txBody>
-      </p:sp>
-      <p:sp>
-        <p:nvSpPr>
-          <p:cNvPr id="5" name="Text 3"/>
-          <p:cNvSpPr/>
-          <p:nvPr/>
-        </p:nvSpPr>
-        <p:spPr>
-          <a:xfrm>
-            <a:off x="457200" y="4617720"/>
-            <a:ext cx="8229600" cy="457200"/>
-          </a:xfrm>
-          <a:prstGeom prst="rect">
-            <a:avLst/>
-          </a:prstGeom>
-          <a:noFill/>
-          <a:ln/>
-        </p:spPr>
-        <p:txBody>
-          <a:bodyPr wrap="square" lIns="0" tIns="0" rIns="0" bIns="0" rtlCol="0" anchor="ctr"/>
-          <a:lstStyle/>
-          <a:p>
-            <a:pPr algn="ctr" indent="0" marL="0">
-              <a:buNone/>
-            </a:pPr>
-            <a:r>
-              <a:rPr lang="en-US" sz="1100" b="1" i="1" dirty="0">
-                <a:solidFill>
-                  <a:srgbClr val="888888"/>
-                </a:solidFill>
-              </a:rPr>
-              <a:t>Not yet established: </a:t>
-            </a:r>
-            <a:pPr algn="ctr" indent="0" marL="0">
-              <a:buNone/>
-            </a:pPr>
-            <a:r>
-              <a:rPr lang="en-US" sz="1100" i="1" dirty="0">
-                <a:solidFill>
-                  <a:srgbClr val="888888"/>
-                </a:solidFill>
-              </a:rPr>
-              <a:t>externally calibrated measure of refactoring quality, statistically conclusive behavioural effect, or generalisation beyond Java / IntelliJ / human traces.</a:t>
-            </a:r>
-            <a:endParaRPr lang="en-US" sz="1100" dirty="0"/>
-          </a:p>
-        </p:txBody>
-      </p:sp>
-    </p:spTree>
-  </p:cSld>
-  <p:clrMapOvr>
-    <a:masterClrMapping/>
-  </p:clrMapOvr>
-</p:sld>
-</file>
-
 <file path=ppt/slides/slide3.xml><?xml version="1.0" encoding="utf-8"?>
 <p:sld xmlns:a="http://schemas.openxmlformats.org/drawingml/2006/main" xmlns:r="http://schemas.openxmlformats.org/officeDocument/2006/relationships" xmlns:p="http://schemas.openxmlformats.org/presentationml/2006/main">
   <p:cSld name="Slide 3">
@@ -17108,6 +17468,272 @@
               <a:t>- match explicit events inside predefined exercises; don't generalise to arbitrary sessions.</a:t>
             </a:r>
             <a:endParaRPr lang="en-US" sz="1300" dirty="0"/>
+          </a:p>
+        </p:txBody>
+      </p:sp>
+    </p:spTree>
+  </p:cSld>
+  <p:clrMapOvr>
+    <a:masterClrMapping/>
+  </p:clrMapOvr>
+</p:sld>
+</file>
+
+<file path=ppt/slides/slide30.xml><?xml version="1.0" encoding="utf-8"?>
+<p:sld xmlns:a="http://schemas.openxmlformats.org/drawingml/2006/main" xmlns:r="http://schemas.openxmlformats.org/officeDocument/2006/relationships" xmlns:p="http://schemas.openxmlformats.org/presentationml/2006/main">
+  <p:cSld name="Slide 30">
+    <p:spTree>
+      <p:nvGrpSpPr>
+        <p:cNvPr id="1" name=""/>
+        <p:cNvGrpSpPr/>
+        <p:nvPr/>
+      </p:nvGrpSpPr>
+      <p:grpSpPr>
+        <a:xfrm>
+          <a:off x="0" y="0"/>
+          <a:ext cx="0" cy="0"/>
+          <a:chOff x="0" y="0"/>
+          <a:chExt cx="0" cy="0"/>
+        </a:xfrm>
+      </p:grpSpPr>
+      <p:sp>
+        <p:nvSpPr>
+          <p:cNvPr id="2" name="Text 0"/>
+          <p:cNvSpPr/>
+          <p:nvPr/>
+        </p:nvSpPr>
+        <p:spPr>
+          <a:xfrm>
+            <a:off x="457200" y="274320"/>
+            <a:ext cx="8229600" cy="640080"/>
+          </a:xfrm>
+          <a:prstGeom prst="rect">
+            <a:avLst/>
+          </a:prstGeom>
+          <a:noFill/>
+          <a:ln/>
+        </p:spPr>
+        <p:txBody>
+          <a:bodyPr wrap="square" lIns="0" tIns="0" rIns="0" bIns="0" rtlCol="0" anchor="ctr"/>
+          <a:lstStyle/>
+          <a:p>
+            <a:pPr indent="0" marL="0">
+              <a:buNone/>
+            </a:pPr>
+            <a:r>
+              <a:rPr lang="en-US" sz="2800" b="1" dirty="0">
+                <a:solidFill>
+                  <a:srgbClr val="000000"/>
+                </a:solidFill>
+              </a:rPr>
+              <a:t>Conclusion</a:t>
+            </a:r>
+            <a:endParaRPr lang="en-US" sz="2800" dirty="0"/>
+          </a:p>
+        </p:txBody>
+      </p:sp>
+      <p:sp>
+        <p:nvSpPr>
+          <p:cNvPr id="3" name="Text 1"/>
+          <p:cNvSpPr/>
+          <p:nvPr/>
+        </p:nvSpPr>
+        <p:spPr>
+          <a:xfrm>
+            <a:off x="457200" y="1005840"/>
+            <a:ext cx="8229600" cy="777240"/>
+          </a:xfrm>
+          <a:prstGeom prst="rect">
+            <a:avLst/>
+          </a:prstGeom>
+          <a:noFill/>
+          <a:ln/>
+        </p:spPr>
+        <p:txBody>
+          <a:bodyPr wrap="square" rtlCol="0" anchor="ctr"/>
+          <a:lstStyle/>
+          <a:p>
+            <a:pPr algn="ctr" indent="0" marL="0">
+              <a:buNone/>
+            </a:pPr>
+            <a:r>
+              <a:rPr lang="en-US" sz="1500" i="1" dirty="0">
+                <a:solidFill>
+                  <a:srgbClr val="0000CD"/>
+                </a:solidFill>
+              </a:rPr>
+              <a:t>Process-aware refactoring evaluation is tractable, and a small randomised study gives directional evidence that feedback improves measured process discipline.</a:t>
+            </a:r>
+            <a:endParaRPr lang="en-US" sz="1500" dirty="0"/>
+          </a:p>
+        </p:txBody>
+      </p:sp>
+      <p:sp>
+        <p:nvSpPr>
+          <p:cNvPr id="4" name="Text 2"/>
+          <p:cNvSpPr/>
+          <p:nvPr/>
+        </p:nvSpPr>
+        <p:spPr>
+          <a:xfrm>
+            <a:off x="457200" y="1920240"/>
+            <a:ext cx="8229600" cy="2651760"/>
+          </a:xfrm>
+          <a:prstGeom prst="rect">
+            <a:avLst/>
+          </a:prstGeom>
+          <a:noFill/>
+          <a:ln/>
+        </p:spPr>
+        <p:txBody>
+          <a:bodyPr wrap="square" rtlCol="0" anchor="t"/>
+          <a:lstStyle/>
+          <a:p>
+            <a:pPr marL="342900" indent="-342900">
+              <a:spcAft>
+                <a:spcPts val="600"/>
+              </a:spcAft>
+              <a:buSzPct val="100000"/>
+              <a:buChar char="•"/>
+            </a:pPr>
+            <a:r>
+              <a:rPr lang="en-US" sz="1600" dirty="0">
+                <a:solidFill>
+                  <a:srgbClr val="000000"/>
+                </a:solidFill>
+              </a:rPr>
+              <a:t>A process-quality metric on </a:t>
+            </a:r>
+            <a:pPr indent="0" marL="0">
+              <a:spcAft>
+                <a:spcPts val="600"/>
+              </a:spcAft>
+              <a:buNone/>
+            </a:pPr>
+            <a:r>
+              <a:rPr lang="en-US" sz="1600" i="1" dirty="0">
+                <a:solidFill>
+                  <a:srgbClr val="000000"/>
+                </a:solidFill>
+              </a:rPr>
+              <a:t>arbitrary sessions</a:t>
+            </a:r>
+            <a:pPr indent="0" marL="0">
+              <a:spcAft>
+                <a:spcPts val="600"/>
+              </a:spcAft>
+              <a:buNone/>
+            </a:pPr>
+            <a:r>
+              <a:rPr lang="en-US" sz="1600" dirty="0">
+                <a:solidFill>
+                  <a:srgbClr val="000000"/>
+                </a:solidFill>
+              </a:rPr>
+              <a:t> combining endpoint, process, and safety signals in one principled score.</a:t>
+            </a:r>
+            <a:endParaRPr lang="en-US" sz="1600" dirty="0"/>
+          </a:p>
+          <a:p>
+            <a:pPr marL="342900" indent="-342900">
+              <a:spcAft>
+                <a:spcPts val="600"/>
+              </a:spcAft>
+              <a:buSzPct val="100000"/>
+              <a:buChar char="•"/>
+            </a:pPr>
+            <a:r>
+              <a:rPr lang="en-US" sz="1600" dirty="0">
+                <a:solidFill>
+                  <a:srgbClr val="000000"/>
+                </a:solidFill>
+              </a:rPr>
+              <a:t>A divergence-point detector with four actionable kinds, each with a per-kind synthesiser that constructs a concrete alternative trajectory.</a:t>
+            </a:r>
+            <a:endParaRPr lang="en-US" sz="1600" dirty="0"/>
+          </a:p>
+          <a:p>
+            <a:pPr marL="342900" indent="-342900">
+              <a:spcAft>
+                <a:spcPts val="600"/>
+              </a:spcAft>
+              <a:buSzPct val="100000"/>
+              <a:buChar char="•"/>
+            </a:pPr>
+            <a:r>
+              <a:rPr lang="en-US" sz="1600" dirty="0">
+                <a:solidFill>
+                  <a:srgbClr val="000000"/>
+                </a:solidFill>
+              </a:rPr>
+              <a:t>Three datasets -45 injection sessions, 30-session user study, 48-session agent extension - with reproducible analysis (Jupyter notebook reproduces every table and figure).</a:t>
+            </a:r>
+            <a:endParaRPr lang="en-US" sz="1600" dirty="0"/>
+          </a:p>
+          <a:p>
+            <a:pPr marL="342900" indent="-342900">
+              <a:spcAft>
+                <a:spcPts val="600"/>
+              </a:spcAft>
+              <a:buSzPct val="100000"/>
+              <a:buChar char="•"/>
+            </a:pPr>
+            <a:r>
+              <a:rPr lang="en-US" sz="1600" dirty="0">
+                <a:solidFill>
+                  <a:srgbClr val="000000"/>
+                </a:solidFill>
+              </a:rPr>
+              <a:t>A working end-to-end research prototype: IntelliJ plugin, analysis backend, and dashboard.</a:t>
+            </a:r>
+            <a:endParaRPr lang="en-US" sz="1600" dirty="0"/>
+          </a:p>
+        </p:txBody>
+      </p:sp>
+      <p:sp>
+        <p:nvSpPr>
+          <p:cNvPr id="5" name="Text 3"/>
+          <p:cNvSpPr/>
+          <p:nvPr/>
+        </p:nvSpPr>
+        <p:spPr>
+          <a:xfrm>
+            <a:off x="457200" y="4617720"/>
+            <a:ext cx="8229600" cy="457200"/>
+          </a:xfrm>
+          <a:prstGeom prst="rect">
+            <a:avLst/>
+          </a:prstGeom>
+          <a:noFill/>
+          <a:ln/>
+        </p:spPr>
+        <p:txBody>
+          <a:bodyPr wrap="square" lIns="0" tIns="0" rIns="0" bIns="0" rtlCol="0" anchor="ctr"/>
+          <a:lstStyle/>
+          <a:p>
+            <a:pPr algn="ctr" indent="0" marL="0">
+              <a:buNone/>
+            </a:pPr>
+            <a:r>
+              <a:rPr lang="en-US" sz="1100" b="1" i="1" dirty="0">
+                <a:solidFill>
+                  <a:srgbClr val="888888"/>
+                </a:solidFill>
+              </a:rPr>
+              <a:t>Not yet established: </a:t>
+            </a:r>
+            <a:pPr algn="ctr" indent="0" marL="0">
+              <a:buNone/>
+            </a:pPr>
+            <a:r>
+              <a:rPr lang="en-US" sz="1100" i="1" dirty="0">
+                <a:solidFill>
+                  <a:srgbClr val="888888"/>
+                </a:solidFill>
+              </a:rPr>
+              <a:t>externally calibrated measure of refactoring quality, statistically conclusive behavioural effect, or generalisation beyond Java / IntelliJ / human traces.</a:t>
+            </a:r>
+            <a:endParaRPr lang="en-US" sz="1100" dirty="0"/>
           </a:p>
         </p:txBody>
       </p:sp>

</xml_diff>

<commit_message>
feat: add more summary pages for developer behaviour experiment
</commit_message>
<xml_diff>
--- a/presentation/slides.pptx
+++ b/presentation/slides.pptx
@@ -34,10 +34,9 @@
     <p:sldId id="282" r:id="rId28"/>
     <p:sldId id="283" r:id="rId29"/>
     <p:sldId id="284" r:id="rId30"/>
-    <p:sldId id="285" r:id="rId31"/>
   </p:sldIdLst>
   <p:notesMasterIdLst>
-    <p:notesMasterId r:id="rId32"/>
+    <p:notesMasterId r:id="rId31"/>
   </p:notesMasterIdLst>
   <p:sldSz cx="9144000" cy="5143500"/>
   <p:notesSz cx="5143500" cy="9144000"/>
@@ -162,459 +161,7 @@
                 </a:solidFill>
                 <a:latin typeface="Arial"/>
               </a:rPr>
-              <a:t>Divergence points per session (per participant)</a:t>
-            </a:r>
-          </a:p>
-        </c:rich>
-      </c:tx>
-      <c:layout/>
-      <c:overlay val="0"/>
-    </c:title>
-    <c:autoTitleDeleted val="0"/>
-    <c:plotArea>
-      <c:layout/>
-      <c:lineChart>
-        <c:varyColors val="0"/>
-        <c:ser>
-          <c:idx val="0"/>
-          <c:order val="0"/>
-          <c:tx>
-            <c:strRef>
-              <c:f>Sheet1!$B$1</c:f>
-              <c:strCache>
-                <c:ptCount val="1"/>
-                <c:pt idx="0">
-                  <c:v>Feedback (per participant)</c:v>
-                </c:pt>
-              </c:strCache>
-            </c:strRef>
-          </c:tx>
-          <c:spPr>
-            <a:solidFill>
-              <a:srgbClr val="0000CD"/>
-            </a:solidFill>
-            <a:ln w="31750" cap="flat">
-              <a:solidFill>
-                <a:srgbClr val="0000CD"/>
-              </a:solidFill>
-              <a:prstDash val="solid"/>
-              <a:round/>
-            </a:ln>
-            <a:effectLst/>
-          </c:spPr>
-          <c:invertIfNegative val="0"/>
-          <c:dLbls>
-            <c:numFmt formatCode="#,##0" sourceLinked="0"/>
-            <c:txPr>
-              <a:bodyPr/>
-              <a:lstStyle/>
-              <a:p>
-                <a:pPr>
-                  <a:defRPr b="0" i="0" strike="noStrike" sz="1200" u="none">
-                    <a:solidFill>
-                      <a:srgbClr val="000000"/>
-                    </a:solidFill>
-                    <a:latin typeface="Arial"/>
-                  </a:defRPr>
-                </a:pPr>
-              </a:p>
-            </c:txPr>
-            <c:showLegendKey val="0"/>
-            <c:showVal val="0"/>
-            <c:showCatName val="0"/>
-            <c:showSerName val="0"/>
-            <c:showPercent val="0"/>
-            <c:showBubbleSize val="0"/>
-            <c:showLeaderLines val="0"/>
-          </c:dLbls>
-          <c:marker>
-            <c:symbol val="circle"/>
-            <c:size val="6"/>
-            <c:spPr>
-              <a:solidFill>
-                <a:srgbClr val="0000CD"/>
-              </a:solidFill>
-              <a:ln w="9525" cap="flat">
-                <a:solidFill>
-                  <a:srgbClr val="0000CD"/>
-                </a:solidFill>
-                <a:prstDash val="solid"/>
-                <a:round/>
-              </a:ln>
-              <a:effectLst/>
-            </c:spPr>
-          </c:marker>
-          <c:cat>
-            <c:multiLvlStrRef>
-              <c:f>Sheet1!$A$2:$A$7</c:f>
-              <c:multiLvlStrCache>
-                <c:ptCount val="6"/>
-                <c:lvl>
-                  <c:pt idx="0">
-                    <c:v>S1</c:v>
-                  </c:pt>
-                  <c:pt idx="1">
-                    <c:v>S2</c:v>
-                  </c:pt>
-                  <c:pt idx="2">
-                    <c:v>S3</c:v>
-                  </c:pt>
-                  <c:pt idx="3">
-                    <c:v>S4</c:v>
-                  </c:pt>
-                  <c:pt idx="4">
-                    <c:v>S5</c:v>
-                  </c:pt>
-                  <c:pt idx="5">
-                    <c:v>S6</c:v>
-                  </c:pt>
-                </c:lvl>
-              </c:multiLvlStrCache>
-            </c:multiLvlStrRef>
-          </c:cat>
-          <c:val>
-            <c:numRef>
-              <c:f>Sheet1!$B$2:$B$7</c:f>
-              <c:numCache>
-                <c:formatCode>General</c:formatCode>
-                <c:ptCount val="6"/>
-                <c:pt idx="0">
-                  <c:v>4</c:v>
-                </c:pt>
-                <c:pt idx="1">
-                  <c:v>5.67</c:v>
-                </c:pt>
-                <c:pt idx="2">
-                  <c:v>3.67</c:v>
-                </c:pt>
-                <c:pt idx="3">
-                  <c:v>0</c:v>
-                </c:pt>
-                <c:pt idx="4">
-                  <c:v>2.33</c:v>
-                </c:pt>
-                <c:pt idx="5">
-                  <c:v>0.67</c:v>
-                </c:pt>
-              </c:numCache>
-            </c:numRef>
-          </c:val>
-          <c:smooth val="0"/>
-        </c:ser>
-        <c:ser>
-          <c:idx val="1"/>
-          <c:order val="1"/>
-          <c:tx>
-            <c:strRef>
-              <c:f>Sheet1!$C$1</c:f>
-              <c:strCache>
-                <c:ptCount val="1"/>
-                <c:pt idx="0">
-                  <c:v>Baseline (per participant)</c:v>
-                </c:pt>
-              </c:strCache>
-            </c:strRef>
-          </c:tx>
-          <c:spPr>
-            <a:solidFill>
-              <a:srgbClr val="B25500"/>
-            </a:solidFill>
-            <a:ln w="31750" cap="flat">
-              <a:solidFill>
-                <a:srgbClr val="B25500"/>
-              </a:solidFill>
-              <a:prstDash val="solid"/>
-              <a:round/>
-            </a:ln>
-            <a:effectLst/>
-          </c:spPr>
-          <c:invertIfNegative val="0"/>
-          <c:dLbls>
-            <c:numFmt formatCode="#,##0" sourceLinked="0"/>
-            <c:txPr>
-              <a:bodyPr/>
-              <a:lstStyle/>
-              <a:p>
-                <a:pPr>
-                  <a:defRPr b="0" i="0" strike="noStrike" sz="1200" u="none">
-                    <a:solidFill>
-                      <a:srgbClr val="000000"/>
-                    </a:solidFill>
-                    <a:latin typeface="Arial"/>
-                  </a:defRPr>
-                </a:pPr>
-              </a:p>
-            </c:txPr>
-            <c:showLegendKey val="0"/>
-            <c:showVal val="0"/>
-            <c:showCatName val="0"/>
-            <c:showSerName val="0"/>
-            <c:showPercent val="0"/>
-            <c:showBubbleSize val="0"/>
-            <c:showLeaderLines val="0"/>
-          </c:dLbls>
-          <c:marker>
-            <c:symbol val="circle"/>
-            <c:size val="6"/>
-            <c:spPr>
-              <a:solidFill>
-                <a:srgbClr val="B25500"/>
-              </a:solidFill>
-              <a:ln w="9525" cap="flat">
-                <a:solidFill>
-                  <a:srgbClr val="B25500"/>
-                </a:solidFill>
-                <a:prstDash val="solid"/>
-                <a:round/>
-              </a:ln>
-              <a:effectLst/>
-            </c:spPr>
-          </c:marker>
-          <c:cat>
-            <c:multiLvlStrRef>
-              <c:f>Sheet1!$A$2:$A$7</c:f>
-              <c:multiLvlStrCache>
-                <c:ptCount val="6"/>
-                <c:lvl>
-                  <c:pt idx="0">
-                    <c:v>S1</c:v>
-                  </c:pt>
-                  <c:pt idx="1">
-                    <c:v>S2</c:v>
-                  </c:pt>
-                  <c:pt idx="2">
-                    <c:v>S3</c:v>
-                  </c:pt>
-                  <c:pt idx="3">
-                    <c:v>S4</c:v>
-                  </c:pt>
-                  <c:pt idx="4">
-                    <c:v>S5</c:v>
-                  </c:pt>
-                  <c:pt idx="5">
-                    <c:v>S6</c:v>
-                  </c:pt>
-                </c:lvl>
-              </c:multiLvlStrCache>
-            </c:multiLvlStrRef>
-          </c:cat>
-          <c:val>
-            <c:numRef>
-              <c:f>Sheet1!$C$2:$C$7</c:f>
-              <c:numCache>
-                <c:formatCode>General</c:formatCode>
-                <c:ptCount val="6"/>
-                <c:pt idx="0">
-                  <c:v>5</c:v>
-                </c:pt>
-                <c:pt idx="1">
-                  <c:v>7.5</c:v>
-                </c:pt>
-                <c:pt idx="2">
-                  <c:v>9.5</c:v>
-                </c:pt>
-                <c:pt idx="3">
-                  <c:v>0</c:v>
-                </c:pt>
-                <c:pt idx="4">
-                  <c:v>6.5</c:v>
-                </c:pt>
-                <c:pt idx="5">
-                  <c:v>7.5</c:v>
-                </c:pt>
-              </c:numCache>
-            </c:numRef>
-          </c:val>
-          <c:smooth val="0"/>
-        </c:ser>
-        <c:dLbls>
-          <c:numFmt formatCode="#,##0" sourceLinked="0"/>
-          <c:txPr>
-            <a:bodyPr/>
-            <a:lstStyle/>
-            <a:p>
-              <a:pPr>
-                <a:defRPr b="0" i="0" strike="noStrike" sz="1200" u="none">
-                  <a:solidFill>
-                    <a:srgbClr val="000000"/>
-                  </a:solidFill>
-                  <a:latin typeface="Arial"/>
-                </a:defRPr>
-              </a:pPr>
-            </a:p>
-          </c:txPr>
-          <c:showLegendKey val="0"/>
-          <c:showVal val="0"/>
-          <c:showCatName val="0"/>
-          <c:showSerName val="0"/>
-          <c:showPercent val="0"/>
-          <c:showBubbleSize val="0"/>
-          <c:showLeaderLines val="0"/>
-        </c:dLbls>
-        <c:marker val="1"/>
-        <c:axId val="2094734554"/>
-        <c:axId val="2094734552"/>
-        <c:axId val="2094734556"/>
-      </c:lineChart>
-      <c:catAx>
-        <c:axId val="2094734554"/>
-        <c:scaling>
-          <c:orientation val="minMax"/>
-        </c:scaling>
-        <c:delete val="0"/>
-        <c:axPos val="b"/>
-        <c:numFmt formatCode="General" sourceLinked="1"/>
-        <c:majorTickMark val="out"/>
-        <c:minorTickMark val="none"/>
-        <c:tickLblPos val="low"/>
-        <c:spPr>
-          <a:ln w="12700" cap="flat">
-            <a:solidFill>
-              <a:srgbClr val="888888"/>
-            </a:solidFill>
-            <a:prstDash val="solid"/>
-            <a:round/>
-          </a:ln>
-        </c:spPr>
-        <c:txPr>
-          <a:bodyPr/>
-          <a:lstStyle/>
-          <a:p>
-            <a:pPr>
-              <a:defRPr sz="900" b="0" i="0" u="none" strike="noStrike">
-                <a:solidFill>
-                  <a:srgbClr val="000000"/>
-                </a:solidFill>
-                <a:latin typeface="Arial"/>
-              </a:defRPr>
-            </a:pPr>
-            <a:endParaRPr lang="en-US"/>
-          </a:p>
-        </c:txPr>
-        <c:crossAx val="2094734552"/>
-        <c:crosses val="autoZero"/>
-        <c:auto val="1"/>
-        <c:lblAlgn val="ctr"/>
-        <c:noMultiLvlLbl val="1"/>
-      </c:catAx>
-      <c:valAx>
-        <c:axId val="2094734552"/>
-        <c:scaling>
-          <c:orientation val="minMax"/>
-          <c:max val="10"/>
-          <c:min val="0"/>
-        </c:scaling>
-        <c:delete val="0"/>
-        <c:axPos val="l"/>
-        <c:majorGridlines>
-          <c:spPr>
-            <a:ln w="12700" cap="flat">
-              <a:solidFill>
-                <a:srgbClr val="888888"/>
-              </a:solidFill>
-              <a:prstDash val="solid"/>
-              <a:round/>
-            </a:ln>
-          </c:spPr>
-        </c:majorGridlines>
-        <c:numFmt formatCode="General" sourceLinked="0"/>
-        <c:majorTickMark val="out"/>
-        <c:minorTickMark val="none"/>
-        <c:tickLblPos val="nextTo"/>
-        <c:spPr>
-          <a:ln w="12700" cap="flat">
-            <a:solidFill>
-              <a:srgbClr val="888888"/>
-            </a:solidFill>
-            <a:prstDash val="solid"/>
-            <a:round/>
-          </a:ln>
-        </c:spPr>
-        <c:txPr>
-          <a:bodyPr/>
-          <a:lstStyle/>
-          <a:p>
-            <a:pPr>
-              <a:defRPr sz="900" b="0" i="0" u="none" strike="noStrike">
-                <a:solidFill>
-                  <a:srgbClr val="000000"/>
-                </a:solidFill>
-                <a:latin typeface="Arial"/>
-              </a:defRPr>
-            </a:pPr>
-            <a:endParaRPr lang="en-US"/>
-          </a:p>
-        </c:txPr>
-        <c:crossAx val="2094734554"/>
-        <c:crosses val="autoZero"/>
-        <c:crossBetween val="between"/>
-        <c:majorUnit val="2"/>
-      </c:valAx>
-      <c:spPr>
-        <a:noFill/>
-        <a:ln>
-          <a:noFill/>
-        </a:ln>
-        <a:effectLst/>
-      </c:spPr>
-    </c:plotArea>
-    <c:legend>
-      <c:legendPos val="b"/>
-      <c:overlay val="0"/>
-      <c:txPr>
-        <a:bodyPr/>
-        <a:lstStyle/>
-        <a:p>
-          <a:pPr>
-            <a:defRPr sz="900">      </a:defRPr>
-          </a:pPr>
-          <a:endParaRPr lang="en-US"/>
-        </a:p>
-      </c:txPr>
-    </c:legend>
-    <c:plotVisOnly val="1"/>
-    <c:dispBlanksAs val="span"/>
-  </c:chart>
-  <c:spPr>
-    <a:noFill/>
-    <a:ln>
-      <a:noFill/>
-    </a:ln>
-    <a:effectLst/>
-  </c:spPr>
-  <c:externalData r:id="rId1">
-    <c:autoUpdate val="0"/>
-  </c:externalData>
-</c:chartSpace>
-</file>
-
-<file path=ppt/charts/chart2.xml><?xml version="1.0" encoding="utf-8"?>
-<c:chartSpace xmlns:c="http://schemas.openxmlformats.org/drawingml/2006/chart" xmlns:a="http://schemas.openxmlformats.org/drawingml/2006/main" xmlns:r="http://schemas.openxmlformats.org/officeDocument/2006/relationships">
-  <c:date1904 val="0"/>
-  <c:roundedCorners val="1"/>
-  <c:chart>
-    <c:title>
-      <c:tx>
-        <c:rich>
-          <a:bodyPr/>
-          <a:lstStyle/>
-          <a:p>
-            <a:pPr>
-              <a:defRPr sz="1100" b="0" i="0" u="none" strike="noStrike">
-                <a:solidFill>
-                  <a:srgbClr val="333333"/>
-                </a:solidFill>
-                <a:latin typeface="Arial"/>
-              </a:defRPr>
-            </a:pPr>
-            <a:r>
-              <a:rPr sz="1100" b="0" i="0" u="none" strike="noStrike">
-                <a:solidFill>
-                  <a:srgbClr val="333333"/>
-                </a:solidFill>
-                <a:latin typeface="Arial"/>
-              </a:rPr>
-              <a:t>Production-weighted process score (with cleanliness gain)</a:t>
+              <a:t>Production-weighted process score</a:t>
             </a:r>
           </a:p>
         </c:rich>
@@ -1040,41 +587,12 @@
 </c:chartSpace>
 </file>
 
-<file path=ppt/charts/chart3.xml><?xml version="1.0" encoding="utf-8"?>
+<file path=ppt/charts/chart2.xml><?xml version="1.0" encoding="utf-8"?>
 <c:chartSpace xmlns:c="http://schemas.openxmlformats.org/drawingml/2006/chart" xmlns:a="http://schemas.openxmlformats.org/drawingml/2006/main" xmlns:r="http://schemas.openxmlformats.org/officeDocument/2006/relationships">
   <c:date1904 val="0"/>
   <c:roundedCorners val="1"/>
   <c:chart>
-    <c:title>
-      <c:tx>
-        <c:rich>
-          <a:bodyPr/>
-          <a:lstStyle/>
-          <a:p>
-            <a:pPr>
-              <a:defRPr sz="1200" b="0" i="0" u="none" strike="noStrike">
-                <a:solidFill>
-                  <a:srgbClr val="333333"/>
-                </a:solidFill>
-                <a:latin typeface="Arial"/>
-              </a:defRPr>
-            </a:pPr>
-            <a:r>
-              <a:rPr sz="1200" b="0" i="0" u="none" strike="noStrike">
-                <a:solidFill>
-                  <a:srgbClr val="333333"/>
-                </a:solidFill>
-                <a:latin typeface="Arial"/>
-              </a:rPr>
-              <a:t>Gain-stripped process score (W_g = W_lag = 0)</a:t>
-            </a:r>
-          </a:p>
-        </c:rich>
-      </c:tx>
-      <c:layout/>
-      <c:overlay val="0"/>
-    </c:title>
-    <c:autoTitleDeleted val="0"/>
+    <c:autoTitleDeleted val="1"/>
     <c:plotArea>
       <c:layout/>
       <c:lineChart>
@@ -1492,7 +1010,7 @@
 </c:chartSpace>
 </file>
 
-<file path=ppt/charts/chart4.xml><?xml version="1.0" encoding="utf-8"?>
+<file path=ppt/charts/chart3.xml><?xml version="1.0" encoding="utf-8"?>
 <c:chartSpace xmlns:c="http://schemas.openxmlformats.org/drawingml/2006/chart" xmlns:a="http://schemas.openxmlformats.org/drawingml/2006/main" xmlns:r="http://schemas.openxmlformats.org/officeDocument/2006/relationships">
   <c:date1904 val="0"/>
   <c:roundedCorners val="1"/>
@@ -4299,94 +3817,6 @@
             <a:fld id="{F7021451-1387-4CA6-816F-3879F97B5CBC}" type="slidenum">
               <a:rPr lang="en-US"/>
               <a:t>3</a:t>
-            </a:fld>
-            <a:endParaRPr lang="en-US"/>
-          </a:p>
-        </p:txBody>
-      </p:sp>
-    </p:spTree>
-    <p:extLst>
-      <p:ext uri="{BB962C8B-B14F-4D97-AF65-F5344CB8AC3E}">
-        <p14:creationId xmlns:p14="http://schemas.microsoft.com/office/powerpoint/2010/main" val="1024086991"/>
-      </p:ext>
-    </p:extLst>
-  </p:cSld>
-  <p:clrMapOvr>
-    <a:masterClrMapping/>
-  </p:clrMapOvr>
-</p:notes>
-</file>
-
-<file path=ppt/notesSlides/notesSlide30.xml><?xml version="1.0" encoding="utf-8"?>
-<p:notes xmlns:a="http://schemas.openxmlformats.org/drawingml/2006/main" xmlns:r="http://schemas.openxmlformats.org/officeDocument/2006/relationships" xmlns:p="http://schemas.openxmlformats.org/presentationml/2006/main">
-  <p:cSld>
-    <p:spTree>
-      <p:nvGrpSpPr>
-        <p:cNvPr id="1" name=""/>
-        <p:cNvGrpSpPr/>
-        <p:nvPr/>
-      </p:nvGrpSpPr>
-      <p:grpSpPr>
-        <a:xfrm>
-          <a:off x="0" y="0"/>
-          <a:ext cx="0" cy="0"/>
-          <a:chOff x="0" y="0"/>
-          <a:chExt cx="0" cy="0"/>
-        </a:xfrm>
-      </p:grpSpPr>
-      <p:sp>
-        <p:nvSpPr>
-          <p:cNvPr id="2" name="Slide Image Placeholder 1"/>
-          <p:cNvSpPr>
-            <a:spLocks noGrp="1" noRot="1" noChangeAspect="1"/>
-          </p:cNvSpPr>
-          <p:nvPr>
-            <p:ph type="sldImg"/>
-          </p:nvPr>
-        </p:nvSpPr>
-        <p:spPr/>
-      </p:sp>
-      <p:sp>
-        <p:nvSpPr>
-          <p:cNvPr id="3" name="Notes Placeholder 2"/>
-          <p:cNvSpPr>
-            <a:spLocks noGrp="1"/>
-          </p:cNvSpPr>
-          <p:nvPr>
-            <p:ph type="body" idx="1"/>
-          </p:nvPr>
-        </p:nvSpPr>
-        <p:spPr/>
-        <p:txBody>
-          <a:bodyPr/>
-          <a:lstStyle/>
-          <a:p>
-            <a:r>
-              <a:rPr lang="en-US" dirty="0"/>
-              <a:t/>
-            </a:r>
-            <a:endParaRPr lang="en-US" dirty="0"/>
-          </a:p>
-        </p:txBody>
-      </p:sp>
-      <p:sp>
-        <p:nvSpPr>
-          <p:cNvPr id="4" name="Slide Number Placeholder 3"/>
-          <p:cNvSpPr>
-            <a:spLocks noGrp="1"/>
-          </p:cNvSpPr>
-          <p:nvPr>
-            <p:ph type="sldNum" sz="quarter" idx="10"/>
-          </p:nvPr>
-        </p:nvSpPr>
-        <p:spPr/>
-        <p:txBody>
-          <a:bodyPr/>
-          <a:lstStyle/>
-          <a:p>
-            <a:fld id="{F7021451-1387-4CA6-816F-3879F97B5CBC}" type="slidenum">
-              <a:rPr lang="en-US"/>
-              <a:t>30</a:t>
             </a:fld>
             <a:endParaRPr lang="en-US"/>
           </a:p>
@@ -15849,8 +15279,8 @@
           <p:nvPr/>
         </p:nvGraphicFramePr>
         <p:xfrm>
-          <a:off x="274320" y="868680"/>
-          <a:ext cx="4206240" cy="3017520"/>
+          <a:off x="274320" y="914400"/>
+          <a:ext cx="4526280" cy="3337560"/>
         </p:xfrm>
         <a:graphic xmlns:a="http://schemas.openxmlformats.org/drawingml/2006/main">
           <a:graphicData uri="http://schemas.openxmlformats.org/drawingml/2006/chart">
@@ -15858,32 +15288,38 @@
           </a:graphicData>
         </a:graphic>
       </p:graphicFrame>
-      <p:graphicFrame>
-        <p:nvGraphicFramePr>
-          <p:cNvPr id="4" name="Chart 1" descr=""/>
-          <p:cNvGraphicFramePr/>
-          <p:nvPr/>
-        </p:nvGraphicFramePr>
-        <p:xfrm>
-          <a:off x="4663440" y="868680"/>
-          <a:ext cx="4206240" cy="3017520"/>
-        </p:xfrm>
-        <a:graphic xmlns:a="http://schemas.openxmlformats.org/drawingml/2006/main">
-          <a:graphicData uri="http://schemas.openxmlformats.org/drawingml/2006/chart">
-            <c:chart xmlns:c="http://schemas.openxmlformats.org/drawingml/2006/chart" r:id="rId2"/>
-          </a:graphicData>
-        </a:graphic>
-      </p:graphicFrame>
-      <p:sp>
-        <p:nvSpPr>
-          <p:cNvPr id="5" name="Text 1"/>
+      <p:sp>
+        <p:nvSpPr>
+          <p:cNvPr id="4" name="Shape 1"/>
           <p:cNvSpPr/>
           <p:nvPr/>
         </p:nvSpPr>
         <p:spPr>
           <a:xfrm>
-            <a:off x="457200" y="4069080"/>
-            <a:ext cx="8229600" cy="868680"/>
+            <a:off x="4937760" y="1417320"/>
+            <a:ext cx="3977640" cy="2331720"/>
+          </a:xfrm>
+          <a:prstGeom prst="roundRect">
+            <a:avLst>
+              <a:gd name="adj" fmla="val 3137"/>
+            </a:avLst>
+          </a:prstGeom>
+          <a:solidFill>
+            <a:srgbClr val="F5F5F5"/>
+          </a:solidFill>
+          <a:ln/>
+        </p:spPr>
+      </p:sp>
+      <p:sp>
+        <p:nvSpPr>
+          <p:cNvPr id="5" name="Text 2"/>
+          <p:cNvSpPr/>
+          <p:nvPr/>
+        </p:nvSpPr>
+        <p:spPr>
+          <a:xfrm>
+            <a:off x="5120640" y="1508760"/>
+            <a:ext cx="3611880" cy="2148840"/>
           </a:xfrm>
           <a:prstGeom prst="rect">
             <a:avLst/>
@@ -15892,102 +15328,89 @@
           <a:ln/>
         </p:spPr>
         <p:txBody>
-          <a:bodyPr wrap="square" lIns="50800" tIns="50800" rIns="50800" bIns="50800" rtlCol="0" anchor="t"/>
-          <a:lstStyle/>
-          <a:p>
-            <a:pPr algn="ctr" indent="0" marL="0">
-              <a:buNone/>
-            </a:pPr>
-            <a:r>
-              <a:rPr lang="en-US" sz="1200" dirty="0">
-                <a:solidFill>
-                  <a:srgbClr val="000000"/>
-                </a:solidFill>
-              </a:rPr>
-              <a:t>DP rate separates clearly: </a:t>
-            </a:r>
-            <a:pPr algn="ctr" indent="0" marL="0">
-              <a:buNone/>
-            </a:pPr>
-            <a:r>
-              <a:rPr lang="en-US" sz="1200" b="1" dirty="0">
-                <a:solidFill>
-                  <a:srgbClr val="0000CD"/>
-                </a:solidFill>
-              </a:rPr>
-              <a:t>2.7</a:t>
-            </a:r>
-            <a:pPr algn="ctr" indent="0" marL="0">
-              <a:buNone/>
-            </a:pPr>
-            <a:r>
-              <a:rPr lang="en-US" sz="1200" dirty="0">
-                <a:solidFill>
-                  <a:srgbClr val="000000"/>
-                </a:solidFill>
-              </a:rPr>
-              <a:t> (feedback) vs </a:t>
-            </a:r>
-            <a:pPr algn="ctr" indent="0" marL="0">
-              <a:buNone/>
-            </a:pPr>
-            <a:r>
-              <a:rPr lang="en-US" sz="1200" b="1" dirty="0">
-                <a:solidFill>
-                  <a:srgbClr val="B25500"/>
-                </a:solidFill>
-              </a:rPr>
-              <a:t>6.0</a:t>
-            </a:r>
+          <a:bodyPr wrap="square" lIns="0" tIns="0" rIns="0" bIns="0" rtlCol="0" anchor="ctr"/>
+          <a:lstStyle/>
+          <a:p>
             <a:pPr algn="ctr" indent="0" marL="0">
               <a:spcAft>
-                <a:spcPts val="400"/>
+                <a:spcPts val="600"/>
               </a:spcAft>
               <a:buNone/>
             </a:pPr>
             <a:r>
-              <a:rPr lang="en-US" sz="1200" dirty="0">
-                <a:solidFill>
-                  <a:srgbClr val="000000"/>
-                </a:solidFill>
-              </a:rPr>
-              <a:t> DPs per session per participant - 2.2× difference.</a:t>
-            </a:r>
-            <a:endParaRPr lang="en-US" sz="1200" dirty="0"/>
+              <a:rPr lang="en-US" sz="4000" b="1" dirty="0">
+                <a:solidFill>
+                  <a:srgbClr val="0000CD"/>
+                </a:solidFill>
+              </a:rPr>
+              <a:t>2.7  vs  6.0</a:t>
+            </a:r>
+            <a:endParaRPr lang="en-US" sz="4000" dirty="0"/>
           </a:p>
           <a:p>
             <a:pPr algn="ctr" indent="0" marL="0">
-              <a:buNone/>
-            </a:pPr>
-            <a:r>
-              <a:rPr lang="en-US" sz="1200" dirty="0">
-                <a:solidFill>
-                  <a:srgbClr val="000000"/>
-                </a:solidFill>
-              </a:rPr>
-              <a:t>But the production-weighted score is dominated by </a:t>
-            </a:r>
+              <a:spcAft>
+                <a:spcPts val="800"/>
+              </a:spcAft>
+              <a:buNone/>
+            </a:pPr>
+            <a:r>
+              <a:rPr lang="en-US" sz="1100" b="1" dirty="0">
+                <a:solidFill>
+                  <a:srgbClr val="1A1A1A"/>
+                </a:solidFill>
+              </a:rPr>
+              <a:t>DPs per session per participant  ·  feedback vs baseline</a:t>
+            </a:r>
+            <a:endParaRPr lang="en-US" sz="4000" dirty="0"/>
+          </a:p>
+          <a:p>
             <a:pPr algn="ctr" indent="0" marL="0">
               <a:buNone/>
             </a:pPr>
             <a:r>
+              <a:rPr lang="en-US" sz="1000" i="1" dirty="0">
+                <a:solidFill>
+                  <a:srgbClr val="555555"/>
+                </a:solidFill>
+              </a:rPr>
+              <a:t>Participants who saw feedback flagged a divergence less than half as often. 2.2× difference across the 30-session study.</a:t>
+            </a:r>
+            <a:endParaRPr lang="en-US" sz="4000" dirty="0"/>
+          </a:p>
+        </p:txBody>
+      </p:sp>
+      <p:sp>
+        <p:nvSpPr>
+          <p:cNvPr id="6" name="Text 3"/>
+          <p:cNvSpPr/>
+          <p:nvPr/>
+        </p:nvSpPr>
+        <p:spPr>
+          <a:xfrm>
+            <a:off x="457200" y="4434840"/>
+            <a:ext cx="8229600" cy="457200"/>
+          </a:xfrm>
+          <a:prstGeom prst="rect">
+            <a:avLst/>
+          </a:prstGeom>
+          <a:noFill/>
+          <a:ln/>
+        </p:spPr>
+        <p:txBody>
+          <a:bodyPr wrap="square" lIns="0" tIns="0" rIns="0" bIns="0" rtlCol="0" anchor="ctr"/>
+          <a:lstStyle/>
+          <a:p>
+            <a:pPr algn="ctr" indent="0" marL="0">
+              <a:buNone/>
+            </a:pPr>
+            <a:r>
               <a:rPr lang="en-US" sz="1200" i="1" dirty="0">
                 <a:solidFill>
-                  <a:srgbClr val="000000"/>
-                </a:solidFill>
-              </a:rPr>
-              <a:t>task difficulty</a:t>
-            </a:r>
-            <a:pPr algn="ctr" indent="0" marL="0">
-              <a:buNone/>
-            </a:pPr>
-            <a:r>
-              <a:rPr lang="en-US" sz="1200" dirty="0">
-                <a:solidFill>
-                  <a:srgbClr val="000000"/>
-                </a:solidFill>
-              </a:rPr>
-              <a:t> - both groups peak at S4 (a short, mechanical task) and dip together at S2/S5. The behavioural signal is buried in the cleanliness gain.</a:t>
+                  <a:srgbClr val="0000CD"/>
+                </a:solidFill>
+              </a:rPr>
+              <a:t>But the production-weighted score is dominated by task difficulty - both groups peak at S4. The behavioural signal needs the gain-stripped view (next slide).</a:t>
             </a:r>
             <a:endParaRPr lang="en-US" sz="1200" dirty="0"/>
           </a:p>
@@ -16054,15 +15477,95 @@
           </a:p>
         </p:txBody>
       </p:sp>
+      <p:sp>
+        <p:nvSpPr>
+          <p:cNvPr id="3" name="Text 1"/>
+          <p:cNvSpPr/>
+          <p:nvPr/>
+        </p:nvSpPr>
+        <p:spPr>
+          <a:xfrm>
+            <a:off x="457200" y="777240"/>
+            <a:ext cx="8229600" cy="274320"/>
+          </a:xfrm>
+          <a:prstGeom prst="rect">
+            <a:avLst/>
+          </a:prstGeom>
+          <a:noFill/>
+          <a:ln/>
+        </p:spPr>
+        <p:txBody>
+          <a:bodyPr wrap="square" lIns="0" tIns="0" rIns="0" bIns="0" rtlCol="0" anchor="ctr"/>
+          <a:lstStyle/>
+          <a:p>
+            <a:pPr algn="ctr" indent="0" marL="0">
+              <a:buNone/>
+            </a:pPr>
+            <a:r>
+              <a:rPr lang="en-US" sz="1200" dirty="0">
+                <a:solidFill>
+                  <a:srgbClr val="333333"/>
+                </a:solidFill>
+              </a:rPr>
+              <a:t>Gain-stripped process score (W</a:t>
+            </a:r>
+            <a:pPr algn="ctr" indent="0" marL="0">
+              <a:buNone/>
+            </a:pPr>
+            <a:r>
+              <a:rPr lang="en-US" sz="1200" baseline="-40000" dirty="0">
+                <a:solidFill>
+                  <a:srgbClr val="333333"/>
+                </a:solidFill>
+              </a:rPr>
+              <a:t>g</a:t>
+            </a:r>
+            <a:pPr algn="ctr" indent="0" marL="0">
+              <a:buNone/>
+            </a:pPr>
+            <a:r>
+              <a:rPr lang="en-US" sz="1200" dirty="0">
+                <a:solidFill>
+                  <a:srgbClr val="333333"/>
+                </a:solidFill>
+              </a:rPr>
+              <a:t> = W</a:t>
+            </a:r>
+            <a:pPr algn="ctr" indent="0" marL="0">
+              <a:buNone/>
+            </a:pPr>
+            <a:r>
+              <a:rPr lang="en-US" sz="1200" baseline="-40000" dirty="0">
+                <a:solidFill>
+                  <a:srgbClr val="333333"/>
+                </a:solidFill>
+              </a:rPr>
+              <a:t>lag</a:t>
+            </a:r>
+            <a:pPr algn="ctr" indent="0" marL="0">
+              <a:buNone/>
+            </a:pPr>
+            <a:r>
+              <a:rPr lang="en-US" sz="1200" dirty="0">
+                <a:solidFill>
+                  <a:srgbClr val="333333"/>
+                </a:solidFill>
+              </a:rPr>
+              <a:t> = 0)</a:t>
+            </a:r>
+            <a:endParaRPr lang="en-US" sz="1200" dirty="0"/>
+          </a:p>
+        </p:txBody>
+      </p:sp>
       <p:graphicFrame>
         <p:nvGraphicFramePr>
-          <p:cNvPr id="3" name="Chart 0" descr=""/>
+          <p:cNvPr id="4" name="Chart 0" descr=""/>
           <p:cNvGraphicFramePr/>
           <p:nvPr/>
         </p:nvGraphicFramePr>
         <p:xfrm>
-          <a:off x="1554480" y="777240"/>
-          <a:ext cx="6035040" cy="3108960"/>
+          <a:off x="1554480" y="1097280"/>
+          <a:ext cx="6035040" cy="2834640"/>
         </p:xfrm>
         <a:graphic xmlns:a="http://schemas.openxmlformats.org/drawingml/2006/main">
           <a:graphicData uri="http://schemas.openxmlformats.org/drawingml/2006/chart">
@@ -16072,7 +15575,7 @@
       </p:graphicFrame>
       <p:sp>
         <p:nvSpPr>
-          <p:cNvPr id="4" name="Text 1"/>
+          <p:cNvPr id="5" name="Text 2"/>
           <p:cNvSpPr/>
           <p:nvPr/>
         </p:nvSpPr>
@@ -16222,67 +15725,6 @@
         </p:nvSpPr>
         <p:spPr>
           <a:xfrm>
-            <a:off x="457200" y="2011680"/>
-            <a:ext cx="8229600" cy="1097280"/>
-          </a:xfrm>
-          <a:prstGeom prst="rect">
-            <a:avLst/>
-          </a:prstGeom>
-          <a:noFill/>
-          <a:ln/>
-        </p:spPr>
-        <p:txBody>
-          <a:bodyPr wrap="square" lIns="0" tIns="0" rIns="0" bIns="0" rtlCol="0" anchor="ctr"/>
-          <a:lstStyle/>
-          <a:p>
-            <a:pPr algn="ctr" indent="0" marL="0">
-              <a:buNone/>
-            </a:pPr>
-            <a:r>
-              <a:rPr lang="en-US" sz="3600" b="1" dirty="0">
-                <a:solidFill>
-                  <a:srgbClr val="1A1A1A"/>
-                </a:solidFill>
-              </a:rPr>
-              <a:t>Extension: Agent Traces</a:t>
-            </a:r>
-            <a:endParaRPr lang="en-US" sz="3600" dirty="0"/>
-          </a:p>
-        </p:txBody>
-      </p:sp>
-    </p:spTree>
-  </p:cSld>
-  <p:clrMapOvr>
-    <a:masterClrMapping/>
-  </p:clrMapOvr>
-</p:sld>
-</file>
-
-<file path=ppt/slides/slide29.xml><?xml version="1.0" encoding="utf-8"?>
-<p:sld xmlns:a="http://schemas.openxmlformats.org/drawingml/2006/main" xmlns:r="http://schemas.openxmlformats.org/officeDocument/2006/relationships" xmlns:p="http://schemas.openxmlformats.org/presentationml/2006/main">
-  <p:cSld name="Slide 29">
-    <p:spTree>
-      <p:nvGrpSpPr>
-        <p:cNvPr id="1" name=""/>
-        <p:cNvGrpSpPr/>
-        <p:nvPr/>
-      </p:nvGrpSpPr>
-      <p:grpSpPr>
-        <a:xfrm>
-          <a:off x="0" y="0"/>
-          <a:ext cx="0" cy="0"/>
-          <a:chOff x="0" y="0"/>
-          <a:chExt cx="0" cy="0"/>
-        </a:xfrm>
-      </p:grpSpPr>
-      <p:sp>
-        <p:nvSpPr>
-          <p:cNvPr id="2" name="Text 0"/>
-          <p:cNvSpPr/>
-          <p:nvPr/>
-        </p:nvSpPr>
-        <p:spPr>
-          <a:xfrm>
             <a:off x="457200" y="137160"/>
             <a:ext cx="8229600" cy="457200"/>
           </a:xfrm>
@@ -16300,14 +15742,14 @@
               <a:buNone/>
             </a:pPr>
             <a:r>
-              <a:rPr lang="en-US" sz="2400" b="1" dirty="0">
+              <a:rPr lang="en-US" sz="2200" b="1" dirty="0">
                 <a:solidFill>
                   <a:srgbClr val="000000"/>
                 </a:solidFill>
               </a:rPr>
-              <a:t>Tool doesn't transfer cleanly to agent traces</a:t>
-            </a:r>
-            <a:endParaRPr lang="en-US" sz="2400" dirty="0"/>
+              <a:t>Extension: tool doesn't transfer cleanly to agent traces</a:t>
+            </a:r>
+            <a:endParaRPr lang="en-US" sz="2200" dirty="0"/>
           </a:p>
         </p:txBody>
       </p:sp>
@@ -16365,7 +15807,7 @@
       </p:graphicFrame>
       <p:graphicFrame>
         <p:nvGraphicFramePr>
-          <p:cNvPr id="30" name="Table 0"/>
+          <p:cNvPr id="29" name="Table 0"/>
           <p:cNvGraphicFramePr>
             <a:graphicFrameLocks noGrp="1"/>
           </p:cNvGraphicFramePr>
@@ -17144,6 +16586,272 @@
 </p:sld>
 </file>
 
+<file path=ppt/slides/slide29.xml><?xml version="1.0" encoding="utf-8"?>
+<p:sld xmlns:a="http://schemas.openxmlformats.org/drawingml/2006/main" xmlns:r="http://schemas.openxmlformats.org/officeDocument/2006/relationships" xmlns:p="http://schemas.openxmlformats.org/presentationml/2006/main">
+  <p:cSld name="Slide 29">
+    <p:spTree>
+      <p:nvGrpSpPr>
+        <p:cNvPr id="1" name=""/>
+        <p:cNvGrpSpPr/>
+        <p:nvPr/>
+      </p:nvGrpSpPr>
+      <p:grpSpPr>
+        <a:xfrm>
+          <a:off x="0" y="0"/>
+          <a:ext cx="0" cy="0"/>
+          <a:chOff x="0" y="0"/>
+          <a:chExt cx="0" cy="0"/>
+        </a:xfrm>
+      </p:grpSpPr>
+      <p:sp>
+        <p:nvSpPr>
+          <p:cNvPr id="2" name="Text 0"/>
+          <p:cNvSpPr/>
+          <p:nvPr/>
+        </p:nvSpPr>
+        <p:spPr>
+          <a:xfrm>
+            <a:off x="457200" y="274320"/>
+            <a:ext cx="8229600" cy="640080"/>
+          </a:xfrm>
+          <a:prstGeom prst="rect">
+            <a:avLst/>
+          </a:prstGeom>
+          <a:noFill/>
+          <a:ln/>
+        </p:spPr>
+        <p:txBody>
+          <a:bodyPr wrap="square" lIns="0" tIns="0" rIns="0" bIns="0" rtlCol="0" anchor="ctr"/>
+          <a:lstStyle/>
+          <a:p>
+            <a:pPr indent="0" marL="0">
+              <a:buNone/>
+            </a:pPr>
+            <a:r>
+              <a:rPr lang="en-US" sz="2800" b="1" dirty="0">
+                <a:solidFill>
+                  <a:srgbClr val="000000"/>
+                </a:solidFill>
+              </a:rPr>
+              <a:t>Conclusion</a:t>
+            </a:r>
+            <a:endParaRPr lang="en-US" sz="2800" dirty="0"/>
+          </a:p>
+        </p:txBody>
+      </p:sp>
+      <p:sp>
+        <p:nvSpPr>
+          <p:cNvPr id="3" name="Text 1"/>
+          <p:cNvSpPr/>
+          <p:nvPr/>
+        </p:nvSpPr>
+        <p:spPr>
+          <a:xfrm>
+            <a:off x="457200" y="1005840"/>
+            <a:ext cx="8229600" cy="777240"/>
+          </a:xfrm>
+          <a:prstGeom prst="rect">
+            <a:avLst/>
+          </a:prstGeom>
+          <a:noFill/>
+          <a:ln/>
+        </p:spPr>
+        <p:txBody>
+          <a:bodyPr wrap="square" rtlCol="0" anchor="ctr"/>
+          <a:lstStyle/>
+          <a:p>
+            <a:pPr algn="ctr" indent="0" marL="0">
+              <a:buNone/>
+            </a:pPr>
+            <a:r>
+              <a:rPr lang="en-US" sz="1500" i="1" dirty="0">
+                <a:solidFill>
+                  <a:srgbClr val="0000CD"/>
+                </a:solidFill>
+              </a:rPr>
+              <a:t>Process-aware refactoring evaluation is tractable, and a small randomised study gives directional evidence that feedback improves measured process discipline.</a:t>
+            </a:r>
+            <a:endParaRPr lang="en-US" sz="1500" dirty="0"/>
+          </a:p>
+        </p:txBody>
+      </p:sp>
+      <p:sp>
+        <p:nvSpPr>
+          <p:cNvPr id="4" name="Text 2"/>
+          <p:cNvSpPr/>
+          <p:nvPr/>
+        </p:nvSpPr>
+        <p:spPr>
+          <a:xfrm>
+            <a:off x="457200" y="1920240"/>
+            <a:ext cx="8229600" cy="2651760"/>
+          </a:xfrm>
+          <a:prstGeom prst="rect">
+            <a:avLst/>
+          </a:prstGeom>
+          <a:noFill/>
+          <a:ln/>
+        </p:spPr>
+        <p:txBody>
+          <a:bodyPr wrap="square" rtlCol="0" anchor="t"/>
+          <a:lstStyle/>
+          <a:p>
+            <a:pPr marL="342900" indent="-342900">
+              <a:spcAft>
+                <a:spcPts val="600"/>
+              </a:spcAft>
+              <a:buSzPct val="100000"/>
+              <a:buChar char="•"/>
+            </a:pPr>
+            <a:r>
+              <a:rPr lang="en-US" sz="1600" dirty="0">
+                <a:solidFill>
+                  <a:srgbClr val="000000"/>
+                </a:solidFill>
+              </a:rPr>
+              <a:t>A process-quality metric on </a:t>
+            </a:r>
+            <a:pPr indent="0" marL="0">
+              <a:spcAft>
+                <a:spcPts val="600"/>
+              </a:spcAft>
+              <a:buNone/>
+            </a:pPr>
+            <a:r>
+              <a:rPr lang="en-US" sz="1600" i="1" dirty="0">
+                <a:solidFill>
+                  <a:srgbClr val="000000"/>
+                </a:solidFill>
+              </a:rPr>
+              <a:t>arbitrary sessions</a:t>
+            </a:r>
+            <a:pPr indent="0" marL="0">
+              <a:spcAft>
+                <a:spcPts val="600"/>
+              </a:spcAft>
+              <a:buNone/>
+            </a:pPr>
+            <a:r>
+              <a:rPr lang="en-US" sz="1600" dirty="0">
+                <a:solidFill>
+                  <a:srgbClr val="000000"/>
+                </a:solidFill>
+              </a:rPr>
+              <a:t> combining endpoint, process, and safety signals in one principled score.</a:t>
+            </a:r>
+            <a:endParaRPr lang="en-US" sz="1600" dirty="0"/>
+          </a:p>
+          <a:p>
+            <a:pPr marL="342900" indent="-342900">
+              <a:spcAft>
+                <a:spcPts val="600"/>
+              </a:spcAft>
+              <a:buSzPct val="100000"/>
+              <a:buChar char="•"/>
+            </a:pPr>
+            <a:r>
+              <a:rPr lang="en-US" sz="1600" dirty="0">
+                <a:solidFill>
+                  <a:srgbClr val="000000"/>
+                </a:solidFill>
+              </a:rPr>
+              <a:t>A divergence-point detector with four actionable kinds, each with a per-kind synthesiser that constructs a concrete alternative trajectory.</a:t>
+            </a:r>
+            <a:endParaRPr lang="en-US" sz="1600" dirty="0"/>
+          </a:p>
+          <a:p>
+            <a:pPr marL="342900" indent="-342900">
+              <a:spcAft>
+                <a:spcPts val="600"/>
+              </a:spcAft>
+              <a:buSzPct val="100000"/>
+              <a:buChar char="•"/>
+            </a:pPr>
+            <a:r>
+              <a:rPr lang="en-US" sz="1600" dirty="0">
+                <a:solidFill>
+                  <a:srgbClr val="000000"/>
+                </a:solidFill>
+              </a:rPr>
+              <a:t>Three datasets -45 injection sessions, 30-session user study, 48-session agent extension - with reproducible analysis (Jupyter notebook reproduces every table and figure).</a:t>
+            </a:r>
+            <a:endParaRPr lang="en-US" sz="1600" dirty="0"/>
+          </a:p>
+          <a:p>
+            <a:pPr marL="342900" indent="-342900">
+              <a:spcAft>
+                <a:spcPts val="600"/>
+              </a:spcAft>
+              <a:buSzPct val="100000"/>
+              <a:buChar char="•"/>
+            </a:pPr>
+            <a:r>
+              <a:rPr lang="en-US" sz="1600" dirty="0">
+                <a:solidFill>
+                  <a:srgbClr val="000000"/>
+                </a:solidFill>
+              </a:rPr>
+              <a:t>A working end-to-end research prototype: IntelliJ plugin, analysis backend, and dashboard.</a:t>
+            </a:r>
+            <a:endParaRPr lang="en-US" sz="1600" dirty="0"/>
+          </a:p>
+        </p:txBody>
+      </p:sp>
+      <p:sp>
+        <p:nvSpPr>
+          <p:cNvPr id="5" name="Text 3"/>
+          <p:cNvSpPr/>
+          <p:nvPr/>
+        </p:nvSpPr>
+        <p:spPr>
+          <a:xfrm>
+            <a:off x="457200" y="4617720"/>
+            <a:ext cx="8229600" cy="457200"/>
+          </a:xfrm>
+          <a:prstGeom prst="rect">
+            <a:avLst/>
+          </a:prstGeom>
+          <a:noFill/>
+          <a:ln/>
+        </p:spPr>
+        <p:txBody>
+          <a:bodyPr wrap="square" lIns="0" tIns="0" rIns="0" bIns="0" rtlCol="0" anchor="ctr"/>
+          <a:lstStyle/>
+          <a:p>
+            <a:pPr algn="ctr" indent="0" marL="0">
+              <a:buNone/>
+            </a:pPr>
+            <a:r>
+              <a:rPr lang="en-US" sz="1100" b="1" i="1" dirty="0">
+                <a:solidFill>
+                  <a:srgbClr val="888888"/>
+                </a:solidFill>
+              </a:rPr>
+              <a:t>Not yet established: </a:t>
+            </a:r>
+            <a:pPr algn="ctr" indent="0" marL="0">
+              <a:buNone/>
+            </a:pPr>
+            <a:r>
+              <a:rPr lang="en-US" sz="1100" i="1" dirty="0">
+                <a:solidFill>
+                  <a:srgbClr val="888888"/>
+                </a:solidFill>
+              </a:rPr>
+              <a:t>externally calibrated measure of refactoring quality, statistically conclusive behavioural effect, or generalisation beyond Java / IntelliJ / human traces.</a:t>
+            </a:r>
+            <a:endParaRPr lang="en-US" sz="1100" dirty="0"/>
+          </a:p>
+        </p:txBody>
+      </p:sp>
+    </p:spTree>
+  </p:cSld>
+  <p:clrMapOvr>
+    <a:masterClrMapping/>
+  </p:clrMapOvr>
+</p:sld>
+</file>
+
 <file path=ppt/slides/slide3.xml><?xml version="1.0" encoding="utf-8"?>
 <p:sld xmlns:a="http://schemas.openxmlformats.org/drawingml/2006/main" xmlns:r="http://schemas.openxmlformats.org/officeDocument/2006/relationships" xmlns:p="http://schemas.openxmlformats.org/presentationml/2006/main">
   <p:cSld name="Slide 3">
@@ -17468,272 +17176,6 @@
               <a:t>- match explicit events inside predefined exercises; don't generalise to arbitrary sessions.</a:t>
             </a:r>
             <a:endParaRPr lang="en-US" sz="1300" dirty="0"/>
-          </a:p>
-        </p:txBody>
-      </p:sp>
-    </p:spTree>
-  </p:cSld>
-  <p:clrMapOvr>
-    <a:masterClrMapping/>
-  </p:clrMapOvr>
-</p:sld>
-</file>
-
-<file path=ppt/slides/slide30.xml><?xml version="1.0" encoding="utf-8"?>
-<p:sld xmlns:a="http://schemas.openxmlformats.org/drawingml/2006/main" xmlns:r="http://schemas.openxmlformats.org/officeDocument/2006/relationships" xmlns:p="http://schemas.openxmlformats.org/presentationml/2006/main">
-  <p:cSld name="Slide 30">
-    <p:spTree>
-      <p:nvGrpSpPr>
-        <p:cNvPr id="1" name=""/>
-        <p:cNvGrpSpPr/>
-        <p:nvPr/>
-      </p:nvGrpSpPr>
-      <p:grpSpPr>
-        <a:xfrm>
-          <a:off x="0" y="0"/>
-          <a:ext cx="0" cy="0"/>
-          <a:chOff x="0" y="0"/>
-          <a:chExt cx="0" cy="0"/>
-        </a:xfrm>
-      </p:grpSpPr>
-      <p:sp>
-        <p:nvSpPr>
-          <p:cNvPr id="2" name="Text 0"/>
-          <p:cNvSpPr/>
-          <p:nvPr/>
-        </p:nvSpPr>
-        <p:spPr>
-          <a:xfrm>
-            <a:off x="457200" y="274320"/>
-            <a:ext cx="8229600" cy="640080"/>
-          </a:xfrm>
-          <a:prstGeom prst="rect">
-            <a:avLst/>
-          </a:prstGeom>
-          <a:noFill/>
-          <a:ln/>
-        </p:spPr>
-        <p:txBody>
-          <a:bodyPr wrap="square" lIns="0" tIns="0" rIns="0" bIns="0" rtlCol="0" anchor="ctr"/>
-          <a:lstStyle/>
-          <a:p>
-            <a:pPr indent="0" marL="0">
-              <a:buNone/>
-            </a:pPr>
-            <a:r>
-              <a:rPr lang="en-US" sz="2800" b="1" dirty="0">
-                <a:solidFill>
-                  <a:srgbClr val="000000"/>
-                </a:solidFill>
-              </a:rPr>
-              <a:t>Conclusion</a:t>
-            </a:r>
-            <a:endParaRPr lang="en-US" sz="2800" dirty="0"/>
-          </a:p>
-        </p:txBody>
-      </p:sp>
-      <p:sp>
-        <p:nvSpPr>
-          <p:cNvPr id="3" name="Text 1"/>
-          <p:cNvSpPr/>
-          <p:nvPr/>
-        </p:nvSpPr>
-        <p:spPr>
-          <a:xfrm>
-            <a:off x="457200" y="1005840"/>
-            <a:ext cx="8229600" cy="777240"/>
-          </a:xfrm>
-          <a:prstGeom prst="rect">
-            <a:avLst/>
-          </a:prstGeom>
-          <a:noFill/>
-          <a:ln/>
-        </p:spPr>
-        <p:txBody>
-          <a:bodyPr wrap="square" rtlCol="0" anchor="ctr"/>
-          <a:lstStyle/>
-          <a:p>
-            <a:pPr algn="ctr" indent="0" marL="0">
-              <a:buNone/>
-            </a:pPr>
-            <a:r>
-              <a:rPr lang="en-US" sz="1500" i="1" dirty="0">
-                <a:solidFill>
-                  <a:srgbClr val="0000CD"/>
-                </a:solidFill>
-              </a:rPr>
-              <a:t>Process-aware refactoring evaluation is tractable, and a small randomised study gives directional evidence that feedback improves measured process discipline.</a:t>
-            </a:r>
-            <a:endParaRPr lang="en-US" sz="1500" dirty="0"/>
-          </a:p>
-        </p:txBody>
-      </p:sp>
-      <p:sp>
-        <p:nvSpPr>
-          <p:cNvPr id="4" name="Text 2"/>
-          <p:cNvSpPr/>
-          <p:nvPr/>
-        </p:nvSpPr>
-        <p:spPr>
-          <a:xfrm>
-            <a:off x="457200" y="1920240"/>
-            <a:ext cx="8229600" cy="2651760"/>
-          </a:xfrm>
-          <a:prstGeom prst="rect">
-            <a:avLst/>
-          </a:prstGeom>
-          <a:noFill/>
-          <a:ln/>
-        </p:spPr>
-        <p:txBody>
-          <a:bodyPr wrap="square" rtlCol="0" anchor="t"/>
-          <a:lstStyle/>
-          <a:p>
-            <a:pPr marL="342900" indent="-342900">
-              <a:spcAft>
-                <a:spcPts val="600"/>
-              </a:spcAft>
-              <a:buSzPct val="100000"/>
-              <a:buChar char="•"/>
-            </a:pPr>
-            <a:r>
-              <a:rPr lang="en-US" sz="1600" dirty="0">
-                <a:solidFill>
-                  <a:srgbClr val="000000"/>
-                </a:solidFill>
-              </a:rPr>
-              <a:t>A process-quality metric on </a:t>
-            </a:r>
-            <a:pPr indent="0" marL="0">
-              <a:spcAft>
-                <a:spcPts val="600"/>
-              </a:spcAft>
-              <a:buNone/>
-            </a:pPr>
-            <a:r>
-              <a:rPr lang="en-US" sz="1600" i="1" dirty="0">
-                <a:solidFill>
-                  <a:srgbClr val="000000"/>
-                </a:solidFill>
-              </a:rPr>
-              <a:t>arbitrary sessions</a:t>
-            </a:r>
-            <a:pPr indent="0" marL="0">
-              <a:spcAft>
-                <a:spcPts val="600"/>
-              </a:spcAft>
-              <a:buNone/>
-            </a:pPr>
-            <a:r>
-              <a:rPr lang="en-US" sz="1600" dirty="0">
-                <a:solidFill>
-                  <a:srgbClr val="000000"/>
-                </a:solidFill>
-              </a:rPr>
-              <a:t> combining endpoint, process, and safety signals in one principled score.</a:t>
-            </a:r>
-            <a:endParaRPr lang="en-US" sz="1600" dirty="0"/>
-          </a:p>
-          <a:p>
-            <a:pPr marL="342900" indent="-342900">
-              <a:spcAft>
-                <a:spcPts val="600"/>
-              </a:spcAft>
-              <a:buSzPct val="100000"/>
-              <a:buChar char="•"/>
-            </a:pPr>
-            <a:r>
-              <a:rPr lang="en-US" sz="1600" dirty="0">
-                <a:solidFill>
-                  <a:srgbClr val="000000"/>
-                </a:solidFill>
-              </a:rPr>
-              <a:t>A divergence-point detector with four actionable kinds, each with a per-kind synthesiser that constructs a concrete alternative trajectory.</a:t>
-            </a:r>
-            <a:endParaRPr lang="en-US" sz="1600" dirty="0"/>
-          </a:p>
-          <a:p>
-            <a:pPr marL="342900" indent="-342900">
-              <a:spcAft>
-                <a:spcPts val="600"/>
-              </a:spcAft>
-              <a:buSzPct val="100000"/>
-              <a:buChar char="•"/>
-            </a:pPr>
-            <a:r>
-              <a:rPr lang="en-US" sz="1600" dirty="0">
-                <a:solidFill>
-                  <a:srgbClr val="000000"/>
-                </a:solidFill>
-              </a:rPr>
-              <a:t>Three datasets -45 injection sessions, 30-session user study, 48-session agent extension - with reproducible analysis (Jupyter notebook reproduces every table and figure).</a:t>
-            </a:r>
-            <a:endParaRPr lang="en-US" sz="1600" dirty="0"/>
-          </a:p>
-          <a:p>
-            <a:pPr marL="342900" indent="-342900">
-              <a:spcAft>
-                <a:spcPts val="600"/>
-              </a:spcAft>
-              <a:buSzPct val="100000"/>
-              <a:buChar char="•"/>
-            </a:pPr>
-            <a:r>
-              <a:rPr lang="en-US" sz="1600" dirty="0">
-                <a:solidFill>
-                  <a:srgbClr val="000000"/>
-                </a:solidFill>
-              </a:rPr>
-              <a:t>A working end-to-end research prototype: IntelliJ plugin, analysis backend, and dashboard.</a:t>
-            </a:r>
-            <a:endParaRPr lang="en-US" sz="1600" dirty="0"/>
-          </a:p>
-        </p:txBody>
-      </p:sp>
-      <p:sp>
-        <p:nvSpPr>
-          <p:cNvPr id="5" name="Text 3"/>
-          <p:cNvSpPr/>
-          <p:nvPr/>
-        </p:nvSpPr>
-        <p:spPr>
-          <a:xfrm>
-            <a:off x="457200" y="4617720"/>
-            <a:ext cx="8229600" cy="457200"/>
-          </a:xfrm>
-          <a:prstGeom prst="rect">
-            <a:avLst/>
-          </a:prstGeom>
-          <a:noFill/>
-          <a:ln/>
-        </p:spPr>
-        <p:txBody>
-          <a:bodyPr wrap="square" lIns="0" tIns="0" rIns="0" bIns="0" rtlCol="0" anchor="ctr"/>
-          <a:lstStyle/>
-          <a:p>
-            <a:pPr algn="ctr" indent="0" marL="0">
-              <a:buNone/>
-            </a:pPr>
-            <a:r>
-              <a:rPr lang="en-US" sz="1100" b="1" i="1" dirty="0">
-                <a:solidFill>
-                  <a:srgbClr val="888888"/>
-                </a:solidFill>
-              </a:rPr>
-              <a:t>Not yet established: </a:t>
-            </a:r>
-            <a:pPr algn="ctr" indent="0" marL="0">
-              <a:buNone/>
-            </a:pPr>
-            <a:r>
-              <a:rPr lang="en-US" sz="1100" i="1" dirty="0">
-                <a:solidFill>
-                  <a:srgbClr val="888888"/>
-                </a:solidFill>
-              </a:rPr>
-              <a:t>externally calibrated measure of refactoring quality, statistically conclusive behavioural effect, or generalisation beyond Java / IntelliJ / human traces.</a:t>
-            </a:r>
-            <a:endParaRPr lang="en-US" sz="1100" dirty="0"/>
           </a:p>
         </p:txBody>
       </p:sp>

</xml_diff>

<commit_message>
feat: fix conclusion slide
</commit_message>
<xml_diff>
--- a/presentation/slides.pptx
+++ b/presentation/slides.pptx
@@ -16697,9 +16697,6 @@
           <a:lstStyle/>
           <a:p>
             <a:pPr marL="342900" indent="-342900">
-              <a:spcAft>
-                <a:spcPts val="600"/>
-              </a:spcAft>
               <a:buSzPct val="100000"/>
               <a:buChar char="•"/>
             </a:pPr>
@@ -16712,9 +16709,6 @@
               <a:t>A process-quality metric on </a:t>
             </a:r>
             <a:pPr indent="0" marL="0">
-              <a:spcAft>
-                <a:spcPts val="600"/>
-              </a:spcAft>
               <a:buNone/>
             </a:pPr>
             <a:r>
@@ -16725,10 +16719,10 @@
               </a:rPr>
               <a:t>arbitrary sessions</a:t>
             </a:r>
+            <a:endParaRPr lang="en-US" sz="1600" dirty="0"/>
+          </a:p>
+          <a:p>
             <a:pPr indent="0" marL="0">
-              <a:spcAft>
-                <a:spcPts val="600"/>
-              </a:spcAft>
               <a:buNone/>
             </a:pPr>
             <a:r>
@@ -16737,15 +16731,12 @@
                   <a:srgbClr val="000000"/>
                 </a:solidFill>
               </a:rPr>
-              <a:t> combining endpoint, process, and safety signals in one principled score.</a:t>
+              <a:t> </a:t>
             </a:r>
             <a:endParaRPr lang="en-US" sz="1600" dirty="0"/>
           </a:p>
           <a:p>
             <a:pPr marL="342900" indent="-342900">
-              <a:spcAft>
-                <a:spcPts val="600"/>
-              </a:spcAft>
               <a:buSzPct val="100000"/>
               <a:buChar char="•"/>
             </a:pPr>
@@ -16755,15 +16746,26 @@
                   <a:srgbClr val="000000"/>
                 </a:solidFill>
               </a:rPr>
-              <a:t>A divergence-point detector with four actionable kinds, each with a per-kind synthesiser that constructs a concrete alternative trajectory.</a:t>
+              <a:t>A divergence-point detector &amp; synthesiser of alternative trajectories.</a:t>
             </a:r>
             <a:endParaRPr lang="en-US" sz="1600" dirty="0"/>
           </a:p>
           <a:p>
+            <a:pPr indent="0" marL="0">
+              <a:buNone/>
+            </a:pPr>
+            <a:r>
+              <a:rPr lang="en-US" sz="1600" dirty="0">
+                <a:solidFill>
+                  <a:srgbClr val="000000"/>
+                </a:solidFill>
+              </a:rPr>
+              <a:t> </a:t>
+            </a:r>
+            <a:endParaRPr lang="en-US" sz="1600" dirty="0"/>
+          </a:p>
+          <a:p>
             <a:pPr marL="342900" indent="-342900">
-              <a:spcAft>
-                <a:spcPts val="600"/>
-              </a:spcAft>
               <a:buSzPct val="100000"/>
               <a:buChar char="•"/>
             </a:pPr>
@@ -16773,15 +16775,26 @@
                   <a:srgbClr val="000000"/>
                 </a:solidFill>
               </a:rPr>
-              <a:t>Three datasets -45 injection sessions, 30-session user study, 48-session agent extension - with reproducible analysis (Jupyter notebook reproduces every table and figure).</a:t>
+              <a:t>Three datasets - 45 injection sessions, 30-session user study, 48-session agent extension.</a:t>
             </a:r>
             <a:endParaRPr lang="en-US" sz="1600" dirty="0"/>
           </a:p>
           <a:p>
+            <a:pPr indent="0" marL="0">
+              <a:buNone/>
+            </a:pPr>
+            <a:r>
+              <a:rPr lang="en-US" sz="1600" dirty="0">
+                <a:solidFill>
+                  <a:srgbClr val="000000"/>
+                </a:solidFill>
+              </a:rPr>
+              <a:t> </a:t>
+            </a:r>
+            <a:endParaRPr lang="en-US" sz="1600" dirty="0"/>
+          </a:p>
+          <a:p>
             <a:pPr marL="342900" indent="-342900">
-              <a:spcAft>
-                <a:spcPts val="600"/>
-              </a:spcAft>
               <a:buSzPct val="100000"/>
               <a:buChar char="•"/>
             </a:pPr>

</xml_diff>